<commit_message>
feat: adiciona roteiro recomendado aos slides
</commit_message>
<xml_diff>
--- a/assets/decks/aula-00-ambiente.pptx
+++ b/assets/decks/aula-00-ambiente.pptx
@@ -2,31 +2,31 @@
 <file path=ppt/presentation.xml><?xml version="1.0" encoding="utf-8"?>
 <p:presentation xmlns:p="http://schemas.openxmlformats.org/presentationml/2006/main">
   <p:sldMasterIdLst>
-    <p:sldMasterId xmlns:r="http://schemas.openxmlformats.org/officeDocument/2006/relationships" id="2147483648" r:id="R6afdfdacae434075"/>
-    <p:sldMasterId xmlns:r="http://schemas.openxmlformats.org/officeDocument/2006/relationships" id="2147483650" r:id="R393fa0fa5c5244a9"/>
+    <p:sldMasterId xmlns:r="http://schemas.openxmlformats.org/officeDocument/2006/relationships" id="2147483648" r:id="R5e0d0328506a493f"/>
+    <p:sldMasterId xmlns:r="http://schemas.openxmlformats.org/officeDocument/2006/relationships" id="2147483650" r:id="R682cfe47e38140ab"/>
   </p:sldMasterIdLst>
   <p:notesMasterIdLst>
-    <p:notesMasterId xmlns:r="http://schemas.openxmlformats.org/officeDocument/2006/relationships" r:id="R7534c00c1cab4473"/>
+    <p:notesMasterId xmlns:r="http://schemas.openxmlformats.org/officeDocument/2006/relationships" r:id="R763758e206154c34"/>
   </p:notesMasterIdLst>
   <p:sldIdLst>
-    <p:sldId xmlns:r="http://schemas.openxmlformats.org/officeDocument/2006/relationships" id="256" r:id="Re7769d1458a7443b"/>
-    <p:sldId xmlns:r="http://schemas.openxmlformats.org/officeDocument/2006/relationships" id="257" r:id="Rbf0461dd12e241b3"/>
-    <p:sldId xmlns:r="http://schemas.openxmlformats.org/officeDocument/2006/relationships" id="258" r:id="R5e4e138a69704484"/>
-    <p:sldId xmlns:r="http://schemas.openxmlformats.org/officeDocument/2006/relationships" id="259" r:id="R582c55be52bf473e"/>
-    <p:sldId xmlns:r="http://schemas.openxmlformats.org/officeDocument/2006/relationships" id="260" r:id="R6500974036064e83"/>
-    <p:sldId xmlns:r="http://schemas.openxmlformats.org/officeDocument/2006/relationships" id="261" r:id="R0d38b4cea843463a"/>
-    <p:sldId xmlns:r="http://schemas.openxmlformats.org/officeDocument/2006/relationships" id="262" r:id="R2ebc70f0f8d54c85"/>
-    <p:sldId xmlns:r="http://schemas.openxmlformats.org/officeDocument/2006/relationships" id="263" r:id="R274ff51fa53748d9"/>
-    <p:sldId xmlns:r="http://schemas.openxmlformats.org/officeDocument/2006/relationships" id="264" r:id="Red122efeb01b4ad6"/>
-    <p:sldId xmlns:r="http://schemas.openxmlformats.org/officeDocument/2006/relationships" id="265" r:id="R43c7a504b4754880"/>
-    <p:sldId xmlns:r="http://schemas.openxmlformats.org/officeDocument/2006/relationships" id="266" r:id="R522f1597cfaf44a3"/>
-    <p:sldId xmlns:r="http://schemas.openxmlformats.org/officeDocument/2006/relationships" id="267" r:id="Rb67864dce8a24d0c"/>
-    <p:sldId xmlns:r="http://schemas.openxmlformats.org/officeDocument/2006/relationships" id="268" r:id="Raf2f52787a2d4b57"/>
-    <p:sldId xmlns:r="http://schemas.openxmlformats.org/officeDocument/2006/relationships" id="269" r:id="Rce9b6a3581004e9d"/>
-    <p:sldId xmlns:r="http://schemas.openxmlformats.org/officeDocument/2006/relationships" id="270" r:id="R369446bd8fcf49fe"/>
-    <p:sldId xmlns:r="http://schemas.openxmlformats.org/officeDocument/2006/relationships" id="271" r:id="Rb633e08fc3684b3f"/>
-    <p:sldId xmlns:r="http://schemas.openxmlformats.org/officeDocument/2006/relationships" id="272" r:id="R761538bb28e84c95"/>
-    <p:sldId xmlns:r="http://schemas.openxmlformats.org/officeDocument/2006/relationships" id="273" r:id="Ra6e32c4762bd48d2"/>
+    <p:sldId xmlns:r="http://schemas.openxmlformats.org/officeDocument/2006/relationships" id="256" r:id="R3c8df0efa0a54afa"/>
+    <p:sldId xmlns:r="http://schemas.openxmlformats.org/officeDocument/2006/relationships" id="257" r:id="R99f70967b6b34ed3"/>
+    <p:sldId xmlns:r="http://schemas.openxmlformats.org/officeDocument/2006/relationships" id="258" r:id="Rd4364d26f6304197"/>
+    <p:sldId xmlns:r="http://schemas.openxmlformats.org/officeDocument/2006/relationships" id="259" r:id="R0b49011138744999"/>
+    <p:sldId xmlns:r="http://schemas.openxmlformats.org/officeDocument/2006/relationships" id="260" r:id="Rb3455e44cab34a2b"/>
+    <p:sldId xmlns:r="http://schemas.openxmlformats.org/officeDocument/2006/relationships" id="261" r:id="R6a4991b7cee343ab"/>
+    <p:sldId xmlns:r="http://schemas.openxmlformats.org/officeDocument/2006/relationships" id="262" r:id="Rb17f69a0f6984cb1"/>
+    <p:sldId xmlns:r="http://schemas.openxmlformats.org/officeDocument/2006/relationships" id="263" r:id="R14fd93f434e44d16"/>
+    <p:sldId xmlns:r="http://schemas.openxmlformats.org/officeDocument/2006/relationships" id="264" r:id="R9aa47c8e51f74d84"/>
+    <p:sldId xmlns:r="http://schemas.openxmlformats.org/officeDocument/2006/relationships" id="265" r:id="R081dc7a74d0c4775"/>
+    <p:sldId xmlns:r="http://schemas.openxmlformats.org/officeDocument/2006/relationships" id="266" r:id="R1f4dcfef1e964790"/>
+    <p:sldId xmlns:r="http://schemas.openxmlformats.org/officeDocument/2006/relationships" id="267" r:id="R9e8b7d09ec174526"/>
+    <p:sldId xmlns:r="http://schemas.openxmlformats.org/officeDocument/2006/relationships" id="268" r:id="R671adcadb0bb47c1"/>
+    <p:sldId xmlns:r="http://schemas.openxmlformats.org/officeDocument/2006/relationships" id="269" r:id="R30b32454c0164808"/>
+    <p:sldId xmlns:r="http://schemas.openxmlformats.org/officeDocument/2006/relationships" id="270" r:id="R5385c3ace79249b3"/>
+    <p:sldId xmlns:r="http://schemas.openxmlformats.org/officeDocument/2006/relationships" id="271" r:id="R947a0f71fa274d88"/>
+    <p:sldId xmlns:r="http://schemas.openxmlformats.org/officeDocument/2006/relationships" id="272" r:id="R0074e42c46cb4835"/>
+    <p:sldId xmlns:r="http://schemas.openxmlformats.org/officeDocument/2006/relationships" id="273" r:id="R5d3f6877a4594b80"/>
   </p:sldIdLst>
   <p:sldSz cx="12192000" cy="6858000"/>
   <p:notesSz cx="6858000" cy="9144000"/>
@@ -460,7 +460,57 @@
           <a:lstStyle xmlns:a="http://schemas.openxmlformats.org/drawingml/2006/main"/>
           <a:p xmlns:a="http://schemas.openxmlformats.org/drawingml/2006/main">
             <a:r>
-              <a:t>Apresente o objetivo do AULA 0 e conecte-o ao checkpoint executável. Você termina com um build, testes e artifacts — não apenas com uma instalação que parece funcionar.</a:t>
+              <a:t>[Roteiro recomendado]</a:t>
+            </a:r>
+          </a:p>
+          <a:p xmlns:a="http://schemas.openxmlformats.org/drawingml/2006/main">
+            <a:r>
+              <a:t>[Tempo sugerido: 00:45]</a:t>
+            </a:r>
+          </a:p>
+          <a:p xmlns:a="http://schemas.openxmlformats.org/drawingml/2006/main">
+            <a:r>
+              <a:t/>
+            </a:r>
+          </a:p>
+          <a:p xmlns:a="http://schemas.openxmlformats.org/drawingml/2006/main">
+            <a:r>
+              <a:t>Fala sugerida:</a:t>
+            </a:r>
+          </a:p>
+          <a:p xmlns:a="http://schemas.openxmlformats.org/drawingml/2006/main">
+            <a:r>
+              <a:t>Bem-vindo à aula 0 do dbt Moderno na Prática. Hoje vamos trabalhar o tema “Prepare seu laboratório dbt sem sofrer com o ambiente”. Windows, macOS, Linux ou Codespaces — o mesmo hands-on local. O objetivo não é apenas conhecer o conceito: vamos conectá-lo ao laboratório e terminar com uma evidência que você consegue reproduzir no seu próprio ambiente. Ao longo da aula, separe sempre o que é recurso aberto e estável daquilo que aparecerá apenas no Radar.</a:t>
+            </a:r>
+          </a:p>
+          <a:p xmlns:a="http://schemas.openxmlformats.org/drawingml/2006/main">
+            <a:r>
+              <a:t/>
+            </a:r>
+          </a:p>
+          <a:p xmlns:a="http://schemas.openxmlformats.org/drawingml/2006/main">
+            <a:r>
+              <a:t>O que destacar:</a:t>
+            </a:r>
+          </a:p>
+          <a:p xmlns:a="http://schemas.openxmlformats.org/drawingml/2006/main">
+            <a:r>
+              <a:t>- Apresente o título, situe o checkpoint 01 e deixe claro que a aula faz parte da trilha open/stable.</a:t>
+            </a:r>
+          </a:p>
+          <a:p xmlns:a="http://schemas.openxmlformats.org/drawingml/2006/main">
+            <a:r>
+              <a:t/>
+            </a:r>
+          </a:p>
+          <a:p xmlns:a="http://schemas.openxmlformats.org/drawingml/2006/main">
+            <a:r>
+              <a:t>Transição:</a:t>
+            </a:r>
+          </a:p>
+          <a:p xmlns:a="http://schemas.openxmlformats.org/drawingml/2006/main">
+            <a:r>
+              <a:t>Com esse ponto estabelecido, avance para “Você termina com um build, testes e artifacts — não apenas com uma instalação que parece funcionar.”.</a:t>
             </a:r>
           </a:p>
           <a:p xmlns:a="http://schemas.openxmlformats.org/drawingml/2006/main">
@@ -575,7 +625,57 @@
           <a:lstStyle xmlns:a="http://schemas.openxmlformats.org/drawingml/2006/main"/>
           <a:p xmlns:a="http://schemas.openxmlformats.org/drawingml/2006/main">
             <a:r>
-              <a:t>Use a composição para explicar visualmente: O support-report ajuda sem publicar tokens ou caminhos sensíveis. Versões e permissões Espaço e arquivos esperados Relatório sanitizado para pedir ajuda</a:t>
+              <a:t>[Roteiro recomendado]</a:t>
+            </a:r>
+          </a:p>
+          <a:p xmlns:a="http://schemas.openxmlformats.org/drawingml/2006/main">
+            <a:r>
+              <a:t>[Tempo sugerido: 00:55]</a:t>
+            </a:r>
+          </a:p>
+          <a:p xmlns:a="http://schemas.openxmlformats.org/drawingml/2006/main">
+            <a:r>
+              <a:t/>
+            </a:r>
+          </a:p>
+          <a:p xmlns:a="http://schemas.openxmlformats.org/drawingml/2006/main">
+            <a:r>
+              <a:t>Fala sugerida:</a:t>
+            </a:r>
+          </a:p>
+          <a:p xmlns:a="http://schemas.openxmlformats.org/drawingml/2006/main">
+            <a:r>
+              <a:t>Agora vamos ler a ideia visualmente. O support-report ajuda sem publicar tokens ou caminhos sensíveis. Siga a composição na ordem mostrada e conecte verde: siga, Amarelo: revise e Vermelho: bloqueie. A imagem ou o fluxo não cria uma regra nova; ele torna visível a relação que acabamos de explicar. Use a disposição dos elementos para reforçar causa, dependência ou comparação.</a:t>
+            </a:r>
+          </a:p>
+          <a:p xmlns:a="http://schemas.openxmlformats.org/drawingml/2006/main">
+            <a:r>
+              <a:t/>
+            </a:r>
+          </a:p>
+          <a:p xmlns:a="http://schemas.openxmlformats.org/drawingml/2006/main">
+            <a:r>
+              <a:t>O que destacar:</a:t>
+            </a:r>
+          </a:p>
+          <a:p xmlns:a="http://schemas.openxmlformats.org/drawingml/2006/main">
+            <a:r>
+              <a:t>- Acompanhe o fluxo ou a comparação com o cursor e preserve a ordem de leitura do slide.</a:t>
+            </a:r>
+          </a:p>
+          <a:p xmlns:a="http://schemas.openxmlformats.org/drawingml/2006/main">
+            <a:r>
+              <a:t/>
+            </a:r>
+          </a:p>
+          <a:p xmlns:a="http://schemas.openxmlformats.org/drawingml/2006/main">
+            <a:r>
+              <a:t>Transição:</a:t>
+            </a:r>
+          </a:p>
+          <a:p xmlns:a="http://schemas.openxmlformats.org/drawingml/2006/main">
+            <a:r>
+              <a:t>Com esse ponto estabelecido, avance para “Demonstração — execute”.</a:t>
             </a:r>
           </a:p>
           <a:p xmlns:a="http://schemas.openxmlformats.org/drawingml/2006/main">
@@ -690,7 +790,57 @@
           <a:lstStyle xmlns:a="http://schemas.openxmlformats.org/drawingml/2006/main"/>
           <a:p xmlns:a="http://schemas.openxmlformats.org/drawingml/2006/main">
             <a:r>
-              <a:t>Execute python course.py setup e depois python course.py checkpoint 01. Pause para o aluno acompanhar o terminal.</a:t>
+              <a:t>[Roteiro recomendado]</a:t>
+            </a:r>
+          </a:p>
+          <a:p xmlns:a="http://schemas.openxmlformats.org/drawingml/2006/main">
+            <a:r>
+              <a:t>[Tempo sugerido: 01:20]</a:t>
+            </a:r>
+          </a:p>
+          <a:p xmlns:a="http://schemas.openxmlformats.org/drawingml/2006/main">
+            <a:r>
+              <a:t/>
+            </a:r>
+          </a:p>
+          <a:p xmlns:a="http://schemas.openxmlformats.org/drawingml/2006/main">
+            <a:r>
+              <a:t>Fala sugerida:</a:t>
+            </a:r>
+          </a:p>
+          <a:p xmlns:a="http://schemas.openxmlformats.org/drawingml/2006/main">
+            <a:r>
+              <a:t>Agora vamos sair da explicação e comprovar o comportamento. Execute os comandos exatamente como aparecem: python course.py setup, depois python course.py checkpoint 01. Não é necessário ativar o ambiente virtual manualmente; o launcher do curso seleciona o ambiente correto. Antes de avançar, confirme que o comando iniciou sem erro e dê tempo para o aluno acompanhar a mesma etapa.</a:t>
+            </a:r>
+          </a:p>
+          <a:p xmlns:a="http://schemas.openxmlformats.org/drawingml/2006/main">
+            <a:r>
+              <a:t/>
+            </a:r>
+          </a:p>
+          <a:p xmlns:a="http://schemas.openxmlformats.org/drawingml/2006/main">
+            <a:r>
+              <a:t>O que destacar:</a:t>
+            </a:r>
+          </a:p>
+          <a:p xmlns:a="http://schemas.openxmlformats.org/drawingml/2006/main">
+            <a:r>
+              <a:t>- Mostre o comando completo, execute uma linha por vez quando houver mais de uma e mantenha o terminal visível.</a:t>
+            </a:r>
+          </a:p>
+          <a:p xmlns:a="http://schemas.openxmlformats.org/drawingml/2006/main">
+            <a:r>
+              <a:t/>
+            </a:r>
+          </a:p>
+          <a:p xmlns:a="http://schemas.openxmlformats.org/drawingml/2006/main">
+            <a:r>
+              <a:t>Transição:</a:t>
+            </a:r>
+          </a:p>
+          <a:p xmlns:a="http://schemas.openxmlformats.org/drawingml/2006/main">
+            <a:r>
+              <a:t>Com esse ponto estabelecido, avance para “Demonstração — observe”.</a:t>
             </a:r>
           </a:p>
           <a:p xmlns:a="http://schemas.openxmlformats.org/drawingml/2006/main">
@@ -805,7 +955,57 @@
           <a:lstStyle xmlns:a="http://schemas.openxmlformats.org/drawingml/2006/main"/>
           <a:p xmlns:a="http://schemas.openxmlformats.org/drawingml/2006/main">
             <a:r>
-              <a:t>Durante a execução, destaque: Ambiente virtual criado; dbt debug concluído; Seeds, build e artifacts executados.</a:t>
+              <a:t>[Roteiro recomendado]</a:t>
+            </a:r>
+          </a:p>
+          <a:p xmlns:a="http://schemas.openxmlformats.org/drawingml/2006/main">
+            <a:r>
+              <a:t>[Tempo sugerido: 01:10]</a:t>
+            </a:r>
+          </a:p>
+          <a:p xmlns:a="http://schemas.openxmlformats.org/drawingml/2006/main">
+            <a:r>
+              <a:t/>
+            </a:r>
+          </a:p>
+          <a:p xmlns:a="http://schemas.openxmlformats.org/drawingml/2006/main">
+            <a:r>
+              <a:t>Fala sugerida:</a:t>
+            </a:r>
+          </a:p>
+          <a:p xmlns:a="http://schemas.openxmlformats.org/drawingml/2006/main">
+            <a:r>
+              <a:t>Enquanto a execução acontece, não olhe apenas para a mensagem final. Observe ambiente virtual criado, dbt debug concluído e Seeds, build e artifacts executados. Cada sinal responde a uma pergunta diferente sobre o pipeline. Se um deles divergir, interrompa a demonstração e investigue; o objetivo do hands-on é produzir evidência, não apenas chegar rapidamente a uma tela verde.</a:t>
+            </a:r>
+          </a:p>
+          <a:p xmlns:a="http://schemas.openxmlformats.org/drawingml/2006/main">
+            <a:r>
+              <a:t/>
+            </a:r>
+          </a:p>
+          <a:p xmlns:a="http://schemas.openxmlformats.org/drawingml/2006/main">
+            <a:r>
+              <a:t>O que destacar:</a:t>
+            </a:r>
+          </a:p>
+          <a:p xmlns:a="http://schemas.openxmlformats.org/drawingml/2006/main">
+            <a:r>
+              <a:t>- Marque cada observação quando ela aparecer no terminal ou no artifact correspondente.</a:t>
+            </a:r>
+          </a:p>
+          <a:p xmlns:a="http://schemas.openxmlformats.org/drawingml/2006/main">
+            <a:r>
+              <a:t/>
+            </a:r>
+          </a:p>
+          <a:p xmlns:a="http://schemas.openxmlformats.org/drawingml/2006/main">
+            <a:r>
+              <a:t>Transição:</a:t>
+            </a:r>
+          </a:p>
+          <a:p xmlns:a="http://schemas.openxmlformats.org/drawingml/2006/main">
+            <a:r>
+              <a:t>Com esse ponto estabelecido, avance para “RESULTADO ESPERADO”.</a:t>
             </a:r>
           </a:p>
           <a:p xmlns:a="http://schemas.openxmlformats.org/drawingml/2006/main">
@@ -920,7 +1120,57 @@
           <a:lstStyle xmlns:a="http://schemas.openxmlformats.org/drawingml/2006/main"/>
           <a:p xmlns:a="http://schemas.openxmlformats.org/drawingml/2006/main">
             <a:r>
-              <a:t>Confirme o resultado esperado: Checkpoint 01 OK. Se o valor divergir, não avance sem investigar.</a:t>
+              <a:t>[Roteiro recomendado]</a:t>
+            </a:r>
+          </a:p>
+          <a:p xmlns:a="http://schemas.openxmlformats.org/drawingml/2006/main">
+            <a:r>
+              <a:t>[Tempo sugerido: 00:45]</a:t>
+            </a:r>
+          </a:p>
+          <a:p xmlns:a="http://schemas.openxmlformats.org/drawingml/2006/main">
+            <a:r>
+              <a:t/>
+            </a:r>
+          </a:p>
+          <a:p xmlns:a="http://schemas.openxmlformats.org/drawingml/2006/main">
+            <a:r>
+              <a:t>Fala sugerida:</a:t>
+            </a:r>
+          </a:p>
+          <a:p xmlns:a="http://schemas.openxmlformats.org/drawingml/2006/main">
+            <a:r>
+              <a:t>Este é o ponto de parada da demonstração: Checkpoint 01 OK. Esse resultado confirma que a etapa executada produziu a evidência esperada para o checkpoint 01. Se o valor, o status ou o artifact estiver diferente, não trate a divergência como detalhe de ambiente. Use o diagnóstico do curso e só avance quando a causa estiver compreendida.</a:t>
+            </a:r>
+          </a:p>
+          <a:p xmlns:a="http://schemas.openxmlformats.org/drawingml/2006/main">
+            <a:r>
+              <a:t/>
+            </a:r>
+          </a:p>
+          <a:p xmlns:a="http://schemas.openxmlformats.org/drawingml/2006/main">
+            <a:r>
+              <a:t>O que destacar:</a:t>
+            </a:r>
+          </a:p>
+          <a:p xmlns:a="http://schemas.openxmlformats.org/drawingml/2006/main">
+            <a:r>
+              <a:t>- Compare o resultado do terminal com a frase central do slide e registre a evidência antes de continuar.</a:t>
+            </a:r>
+          </a:p>
+          <a:p xmlns:a="http://schemas.openxmlformats.org/drawingml/2006/main">
+            <a:r>
+              <a:t/>
+            </a:r>
+          </a:p>
+          <a:p xmlns:a="http://schemas.openxmlformats.org/drawingml/2006/main">
+            <a:r>
+              <a:t>Transição:</a:t>
+            </a:r>
+          </a:p>
+          <a:p xmlns:a="http://schemas.openxmlformats.org/drawingml/2006/main">
+            <a:r>
+              <a:t>Com esse ponto estabelecido, avance para “O mesmo recurso afeta três decisões”.</a:t>
             </a:r>
           </a:p>
           <a:p xmlns:a="http://schemas.openxmlformats.org/drawingml/2006/main">
@@ -1035,7 +1285,57 @@
           <a:lstStyle xmlns:a="http://schemas.openxmlformats.org/drawingml/2006/main"/>
           <a:p xmlns:a="http://schemas.openxmlformats.org/drawingml/2006/main">
             <a:r>
-              <a:t>Conecte a técnica aos efeitos: Governança: versões fixadas; FinOps: execução local; IA: nenhuma chave necessária. Não prometa economia sem medição.</a:t>
+              <a:t>[Roteiro recomendado]</a:t>
+            </a:r>
+          </a:p>
+          <a:p xmlns:a="http://schemas.openxmlformats.org/drawingml/2006/main">
+            <a:r>
+              <a:t>[Tempo sugerido: 01:00]</a:t>
+            </a:r>
+          </a:p>
+          <a:p xmlns:a="http://schemas.openxmlformats.org/drawingml/2006/main">
+            <a:r>
+              <a:t/>
+            </a:r>
+          </a:p>
+          <a:p xmlns:a="http://schemas.openxmlformats.org/drawingml/2006/main">
+            <a:r>
+              <a:t>Fala sugerida:</a:t>
+            </a:r>
+          </a:p>
+          <a:p xmlns:a="http://schemas.openxmlformats.org/drawingml/2006/main">
+            <a:r>
+              <a:t>Antes de seguir, conecte a técnica às decisões que ela afeta: Governança: versões fixadas, FinOps: execução local e IA: nenhuma chave necessária. Governança define responsabilidade e consistência; FinOps pergunta quanto trabalho estamos repetindo; e IA depende do contexto que decidimos expor. A mesma implementação pode melhorar os três eixos, mas os ganhos devem ser medidos separadamente.</a:t>
+            </a:r>
+          </a:p>
+          <a:p xmlns:a="http://schemas.openxmlformats.org/drawingml/2006/main">
+            <a:r>
+              <a:t/>
+            </a:r>
+          </a:p>
+          <a:p xmlns:a="http://schemas.openxmlformats.org/drawingml/2006/main">
+            <a:r>
+              <a:t>O que destacar:</a:t>
+            </a:r>
+          </a:p>
+          <a:p xmlns:a="http://schemas.openxmlformats.org/drawingml/2006/main">
+            <a:r>
+              <a:t>- Percorra os três eixos e evite apresentar economia ou acurácia como consequência automática.</a:t>
+            </a:r>
+          </a:p>
+          <a:p xmlns:a="http://schemas.openxmlformats.org/drawingml/2006/main">
+            <a:r>
+              <a:t/>
+            </a:r>
+          </a:p>
+          <a:p xmlns:a="http://schemas.openxmlformats.org/drawingml/2006/main">
+            <a:r>
+              <a:t>Transição:</a:t>
+            </a:r>
+          </a:p>
+          <a:p xmlns:a="http://schemas.openxmlformats.org/drawingml/2006/main">
+            <a:r>
+              <a:t>Com esse ponto estabelecido, avance para “46 recursos”.</a:t>
             </a:r>
           </a:p>
           <a:p xmlns:a="http://schemas.openxmlformats.org/drawingml/2006/main">
@@ -1150,7 +1450,57 @@
           <a:lstStyle xmlns:a="http://schemas.openxmlformats.org/drawingml/2006/main"/>
           <a:p xmlns:a="http://schemas.openxmlformats.org/drawingml/2006/main">
             <a:r>
-              <a:t>46 recursos: baseline dbt validado localmente. Resultado do laboratório, não benchmark de produção.</a:t>
+              <a:t>[Roteiro recomendado]</a:t>
+            </a:r>
+          </a:p>
+          <a:p xmlns:a="http://schemas.openxmlformats.org/drawingml/2006/main">
+            <a:r>
+              <a:t>[Tempo sugerido: 00:55]</a:t>
+            </a:r>
+          </a:p>
+          <a:p xmlns:a="http://schemas.openxmlformats.org/drawingml/2006/main">
+            <a:r>
+              <a:t/>
+            </a:r>
+          </a:p>
+          <a:p xmlns:a="http://schemas.openxmlformats.org/drawingml/2006/main">
+            <a:r>
+              <a:t>Fala sugerida:</a:t>
+            </a:r>
+          </a:p>
+          <a:p xmlns:a="http://schemas.openxmlformats.org/drawingml/2006/main">
+            <a:r>
+              <a:t>Aqui temos 46 recursos: baseline dbt validado localmente. O número ajuda a dimensionar o exemplo, mas precisa ser lido com a ressalva correta. Resultado do laboratório, não benchmark de produção. Use o case como evidência contextual e não como promessa de que outro projeto repetirá o mesmo resultado sem as mesmas condições.</a:t>
+            </a:r>
+          </a:p>
+          <a:p xmlns:a="http://schemas.openxmlformats.org/drawingml/2006/main">
+            <a:r>
+              <a:t/>
+            </a:r>
+          </a:p>
+          <a:p xmlns:a="http://schemas.openxmlformats.org/drawingml/2006/main">
+            <a:r>
+              <a:t>O que destacar:</a:t>
+            </a:r>
+          </a:p>
+          <a:p xmlns:a="http://schemas.openxmlformats.org/drawingml/2006/main">
+            <a:r>
+              <a:t>- Apresente primeiro o número, depois a definição e termine obrigatoriamente com a ressalva.</a:t>
+            </a:r>
+          </a:p>
+          <a:p xmlns:a="http://schemas.openxmlformats.org/drawingml/2006/main">
+            <a:r>
+              <a:t/>
+            </a:r>
+          </a:p>
+          <a:p xmlns:a="http://schemas.openxmlformats.org/drawingml/2006/main">
+            <a:r>
+              <a:t>Transição:</a:t>
+            </a:r>
+          </a:p>
+          <a:p xmlns:a="http://schemas.openxmlformats.org/drawingml/2006/main">
+            <a:r>
+              <a:t>Com esse ponto estabelecido, avance para “Limitações que precisam permanecer visíveis”.</a:t>
             </a:r>
           </a:p>
           <a:p xmlns:a="http://schemas.openxmlformats.org/drawingml/2006/main">
@@ -1265,7 +1615,57 @@
           <a:lstStyle xmlns:a="http://schemas.openxmlformats.org/drawingml/2006/main"/>
           <a:p xmlns:a="http://schemas.openxmlformats.org/drawingml/2006/main">
             <a:r>
-              <a:t>Apresente os limites sem minimizá-los: A instalação inicial ainda precisa de internet; Codespaces depende da conta e da franquia; 2 CPUs, 4 GB e 2 GB livres são a meta validada.</a:t>
+              <a:t>[Roteiro recomendado]</a:t>
+            </a:r>
+          </a:p>
+          <a:p xmlns:a="http://schemas.openxmlformats.org/drawingml/2006/main">
+            <a:r>
+              <a:t>[Tempo sugerido: 01:00]</a:t>
+            </a:r>
+          </a:p>
+          <a:p xmlns:a="http://schemas.openxmlformats.org/drawingml/2006/main">
+            <a:r>
+              <a:t/>
+            </a:r>
+          </a:p>
+          <a:p xmlns:a="http://schemas.openxmlformats.org/drawingml/2006/main">
+            <a:r>
+              <a:t>Fala sugerida:</a:t>
+            </a:r>
+          </a:p>
+          <a:p xmlns:a="http://schemas.openxmlformats.org/drawingml/2006/main">
+            <a:r>
+              <a:t>Também precisamos declarar os limites da recomendação. Neste cenário, considere a instalação inicial ainda precisa de internet, Codespaces depende da conta e da franquia e 2 CPUs, 4 GB e 2 GB livres são a meta validada. Esses pontos não anulam a técnica; eles delimitam onde a demonstração é válida e quais condições precisam ser verificadas antes de levar o padrão para produção. Tratar limites como parte do design evita transformar uma boa prática em regra universal.</a:t>
+            </a:r>
+          </a:p>
+          <a:p xmlns:a="http://schemas.openxmlformats.org/drawingml/2006/main">
+            <a:r>
+              <a:t/>
+            </a:r>
+          </a:p>
+          <a:p xmlns:a="http://schemas.openxmlformats.org/drawingml/2006/main">
+            <a:r>
+              <a:t>O que destacar:</a:t>
+            </a:r>
+          </a:p>
+          <a:p xmlns:a="http://schemas.openxmlformats.org/drawingml/2006/main">
+            <a:r>
+              <a:t>- Leia os limites com o mesmo peso dado aos benefícios e diferencie restrição do laboratório de restrição do produto.</a:t>
+            </a:r>
+          </a:p>
+          <a:p xmlns:a="http://schemas.openxmlformats.org/drawingml/2006/main">
+            <a:r>
+              <a:t/>
+            </a:r>
+          </a:p>
+          <a:p xmlns:a="http://schemas.openxmlformats.org/drawingml/2006/main">
+            <a:r>
+              <a:t>Transição:</a:t>
+            </a:r>
+          </a:p>
+          <a:p xmlns:a="http://schemas.openxmlformats.org/drawingml/2006/main">
+            <a:r>
+              <a:t>Com esse ponto estabelecido, avance para “RADAR”.</a:t>
             </a:r>
           </a:p>
           <a:p xmlns:a="http://schemas.openxmlformats.org/drawingml/2006/main">
@@ -1380,7 +1780,57 @@
           <a:lstStyle xmlns:a="http://schemas.openxmlformats.org/drawingml/2006/main"/>
           <a:p xmlns:a="http://schemas.openxmlformats.org/drawingml/2006/main">
             <a:r>
-              <a:t>Core 2.0 e Fusion ficam apenas no Radar; a aula executa Core 1.12 estável. Reforce que beta e preview não fazem parte da aceitação.</a:t>
+              <a:t>[Roteiro recomendado]</a:t>
+            </a:r>
+          </a:p>
+          <a:p xmlns:a="http://schemas.openxmlformats.org/drawingml/2006/main">
+            <a:r>
+              <a:t>[Tempo sugerido: 00:55]</a:t>
+            </a:r>
+          </a:p>
+          <a:p xmlns:a="http://schemas.openxmlformats.org/drawingml/2006/main">
+            <a:r>
+              <a:t/>
+            </a:r>
+          </a:p>
+          <a:p xmlns:a="http://schemas.openxmlformats.org/drawingml/2006/main">
+            <a:r>
+              <a:t>Fala sugerida:</a:t>
+            </a:r>
+          </a:p>
+          <a:p xmlns:a="http://schemas.openxmlformats.org/drawingml/2006/main">
+            <a:r>
+              <a:t>Este é o nosso Radar: Core 2.0 e Fusion ficam apenas no Radar; a aula executa Core 1.12 estável. A intenção é mostrar a direção da ferramenta sem misturar preview com o caminho suportado da aula. Novidade observada não é recomendação de produção. Para adotar qualquer recurso futuro, confirme maturidade, adaptador, documentação e impacto sobre o projeto antes de alterar o baseline estável.</a:t>
+            </a:r>
+          </a:p>
+          <a:p xmlns:a="http://schemas.openxmlformats.org/drawingml/2006/main">
+            <a:r>
+              <a:t/>
+            </a:r>
+          </a:p>
+          <a:p xmlns:a="http://schemas.openxmlformats.org/drawingml/2006/main">
+            <a:r>
+              <a:t>O que destacar:</a:t>
+            </a:r>
+          </a:p>
+          <a:p xmlns:a="http://schemas.openxmlformats.org/drawingml/2006/main">
+            <a:r>
+              <a:t>- Reforce visualmente a regra do rodapé e não execute comandos beta ou preview como parte obrigatória da aula.</a:t>
+            </a:r>
+          </a:p>
+          <a:p xmlns:a="http://schemas.openxmlformats.org/drawingml/2006/main">
+            <a:r>
+              <a:t/>
+            </a:r>
+          </a:p>
+          <a:p xmlns:a="http://schemas.openxmlformats.org/drawingml/2006/main">
+            <a:r>
+              <a:t>Transição:</a:t>
+            </a:r>
+          </a:p>
+          <a:p xmlns:a="http://schemas.openxmlformats.org/drawingml/2006/main">
+            <a:r>
+              <a:t>Com esse ponto estabelecido, avance para “PRÓXIMO PASSO”.</a:t>
             </a:r>
           </a:p>
           <a:p xmlns:a="http://schemas.openxmlformats.org/drawingml/2006/main">
@@ -1495,7 +1945,57 @@
           <a:lstStyle xmlns:a="http://schemas.openxmlformats.org/drawingml/2006/main"/>
           <a:p xmlns:a="http://schemas.openxmlformats.org/drawingml/2006/main">
             <a:r>
-              <a:t>Execute doctor, setup e checkpoint 01 antes de avançar. Encerre conectando a aula ao próximo checkpoint.</a:t>
+              <a:t>[Roteiro recomendado]</a:t>
+            </a:r>
+          </a:p>
+          <a:p xmlns:a="http://schemas.openxmlformats.org/drawingml/2006/main">
+            <a:r>
+              <a:t>[Tempo sugerido: 00:40]</a:t>
+            </a:r>
+          </a:p>
+          <a:p xmlns:a="http://schemas.openxmlformats.org/drawingml/2006/main">
+            <a:r>
+              <a:t/>
+            </a:r>
+          </a:p>
+          <a:p xmlns:a="http://schemas.openxmlformats.org/drawingml/2006/main">
+            <a:r>
+              <a:t>Fala sugerida:</a:t>
+            </a:r>
+          </a:p>
+          <a:p xmlns:a="http://schemas.openxmlformats.org/drawingml/2006/main">
+            <a:r>
+              <a:t>Execute doctor, setup e checkpoint 01 antes de avançar. Faça essa etapa antes de seguir para o próximo episódio, porque o curso é cumulativo e o checkpoint atual se torna a base da aula seguinte. Se houver divergência, use o relatório de suporte e registre o que foi observado. O objetivo é avançar com um estado conhecido e reproduzível, não apenas assistir ao conteúdo.</a:t>
+            </a:r>
+          </a:p>
+          <a:p xmlns:a="http://schemas.openxmlformats.org/drawingml/2006/main">
+            <a:r>
+              <a:t/>
+            </a:r>
+          </a:p>
+          <a:p xmlns:a="http://schemas.openxmlformats.org/drawingml/2006/main">
+            <a:r>
+              <a:t>O que destacar:</a:t>
+            </a:r>
+          </a:p>
+          <a:p xmlns:a="http://schemas.openxmlformats.org/drawingml/2006/main">
+            <a:r>
+              <a:t>- Mostre o checkpoint e indique no repositório onde ficam o roteiro, os comandos e as referências da aula.</a:t>
+            </a:r>
+          </a:p>
+          <a:p xmlns:a="http://schemas.openxmlformats.org/drawingml/2006/main">
+            <a:r>
+              <a:t/>
+            </a:r>
+          </a:p>
+          <a:p xmlns:a="http://schemas.openxmlformats.org/drawingml/2006/main">
+            <a:r>
+              <a:t>Transição:</a:t>
+            </a:r>
+          </a:p>
+          <a:p xmlns:a="http://schemas.openxmlformats.org/drawingml/2006/main">
+            <a:r>
+              <a:t>Encerre retomando a pergunta inicial e confirme que o aluno sabe qual ação executar depois da aula 0.</a:t>
             </a:r>
           </a:p>
           <a:p xmlns:a="http://schemas.openxmlformats.org/drawingml/2006/main">
@@ -1610,7 +2110,57 @@
           <a:lstStyle xmlns:a="http://schemas.openxmlformats.org/drawingml/2006/main"/>
           <a:p xmlns:a="http://schemas.openxmlformats.org/drawingml/2006/main">
             <a:r>
-              <a:t>Você termina com um build, testes e artifacts — não apenas com uma instalação que parece funcionar. Use o diagrama para antecipar o problema que será comprovado no laboratório.</a:t>
+              <a:t>[Roteiro recomendado]</a:t>
+            </a:r>
+          </a:p>
+          <a:p xmlns:a="http://schemas.openxmlformats.org/drawingml/2006/main">
+            <a:r>
+              <a:t>[Tempo sugerido: 01:00]</a:t>
+            </a:r>
+          </a:p>
+          <a:p xmlns:a="http://schemas.openxmlformats.org/drawingml/2006/main">
+            <a:r>
+              <a:t/>
+            </a:r>
+          </a:p>
+          <a:p xmlns:a="http://schemas.openxmlformats.org/drawingml/2006/main">
+            <a:r>
+              <a:t>Fala sugerida:</a:t>
+            </a:r>
+          </a:p>
+          <a:p xmlns:a="http://schemas.openxmlformats.org/drawingml/2006/main">
+            <a:r>
+              <a:t>Quero começar com uma provocação: Você termina com um build, testes e artifacts — não apenas com uma instalação que parece funcionar. Essa pergunta orienta toda a aula. Em vez de aceitar uma afirmação porque ela parece correta, vamos procurar uma definição verificável e uma demonstração executável. Guarde essa tensão, porque voltaremos a ela quando compararmos o conceito com o resultado do laboratório.</a:t>
+            </a:r>
+          </a:p>
+          <a:p xmlns:a="http://schemas.openxmlformats.org/drawingml/2006/main">
+            <a:r>
+              <a:t/>
+            </a:r>
+          </a:p>
+          <a:p xmlns:a="http://schemas.openxmlformats.org/drawingml/2006/main">
+            <a:r>
+              <a:t>O que destacar:</a:t>
+            </a:r>
+          </a:p>
+          <a:p xmlns:a="http://schemas.openxmlformats.org/drawingml/2006/main">
+            <a:r>
+              <a:t>- Dê uma pausa depois da provocação e use o diagrama como mapa do problema, sem explicar todas as etapas ainda.</a:t>
+            </a:r>
+          </a:p>
+          <a:p xmlns:a="http://schemas.openxmlformats.org/drawingml/2006/main">
+            <a:r>
+              <a:t/>
+            </a:r>
+          </a:p>
+          <a:p xmlns:a="http://schemas.openxmlformats.org/drawingml/2006/main">
+            <a:r>
+              <a:t>Transição:</a:t>
+            </a:r>
+          </a:p>
+          <a:p xmlns:a="http://schemas.openxmlformats.org/drawingml/2006/main">
+            <a:r>
+              <a:t>Com esse ponto estabelecido, avance para “Ao final, você consegue...”.</a:t>
             </a:r>
           </a:p>
           <a:p xmlns:a="http://schemas.openxmlformats.org/drawingml/2006/main">
@@ -1725,7 +2275,57 @@
           <a:lstStyle xmlns:a="http://schemas.openxmlformats.org/drawingml/2006/main"/>
           <a:p xmlns:a="http://schemas.openxmlformats.org/drawingml/2006/main">
             <a:r>
-              <a:t>Explique os três resultados observáveis da aula: Validar os pré-requisitos; Preparar o ambiente isolado; Fechar o primeiro checkpoint.</a:t>
+              <a:t>[Roteiro recomendado]</a:t>
+            </a:r>
+          </a:p>
+          <a:p xmlns:a="http://schemas.openxmlformats.org/drawingml/2006/main">
+            <a:r>
+              <a:t>[Tempo sugerido: 01:00]</a:t>
+            </a:r>
+          </a:p>
+          <a:p xmlns:a="http://schemas.openxmlformats.org/drawingml/2006/main">
+            <a:r>
+              <a:t/>
+            </a:r>
+          </a:p>
+          <a:p xmlns:a="http://schemas.openxmlformats.org/drawingml/2006/main">
+            <a:r>
+              <a:t>Fala sugerida:</a:t>
+            </a:r>
+          </a:p>
+          <a:p xmlns:a="http://schemas.openxmlformats.org/drawingml/2006/main">
+            <a:r>
+              <a:t>Ao final desta aula, você deverá conseguir validar os pré-requisitos, Preparar o ambiente isolado e Fechar o primeiro checkpoint. Esses resultados formam uma sequência: primeiro entendemos a regra, depois observamos sua representação no projeto e, por fim, comprovamos o comportamento no checkpoint. Se alguma dessas três partes não estiver clara, volte ao slide correspondente antes de executar a demonstração.</a:t>
+            </a:r>
+          </a:p>
+          <a:p xmlns:a="http://schemas.openxmlformats.org/drawingml/2006/main">
+            <a:r>
+              <a:t/>
+            </a:r>
+          </a:p>
+          <a:p xmlns:a="http://schemas.openxmlformats.org/drawingml/2006/main">
+            <a:r>
+              <a:t>O que destacar:</a:t>
+            </a:r>
+          </a:p>
+          <a:p xmlns:a="http://schemas.openxmlformats.org/drawingml/2006/main">
+            <a:r>
+              <a:t>- Percorra os objetivos da esquerda para a direita e apresente-os como resultados observáveis, não como uma agenda abstrata.</a:t>
+            </a:r>
+          </a:p>
+          <a:p xmlns:a="http://schemas.openxmlformats.org/drawingml/2006/main">
+            <a:r>
+              <a:t/>
+            </a:r>
+          </a:p>
+          <a:p xmlns:a="http://schemas.openxmlformats.org/drawingml/2006/main">
+            <a:r>
+              <a:t>Transição:</a:t>
+            </a:r>
+          </a:p>
+          <a:p xmlns:a="http://schemas.openxmlformats.org/drawingml/2006/main">
+            <a:r>
+              <a:t>Com esse ponto estabelecido, avance para “SQL básico basta para começar”.</a:t>
             </a:r>
           </a:p>
           <a:p xmlns:a="http://schemas.openxmlformats.org/drawingml/2006/main">
@@ -1840,7 +2440,57 @@
           <a:lstStyle xmlns:a="http://schemas.openxmlformats.org/drawingml/2006/main"/>
           <a:p xmlns:a="http://schemas.openxmlformats.org/drawingml/2006/main">
             <a:r>
-              <a:t>Terminal, Git, Python e dbt entram passo a passo. Desenvolva os pontos: SELECT, JOIN, GROUP BY, SUM e COUNT; Nenhuma experiência prévia com dbt; Comandos completos em todas as aulas.</a:t>
+              <a:t>[Roteiro recomendado]</a:t>
+            </a:r>
+          </a:p>
+          <a:p xmlns:a="http://schemas.openxmlformats.org/drawingml/2006/main">
+            <a:r>
+              <a:t>[Tempo sugerido: 01:10]</a:t>
+            </a:r>
+          </a:p>
+          <a:p xmlns:a="http://schemas.openxmlformats.org/drawingml/2006/main">
+            <a:r>
+              <a:t/>
+            </a:r>
+          </a:p>
+          <a:p xmlns:a="http://schemas.openxmlformats.org/drawingml/2006/main">
+            <a:r>
+              <a:t>Fala sugerida:</a:t>
+            </a:r>
+          </a:p>
+          <a:p xmlns:a="http://schemas.openxmlformats.org/drawingml/2006/main">
+            <a:r>
+              <a:t>A mensagem principal deste slide é: Terminal, Git, Python e dbt entram passo a passo. Para tornar isso concreto, observe SELECT, JOIN, GROUP BY, SUM e COUNT, Nenhuma experiência prévia com dbt e Comandos completos em todas as aulas. Esses pontos devem ser entendidos em conjunto; não são funcionalidades isoladas. No projeto, essa combinação transforma uma convenção informal em algo que pode ser revisado, testado ou consumido de maneira consistente.</a:t>
+            </a:r>
+          </a:p>
+          <a:p xmlns:a="http://schemas.openxmlformats.org/drawingml/2006/main">
+            <a:r>
+              <a:t/>
+            </a:r>
+          </a:p>
+          <a:p xmlns:a="http://schemas.openxmlformats.org/drawingml/2006/main">
+            <a:r>
+              <a:t>O que destacar:</a:t>
+            </a:r>
+          </a:p>
+          <a:p xmlns:a="http://schemas.openxmlformats.org/drawingml/2006/main">
+            <a:r>
+              <a:t>- Comece pelo título, leia a afirmação abaixo dele e depois desenvolva os itens sem repetir o texto palavra por palavra.</a:t>
+            </a:r>
+          </a:p>
+          <a:p xmlns:a="http://schemas.openxmlformats.org/drawingml/2006/main">
+            <a:r>
+              <a:t/>
+            </a:r>
+          </a:p>
+          <a:p xmlns:a="http://schemas.openxmlformats.org/drawingml/2006/main">
+            <a:r>
+              <a:t>Transição:</a:t>
+            </a:r>
+          </a:p>
+          <a:p xmlns:a="http://schemas.openxmlformats.org/drawingml/2006/main">
+            <a:r>
+              <a:t>Com esse ponto estabelecido, avance para “Local e Codespaces chegam ao mesmo laboratório”.</a:t>
             </a:r>
           </a:p>
           <a:p xmlns:a="http://schemas.openxmlformats.org/drawingml/2006/main">
@@ -1955,7 +2605,57 @@
           <a:lstStyle xmlns:a="http://schemas.openxmlformats.org/drawingml/2006/main"/>
           <a:p xmlns:a="http://schemas.openxmlformats.org/drawingml/2006/main">
             <a:r>
-              <a:t>A rota muda; o checkpoint e o resultado permanecem iguais. Desenvolva os pontos: Local: funciona offline depois do setup; Codespaces: desbloqueia o início pelo navegador; Os dois usam o mesmo course.py.</a:t>
+              <a:t>[Roteiro recomendado]</a:t>
+            </a:r>
+          </a:p>
+          <a:p xmlns:a="http://schemas.openxmlformats.org/drawingml/2006/main">
+            <a:r>
+              <a:t>[Tempo sugerido: 01:10]</a:t>
+            </a:r>
+          </a:p>
+          <a:p xmlns:a="http://schemas.openxmlformats.org/drawingml/2006/main">
+            <a:r>
+              <a:t/>
+            </a:r>
+          </a:p>
+          <a:p xmlns:a="http://schemas.openxmlformats.org/drawingml/2006/main">
+            <a:r>
+              <a:t>Fala sugerida:</a:t>
+            </a:r>
+          </a:p>
+          <a:p xmlns:a="http://schemas.openxmlformats.org/drawingml/2006/main">
+            <a:r>
+              <a:t>A mensagem principal deste slide é: A rota muda; o checkpoint e o resultado permanecem iguais. Para tornar isso concreto, observe local: funciona offline depois do setup, Codespaces: desbloqueia o início pelo navegador e Os dois usam o mesmo course.py. Esses pontos devem ser entendidos em conjunto; não são funcionalidades isoladas. No projeto, essa combinação transforma uma convenção informal em algo que pode ser revisado, testado ou consumido de maneira consistente.</a:t>
+            </a:r>
+          </a:p>
+          <a:p xmlns:a="http://schemas.openxmlformats.org/drawingml/2006/main">
+            <a:r>
+              <a:t/>
+            </a:r>
+          </a:p>
+          <a:p xmlns:a="http://schemas.openxmlformats.org/drawingml/2006/main">
+            <a:r>
+              <a:t>O que destacar:</a:t>
+            </a:r>
+          </a:p>
+          <a:p xmlns:a="http://schemas.openxmlformats.org/drawingml/2006/main">
+            <a:r>
+              <a:t>- Comece pelo título, leia a afirmação abaixo dele e depois desenvolva os itens sem repetir o texto palavra por palavra.</a:t>
+            </a:r>
+          </a:p>
+          <a:p xmlns:a="http://schemas.openxmlformats.org/drawingml/2006/main">
+            <a:r>
+              <a:t/>
+            </a:r>
+          </a:p>
+          <a:p xmlns:a="http://schemas.openxmlformats.org/drawingml/2006/main">
+            <a:r>
+              <a:t>Transição:</a:t>
+            </a:r>
+          </a:p>
+          <a:p xmlns:a="http://schemas.openxmlformats.org/drawingml/2006/main">
+            <a:r>
+              <a:t>Com esse ponto estabelecido, avance para “Local e Codespaces chegam ao mesmo laboratório”.</a:t>
             </a:r>
           </a:p>
           <a:p xmlns:a="http://schemas.openxmlformats.org/drawingml/2006/main">
@@ -2070,7 +2770,57 @@
           <a:lstStyle xmlns:a="http://schemas.openxmlformats.org/drawingml/2006/main"/>
           <a:p xmlns:a="http://schemas.openxmlformats.org/drawingml/2006/main">
             <a:r>
-              <a:t>Use a composição para explicar visualmente: A rota muda; o checkpoint e o resultado permanecem iguais. Local: funciona offline depois do setup Codespaces: desbloqueia o início pelo navegador Os dois usam o mesmo course.py</a:t>
+              <a:t>[Roteiro recomendado]</a:t>
+            </a:r>
+          </a:p>
+          <a:p xmlns:a="http://schemas.openxmlformats.org/drawingml/2006/main">
+            <a:r>
+              <a:t>[Tempo sugerido: 00:55]</a:t>
+            </a:r>
+          </a:p>
+          <a:p xmlns:a="http://schemas.openxmlformats.org/drawingml/2006/main">
+            <a:r>
+              <a:t/>
+            </a:r>
+          </a:p>
+          <a:p xmlns:a="http://schemas.openxmlformats.org/drawingml/2006/main">
+            <a:r>
+              <a:t>Fala sugerida:</a:t>
+            </a:r>
+          </a:p>
+          <a:p xmlns:a="http://schemas.openxmlformats.org/drawingml/2006/main">
+            <a:r>
+              <a:t>Agora vamos ler a ideia visualmente. A rota muda; o checkpoint e o resultado permanecem iguais. Siga a composição na ordem mostrada e conecte local, Codespaces, Local: funciona offline depois do setup, Codespaces: desbloqueia o início pelo navegador e Os dois usam o mesmo course.py. A imagem ou o fluxo não cria uma regra nova; ele torna visível a relação que acabamos de explicar. Use a disposição dos elementos para reforçar causa, dependência ou comparação.</a:t>
+            </a:r>
+          </a:p>
+          <a:p xmlns:a="http://schemas.openxmlformats.org/drawingml/2006/main">
+            <a:r>
+              <a:t/>
+            </a:r>
+          </a:p>
+          <a:p xmlns:a="http://schemas.openxmlformats.org/drawingml/2006/main">
+            <a:r>
+              <a:t>O que destacar:</a:t>
+            </a:r>
+          </a:p>
+          <a:p xmlns:a="http://schemas.openxmlformats.org/drawingml/2006/main">
+            <a:r>
+              <a:t>- Acompanhe o fluxo ou a comparação com o cursor e preserve a ordem de leitura do slide.</a:t>
+            </a:r>
+          </a:p>
+          <a:p xmlns:a="http://schemas.openxmlformats.org/drawingml/2006/main">
+            <a:r>
+              <a:t/>
+            </a:r>
+          </a:p>
+          <a:p xmlns:a="http://schemas.openxmlformats.org/drawingml/2006/main">
+            <a:r>
+              <a:t>Transição:</a:t>
+            </a:r>
+          </a:p>
+          <a:p xmlns:a="http://schemas.openxmlformats.org/drawingml/2006/main">
+            <a:r>
+              <a:t>Com esse ponto estabelecido, avance para “Um launcher esconde diferenças do sistema”.</a:t>
             </a:r>
           </a:p>
           <a:p xmlns:a="http://schemas.openxmlformats.org/drawingml/2006/main">
@@ -2185,7 +2935,57 @@
           <a:lstStyle xmlns:a="http://schemas.openxmlformats.org/drawingml/2006/main"/>
           <a:p xmlns:a="http://schemas.openxmlformats.org/drawingml/2006/main">
             <a:r>
-              <a:t>O aluno executa a aula sem ativar virtualenv manualmente. Desenvolva os pontos: doctor encontra bloqueios; setup cria o ambiente; checkpoint executa a aula.</a:t>
+              <a:t>[Roteiro recomendado]</a:t>
+            </a:r>
+          </a:p>
+          <a:p xmlns:a="http://schemas.openxmlformats.org/drawingml/2006/main">
+            <a:r>
+              <a:t>[Tempo sugerido: 01:10]</a:t>
+            </a:r>
+          </a:p>
+          <a:p xmlns:a="http://schemas.openxmlformats.org/drawingml/2006/main">
+            <a:r>
+              <a:t/>
+            </a:r>
+          </a:p>
+          <a:p xmlns:a="http://schemas.openxmlformats.org/drawingml/2006/main">
+            <a:r>
+              <a:t>Fala sugerida:</a:t>
+            </a:r>
+          </a:p>
+          <a:p xmlns:a="http://schemas.openxmlformats.org/drawingml/2006/main">
+            <a:r>
+              <a:t>A mensagem principal deste slide é: O aluno executa a aula sem ativar virtualenv manualmente. Para tornar isso concreto, observe doctor encontra bloqueios, setup cria o ambiente e checkpoint executa a aula. Esses pontos devem ser entendidos em conjunto; não são funcionalidades isoladas. No projeto, essa combinação transforma uma convenção informal em algo que pode ser revisado, testado ou consumido de maneira consistente.</a:t>
+            </a:r>
+          </a:p>
+          <a:p xmlns:a="http://schemas.openxmlformats.org/drawingml/2006/main">
+            <a:r>
+              <a:t/>
+            </a:r>
+          </a:p>
+          <a:p xmlns:a="http://schemas.openxmlformats.org/drawingml/2006/main">
+            <a:r>
+              <a:t>O que destacar:</a:t>
+            </a:r>
+          </a:p>
+          <a:p xmlns:a="http://schemas.openxmlformats.org/drawingml/2006/main">
+            <a:r>
+              <a:t>- Comece pelo título, leia a afirmação abaixo dele e depois desenvolva os itens sem repetir o texto palavra por palavra.</a:t>
+            </a:r>
+          </a:p>
+          <a:p xmlns:a="http://schemas.openxmlformats.org/drawingml/2006/main">
+            <a:r>
+              <a:t/>
+            </a:r>
+          </a:p>
+          <a:p xmlns:a="http://schemas.openxmlformats.org/drawingml/2006/main">
+            <a:r>
+              <a:t>Transição:</a:t>
+            </a:r>
+          </a:p>
+          <a:p xmlns:a="http://schemas.openxmlformats.org/drawingml/2006/main">
+            <a:r>
+              <a:t>Com esse ponto estabelecido, avance para “Um launcher esconde diferenças do sistema”.</a:t>
             </a:r>
           </a:p>
           <a:p xmlns:a="http://schemas.openxmlformats.org/drawingml/2006/main">
@@ -2300,7 +3100,57 @@
           <a:lstStyle xmlns:a="http://schemas.openxmlformats.org/drawingml/2006/main"/>
           <a:p xmlns:a="http://schemas.openxmlformats.org/drawingml/2006/main">
             <a:r>
-              <a:t>Use a composição para explicar visualmente: O aluno executa a aula sem ativar virtualenv manualmente. doctor encontra bloqueios setup cria o ambiente checkpoint executa a aula</a:t>
+              <a:t>[Roteiro recomendado]</a:t>
+            </a:r>
+          </a:p>
+          <a:p xmlns:a="http://schemas.openxmlformats.org/drawingml/2006/main">
+            <a:r>
+              <a:t>[Tempo sugerido: 00:55]</a:t>
+            </a:r>
+          </a:p>
+          <a:p xmlns:a="http://schemas.openxmlformats.org/drawingml/2006/main">
+            <a:r>
+              <a:t/>
+            </a:r>
+          </a:p>
+          <a:p xmlns:a="http://schemas.openxmlformats.org/drawingml/2006/main">
+            <a:r>
+              <a:t>Fala sugerida:</a:t>
+            </a:r>
+          </a:p>
+          <a:p xmlns:a="http://schemas.openxmlformats.org/drawingml/2006/main">
+            <a:r>
+              <a:t>Agora vamos ler a ideia visualmente. O aluno executa a aula sem ativar virtualenv manualmente. Siga a composição na ordem mostrada e conecte seu sistema, course.py, dbt + DuckDB e checkpoint. A imagem ou o fluxo não cria uma regra nova; ele torna visível a relação que acabamos de explicar. Use a disposição dos elementos para reforçar causa, dependência ou comparação.</a:t>
+            </a:r>
+          </a:p>
+          <a:p xmlns:a="http://schemas.openxmlformats.org/drawingml/2006/main">
+            <a:r>
+              <a:t/>
+            </a:r>
+          </a:p>
+          <a:p xmlns:a="http://schemas.openxmlformats.org/drawingml/2006/main">
+            <a:r>
+              <a:t>O que destacar:</a:t>
+            </a:r>
+          </a:p>
+          <a:p xmlns:a="http://schemas.openxmlformats.org/drawingml/2006/main">
+            <a:r>
+              <a:t>- Acompanhe o fluxo ou a comparação com o cursor e preserve a ordem de leitura do slide.</a:t>
+            </a:r>
+          </a:p>
+          <a:p xmlns:a="http://schemas.openxmlformats.org/drawingml/2006/main">
+            <a:r>
+              <a:t/>
+            </a:r>
+          </a:p>
+          <a:p xmlns:a="http://schemas.openxmlformats.org/drawingml/2006/main">
+            <a:r>
+              <a:t>Transição:</a:t>
+            </a:r>
+          </a:p>
+          <a:p xmlns:a="http://schemas.openxmlformats.org/drawingml/2006/main">
+            <a:r>
+              <a:t>Com esse ponto estabelecido, avance para “Diagnóstico vem antes da tentativa e erro”.</a:t>
             </a:r>
           </a:p>
           <a:p xmlns:a="http://schemas.openxmlformats.org/drawingml/2006/main">
@@ -2415,7 +3265,57 @@
           <a:lstStyle xmlns:a="http://schemas.openxmlformats.org/drawingml/2006/main"/>
           <a:p xmlns:a="http://schemas.openxmlformats.org/drawingml/2006/main">
             <a:r>
-              <a:t>O support-report ajuda sem publicar tokens ou caminhos sensíveis. Desenvolva os pontos: Versões e permissões; Espaço e arquivos esperados; Relatório sanitizado para pedir ajuda.</a:t>
+              <a:t>[Roteiro recomendado]</a:t>
+            </a:r>
+          </a:p>
+          <a:p xmlns:a="http://schemas.openxmlformats.org/drawingml/2006/main">
+            <a:r>
+              <a:t>[Tempo sugerido: 01:10]</a:t>
+            </a:r>
+          </a:p>
+          <a:p xmlns:a="http://schemas.openxmlformats.org/drawingml/2006/main">
+            <a:r>
+              <a:t/>
+            </a:r>
+          </a:p>
+          <a:p xmlns:a="http://schemas.openxmlformats.org/drawingml/2006/main">
+            <a:r>
+              <a:t>Fala sugerida:</a:t>
+            </a:r>
+          </a:p>
+          <a:p xmlns:a="http://schemas.openxmlformats.org/drawingml/2006/main">
+            <a:r>
+              <a:t>A mensagem principal deste slide é: O support-report ajuda sem publicar tokens ou caminhos sensíveis. Para tornar isso concreto, observe versões e permissões, Espaço e arquivos esperados e Relatório sanitizado para pedir ajuda. Esses pontos devem ser entendidos em conjunto; não são funcionalidades isoladas. No projeto, essa combinação transforma uma convenção informal em algo que pode ser revisado, testado ou consumido de maneira consistente.</a:t>
+            </a:r>
+          </a:p>
+          <a:p xmlns:a="http://schemas.openxmlformats.org/drawingml/2006/main">
+            <a:r>
+              <a:t/>
+            </a:r>
+          </a:p>
+          <a:p xmlns:a="http://schemas.openxmlformats.org/drawingml/2006/main">
+            <a:r>
+              <a:t>O que destacar:</a:t>
+            </a:r>
+          </a:p>
+          <a:p xmlns:a="http://schemas.openxmlformats.org/drawingml/2006/main">
+            <a:r>
+              <a:t>- Comece pelo título, leia a afirmação abaixo dele e depois desenvolva os itens sem repetir o texto palavra por palavra.</a:t>
+            </a:r>
+          </a:p>
+          <a:p xmlns:a="http://schemas.openxmlformats.org/drawingml/2006/main">
+            <a:r>
+              <a:t/>
+            </a:r>
+          </a:p>
+          <a:p xmlns:a="http://schemas.openxmlformats.org/drawingml/2006/main">
+            <a:r>
+              <a:t>Transição:</a:t>
+            </a:r>
+          </a:p>
+          <a:p xmlns:a="http://schemas.openxmlformats.org/drawingml/2006/main">
+            <a:r>
+              <a:t>Com esse ponto estabelecido, avance para “Diagnóstico vem antes da tentativa e erro”.</a:t>
             </a:r>
           </a:p>
           <a:p xmlns:a="http://schemas.openxmlformats.org/drawingml/2006/main">
@@ -2562,7 +3462,7 @@
   </p:cSld>
   <p:clrMap bg1="lt1" tx1="dk1" bg2="lt2" tx2="dk2" accent1="accent1" accent2="accent2" accent3="accent3" accent4="accent4" accent5="accent5" accent6="accent6" hlink="hlink" folHlink="folHlink"/>
   <p:sldLayoutIdLst>
-    <p:sldLayoutId xmlns:r="http://schemas.openxmlformats.org/officeDocument/2006/relationships" id="2147483649" r:id="Rd5434dc8d38d48fe"/>
+    <p:sldLayoutId xmlns:r="http://schemas.openxmlformats.org/officeDocument/2006/relationships" id="2147483649" r:id="R7fb389b9ccda4914"/>
   </p:sldLayoutIdLst>
   <p:txStyles>
     <p:titleStyle>
@@ -2860,8 +3760,8 @@
   </p:cSld>
   <p:clrMap bg1="lt1" tx1="dk1" bg2="lt2" tx2="dk2" accent1="accent1" accent2="accent2" accent3="accent3" accent4="accent4" accent5="accent5" accent6="accent6" hlink="hlink" folHlink="folHlink"/>
   <p:sldLayoutIdLst>
-    <p:sldLayoutId xmlns:r="http://schemas.openxmlformats.org/officeDocument/2006/relationships" id="2147483651" r:id="R697316c6c5ec4a3d"/>
-    <p:sldLayoutId xmlns:r="http://schemas.openxmlformats.org/officeDocument/2006/relationships" id="2147483652" r:id="R9442e1dcde424ec5"/>
+    <p:sldLayoutId xmlns:r="http://schemas.openxmlformats.org/officeDocument/2006/relationships" id="2147483651" r:id="Rb76cb26d75464e99"/>
+    <p:sldLayoutId xmlns:r="http://schemas.openxmlformats.org/officeDocument/2006/relationships" id="2147483652" r:id="R631472c0372848ca"/>
   </p:sldLayoutIdLst>
 </p:sldMaster>
 </file>
@@ -3385,14 +4285,14 @@
       </p:grpSpPr>
       <p:pic>
         <p:nvPicPr>
-          <p:cNvPr id="9" name="" descr="Ilustração conceitual autoral da capa: AULA 0 — Prepare seu laboratório dbt sem sofrer com o ambiente."/>
+          <p:cNvPr id="10" name="" descr="Ilustração conceitual autoral da capa: AULA 0 — Prepare seu laboratório dbt sem sofrer com o ambiente."/>
           <p:cNvPicPr>
             <a:picLocks xmlns:a="http://schemas.openxmlformats.org/drawingml/2006/main" noChangeAspect="1"/>
           </p:cNvPicPr>
           <p:nvPr/>
         </p:nvPicPr>
         <p:blipFill>
-          <a:blip xmlns:r="http://schemas.openxmlformats.org/officeDocument/2006/relationships" xmlns:a="http://schemas.openxmlformats.org/drawingml/2006/main" r:embed="Re2917d8b52174884"/>
+          <a:blip xmlns:r="http://schemas.openxmlformats.org/officeDocument/2006/relationships" xmlns:a="http://schemas.openxmlformats.org/drawingml/2006/main" r:embed="R9b05625ee2c3478f"/>
           <a:srcRect xmlns:a="http://schemas.openxmlformats.org/drawingml/2006/main" l="19785" t="0" r="19785" b="0"/>
           <a:stretch xmlns:a="http://schemas.openxmlformats.org/drawingml/2006/main">
             <a:fillRect l="0" t="0" r="0" b="0"/>
@@ -3505,6 +4405,7 @@
           <a:lstStyle xmlns:a="http://schemas.openxmlformats.org/drawingml/2006/main"/>
           <a:p xmlns:a="http://schemas.openxmlformats.org/drawingml/2006/main">
             <a:pPr>
+              <a:buNone/>
               <a:defRPr sz="1350" b="1">
                 <a:solidFill>
                   <a:srgbClr val="1EC5FF"/>
@@ -3555,6 +4456,7 @@
           <a:lstStyle xmlns:a="http://schemas.openxmlformats.org/drawingml/2006/main"/>
           <a:p xmlns:a="http://schemas.openxmlformats.org/drawingml/2006/main">
             <a:pPr>
+              <a:buNone/>
               <a:defRPr sz="3225" b="1">
                 <a:solidFill>
                   <a:srgbClr val="FFFFFF"/>
@@ -3605,6 +4507,7 @@
           <a:lstStyle xmlns:a="http://schemas.openxmlformats.org/drawingml/2006/main"/>
           <a:p xmlns:a="http://schemas.openxmlformats.org/drawingml/2006/main">
             <a:pPr>
+              <a:buNone/>
               <a:defRPr sz="1800">
                 <a:solidFill>
                   <a:srgbClr val="E2F2FF"/>
@@ -3686,6 +4589,7 @@
           <a:lstStyle xmlns:a="http://schemas.openxmlformats.org/drawingml/2006/main"/>
           <a:p xmlns:a="http://schemas.openxmlformats.org/drawingml/2006/main">
             <a:pPr>
+              <a:buNone/>
               <a:defRPr sz="1200" b="1">
                 <a:solidFill>
                   <a:srgbClr val="FFFFFF">
@@ -3777,6 +4681,7 @@
           <a:lstStyle xmlns:a="http://schemas.openxmlformats.org/drawingml/2006/main"/>
           <a:p xmlns:a="http://schemas.openxmlformats.org/drawingml/2006/main">
             <a:pPr>
+              <a:buNone/>
               <a:defRPr sz="2925" b="1">
                 <a:solidFill>
                   <a:srgbClr val="FFFFFF"/>
@@ -3860,6 +4765,7 @@
           <a:lstStyle xmlns:a="http://schemas.openxmlformats.org/drawingml/2006/main"/>
           <a:p xmlns:a="http://schemas.openxmlformats.org/drawingml/2006/main">
             <a:pPr algn="ctr">
+              <a:buNone/>
               <a:defRPr sz="1575" b="1">
                 <a:solidFill>
                   <a:srgbClr val="FFFFFF"/>
@@ -3943,6 +4849,7 @@
           <a:lstStyle xmlns:a="http://schemas.openxmlformats.org/drawingml/2006/main"/>
           <a:p xmlns:a="http://schemas.openxmlformats.org/drawingml/2006/main">
             <a:pPr algn="ctr">
+              <a:buNone/>
               <a:defRPr sz="1575" b="1">
                 <a:solidFill>
                   <a:srgbClr val="FFFFFF"/>
@@ -4026,6 +4933,7 @@
           <a:lstStyle xmlns:a="http://schemas.openxmlformats.org/drawingml/2006/main"/>
           <a:p xmlns:a="http://schemas.openxmlformats.org/drawingml/2006/main">
             <a:pPr algn="ctr">
+              <a:buNone/>
               <a:defRPr sz="1575" b="1">
                 <a:solidFill>
                   <a:srgbClr val="FFFFFF"/>
@@ -4076,6 +4984,7 @@
           <a:lstStyle xmlns:a="http://schemas.openxmlformats.org/drawingml/2006/main"/>
           <a:p xmlns:a="http://schemas.openxmlformats.org/drawingml/2006/main">
             <a:pPr>
+              <a:buNone/>
               <a:defRPr sz="1050" b="1">
                 <a:solidFill>
                   <a:srgbClr val="1EC5FF"/>
@@ -4159,6 +5068,7 @@
           <a:lstStyle xmlns:a="http://schemas.openxmlformats.org/drawingml/2006/main"/>
           <a:p xmlns:a="http://schemas.openxmlformats.org/drawingml/2006/main">
             <a:pPr>
+              <a:buNone/>
               <a:defRPr sz="825">
                 <a:solidFill>
                   <a:srgbClr val="FFFFFF">
@@ -4213,6 +5123,7 @@
           <a:lstStyle xmlns:a="http://schemas.openxmlformats.org/drawingml/2006/main"/>
           <a:p xmlns:a="http://schemas.openxmlformats.org/drawingml/2006/main">
             <a:pPr algn="r">
+              <a:buNone/>
               <a:defRPr sz="825" b="1">
                 <a:solidFill>
                   <a:srgbClr val="FFFFFF">
@@ -4304,6 +5215,7 @@
           <a:lstStyle xmlns:a="http://schemas.openxmlformats.org/drawingml/2006/main"/>
           <a:p xmlns:a="http://schemas.openxmlformats.org/drawingml/2006/main">
             <a:pPr>
+              <a:buNone/>
               <a:defRPr sz="2925" b="1">
                 <a:solidFill>
                   <a:srgbClr val="FFFFFF"/>
@@ -4389,6 +5301,7 @@
           <a:lstStyle xmlns:a="http://schemas.openxmlformats.org/drawingml/2006/main"/>
           <a:p xmlns:a="http://schemas.openxmlformats.org/drawingml/2006/main">
             <a:pPr>
+              <a:buNone/>
               <a:defRPr sz="1875" b="1">
                 <a:solidFill>
                   <a:srgbClr val="1EC5FF"/>
@@ -4406,6 +5319,7 @@
           </a:p>
           <a:p xmlns:a="http://schemas.openxmlformats.org/drawingml/2006/main">
             <a:pPr>
+              <a:buNone/>
               <a:defRPr sz="1875" b="1">
                 <a:solidFill>
                   <a:srgbClr val="1EC5FF"/>
@@ -4456,6 +5370,7 @@
           <a:lstStyle xmlns:a="http://schemas.openxmlformats.org/drawingml/2006/main"/>
           <a:p xmlns:a="http://schemas.openxmlformats.org/drawingml/2006/main">
             <a:pPr>
+              <a:buNone/>
               <a:defRPr sz="1425">
                 <a:solidFill>
                   <a:srgbClr val="E2F2FF"/>
@@ -4506,6 +5421,7 @@
           <a:lstStyle xmlns:a="http://schemas.openxmlformats.org/drawingml/2006/main"/>
           <a:p xmlns:a="http://schemas.openxmlformats.org/drawingml/2006/main">
             <a:pPr>
+              <a:buNone/>
               <a:defRPr sz="1050" b="1">
                 <a:solidFill>
                   <a:srgbClr val="1EC5FF"/>
@@ -4589,6 +5505,7 @@
           <a:lstStyle xmlns:a="http://schemas.openxmlformats.org/drawingml/2006/main"/>
           <a:p xmlns:a="http://schemas.openxmlformats.org/drawingml/2006/main">
             <a:pPr>
+              <a:buNone/>
               <a:defRPr sz="825">
                 <a:solidFill>
                   <a:srgbClr val="FFFFFF">
@@ -4643,6 +5560,7 @@
           <a:lstStyle xmlns:a="http://schemas.openxmlformats.org/drawingml/2006/main"/>
           <a:p xmlns:a="http://schemas.openxmlformats.org/drawingml/2006/main">
             <a:pPr algn="r">
+              <a:buNone/>
               <a:defRPr sz="825" b="1">
                 <a:solidFill>
                   <a:srgbClr val="FFFFFF">
@@ -4726,6 +5644,7 @@
           <a:lstStyle xmlns:a="http://schemas.openxmlformats.org/drawingml/2006/main"/>
           <a:p xmlns:a="http://schemas.openxmlformats.org/drawingml/2006/main">
             <a:pPr>
+              <a:buNone/>
               <a:defRPr sz="2925" b="1">
                 <a:solidFill>
                   <a:srgbClr val="0B1F3A"/>
@@ -4776,6 +5695,7 @@
           <a:lstStyle xmlns:a="http://schemas.openxmlformats.org/drawingml/2006/main"/>
           <a:p xmlns:a="http://schemas.openxmlformats.org/drawingml/2006/main">
             <a:pPr>
+              <a:buNone/>
               <a:defRPr sz="3450" b="1">
                 <a:solidFill>
                   <a:srgbClr val="1565C0"/>
@@ -4826,6 +5746,7 @@
           <a:lstStyle xmlns:a="http://schemas.openxmlformats.org/drawingml/2006/main"/>
           <a:p xmlns:a="http://schemas.openxmlformats.org/drawingml/2006/main">
             <a:pPr>
+              <a:buNone/>
               <a:defRPr sz="1575" b="1">
                 <a:solidFill>
                   <a:srgbClr val="0B1F3A"/>
@@ -4907,6 +5828,7 @@
           <a:lstStyle xmlns:a="http://schemas.openxmlformats.org/drawingml/2006/main"/>
           <a:p xmlns:a="http://schemas.openxmlformats.org/drawingml/2006/main">
             <a:pPr>
+              <a:buNone/>
               <a:defRPr sz="3450" b="1">
                 <a:solidFill>
                   <a:srgbClr val="1565C0"/>
@@ -4957,6 +5879,7 @@
           <a:lstStyle xmlns:a="http://schemas.openxmlformats.org/drawingml/2006/main"/>
           <a:p xmlns:a="http://schemas.openxmlformats.org/drawingml/2006/main">
             <a:pPr>
+              <a:buNone/>
               <a:defRPr sz="1575" b="1">
                 <a:solidFill>
                   <a:srgbClr val="0B1F3A"/>
@@ -5038,6 +5961,7 @@
           <a:lstStyle xmlns:a="http://schemas.openxmlformats.org/drawingml/2006/main"/>
           <a:p xmlns:a="http://schemas.openxmlformats.org/drawingml/2006/main">
             <a:pPr>
+              <a:buNone/>
               <a:defRPr sz="3450" b="1">
                 <a:solidFill>
                   <a:srgbClr val="1565C0"/>
@@ -5088,6 +6012,7 @@
           <a:lstStyle xmlns:a="http://schemas.openxmlformats.org/drawingml/2006/main"/>
           <a:p xmlns:a="http://schemas.openxmlformats.org/drawingml/2006/main">
             <a:pPr>
+              <a:buNone/>
               <a:defRPr sz="1575" b="1">
                 <a:solidFill>
                   <a:srgbClr val="0B1F3A"/>
@@ -5138,6 +6063,7 @@
           <a:lstStyle xmlns:a="http://schemas.openxmlformats.org/drawingml/2006/main"/>
           <a:p xmlns:a="http://schemas.openxmlformats.org/drawingml/2006/main">
             <a:pPr>
+              <a:buNone/>
               <a:defRPr sz="1050" b="1">
                 <a:solidFill>
                   <a:srgbClr val="1565C0"/>
@@ -5221,6 +6147,7 @@
           <a:lstStyle xmlns:a="http://schemas.openxmlformats.org/drawingml/2006/main"/>
           <a:p xmlns:a="http://schemas.openxmlformats.org/drawingml/2006/main">
             <a:pPr>
+              <a:buNone/>
               <a:defRPr sz="825">
                 <a:solidFill>
                   <a:srgbClr val="0B1F3A">
@@ -5275,6 +6202,7 @@
           <a:lstStyle xmlns:a="http://schemas.openxmlformats.org/drawingml/2006/main"/>
           <a:p xmlns:a="http://schemas.openxmlformats.org/drawingml/2006/main">
             <a:pPr algn="r">
+              <a:buNone/>
               <a:defRPr sz="825" b="1">
                 <a:solidFill>
                   <a:srgbClr val="0B1F3A">
@@ -5366,6 +6294,7 @@
           <a:lstStyle xmlns:a="http://schemas.openxmlformats.org/drawingml/2006/main"/>
           <a:p xmlns:a="http://schemas.openxmlformats.org/drawingml/2006/main">
             <a:pPr>
+              <a:buNone/>
               <a:defRPr sz="1350" b="1">
                 <a:solidFill>
                   <a:srgbClr val="1EC5FF"/>
@@ -5416,6 +6345,7 @@
           <a:lstStyle xmlns:a="http://schemas.openxmlformats.org/drawingml/2006/main"/>
           <a:p xmlns:a="http://schemas.openxmlformats.org/drawingml/2006/main">
             <a:pPr>
+              <a:buNone/>
               <a:defRPr sz="3450" b="1">
                 <a:solidFill>
                   <a:srgbClr val="FFFFFF"/>
@@ -5466,6 +6396,7 @@
           <a:lstStyle xmlns:a="http://schemas.openxmlformats.org/drawingml/2006/main"/>
           <a:p xmlns:a="http://schemas.openxmlformats.org/drawingml/2006/main">
             <a:pPr>
+              <a:buNone/>
               <a:defRPr sz="1650">
                 <a:solidFill>
                   <a:srgbClr val="E2F2FF"/>
@@ -5590,6 +6521,7 @@
           <a:lstStyle xmlns:a="http://schemas.openxmlformats.org/drawingml/2006/main"/>
           <a:p xmlns:a="http://schemas.openxmlformats.org/drawingml/2006/main">
             <a:pPr>
+              <a:buNone/>
               <a:defRPr sz="1050" b="1">
                 <a:solidFill>
                   <a:srgbClr val="1EC5FF"/>
@@ -5673,6 +6605,7 @@
           <a:lstStyle xmlns:a="http://schemas.openxmlformats.org/drawingml/2006/main"/>
           <a:p xmlns:a="http://schemas.openxmlformats.org/drawingml/2006/main">
             <a:pPr>
+              <a:buNone/>
               <a:defRPr sz="825">
                 <a:solidFill>
                   <a:srgbClr val="FFFFFF">
@@ -5727,6 +6660,7 @@
           <a:lstStyle xmlns:a="http://schemas.openxmlformats.org/drawingml/2006/main"/>
           <a:p xmlns:a="http://schemas.openxmlformats.org/drawingml/2006/main">
             <a:pPr algn="r">
+              <a:buNone/>
               <a:defRPr sz="825" b="1">
                 <a:solidFill>
                   <a:srgbClr val="FFFFFF">
@@ -5810,6 +6744,7 @@
           <a:lstStyle xmlns:a="http://schemas.openxmlformats.org/drawingml/2006/main"/>
           <a:p xmlns:a="http://schemas.openxmlformats.org/drawingml/2006/main">
             <a:pPr>
+              <a:buNone/>
               <a:defRPr sz="2925" b="1">
                 <a:solidFill>
                   <a:srgbClr val="0B1F3A"/>
@@ -5860,6 +6795,7 @@
           <a:lstStyle xmlns:a="http://schemas.openxmlformats.org/drawingml/2006/main"/>
           <a:p xmlns:a="http://schemas.openxmlformats.org/drawingml/2006/main">
             <a:pPr>
+              <a:buNone/>
               <a:defRPr sz="3450" b="1">
                 <a:solidFill>
                   <a:srgbClr val="1565C0"/>
@@ -5910,6 +6846,7 @@
           <a:lstStyle xmlns:a="http://schemas.openxmlformats.org/drawingml/2006/main"/>
           <a:p xmlns:a="http://schemas.openxmlformats.org/drawingml/2006/main">
             <a:pPr>
+              <a:buNone/>
               <a:defRPr sz="1575" b="1">
                 <a:solidFill>
                   <a:srgbClr val="0B1F3A"/>
@@ -5991,6 +6928,7 @@
           <a:lstStyle xmlns:a="http://schemas.openxmlformats.org/drawingml/2006/main"/>
           <a:p xmlns:a="http://schemas.openxmlformats.org/drawingml/2006/main">
             <a:pPr>
+              <a:buNone/>
               <a:defRPr sz="3450" b="1">
                 <a:solidFill>
                   <a:srgbClr val="1565C0"/>
@@ -6041,6 +6979,7 @@
           <a:lstStyle xmlns:a="http://schemas.openxmlformats.org/drawingml/2006/main"/>
           <a:p xmlns:a="http://schemas.openxmlformats.org/drawingml/2006/main">
             <a:pPr>
+              <a:buNone/>
               <a:defRPr sz="1575" b="1">
                 <a:solidFill>
                   <a:srgbClr val="0B1F3A"/>
@@ -6122,6 +7061,7 @@
           <a:lstStyle xmlns:a="http://schemas.openxmlformats.org/drawingml/2006/main"/>
           <a:p xmlns:a="http://schemas.openxmlformats.org/drawingml/2006/main">
             <a:pPr>
+              <a:buNone/>
               <a:defRPr sz="3450" b="1">
                 <a:solidFill>
                   <a:srgbClr val="1565C0"/>
@@ -6172,6 +7112,7 @@
           <a:lstStyle xmlns:a="http://schemas.openxmlformats.org/drawingml/2006/main"/>
           <a:p xmlns:a="http://schemas.openxmlformats.org/drawingml/2006/main">
             <a:pPr>
+              <a:buNone/>
               <a:defRPr sz="1575" b="1">
                 <a:solidFill>
                   <a:srgbClr val="0B1F3A"/>
@@ -6222,6 +7163,7 @@
           <a:lstStyle xmlns:a="http://schemas.openxmlformats.org/drawingml/2006/main"/>
           <a:p xmlns:a="http://schemas.openxmlformats.org/drawingml/2006/main">
             <a:pPr>
+              <a:buNone/>
               <a:defRPr sz="1050" b="1">
                 <a:solidFill>
                   <a:srgbClr val="1565C0"/>
@@ -6305,6 +7247,7 @@
           <a:lstStyle xmlns:a="http://schemas.openxmlformats.org/drawingml/2006/main"/>
           <a:p xmlns:a="http://schemas.openxmlformats.org/drawingml/2006/main">
             <a:pPr>
+              <a:buNone/>
               <a:defRPr sz="825">
                 <a:solidFill>
                   <a:srgbClr val="0B1F3A">
@@ -6359,6 +7302,7 @@
           <a:lstStyle xmlns:a="http://schemas.openxmlformats.org/drawingml/2006/main"/>
           <a:p xmlns:a="http://schemas.openxmlformats.org/drawingml/2006/main">
             <a:pPr algn="r">
+              <a:buNone/>
               <a:defRPr sz="825" b="1">
                 <a:solidFill>
                   <a:srgbClr val="0B1F3A">
@@ -6450,6 +7394,7 @@
           <a:lstStyle xmlns:a="http://schemas.openxmlformats.org/drawingml/2006/main"/>
           <a:p xmlns:a="http://schemas.openxmlformats.org/drawingml/2006/main">
             <a:pPr>
+              <a:buNone/>
               <a:defRPr sz="5550" b="1">
                 <a:solidFill>
                   <a:srgbClr val="1EC5FF"/>
@@ -6500,6 +7445,7 @@
           <a:lstStyle xmlns:a="http://schemas.openxmlformats.org/drawingml/2006/main"/>
           <a:p xmlns:a="http://schemas.openxmlformats.org/drawingml/2006/main">
             <a:pPr>
+              <a:buNone/>
               <a:defRPr sz="2250" b="1">
                 <a:solidFill>
                   <a:srgbClr val="FFFFFF"/>
@@ -6583,6 +7529,7 @@
           <a:lstStyle xmlns:a="http://schemas.openxmlformats.org/drawingml/2006/main"/>
           <a:p xmlns:a="http://schemas.openxmlformats.org/drawingml/2006/main">
             <a:pPr>
+              <a:buNone/>
               <a:defRPr sz="1800">
                 <a:solidFill>
                   <a:srgbClr val="E2F2FF"/>
@@ -6633,6 +7580,7 @@
           <a:lstStyle xmlns:a="http://schemas.openxmlformats.org/drawingml/2006/main"/>
           <a:p xmlns:a="http://schemas.openxmlformats.org/drawingml/2006/main">
             <a:pPr>
+              <a:buNone/>
               <a:defRPr sz="1050" b="1">
                 <a:solidFill>
                   <a:srgbClr val="1EC5FF"/>
@@ -6716,6 +7664,7 @@
           <a:lstStyle xmlns:a="http://schemas.openxmlformats.org/drawingml/2006/main"/>
           <a:p xmlns:a="http://schemas.openxmlformats.org/drawingml/2006/main">
             <a:pPr>
+              <a:buNone/>
               <a:defRPr sz="825">
                 <a:solidFill>
                   <a:srgbClr val="FFFFFF">
@@ -6770,6 +7719,7 @@
           <a:lstStyle xmlns:a="http://schemas.openxmlformats.org/drawingml/2006/main"/>
           <a:p xmlns:a="http://schemas.openxmlformats.org/drawingml/2006/main">
             <a:pPr algn="r">
+              <a:buNone/>
               <a:defRPr sz="825" b="1">
                 <a:solidFill>
                   <a:srgbClr val="FFFFFF">
@@ -6853,6 +7803,7 @@
           <a:lstStyle xmlns:a="http://schemas.openxmlformats.org/drawingml/2006/main"/>
           <a:p xmlns:a="http://schemas.openxmlformats.org/drawingml/2006/main">
             <a:pPr>
+              <a:buNone/>
               <a:defRPr sz="2925" b="1">
                 <a:solidFill>
                   <a:srgbClr val="0B1F3A"/>
@@ -6903,6 +7854,7 @@
           <a:lstStyle xmlns:a="http://schemas.openxmlformats.org/drawingml/2006/main"/>
           <a:p xmlns:a="http://schemas.openxmlformats.org/drawingml/2006/main">
             <a:pPr>
+              <a:buNone/>
               <a:defRPr sz="1950">
                 <a:solidFill>
                   <a:srgbClr val="0B1F3A"/>
@@ -6920,6 +7872,7 @@
           </a:p>
           <a:p xmlns:a="http://schemas.openxmlformats.org/drawingml/2006/main">
             <a:pPr>
+              <a:buNone/>
               <a:defRPr sz="1950">
                 <a:solidFill>
                   <a:srgbClr val="0B1F3A"/>
@@ -6937,6 +7890,7 @@
           </a:p>
           <a:p xmlns:a="http://schemas.openxmlformats.org/drawingml/2006/main">
             <a:pPr>
+              <a:buNone/>
               <a:defRPr sz="1950">
                 <a:solidFill>
                   <a:srgbClr val="0B1F3A"/>
@@ -6987,6 +7941,7 @@
           <a:lstStyle xmlns:a="http://schemas.openxmlformats.org/drawingml/2006/main"/>
           <a:p xmlns:a="http://schemas.openxmlformats.org/drawingml/2006/main">
             <a:pPr>
+              <a:buNone/>
               <a:defRPr sz="1050" b="1">
                 <a:solidFill>
                   <a:srgbClr val="1565C0"/>
@@ -7070,6 +8025,7 @@
           <a:lstStyle xmlns:a="http://schemas.openxmlformats.org/drawingml/2006/main"/>
           <a:p xmlns:a="http://schemas.openxmlformats.org/drawingml/2006/main">
             <a:pPr>
+              <a:buNone/>
               <a:defRPr sz="825">
                 <a:solidFill>
                   <a:srgbClr val="0B1F3A">
@@ -7124,6 +8080,7 @@
           <a:lstStyle xmlns:a="http://schemas.openxmlformats.org/drawingml/2006/main"/>
           <a:p xmlns:a="http://schemas.openxmlformats.org/drawingml/2006/main">
             <a:pPr algn="r">
+              <a:buNone/>
               <a:defRPr sz="825" b="1">
                 <a:solidFill>
                   <a:srgbClr val="0B1F3A">
@@ -7215,6 +8172,7 @@
           <a:lstStyle xmlns:a="http://schemas.openxmlformats.org/drawingml/2006/main"/>
           <a:p xmlns:a="http://schemas.openxmlformats.org/drawingml/2006/main">
             <a:pPr>
+              <a:buNone/>
               <a:defRPr sz="1500" b="1">
                 <a:solidFill>
                   <a:srgbClr val="1EC5FF"/>
@@ -7265,6 +8223,7 @@
           <a:lstStyle xmlns:a="http://schemas.openxmlformats.org/drawingml/2006/main"/>
           <a:p xmlns:a="http://schemas.openxmlformats.org/drawingml/2006/main">
             <a:pPr>
+              <a:buNone/>
               <a:defRPr sz="2850" b="1">
                 <a:solidFill>
                   <a:srgbClr val="FFFFFF"/>
@@ -7315,6 +8274,7 @@
           <a:lstStyle xmlns:a="http://schemas.openxmlformats.org/drawingml/2006/main"/>
           <a:p xmlns:a="http://schemas.openxmlformats.org/drawingml/2006/main">
             <a:pPr>
+              <a:buNone/>
               <a:defRPr sz="1500">
                 <a:solidFill>
                   <a:srgbClr val="E2F2FF"/>
@@ -7439,6 +8399,7 @@
           <a:lstStyle xmlns:a="http://schemas.openxmlformats.org/drawingml/2006/main"/>
           <a:p xmlns:a="http://schemas.openxmlformats.org/drawingml/2006/main">
             <a:pPr>
+              <a:buNone/>
               <a:defRPr sz="1050" b="1">
                 <a:solidFill>
                   <a:srgbClr val="1EC5FF"/>
@@ -7522,6 +8483,7 @@
           <a:lstStyle xmlns:a="http://schemas.openxmlformats.org/drawingml/2006/main"/>
           <a:p xmlns:a="http://schemas.openxmlformats.org/drawingml/2006/main">
             <a:pPr>
+              <a:buNone/>
               <a:defRPr sz="825">
                 <a:solidFill>
                   <a:srgbClr val="FFFFFF">
@@ -7576,6 +8538,7 @@
           <a:lstStyle xmlns:a="http://schemas.openxmlformats.org/drawingml/2006/main"/>
           <a:p xmlns:a="http://schemas.openxmlformats.org/drawingml/2006/main">
             <a:pPr algn="r">
+              <a:buNone/>
               <a:defRPr sz="825" b="1">
                 <a:solidFill>
                   <a:srgbClr val="FFFFFF">
@@ -7659,6 +8622,7 @@
           <a:lstStyle xmlns:a="http://schemas.openxmlformats.org/drawingml/2006/main"/>
           <a:p xmlns:a="http://schemas.openxmlformats.org/drawingml/2006/main">
             <a:pPr>
+              <a:buNone/>
               <a:defRPr sz="1350" b="1">
                 <a:solidFill>
                   <a:srgbClr val="1565C0"/>
@@ -7709,6 +8673,7 @@
           <a:lstStyle xmlns:a="http://schemas.openxmlformats.org/drawingml/2006/main"/>
           <a:p xmlns:a="http://schemas.openxmlformats.org/drawingml/2006/main">
             <a:pPr>
+              <a:buNone/>
               <a:defRPr sz="3300" b="1">
                 <a:solidFill>
                   <a:srgbClr val="0B1F3A"/>
@@ -7759,6 +8724,7 @@
           <a:lstStyle xmlns:a="http://schemas.openxmlformats.org/drawingml/2006/main"/>
           <a:p xmlns:a="http://schemas.openxmlformats.org/drawingml/2006/main">
             <a:pPr>
+              <a:buNone/>
               <a:defRPr sz="1500">
                 <a:solidFill>
                   <a:srgbClr val="5C6F86"/>
@@ -7809,6 +8775,7 @@
           <a:lstStyle xmlns:a="http://schemas.openxmlformats.org/drawingml/2006/main"/>
           <a:p xmlns:a="http://schemas.openxmlformats.org/drawingml/2006/main">
             <a:pPr>
+              <a:buNone/>
               <a:defRPr sz="1050" b="1">
                 <a:solidFill>
                   <a:srgbClr val="1565C0"/>
@@ -7892,6 +8859,7 @@
           <a:lstStyle xmlns:a="http://schemas.openxmlformats.org/drawingml/2006/main"/>
           <a:p xmlns:a="http://schemas.openxmlformats.org/drawingml/2006/main">
             <a:pPr>
+              <a:buNone/>
               <a:defRPr sz="825">
                 <a:solidFill>
                   <a:srgbClr val="0B1F3A">
@@ -7946,6 +8914,7 @@
           <a:lstStyle xmlns:a="http://schemas.openxmlformats.org/drawingml/2006/main"/>
           <a:p xmlns:a="http://schemas.openxmlformats.org/drawingml/2006/main">
             <a:pPr algn="r">
+              <a:buNone/>
               <a:defRPr sz="825" b="1">
                 <a:solidFill>
                   <a:srgbClr val="0B1F3A">
@@ -8029,6 +8998,7 @@
           <a:lstStyle xmlns:a="http://schemas.openxmlformats.org/drawingml/2006/main"/>
           <a:p xmlns:a="http://schemas.openxmlformats.org/drawingml/2006/main">
             <a:pPr>
+              <a:buNone/>
               <a:defRPr sz="2850" b="1">
                 <a:solidFill>
                   <a:srgbClr val="0B1F3A"/>
@@ -8110,6 +9080,7 @@
           <a:lstStyle xmlns:a="http://schemas.openxmlformats.org/drawingml/2006/main"/>
           <a:p xmlns:a="http://schemas.openxmlformats.org/drawingml/2006/main">
             <a:pPr>
+              <a:buNone/>
               <a:defRPr sz="1425" b="1">
                 <a:solidFill>
                   <a:srgbClr val="1565C0"/>
@@ -8164,14 +9135,14 @@
       </p:sp>
       <p:pic>
         <p:nvPicPr>
-          <p:cNvPr id="14" name="" descr="Diagrama didático autoral que apresenta: Você termina com um build, testes e artifacts — não apenas com uma instalação que parece funcionar. — A pergunta que guia a aula."/>
+          <p:cNvPr id="16" name="" descr="Diagrama didático autoral que apresenta: Você termina com um build, testes e artifacts — não apenas com uma instalação que parece funcionar. — A pergunta que guia a aula."/>
           <p:cNvPicPr>
             <a:picLocks xmlns:a="http://schemas.openxmlformats.org/drawingml/2006/main" noChangeAspect="1"/>
           </p:cNvPicPr>
           <p:nvPr/>
         </p:nvPicPr>
         <p:blipFill>
-          <a:blip xmlns:r="http://schemas.openxmlformats.org/officeDocument/2006/relationships" xmlns:a="http://schemas.openxmlformats.org/drawingml/2006/main" r:embed="Re29f31dd513d4790"/>
+          <a:blip xmlns:r="http://schemas.openxmlformats.org/officeDocument/2006/relationships" xmlns:a="http://schemas.openxmlformats.org/drawingml/2006/main" r:embed="R01acf5f406e246ce"/>
           <a:stretch xmlns:a="http://schemas.openxmlformats.org/drawingml/2006/main"/>
         </p:blipFill>
         <p:spPr>
@@ -8217,6 +9188,7 @@
           <a:lstStyle xmlns:a="http://schemas.openxmlformats.org/drawingml/2006/main"/>
           <a:p xmlns:a="http://schemas.openxmlformats.org/drawingml/2006/main">
             <a:pPr>
+              <a:buNone/>
               <a:defRPr sz="1050" b="1">
                 <a:solidFill>
                   <a:srgbClr val="1565C0"/>
@@ -8300,6 +9272,7 @@
           <a:lstStyle xmlns:a="http://schemas.openxmlformats.org/drawingml/2006/main"/>
           <a:p xmlns:a="http://schemas.openxmlformats.org/drawingml/2006/main">
             <a:pPr>
+              <a:buNone/>
               <a:defRPr sz="825">
                 <a:solidFill>
                   <a:srgbClr val="0B1F3A">
@@ -8354,6 +9327,7 @@
           <a:lstStyle xmlns:a="http://schemas.openxmlformats.org/drawingml/2006/main"/>
           <a:p xmlns:a="http://schemas.openxmlformats.org/drawingml/2006/main">
             <a:pPr algn="r">
+              <a:buNone/>
               <a:defRPr sz="825" b="1">
                 <a:solidFill>
                   <a:srgbClr val="0B1F3A">
@@ -8445,6 +9419,7 @@
           <a:lstStyle xmlns:a="http://schemas.openxmlformats.org/drawingml/2006/main"/>
           <a:p xmlns:a="http://schemas.openxmlformats.org/drawingml/2006/main">
             <a:pPr>
+              <a:buNone/>
               <a:defRPr sz="2925" b="1">
                 <a:solidFill>
                   <a:srgbClr val="FFFFFF"/>
@@ -8495,6 +9470,7 @@
           <a:lstStyle xmlns:a="http://schemas.openxmlformats.org/drawingml/2006/main"/>
           <a:p xmlns:a="http://schemas.openxmlformats.org/drawingml/2006/main">
             <a:pPr>
+              <a:buNone/>
               <a:defRPr sz="3450" b="1">
                 <a:solidFill>
                   <a:srgbClr val="1EC5FF"/>
@@ -8545,6 +9521,7 @@
           <a:lstStyle xmlns:a="http://schemas.openxmlformats.org/drawingml/2006/main"/>
           <a:p xmlns:a="http://schemas.openxmlformats.org/drawingml/2006/main">
             <a:pPr>
+              <a:buNone/>
               <a:defRPr sz="1575" b="1">
                 <a:solidFill>
                   <a:srgbClr val="FFFFFF"/>
@@ -8626,6 +9603,7 @@
           <a:lstStyle xmlns:a="http://schemas.openxmlformats.org/drawingml/2006/main"/>
           <a:p xmlns:a="http://schemas.openxmlformats.org/drawingml/2006/main">
             <a:pPr>
+              <a:buNone/>
               <a:defRPr sz="3450" b="1">
                 <a:solidFill>
                   <a:srgbClr val="1EC5FF"/>
@@ -8676,6 +9654,7 @@
           <a:lstStyle xmlns:a="http://schemas.openxmlformats.org/drawingml/2006/main"/>
           <a:p xmlns:a="http://schemas.openxmlformats.org/drawingml/2006/main">
             <a:pPr>
+              <a:buNone/>
               <a:defRPr sz="1575" b="1">
                 <a:solidFill>
                   <a:srgbClr val="FFFFFF"/>
@@ -8757,6 +9736,7 @@
           <a:lstStyle xmlns:a="http://schemas.openxmlformats.org/drawingml/2006/main"/>
           <a:p xmlns:a="http://schemas.openxmlformats.org/drawingml/2006/main">
             <a:pPr>
+              <a:buNone/>
               <a:defRPr sz="3450" b="1">
                 <a:solidFill>
                   <a:srgbClr val="1EC5FF"/>
@@ -8807,6 +9787,7 @@
           <a:lstStyle xmlns:a="http://schemas.openxmlformats.org/drawingml/2006/main"/>
           <a:p xmlns:a="http://schemas.openxmlformats.org/drawingml/2006/main">
             <a:pPr>
+              <a:buNone/>
               <a:defRPr sz="1575" b="1">
                 <a:solidFill>
                   <a:srgbClr val="FFFFFF"/>
@@ -8857,6 +9838,7 @@
           <a:lstStyle xmlns:a="http://schemas.openxmlformats.org/drawingml/2006/main"/>
           <a:p xmlns:a="http://schemas.openxmlformats.org/drawingml/2006/main">
             <a:pPr>
+              <a:buNone/>
               <a:defRPr sz="1050" b="1">
                 <a:solidFill>
                   <a:srgbClr val="1EC5FF"/>
@@ -8940,6 +9922,7 @@
           <a:lstStyle xmlns:a="http://schemas.openxmlformats.org/drawingml/2006/main"/>
           <a:p xmlns:a="http://schemas.openxmlformats.org/drawingml/2006/main">
             <a:pPr>
+              <a:buNone/>
               <a:defRPr sz="825">
                 <a:solidFill>
                   <a:srgbClr val="FFFFFF">
@@ -8994,6 +9977,7 @@
           <a:lstStyle xmlns:a="http://schemas.openxmlformats.org/drawingml/2006/main"/>
           <a:p xmlns:a="http://schemas.openxmlformats.org/drawingml/2006/main">
             <a:pPr algn="r">
+              <a:buNone/>
               <a:defRPr sz="825" b="1">
                 <a:solidFill>
                   <a:srgbClr val="FFFFFF">
@@ -9085,6 +10069,7 @@
           <a:lstStyle xmlns:a="http://schemas.openxmlformats.org/drawingml/2006/main"/>
           <a:p xmlns:a="http://schemas.openxmlformats.org/drawingml/2006/main">
             <a:pPr>
+              <a:buNone/>
               <a:defRPr sz="2925" b="1">
                 <a:solidFill>
                   <a:srgbClr val="FFFFFF"/>
@@ -9135,6 +10120,7 @@
           <a:lstStyle xmlns:a="http://schemas.openxmlformats.org/drawingml/2006/main"/>
           <a:p xmlns:a="http://schemas.openxmlformats.org/drawingml/2006/main">
             <a:pPr>
+              <a:buNone/>
               <a:defRPr sz="1650">
                 <a:solidFill>
                   <a:srgbClr val="E2F2FF"/>
@@ -9185,6 +10171,7 @@
           <a:lstStyle xmlns:a="http://schemas.openxmlformats.org/drawingml/2006/main"/>
           <a:p xmlns:a="http://schemas.openxmlformats.org/drawingml/2006/main">
             <a:pPr>
+              <a:buNone/>
               <a:defRPr sz="1800">
                 <a:solidFill>
                   <a:srgbClr val="FFFFFF"/>
@@ -9202,6 +10189,7 @@
           </a:p>
           <a:p xmlns:a="http://schemas.openxmlformats.org/drawingml/2006/main">
             <a:pPr>
+              <a:buNone/>
               <a:defRPr sz="1800">
                 <a:solidFill>
                   <a:srgbClr val="FFFFFF"/>
@@ -9219,6 +10207,7 @@
           </a:p>
           <a:p xmlns:a="http://schemas.openxmlformats.org/drawingml/2006/main">
             <a:pPr>
+              <a:buNone/>
               <a:defRPr sz="1800">
                 <a:solidFill>
                   <a:srgbClr val="FFFFFF"/>
@@ -9343,6 +10332,7 @@
           <a:lstStyle xmlns:a="http://schemas.openxmlformats.org/drawingml/2006/main"/>
           <a:p xmlns:a="http://schemas.openxmlformats.org/drawingml/2006/main">
             <a:pPr algn="ctr">
+              <a:buNone/>
               <a:defRPr sz="4650" b="1">
                 <a:solidFill>
                   <a:srgbClr val="1EC5FF"/>
@@ -9393,6 +10383,7 @@
           <a:lstStyle xmlns:a="http://schemas.openxmlformats.org/drawingml/2006/main"/>
           <a:p xmlns:a="http://schemas.openxmlformats.org/drawingml/2006/main">
             <a:pPr>
+              <a:buNone/>
               <a:defRPr sz="1050" b="1">
                 <a:solidFill>
                   <a:srgbClr val="1EC5FF"/>
@@ -9476,6 +10467,7 @@
           <a:lstStyle xmlns:a="http://schemas.openxmlformats.org/drawingml/2006/main"/>
           <a:p xmlns:a="http://schemas.openxmlformats.org/drawingml/2006/main">
             <a:pPr>
+              <a:buNone/>
               <a:defRPr sz="825">
                 <a:solidFill>
                   <a:srgbClr val="FFFFFF">
@@ -9530,6 +10522,7 @@
           <a:lstStyle xmlns:a="http://schemas.openxmlformats.org/drawingml/2006/main"/>
           <a:p xmlns:a="http://schemas.openxmlformats.org/drawingml/2006/main">
             <a:pPr algn="r">
+              <a:buNone/>
               <a:defRPr sz="825" b="1">
                 <a:solidFill>
                   <a:srgbClr val="FFFFFF">
@@ -9613,6 +10606,7 @@
           <a:lstStyle xmlns:a="http://schemas.openxmlformats.org/drawingml/2006/main"/>
           <a:p xmlns:a="http://schemas.openxmlformats.org/drawingml/2006/main">
             <a:pPr>
+              <a:buNone/>
               <a:defRPr sz="2925" b="1">
                 <a:solidFill>
                   <a:srgbClr val="0B1F3A"/>
@@ -9663,6 +10657,7 @@
           <a:lstStyle xmlns:a="http://schemas.openxmlformats.org/drawingml/2006/main"/>
           <a:p xmlns:a="http://schemas.openxmlformats.org/drawingml/2006/main">
             <a:pPr>
+              <a:buNone/>
               <a:defRPr sz="1650">
                 <a:solidFill>
                   <a:srgbClr val="5C6F86"/>
@@ -9713,6 +10708,7 @@
           <a:lstStyle xmlns:a="http://schemas.openxmlformats.org/drawingml/2006/main"/>
           <a:p xmlns:a="http://schemas.openxmlformats.org/drawingml/2006/main">
             <a:pPr>
+              <a:buNone/>
               <a:defRPr sz="1800">
                 <a:solidFill>
                   <a:srgbClr val="0B1F3A"/>
@@ -9730,6 +10726,7 @@
           </a:p>
           <a:p xmlns:a="http://schemas.openxmlformats.org/drawingml/2006/main">
             <a:pPr>
+              <a:buNone/>
               <a:defRPr sz="1800">
                 <a:solidFill>
                   <a:srgbClr val="0B1F3A"/>
@@ -9747,6 +10744,7 @@
           </a:p>
           <a:p xmlns:a="http://schemas.openxmlformats.org/drawingml/2006/main">
             <a:pPr>
+              <a:buNone/>
               <a:defRPr sz="1800">
                 <a:solidFill>
                   <a:srgbClr val="0B1F3A"/>
@@ -9871,6 +10869,7 @@
           <a:lstStyle xmlns:a="http://schemas.openxmlformats.org/drawingml/2006/main"/>
           <a:p xmlns:a="http://schemas.openxmlformats.org/drawingml/2006/main">
             <a:pPr algn="ctr">
+              <a:buNone/>
               <a:defRPr sz="4650" b="1">
                 <a:solidFill>
                   <a:srgbClr val="1565C0"/>
@@ -9921,6 +10920,7 @@
           <a:lstStyle xmlns:a="http://schemas.openxmlformats.org/drawingml/2006/main"/>
           <a:p xmlns:a="http://schemas.openxmlformats.org/drawingml/2006/main">
             <a:pPr>
+              <a:buNone/>
               <a:defRPr sz="1050" b="1">
                 <a:solidFill>
                   <a:srgbClr val="1565C0"/>
@@ -10004,6 +11004,7 @@
           <a:lstStyle xmlns:a="http://schemas.openxmlformats.org/drawingml/2006/main"/>
           <a:p xmlns:a="http://schemas.openxmlformats.org/drawingml/2006/main">
             <a:pPr>
+              <a:buNone/>
               <a:defRPr sz="825">
                 <a:solidFill>
                   <a:srgbClr val="0B1F3A">
@@ -10058,6 +11059,7 @@
           <a:lstStyle xmlns:a="http://schemas.openxmlformats.org/drawingml/2006/main"/>
           <a:p xmlns:a="http://schemas.openxmlformats.org/drawingml/2006/main">
             <a:pPr algn="r">
+              <a:buNone/>
               <a:defRPr sz="825" b="1">
                 <a:solidFill>
                   <a:srgbClr val="0B1F3A">
@@ -10149,6 +11151,7 @@
           <a:lstStyle xmlns:a="http://schemas.openxmlformats.org/drawingml/2006/main"/>
           <a:p xmlns:a="http://schemas.openxmlformats.org/drawingml/2006/main">
             <a:pPr>
+              <a:buNone/>
               <a:defRPr sz="2925" b="1">
                 <a:solidFill>
                   <a:srgbClr val="FFFFFF"/>
@@ -10199,6 +11202,7 @@
           <a:lstStyle xmlns:a="http://schemas.openxmlformats.org/drawingml/2006/main"/>
           <a:p xmlns:a="http://schemas.openxmlformats.org/drawingml/2006/main">
             <a:pPr>
+              <a:buNone/>
               <a:defRPr sz="2100" b="1">
                 <a:solidFill>
                   <a:srgbClr val="1EC5FF"/>
@@ -10249,6 +11253,7 @@
           <a:lstStyle xmlns:a="http://schemas.openxmlformats.org/drawingml/2006/main"/>
           <a:p xmlns:a="http://schemas.openxmlformats.org/drawingml/2006/main">
             <a:pPr>
+              <a:buNone/>
               <a:defRPr sz="2100" b="1">
                 <a:solidFill>
                   <a:srgbClr val="2DBE8C"/>
@@ -10332,6 +11337,7 @@
           <a:lstStyle xmlns:a="http://schemas.openxmlformats.org/drawingml/2006/main"/>
           <a:p xmlns:a="http://schemas.openxmlformats.org/drawingml/2006/main">
             <a:pPr>
+              <a:buNone/>
               <a:defRPr sz="1650">
                 <a:solidFill>
                   <a:srgbClr val="FFFFFF"/>
@@ -10349,6 +11355,7 @@
           </a:p>
           <a:p xmlns:a="http://schemas.openxmlformats.org/drawingml/2006/main">
             <a:pPr>
+              <a:buNone/>
               <a:defRPr sz="1650">
                 <a:solidFill>
                   <a:srgbClr val="FFFFFF"/>
@@ -10399,6 +11406,7 @@
           <a:lstStyle xmlns:a="http://schemas.openxmlformats.org/drawingml/2006/main"/>
           <a:p xmlns:a="http://schemas.openxmlformats.org/drawingml/2006/main">
             <a:pPr>
+              <a:buNone/>
               <a:defRPr sz="1650">
                 <a:solidFill>
                   <a:srgbClr val="FFFFFF"/>
@@ -10449,6 +11457,7 @@
           <a:lstStyle xmlns:a="http://schemas.openxmlformats.org/drawingml/2006/main"/>
           <a:p xmlns:a="http://schemas.openxmlformats.org/drawingml/2006/main">
             <a:pPr>
+              <a:buNone/>
               <a:defRPr sz="1050" b="1">
                 <a:solidFill>
                   <a:srgbClr val="1EC5FF"/>
@@ -10532,6 +11541,7 @@
           <a:lstStyle xmlns:a="http://schemas.openxmlformats.org/drawingml/2006/main"/>
           <a:p xmlns:a="http://schemas.openxmlformats.org/drawingml/2006/main">
             <a:pPr>
+              <a:buNone/>
               <a:defRPr sz="825">
                 <a:solidFill>
                   <a:srgbClr val="FFFFFF">
@@ -10586,6 +11596,7 @@
           <a:lstStyle xmlns:a="http://schemas.openxmlformats.org/drawingml/2006/main"/>
           <a:p xmlns:a="http://schemas.openxmlformats.org/drawingml/2006/main">
             <a:pPr algn="r">
+              <a:buNone/>
               <a:defRPr sz="825" b="1">
                 <a:solidFill>
                   <a:srgbClr val="FFFFFF">
@@ -10677,6 +11688,7 @@
           <a:lstStyle xmlns:a="http://schemas.openxmlformats.org/drawingml/2006/main"/>
           <a:p xmlns:a="http://schemas.openxmlformats.org/drawingml/2006/main">
             <a:pPr>
+              <a:buNone/>
               <a:defRPr sz="2925" b="1">
                 <a:solidFill>
                   <a:srgbClr val="FFFFFF"/>
@@ -10727,6 +11739,7 @@
           <a:lstStyle xmlns:a="http://schemas.openxmlformats.org/drawingml/2006/main"/>
           <a:p xmlns:a="http://schemas.openxmlformats.org/drawingml/2006/main">
             <a:pPr>
+              <a:buNone/>
               <a:defRPr sz="1650">
                 <a:solidFill>
                   <a:srgbClr val="E2F2FF"/>
@@ -10777,6 +11790,7 @@
           <a:lstStyle xmlns:a="http://schemas.openxmlformats.org/drawingml/2006/main"/>
           <a:p xmlns:a="http://schemas.openxmlformats.org/drawingml/2006/main">
             <a:pPr>
+              <a:buNone/>
               <a:defRPr sz="1800">
                 <a:solidFill>
                   <a:srgbClr val="FFFFFF"/>
@@ -10794,6 +11808,7 @@
           </a:p>
           <a:p xmlns:a="http://schemas.openxmlformats.org/drawingml/2006/main">
             <a:pPr>
+              <a:buNone/>
               <a:defRPr sz="1800">
                 <a:solidFill>
                   <a:srgbClr val="FFFFFF"/>
@@ -10811,6 +11826,7 @@
           </a:p>
           <a:p xmlns:a="http://schemas.openxmlformats.org/drawingml/2006/main">
             <a:pPr>
+              <a:buNone/>
               <a:defRPr sz="1800">
                 <a:solidFill>
                   <a:srgbClr val="FFFFFF"/>
@@ -10935,6 +11951,7 @@
           <a:lstStyle xmlns:a="http://schemas.openxmlformats.org/drawingml/2006/main"/>
           <a:p xmlns:a="http://schemas.openxmlformats.org/drawingml/2006/main">
             <a:pPr algn="ctr">
+              <a:buNone/>
               <a:defRPr sz="4650" b="1">
                 <a:solidFill>
                   <a:srgbClr val="1EC5FF"/>
@@ -10985,6 +12002,7 @@
           <a:lstStyle xmlns:a="http://schemas.openxmlformats.org/drawingml/2006/main"/>
           <a:p xmlns:a="http://schemas.openxmlformats.org/drawingml/2006/main">
             <a:pPr>
+              <a:buNone/>
               <a:defRPr sz="1050" b="1">
                 <a:solidFill>
                   <a:srgbClr val="1EC5FF"/>
@@ -11068,6 +12086,7 @@
           <a:lstStyle xmlns:a="http://schemas.openxmlformats.org/drawingml/2006/main"/>
           <a:p xmlns:a="http://schemas.openxmlformats.org/drawingml/2006/main">
             <a:pPr>
+              <a:buNone/>
               <a:defRPr sz="825">
                 <a:solidFill>
                   <a:srgbClr val="FFFFFF">
@@ -11122,6 +12141,7 @@
           <a:lstStyle xmlns:a="http://schemas.openxmlformats.org/drawingml/2006/main"/>
           <a:p xmlns:a="http://schemas.openxmlformats.org/drawingml/2006/main">
             <a:pPr algn="r">
+              <a:buNone/>
               <a:defRPr sz="825" b="1">
                 <a:solidFill>
                   <a:srgbClr val="FFFFFF">
@@ -11205,6 +12225,7 @@
           <a:lstStyle xmlns:a="http://schemas.openxmlformats.org/drawingml/2006/main"/>
           <a:p xmlns:a="http://schemas.openxmlformats.org/drawingml/2006/main">
             <a:pPr>
+              <a:buNone/>
               <a:defRPr sz="2925" b="1">
                 <a:solidFill>
                   <a:srgbClr val="0B1F3A"/>
@@ -11261,6 +12282,7 @@
           <a:lstStyle xmlns:a="http://schemas.openxmlformats.org/drawingml/2006/main"/>
           <a:p xmlns:a="http://schemas.openxmlformats.org/drawingml/2006/main">
             <a:pPr algn="ctr">
+              <a:buNone/>
               <a:defRPr sz="1575" b="1">
                 <a:solidFill>
                   <a:srgbClr val="0B1F3A"/>
@@ -11317,6 +12339,7 @@
           <a:lstStyle xmlns:a="http://schemas.openxmlformats.org/drawingml/2006/main"/>
           <a:p xmlns:a="http://schemas.openxmlformats.org/drawingml/2006/main">
             <a:pPr algn="ctr">
+              <a:buNone/>
               <a:defRPr sz="1575" b="1">
                 <a:solidFill>
                   <a:srgbClr val="0B1F3A"/>
@@ -11373,6 +12396,7 @@
           <a:lstStyle xmlns:a="http://schemas.openxmlformats.org/drawingml/2006/main"/>
           <a:p xmlns:a="http://schemas.openxmlformats.org/drawingml/2006/main">
             <a:pPr algn="ctr">
+              <a:buNone/>
               <a:defRPr sz="1575" b="1">
                 <a:solidFill>
                   <a:srgbClr val="0B1F3A"/>
@@ -11429,6 +12453,7 @@
           <a:lstStyle xmlns:a="http://schemas.openxmlformats.org/drawingml/2006/main"/>
           <a:p xmlns:a="http://schemas.openxmlformats.org/drawingml/2006/main">
             <a:pPr algn="ctr">
+              <a:buNone/>
               <a:defRPr sz="1575" b="1">
                 <a:solidFill>
                   <a:srgbClr val="0B1F3A"/>
@@ -11448,7 +12473,7 @@
       </p:sp>
       <p:cxnSp>
         <p:nvCxnSpPr>
-          <p:cNvPr id="18" name=""/>
+          <p:cNvPr id="26" name=""/>
           <p:cNvCxnSpPr>
             <a:stCxn xmlns:a="http://schemas.openxmlformats.org/drawingml/2006/main" id="2" idx="3"/>
             <a:endCxn xmlns:a="http://schemas.openxmlformats.org/drawingml/2006/main" id="3" idx="1"/>
@@ -11474,7 +12499,7 @@
       </p:cxnSp>
       <p:cxnSp>
         <p:nvCxnSpPr>
-          <p:cNvPr id="19" name=""/>
+          <p:cNvPr id="27" name=""/>
           <p:cNvCxnSpPr>
             <a:stCxn xmlns:a="http://schemas.openxmlformats.org/drawingml/2006/main" id="3" idx="3"/>
             <a:endCxn xmlns:a="http://schemas.openxmlformats.org/drawingml/2006/main" id="4" idx="1"/>
@@ -11500,7 +12525,7 @@
       </p:cxnSp>
       <p:cxnSp>
         <p:nvCxnSpPr>
-          <p:cNvPr id="20" name=""/>
+          <p:cNvPr id="28" name=""/>
           <p:cNvCxnSpPr>
             <a:stCxn xmlns:a="http://schemas.openxmlformats.org/drawingml/2006/main" id="4" idx="3"/>
             <a:endCxn xmlns:a="http://schemas.openxmlformats.org/drawingml/2006/main" id="5" idx="1"/>
@@ -11557,6 +12582,7 @@
           <a:lstStyle xmlns:a="http://schemas.openxmlformats.org/drawingml/2006/main"/>
           <a:p xmlns:a="http://schemas.openxmlformats.org/drawingml/2006/main">
             <a:pPr>
+              <a:buNone/>
               <a:defRPr sz="1050" b="1">
                 <a:solidFill>
                   <a:srgbClr val="1565C0"/>
@@ -11640,6 +12666,7 @@
           <a:lstStyle xmlns:a="http://schemas.openxmlformats.org/drawingml/2006/main"/>
           <a:p xmlns:a="http://schemas.openxmlformats.org/drawingml/2006/main">
             <a:pPr>
+              <a:buNone/>
               <a:defRPr sz="825">
                 <a:solidFill>
                   <a:srgbClr val="0B1F3A">
@@ -11694,6 +12721,7 @@
           <a:lstStyle xmlns:a="http://schemas.openxmlformats.org/drawingml/2006/main"/>
           <a:p xmlns:a="http://schemas.openxmlformats.org/drawingml/2006/main">
             <a:pPr algn="r">
+              <a:buNone/>
               <a:defRPr sz="825" b="1">
                 <a:solidFill>
                   <a:srgbClr val="0B1F3A">
@@ -11777,6 +12805,7 @@
           <a:lstStyle xmlns:a="http://schemas.openxmlformats.org/drawingml/2006/main"/>
           <a:p xmlns:a="http://schemas.openxmlformats.org/drawingml/2006/main">
             <a:pPr>
+              <a:buNone/>
               <a:defRPr sz="2925" b="1">
                 <a:solidFill>
                   <a:srgbClr val="0B1F3A"/>
@@ -11827,6 +12856,7 @@
           <a:lstStyle xmlns:a="http://schemas.openxmlformats.org/drawingml/2006/main"/>
           <a:p xmlns:a="http://schemas.openxmlformats.org/drawingml/2006/main">
             <a:pPr>
+              <a:buNone/>
               <a:defRPr sz="1650">
                 <a:solidFill>
                   <a:srgbClr val="5C6F86"/>
@@ -11877,6 +12907,7 @@
           <a:lstStyle xmlns:a="http://schemas.openxmlformats.org/drawingml/2006/main"/>
           <a:p xmlns:a="http://schemas.openxmlformats.org/drawingml/2006/main">
             <a:pPr>
+              <a:buNone/>
               <a:defRPr sz="1800">
                 <a:solidFill>
                   <a:srgbClr val="0B1F3A"/>
@@ -11894,6 +12925,7 @@
           </a:p>
           <a:p xmlns:a="http://schemas.openxmlformats.org/drawingml/2006/main">
             <a:pPr>
+              <a:buNone/>
               <a:defRPr sz="1800">
                 <a:solidFill>
                   <a:srgbClr val="0B1F3A"/>
@@ -11911,6 +12943,7 @@
           </a:p>
           <a:p xmlns:a="http://schemas.openxmlformats.org/drawingml/2006/main">
             <a:pPr>
+              <a:buNone/>
               <a:defRPr sz="1800">
                 <a:solidFill>
                   <a:srgbClr val="0B1F3A"/>
@@ -12035,6 +13068,7 @@
           <a:lstStyle xmlns:a="http://schemas.openxmlformats.org/drawingml/2006/main"/>
           <a:p xmlns:a="http://schemas.openxmlformats.org/drawingml/2006/main">
             <a:pPr algn="ctr">
+              <a:buNone/>
               <a:defRPr sz="4650" b="1">
                 <a:solidFill>
                   <a:srgbClr val="1565C0"/>
@@ -12085,6 +13119,7 @@
           <a:lstStyle xmlns:a="http://schemas.openxmlformats.org/drawingml/2006/main"/>
           <a:p xmlns:a="http://schemas.openxmlformats.org/drawingml/2006/main">
             <a:pPr>
+              <a:buNone/>
               <a:defRPr sz="1050" b="1">
                 <a:solidFill>
                   <a:srgbClr val="1565C0"/>
@@ -12168,6 +13203,7 @@
           <a:lstStyle xmlns:a="http://schemas.openxmlformats.org/drawingml/2006/main"/>
           <a:p xmlns:a="http://schemas.openxmlformats.org/drawingml/2006/main">
             <a:pPr>
+              <a:buNone/>
               <a:defRPr sz="825">
                 <a:solidFill>
                   <a:srgbClr val="0B1F3A">
@@ -12222,6 +13258,7 @@
           <a:lstStyle xmlns:a="http://schemas.openxmlformats.org/drawingml/2006/main"/>
           <a:p xmlns:a="http://schemas.openxmlformats.org/drawingml/2006/main">
             <a:pPr algn="r">
+              <a:buNone/>
               <a:defRPr sz="825" b="1">
                 <a:solidFill>
                   <a:srgbClr val="0B1F3A">

</xml_diff>

<commit_message>
docs: alinha Aula 0 com DuckDB UI
</commit_message>
<xml_diff>
--- a/assets/decks/aula-00-ambiente.pptx
+++ b/assets/decks/aula-00-ambiente.pptx
@@ -2,35 +2,35 @@
 <file path=ppt/presentation.xml><?xml version="1.0" encoding="utf-8"?>
 <p:presentation xmlns:p="http://schemas.openxmlformats.org/presentationml/2006/main">
   <p:sldMasterIdLst>
-    <p:sldMasterId xmlns:r="http://schemas.openxmlformats.org/officeDocument/2006/relationships" id="2147483648" r:id="R72e5172c51af42a3"/>
-    <p:sldMasterId xmlns:r="http://schemas.openxmlformats.org/officeDocument/2006/relationships" id="2147483650" r:id="R3ed0c62bd35b4fa7"/>
+    <p:sldMasterId xmlns:r="http://schemas.openxmlformats.org/officeDocument/2006/relationships" id="2147483648" r:id="R2cdf756852eb4a42"/>
+    <p:sldMasterId xmlns:r="http://schemas.openxmlformats.org/officeDocument/2006/relationships" id="2147483650" r:id="Rd56d015f13274f96"/>
   </p:sldMasterIdLst>
   <p:notesMasterIdLst>
-    <p:notesMasterId xmlns:r="http://schemas.openxmlformats.org/officeDocument/2006/relationships" r:id="R39726bc2e8264eb3"/>
+    <p:notesMasterId xmlns:r="http://schemas.openxmlformats.org/officeDocument/2006/relationships" r:id="Rf145efaa8b624fc5"/>
   </p:notesMasterIdLst>
   <p:sldIdLst>
-    <p:sldId xmlns:r="http://schemas.openxmlformats.org/officeDocument/2006/relationships" id="256" r:id="R5686984863e44c85"/>
-    <p:sldId xmlns:r="http://schemas.openxmlformats.org/officeDocument/2006/relationships" id="257" r:id="R0ad09488d3e04fd8"/>
-    <p:sldId xmlns:r="http://schemas.openxmlformats.org/officeDocument/2006/relationships" id="258" r:id="Rf7b2810f451a450c"/>
-    <p:sldId xmlns:r="http://schemas.openxmlformats.org/officeDocument/2006/relationships" id="259" r:id="R674110ee85e546f5"/>
-    <p:sldId xmlns:r="http://schemas.openxmlformats.org/officeDocument/2006/relationships" id="260" r:id="R4917cd22ed024e29"/>
-    <p:sldId xmlns:r="http://schemas.openxmlformats.org/officeDocument/2006/relationships" id="261" r:id="Ra015d4441b374914"/>
-    <p:sldId xmlns:r="http://schemas.openxmlformats.org/officeDocument/2006/relationships" id="262" r:id="R77aa314ef1294e6a"/>
-    <p:sldId xmlns:r="http://schemas.openxmlformats.org/officeDocument/2006/relationships" id="263" r:id="R4a7c9184ab4c4105"/>
-    <p:sldId xmlns:r="http://schemas.openxmlformats.org/officeDocument/2006/relationships" id="264" r:id="R9ae0a9882fec42c4"/>
-    <p:sldId xmlns:r="http://schemas.openxmlformats.org/officeDocument/2006/relationships" id="265" r:id="R42d6045d2fd44126"/>
-    <p:sldId xmlns:r="http://schemas.openxmlformats.org/officeDocument/2006/relationships" id="266" r:id="R5a31ae384f07426b"/>
-    <p:sldId xmlns:r="http://schemas.openxmlformats.org/officeDocument/2006/relationships" id="267" r:id="R248ba1084aaa47df"/>
-    <p:sldId xmlns:r="http://schemas.openxmlformats.org/officeDocument/2006/relationships" id="268" r:id="R688eb6b52e294d8d"/>
-    <p:sldId xmlns:r="http://schemas.openxmlformats.org/officeDocument/2006/relationships" id="269" r:id="Rb5e45949629c489b"/>
-    <p:sldId xmlns:r="http://schemas.openxmlformats.org/officeDocument/2006/relationships" id="270" r:id="Ra40aede61e5d42f3"/>
-    <p:sldId xmlns:r="http://schemas.openxmlformats.org/officeDocument/2006/relationships" id="271" r:id="R798871a3b4684975"/>
-    <p:sldId xmlns:r="http://schemas.openxmlformats.org/officeDocument/2006/relationships" id="272" r:id="R76e46bcd57764ffe"/>
-    <p:sldId xmlns:r="http://schemas.openxmlformats.org/officeDocument/2006/relationships" id="273" r:id="R28dda564b5df4152"/>
-    <p:sldId xmlns:r="http://schemas.openxmlformats.org/officeDocument/2006/relationships" id="274" r:id="Refd5d44827094f9d"/>
-    <p:sldId xmlns:r="http://schemas.openxmlformats.org/officeDocument/2006/relationships" id="275" r:id="R04e40a93714c4f7c"/>
-    <p:sldId xmlns:r="http://schemas.openxmlformats.org/officeDocument/2006/relationships" id="276" r:id="R20a50ae290574228"/>
-    <p:sldId xmlns:r="http://schemas.openxmlformats.org/officeDocument/2006/relationships" id="277" r:id="R9b11fae998424c53"/>
+    <p:sldId xmlns:r="http://schemas.openxmlformats.org/officeDocument/2006/relationships" id="256" r:id="R598257d628f04eb2"/>
+    <p:sldId xmlns:r="http://schemas.openxmlformats.org/officeDocument/2006/relationships" id="257" r:id="R1c72c6260b964ae4"/>
+    <p:sldId xmlns:r="http://schemas.openxmlformats.org/officeDocument/2006/relationships" id="258" r:id="R43b0f2cbb6b846f1"/>
+    <p:sldId xmlns:r="http://schemas.openxmlformats.org/officeDocument/2006/relationships" id="259" r:id="Rfd27a0f0a1334be9"/>
+    <p:sldId xmlns:r="http://schemas.openxmlformats.org/officeDocument/2006/relationships" id="260" r:id="R096a49cccc80432f"/>
+    <p:sldId xmlns:r="http://schemas.openxmlformats.org/officeDocument/2006/relationships" id="261" r:id="Raad7281d8030418b"/>
+    <p:sldId xmlns:r="http://schemas.openxmlformats.org/officeDocument/2006/relationships" id="262" r:id="R56fe5049679e4cf0"/>
+    <p:sldId xmlns:r="http://schemas.openxmlformats.org/officeDocument/2006/relationships" id="263" r:id="R222ba59fdd4144ef"/>
+    <p:sldId xmlns:r="http://schemas.openxmlformats.org/officeDocument/2006/relationships" id="264" r:id="R378320da6ac1477b"/>
+    <p:sldId xmlns:r="http://schemas.openxmlformats.org/officeDocument/2006/relationships" id="265" r:id="Ra79e06bdac584763"/>
+    <p:sldId xmlns:r="http://schemas.openxmlformats.org/officeDocument/2006/relationships" id="266" r:id="R2f91e56e75694ec8"/>
+    <p:sldId xmlns:r="http://schemas.openxmlformats.org/officeDocument/2006/relationships" id="267" r:id="Rcd50333d4aad469d"/>
+    <p:sldId xmlns:r="http://schemas.openxmlformats.org/officeDocument/2006/relationships" id="268" r:id="R886512bd4f7f45b5"/>
+    <p:sldId xmlns:r="http://schemas.openxmlformats.org/officeDocument/2006/relationships" id="269" r:id="Rc824342c927643d0"/>
+    <p:sldId xmlns:r="http://schemas.openxmlformats.org/officeDocument/2006/relationships" id="270" r:id="R85f2e4329dee4ce5"/>
+    <p:sldId xmlns:r="http://schemas.openxmlformats.org/officeDocument/2006/relationships" id="271" r:id="R6c27c2e0a467478f"/>
+    <p:sldId xmlns:r="http://schemas.openxmlformats.org/officeDocument/2006/relationships" id="272" r:id="Rc8d3b7b28fe24767"/>
+    <p:sldId xmlns:r="http://schemas.openxmlformats.org/officeDocument/2006/relationships" id="273" r:id="R6dec51814432475b"/>
+    <p:sldId xmlns:r="http://schemas.openxmlformats.org/officeDocument/2006/relationships" id="274" r:id="R58bb461460bc4405"/>
+    <p:sldId xmlns:r="http://schemas.openxmlformats.org/officeDocument/2006/relationships" id="275" r:id="Rbef5bf8cb0f54770"/>
+    <p:sldId xmlns:r="http://schemas.openxmlformats.org/officeDocument/2006/relationships" id="276" r:id="R9b596c8f01024046"/>
+    <p:sldId xmlns:r="http://schemas.openxmlformats.org/officeDocument/2006/relationships" id="277" r:id="R1e87f65560d4415f"/>
   </p:sldIdLst>
   <p:sldSz cx="12192000" cy="6858000"/>
   <p:notesSz cx="6858000" cy="9144000"/>
@@ -549,6 +549,16 @@
           </a:p>
           <a:p xmlns:a="http://schemas.openxmlformats.org/drawingml/2006/main">
             <a:r>
+              <a:t>- https://docs.github.com/en/codespaces/reference/security-in-github-codespaces</a:t>
+            </a:r>
+          </a:p>
+          <a:p xmlns:a="http://schemas.openxmlformats.org/drawingml/2006/main">
+            <a:r>
+              <a:t>- https://duckdb.org/docs/current/core_extensions/ui</a:t>
+            </a:r>
+          </a:p>
+          <a:p xmlns:a="http://schemas.openxmlformats.org/drawingml/2006/main">
+            <a:r>
               <a:t>- https://docs.getdbt.com/guides/manual-install?step=1</a:t>
             </a:r>
           </a:p>
@@ -664,7 +674,7 @@
           </a:p>
           <a:p xmlns:a="http://schemas.openxmlformats.org/drawingml/2006/main">
             <a:r>
-              <a:t>Agora vamos ler a ideia visualmente. O dev container executa setup na criação e doctor a cada abertura. Siga a composição na ordem mostrada e conecte create, setup, doctor e checkpoint. A imagem ou o fluxo não cria uma regra nova; ele torna visível a relação que acabamos de explicar. Use a disposição dos elementos para reforçar causa, dependência ou comparação.</a:t>
+              <a:t>Agora vamos ler a ideia visualmente. Setup instala uma vez; a reabertura restaura PATH, profile e caminhos detectados. Siga a composição na ordem mostrada e conecte create, setup, paths e checkpoint. A imagem ou o fluxo não cria uma regra nova; ele torna visível a relação que acabamos de explicar. Use a disposição dos elementos para reforçar causa, dependência ou comparação.</a:t>
             </a:r>
           </a:p>
           <a:p xmlns:a="http://schemas.openxmlformats.org/drawingml/2006/main">
@@ -725,6 +735,16 @@
           <a:p xmlns:a="http://schemas.openxmlformats.org/drawingml/2006/main">
             <a:r>
               <a:t>- https://docs.github.com/en/codespaces/developing-in-a-codespace/stopping-and-starting-a-codespace</a:t>
+            </a:r>
+          </a:p>
+          <a:p xmlns:a="http://schemas.openxmlformats.org/drawingml/2006/main">
+            <a:r>
+              <a:t>- https://docs.github.com/en/codespaces/reference/security-in-github-codespaces</a:t>
+            </a:r>
+          </a:p>
+          <a:p xmlns:a="http://schemas.openxmlformats.org/drawingml/2006/main">
+            <a:r>
+              <a:t>- https://duckdb.org/docs/current/core_extensions/ui</a:t>
             </a:r>
           </a:p>
           <a:p xmlns:a="http://schemas.openxmlformats.org/drawingml/2006/main">
@@ -909,6 +929,16 @@
           </a:p>
           <a:p xmlns:a="http://schemas.openxmlformats.org/drawingml/2006/main">
             <a:r>
+              <a:t>- https://docs.github.com/en/codespaces/reference/security-in-github-codespaces</a:t>
+            </a:r>
+          </a:p>
+          <a:p xmlns:a="http://schemas.openxmlformats.org/drawingml/2006/main">
+            <a:r>
+              <a:t>- https://duckdb.org/docs/current/core_extensions/ui</a:t>
+            </a:r>
+          </a:p>
+          <a:p xmlns:a="http://schemas.openxmlformats.org/drawingml/2006/main">
+            <a:r>
               <a:t>- https://docs.getdbt.com/guides/manual-install?step=1</a:t>
             </a:r>
           </a:p>
@@ -1054,7 +1084,7 @@
           </a:p>
           <a:p xmlns:a="http://schemas.openxmlformats.org/drawingml/2006/main">
             <a:r>
-              <a:t>Com esse ponto estabelecido, avance para “Local continua sendo a rota alternativa”.</a:t>
+              <a:t>Com esse ponto estabelecido, avance para “Explore a cópia do banco no navegador”.</a:t>
             </a:r>
           </a:p>
           <a:p xmlns:a="http://schemas.openxmlformats.org/drawingml/2006/main">
@@ -1085,6 +1115,16 @@
           <a:p xmlns:a="http://schemas.openxmlformats.org/drawingml/2006/main">
             <a:r>
               <a:t>- https://docs.github.com/en/codespaces/developing-in-a-codespace/stopping-and-starting-a-codespace</a:t>
+            </a:r>
+          </a:p>
+          <a:p xmlns:a="http://schemas.openxmlformats.org/drawingml/2006/main">
+            <a:r>
+              <a:t>- https://docs.github.com/en/codespaces/reference/security-in-github-codespaces</a:t>
+            </a:r>
+          </a:p>
+          <a:p xmlns:a="http://schemas.openxmlformats.org/drawingml/2006/main">
+            <a:r>
+              <a:t>- https://duckdb.org/docs/current/core_extensions/ui</a:t>
             </a:r>
           </a:p>
           <a:p xmlns:a="http://schemas.openxmlformats.org/drawingml/2006/main">
@@ -1209,7 +1249,7 @@
           </a:p>
           <a:p xmlns:a="http://schemas.openxmlformats.org/drawingml/2006/main">
             <a:r>
-              <a:t>A mensagem principal deste slide é: O launcher mantém o mesmo resultado quando Codespaces ou internet não estão disponíveis. Para tornar isso concreto, observe windows, macOS e Linux documentados, doctor encontra bloqueios e support-report sanitiza a ajuda. Esses pontos devem ser entendidos em conjunto; não são funcionalidades isoladas. No projeto, essa combinação transforma uma convenção informal em algo que pode ser revisado, testado ou consumido de maneira consistente.</a:t>
+              <a:t>A mensagem principal deste slide é: DuckDB UI abre na porta privada 4213 sem bloquear nem modificar o banco usado pelo dbt. Para tornar isso concreto, observe execute depois do checkpoint, Mantenha o terminal aberto e Ctrl+C encerra e permite atualizar. Esses pontos devem ser entendidos em conjunto; não são funcionalidades isoladas. No projeto, essa combinação transforma uma convenção informal em algo que pode ser revisado, testado ou consumido de maneira consistente.</a:t>
             </a:r>
           </a:p>
           <a:p xmlns:a="http://schemas.openxmlformats.org/drawingml/2006/main">
@@ -1239,7 +1279,7 @@
           </a:p>
           <a:p xmlns:a="http://schemas.openxmlformats.org/drawingml/2006/main">
             <a:r>
-              <a:t>Com esse ponto estabelecido, avance para “Local continua sendo a rota alternativa”.</a:t>
+              <a:t>Com esse ponto estabelecido, avance para “Explore a cópia do banco no navegador”.</a:t>
             </a:r>
           </a:p>
           <a:p xmlns:a="http://schemas.openxmlformats.org/drawingml/2006/main">
@@ -1270,6 +1310,16 @@
           <a:p xmlns:a="http://schemas.openxmlformats.org/drawingml/2006/main">
             <a:r>
               <a:t>- https://docs.github.com/en/codespaces/developing-in-a-codespace/stopping-and-starting-a-codespace</a:t>
+            </a:r>
+          </a:p>
+          <a:p xmlns:a="http://schemas.openxmlformats.org/drawingml/2006/main">
+            <a:r>
+              <a:t>- https://docs.github.com/en/codespaces/reference/security-in-github-codespaces</a:t>
+            </a:r>
+          </a:p>
+          <a:p xmlns:a="http://schemas.openxmlformats.org/drawingml/2006/main">
+            <a:r>
+              <a:t>- https://duckdb.org/docs/current/core_extensions/ui</a:t>
             </a:r>
           </a:p>
           <a:p xmlns:a="http://schemas.openxmlformats.org/drawingml/2006/main">
@@ -1389,7 +1439,7 @@
           </a:p>
           <a:p xmlns:a="http://schemas.openxmlformats.org/drawingml/2006/main">
             <a:r>
-              <a:t>Agora vamos ler a ideia visualmente. O launcher mantém o mesmo resultado quando Codespaces ou internet não estão disponíveis. Siga a composição na ordem mostrada e conecte codespaces: recomendado, Local: alternativa e Suporte: diagnóstico. A imagem ou o fluxo não cria uma regra nova; ele torna visível a relação que acabamos de explicar. Use a disposição dos elementos para reforçar causa, dependência ou comparação.</a:t>
+              <a:t>Agora vamos ler a ideia visualmente. DuckDB UI abre na porta privada 4213 sem bloquear nem modificar o banco usado pelo dbt. Siga a composição na ordem mostrada e conecte dbt build, snapshot, DuckDB UI e navegador. A imagem ou o fluxo não cria uma regra nova; ele torna visível a relação que acabamos de explicar. Use a disposição dos elementos para reforçar causa, dependência ou comparação.</a:t>
             </a:r>
           </a:p>
           <a:p xmlns:a="http://schemas.openxmlformats.org/drawingml/2006/main">
@@ -1450,6 +1500,16 @@
           <a:p xmlns:a="http://schemas.openxmlformats.org/drawingml/2006/main">
             <a:r>
               <a:t>- https://docs.github.com/en/codespaces/developing-in-a-codespace/stopping-and-starting-a-codespace</a:t>
+            </a:r>
+          </a:p>
+          <a:p xmlns:a="http://schemas.openxmlformats.org/drawingml/2006/main">
+            <a:r>
+              <a:t>- https://docs.github.com/en/codespaces/reference/security-in-github-codespaces</a:t>
+            </a:r>
+          </a:p>
+          <a:p xmlns:a="http://schemas.openxmlformats.org/drawingml/2006/main">
+            <a:r>
+              <a:t>- https://duckdb.org/docs/current/core_extensions/ui</a:t>
             </a:r>
           </a:p>
           <a:p xmlns:a="http://schemas.openxmlformats.org/drawingml/2006/main">
@@ -1569,7 +1629,7 @@
           </a:p>
           <a:p xmlns:a="http://schemas.openxmlformats.org/drawingml/2006/main">
             <a:r>
-              <a:t>Agora vamos sair da explicação e comprovar o comportamento. Execute os comandos exatamente como aparecem: python course.py doctor, depois python course.py checkpoint 01. Não é necessário ativar o ambiente virtual manualmente; o launcher do curso seleciona o ambiente correto. Antes de avançar, confirme que o comando iniciou sem erro e dê tempo para o aluno acompanhar a mesma etapa.</a:t>
+              <a:t>Agora vamos sair da explicação e comprovar o comportamento. Execute os comandos exatamente como aparecem: python course.py paths, depois python course.py checkpoint 01, depois python course.py data-ui. Não é necessário ativar o ambiente virtual manualmente; o launcher do curso seleciona o ambiente correto. Antes de avançar, confirme que o comando iniciou sem erro e dê tempo para o aluno acompanhar a mesma etapa.</a:t>
             </a:r>
           </a:p>
           <a:p xmlns:a="http://schemas.openxmlformats.org/drawingml/2006/main">
@@ -1630,6 +1690,16 @@
           <a:p xmlns:a="http://schemas.openxmlformats.org/drawingml/2006/main">
             <a:r>
               <a:t>- https://docs.github.com/en/codespaces/developing-in-a-codespace/stopping-and-starting-a-codespace</a:t>
+            </a:r>
+          </a:p>
+          <a:p xmlns:a="http://schemas.openxmlformats.org/drawingml/2006/main">
+            <a:r>
+              <a:t>- https://docs.github.com/en/codespaces/reference/security-in-github-codespaces</a:t>
+            </a:r>
+          </a:p>
+          <a:p xmlns:a="http://schemas.openxmlformats.org/drawingml/2006/main">
+            <a:r>
+              <a:t>- https://duckdb.org/docs/current/core_extensions/ui</a:t>
             </a:r>
           </a:p>
           <a:p xmlns:a="http://schemas.openxmlformats.org/drawingml/2006/main">
@@ -1749,7 +1819,7 @@
           </a:p>
           <a:p xmlns:a="http://schemas.openxmlformats.org/drawingml/2006/main">
             <a:r>
-              <a:t>Enquanto a execução acontece, não olhe apenas para a mensagem final. Observe python 3.12 e Git OK, dbt build concluído e Seeds e artifacts executados. Cada sinal responde a uma pergunta diferente sobre o pipeline. Se um deles divergir, interrompa a demonstração e investigue; o objetivo do hands-on é produzir evidência, não apenas chegar rapidamente a uma tela verde.</a:t>
+              <a:t>Enquanto a execução acontece, não olhe apenas para a mensagem final. Observe dbt e DuckDB do ambiente isolado, Seeds e artifacts executados e DuckDB UI na porta privada 4213. Cada sinal responde a uma pergunta diferente sobre o pipeline. Se um deles divergir, interrompa a demonstração e investigue; o objetivo do hands-on é produzir evidência, não apenas chegar rapidamente a uma tela verde.</a:t>
             </a:r>
           </a:p>
           <a:p xmlns:a="http://schemas.openxmlformats.org/drawingml/2006/main">
@@ -1810,6 +1880,16 @@
           <a:p xmlns:a="http://schemas.openxmlformats.org/drawingml/2006/main">
             <a:r>
               <a:t>- https://docs.github.com/en/codespaces/developing-in-a-codespace/stopping-and-starting-a-codespace</a:t>
+            </a:r>
+          </a:p>
+          <a:p xmlns:a="http://schemas.openxmlformats.org/drawingml/2006/main">
+            <a:r>
+              <a:t>- https://docs.github.com/en/codespaces/reference/security-in-github-codespaces</a:t>
+            </a:r>
+          </a:p>
+          <a:p xmlns:a="http://schemas.openxmlformats.org/drawingml/2006/main">
+            <a:r>
+              <a:t>- https://duckdb.org/docs/current/core_extensions/ui</a:t>
             </a:r>
           </a:p>
           <a:p xmlns:a="http://schemas.openxmlformats.org/drawingml/2006/main">
@@ -1929,7 +2009,7 @@
           </a:p>
           <a:p xmlns:a="http://schemas.openxmlformats.org/drawingml/2006/main">
             <a:r>
-              <a:t>Este é o ponto de parada da demonstração: Checkpoint 01 OK. Esse resultado confirma que a etapa executada produziu a evidência esperada para o checkpoint 01. Se o valor, o status ou o artifact estiver diferente, não trate a divergência como detalhe de ambiente. Use o diagnóstico do curso e só avance quando a causa estiver compreendida.</a:t>
+              <a:t>Este é o ponto de parada da demonstração: Checkpoint 01 OK + exploração gráfica opcional. Esse resultado confirma que a etapa executada produziu a evidência esperada para o checkpoint 01. Se o valor, o status ou o artifact estiver diferente, não trate a divergência como detalhe de ambiente. Use o diagnóstico do curso e só avance quando a causa estiver compreendida.</a:t>
             </a:r>
           </a:p>
           <a:p xmlns:a="http://schemas.openxmlformats.org/drawingml/2006/main">
@@ -1990,6 +2070,16 @@
           <a:p xmlns:a="http://schemas.openxmlformats.org/drawingml/2006/main">
             <a:r>
               <a:t>- https://docs.github.com/en/codespaces/developing-in-a-codespace/stopping-and-starting-a-codespace</a:t>
+            </a:r>
+          </a:p>
+          <a:p xmlns:a="http://schemas.openxmlformats.org/drawingml/2006/main">
+            <a:r>
+              <a:t>- https://docs.github.com/en/codespaces/reference/security-in-github-codespaces</a:t>
+            </a:r>
+          </a:p>
+          <a:p xmlns:a="http://schemas.openxmlformats.org/drawingml/2006/main">
+            <a:r>
+              <a:t>- https://duckdb.org/docs/current/core_extensions/ui</a:t>
             </a:r>
           </a:p>
           <a:p xmlns:a="http://schemas.openxmlformats.org/drawingml/2006/main">
@@ -2174,6 +2264,16 @@
           </a:p>
           <a:p xmlns:a="http://schemas.openxmlformats.org/drawingml/2006/main">
             <a:r>
+              <a:t>- https://docs.github.com/en/codespaces/reference/security-in-github-codespaces</a:t>
+            </a:r>
+          </a:p>
+          <a:p xmlns:a="http://schemas.openxmlformats.org/drawingml/2006/main">
+            <a:r>
+              <a:t>- https://duckdb.org/docs/current/core_extensions/ui</a:t>
+            </a:r>
+          </a:p>
+          <a:p xmlns:a="http://schemas.openxmlformats.org/drawingml/2006/main">
+            <a:r>
               <a:t>- https://docs.getdbt.com/guides/manual-install?step=1</a:t>
             </a:r>
           </a:p>
@@ -2354,6 +2454,16 @@
           </a:p>
           <a:p xmlns:a="http://schemas.openxmlformats.org/drawingml/2006/main">
             <a:r>
+              <a:t>- https://docs.github.com/en/codespaces/reference/security-in-github-codespaces</a:t>
+            </a:r>
+          </a:p>
+          <a:p xmlns:a="http://schemas.openxmlformats.org/drawingml/2006/main">
+            <a:r>
+              <a:t>- https://duckdb.org/docs/current/core_extensions/ui</a:t>
+            </a:r>
+          </a:p>
+          <a:p xmlns:a="http://schemas.openxmlformats.org/drawingml/2006/main">
+            <a:r>
               <a:t>- https://docs.getdbt.com/guides/manual-install?step=1</a:t>
             </a:r>
           </a:p>
@@ -2534,6 +2644,16 @@
           </a:p>
           <a:p xmlns:a="http://schemas.openxmlformats.org/drawingml/2006/main">
             <a:r>
+              <a:t>- https://docs.github.com/en/codespaces/reference/security-in-github-codespaces</a:t>
+            </a:r>
+          </a:p>
+          <a:p xmlns:a="http://schemas.openxmlformats.org/drawingml/2006/main">
+            <a:r>
+              <a:t>- https://duckdb.org/docs/current/core_extensions/ui</a:t>
+            </a:r>
+          </a:p>
+          <a:p xmlns:a="http://schemas.openxmlformats.org/drawingml/2006/main">
+            <a:r>
               <a:t>- https://docs.getdbt.com/guides/manual-install?step=1</a:t>
             </a:r>
           </a:p>
@@ -2649,7 +2769,7 @@
           </a:p>
           <a:p xmlns:a="http://schemas.openxmlformats.org/drawingml/2006/main">
             <a:r>
-              <a:t>Também precisamos declarar os limites da recomendação. Neste cenário, considere codespaces exige internet e conta pessoal GitHub, Franquias e cobrança podem mudar, Ambiente parado ainda consome armazenamento e Instalação local permanece disponível. Esses pontos não anulam a técnica; eles delimitam onde a demonstração é válida e quais condições precisam ser verificadas antes de levar o padrão para produção. Tratar limites como parte do design evita transformar uma boa prática em regra universal.</a:t>
+              <a:t>Também precisamos declarar os limites da recomendação. Neste cenário, considere codespaces exige internet e conta pessoal GitHub, Franquias e cobrança podem mudar, DuckDB UI instala a extensão no primeiro uso e Instalação local permanece disponível. Esses pontos não anulam a técnica; eles delimitam onde a demonstração é válida e quais condições precisam ser verificadas antes de levar o padrão para produção. Tratar limites como parte do design evita transformar uma boa prática em regra universal.</a:t>
             </a:r>
           </a:p>
           <a:p xmlns:a="http://schemas.openxmlformats.org/drawingml/2006/main">
@@ -2710,6 +2830,16 @@
           <a:p xmlns:a="http://schemas.openxmlformats.org/drawingml/2006/main">
             <a:r>
               <a:t>- https://docs.github.com/en/codespaces/developing-in-a-codespace/stopping-and-starting-a-codespace</a:t>
+            </a:r>
+          </a:p>
+          <a:p xmlns:a="http://schemas.openxmlformats.org/drawingml/2006/main">
+            <a:r>
+              <a:t>- https://docs.github.com/en/codespaces/reference/security-in-github-codespaces</a:t>
+            </a:r>
+          </a:p>
+          <a:p xmlns:a="http://schemas.openxmlformats.org/drawingml/2006/main">
+            <a:r>
+              <a:t>- https://duckdb.org/docs/current/core_extensions/ui</a:t>
             </a:r>
           </a:p>
           <a:p xmlns:a="http://schemas.openxmlformats.org/drawingml/2006/main">
@@ -2894,6 +3024,16 @@
           </a:p>
           <a:p xmlns:a="http://schemas.openxmlformats.org/drawingml/2006/main">
             <a:r>
+              <a:t>- https://docs.github.com/en/codespaces/reference/security-in-github-codespaces</a:t>
+            </a:r>
+          </a:p>
+          <a:p xmlns:a="http://schemas.openxmlformats.org/drawingml/2006/main">
+            <a:r>
+              <a:t>- https://duckdb.org/docs/current/core_extensions/ui</a:t>
+            </a:r>
+          </a:p>
+          <a:p xmlns:a="http://schemas.openxmlformats.org/drawingml/2006/main">
+            <a:r>
               <a:t>- https://docs.getdbt.com/guides/manual-install?step=1</a:t>
             </a:r>
           </a:p>
@@ -3009,7 +3149,7 @@
           </a:p>
           <a:p xmlns:a="http://schemas.openxmlformats.org/drawingml/2006/main">
             <a:r>
-              <a:t>Abra o Codespace em 2-core, execute doctor e checkpoint 01 e pare ao terminar. Faça essa etapa antes de seguir para o próximo episódio, porque o curso é cumulativo e o checkpoint atual se torna a base da aula seguinte. Se houver divergência, use o relatório de suporte e registre o que foi observado. O objetivo é avançar com um estado conhecido e reproduzível, não apenas assistir ao conteúdo.</a:t>
+              <a:t>Abra o Codespace em 2-core, confira paths, execute checkpoint 01, explore a UI e pare ao terminar. Faça essa etapa antes de seguir para o próximo episódio, porque o curso é cumulativo e o checkpoint atual se torna a base da aula seguinte. Se houver divergência, use o relatório de suporte e registre o que foi observado. O objetivo é avançar com um estado conhecido e reproduzível, não apenas assistir ao conteúdo.</a:t>
             </a:r>
           </a:p>
           <a:p xmlns:a="http://schemas.openxmlformats.org/drawingml/2006/main">
@@ -3070,6 +3210,16 @@
           <a:p xmlns:a="http://schemas.openxmlformats.org/drawingml/2006/main">
             <a:r>
               <a:t>- https://docs.github.com/en/codespaces/developing-in-a-codespace/stopping-and-starting-a-codespace</a:t>
+            </a:r>
+          </a:p>
+          <a:p xmlns:a="http://schemas.openxmlformats.org/drawingml/2006/main">
+            <a:r>
+              <a:t>- https://docs.github.com/en/codespaces/reference/security-in-github-codespaces</a:t>
+            </a:r>
+          </a:p>
+          <a:p xmlns:a="http://schemas.openxmlformats.org/drawingml/2006/main">
+            <a:r>
+              <a:t>- https://duckdb.org/docs/current/core_extensions/ui</a:t>
             </a:r>
           </a:p>
           <a:p xmlns:a="http://schemas.openxmlformats.org/drawingml/2006/main">
@@ -3254,6 +3404,16 @@
           </a:p>
           <a:p xmlns:a="http://schemas.openxmlformats.org/drawingml/2006/main">
             <a:r>
+              <a:t>- https://docs.github.com/en/codespaces/reference/security-in-github-codespaces</a:t>
+            </a:r>
+          </a:p>
+          <a:p xmlns:a="http://schemas.openxmlformats.org/drawingml/2006/main">
+            <a:r>
+              <a:t>- https://duckdb.org/docs/current/core_extensions/ui</a:t>
+            </a:r>
+          </a:p>
+          <a:p xmlns:a="http://schemas.openxmlformats.org/drawingml/2006/main">
+            <a:r>
               <a:t>- https://docs.getdbt.com/guides/manual-install?step=1</a:t>
             </a:r>
           </a:p>
@@ -3434,6 +3594,16 @@
           </a:p>
           <a:p xmlns:a="http://schemas.openxmlformats.org/drawingml/2006/main">
             <a:r>
+              <a:t>- https://docs.github.com/en/codespaces/reference/security-in-github-codespaces</a:t>
+            </a:r>
+          </a:p>
+          <a:p xmlns:a="http://schemas.openxmlformats.org/drawingml/2006/main">
+            <a:r>
+              <a:t>- https://duckdb.org/docs/current/core_extensions/ui</a:t>
+            </a:r>
+          </a:p>
+          <a:p xmlns:a="http://schemas.openxmlformats.org/drawingml/2006/main">
+            <a:r>
               <a:t>- https://docs.getdbt.com/guides/manual-install?step=1</a:t>
             </a:r>
           </a:p>
@@ -3614,6 +3784,16 @@
           </a:p>
           <a:p xmlns:a="http://schemas.openxmlformats.org/drawingml/2006/main">
             <a:r>
+              <a:t>- https://docs.github.com/en/codespaces/reference/security-in-github-codespaces</a:t>
+            </a:r>
+          </a:p>
+          <a:p xmlns:a="http://schemas.openxmlformats.org/drawingml/2006/main">
+            <a:r>
+              <a:t>- https://duckdb.org/docs/current/core_extensions/ui</a:t>
+            </a:r>
+          </a:p>
+          <a:p xmlns:a="http://schemas.openxmlformats.org/drawingml/2006/main">
+            <a:r>
               <a:t>- https://docs.getdbt.com/guides/manual-install?step=1</a:t>
             </a:r>
           </a:p>
@@ -3794,6 +3974,16 @@
           </a:p>
           <a:p xmlns:a="http://schemas.openxmlformats.org/drawingml/2006/main">
             <a:r>
+              <a:t>- https://docs.github.com/en/codespaces/reference/security-in-github-codespaces</a:t>
+            </a:r>
+          </a:p>
+          <a:p xmlns:a="http://schemas.openxmlformats.org/drawingml/2006/main">
+            <a:r>
+              <a:t>- https://duckdb.org/docs/current/core_extensions/ui</a:t>
+            </a:r>
+          </a:p>
+          <a:p xmlns:a="http://schemas.openxmlformats.org/drawingml/2006/main">
+            <a:r>
               <a:t>- https://docs.getdbt.com/guides/manual-install?step=1</a:t>
             </a:r>
           </a:p>
@@ -3979,6 +4169,16 @@
           </a:p>
           <a:p xmlns:a="http://schemas.openxmlformats.org/drawingml/2006/main">
             <a:r>
+              <a:t>- https://docs.github.com/en/codespaces/reference/security-in-github-codespaces</a:t>
+            </a:r>
+          </a:p>
+          <a:p xmlns:a="http://schemas.openxmlformats.org/drawingml/2006/main">
+            <a:r>
+              <a:t>- https://duckdb.org/docs/current/core_extensions/ui</a:t>
+            </a:r>
+          </a:p>
+          <a:p xmlns:a="http://schemas.openxmlformats.org/drawingml/2006/main">
+            <a:r>
               <a:t>- https://docs.getdbt.com/guides/manual-install?step=1</a:t>
             </a:r>
           </a:p>
@@ -4124,7 +4324,7 @@
           </a:p>
           <a:p xmlns:a="http://schemas.openxmlformats.org/drawingml/2006/main">
             <a:r>
-              <a:t>Com esse ponto estabelecido, avance para “O repositório prepara o ambiente”.</a:t>
+              <a:t>Com esse ponto estabelecido, avance para “O repositório restaura o ambiente”.</a:t>
             </a:r>
           </a:p>
           <a:p xmlns:a="http://schemas.openxmlformats.org/drawingml/2006/main">
@@ -4155,6 +4355,16 @@
           <a:p xmlns:a="http://schemas.openxmlformats.org/drawingml/2006/main">
             <a:r>
               <a:t>- https://docs.github.com/en/codespaces/developing-in-a-codespace/stopping-and-starting-a-codespace</a:t>
+            </a:r>
+          </a:p>
+          <a:p xmlns:a="http://schemas.openxmlformats.org/drawingml/2006/main">
+            <a:r>
+              <a:t>- https://docs.github.com/en/codespaces/reference/security-in-github-codespaces</a:t>
+            </a:r>
+          </a:p>
+          <a:p xmlns:a="http://schemas.openxmlformats.org/drawingml/2006/main">
+            <a:r>
+              <a:t>- https://duckdb.org/docs/current/core_extensions/ui</a:t>
             </a:r>
           </a:p>
           <a:p xmlns:a="http://schemas.openxmlformats.org/drawingml/2006/main">
@@ -4279,7 +4489,7 @@
           </a:p>
           <a:p xmlns:a="http://schemas.openxmlformats.org/drawingml/2006/main">
             <a:r>
-              <a:t>A mensagem principal deste slide é: O dev container executa setup na criação e doctor a cada abertura. Para tornar isso concreto, observe python 3.12 fixado, dbt + DuckDB instalados, Nenhuma ativação manual e Checkpoint reproduzível. Esses pontos devem ser entendidos em conjunto; não são funcionalidades isoladas. No projeto, essa combinação transforma uma convenção informal em algo que pode ser revisado, testado ou consumido de maneira consistente.</a:t>
+              <a:t>A mensagem principal deste slide é: Setup instala uma vez; a reabertura restaura PATH, profile e caminhos detectados. Para tornar isso concreto, observe python 3.12 fixado, dbt Core 1.12.3, DuckDB 1.5.5 e Sem ativação manual. Esses pontos devem ser entendidos em conjunto; não são funcionalidades isoladas. No projeto, essa combinação transforma uma convenção informal em algo que pode ser revisado, testado ou consumido de maneira consistente.</a:t>
             </a:r>
           </a:p>
           <a:p xmlns:a="http://schemas.openxmlformats.org/drawingml/2006/main">
@@ -4309,7 +4519,7 @@
           </a:p>
           <a:p xmlns:a="http://schemas.openxmlformats.org/drawingml/2006/main">
             <a:r>
-              <a:t>Com esse ponto estabelecido, avance para “O repositório prepara o ambiente”.</a:t>
+              <a:t>Com esse ponto estabelecido, avance para “O repositório restaura o ambiente”.</a:t>
             </a:r>
           </a:p>
           <a:p xmlns:a="http://schemas.openxmlformats.org/drawingml/2006/main">
@@ -4340,6 +4550,16 @@
           <a:p xmlns:a="http://schemas.openxmlformats.org/drawingml/2006/main">
             <a:r>
               <a:t>- https://docs.github.com/en/codespaces/developing-in-a-codespace/stopping-and-starting-a-codespace</a:t>
+            </a:r>
+          </a:p>
+          <a:p xmlns:a="http://schemas.openxmlformats.org/drawingml/2006/main">
+            <a:r>
+              <a:t>- https://docs.github.com/en/codespaces/reference/security-in-github-codespaces</a:t>
+            </a:r>
+          </a:p>
+          <a:p xmlns:a="http://schemas.openxmlformats.org/drawingml/2006/main">
+            <a:r>
+              <a:t>- https://duckdb.org/docs/current/core_extensions/ui</a:t>
             </a:r>
           </a:p>
           <a:p xmlns:a="http://schemas.openxmlformats.org/drawingml/2006/main">
@@ -4471,7 +4691,7 @@
   </p:cSld>
   <p:clrMap bg1="lt1" tx1="dk1" bg2="lt2" tx2="dk2" accent1="accent1" accent2="accent2" accent3="accent3" accent4="accent4" accent5="accent5" accent6="accent6" hlink="hlink" folHlink="folHlink"/>
   <p:sldLayoutIdLst>
-    <p:sldLayoutId xmlns:r="http://schemas.openxmlformats.org/officeDocument/2006/relationships" id="2147483649" r:id="R4ea469d7206d4c8d"/>
+    <p:sldLayoutId xmlns:r="http://schemas.openxmlformats.org/officeDocument/2006/relationships" id="2147483649" r:id="R8db020e79576446a"/>
   </p:sldLayoutIdLst>
   <p:txStyles>
     <p:titleStyle>
@@ -4769,8 +4989,8 @@
   </p:cSld>
   <p:clrMap bg1="lt1" tx1="dk1" bg2="lt2" tx2="dk2" accent1="accent1" accent2="accent2" accent3="accent3" accent4="accent4" accent5="accent5" accent6="accent6" hlink="hlink" folHlink="folHlink"/>
   <p:sldLayoutIdLst>
-    <p:sldLayoutId xmlns:r="http://schemas.openxmlformats.org/officeDocument/2006/relationships" id="2147483651" r:id="R2785c02e93ad42c1"/>
-    <p:sldLayoutId xmlns:r="http://schemas.openxmlformats.org/officeDocument/2006/relationships" id="2147483652" r:id="R602fbad24d204a98"/>
+    <p:sldLayoutId xmlns:r="http://schemas.openxmlformats.org/officeDocument/2006/relationships" id="2147483651" r:id="Re69c1d9c70d34e47"/>
+    <p:sldLayoutId xmlns:r="http://schemas.openxmlformats.org/officeDocument/2006/relationships" id="2147483652" r:id="R584deff15c944e8b"/>
   </p:sldLayoutIdLst>
 </p:sldMaster>
 </file>
@@ -5301,7 +5521,7 @@
           <p:nvPr/>
         </p:nvPicPr>
         <p:blipFill>
-          <a:blip xmlns:r="http://schemas.openxmlformats.org/officeDocument/2006/relationships" xmlns:a="http://schemas.openxmlformats.org/drawingml/2006/main" r:embed="R8dbc156259084f17"/>
+          <a:blip xmlns:r="http://schemas.openxmlformats.org/officeDocument/2006/relationships" xmlns:a="http://schemas.openxmlformats.org/drawingml/2006/main" r:embed="Ra2c06dba5c8d4e87"/>
           <a:srcRect xmlns:a="http://schemas.openxmlformats.org/drawingml/2006/main" l="19785" t="0" r="19785" b="0"/>
           <a:stretch xmlns:a="http://schemas.openxmlformats.org/drawingml/2006/main">
             <a:fillRect l="0" t="0" r="0" b="0"/>
@@ -5322,7 +5542,7 @@
           <p:cNvPr id="2" name="cover-text-surface">
             <a:extLst xmlns:a="http://schemas.openxmlformats.org/drawingml/2006/main">
               <a:ext uri="{FF2B5EF4-FFF2-40B4-BE49-F238E27FC236}">
-                <a16:creationId xmlns:a16="http://schemas.microsoft.com/office/drawing/2014/main" id="{40862A8D-4C2E-4BA2-B43E-273AED5A3E06}"/>
+                <a16:creationId xmlns:a16="http://schemas.microsoft.com/office/drawing/2014/main" id="{78A00156-943C-4DCE-A318-5578213832CF}"/>
               </a:ext>
             </a:extLst>
           </p:cNvPr>
@@ -5355,7 +5575,7 @@
           <p:cNvPr id="3" name="cover-divider">
             <a:extLst xmlns:a="http://schemas.openxmlformats.org/drawingml/2006/main">
               <a:ext uri="{FF2B5EF4-FFF2-40B4-BE49-F238E27FC236}">
-                <a16:creationId xmlns:a16="http://schemas.microsoft.com/office/drawing/2014/main" id="{BD541A9C-1890-4E07-AB85-F13C606615F0}"/>
+                <a16:creationId xmlns:a16="http://schemas.microsoft.com/office/drawing/2014/main" id="{95513F46-406C-4CAA-BE74-0B7A242970ED}"/>
               </a:ext>
             </a:extLst>
           </p:cNvPr>
@@ -5386,7 +5606,7 @@
           <p:cNvPr id="4" name="cover-episode">
             <a:extLst xmlns:a="http://schemas.openxmlformats.org/drawingml/2006/main">
               <a:ext uri="{FF2B5EF4-FFF2-40B4-BE49-F238E27FC236}">
-                <a16:creationId xmlns:a16="http://schemas.microsoft.com/office/drawing/2014/main" id="{0BC3D243-2E6C-4E4E-BEAE-15D8D3C6FC43}"/>
+                <a16:creationId xmlns:a16="http://schemas.microsoft.com/office/drawing/2014/main" id="{CF02AC90-1433-4704-B79B-7435365C13E5}"/>
               </a:ext>
             </a:extLst>
           </p:cNvPr>
@@ -5437,7 +5657,7 @@
           <p:cNvPr id="5" name="cover-title">
             <a:extLst xmlns:a="http://schemas.openxmlformats.org/drawingml/2006/main">
               <a:ext uri="{FF2B5EF4-FFF2-40B4-BE49-F238E27FC236}">
-                <a16:creationId xmlns:a16="http://schemas.microsoft.com/office/drawing/2014/main" id="{8C16D8C3-F32F-442C-98EC-01FB1AF98975}"/>
+                <a16:creationId xmlns:a16="http://schemas.microsoft.com/office/drawing/2014/main" id="{58993632-6EE7-4DBC-A519-729BAA418D67}"/>
               </a:ext>
             </a:extLst>
           </p:cNvPr>
@@ -5488,7 +5708,7 @@
           <p:cNvPr id="6" name="cover-subtitle">
             <a:extLst xmlns:a="http://schemas.openxmlformats.org/drawingml/2006/main">
               <a:ext uri="{FF2B5EF4-FFF2-40B4-BE49-F238E27FC236}">
-                <a16:creationId xmlns:a16="http://schemas.microsoft.com/office/drawing/2014/main" id="{D304A9D2-C308-4D09-A6D9-3E93DFF3C7F0}"/>
+                <a16:creationId xmlns:a16="http://schemas.microsoft.com/office/drawing/2014/main" id="{3CECE5B1-D43D-4E7B-92D2-975E2E8EFD92}"/>
               </a:ext>
             </a:extLst>
           </p:cNvPr>
@@ -5539,7 +5759,7 @@
           <p:cNvPr id="7" name="cover-accent">
             <a:extLst xmlns:a="http://schemas.openxmlformats.org/drawingml/2006/main">
               <a:ext uri="{FF2B5EF4-FFF2-40B4-BE49-F238E27FC236}">
-                <a16:creationId xmlns:a16="http://schemas.microsoft.com/office/drawing/2014/main" id="{57F0C15D-3E29-42E4-AFDE-70E98CDE6EF4}"/>
+                <a16:creationId xmlns:a16="http://schemas.microsoft.com/office/drawing/2014/main" id="{C23E8888-1E54-4F62-B822-E11043DEF3BC}"/>
               </a:ext>
             </a:extLst>
           </p:cNvPr>
@@ -5570,7 +5790,7 @@
           <p:cNvPr id="8" name="cover-meta">
             <a:extLst xmlns:a="http://schemas.openxmlformats.org/drawingml/2006/main">
               <a:ext uri="{FF2B5EF4-FFF2-40B4-BE49-F238E27FC236}">
-                <a16:creationId xmlns:a16="http://schemas.microsoft.com/office/drawing/2014/main" id="{C9811158-564A-4657-9C7F-10A5D662FBB2}"/>
+                <a16:creationId xmlns:a16="http://schemas.microsoft.com/office/drawing/2014/main" id="{84B3F8A1-04B9-48FF-ABBB-1418E5CD72D1}"/>
               </a:ext>
             </a:extLst>
           </p:cNvPr>
@@ -5623,7 +5843,7 @@
     </p:spTree>
     <p:extLst>
       <p:ext uri="{BB962C8B-B14F-4D97-AF65-F5344CB8AC3E}">
-        <p14:creationId xmlns:p14="http://schemas.microsoft.com/office/powerpoint/2010/main" val="1368042430"/>
+        <p14:creationId xmlns:p14="http://schemas.microsoft.com/office/powerpoint/2010/main" val="2039327846"/>
       </p:ext>
     </p:extLst>
   </p:cSld>
@@ -5662,7 +5882,7 @@
           <p:cNvPr id="13" name="slide-title">
             <a:extLst xmlns:a="http://schemas.openxmlformats.org/drawingml/2006/main">
               <a:ext uri="{FF2B5EF4-FFF2-40B4-BE49-F238E27FC236}">
-                <a16:creationId xmlns:a16="http://schemas.microsoft.com/office/drawing/2014/main" id="{D3346A7F-294E-4069-B52C-DF85B1CAD683}"/>
+                <a16:creationId xmlns:a16="http://schemas.microsoft.com/office/drawing/2014/main" id="{E9920752-E5CD-404F-862F-2FA902A2A5FC}"/>
               </a:ext>
             </a:extLst>
           </p:cNvPr>
@@ -5703,7 +5923,7 @@
                   <a:srgbClr val="FFFFFF"/>
                 </a:solidFill>
               </a:rPr>
-              <a:t>O repositório prepara o ambiente</a:t>
+              <a:t>O repositório restaura o ambiente</a:t>
             </a:r>
           </a:p>
         </p:txBody>
@@ -5713,7 +5933,7 @@
           <p:cNvPr id="2" name="flow-1">
             <a:extLst xmlns:a="http://schemas.openxmlformats.org/drawingml/2006/main">
               <a:ext uri="{FF2B5EF4-FFF2-40B4-BE49-F238E27FC236}">
-                <a16:creationId xmlns:a16="http://schemas.microsoft.com/office/drawing/2014/main" id="{23DE3314-3ACB-4ACB-9B54-AD6187AC6A21}"/>
+                <a16:creationId xmlns:a16="http://schemas.microsoft.com/office/drawing/2014/main" id="{FD5CFC25-C8DE-4133-943A-EA1553C62D35}"/>
               </a:ext>
             </a:extLst>
           </p:cNvPr>
@@ -5770,7 +5990,7 @@
           <p:cNvPr id="3" name="flow-2">
             <a:extLst xmlns:a="http://schemas.openxmlformats.org/drawingml/2006/main">
               <a:ext uri="{FF2B5EF4-FFF2-40B4-BE49-F238E27FC236}">
-                <a16:creationId xmlns:a16="http://schemas.microsoft.com/office/drawing/2014/main" id="{8174DFE1-AD7E-4882-A258-DEE1500A8799}"/>
+                <a16:creationId xmlns:a16="http://schemas.microsoft.com/office/drawing/2014/main" id="{956F867A-3C8E-4B9D-A0FE-A78D43D9AC75}"/>
               </a:ext>
             </a:extLst>
           </p:cNvPr>
@@ -5827,7 +6047,7 @@
           <p:cNvPr id="4" name="flow-3">
             <a:extLst xmlns:a="http://schemas.openxmlformats.org/drawingml/2006/main">
               <a:ext uri="{FF2B5EF4-FFF2-40B4-BE49-F238E27FC236}">
-                <a16:creationId xmlns:a16="http://schemas.microsoft.com/office/drawing/2014/main" id="{3636FDDC-F50C-4AB3-B1C7-4CB255713008}"/>
+                <a16:creationId xmlns:a16="http://schemas.microsoft.com/office/drawing/2014/main" id="{D51C645F-0CD7-4092-899B-B4FAEA1E15B4}"/>
               </a:ext>
             </a:extLst>
           </p:cNvPr>
@@ -5874,7 +6094,7 @@
                   <a:srgbClr val="FFFFFF"/>
                 </a:solidFill>
               </a:rPr>
-              <a:t>doctor</a:t>
+              <a:t>paths</a:t>
             </a:r>
           </a:p>
         </p:txBody>
@@ -5884,7 +6104,7 @@
           <p:cNvPr id="5" name="flow-4">
             <a:extLst xmlns:a="http://schemas.openxmlformats.org/drawingml/2006/main">
               <a:ext uri="{FF2B5EF4-FFF2-40B4-BE49-F238E27FC236}">
-                <a16:creationId xmlns:a16="http://schemas.microsoft.com/office/drawing/2014/main" id="{3FBE429F-C1E2-4B4B-8A24-C5DBE74FEAB5}"/>
+                <a16:creationId xmlns:a16="http://schemas.microsoft.com/office/drawing/2014/main" id="{06856412-8C22-4E8F-8FF2-2F2274FA7612}"/>
               </a:ext>
             </a:extLst>
           </p:cNvPr>
@@ -6019,7 +6239,7 @@
           <p:cNvPr id="9" name="eyebrow">
             <a:extLst xmlns:a="http://schemas.openxmlformats.org/drawingml/2006/main">
               <a:ext uri="{FF2B5EF4-FFF2-40B4-BE49-F238E27FC236}">
-                <a16:creationId xmlns:a16="http://schemas.microsoft.com/office/drawing/2014/main" id="{440EE247-82EA-4B25-B66A-4DD300ECEA2B}"/>
+                <a16:creationId xmlns:a16="http://schemas.microsoft.com/office/drawing/2014/main" id="{185AAA6D-BE01-48F5-9916-5C5FB454BAED}"/>
               </a:ext>
             </a:extLst>
           </p:cNvPr>
@@ -6070,7 +6290,7 @@
           <p:cNvPr id="10" name="footer-rule">
             <a:extLst xmlns:a="http://schemas.openxmlformats.org/drawingml/2006/main">
               <a:ext uri="{FF2B5EF4-FFF2-40B4-BE49-F238E27FC236}">
-                <a16:creationId xmlns:a16="http://schemas.microsoft.com/office/drawing/2014/main" id="{4096A580-449A-4A1D-A81E-14A1D8C10289}"/>
+                <a16:creationId xmlns:a16="http://schemas.microsoft.com/office/drawing/2014/main" id="{68A0BC67-C0DF-4028-A521-69E24C124E18}"/>
               </a:ext>
             </a:extLst>
           </p:cNvPr>
@@ -6103,7 +6323,7 @@
           <p:cNvPr id="11" name="footer">
             <a:extLst xmlns:a="http://schemas.openxmlformats.org/drawingml/2006/main">
               <a:ext uri="{FF2B5EF4-FFF2-40B4-BE49-F238E27FC236}">
-                <a16:creationId xmlns:a16="http://schemas.microsoft.com/office/drawing/2014/main" id="{B9975CDB-2702-4137-9F1F-C4CB112AA57B}"/>
+                <a16:creationId xmlns:a16="http://schemas.microsoft.com/office/drawing/2014/main" id="{D99FFFAC-2C75-46F6-B08C-ECB9D9F2B252}"/>
               </a:ext>
             </a:extLst>
           </p:cNvPr>
@@ -6158,7 +6378,7 @@
           <p:cNvPr id="12" name="page-number">
             <a:extLst xmlns:a="http://schemas.openxmlformats.org/drawingml/2006/main">
               <a:ext uri="{FF2B5EF4-FFF2-40B4-BE49-F238E27FC236}">
-                <a16:creationId xmlns:a16="http://schemas.microsoft.com/office/drawing/2014/main" id="{4633699B-0B6E-4C7A-9480-C3B2A253F50B}"/>
+                <a16:creationId xmlns:a16="http://schemas.microsoft.com/office/drawing/2014/main" id="{1D73A6E1-1B23-46C8-A3C0-1D88E6B6205D}"/>
               </a:ext>
             </a:extLst>
           </p:cNvPr>
@@ -6211,7 +6431,7 @@
     </p:spTree>
     <p:extLst>
       <p:ext uri="{BB962C8B-B14F-4D97-AF65-F5344CB8AC3E}">
-        <p14:creationId xmlns:p14="http://schemas.microsoft.com/office/powerpoint/2010/main" val="593477345"/>
+        <p14:creationId xmlns:p14="http://schemas.microsoft.com/office/powerpoint/2010/main" val="711303951"/>
       </p:ext>
     </p:extLst>
   </p:cSld>
@@ -6250,7 +6470,7 @@
           <p:cNvPr id="11" name="slide-title">
             <a:extLst xmlns:a="http://schemas.openxmlformats.org/drawingml/2006/main">
               <a:ext uri="{FF2B5EF4-FFF2-40B4-BE49-F238E27FC236}">
-                <a16:creationId xmlns:a16="http://schemas.microsoft.com/office/drawing/2014/main" id="{5A106A77-9524-4CD0-AD23-47F4CE24C761}"/>
+                <a16:creationId xmlns:a16="http://schemas.microsoft.com/office/drawing/2014/main" id="{6BA95B40-9290-435D-A65E-6253748C2A5A}"/>
               </a:ext>
             </a:extLst>
           </p:cNvPr>
@@ -6301,7 +6521,7 @@
           <p:cNvPr id="2" name="slide-subtitle">
             <a:extLst xmlns:a="http://schemas.openxmlformats.org/drawingml/2006/main">
               <a:ext uri="{FF2B5EF4-FFF2-40B4-BE49-F238E27FC236}">
-                <a16:creationId xmlns:a16="http://schemas.microsoft.com/office/drawing/2014/main" id="{03E336E1-E381-4917-97B7-420217B303F6}"/>
+                <a16:creationId xmlns:a16="http://schemas.microsoft.com/office/drawing/2014/main" id="{FE8C4CC7-7026-4583-AC6A-2B9A859976BF}"/>
               </a:ext>
             </a:extLst>
           </p:cNvPr>
@@ -6352,7 +6572,7 @@
           <p:cNvPr id="3" name="bullets">
             <a:extLst xmlns:a="http://schemas.openxmlformats.org/drawingml/2006/main">
               <a:ext uri="{FF2B5EF4-FFF2-40B4-BE49-F238E27FC236}">
-                <a16:creationId xmlns:a16="http://schemas.microsoft.com/office/drawing/2014/main" id="{CF941D06-9B10-4808-92CA-CD631250FA39}"/>
+                <a16:creationId xmlns:a16="http://schemas.microsoft.com/office/drawing/2014/main" id="{A916832D-7F01-497A-8B65-FAE34C5FA753}"/>
               </a:ext>
             </a:extLst>
           </p:cNvPr>
@@ -6439,7 +6659,7 @@
           <p:cNvPr id="4" name="ambient-glow">
             <a:extLst xmlns:a="http://schemas.openxmlformats.org/drawingml/2006/main">
               <a:ext uri="{FF2B5EF4-FFF2-40B4-BE49-F238E27FC236}">
-                <a16:creationId xmlns:a16="http://schemas.microsoft.com/office/drawing/2014/main" id="{3C8D8A0E-267F-49EA-8C9C-59F2BC49A865}"/>
+                <a16:creationId xmlns:a16="http://schemas.microsoft.com/office/drawing/2014/main" id="{9BD7EFD0-28E8-494E-8671-E4EE5F377597}"/>
               </a:ext>
             </a:extLst>
           </p:cNvPr>
@@ -6476,7 +6696,7 @@
           <p:cNvPr id="5" name="ambient-core">
             <a:extLst xmlns:a="http://schemas.openxmlformats.org/drawingml/2006/main">
               <a:ext uri="{FF2B5EF4-FFF2-40B4-BE49-F238E27FC236}">
-                <a16:creationId xmlns:a16="http://schemas.microsoft.com/office/drawing/2014/main" id="{DBA3F939-F7DA-41A0-B291-0F0148B2D047}"/>
+                <a16:creationId xmlns:a16="http://schemas.microsoft.com/office/drawing/2014/main" id="{7DF440E0-A45F-4884-8155-3187AF34E62C}"/>
               </a:ext>
             </a:extLst>
           </p:cNvPr>
@@ -6513,7 +6733,7 @@
           <p:cNvPr id="6" name="section-number">
             <a:extLst xmlns:a="http://schemas.openxmlformats.org/drawingml/2006/main">
               <a:ext uri="{FF2B5EF4-FFF2-40B4-BE49-F238E27FC236}">
-                <a16:creationId xmlns:a16="http://schemas.microsoft.com/office/drawing/2014/main" id="{21E39327-2796-497E-B1DF-3024614F059A}"/>
+                <a16:creationId xmlns:a16="http://schemas.microsoft.com/office/drawing/2014/main" id="{8D3F3C25-0BC8-4634-A10D-A1FE98356685}"/>
               </a:ext>
             </a:extLst>
           </p:cNvPr>
@@ -6564,7 +6784,7 @@
           <p:cNvPr id="7" name="eyebrow">
             <a:extLst xmlns:a="http://schemas.openxmlformats.org/drawingml/2006/main">
               <a:ext uri="{FF2B5EF4-FFF2-40B4-BE49-F238E27FC236}">
-                <a16:creationId xmlns:a16="http://schemas.microsoft.com/office/drawing/2014/main" id="{26A7CC20-5B40-4C0D-B902-5E10AF4A04B6}"/>
+                <a16:creationId xmlns:a16="http://schemas.microsoft.com/office/drawing/2014/main" id="{C54EA6DD-FA89-4569-95CF-EA559367FB64}"/>
               </a:ext>
             </a:extLst>
           </p:cNvPr>
@@ -6615,7 +6835,7 @@
           <p:cNvPr id="8" name="footer-rule">
             <a:extLst xmlns:a="http://schemas.openxmlformats.org/drawingml/2006/main">
               <a:ext uri="{FF2B5EF4-FFF2-40B4-BE49-F238E27FC236}">
-                <a16:creationId xmlns:a16="http://schemas.microsoft.com/office/drawing/2014/main" id="{2151FC66-7C53-4332-BA77-9F5425A6023A}"/>
+                <a16:creationId xmlns:a16="http://schemas.microsoft.com/office/drawing/2014/main" id="{D978B08C-E0FA-4DC5-A4CA-24EF9BEB73D0}"/>
               </a:ext>
             </a:extLst>
           </p:cNvPr>
@@ -6648,7 +6868,7 @@
           <p:cNvPr id="9" name="footer">
             <a:extLst xmlns:a="http://schemas.openxmlformats.org/drawingml/2006/main">
               <a:ext uri="{FF2B5EF4-FFF2-40B4-BE49-F238E27FC236}">
-                <a16:creationId xmlns:a16="http://schemas.microsoft.com/office/drawing/2014/main" id="{CF6E77D8-E98C-4E90-9F3D-052D186412AA}"/>
+                <a16:creationId xmlns:a16="http://schemas.microsoft.com/office/drawing/2014/main" id="{75D8066A-55AD-47EB-9ADC-F9CCCA37B9B9}"/>
               </a:ext>
             </a:extLst>
           </p:cNvPr>
@@ -6703,7 +6923,7 @@
           <p:cNvPr id="10" name="page-number">
             <a:extLst xmlns:a="http://schemas.openxmlformats.org/drawingml/2006/main">
               <a:ext uri="{FF2B5EF4-FFF2-40B4-BE49-F238E27FC236}">
-                <a16:creationId xmlns:a16="http://schemas.microsoft.com/office/drawing/2014/main" id="{AB3357BD-CDE9-44E9-BD2F-E6EB03A45FE2}"/>
+                <a16:creationId xmlns:a16="http://schemas.microsoft.com/office/drawing/2014/main" id="{C77A3787-7A36-4820-B200-294BC4DF0745}"/>
               </a:ext>
             </a:extLst>
           </p:cNvPr>
@@ -6756,7 +6976,7 @@
     </p:spTree>
     <p:extLst>
       <p:ext uri="{BB962C8B-B14F-4D97-AF65-F5344CB8AC3E}">
-        <p14:creationId xmlns:p14="http://schemas.microsoft.com/office/powerpoint/2010/main" val="1460119431"/>
+        <p14:creationId xmlns:p14="http://schemas.microsoft.com/office/powerpoint/2010/main" val="383801454"/>
       </p:ext>
     </p:extLst>
   </p:cSld>
@@ -6787,7 +7007,7 @@
           <p:cNvPr id="10" name="slide-title">
             <a:extLst xmlns:a="http://schemas.openxmlformats.org/drawingml/2006/main">
               <a:ext uri="{FF2B5EF4-FFF2-40B4-BE49-F238E27FC236}">
-                <a16:creationId xmlns:a16="http://schemas.microsoft.com/office/drawing/2014/main" id="{D34EAD4B-6E97-4990-8A63-8A5147F3FD09}"/>
+                <a16:creationId xmlns:a16="http://schemas.microsoft.com/office/drawing/2014/main" id="{55F9A520-F08F-4D9E-85D6-B75BC7C077D3}"/>
               </a:ext>
             </a:extLst>
           </p:cNvPr>
@@ -6838,7 +7058,7 @@
           <p:cNvPr id="2" name="visual-claim">
             <a:extLst xmlns:a="http://schemas.openxmlformats.org/drawingml/2006/main">
               <a:ext uri="{FF2B5EF4-FFF2-40B4-BE49-F238E27FC236}">
-                <a16:creationId xmlns:a16="http://schemas.microsoft.com/office/drawing/2014/main" id="{10A3085E-055C-4D1F-A3F2-0FA60325EAA0}"/>
+                <a16:creationId xmlns:a16="http://schemas.microsoft.com/office/drawing/2014/main" id="{D030A6C5-F410-46E9-A61C-409F78B5A9C1}"/>
               </a:ext>
             </a:extLst>
           </p:cNvPr>
@@ -6889,7 +7109,7 @@
           <p:cNvPr id="3" name="image-surface">
             <a:extLst xmlns:a="http://schemas.openxmlformats.org/drawingml/2006/main">
               <a:ext uri="{FF2B5EF4-FFF2-40B4-BE49-F238E27FC236}">
-                <a16:creationId xmlns:a16="http://schemas.microsoft.com/office/drawing/2014/main" id="{EFF2DC37-EF88-4AE8-A0E1-3F8547CD8CC2}"/>
+                <a16:creationId xmlns:a16="http://schemas.microsoft.com/office/drawing/2014/main" id="{24454482-9449-4A68-BD44-169CF46530E6}"/>
               </a:ext>
             </a:extLst>
           </p:cNvPr>
@@ -6928,7 +7148,7 @@
           <p:nvPr/>
         </p:nvPicPr>
         <p:blipFill>
-          <a:blip xmlns:r="http://schemas.openxmlformats.org/officeDocument/2006/relationships" xmlns:a="http://schemas.openxmlformats.org/drawingml/2006/main" r:embed="Ra47b57dec0564c7f"/>
+          <a:blip xmlns:r="http://schemas.openxmlformats.org/officeDocument/2006/relationships" xmlns:a="http://schemas.openxmlformats.org/drawingml/2006/main" r:embed="Rc463f8076f48410f"/>
           <a:stretch xmlns:a="http://schemas.openxmlformats.org/drawingml/2006/main"/>
         </p:blipFill>
         <p:spPr>
@@ -6946,7 +7166,7 @@
           <p:cNvPr id="5" name="image-caption">
             <a:extLst xmlns:a="http://schemas.openxmlformats.org/drawingml/2006/main">
               <a:ext uri="{FF2B5EF4-FFF2-40B4-BE49-F238E27FC236}">
-                <a16:creationId xmlns:a16="http://schemas.microsoft.com/office/drawing/2014/main" id="{FE69EE92-59E5-4BB7-9E1F-D56CC27106B3}"/>
+                <a16:creationId xmlns:a16="http://schemas.microsoft.com/office/drawing/2014/main" id="{78F64461-DB26-4844-B85F-5CA6756E13C7}"/>
               </a:ext>
             </a:extLst>
           </p:cNvPr>
@@ -6997,7 +7217,7 @@
           <p:cNvPr id="6" name="eyebrow">
             <a:extLst xmlns:a="http://schemas.openxmlformats.org/drawingml/2006/main">
               <a:ext uri="{FF2B5EF4-FFF2-40B4-BE49-F238E27FC236}">
-                <a16:creationId xmlns:a16="http://schemas.microsoft.com/office/drawing/2014/main" id="{8134BC02-DA58-4A6B-8EC0-509957B39327}"/>
+                <a16:creationId xmlns:a16="http://schemas.microsoft.com/office/drawing/2014/main" id="{16B165A4-63DE-4C5F-9E86-FFC065922BD2}"/>
               </a:ext>
             </a:extLst>
           </p:cNvPr>
@@ -7048,7 +7268,7 @@
           <p:cNvPr id="7" name="footer-rule">
             <a:extLst xmlns:a="http://schemas.openxmlformats.org/drawingml/2006/main">
               <a:ext uri="{FF2B5EF4-FFF2-40B4-BE49-F238E27FC236}">
-                <a16:creationId xmlns:a16="http://schemas.microsoft.com/office/drawing/2014/main" id="{083DEEE1-61A8-4FA7-B200-47EBC06EDFE0}"/>
+                <a16:creationId xmlns:a16="http://schemas.microsoft.com/office/drawing/2014/main" id="{BD72494F-8D03-47DF-94D2-97D62EE6A6B0}"/>
               </a:ext>
             </a:extLst>
           </p:cNvPr>
@@ -7081,7 +7301,7 @@
           <p:cNvPr id="8" name="footer">
             <a:extLst xmlns:a="http://schemas.openxmlformats.org/drawingml/2006/main">
               <a:ext uri="{FF2B5EF4-FFF2-40B4-BE49-F238E27FC236}">
-                <a16:creationId xmlns:a16="http://schemas.microsoft.com/office/drawing/2014/main" id="{714CB105-E374-4059-B421-832C94FA6791}"/>
+                <a16:creationId xmlns:a16="http://schemas.microsoft.com/office/drawing/2014/main" id="{AF46AE38-65A7-4F72-AFD5-FF8FB2CBBA8D}"/>
               </a:ext>
             </a:extLst>
           </p:cNvPr>
@@ -7136,7 +7356,7 @@
           <p:cNvPr id="9" name="page-number">
             <a:extLst xmlns:a="http://schemas.openxmlformats.org/drawingml/2006/main">
               <a:ext uri="{FF2B5EF4-FFF2-40B4-BE49-F238E27FC236}">
-                <a16:creationId xmlns:a16="http://schemas.microsoft.com/office/drawing/2014/main" id="{D81C5C6B-7723-4F3C-A889-A64E30FBE8E0}"/>
+                <a16:creationId xmlns:a16="http://schemas.microsoft.com/office/drawing/2014/main" id="{BCEA44E9-78E8-47CB-A320-6DFD91FA6E0A}"/>
               </a:ext>
             </a:extLst>
           </p:cNvPr>
@@ -7189,7 +7409,7 @@
     </p:spTree>
     <p:extLst>
       <p:ext uri="{BB962C8B-B14F-4D97-AF65-F5344CB8AC3E}">
-        <p14:creationId xmlns:p14="http://schemas.microsoft.com/office/powerpoint/2010/main" val="947573399"/>
+        <p14:creationId xmlns:p14="http://schemas.microsoft.com/office/powerpoint/2010/main" val="1867881638"/>
       </p:ext>
     </p:extLst>
   </p:cSld>
@@ -7220,7 +7440,7 @@
           <p:cNvPr id="11" name="slide-title">
             <a:extLst xmlns:a="http://schemas.openxmlformats.org/drawingml/2006/main">
               <a:ext uri="{FF2B5EF4-FFF2-40B4-BE49-F238E27FC236}">
-                <a16:creationId xmlns:a16="http://schemas.microsoft.com/office/drawing/2014/main" id="{01C1E5B7-2E9B-4665-925E-9EFE7E6512C9}"/>
+                <a16:creationId xmlns:a16="http://schemas.microsoft.com/office/drawing/2014/main" id="{FFBB80D3-CD58-4E29-AF97-390D59718428}"/>
               </a:ext>
             </a:extLst>
           </p:cNvPr>
@@ -7261,7 +7481,7 @@
                   <a:srgbClr val="0B1F3A"/>
                 </a:solidFill>
               </a:rPr>
-              <a:t>Local continua sendo a rota alternativa</a:t>
+              <a:t>Explore a cópia do banco no navegador</a:t>
             </a:r>
           </a:p>
         </p:txBody>
@@ -7271,7 +7491,7 @@
           <p:cNvPr id="2" name="slide-subtitle">
             <a:extLst xmlns:a="http://schemas.openxmlformats.org/drawingml/2006/main">
               <a:ext uri="{FF2B5EF4-FFF2-40B4-BE49-F238E27FC236}">
-                <a16:creationId xmlns:a16="http://schemas.microsoft.com/office/drawing/2014/main" id="{B82E5C5F-4AB2-40FA-86E6-4929429E46D4}"/>
+                <a16:creationId xmlns:a16="http://schemas.microsoft.com/office/drawing/2014/main" id="{B845F0E7-A249-48EF-BA34-AFBE34368820}"/>
               </a:ext>
             </a:extLst>
           </p:cNvPr>
@@ -7312,7 +7532,7 @@
                   <a:srgbClr val="5C6F86"/>
                 </a:solidFill>
               </a:rPr>
-              <a:t>O launcher mantém o mesmo resultado quando Codespaces ou internet não estão disponíveis.</a:t>
+              <a:t>DuckDB UI abre na porta privada 4213 sem bloquear nem modificar o banco usado pelo dbt.</a:t>
             </a:r>
           </a:p>
         </p:txBody>
@@ -7322,7 +7542,7 @@
           <p:cNvPr id="3" name="bullets">
             <a:extLst xmlns:a="http://schemas.openxmlformats.org/drawingml/2006/main">
               <a:ext uri="{FF2B5EF4-FFF2-40B4-BE49-F238E27FC236}">
-                <a16:creationId xmlns:a16="http://schemas.microsoft.com/office/drawing/2014/main" id="{CD855CF9-48BA-4C5D-849C-C3FE7C3D7390}"/>
+                <a16:creationId xmlns:a16="http://schemas.microsoft.com/office/drawing/2014/main" id="{23BDA795-FCC8-4AB9-BAB5-8C074EC2C1D5}"/>
               </a:ext>
             </a:extLst>
           </p:cNvPr>
@@ -7363,7 +7583,7 @@
                   <a:srgbClr val="0B1F3A"/>
                 </a:solidFill>
               </a:rPr>
-              <a:t>• Windows, macOS e Linux documentados</a:t>
+              <a:t>• Execute depois do checkpoint</a:t>
             </a:r>
           </a:p>
           <a:p xmlns:a="http://schemas.openxmlformats.org/drawingml/2006/main">
@@ -7381,7 +7601,7 @@
                   <a:srgbClr val="0B1F3A"/>
                 </a:solidFill>
               </a:rPr>
-              <a:t>• doctor encontra bloqueios</a:t>
+              <a:t>• Mantenha o terminal aberto</a:t>
             </a:r>
           </a:p>
           <a:p xmlns:a="http://schemas.openxmlformats.org/drawingml/2006/main">
@@ -7399,7 +7619,7 @@
                   <a:srgbClr val="0B1F3A"/>
                 </a:solidFill>
               </a:rPr>
-              <a:t>• support-report sanitiza a ajuda</a:t>
+              <a:t>• Ctrl+C encerra e permite atualizar</a:t>
             </a:r>
           </a:p>
         </p:txBody>
@@ -7409,7 +7629,7 @@
           <p:cNvPr id="4" name="ambient-glow">
             <a:extLst xmlns:a="http://schemas.openxmlformats.org/drawingml/2006/main">
               <a:ext uri="{FF2B5EF4-FFF2-40B4-BE49-F238E27FC236}">
-                <a16:creationId xmlns:a16="http://schemas.microsoft.com/office/drawing/2014/main" id="{9B278757-64DE-435B-A5E5-3EA3918A8A30}"/>
+                <a16:creationId xmlns:a16="http://schemas.microsoft.com/office/drawing/2014/main" id="{9D05A191-1E49-41AB-87D3-4F0DD1C9A689}"/>
               </a:ext>
             </a:extLst>
           </p:cNvPr>
@@ -7446,7 +7666,7 @@
           <p:cNvPr id="5" name="ambient-core">
             <a:extLst xmlns:a="http://schemas.openxmlformats.org/drawingml/2006/main">
               <a:ext uri="{FF2B5EF4-FFF2-40B4-BE49-F238E27FC236}">
-                <a16:creationId xmlns:a16="http://schemas.microsoft.com/office/drawing/2014/main" id="{44E154DD-7F3C-4EAB-9DEA-2D698A00BD2A}"/>
+                <a16:creationId xmlns:a16="http://schemas.microsoft.com/office/drawing/2014/main" id="{333742DF-8B8F-4AFE-9ADA-89640C3EF368}"/>
               </a:ext>
             </a:extLst>
           </p:cNvPr>
@@ -7483,7 +7703,7 @@
           <p:cNvPr id="6" name="section-number">
             <a:extLst xmlns:a="http://schemas.openxmlformats.org/drawingml/2006/main">
               <a:ext uri="{FF2B5EF4-FFF2-40B4-BE49-F238E27FC236}">
-                <a16:creationId xmlns:a16="http://schemas.microsoft.com/office/drawing/2014/main" id="{514569F6-F399-464F-9B95-5B04B746FD5D}"/>
+                <a16:creationId xmlns:a16="http://schemas.microsoft.com/office/drawing/2014/main" id="{F9C0487B-8F03-448D-BE9C-F69882C041E2}"/>
               </a:ext>
             </a:extLst>
           </p:cNvPr>
@@ -7534,7 +7754,7 @@
           <p:cNvPr id="7" name="eyebrow">
             <a:extLst xmlns:a="http://schemas.openxmlformats.org/drawingml/2006/main">
               <a:ext uri="{FF2B5EF4-FFF2-40B4-BE49-F238E27FC236}">
-                <a16:creationId xmlns:a16="http://schemas.microsoft.com/office/drawing/2014/main" id="{CE8DD9F8-7292-4F7A-8038-97304A19E565}"/>
+                <a16:creationId xmlns:a16="http://schemas.microsoft.com/office/drawing/2014/main" id="{C723F1EC-0E57-4C0E-8EF4-809EB70DDBF5}"/>
               </a:ext>
             </a:extLst>
           </p:cNvPr>
@@ -7585,7 +7805,7 @@
           <p:cNvPr id="8" name="footer-rule">
             <a:extLst xmlns:a="http://schemas.openxmlformats.org/drawingml/2006/main">
               <a:ext uri="{FF2B5EF4-FFF2-40B4-BE49-F238E27FC236}">
-                <a16:creationId xmlns:a16="http://schemas.microsoft.com/office/drawing/2014/main" id="{4E9C23FF-24A7-40DB-BABD-6808F04F2961}"/>
+                <a16:creationId xmlns:a16="http://schemas.microsoft.com/office/drawing/2014/main" id="{209A9B78-D1BE-47D7-A25B-60566AF78AAD}"/>
               </a:ext>
             </a:extLst>
           </p:cNvPr>
@@ -7618,7 +7838,7 @@
           <p:cNvPr id="9" name="footer">
             <a:extLst xmlns:a="http://schemas.openxmlformats.org/drawingml/2006/main">
               <a:ext uri="{FF2B5EF4-FFF2-40B4-BE49-F238E27FC236}">
-                <a16:creationId xmlns:a16="http://schemas.microsoft.com/office/drawing/2014/main" id="{97385242-CEF1-42D7-8C1B-5F9B470B4AC1}"/>
+                <a16:creationId xmlns:a16="http://schemas.microsoft.com/office/drawing/2014/main" id="{9A030E42-F79C-4787-B439-63F7572B2A67}"/>
               </a:ext>
             </a:extLst>
           </p:cNvPr>
@@ -7673,7 +7893,7 @@
           <p:cNvPr id="10" name="page-number">
             <a:extLst xmlns:a="http://schemas.openxmlformats.org/drawingml/2006/main">
               <a:ext uri="{FF2B5EF4-FFF2-40B4-BE49-F238E27FC236}">
-                <a16:creationId xmlns:a16="http://schemas.microsoft.com/office/drawing/2014/main" id="{A549871B-3DF6-4F3A-A6EE-C05EAE934AF6}"/>
+                <a16:creationId xmlns:a16="http://schemas.microsoft.com/office/drawing/2014/main" id="{497B3FD2-03F2-4C3E-854F-16B8BD13E8F7}"/>
               </a:ext>
             </a:extLst>
           </p:cNvPr>
@@ -7726,7 +7946,7 @@
     </p:spTree>
     <p:extLst>
       <p:ext uri="{BB962C8B-B14F-4D97-AF65-F5344CB8AC3E}">
-        <p14:creationId xmlns:p14="http://schemas.microsoft.com/office/powerpoint/2010/main" val="1614947613"/>
+        <p14:creationId xmlns:p14="http://schemas.microsoft.com/office/powerpoint/2010/main" val="1257307493"/>
       </p:ext>
     </p:extLst>
   </p:cSld>
@@ -7762,10 +7982,10 @@
       </p:grpSpPr>
       <p:sp>
         <p:nvSpPr>
-          <p:cNvPr id="12" name="slide-title">
-            <a:extLst xmlns:a="http://schemas.openxmlformats.org/drawingml/2006/main">
-              <a:ext uri="{FF2B5EF4-FFF2-40B4-BE49-F238E27FC236}">
-                <a16:creationId xmlns:a16="http://schemas.microsoft.com/office/drawing/2014/main" id="{4BB82FB4-4D1E-4BAB-822A-99440B4E8A1B}"/>
+          <p:cNvPr id="13" name="slide-title">
+            <a:extLst xmlns:a="http://schemas.openxmlformats.org/drawingml/2006/main">
+              <a:ext uri="{FF2B5EF4-FFF2-40B4-BE49-F238E27FC236}">
+                <a16:creationId xmlns:a16="http://schemas.microsoft.com/office/drawing/2014/main" id="{378EE93E-2021-4DEC-8E03-C9BBA1390992}"/>
               </a:ext>
             </a:extLst>
           </p:cNvPr>
@@ -7806,74 +8026,47 @@
                   <a:srgbClr val="FFFFFF"/>
                 </a:solidFill>
               </a:rPr>
-              <a:t>Local continua sendo a rota alternativa</a:t>
-            </a:r>
-          </a:p>
-        </p:txBody>
-      </p:sp>
-      <p:sp>
-        <p:nvSpPr>
-          <p:cNvPr id="2" name="status-dot-1">
-            <a:extLst xmlns:a="http://schemas.openxmlformats.org/drawingml/2006/main">
-              <a:ext uri="{FF2B5EF4-FFF2-40B4-BE49-F238E27FC236}">
-                <a16:creationId xmlns:a16="http://schemas.microsoft.com/office/drawing/2014/main" id="{ED1DDFE0-F0C1-4691-8901-3B40D0CD6A71}"/>
-              </a:ext>
-            </a:extLst>
-          </p:cNvPr>
-          <p:cNvSpPr>
-            <a:spLocks xmlns:a="http://schemas.openxmlformats.org/drawingml/2006/main" noGrp="1"/>
-          </p:cNvSpPr>
-          <p:nvPr/>
-        </p:nvSpPr>
-        <p:spPr>
-          <a:xfrm xmlns:a="http://schemas.openxmlformats.org/drawingml/2006/main">
-            <a:off x="2152650" y="3105150"/>
-            <a:ext cx="457200" cy="457200"/>
-          </a:xfrm>
-          <a:prstGeom xmlns:a="http://schemas.openxmlformats.org/drawingml/2006/main" prst="ellipse">
-            <a:avLst/>
+              <a:t>Explore a cópia do banco no navegador</a:t>
+            </a:r>
+          </a:p>
+        </p:txBody>
+      </p:sp>
+      <p:sp>
+        <p:nvSpPr>
+          <p:cNvPr id="2" name="flow-1">
+            <a:extLst xmlns:a="http://schemas.openxmlformats.org/drawingml/2006/main">
+              <a:ext uri="{FF2B5EF4-FFF2-40B4-BE49-F238E27FC236}">
+                <a16:creationId xmlns:a16="http://schemas.microsoft.com/office/drawing/2014/main" id="{8E27CE16-1191-4364-ACC8-CE1BD70E2770}"/>
+              </a:ext>
+            </a:extLst>
+          </p:cNvPr>
+          <p:cNvSpPr>
+            <a:spLocks xmlns:a="http://schemas.openxmlformats.org/drawingml/2006/main" noGrp="1"/>
+          </p:cNvSpPr>
+          <p:nvPr/>
+        </p:nvSpPr>
+        <p:spPr>
+          <a:xfrm xmlns:a="http://schemas.openxmlformats.org/drawingml/2006/main">
+            <a:off x="809625" y="3429000"/>
+            <a:ext cx="2443163" cy="1066800"/>
+          </a:xfrm>
+          <a:prstGeom xmlns:a="http://schemas.openxmlformats.org/drawingml/2006/main" prst="roundRect">
+            <a:avLst>
+              <a:gd name="adj" fmla="val 7143"/>
+            </a:avLst>
           </a:prstGeom>
           <a:solidFill xmlns:a="http://schemas.openxmlformats.org/drawingml/2006/main">
-            <a:srgbClr val="2DBE8C"/>
+            <a:srgbClr val="0D3260"/>
           </a:solidFill>
           <a:ln xmlns:a="http://schemas.openxmlformats.org/drawingml/2006/main" w="19050">
             <a:solidFill>
-              <a:srgbClr val="FFFFFF"/>
+              <a:srgbClr val="1EC5FF"/>
             </a:solidFill>
             <a:prstDash val="solid"/>
           </a:ln>
         </p:spPr>
-      </p:sp>
-      <p:sp>
-        <p:nvSpPr>
-          <p:cNvPr id="3" name="status-label-1">
-            <a:extLst xmlns:a="http://schemas.openxmlformats.org/drawingml/2006/main">
-              <a:ext uri="{FF2B5EF4-FFF2-40B4-BE49-F238E27FC236}">
-                <a16:creationId xmlns:a16="http://schemas.microsoft.com/office/drawing/2014/main" id="{7573F831-8065-43A9-B795-A188164C4790}"/>
-              </a:ext>
-            </a:extLst>
-          </p:cNvPr>
-          <p:cNvSpPr>
-            <a:spLocks xmlns:a="http://schemas.openxmlformats.org/drawingml/2006/main" noGrp="1"/>
-          </p:cNvSpPr>
-          <p:nvPr/>
-        </p:nvSpPr>
-        <p:spPr>
-          <a:xfrm xmlns:a="http://schemas.openxmlformats.org/drawingml/2006/main">
-            <a:off x="857250" y="3810000"/>
-            <a:ext cx="3048000" cy="857250"/>
-          </a:xfrm>
-          <a:prstGeom xmlns:a="http://schemas.openxmlformats.org/drawingml/2006/main" prst="rect">
-            <a:avLst/>
-          </a:prstGeom>
-          <a:noFill xmlns:a="http://schemas.openxmlformats.org/drawingml/2006/main"/>
-          <a:ln xmlns:a="http://schemas.openxmlformats.org/drawingml/2006/main" w="0">
-            <a:noFill/>
-            <a:prstDash val="solid"/>
-          </a:ln>
-        </p:spPr>
-        <p:txBody>
-          <a:bodyPr xmlns:a="http://schemas.openxmlformats.org/drawingml/2006/main"/>
+        <p:txBody>
+          <a:bodyPr xmlns:a="http://schemas.openxmlformats.org/drawingml/2006/main" anchor="ctr"/>
           <a:lstStyle xmlns:a="http://schemas.openxmlformats.org/drawingml/2006/main"/>
           <a:p xmlns:a="http://schemas.openxmlformats.org/drawingml/2006/main">
             <a:pPr algn="ctr">
@@ -7890,74 +8083,47 @@
                   <a:srgbClr val="FFFFFF"/>
                 </a:solidFill>
               </a:rPr>
-              <a:t>Codespaces: recomendado</a:t>
-            </a:r>
-          </a:p>
-        </p:txBody>
-      </p:sp>
-      <p:sp>
-        <p:nvSpPr>
-          <p:cNvPr id="4" name="status-dot-2">
-            <a:extLst xmlns:a="http://schemas.openxmlformats.org/drawingml/2006/main">
-              <a:ext uri="{FF2B5EF4-FFF2-40B4-BE49-F238E27FC236}">
-                <a16:creationId xmlns:a16="http://schemas.microsoft.com/office/drawing/2014/main" id="{B4F8F521-4833-4868-8299-BEB65265A469}"/>
-              </a:ext>
-            </a:extLst>
-          </p:cNvPr>
-          <p:cNvSpPr>
-            <a:spLocks xmlns:a="http://schemas.openxmlformats.org/drawingml/2006/main" noGrp="1"/>
-          </p:cNvSpPr>
-          <p:nvPr/>
-        </p:nvSpPr>
-        <p:spPr>
-          <a:xfrm xmlns:a="http://schemas.openxmlformats.org/drawingml/2006/main">
-            <a:off x="5486400" y="3105150"/>
-            <a:ext cx="457200" cy="457200"/>
-          </a:xfrm>
-          <a:prstGeom xmlns:a="http://schemas.openxmlformats.org/drawingml/2006/main" prst="ellipse">
-            <a:avLst/>
+              <a:t>dbt build</a:t>
+            </a:r>
+          </a:p>
+        </p:txBody>
+      </p:sp>
+      <p:sp>
+        <p:nvSpPr>
+          <p:cNvPr id="3" name="flow-2">
+            <a:extLst xmlns:a="http://schemas.openxmlformats.org/drawingml/2006/main">
+              <a:ext uri="{FF2B5EF4-FFF2-40B4-BE49-F238E27FC236}">
+                <a16:creationId xmlns:a16="http://schemas.microsoft.com/office/drawing/2014/main" id="{011D50B5-1AA5-4352-BDDA-6D05FB7C9F3F}"/>
+              </a:ext>
+            </a:extLst>
+          </p:cNvPr>
+          <p:cNvSpPr>
+            <a:spLocks xmlns:a="http://schemas.openxmlformats.org/drawingml/2006/main" noGrp="1"/>
+          </p:cNvSpPr>
+          <p:nvPr/>
+        </p:nvSpPr>
+        <p:spPr>
+          <a:xfrm xmlns:a="http://schemas.openxmlformats.org/drawingml/2006/main">
+            <a:off x="3519488" y="3429000"/>
+            <a:ext cx="2443163" cy="1066800"/>
+          </a:xfrm>
+          <a:prstGeom xmlns:a="http://schemas.openxmlformats.org/drawingml/2006/main" prst="roundRect">
+            <a:avLst>
+              <a:gd name="adj" fmla="val 7143"/>
+            </a:avLst>
           </a:prstGeom>
           <a:solidFill xmlns:a="http://schemas.openxmlformats.org/drawingml/2006/main">
-            <a:srgbClr val="F4B942"/>
+            <a:srgbClr val="0D3260"/>
           </a:solidFill>
           <a:ln xmlns:a="http://schemas.openxmlformats.org/drawingml/2006/main" w="19050">
             <a:solidFill>
-              <a:srgbClr val="FFFFFF"/>
+              <a:srgbClr val="1EC5FF"/>
             </a:solidFill>
             <a:prstDash val="solid"/>
           </a:ln>
         </p:spPr>
-      </p:sp>
-      <p:sp>
-        <p:nvSpPr>
-          <p:cNvPr id="5" name="status-label-2">
-            <a:extLst xmlns:a="http://schemas.openxmlformats.org/drawingml/2006/main">
-              <a:ext uri="{FF2B5EF4-FFF2-40B4-BE49-F238E27FC236}">
-                <a16:creationId xmlns:a16="http://schemas.microsoft.com/office/drawing/2014/main" id="{6D6B98DE-3624-4416-9013-A99641DCF681}"/>
-              </a:ext>
-            </a:extLst>
-          </p:cNvPr>
-          <p:cNvSpPr>
-            <a:spLocks xmlns:a="http://schemas.openxmlformats.org/drawingml/2006/main" noGrp="1"/>
-          </p:cNvSpPr>
-          <p:nvPr/>
-        </p:nvSpPr>
-        <p:spPr>
-          <a:xfrm xmlns:a="http://schemas.openxmlformats.org/drawingml/2006/main">
-            <a:off x="4191000" y="3810000"/>
-            <a:ext cx="3048000" cy="857250"/>
-          </a:xfrm>
-          <a:prstGeom xmlns:a="http://schemas.openxmlformats.org/drawingml/2006/main" prst="rect">
-            <a:avLst/>
-          </a:prstGeom>
-          <a:noFill xmlns:a="http://schemas.openxmlformats.org/drawingml/2006/main"/>
-          <a:ln xmlns:a="http://schemas.openxmlformats.org/drawingml/2006/main" w="0">
-            <a:noFill/>
-            <a:prstDash val="solid"/>
-          </a:ln>
-        </p:spPr>
-        <p:txBody>
-          <a:bodyPr xmlns:a="http://schemas.openxmlformats.org/drawingml/2006/main"/>
+        <p:txBody>
+          <a:bodyPr xmlns:a="http://schemas.openxmlformats.org/drawingml/2006/main" anchor="ctr"/>
           <a:lstStyle xmlns:a="http://schemas.openxmlformats.org/drawingml/2006/main"/>
           <a:p xmlns:a="http://schemas.openxmlformats.org/drawingml/2006/main">
             <a:pPr algn="ctr">
@@ -7974,62 +8140,221 @@
                   <a:srgbClr val="FFFFFF"/>
                 </a:solidFill>
               </a:rPr>
-              <a:t>Local: alternativa</a:t>
-            </a:r>
-          </a:p>
-        </p:txBody>
-      </p:sp>
-      <p:sp>
-        <p:nvSpPr>
-          <p:cNvPr id="6" name="status-dot-3">
-            <a:extLst xmlns:a="http://schemas.openxmlformats.org/drawingml/2006/main">
-              <a:ext uri="{FF2B5EF4-FFF2-40B4-BE49-F238E27FC236}">
-                <a16:creationId xmlns:a16="http://schemas.microsoft.com/office/drawing/2014/main" id="{932864F4-1C8C-4C22-83AD-246B7411F575}"/>
-              </a:ext>
-            </a:extLst>
-          </p:cNvPr>
-          <p:cNvSpPr>
-            <a:spLocks xmlns:a="http://schemas.openxmlformats.org/drawingml/2006/main" noGrp="1"/>
-          </p:cNvSpPr>
-          <p:nvPr/>
-        </p:nvSpPr>
-        <p:spPr>
-          <a:xfrm xmlns:a="http://schemas.openxmlformats.org/drawingml/2006/main">
-            <a:off x="8820150" y="3105150"/>
-            <a:ext cx="457200" cy="457200"/>
-          </a:xfrm>
-          <a:prstGeom xmlns:a="http://schemas.openxmlformats.org/drawingml/2006/main" prst="ellipse">
-            <a:avLst/>
+              <a:t>snapshot</a:t>
+            </a:r>
+          </a:p>
+        </p:txBody>
+      </p:sp>
+      <p:sp>
+        <p:nvSpPr>
+          <p:cNvPr id="4" name="flow-3">
+            <a:extLst xmlns:a="http://schemas.openxmlformats.org/drawingml/2006/main">
+              <a:ext uri="{FF2B5EF4-FFF2-40B4-BE49-F238E27FC236}">
+                <a16:creationId xmlns:a16="http://schemas.microsoft.com/office/drawing/2014/main" id="{EFB0E081-A919-4005-A02A-D418FA758468}"/>
+              </a:ext>
+            </a:extLst>
+          </p:cNvPr>
+          <p:cNvSpPr>
+            <a:spLocks xmlns:a="http://schemas.openxmlformats.org/drawingml/2006/main" noGrp="1"/>
+          </p:cNvSpPr>
+          <p:nvPr/>
+        </p:nvSpPr>
+        <p:spPr>
+          <a:xfrm xmlns:a="http://schemas.openxmlformats.org/drawingml/2006/main">
+            <a:off x="6229350" y="3429000"/>
+            <a:ext cx="2443163" cy="1066800"/>
+          </a:xfrm>
+          <a:prstGeom xmlns:a="http://schemas.openxmlformats.org/drawingml/2006/main" prst="roundRect">
+            <a:avLst>
+              <a:gd name="adj" fmla="val 7143"/>
+            </a:avLst>
           </a:prstGeom>
           <a:solidFill xmlns:a="http://schemas.openxmlformats.org/drawingml/2006/main">
-            <a:srgbClr val="EA5B5B"/>
+            <a:srgbClr val="0D3260"/>
           </a:solidFill>
           <a:ln xmlns:a="http://schemas.openxmlformats.org/drawingml/2006/main" w="19050">
             <a:solidFill>
-              <a:srgbClr val="FFFFFF"/>
+              <a:srgbClr val="1EC5FF"/>
             </a:solidFill>
             <a:prstDash val="solid"/>
           </a:ln>
         </p:spPr>
-      </p:sp>
-      <p:sp>
-        <p:nvSpPr>
-          <p:cNvPr id="7" name="status-label-3">
-            <a:extLst xmlns:a="http://schemas.openxmlformats.org/drawingml/2006/main">
-              <a:ext uri="{FF2B5EF4-FFF2-40B4-BE49-F238E27FC236}">
-                <a16:creationId xmlns:a16="http://schemas.microsoft.com/office/drawing/2014/main" id="{93A6C014-443C-4C6A-90BB-3481FDEDA2D0}"/>
-              </a:ext>
-            </a:extLst>
-          </p:cNvPr>
-          <p:cNvSpPr>
-            <a:spLocks xmlns:a="http://schemas.openxmlformats.org/drawingml/2006/main" noGrp="1"/>
-          </p:cNvSpPr>
-          <p:nvPr/>
-        </p:nvSpPr>
-        <p:spPr>
-          <a:xfrm xmlns:a="http://schemas.openxmlformats.org/drawingml/2006/main">
-            <a:off x="7524750" y="3810000"/>
-            <a:ext cx="3048000" cy="857250"/>
+        <p:txBody>
+          <a:bodyPr xmlns:a="http://schemas.openxmlformats.org/drawingml/2006/main" anchor="ctr"/>
+          <a:lstStyle xmlns:a="http://schemas.openxmlformats.org/drawingml/2006/main"/>
+          <a:p xmlns:a="http://schemas.openxmlformats.org/drawingml/2006/main">
+            <a:pPr algn="ctr">
+              <a:buNone/>
+              <a:defRPr sz="1575" b="1">
+                <a:solidFill>
+                  <a:srgbClr val="FFFFFF"/>
+                </a:solidFill>
+              </a:defRPr>
+            </a:pPr>
+            <a:r>
+              <a:rPr sz="1575" b="1">
+                <a:solidFill>
+                  <a:srgbClr val="FFFFFF"/>
+                </a:solidFill>
+              </a:rPr>
+              <a:t>DuckDB UI</a:t>
+            </a:r>
+          </a:p>
+        </p:txBody>
+      </p:sp>
+      <p:sp>
+        <p:nvSpPr>
+          <p:cNvPr id="5" name="flow-4">
+            <a:extLst xmlns:a="http://schemas.openxmlformats.org/drawingml/2006/main">
+              <a:ext uri="{FF2B5EF4-FFF2-40B4-BE49-F238E27FC236}">
+                <a16:creationId xmlns:a16="http://schemas.microsoft.com/office/drawing/2014/main" id="{63AF95BB-5443-421F-9146-457A5CE41C2B}"/>
+              </a:ext>
+            </a:extLst>
+          </p:cNvPr>
+          <p:cNvSpPr>
+            <a:spLocks xmlns:a="http://schemas.openxmlformats.org/drawingml/2006/main" noGrp="1"/>
+          </p:cNvSpPr>
+          <p:nvPr/>
+        </p:nvSpPr>
+        <p:spPr>
+          <a:xfrm xmlns:a="http://schemas.openxmlformats.org/drawingml/2006/main">
+            <a:off x="8939213" y="3429000"/>
+            <a:ext cx="2443163" cy="1066800"/>
+          </a:xfrm>
+          <a:prstGeom xmlns:a="http://schemas.openxmlformats.org/drawingml/2006/main" prst="roundRect">
+            <a:avLst>
+              <a:gd name="adj" fmla="val 7143"/>
+            </a:avLst>
+          </a:prstGeom>
+          <a:solidFill xmlns:a="http://schemas.openxmlformats.org/drawingml/2006/main">
+            <a:srgbClr val="0D3260"/>
+          </a:solidFill>
+          <a:ln xmlns:a="http://schemas.openxmlformats.org/drawingml/2006/main" w="19050">
+            <a:solidFill>
+              <a:srgbClr val="1EC5FF"/>
+            </a:solidFill>
+            <a:prstDash val="solid"/>
+          </a:ln>
+        </p:spPr>
+        <p:txBody>
+          <a:bodyPr xmlns:a="http://schemas.openxmlformats.org/drawingml/2006/main" anchor="ctr"/>
+          <a:lstStyle xmlns:a="http://schemas.openxmlformats.org/drawingml/2006/main"/>
+          <a:p xmlns:a="http://schemas.openxmlformats.org/drawingml/2006/main">
+            <a:pPr algn="ctr">
+              <a:buNone/>
+              <a:defRPr sz="1575" b="1">
+                <a:solidFill>
+                  <a:srgbClr val="FFFFFF"/>
+                </a:solidFill>
+              </a:defRPr>
+            </a:pPr>
+            <a:r>
+              <a:rPr sz="1575" b="1">
+                <a:solidFill>
+                  <a:srgbClr val="FFFFFF"/>
+                </a:solidFill>
+              </a:rPr>
+              <a:t>navegador</a:t>
+            </a:r>
+          </a:p>
+        </p:txBody>
+      </p:sp>
+      <p:cxnSp>
+        <p:nvCxnSpPr>
+          <p:cNvPr id="26" name=""/>
+          <p:cNvCxnSpPr>
+            <a:stCxn xmlns:a="http://schemas.openxmlformats.org/drawingml/2006/main" id="2" idx="3"/>
+            <a:endCxn xmlns:a="http://schemas.openxmlformats.org/drawingml/2006/main" id="3" idx="1"/>
+          </p:cNvCxnSpPr>
+          <p:nvPr/>
+        </p:nvCxnSpPr>
+        <p:spPr>
+          <a:xfrm xmlns:a="http://schemas.openxmlformats.org/drawingml/2006/main">
+            <a:off x="3252788" y="3962400"/>
+            <a:ext cx="266700" cy="0"/>
+          </a:xfrm>
+          <a:prstGeom xmlns:a="http://schemas.openxmlformats.org/drawingml/2006/main" prst="straightConnector1">
+            <a:avLst/>
+          </a:prstGeom>
+          <a:ln xmlns:a="http://schemas.openxmlformats.org/drawingml/2006/main" w="28575">
+            <a:solidFill>
+              <a:srgbClr val="1EC5FF"/>
+            </a:solidFill>
+            <a:prstDash val="solid"/>
+            <a:headEnd type="arrow" w="med" len="med"/>
+          </a:ln>
+        </p:spPr>
+      </p:cxnSp>
+      <p:cxnSp>
+        <p:nvCxnSpPr>
+          <p:cNvPr id="27" name=""/>
+          <p:cNvCxnSpPr>
+            <a:stCxn xmlns:a="http://schemas.openxmlformats.org/drawingml/2006/main" id="3" idx="3"/>
+            <a:endCxn xmlns:a="http://schemas.openxmlformats.org/drawingml/2006/main" id="4" idx="1"/>
+          </p:cNvCxnSpPr>
+          <p:nvPr/>
+        </p:nvCxnSpPr>
+        <p:spPr>
+          <a:xfrm xmlns:a="http://schemas.openxmlformats.org/drawingml/2006/main">
+            <a:off x="5962651" y="3962400"/>
+            <a:ext cx="266699" cy="0"/>
+          </a:xfrm>
+          <a:prstGeom xmlns:a="http://schemas.openxmlformats.org/drawingml/2006/main" prst="straightConnector1">
+            <a:avLst/>
+          </a:prstGeom>
+          <a:ln xmlns:a="http://schemas.openxmlformats.org/drawingml/2006/main" w="28575">
+            <a:solidFill>
+              <a:srgbClr val="1EC5FF"/>
+            </a:solidFill>
+            <a:prstDash val="solid"/>
+            <a:headEnd type="arrow" w="med" len="med"/>
+          </a:ln>
+        </p:spPr>
+      </p:cxnSp>
+      <p:cxnSp>
+        <p:nvCxnSpPr>
+          <p:cNvPr id="28" name=""/>
+          <p:cNvCxnSpPr>
+            <a:stCxn xmlns:a="http://schemas.openxmlformats.org/drawingml/2006/main" id="4" idx="3"/>
+            <a:endCxn xmlns:a="http://schemas.openxmlformats.org/drawingml/2006/main" id="5" idx="1"/>
+          </p:cNvCxnSpPr>
+          <p:nvPr/>
+        </p:nvCxnSpPr>
+        <p:spPr>
+          <a:xfrm xmlns:a="http://schemas.openxmlformats.org/drawingml/2006/main">
+            <a:off x="8672513" y="3962400"/>
+            <a:ext cx="266700" cy="0"/>
+          </a:xfrm>
+          <a:prstGeom xmlns:a="http://schemas.openxmlformats.org/drawingml/2006/main" prst="straightConnector1">
+            <a:avLst/>
+          </a:prstGeom>
+          <a:ln xmlns:a="http://schemas.openxmlformats.org/drawingml/2006/main" w="28575">
+            <a:solidFill>
+              <a:srgbClr val="1EC5FF"/>
+            </a:solidFill>
+            <a:prstDash val="solid"/>
+            <a:headEnd type="arrow" w="med" len="med"/>
+          </a:ln>
+        </p:spPr>
+      </p:cxnSp>
+      <p:sp>
+        <p:nvSpPr>
+          <p:cNvPr id="9" name="eyebrow">
+            <a:extLst xmlns:a="http://schemas.openxmlformats.org/drawingml/2006/main">
+              <a:ext uri="{FF2B5EF4-FFF2-40B4-BE49-F238E27FC236}">
+                <a16:creationId xmlns:a16="http://schemas.microsoft.com/office/drawing/2014/main" id="{66E8346F-16B3-40F0-95C4-B8331F63D7A4}"/>
+              </a:ext>
+            </a:extLst>
+          </p:cNvPr>
+          <p:cNvSpPr>
+            <a:spLocks xmlns:a="http://schemas.openxmlformats.org/drawingml/2006/main" noGrp="1"/>
+          </p:cNvSpPr>
+          <p:nvPr/>
+        </p:nvSpPr>
+        <p:spPr>
+          <a:xfrm xmlns:a="http://schemas.openxmlformats.org/drawingml/2006/main">
+            <a:off x="685800" y="266700"/>
+            <a:ext cx="5143500" cy="266700"/>
           </a:xfrm>
           <a:prstGeom xmlns:a="http://schemas.openxmlformats.org/drawingml/2006/main" prst="rect">
             <a:avLst/>
@@ -8044,57 +8369,6 @@
           <a:bodyPr xmlns:a="http://schemas.openxmlformats.org/drawingml/2006/main"/>
           <a:lstStyle xmlns:a="http://schemas.openxmlformats.org/drawingml/2006/main"/>
           <a:p xmlns:a="http://schemas.openxmlformats.org/drawingml/2006/main">
-            <a:pPr algn="ctr">
-              <a:buNone/>
-              <a:defRPr sz="1575" b="1">
-                <a:solidFill>
-                  <a:srgbClr val="FFFFFF"/>
-                </a:solidFill>
-              </a:defRPr>
-            </a:pPr>
-            <a:r>
-              <a:rPr sz="1575" b="1">
-                <a:solidFill>
-                  <a:srgbClr val="FFFFFF"/>
-                </a:solidFill>
-              </a:rPr>
-              <a:t>Suporte: diagnóstico</a:t>
-            </a:r>
-          </a:p>
-        </p:txBody>
-      </p:sp>
-      <p:sp>
-        <p:nvSpPr>
-          <p:cNvPr id="8" name="eyebrow">
-            <a:extLst xmlns:a="http://schemas.openxmlformats.org/drawingml/2006/main">
-              <a:ext uri="{FF2B5EF4-FFF2-40B4-BE49-F238E27FC236}">
-                <a16:creationId xmlns:a16="http://schemas.microsoft.com/office/drawing/2014/main" id="{35EF1011-C474-400A-9052-E1A280BBF913}"/>
-              </a:ext>
-            </a:extLst>
-          </p:cNvPr>
-          <p:cNvSpPr>
-            <a:spLocks xmlns:a="http://schemas.openxmlformats.org/drawingml/2006/main" noGrp="1"/>
-          </p:cNvSpPr>
-          <p:nvPr/>
-        </p:nvSpPr>
-        <p:spPr>
-          <a:xfrm xmlns:a="http://schemas.openxmlformats.org/drawingml/2006/main">
-            <a:off x="685800" y="266700"/>
-            <a:ext cx="5143500" cy="266700"/>
-          </a:xfrm>
-          <a:prstGeom xmlns:a="http://schemas.openxmlformats.org/drawingml/2006/main" prst="rect">
-            <a:avLst/>
-          </a:prstGeom>
-          <a:noFill xmlns:a="http://schemas.openxmlformats.org/drawingml/2006/main"/>
-          <a:ln xmlns:a="http://schemas.openxmlformats.org/drawingml/2006/main" w="0">
-            <a:noFill/>
-            <a:prstDash val="solid"/>
-          </a:ln>
-        </p:spPr>
-        <p:txBody>
-          <a:bodyPr xmlns:a="http://schemas.openxmlformats.org/drawingml/2006/main"/>
-          <a:lstStyle xmlns:a="http://schemas.openxmlformats.org/drawingml/2006/main"/>
-          <a:p xmlns:a="http://schemas.openxmlformats.org/drawingml/2006/main">
             <a:pPr>
               <a:buNone/>
               <a:defRPr sz="1050" b="1">
@@ -8116,10 +8390,10 @@
       </p:sp>
       <p:sp>
         <p:nvSpPr>
-          <p:cNvPr id="9" name="footer-rule">
-            <a:extLst xmlns:a="http://schemas.openxmlformats.org/drawingml/2006/main">
-              <a:ext uri="{FF2B5EF4-FFF2-40B4-BE49-F238E27FC236}">
-                <a16:creationId xmlns:a16="http://schemas.microsoft.com/office/drawing/2014/main" id="{2ECDFC25-290F-4988-8535-59C8080100C9}"/>
+          <p:cNvPr id="10" name="footer-rule">
+            <a:extLst xmlns:a="http://schemas.openxmlformats.org/drawingml/2006/main">
+              <a:ext uri="{FF2B5EF4-FFF2-40B4-BE49-F238E27FC236}">
+                <a16:creationId xmlns:a16="http://schemas.microsoft.com/office/drawing/2014/main" id="{AE9A7DED-9472-480C-9C85-69D840EFC636}"/>
               </a:ext>
             </a:extLst>
           </p:cNvPr>
@@ -8149,10 +8423,10 @@
       </p:sp>
       <p:sp>
         <p:nvSpPr>
-          <p:cNvPr id="10" name="footer">
-            <a:extLst xmlns:a="http://schemas.openxmlformats.org/drawingml/2006/main">
-              <a:ext uri="{FF2B5EF4-FFF2-40B4-BE49-F238E27FC236}">
-                <a16:creationId xmlns:a16="http://schemas.microsoft.com/office/drawing/2014/main" id="{65A8EE9E-15A1-4A66-BB2A-A4AB2A58C6A9}"/>
+          <p:cNvPr id="11" name="footer">
+            <a:extLst xmlns:a="http://schemas.openxmlformats.org/drawingml/2006/main">
+              <a:ext uri="{FF2B5EF4-FFF2-40B4-BE49-F238E27FC236}">
+                <a16:creationId xmlns:a16="http://schemas.microsoft.com/office/drawing/2014/main" id="{7A454C72-E356-47AC-880E-DB4DE820FC73}"/>
               </a:ext>
             </a:extLst>
           </p:cNvPr>
@@ -8204,10 +8478,10 @@
       </p:sp>
       <p:sp>
         <p:nvSpPr>
-          <p:cNvPr id="11" name="page-number">
-            <a:extLst xmlns:a="http://schemas.openxmlformats.org/drawingml/2006/main">
-              <a:ext uri="{FF2B5EF4-FFF2-40B4-BE49-F238E27FC236}">
-                <a16:creationId xmlns:a16="http://schemas.microsoft.com/office/drawing/2014/main" id="{F6984D09-0943-4973-8E26-77DBEEFF2315}"/>
+          <p:cNvPr id="12" name="page-number">
+            <a:extLst xmlns:a="http://schemas.openxmlformats.org/drawingml/2006/main">
+              <a:ext uri="{FF2B5EF4-FFF2-40B4-BE49-F238E27FC236}">
+                <a16:creationId xmlns:a16="http://schemas.microsoft.com/office/drawing/2014/main" id="{1764148F-6C1E-42BD-A968-5B11993D1207}"/>
               </a:ext>
             </a:extLst>
           </p:cNvPr>
@@ -8260,7 +8534,7 @@
     </p:spTree>
     <p:extLst>
       <p:ext uri="{BB962C8B-B14F-4D97-AF65-F5344CB8AC3E}">
-        <p14:creationId xmlns:p14="http://schemas.microsoft.com/office/powerpoint/2010/main" val="985147844"/>
+        <p14:creationId xmlns:p14="http://schemas.microsoft.com/office/powerpoint/2010/main" val="560762889"/>
       </p:ext>
     </p:extLst>
   </p:cSld>
@@ -8299,7 +8573,7 @@
           <p:cNvPr id="9" name="slide-title">
             <a:extLst xmlns:a="http://schemas.openxmlformats.org/drawingml/2006/main">
               <a:ext uri="{FF2B5EF4-FFF2-40B4-BE49-F238E27FC236}">
-                <a16:creationId xmlns:a16="http://schemas.microsoft.com/office/drawing/2014/main" id="{9B59517F-EB97-49D2-845F-D7C89E704F8B}"/>
+                <a16:creationId xmlns:a16="http://schemas.microsoft.com/office/drawing/2014/main" id="{502AC5E9-C6A8-4CE3-85F5-6F64FB353811}"/>
               </a:ext>
             </a:extLst>
           </p:cNvPr>
@@ -8350,7 +8624,7 @@
           <p:cNvPr id="2" name="code-surface">
             <a:extLst xmlns:a="http://schemas.openxmlformats.org/drawingml/2006/main">
               <a:ext uri="{FF2B5EF4-FFF2-40B4-BE49-F238E27FC236}">
-                <a16:creationId xmlns:a16="http://schemas.microsoft.com/office/drawing/2014/main" id="{E0B02AF8-8F19-418B-9DF9-01CFAFCA61AA}"/>
+                <a16:creationId xmlns:a16="http://schemas.microsoft.com/office/drawing/2014/main" id="{02285E99-0936-4913-926B-C28BC54AF476}"/>
               </a:ext>
             </a:extLst>
           </p:cNvPr>
@@ -8385,7 +8659,7 @@
           <p:cNvPr id="3" name="command">
             <a:extLst xmlns:a="http://schemas.openxmlformats.org/drawingml/2006/main">
               <a:ext uri="{FF2B5EF4-FFF2-40B4-BE49-F238E27FC236}">
-                <a16:creationId xmlns:a16="http://schemas.microsoft.com/office/drawing/2014/main" id="{9F240185-320D-455B-929B-DBFA539D2819}"/>
+                <a16:creationId xmlns:a16="http://schemas.microsoft.com/office/drawing/2014/main" id="{A8FC6898-B120-4D76-BEDD-570093872553}"/>
               </a:ext>
             </a:extLst>
           </p:cNvPr>
@@ -8426,7 +8700,7 @@
                   <a:srgbClr val="1EC5FF"/>
                 </a:solidFill>
               </a:rPr>
-              <a:t>python course.py doctor</a:t>
+              <a:t>python course.py paths</a:t>
             </a:r>
           </a:p>
           <a:p xmlns:a="http://schemas.openxmlformats.org/drawingml/2006/main">
@@ -8447,6 +8721,24 @@
               <a:t>python course.py checkpoint 01</a:t>
             </a:r>
           </a:p>
+          <a:p xmlns:a="http://schemas.openxmlformats.org/drawingml/2006/main">
+            <a:pPr>
+              <a:buNone/>
+              <a:defRPr sz="1875" b="1">
+                <a:solidFill>
+                  <a:srgbClr val="1EC5FF"/>
+                </a:solidFill>
+              </a:defRPr>
+            </a:pPr>
+            <a:r>
+              <a:rPr sz="1875" b="1">
+                <a:solidFill>
+                  <a:srgbClr val="1EC5FF"/>
+                </a:solidFill>
+              </a:rPr>
+              <a:t>python course.py data-ui</a:t>
+            </a:r>
+          </a:p>
         </p:txBody>
       </p:sp>
       <p:sp>
@@ -8454,7 +8746,7 @@
           <p:cNvPr id="4" name="command-help">
             <a:extLst xmlns:a="http://schemas.openxmlformats.org/drawingml/2006/main">
               <a:ext uri="{FF2B5EF4-FFF2-40B4-BE49-F238E27FC236}">
-                <a16:creationId xmlns:a16="http://schemas.microsoft.com/office/drawing/2014/main" id="{20ECB557-E71E-434A-A5C7-1D29EFA65ED6}"/>
+                <a16:creationId xmlns:a16="http://schemas.microsoft.com/office/drawing/2014/main" id="{5CC5452B-D51F-4CD7-83B0-565961E910FD}"/>
               </a:ext>
             </a:extLst>
           </p:cNvPr>
@@ -8505,7 +8797,7 @@
           <p:cNvPr id="5" name="eyebrow">
             <a:extLst xmlns:a="http://schemas.openxmlformats.org/drawingml/2006/main">
               <a:ext uri="{FF2B5EF4-FFF2-40B4-BE49-F238E27FC236}">
-                <a16:creationId xmlns:a16="http://schemas.microsoft.com/office/drawing/2014/main" id="{D65120BA-D228-43B0-8081-A6420024EA7C}"/>
+                <a16:creationId xmlns:a16="http://schemas.microsoft.com/office/drawing/2014/main" id="{5F13D0F7-FE02-421C-8ED8-A0CEE45DAD81}"/>
               </a:ext>
             </a:extLst>
           </p:cNvPr>
@@ -8556,7 +8848,7 @@
           <p:cNvPr id="6" name="footer-rule">
             <a:extLst xmlns:a="http://schemas.openxmlformats.org/drawingml/2006/main">
               <a:ext uri="{FF2B5EF4-FFF2-40B4-BE49-F238E27FC236}">
-                <a16:creationId xmlns:a16="http://schemas.microsoft.com/office/drawing/2014/main" id="{0DD922C6-EAA6-4A06-99B9-E456C62DF850}"/>
+                <a16:creationId xmlns:a16="http://schemas.microsoft.com/office/drawing/2014/main" id="{798154F5-7A9D-4E37-B4EF-E68CE696C972}"/>
               </a:ext>
             </a:extLst>
           </p:cNvPr>
@@ -8589,7 +8881,7 @@
           <p:cNvPr id="7" name="footer">
             <a:extLst xmlns:a="http://schemas.openxmlformats.org/drawingml/2006/main">
               <a:ext uri="{FF2B5EF4-FFF2-40B4-BE49-F238E27FC236}">
-                <a16:creationId xmlns:a16="http://schemas.microsoft.com/office/drawing/2014/main" id="{12CCC7E6-6F04-4DC6-8147-CECE254A66E2}"/>
+                <a16:creationId xmlns:a16="http://schemas.microsoft.com/office/drawing/2014/main" id="{C96D0AEC-BFCF-4097-8003-3079ADCD3A3E}"/>
               </a:ext>
             </a:extLst>
           </p:cNvPr>
@@ -8644,7 +8936,7 @@
           <p:cNvPr id="8" name="page-number">
             <a:extLst xmlns:a="http://schemas.openxmlformats.org/drawingml/2006/main">
               <a:ext uri="{FF2B5EF4-FFF2-40B4-BE49-F238E27FC236}">
-                <a16:creationId xmlns:a16="http://schemas.microsoft.com/office/drawing/2014/main" id="{047DDEE7-D8D0-4655-ABE3-9491FAF9C906}"/>
+                <a16:creationId xmlns:a16="http://schemas.microsoft.com/office/drawing/2014/main" id="{500BAFB2-04DA-45EE-A2C4-19C883B0D59C}"/>
               </a:ext>
             </a:extLst>
           </p:cNvPr>
@@ -8697,7 +8989,7 @@
     </p:spTree>
     <p:extLst>
       <p:ext uri="{BB962C8B-B14F-4D97-AF65-F5344CB8AC3E}">
-        <p14:creationId xmlns:p14="http://schemas.microsoft.com/office/powerpoint/2010/main" val="1910635349"/>
+        <p14:creationId xmlns:p14="http://schemas.microsoft.com/office/powerpoint/2010/main" val="554509972"/>
       </p:ext>
     </p:extLst>
   </p:cSld>
@@ -8728,7 +9020,7 @@
           <p:cNvPr id="14" name="slide-title">
             <a:extLst xmlns:a="http://schemas.openxmlformats.org/drawingml/2006/main">
               <a:ext uri="{FF2B5EF4-FFF2-40B4-BE49-F238E27FC236}">
-                <a16:creationId xmlns:a16="http://schemas.microsoft.com/office/drawing/2014/main" id="{7903B6D6-3A4B-46F0-93F7-756891698132}"/>
+                <a16:creationId xmlns:a16="http://schemas.microsoft.com/office/drawing/2014/main" id="{0CE5D42A-3154-4096-A28B-7DB123AB1B90}"/>
               </a:ext>
             </a:extLst>
           </p:cNvPr>
@@ -8779,7 +9071,7 @@
           <p:cNvPr id="2" name="step-num-1">
             <a:extLst xmlns:a="http://schemas.openxmlformats.org/drawingml/2006/main">
               <a:ext uri="{FF2B5EF4-FFF2-40B4-BE49-F238E27FC236}">
-                <a16:creationId xmlns:a16="http://schemas.microsoft.com/office/drawing/2014/main" id="{5D834206-EBCD-4778-BC85-531B8F55FFF9}"/>
+                <a16:creationId xmlns:a16="http://schemas.microsoft.com/office/drawing/2014/main" id="{37D9C54D-B372-4264-BBA8-C22E2791DE5D}"/>
               </a:ext>
             </a:extLst>
           </p:cNvPr>
@@ -8830,7 +9122,7 @@
           <p:cNvPr id="3" name="step-label-1">
             <a:extLst xmlns:a="http://schemas.openxmlformats.org/drawingml/2006/main">
               <a:ext uri="{FF2B5EF4-FFF2-40B4-BE49-F238E27FC236}">
-                <a16:creationId xmlns:a16="http://schemas.microsoft.com/office/drawing/2014/main" id="{6B2EDE68-B5FF-4E43-8A18-5AB5CE410A35}"/>
+                <a16:creationId xmlns:a16="http://schemas.microsoft.com/office/drawing/2014/main" id="{E987139C-FF54-4287-9BC2-93C201F4DE44}"/>
               </a:ext>
             </a:extLst>
           </p:cNvPr>
@@ -8871,7 +9163,7 @@
                   <a:srgbClr val="0B1F3A"/>
                 </a:solidFill>
               </a:rPr>
-              <a:t>Python 3.12 e Git OK</a:t>
+              <a:t>dbt e DuckDB do ambiente isolado</a:t>
             </a:r>
           </a:p>
         </p:txBody>
@@ -8881,7 +9173,7 @@
           <p:cNvPr id="4" name="step-line-1">
             <a:extLst xmlns:a="http://schemas.openxmlformats.org/drawingml/2006/main">
               <a:ext uri="{FF2B5EF4-FFF2-40B4-BE49-F238E27FC236}">
-                <a16:creationId xmlns:a16="http://schemas.microsoft.com/office/drawing/2014/main" id="{5126FE72-95A7-4904-8042-04C43994354C}"/>
+                <a16:creationId xmlns:a16="http://schemas.microsoft.com/office/drawing/2014/main" id="{DB489D0B-A0F0-491A-B395-CA8D594FA558}"/>
               </a:ext>
             </a:extLst>
           </p:cNvPr>
@@ -8912,7 +9204,7 @@
           <p:cNvPr id="5" name="step-num-2">
             <a:extLst xmlns:a="http://schemas.openxmlformats.org/drawingml/2006/main">
               <a:ext uri="{FF2B5EF4-FFF2-40B4-BE49-F238E27FC236}">
-                <a16:creationId xmlns:a16="http://schemas.microsoft.com/office/drawing/2014/main" id="{90C223A8-7F92-4B17-8C1B-9690A4C994A4}"/>
+                <a16:creationId xmlns:a16="http://schemas.microsoft.com/office/drawing/2014/main" id="{030AEB57-3031-4BE3-BA9E-54AB7469B75C}"/>
               </a:ext>
             </a:extLst>
           </p:cNvPr>
@@ -8963,7 +9255,7 @@
           <p:cNvPr id="6" name="step-label-2">
             <a:extLst xmlns:a="http://schemas.openxmlformats.org/drawingml/2006/main">
               <a:ext uri="{FF2B5EF4-FFF2-40B4-BE49-F238E27FC236}">
-                <a16:creationId xmlns:a16="http://schemas.microsoft.com/office/drawing/2014/main" id="{E22406AE-248C-45BE-B315-D8009F1270D6}"/>
+                <a16:creationId xmlns:a16="http://schemas.microsoft.com/office/drawing/2014/main" id="{11523468-ABE7-4FEC-9EE9-10272DF067D5}"/>
               </a:ext>
             </a:extLst>
           </p:cNvPr>
@@ -9004,7 +9296,7 @@
                   <a:srgbClr val="0B1F3A"/>
                 </a:solidFill>
               </a:rPr>
-              <a:t>dbt build concluído</a:t>
+              <a:t>Seeds e artifacts executados</a:t>
             </a:r>
           </a:p>
         </p:txBody>
@@ -9014,7 +9306,7 @@
           <p:cNvPr id="7" name="step-line-2">
             <a:extLst xmlns:a="http://schemas.openxmlformats.org/drawingml/2006/main">
               <a:ext uri="{FF2B5EF4-FFF2-40B4-BE49-F238E27FC236}">
-                <a16:creationId xmlns:a16="http://schemas.microsoft.com/office/drawing/2014/main" id="{BC08B669-A71F-4963-A265-671B9166C596}"/>
+                <a16:creationId xmlns:a16="http://schemas.microsoft.com/office/drawing/2014/main" id="{7DE5663E-90E1-44C8-9003-95CD97439A71}"/>
               </a:ext>
             </a:extLst>
           </p:cNvPr>
@@ -9045,7 +9337,7 @@
           <p:cNvPr id="8" name="step-num-3">
             <a:extLst xmlns:a="http://schemas.openxmlformats.org/drawingml/2006/main">
               <a:ext uri="{FF2B5EF4-FFF2-40B4-BE49-F238E27FC236}">
-                <a16:creationId xmlns:a16="http://schemas.microsoft.com/office/drawing/2014/main" id="{4CC7A6FC-A092-43B1-8E67-87B8A41B1E37}"/>
+                <a16:creationId xmlns:a16="http://schemas.microsoft.com/office/drawing/2014/main" id="{2CF2012B-D4FA-48B3-9B1A-3C3ECA2C08FE}"/>
               </a:ext>
             </a:extLst>
           </p:cNvPr>
@@ -9096,7 +9388,7 @@
           <p:cNvPr id="9" name="step-label-3">
             <a:extLst xmlns:a="http://schemas.openxmlformats.org/drawingml/2006/main">
               <a:ext uri="{FF2B5EF4-FFF2-40B4-BE49-F238E27FC236}">
-                <a16:creationId xmlns:a16="http://schemas.microsoft.com/office/drawing/2014/main" id="{D93D64DC-C8CE-4921-988E-721A8A8107A9}"/>
+                <a16:creationId xmlns:a16="http://schemas.microsoft.com/office/drawing/2014/main" id="{10BF5CC6-FBCC-494B-80CF-D91DB5F3E323}"/>
               </a:ext>
             </a:extLst>
           </p:cNvPr>
@@ -9137,7 +9429,7 @@
                   <a:srgbClr val="0B1F3A"/>
                 </a:solidFill>
               </a:rPr>
-              <a:t>Seeds e artifacts executados</a:t>
+              <a:t>DuckDB UI na porta privada 4213</a:t>
             </a:r>
           </a:p>
         </p:txBody>
@@ -9147,7 +9439,7 @@
           <p:cNvPr id="10" name="eyebrow">
             <a:extLst xmlns:a="http://schemas.openxmlformats.org/drawingml/2006/main">
               <a:ext uri="{FF2B5EF4-FFF2-40B4-BE49-F238E27FC236}">
-                <a16:creationId xmlns:a16="http://schemas.microsoft.com/office/drawing/2014/main" id="{1D7B19C6-3F30-4BA5-9991-E0200AD2A564}"/>
+                <a16:creationId xmlns:a16="http://schemas.microsoft.com/office/drawing/2014/main" id="{E65E50EF-9842-474A-9008-A1CF63DDC3F2}"/>
               </a:ext>
             </a:extLst>
           </p:cNvPr>
@@ -9198,7 +9490,7 @@
           <p:cNvPr id="11" name="footer-rule">
             <a:extLst xmlns:a="http://schemas.openxmlformats.org/drawingml/2006/main">
               <a:ext uri="{FF2B5EF4-FFF2-40B4-BE49-F238E27FC236}">
-                <a16:creationId xmlns:a16="http://schemas.microsoft.com/office/drawing/2014/main" id="{F430F6FE-F6CA-4166-A329-14C433DB96ED}"/>
+                <a16:creationId xmlns:a16="http://schemas.microsoft.com/office/drawing/2014/main" id="{E9A4FAF0-CDEB-41F6-B708-04D34B7BDA1A}"/>
               </a:ext>
             </a:extLst>
           </p:cNvPr>
@@ -9231,7 +9523,7 @@
           <p:cNvPr id="12" name="footer">
             <a:extLst xmlns:a="http://schemas.openxmlformats.org/drawingml/2006/main">
               <a:ext uri="{FF2B5EF4-FFF2-40B4-BE49-F238E27FC236}">
-                <a16:creationId xmlns:a16="http://schemas.microsoft.com/office/drawing/2014/main" id="{DB1626F8-002B-426C-B4FE-371C679ADF30}"/>
+                <a16:creationId xmlns:a16="http://schemas.microsoft.com/office/drawing/2014/main" id="{A63112F2-6551-4DB6-BD5D-F6E6BC3166EF}"/>
               </a:ext>
             </a:extLst>
           </p:cNvPr>
@@ -9286,7 +9578,7 @@
           <p:cNvPr id="13" name="page-number">
             <a:extLst xmlns:a="http://schemas.openxmlformats.org/drawingml/2006/main">
               <a:ext uri="{FF2B5EF4-FFF2-40B4-BE49-F238E27FC236}">
-                <a16:creationId xmlns:a16="http://schemas.microsoft.com/office/drawing/2014/main" id="{9D289A09-95ED-4372-8FB9-0212A0846416}"/>
+                <a16:creationId xmlns:a16="http://schemas.microsoft.com/office/drawing/2014/main" id="{B8535321-4BA7-4325-BAD2-47F175A289E6}"/>
               </a:ext>
             </a:extLst>
           </p:cNvPr>
@@ -9339,7 +9631,7 @@
     </p:spTree>
     <p:extLst>
       <p:ext uri="{BB962C8B-B14F-4D97-AF65-F5344CB8AC3E}">
-        <p14:creationId xmlns:p14="http://schemas.microsoft.com/office/powerpoint/2010/main" val="1327261736"/>
+        <p14:creationId xmlns:p14="http://schemas.microsoft.com/office/powerpoint/2010/main" val="349955144"/>
       </p:ext>
     </p:extLst>
   </p:cSld>
@@ -9378,7 +9670,7 @@
           <p:cNvPr id="10" name="result-label">
             <a:extLst xmlns:a="http://schemas.openxmlformats.org/drawingml/2006/main">
               <a:ext uri="{FF2B5EF4-FFF2-40B4-BE49-F238E27FC236}">
-                <a16:creationId xmlns:a16="http://schemas.microsoft.com/office/drawing/2014/main" id="{9B959EB1-BB17-4C02-994E-0A57A72357AD}"/>
+                <a16:creationId xmlns:a16="http://schemas.microsoft.com/office/drawing/2014/main" id="{ED6CD16E-A0A6-4CF0-AC03-3B6DBF152BAC}"/>
               </a:ext>
             </a:extLst>
           </p:cNvPr>
@@ -9429,7 +9721,7 @@
           <p:cNvPr id="2" name="result">
             <a:extLst xmlns:a="http://schemas.openxmlformats.org/drawingml/2006/main">
               <a:ext uri="{FF2B5EF4-FFF2-40B4-BE49-F238E27FC236}">
-                <a16:creationId xmlns:a16="http://schemas.microsoft.com/office/drawing/2014/main" id="{A7286693-D8C2-4454-98DD-497B8E8B748A}"/>
+                <a16:creationId xmlns:a16="http://schemas.microsoft.com/office/drawing/2014/main" id="{B2597586-2A9C-44D3-AA09-14FE6FDA131F}"/>
               </a:ext>
             </a:extLst>
           </p:cNvPr>
@@ -9470,7 +9762,7 @@
                   <a:srgbClr val="FFFFFF"/>
                 </a:solidFill>
               </a:rPr>
-              <a:t>Checkpoint 01 OK</a:t>
+              <a:t>Checkpoint 01 OK + exploração gráfica opcional</a:t>
             </a:r>
           </a:p>
         </p:txBody>
@@ -9480,7 +9772,7 @@
           <p:cNvPr id="3" name="result-meta">
             <a:extLst xmlns:a="http://schemas.openxmlformats.org/drawingml/2006/main">
               <a:ext uri="{FF2B5EF4-FFF2-40B4-BE49-F238E27FC236}">
-                <a16:creationId xmlns:a16="http://schemas.microsoft.com/office/drawing/2014/main" id="{7C0B2DF3-B2A5-4227-986F-C24C009D1449}"/>
+                <a16:creationId xmlns:a16="http://schemas.microsoft.com/office/drawing/2014/main" id="{5243CF52-BFBD-4374-A3FB-2FEA64FC3693}"/>
               </a:ext>
             </a:extLst>
           </p:cNvPr>
@@ -9531,7 +9823,7 @@
           <p:cNvPr id="4" name="ambient-glow">
             <a:extLst xmlns:a="http://schemas.openxmlformats.org/drawingml/2006/main">
               <a:ext uri="{FF2B5EF4-FFF2-40B4-BE49-F238E27FC236}">
-                <a16:creationId xmlns:a16="http://schemas.microsoft.com/office/drawing/2014/main" id="{798FF95A-D388-44B6-944D-0E3CC8A8C30C}"/>
+                <a16:creationId xmlns:a16="http://schemas.microsoft.com/office/drawing/2014/main" id="{7B8A6709-BDC8-4FF8-BA94-4A37D1A39218}"/>
               </a:ext>
             </a:extLst>
           </p:cNvPr>
@@ -9568,7 +9860,7 @@
           <p:cNvPr id="5" name="ambient-core">
             <a:extLst xmlns:a="http://schemas.openxmlformats.org/drawingml/2006/main">
               <a:ext uri="{FF2B5EF4-FFF2-40B4-BE49-F238E27FC236}">
-                <a16:creationId xmlns:a16="http://schemas.microsoft.com/office/drawing/2014/main" id="{3DBE866F-59A2-4D36-B9D7-D8825843AE55}"/>
+                <a16:creationId xmlns:a16="http://schemas.microsoft.com/office/drawing/2014/main" id="{FD9CD72E-6B0E-4DE3-A6BB-CBD54C1C6101}"/>
               </a:ext>
             </a:extLst>
           </p:cNvPr>
@@ -9605,7 +9897,7 @@
           <p:cNvPr id="6" name="eyebrow">
             <a:extLst xmlns:a="http://schemas.openxmlformats.org/drawingml/2006/main">
               <a:ext uri="{FF2B5EF4-FFF2-40B4-BE49-F238E27FC236}">
-                <a16:creationId xmlns:a16="http://schemas.microsoft.com/office/drawing/2014/main" id="{D25E33C7-C2CE-47A1-A469-A71392F0EE86}"/>
+                <a16:creationId xmlns:a16="http://schemas.microsoft.com/office/drawing/2014/main" id="{9C33644C-70A3-401F-AEAB-C512D5FA01F7}"/>
               </a:ext>
             </a:extLst>
           </p:cNvPr>
@@ -9656,7 +9948,7 @@
           <p:cNvPr id="7" name="footer-rule">
             <a:extLst xmlns:a="http://schemas.openxmlformats.org/drawingml/2006/main">
               <a:ext uri="{FF2B5EF4-FFF2-40B4-BE49-F238E27FC236}">
-                <a16:creationId xmlns:a16="http://schemas.microsoft.com/office/drawing/2014/main" id="{CB8394E0-1AD1-4A4E-A9C6-6728FA0F3B24}"/>
+                <a16:creationId xmlns:a16="http://schemas.microsoft.com/office/drawing/2014/main" id="{4681B2FF-A943-49EC-A769-9CCFD4A1D098}"/>
               </a:ext>
             </a:extLst>
           </p:cNvPr>
@@ -9689,7 +9981,7 @@
           <p:cNvPr id="8" name="footer">
             <a:extLst xmlns:a="http://schemas.openxmlformats.org/drawingml/2006/main">
               <a:ext uri="{FF2B5EF4-FFF2-40B4-BE49-F238E27FC236}">
-                <a16:creationId xmlns:a16="http://schemas.microsoft.com/office/drawing/2014/main" id="{8A8CC110-CC09-453E-B3D5-85051BECE742}"/>
+                <a16:creationId xmlns:a16="http://schemas.microsoft.com/office/drawing/2014/main" id="{3615772D-1CF6-4DCE-AE1D-E409B9393001}"/>
               </a:ext>
             </a:extLst>
           </p:cNvPr>
@@ -9744,7 +10036,7 @@
           <p:cNvPr id="9" name="page-number">
             <a:extLst xmlns:a="http://schemas.openxmlformats.org/drawingml/2006/main">
               <a:ext uri="{FF2B5EF4-FFF2-40B4-BE49-F238E27FC236}">
-                <a16:creationId xmlns:a16="http://schemas.microsoft.com/office/drawing/2014/main" id="{80FE8340-3F63-4842-89BD-7070DA15D038}"/>
+                <a16:creationId xmlns:a16="http://schemas.microsoft.com/office/drawing/2014/main" id="{26803B3D-2228-4E51-AC3B-67C624651BCF}"/>
               </a:ext>
             </a:extLst>
           </p:cNvPr>
@@ -9797,7 +10089,7 @@
     </p:spTree>
     <p:extLst>
       <p:ext uri="{BB962C8B-B14F-4D97-AF65-F5344CB8AC3E}">
-        <p14:creationId xmlns:p14="http://schemas.microsoft.com/office/powerpoint/2010/main" val="863285162"/>
+        <p14:creationId xmlns:p14="http://schemas.microsoft.com/office/powerpoint/2010/main" val="579487179"/>
       </p:ext>
     </p:extLst>
   </p:cSld>
@@ -9828,7 +10120,7 @@
           <p:cNvPr id="14" name="slide-title">
             <a:extLst xmlns:a="http://schemas.openxmlformats.org/drawingml/2006/main">
               <a:ext uri="{FF2B5EF4-FFF2-40B4-BE49-F238E27FC236}">
-                <a16:creationId xmlns:a16="http://schemas.microsoft.com/office/drawing/2014/main" id="{67100A73-2AAE-4E6D-AB7D-FF371380D37B}"/>
+                <a16:creationId xmlns:a16="http://schemas.microsoft.com/office/drawing/2014/main" id="{DC63D2BE-B702-44E5-83BB-6A42B21CD9C6}"/>
               </a:ext>
             </a:extLst>
           </p:cNvPr>
@@ -9879,7 +10171,7 @@
           <p:cNvPr id="2" name="step-num-1">
             <a:extLst xmlns:a="http://schemas.openxmlformats.org/drawingml/2006/main">
               <a:ext uri="{FF2B5EF4-FFF2-40B4-BE49-F238E27FC236}">
-                <a16:creationId xmlns:a16="http://schemas.microsoft.com/office/drawing/2014/main" id="{5B6B3F24-0DF4-4C5D-992D-7ED9B7400AA2}"/>
+                <a16:creationId xmlns:a16="http://schemas.microsoft.com/office/drawing/2014/main" id="{769CB97E-3668-4800-84A7-F23E6B5A9203}"/>
               </a:ext>
             </a:extLst>
           </p:cNvPr>
@@ -9930,7 +10222,7 @@
           <p:cNvPr id="3" name="step-label-1">
             <a:extLst xmlns:a="http://schemas.openxmlformats.org/drawingml/2006/main">
               <a:ext uri="{FF2B5EF4-FFF2-40B4-BE49-F238E27FC236}">
-                <a16:creationId xmlns:a16="http://schemas.microsoft.com/office/drawing/2014/main" id="{FCF3991D-CFEE-4171-9111-3962E16455A0}"/>
+                <a16:creationId xmlns:a16="http://schemas.microsoft.com/office/drawing/2014/main" id="{40D5F8F8-2B3C-41B3-A26A-9856B0BBED6A}"/>
               </a:ext>
             </a:extLst>
           </p:cNvPr>
@@ -9981,7 +10273,7 @@
           <p:cNvPr id="4" name="step-line-1">
             <a:extLst xmlns:a="http://schemas.openxmlformats.org/drawingml/2006/main">
               <a:ext uri="{FF2B5EF4-FFF2-40B4-BE49-F238E27FC236}">
-                <a16:creationId xmlns:a16="http://schemas.microsoft.com/office/drawing/2014/main" id="{8B5E4D2B-071B-4B2F-B0EE-812627E1F589}"/>
+                <a16:creationId xmlns:a16="http://schemas.microsoft.com/office/drawing/2014/main" id="{DE728F96-DF96-4683-96BE-DE8E1757E201}"/>
               </a:ext>
             </a:extLst>
           </p:cNvPr>
@@ -10012,7 +10304,7 @@
           <p:cNvPr id="5" name="step-num-2">
             <a:extLst xmlns:a="http://schemas.openxmlformats.org/drawingml/2006/main">
               <a:ext uri="{FF2B5EF4-FFF2-40B4-BE49-F238E27FC236}">
-                <a16:creationId xmlns:a16="http://schemas.microsoft.com/office/drawing/2014/main" id="{C77282B8-EEB8-4C5A-97EB-A680118B57B9}"/>
+                <a16:creationId xmlns:a16="http://schemas.microsoft.com/office/drawing/2014/main" id="{A0FB96CB-0D7B-4A07-9CA1-8AB3DA97012D}"/>
               </a:ext>
             </a:extLst>
           </p:cNvPr>
@@ -10063,7 +10355,7 @@
           <p:cNvPr id="6" name="step-label-2">
             <a:extLst xmlns:a="http://schemas.openxmlformats.org/drawingml/2006/main">
               <a:ext uri="{FF2B5EF4-FFF2-40B4-BE49-F238E27FC236}">
-                <a16:creationId xmlns:a16="http://schemas.microsoft.com/office/drawing/2014/main" id="{A6ACD77D-6EE9-4402-B110-B2B589E2B456}"/>
+                <a16:creationId xmlns:a16="http://schemas.microsoft.com/office/drawing/2014/main" id="{AF377FA1-2C0C-4BD0-B5CA-3FED2B3A83BE}"/>
               </a:ext>
             </a:extLst>
           </p:cNvPr>
@@ -10114,7 +10406,7 @@
           <p:cNvPr id="7" name="step-line-2">
             <a:extLst xmlns:a="http://schemas.openxmlformats.org/drawingml/2006/main">
               <a:ext uri="{FF2B5EF4-FFF2-40B4-BE49-F238E27FC236}">
-                <a16:creationId xmlns:a16="http://schemas.microsoft.com/office/drawing/2014/main" id="{7BE773B3-14CF-46AC-A33E-ABC4DFFBDD44}"/>
+                <a16:creationId xmlns:a16="http://schemas.microsoft.com/office/drawing/2014/main" id="{6E9B0E29-98F0-4846-A8C3-92BA04E59BE6}"/>
               </a:ext>
             </a:extLst>
           </p:cNvPr>
@@ -10145,7 +10437,7 @@
           <p:cNvPr id="8" name="step-num-3">
             <a:extLst xmlns:a="http://schemas.openxmlformats.org/drawingml/2006/main">
               <a:ext uri="{FF2B5EF4-FFF2-40B4-BE49-F238E27FC236}">
-                <a16:creationId xmlns:a16="http://schemas.microsoft.com/office/drawing/2014/main" id="{F1E46750-1937-4164-AFEF-11FB82390AEB}"/>
+                <a16:creationId xmlns:a16="http://schemas.microsoft.com/office/drawing/2014/main" id="{1C66EB0A-DC36-4FEA-8A18-1825ACD86CD9}"/>
               </a:ext>
             </a:extLst>
           </p:cNvPr>
@@ -10196,7 +10488,7 @@
           <p:cNvPr id="9" name="step-label-3">
             <a:extLst xmlns:a="http://schemas.openxmlformats.org/drawingml/2006/main">
               <a:ext uri="{FF2B5EF4-FFF2-40B4-BE49-F238E27FC236}">
-                <a16:creationId xmlns:a16="http://schemas.microsoft.com/office/drawing/2014/main" id="{014AF72B-547F-4398-9C08-9EB025E6B7B8}"/>
+                <a16:creationId xmlns:a16="http://schemas.microsoft.com/office/drawing/2014/main" id="{83753B0A-AD8D-497E-A546-92ACEFC0D869}"/>
               </a:ext>
             </a:extLst>
           </p:cNvPr>
@@ -10247,7 +10539,7 @@
           <p:cNvPr id="10" name="eyebrow">
             <a:extLst xmlns:a="http://schemas.openxmlformats.org/drawingml/2006/main">
               <a:ext uri="{FF2B5EF4-FFF2-40B4-BE49-F238E27FC236}">
-                <a16:creationId xmlns:a16="http://schemas.microsoft.com/office/drawing/2014/main" id="{BAB03EC0-B3AE-40A8-B2CA-33B321708316}"/>
+                <a16:creationId xmlns:a16="http://schemas.microsoft.com/office/drawing/2014/main" id="{6D0BAA5A-FFFB-48CF-946E-0A95B4193CDE}"/>
               </a:ext>
             </a:extLst>
           </p:cNvPr>
@@ -10298,7 +10590,7 @@
           <p:cNvPr id="11" name="footer-rule">
             <a:extLst xmlns:a="http://schemas.openxmlformats.org/drawingml/2006/main">
               <a:ext uri="{FF2B5EF4-FFF2-40B4-BE49-F238E27FC236}">
-                <a16:creationId xmlns:a16="http://schemas.microsoft.com/office/drawing/2014/main" id="{A1CAF173-9DDA-4A8A-AB0D-39AFF83EF71F}"/>
+                <a16:creationId xmlns:a16="http://schemas.microsoft.com/office/drawing/2014/main" id="{505FB691-A32C-44B0-A861-E6E57FFC014E}"/>
               </a:ext>
             </a:extLst>
           </p:cNvPr>
@@ -10331,7 +10623,7 @@
           <p:cNvPr id="12" name="footer">
             <a:extLst xmlns:a="http://schemas.openxmlformats.org/drawingml/2006/main">
               <a:ext uri="{FF2B5EF4-FFF2-40B4-BE49-F238E27FC236}">
-                <a16:creationId xmlns:a16="http://schemas.microsoft.com/office/drawing/2014/main" id="{01E6D4AE-3599-4905-8CE3-82FD2B7A62F7}"/>
+                <a16:creationId xmlns:a16="http://schemas.microsoft.com/office/drawing/2014/main" id="{107BA4EB-93DF-4703-B21C-F11621C094AE}"/>
               </a:ext>
             </a:extLst>
           </p:cNvPr>
@@ -10386,7 +10678,7 @@
           <p:cNvPr id="13" name="page-number">
             <a:extLst xmlns:a="http://schemas.openxmlformats.org/drawingml/2006/main">
               <a:ext uri="{FF2B5EF4-FFF2-40B4-BE49-F238E27FC236}">
-                <a16:creationId xmlns:a16="http://schemas.microsoft.com/office/drawing/2014/main" id="{78A67382-784E-4EDA-A0E1-6970BC521D94}"/>
+                <a16:creationId xmlns:a16="http://schemas.microsoft.com/office/drawing/2014/main" id="{00760E3A-B4EE-4836-8728-CC425FD9B3B4}"/>
               </a:ext>
             </a:extLst>
           </p:cNvPr>
@@ -10439,7 +10731,7 @@
     </p:spTree>
     <p:extLst>
       <p:ext uri="{BB962C8B-B14F-4D97-AF65-F5344CB8AC3E}">
-        <p14:creationId xmlns:p14="http://schemas.microsoft.com/office/powerpoint/2010/main" val="1764335913"/>
+        <p14:creationId xmlns:p14="http://schemas.microsoft.com/office/powerpoint/2010/main" val="1846487983"/>
       </p:ext>
     </p:extLst>
   </p:cSld>
@@ -10478,7 +10770,7 @@
           <p:cNvPr id="9" name="case-number">
             <a:extLst xmlns:a="http://schemas.openxmlformats.org/drawingml/2006/main">
               <a:ext uri="{FF2B5EF4-FFF2-40B4-BE49-F238E27FC236}">
-                <a16:creationId xmlns:a16="http://schemas.microsoft.com/office/drawing/2014/main" id="{EDF88376-E200-4E40-882E-9AB700E7BBAC}"/>
+                <a16:creationId xmlns:a16="http://schemas.microsoft.com/office/drawing/2014/main" id="{CCE0BDDB-0211-4AB9-B82D-0601754F0D94}"/>
               </a:ext>
             </a:extLst>
           </p:cNvPr>
@@ -10529,7 +10821,7 @@
           <p:cNvPr id="2" name="case-label">
             <a:extLst xmlns:a="http://schemas.openxmlformats.org/drawingml/2006/main">
               <a:ext uri="{FF2B5EF4-FFF2-40B4-BE49-F238E27FC236}">
-                <a16:creationId xmlns:a16="http://schemas.microsoft.com/office/drawing/2014/main" id="{1F2B22B3-BEBB-4784-9BF9-C0F0FE249579}"/>
+                <a16:creationId xmlns:a16="http://schemas.microsoft.com/office/drawing/2014/main" id="{95A8546C-7DFF-4EE6-AA92-36A6DC44D54B}"/>
               </a:ext>
             </a:extLst>
           </p:cNvPr>
@@ -10580,7 +10872,7 @@
           <p:cNvPr id="3" name="case-divider">
             <a:extLst xmlns:a="http://schemas.openxmlformats.org/drawingml/2006/main">
               <a:ext uri="{FF2B5EF4-FFF2-40B4-BE49-F238E27FC236}">
-                <a16:creationId xmlns:a16="http://schemas.microsoft.com/office/drawing/2014/main" id="{A08BC553-5E28-4365-A018-A5B7CE3C01E8}"/>
+                <a16:creationId xmlns:a16="http://schemas.microsoft.com/office/drawing/2014/main" id="{7D4D59EA-F033-49A9-8DFC-194D71A59FA1}"/>
               </a:ext>
             </a:extLst>
           </p:cNvPr>
@@ -10613,7 +10905,7 @@
           <p:cNvPr id="4" name="case-caveat">
             <a:extLst xmlns:a="http://schemas.openxmlformats.org/drawingml/2006/main">
               <a:ext uri="{FF2B5EF4-FFF2-40B4-BE49-F238E27FC236}">
-                <a16:creationId xmlns:a16="http://schemas.microsoft.com/office/drawing/2014/main" id="{64943E90-A623-4F6B-80C6-E8E840A0717D}"/>
+                <a16:creationId xmlns:a16="http://schemas.microsoft.com/office/drawing/2014/main" id="{95E51BDC-60DB-4069-B67A-A7FDE7CF86FE}"/>
               </a:ext>
             </a:extLst>
           </p:cNvPr>
@@ -10664,7 +10956,7 @@
           <p:cNvPr id="5" name="eyebrow">
             <a:extLst xmlns:a="http://schemas.openxmlformats.org/drawingml/2006/main">
               <a:ext uri="{FF2B5EF4-FFF2-40B4-BE49-F238E27FC236}">
-                <a16:creationId xmlns:a16="http://schemas.microsoft.com/office/drawing/2014/main" id="{57E2A924-5DC7-4820-90ED-C371D3F15E2B}"/>
+                <a16:creationId xmlns:a16="http://schemas.microsoft.com/office/drawing/2014/main" id="{F77F048A-461B-4296-987A-D0BADD6C4425}"/>
               </a:ext>
             </a:extLst>
           </p:cNvPr>
@@ -10715,7 +11007,7 @@
           <p:cNvPr id="6" name="footer-rule">
             <a:extLst xmlns:a="http://schemas.openxmlformats.org/drawingml/2006/main">
               <a:ext uri="{FF2B5EF4-FFF2-40B4-BE49-F238E27FC236}">
-                <a16:creationId xmlns:a16="http://schemas.microsoft.com/office/drawing/2014/main" id="{FD131AE4-B17C-40CA-A3FD-73DBD0D9B29F}"/>
+                <a16:creationId xmlns:a16="http://schemas.microsoft.com/office/drawing/2014/main" id="{F33BB4D1-7567-49DC-90B6-976FB6A977A7}"/>
               </a:ext>
             </a:extLst>
           </p:cNvPr>
@@ -10748,7 +11040,7 @@
           <p:cNvPr id="7" name="footer">
             <a:extLst xmlns:a="http://schemas.openxmlformats.org/drawingml/2006/main">
               <a:ext uri="{FF2B5EF4-FFF2-40B4-BE49-F238E27FC236}">
-                <a16:creationId xmlns:a16="http://schemas.microsoft.com/office/drawing/2014/main" id="{781098B4-2E2F-4579-BD43-AE3EB13D8E54}"/>
+                <a16:creationId xmlns:a16="http://schemas.microsoft.com/office/drawing/2014/main" id="{1AF7CA0C-F070-4538-B002-847AA6F72FEE}"/>
               </a:ext>
             </a:extLst>
           </p:cNvPr>
@@ -10803,7 +11095,7 @@
           <p:cNvPr id="8" name="page-number">
             <a:extLst xmlns:a="http://schemas.openxmlformats.org/drawingml/2006/main">
               <a:ext uri="{FF2B5EF4-FFF2-40B4-BE49-F238E27FC236}">
-                <a16:creationId xmlns:a16="http://schemas.microsoft.com/office/drawing/2014/main" id="{29CE600F-6B06-40C6-B3B6-9A56C8FDC7DD}"/>
+                <a16:creationId xmlns:a16="http://schemas.microsoft.com/office/drawing/2014/main" id="{51B1A45C-1FAE-4A50-9DC3-FF4330B29A2F}"/>
               </a:ext>
             </a:extLst>
           </p:cNvPr>
@@ -10856,7 +11148,7 @@
     </p:spTree>
     <p:extLst>
       <p:ext uri="{BB962C8B-B14F-4D97-AF65-F5344CB8AC3E}">
-        <p14:creationId xmlns:p14="http://schemas.microsoft.com/office/powerpoint/2010/main" val="1984717399"/>
+        <p14:creationId xmlns:p14="http://schemas.microsoft.com/office/powerpoint/2010/main" val="1397957439"/>
       </p:ext>
     </p:extLst>
   </p:cSld>
@@ -10887,7 +11179,7 @@
           <p:cNvPr id="10" name="hook">
             <a:extLst xmlns:a="http://schemas.openxmlformats.org/drawingml/2006/main">
               <a:ext uri="{FF2B5EF4-FFF2-40B4-BE49-F238E27FC236}">
-                <a16:creationId xmlns:a16="http://schemas.microsoft.com/office/drawing/2014/main" id="{1B5E19D9-B5E2-4382-B92F-C3CED575D6B1}"/>
+                <a16:creationId xmlns:a16="http://schemas.microsoft.com/office/drawing/2014/main" id="{B33E20CC-FD47-44D0-BB67-DD7EE9CB1958}"/>
               </a:ext>
             </a:extLst>
           </p:cNvPr>
@@ -10938,7 +11230,7 @@
           <p:cNvPr id="2" name="hook-rule">
             <a:extLst xmlns:a="http://schemas.openxmlformats.org/drawingml/2006/main">
               <a:ext uri="{FF2B5EF4-FFF2-40B4-BE49-F238E27FC236}">
-                <a16:creationId xmlns:a16="http://schemas.microsoft.com/office/drawing/2014/main" id="{4A992075-43FE-4999-9565-8CB24E88A5FC}"/>
+                <a16:creationId xmlns:a16="http://schemas.microsoft.com/office/drawing/2014/main" id="{0FDDC59C-FA90-41AE-96DA-B56C2A8E9B31}"/>
               </a:ext>
             </a:extLst>
           </p:cNvPr>
@@ -10969,7 +11261,7 @@
           <p:cNvPr id="3" name="hook-label">
             <a:extLst xmlns:a="http://schemas.openxmlformats.org/drawingml/2006/main">
               <a:ext uri="{FF2B5EF4-FFF2-40B4-BE49-F238E27FC236}">
-                <a16:creationId xmlns:a16="http://schemas.microsoft.com/office/drawing/2014/main" id="{FF6F477D-0D32-4262-9E1F-4981836C855C}"/>
+                <a16:creationId xmlns:a16="http://schemas.microsoft.com/office/drawing/2014/main" id="{73CFD472-CEE8-42B2-90FA-230D36D440A5}"/>
               </a:ext>
             </a:extLst>
           </p:cNvPr>
@@ -11020,7 +11312,7 @@
           <p:cNvPr id="4" name="diagram-surface">
             <a:extLst xmlns:a="http://schemas.openxmlformats.org/drawingml/2006/main">
               <a:ext uri="{FF2B5EF4-FFF2-40B4-BE49-F238E27FC236}">
-                <a16:creationId xmlns:a16="http://schemas.microsoft.com/office/drawing/2014/main" id="{AD609A19-0C1B-4DB8-8598-74B43F78704A}"/>
+                <a16:creationId xmlns:a16="http://schemas.microsoft.com/office/drawing/2014/main" id="{6AD275CE-8587-47B5-9284-2E7311480B8A}"/>
               </a:ext>
             </a:extLst>
           </p:cNvPr>
@@ -11059,7 +11351,7 @@
           <p:nvPr/>
         </p:nvPicPr>
         <p:blipFill>
-          <a:blip xmlns:r="http://schemas.openxmlformats.org/officeDocument/2006/relationships" xmlns:a="http://schemas.openxmlformats.org/drawingml/2006/main" r:embed="R894027929c6d43f3"/>
+          <a:blip xmlns:r="http://schemas.openxmlformats.org/officeDocument/2006/relationships" xmlns:a="http://schemas.openxmlformats.org/drawingml/2006/main" r:embed="R94af854042ce47f2"/>
           <a:stretch xmlns:a="http://schemas.openxmlformats.org/drawingml/2006/main"/>
         </p:blipFill>
         <p:spPr>
@@ -11077,7 +11369,7 @@
           <p:cNvPr id="6" name="eyebrow">
             <a:extLst xmlns:a="http://schemas.openxmlformats.org/drawingml/2006/main">
               <a:ext uri="{FF2B5EF4-FFF2-40B4-BE49-F238E27FC236}">
-                <a16:creationId xmlns:a16="http://schemas.microsoft.com/office/drawing/2014/main" id="{F363A4B1-8500-42A6-ACE0-BEAC26F0309C}"/>
+                <a16:creationId xmlns:a16="http://schemas.microsoft.com/office/drawing/2014/main" id="{9B6017FE-3684-401E-BB53-48C0D104424B}"/>
               </a:ext>
             </a:extLst>
           </p:cNvPr>
@@ -11128,7 +11420,7 @@
           <p:cNvPr id="7" name="footer-rule">
             <a:extLst xmlns:a="http://schemas.openxmlformats.org/drawingml/2006/main">
               <a:ext uri="{FF2B5EF4-FFF2-40B4-BE49-F238E27FC236}">
-                <a16:creationId xmlns:a16="http://schemas.microsoft.com/office/drawing/2014/main" id="{56F731C0-6739-4CB1-89A4-B52178C10C84}"/>
+                <a16:creationId xmlns:a16="http://schemas.microsoft.com/office/drawing/2014/main" id="{AEAED658-38EC-458A-8F1A-640A526606B0}"/>
               </a:ext>
             </a:extLst>
           </p:cNvPr>
@@ -11161,7 +11453,7 @@
           <p:cNvPr id="8" name="footer">
             <a:extLst xmlns:a="http://schemas.openxmlformats.org/drawingml/2006/main">
               <a:ext uri="{FF2B5EF4-FFF2-40B4-BE49-F238E27FC236}">
-                <a16:creationId xmlns:a16="http://schemas.microsoft.com/office/drawing/2014/main" id="{9234F859-E287-4DAB-B6E0-3373A19BAF61}"/>
+                <a16:creationId xmlns:a16="http://schemas.microsoft.com/office/drawing/2014/main" id="{61D88E26-17DA-43BE-9581-8215F6E310EA}"/>
               </a:ext>
             </a:extLst>
           </p:cNvPr>
@@ -11216,7 +11508,7 @@
           <p:cNvPr id="9" name="page-number">
             <a:extLst xmlns:a="http://schemas.openxmlformats.org/drawingml/2006/main">
               <a:ext uri="{FF2B5EF4-FFF2-40B4-BE49-F238E27FC236}">
-                <a16:creationId xmlns:a16="http://schemas.microsoft.com/office/drawing/2014/main" id="{B6355F33-2029-4C32-B48C-2FABBFFF3E2D}"/>
+                <a16:creationId xmlns:a16="http://schemas.microsoft.com/office/drawing/2014/main" id="{4BC644F4-5AE8-473B-B399-10FB9226A174}"/>
               </a:ext>
             </a:extLst>
           </p:cNvPr>
@@ -11269,7 +11561,7 @@
     </p:spTree>
     <p:extLst>
       <p:ext uri="{BB962C8B-B14F-4D97-AF65-F5344CB8AC3E}">
-        <p14:creationId xmlns:p14="http://schemas.microsoft.com/office/powerpoint/2010/main" val="108394242"/>
+        <p14:creationId xmlns:p14="http://schemas.microsoft.com/office/powerpoint/2010/main" val="731638468"/>
       </p:ext>
     </p:extLst>
   </p:cSld>
@@ -11300,7 +11592,7 @@
           <p:cNvPr id="7" name="slide-title">
             <a:extLst xmlns:a="http://schemas.openxmlformats.org/drawingml/2006/main">
               <a:ext uri="{FF2B5EF4-FFF2-40B4-BE49-F238E27FC236}">
-                <a16:creationId xmlns:a16="http://schemas.microsoft.com/office/drawing/2014/main" id="{10A9A708-195C-4D77-A75F-B92BBBB0AC23}"/>
+                <a16:creationId xmlns:a16="http://schemas.microsoft.com/office/drawing/2014/main" id="{4C6D3168-297A-43E3-9E26-6C696EE032EB}"/>
               </a:ext>
             </a:extLst>
           </p:cNvPr>
@@ -11351,7 +11643,7 @@
           <p:cNvPr id="2" name="bullets">
             <a:extLst xmlns:a="http://schemas.openxmlformats.org/drawingml/2006/main">
               <a:ext uri="{FF2B5EF4-FFF2-40B4-BE49-F238E27FC236}">
-                <a16:creationId xmlns:a16="http://schemas.microsoft.com/office/drawing/2014/main" id="{DAA3C579-C222-4843-97DA-3FB647528A05}"/>
+                <a16:creationId xmlns:a16="http://schemas.microsoft.com/office/drawing/2014/main" id="{43D81298-7C16-476A-95CB-7B9D5B198334}"/>
               </a:ext>
             </a:extLst>
           </p:cNvPr>
@@ -11428,7 +11720,7 @@
                   <a:srgbClr val="0B1F3A"/>
                 </a:solidFill>
               </a:rPr>
-              <a:t>• Ambiente parado ainda consome armazenamento</a:t>
+              <a:t>• DuckDB UI instala a extensão no primeiro uso</a:t>
             </a:r>
           </a:p>
           <a:p xmlns:a="http://schemas.openxmlformats.org/drawingml/2006/main">
@@ -11456,7 +11748,7 @@
           <p:cNvPr id="3" name="eyebrow">
             <a:extLst xmlns:a="http://schemas.openxmlformats.org/drawingml/2006/main">
               <a:ext uri="{FF2B5EF4-FFF2-40B4-BE49-F238E27FC236}">
-                <a16:creationId xmlns:a16="http://schemas.microsoft.com/office/drawing/2014/main" id="{16CA9D44-3BA7-4515-B7B0-B342789A5614}"/>
+                <a16:creationId xmlns:a16="http://schemas.microsoft.com/office/drawing/2014/main" id="{849ACCB6-216F-4599-BB15-208B54D61C83}"/>
               </a:ext>
             </a:extLst>
           </p:cNvPr>
@@ -11507,7 +11799,7 @@
           <p:cNvPr id="4" name="footer-rule">
             <a:extLst xmlns:a="http://schemas.openxmlformats.org/drawingml/2006/main">
               <a:ext uri="{FF2B5EF4-FFF2-40B4-BE49-F238E27FC236}">
-                <a16:creationId xmlns:a16="http://schemas.microsoft.com/office/drawing/2014/main" id="{D705C198-3633-4D23-AB2D-A402E1FF3D09}"/>
+                <a16:creationId xmlns:a16="http://schemas.microsoft.com/office/drawing/2014/main" id="{B2693FBA-B016-40EC-979A-F1A26E949FD0}"/>
               </a:ext>
             </a:extLst>
           </p:cNvPr>
@@ -11540,7 +11832,7 @@
           <p:cNvPr id="5" name="footer">
             <a:extLst xmlns:a="http://schemas.openxmlformats.org/drawingml/2006/main">
               <a:ext uri="{FF2B5EF4-FFF2-40B4-BE49-F238E27FC236}">
-                <a16:creationId xmlns:a16="http://schemas.microsoft.com/office/drawing/2014/main" id="{688D18BE-C645-4FD0-80F5-95C2F7EE3568}"/>
+                <a16:creationId xmlns:a16="http://schemas.microsoft.com/office/drawing/2014/main" id="{02EF495F-BCAE-484F-B59F-1386CA13FFC0}"/>
               </a:ext>
             </a:extLst>
           </p:cNvPr>
@@ -11595,7 +11887,7 @@
           <p:cNvPr id="6" name="page-number">
             <a:extLst xmlns:a="http://schemas.openxmlformats.org/drawingml/2006/main">
               <a:ext uri="{FF2B5EF4-FFF2-40B4-BE49-F238E27FC236}">
-                <a16:creationId xmlns:a16="http://schemas.microsoft.com/office/drawing/2014/main" id="{DB8F1F31-4E92-4570-B331-D17873906C40}"/>
+                <a16:creationId xmlns:a16="http://schemas.microsoft.com/office/drawing/2014/main" id="{894CDDAD-E281-459A-9B64-2BC2DA45E324}"/>
               </a:ext>
             </a:extLst>
           </p:cNvPr>
@@ -11648,7 +11940,7 @@
     </p:spTree>
     <p:extLst>
       <p:ext uri="{BB962C8B-B14F-4D97-AF65-F5344CB8AC3E}">
-        <p14:creationId xmlns:p14="http://schemas.microsoft.com/office/powerpoint/2010/main" val="1347022493"/>
+        <p14:creationId xmlns:p14="http://schemas.microsoft.com/office/powerpoint/2010/main" val="719168814"/>
       </p:ext>
     </p:extLst>
   </p:cSld>
@@ -11687,7 +11979,7 @@
           <p:cNvPr id="10" name="radar-label">
             <a:extLst xmlns:a="http://schemas.openxmlformats.org/drawingml/2006/main">
               <a:ext uri="{FF2B5EF4-FFF2-40B4-BE49-F238E27FC236}">
-                <a16:creationId xmlns:a16="http://schemas.microsoft.com/office/drawing/2014/main" id="{09ADC651-2E9D-4429-930F-3EF13D66CC0B}"/>
+                <a16:creationId xmlns:a16="http://schemas.microsoft.com/office/drawing/2014/main" id="{A17BE7F7-5E8A-4538-8606-7B966F3E2ADF}"/>
               </a:ext>
             </a:extLst>
           </p:cNvPr>
@@ -11738,7 +12030,7 @@
           <p:cNvPr id="2" name="radar-text">
             <a:extLst xmlns:a="http://schemas.openxmlformats.org/drawingml/2006/main">
               <a:ext uri="{FF2B5EF4-FFF2-40B4-BE49-F238E27FC236}">
-                <a16:creationId xmlns:a16="http://schemas.microsoft.com/office/drawing/2014/main" id="{4919899A-087E-4E53-B9DD-53F77DA543BC}"/>
+                <a16:creationId xmlns:a16="http://schemas.microsoft.com/office/drawing/2014/main" id="{57321A7E-3FF2-4538-B173-6FF205B39CDB}"/>
               </a:ext>
             </a:extLst>
           </p:cNvPr>
@@ -11789,7 +12081,7 @@
           <p:cNvPr id="3" name="radar-rule">
             <a:extLst xmlns:a="http://schemas.openxmlformats.org/drawingml/2006/main">
               <a:ext uri="{FF2B5EF4-FFF2-40B4-BE49-F238E27FC236}">
-                <a16:creationId xmlns:a16="http://schemas.microsoft.com/office/drawing/2014/main" id="{31A3E4E1-E1F0-4B3C-AC2E-ADB0A322D845}"/>
+                <a16:creationId xmlns:a16="http://schemas.microsoft.com/office/drawing/2014/main" id="{368CEB4F-2415-4810-B845-DD6D0F576478}"/>
               </a:ext>
             </a:extLst>
           </p:cNvPr>
@@ -11840,7 +12132,7 @@
           <p:cNvPr id="4" name="ambient-glow">
             <a:extLst xmlns:a="http://schemas.openxmlformats.org/drawingml/2006/main">
               <a:ext uri="{FF2B5EF4-FFF2-40B4-BE49-F238E27FC236}">
-                <a16:creationId xmlns:a16="http://schemas.microsoft.com/office/drawing/2014/main" id="{D64D0F29-314F-4697-83E5-3C87992DDB1F}"/>
+                <a16:creationId xmlns:a16="http://schemas.microsoft.com/office/drawing/2014/main" id="{EFBD90C9-23E5-406B-A22A-5110AA2FCB59}"/>
               </a:ext>
             </a:extLst>
           </p:cNvPr>
@@ -11877,7 +12169,7 @@
           <p:cNvPr id="5" name="ambient-core">
             <a:extLst xmlns:a="http://schemas.openxmlformats.org/drawingml/2006/main">
               <a:ext uri="{FF2B5EF4-FFF2-40B4-BE49-F238E27FC236}">
-                <a16:creationId xmlns:a16="http://schemas.microsoft.com/office/drawing/2014/main" id="{07B388CF-B339-454C-9ED0-5B5177DFD7C5}"/>
+                <a16:creationId xmlns:a16="http://schemas.microsoft.com/office/drawing/2014/main" id="{2595EADB-E2F8-4B06-A5DE-F76A938D1110}"/>
               </a:ext>
             </a:extLst>
           </p:cNvPr>
@@ -11914,7 +12206,7 @@
           <p:cNvPr id="6" name="eyebrow">
             <a:extLst xmlns:a="http://schemas.openxmlformats.org/drawingml/2006/main">
               <a:ext uri="{FF2B5EF4-FFF2-40B4-BE49-F238E27FC236}">
-                <a16:creationId xmlns:a16="http://schemas.microsoft.com/office/drawing/2014/main" id="{D28C190E-BEAA-4205-8204-133CC9B32229}"/>
+                <a16:creationId xmlns:a16="http://schemas.microsoft.com/office/drawing/2014/main" id="{0434274B-A4FE-46EA-8E64-64D3C41AA91E}"/>
               </a:ext>
             </a:extLst>
           </p:cNvPr>
@@ -11965,7 +12257,7 @@
           <p:cNvPr id="7" name="footer-rule">
             <a:extLst xmlns:a="http://schemas.openxmlformats.org/drawingml/2006/main">
               <a:ext uri="{FF2B5EF4-FFF2-40B4-BE49-F238E27FC236}">
-                <a16:creationId xmlns:a16="http://schemas.microsoft.com/office/drawing/2014/main" id="{A3EDC77D-DD60-457F-8302-BA4556528E3D}"/>
+                <a16:creationId xmlns:a16="http://schemas.microsoft.com/office/drawing/2014/main" id="{F0E8DB29-1D73-46BB-BE3A-2CD3AD12B4B5}"/>
               </a:ext>
             </a:extLst>
           </p:cNvPr>
@@ -11998,7 +12290,7 @@
           <p:cNvPr id="8" name="footer">
             <a:extLst xmlns:a="http://schemas.openxmlformats.org/drawingml/2006/main">
               <a:ext uri="{FF2B5EF4-FFF2-40B4-BE49-F238E27FC236}">
-                <a16:creationId xmlns:a16="http://schemas.microsoft.com/office/drawing/2014/main" id="{A89C1B96-6689-47E0-B0C1-822C76B5150D}"/>
+                <a16:creationId xmlns:a16="http://schemas.microsoft.com/office/drawing/2014/main" id="{089500D8-DDE8-4568-B491-73FBCADF05BD}"/>
               </a:ext>
             </a:extLst>
           </p:cNvPr>
@@ -12053,7 +12345,7 @@
           <p:cNvPr id="9" name="page-number">
             <a:extLst xmlns:a="http://schemas.openxmlformats.org/drawingml/2006/main">
               <a:ext uri="{FF2B5EF4-FFF2-40B4-BE49-F238E27FC236}">
-                <a16:creationId xmlns:a16="http://schemas.microsoft.com/office/drawing/2014/main" id="{865EF6C8-0E84-4254-B081-C4773A4FC960}"/>
+                <a16:creationId xmlns:a16="http://schemas.microsoft.com/office/drawing/2014/main" id="{09B00172-0F1A-4AEF-9348-D99AE57F8CD1}"/>
               </a:ext>
             </a:extLst>
           </p:cNvPr>
@@ -12106,7 +12398,7 @@
     </p:spTree>
     <p:extLst>
       <p:ext uri="{BB962C8B-B14F-4D97-AF65-F5344CB8AC3E}">
-        <p14:creationId xmlns:p14="http://schemas.microsoft.com/office/powerpoint/2010/main" val="1687950724"/>
+        <p14:creationId xmlns:p14="http://schemas.microsoft.com/office/powerpoint/2010/main" val="1830265128"/>
       </p:ext>
     </p:extLst>
   </p:cSld>
@@ -12137,7 +12429,7 @@
           <p:cNvPr id="8" name="cta-label">
             <a:extLst xmlns:a="http://schemas.openxmlformats.org/drawingml/2006/main">
               <a:ext uri="{FF2B5EF4-FFF2-40B4-BE49-F238E27FC236}">
-                <a16:creationId xmlns:a16="http://schemas.microsoft.com/office/drawing/2014/main" id="{23177492-679A-43A0-BD98-B312ABCFF16E}"/>
+                <a16:creationId xmlns:a16="http://schemas.microsoft.com/office/drawing/2014/main" id="{96AD9A45-1A4D-4CD2-83FE-9FBEB234B664}"/>
               </a:ext>
             </a:extLst>
           </p:cNvPr>
@@ -12188,7 +12480,7 @@
           <p:cNvPr id="2" name="cta">
             <a:extLst xmlns:a="http://schemas.openxmlformats.org/drawingml/2006/main">
               <a:ext uri="{FF2B5EF4-FFF2-40B4-BE49-F238E27FC236}">
-                <a16:creationId xmlns:a16="http://schemas.microsoft.com/office/drawing/2014/main" id="{5F924FF1-A852-4A77-98E6-33811ABE6540}"/>
+                <a16:creationId xmlns:a16="http://schemas.microsoft.com/office/drawing/2014/main" id="{64A16B97-3E63-4410-8946-329E81906D84}"/>
               </a:ext>
             </a:extLst>
           </p:cNvPr>
@@ -12229,7 +12521,7 @@
                   <a:srgbClr val="0B1F3A"/>
                 </a:solidFill>
               </a:rPr>
-              <a:t>Abra o Codespace em 2-core, execute doctor e checkpoint 01 e pare ao terminar.</a:t>
+              <a:t>Abra o Codespace em 2-core, confira paths, execute checkpoint 01, explore a UI e pare ao terminar.</a:t>
             </a:r>
           </a:p>
         </p:txBody>
@@ -12239,7 +12531,7 @@
           <p:cNvPr id="3" name="cta-meta">
             <a:extLst xmlns:a="http://schemas.openxmlformats.org/drawingml/2006/main">
               <a:ext uri="{FF2B5EF4-FFF2-40B4-BE49-F238E27FC236}">
-                <a16:creationId xmlns:a16="http://schemas.microsoft.com/office/drawing/2014/main" id="{E8C3589B-B596-437F-AF6F-F9CE9A235F64}"/>
+                <a16:creationId xmlns:a16="http://schemas.microsoft.com/office/drawing/2014/main" id="{9CA67587-1463-47EF-86EA-05B42E49A0A8}"/>
               </a:ext>
             </a:extLst>
           </p:cNvPr>
@@ -12290,7 +12582,7 @@
           <p:cNvPr id="4" name="eyebrow">
             <a:extLst xmlns:a="http://schemas.openxmlformats.org/drawingml/2006/main">
               <a:ext uri="{FF2B5EF4-FFF2-40B4-BE49-F238E27FC236}">
-                <a16:creationId xmlns:a16="http://schemas.microsoft.com/office/drawing/2014/main" id="{D36C2CD5-75A0-4294-88AF-F270D4B04852}"/>
+                <a16:creationId xmlns:a16="http://schemas.microsoft.com/office/drawing/2014/main" id="{F3971821-34B2-453D-9C29-E97541177835}"/>
               </a:ext>
             </a:extLst>
           </p:cNvPr>
@@ -12341,7 +12633,7 @@
           <p:cNvPr id="5" name="footer-rule">
             <a:extLst xmlns:a="http://schemas.openxmlformats.org/drawingml/2006/main">
               <a:ext uri="{FF2B5EF4-FFF2-40B4-BE49-F238E27FC236}">
-                <a16:creationId xmlns:a16="http://schemas.microsoft.com/office/drawing/2014/main" id="{1544D283-DE9A-4034-986E-A73FF9CAE458}"/>
+                <a16:creationId xmlns:a16="http://schemas.microsoft.com/office/drawing/2014/main" id="{899E8DD1-53C6-4826-8601-879B18B3FE4F}"/>
               </a:ext>
             </a:extLst>
           </p:cNvPr>
@@ -12374,7 +12666,7 @@
           <p:cNvPr id="6" name="footer">
             <a:extLst xmlns:a="http://schemas.openxmlformats.org/drawingml/2006/main">
               <a:ext uri="{FF2B5EF4-FFF2-40B4-BE49-F238E27FC236}">
-                <a16:creationId xmlns:a16="http://schemas.microsoft.com/office/drawing/2014/main" id="{D1A27543-A1EB-4FB4-A405-30B5A27CD523}"/>
+                <a16:creationId xmlns:a16="http://schemas.microsoft.com/office/drawing/2014/main" id="{026F81E4-9B37-4193-B544-7064D411B023}"/>
               </a:ext>
             </a:extLst>
           </p:cNvPr>
@@ -12429,7 +12721,7 @@
           <p:cNvPr id="7" name="page-number">
             <a:extLst xmlns:a="http://schemas.openxmlformats.org/drawingml/2006/main">
               <a:ext uri="{FF2B5EF4-FFF2-40B4-BE49-F238E27FC236}">
-                <a16:creationId xmlns:a16="http://schemas.microsoft.com/office/drawing/2014/main" id="{B17B60ED-2CBB-44B2-BA74-C10C8E5DE021}"/>
+                <a16:creationId xmlns:a16="http://schemas.microsoft.com/office/drawing/2014/main" id="{D104F694-4CD4-4319-809A-91A8C8F0477F}"/>
               </a:ext>
             </a:extLst>
           </p:cNvPr>
@@ -12482,7 +12774,7 @@
     </p:spTree>
     <p:extLst>
       <p:ext uri="{BB962C8B-B14F-4D97-AF65-F5344CB8AC3E}">
-        <p14:creationId xmlns:p14="http://schemas.microsoft.com/office/powerpoint/2010/main" val="1145582048"/>
+        <p14:creationId xmlns:p14="http://schemas.microsoft.com/office/powerpoint/2010/main" val="1390372137"/>
       </p:ext>
     </p:extLst>
   </p:cSld>
@@ -12521,7 +12813,7 @@
           <p:cNvPr id="14" name="slide-title">
             <a:extLst xmlns:a="http://schemas.openxmlformats.org/drawingml/2006/main">
               <a:ext uri="{FF2B5EF4-FFF2-40B4-BE49-F238E27FC236}">
-                <a16:creationId xmlns:a16="http://schemas.microsoft.com/office/drawing/2014/main" id="{D7502C1E-D20C-4288-8B7C-007C8007D4F3}"/>
+                <a16:creationId xmlns:a16="http://schemas.microsoft.com/office/drawing/2014/main" id="{4DF6763B-A9A5-4FBD-9BAD-0A9F29217A54}"/>
               </a:ext>
             </a:extLst>
           </p:cNvPr>
@@ -12572,7 +12864,7 @@
           <p:cNvPr id="2" name="step-num-1">
             <a:extLst xmlns:a="http://schemas.openxmlformats.org/drawingml/2006/main">
               <a:ext uri="{FF2B5EF4-FFF2-40B4-BE49-F238E27FC236}">
-                <a16:creationId xmlns:a16="http://schemas.microsoft.com/office/drawing/2014/main" id="{FB52A709-DCAC-4A7B-A1E3-E14343E6C7FE}"/>
+                <a16:creationId xmlns:a16="http://schemas.microsoft.com/office/drawing/2014/main" id="{87177341-1B6F-4841-A89B-3DDCF9EF5183}"/>
               </a:ext>
             </a:extLst>
           </p:cNvPr>
@@ -12623,7 +12915,7 @@
           <p:cNvPr id="3" name="step-label-1">
             <a:extLst xmlns:a="http://schemas.openxmlformats.org/drawingml/2006/main">
               <a:ext uri="{FF2B5EF4-FFF2-40B4-BE49-F238E27FC236}">
-                <a16:creationId xmlns:a16="http://schemas.microsoft.com/office/drawing/2014/main" id="{29FB2D61-97A5-41AD-8B26-02C81FB0C824}"/>
+                <a16:creationId xmlns:a16="http://schemas.microsoft.com/office/drawing/2014/main" id="{F48B1242-826B-4544-92A6-1845C74F5BB2}"/>
               </a:ext>
             </a:extLst>
           </p:cNvPr>
@@ -12674,7 +12966,7 @@
           <p:cNvPr id="4" name="step-line-1">
             <a:extLst xmlns:a="http://schemas.openxmlformats.org/drawingml/2006/main">
               <a:ext uri="{FF2B5EF4-FFF2-40B4-BE49-F238E27FC236}">
-                <a16:creationId xmlns:a16="http://schemas.microsoft.com/office/drawing/2014/main" id="{6E1A68C7-5FC4-4D72-A959-0D530E044BC1}"/>
+                <a16:creationId xmlns:a16="http://schemas.microsoft.com/office/drawing/2014/main" id="{497B69DB-5A11-458E-88F9-05384E711C63}"/>
               </a:ext>
             </a:extLst>
           </p:cNvPr>
@@ -12705,7 +12997,7 @@
           <p:cNvPr id="5" name="step-num-2">
             <a:extLst xmlns:a="http://schemas.openxmlformats.org/drawingml/2006/main">
               <a:ext uri="{FF2B5EF4-FFF2-40B4-BE49-F238E27FC236}">
-                <a16:creationId xmlns:a16="http://schemas.microsoft.com/office/drawing/2014/main" id="{769C0E6D-9EE1-47A5-871E-E9A909D21078}"/>
+                <a16:creationId xmlns:a16="http://schemas.microsoft.com/office/drawing/2014/main" id="{4DA6ED3F-BE11-45EF-8AAD-915F34AB694D}"/>
               </a:ext>
             </a:extLst>
           </p:cNvPr>
@@ -12756,7 +13048,7 @@
           <p:cNvPr id="6" name="step-label-2">
             <a:extLst xmlns:a="http://schemas.openxmlformats.org/drawingml/2006/main">
               <a:ext uri="{FF2B5EF4-FFF2-40B4-BE49-F238E27FC236}">
-                <a16:creationId xmlns:a16="http://schemas.microsoft.com/office/drawing/2014/main" id="{65F515DF-29A3-4F8C-8BBC-34B10FA5B32A}"/>
+                <a16:creationId xmlns:a16="http://schemas.microsoft.com/office/drawing/2014/main" id="{5F4D8E54-88C9-4EAD-BC86-6AFEF9B75211}"/>
               </a:ext>
             </a:extLst>
           </p:cNvPr>
@@ -12807,7 +13099,7 @@
           <p:cNvPr id="7" name="step-line-2">
             <a:extLst xmlns:a="http://schemas.openxmlformats.org/drawingml/2006/main">
               <a:ext uri="{FF2B5EF4-FFF2-40B4-BE49-F238E27FC236}">
-                <a16:creationId xmlns:a16="http://schemas.microsoft.com/office/drawing/2014/main" id="{FF0B6EF0-67D8-4543-AEC3-C1C0FA5AFB0F}"/>
+                <a16:creationId xmlns:a16="http://schemas.microsoft.com/office/drawing/2014/main" id="{EEA1CFF9-6F64-4593-9B17-B43F27E33C0D}"/>
               </a:ext>
             </a:extLst>
           </p:cNvPr>
@@ -12838,7 +13130,7 @@
           <p:cNvPr id="8" name="step-num-3">
             <a:extLst xmlns:a="http://schemas.openxmlformats.org/drawingml/2006/main">
               <a:ext uri="{FF2B5EF4-FFF2-40B4-BE49-F238E27FC236}">
-                <a16:creationId xmlns:a16="http://schemas.microsoft.com/office/drawing/2014/main" id="{DBBC1E3F-92F3-4C4B-B202-27E04518A708}"/>
+                <a16:creationId xmlns:a16="http://schemas.microsoft.com/office/drawing/2014/main" id="{0F810D4E-CA3C-4991-A726-448196497419}"/>
               </a:ext>
             </a:extLst>
           </p:cNvPr>
@@ -12889,7 +13181,7 @@
           <p:cNvPr id="9" name="step-label-3">
             <a:extLst xmlns:a="http://schemas.openxmlformats.org/drawingml/2006/main">
               <a:ext uri="{FF2B5EF4-FFF2-40B4-BE49-F238E27FC236}">
-                <a16:creationId xmlns:a16="http://schemas.microsoft.com/office/drawing/2014/main" id="{46EA92D4-DE3C-49E8-AE23-F7EF1D005FF9}"/>
+                <a16:creationId xmlns:a16="http://schemas.microsoft.com/office/drawing/2014/main" id="{3434BCC5-E8F7-4139-A64B-B9769DB6EED4}"/>
               </a:ext>
             </a:extLst>
           </p:cNvPr>
@@ -12940,7 +13232,7 @@
           <p:cNvPr id="10" name="eyebrow">
             <a:extLst xmlns:a="http://schemas.openxmlformats.org/drawingml/2006/main">
               <a:ext uri="{FF2B5EF4-FFF2-40B4-BE49-F238E27FC236}">
-                <a16:creationId xmlns:a16="http://schemas.microsoft.com/office/drawing/2014/main" id="{B36E4EEC-CF88-4199-9D88-F2A956207545}"/>
+                <a16:creationId xmlns:a16="http://schemas.microsoft.com/office/drawing/2014/main" id="{353D0FB6-A9C3-4331-8052-6AF6FD73A3B9}"/>
               </a:ext>
             </a:extLst>
           </p:cNvPr>
@@ -12991,7 +13283,7 @@
           <p:cNvPr id="11" name="footer-rule">
             <a:extLst xmlns:a="http://schemas.openxmlformats.org/drawingml/2006/main">
               <a:ext uri="{FF2B5EF4-FFF2-40B4-BE49-F238E27FC236}">
-                <a16:creationId xmlns:a16="http://schemas.microsoft.com/office/drawing/2014/main" id="{1AD27AEB-DDD8-43C6-B383-61E6D77363E0}"/>
+                <a16:creationId xmlns:a16="http://schemas.microsoft.com/office/drawing/2014/main" id="{F90829FE-8BA2-42C1-AE91-013BCF0DE9E2}"/>
               </a:ext>
             </a:extLst>
           </p:cNvPr>
@@ -13024,7 +13316,7 @@
           <p:cNvPr id="12" name="footer">
             <a:extLst xmlns:a="http://schemas.openxmlformats.org/drawingml/2006/main">
               <a:ext uri="{FF2B5EF4-FFF2-40B4-BE49-F238E27FC236}">
-                <a16:creationId xmlns:a16="http://schemas.microsoft.com/office/drawing/2014/main" id="{90B4291F-4EB9-405E-BC2A-386B1FE99B4C}"/>
+                <a16:creationId xmlns:a16="http://schemas.microsoft.com/office/drawing/2014/main" id="{5E7BD1C4-C325-4C3B-A90E-55F77FABF7EA}"/>
               </a:ext>
             </a:extLst>
           </p:cNvPr>
@@ -13079,7 +13371,7 @@
           <p:cNvPr id="13" name="page-number">
             <a:extLst xmlns:a="http://schemas.openxmlformats.org/drawingml/2006/main">
               <a:ext uri="{FF2B5EF4-FFF2-40B4-BE49-F238E27FC236}">
-                <a16:creationId xmlns:a16="http://schemas.microsoft.com/office/drawing/2014/main" id="{3C678EC4-C919-4DF8-89BD-4EA04235460A}"/>
+                <a16:creationId xmlns:a16="http://schemas.microsoft.com/office/drawing/2014/main" id="{99AA8B3F-5239-43D9-8C1B-F5B2577A4388}"/>
               </a:ext>
             </a:extLst>
           </p:cNvPr>
@@ -13132,7 +13424,7 @@
     </p:spTree>
     <p:extLst>
       <p:ext uri="{BB962C8B-B14F-4D97-AF65-F5344CB8AC3E}">
-        <p14:creationId xmlns:p14="http://schemas.microsoft.com/office/powerpoint/2010/main" val="441653147"/>
+        <p14:creationId xmlns:p14="http://schemas.microsoft.com/office/powerpoint/2010/main" val="1594604825"/>
       </p:ext>
     </p:extLst>
   </p:cSld>
@@ -13171,7 +13463,7 @@
           <p:cNvPr id="11" name="slide-title">
             <a:extLst xmlns:a="http://schemas.openxmlformats.org/drawingml/2006/main">
               <a:ext uri="{FF2B5EF4-FFF2-40B4-BE49-F238E27FC236}">
-                <a16:creationId xmlns:a16="http://schemas.microsoft.com/office/drawing/2014/main" id="{2F78BB0D-FE8F-45FB-B11D-1B29562F8B2B}"/>
+                <a16:creationId xmlns:a16="http://schemas.microsoft.com/office/drawing/2014/main" id="{FE997CB6-7E5B-4F4E-90A2-B31810011FA7}"/>
               </a:ext>
             </a:extLst>
           </p:cNvPr>
@@ -13222,7 +13514,7 @@
           <p:cNvPr id="2" name="slide-subtitle">
             <a:extLst xmlns:a="http://schemas.openxmlformats.org/drawingml/2006/main">
               <a:ext uri="{FF2B5EF4-FFF2-40B4-BE49-F238E27FC236}">
-                <a16:creationId xmlns:a16="http://schemas.microsoft.com/office/drawing/2014/main" id="{895B84FA-6A43-4F81-B878-AB801399D517}"/>
+                <a16:creationId xmlns:a16="http://schemas.microsoft.com/office/drawing/2014/main" id="{AAFF1837-DBBE-43EA-AD2F-AB42A9678D02}"/>
               </a:ext>
             </a:extLst>
           </p:cNvPr>
@@ -13273,7 +13565,7 @@
           <p:cNvPr id="3" name="bullets">
             <a:extLst xmlns:a="http://schemas.openxmlformats.org/drawingml/2006/main">
               <a:ext uri="{FF2B5EF4-FFF2-40B4-BE49-F238E27FC236}">
-                <a16:creationId xmlns:a16="http://schemas.microsoft.com/office/drawing/2014/main" id="{88027922-9394-45D6-A1BA-9A35D9EAB3F1}"/>
+                <a16:creationId xmlns:a16="http://schemas.microsoft.com/office/drawing/2014/main" id="{CDDA3CB1-92A1-4486-BA44-A15539BB56C4}"/>
               </a:ext>
             </a:extLst>
           </p:cNvPr>
@@ -13360,7 +13652,7 @@
           <p:cNvPr id="4" name="ambient-glow">
             <a:extLst xmlns:a="http://schemas.openxmlformats.org/drawingml/2006/main">
               <a:ext uri="{FF2B5EF4-FFF2-40B4-BE49-F238E27FC236}">
-                <a16:creationId xmlns:a16="http://schemas.microsoft.com/office/drawing/2014/main" id="{B02DEB73-FDAC-46D9-8292-FF74CACCDE04}"/>
+                <a16:creationId xmlns:a16="http://schemas.microsoft.com/office/drawing/2014/main" id="{19B00E16-4F96-4D4C-86B9-F803621859A0}"/>
               </a:ext>
             </a:extLst>
           </p:cNvPr>
@@ -13397,7 +13689,7 @@
           <p:cNvPr id="5" name="ambient-core">
             <a:extLst xmlns:a="http://schemas.openxmlformats.org/drawingml/2006/main">
               <a:ext uri="{FF2B5EF4-FFF2-40B4-BE49-F238E27FC236}">
-                <a16:creationId xmlns:a16="http://schemas.microsoft.com/office/drawing/2014/main" id="{C5C8DEF5-9EBD-4F8B-A3BD-06C914D96AF3}"/>
+                <a16:creationId xmlns:a16="http://schemas.microsoft.com/office/drawing/2014/main" id="{E2DF7569-4E9A-44AF-B623-91F0CB0405A6}"/>
               </a:ext>
             </a:extLst>
           </p:cNvPr>
@@ -13434,7 +13726,7 @@
           <p:cNvPr id="6" name="section-number">
             <a:extLst xmlns:a="http://schemas.openxmlformats.org/drawingml/2006/main">
               <a:ext uri="{FF2B5EF4-FFF2-40B4-BE49-F238E27FC236}">
-                <a16:creationId xmlns:a16="http://schemas.microsoft.com/office/drawing/2014/main" id="{18E77AF5-E8EC-4607-9318-C2CB753B7604}"/>
+                <a16:creationId xmlns:a16="http://schemas.microsoft.com/office/drawing/2014/main" id="{81342FDE-4A49-45ED-A7C6-9A0FB0EDE060}"/>
               </a:ext>
             </a:extLst>
           </p:cNvPr>
@@ -13485,7 +13777,7 @@
           <p:cNvPr id="7" name="eyebrow">
             <a:extLst xmlns:a="http://schemas.openxmlformats.org/drawingml/2006/main">
               <a:ext uri="{FF2B5EF4-FFF2-40B4-BE49-F238E27FC236}">
-                <a16:creationId xmlns:a16="http://schemas.microsoft.com/office/drawing/2014/main" id="{4C59FFFD-CD84-44A7-A5D6-7D9F4FA1DCD5}"/>
+                <a16:creationId xmlns:a16="http://schemas.microsoft.com/office/drawing/2014/main" id="{3428A287-6DF4-4C7B-BE28-372ADFF7FEB3}"/>
               </a:ext>
             </a:extLst>
           </p:cNvPr>
@@ -13536,7 +13828,7 @@
           <p:cNvPr id="8" name="footer-rule">
             <a:extLst xmlns:a="http://schemas.openxmlformats.org/drawingml/2006/main">
               <a:ext uri="{FF2B5EF4-FFF2-40B4-BE49-F238E27FC236}">
-                <a16:creationId xmlns:a16="http://schemas.microsoft.com/office/drawing/2014/main" id="{25DE666B-ED6F-4F8B-BAAC-6FBBCC819ED5}"/>
+                <a16:creationId xmlns:a16="http://schemas.microsoft.com/office/drawing/2014/main" id="{605A1B23-B3B3-4FCE-8645-F8010F5CB236}"/>
               </a:ext>
             </a:extLst>
           </p:cNvPr>
@@ -13569,7 +13861,7 @@
           <p:cNvPr id="9" name="footer">
             <a:extLst xmlns:a="http://schemas.openxmlformats.org/drawingml/2006/main">
               <a:ext uri="{FF2B5EF4-FFF2-40B4-BE49-F238E27FC236}">
-                <a16:creationId xmlns:a16="http://schemas.microsoft.com/office/drawing/2014/main" id="{0109B334-F055-4055-9F4B-3DD7F9D66137}"/>
+                <a16:creationId xmlns:a16="http://schemas.microsoft.com/office/drawing/2014/main" id="{83DF2ABE-4A6F-401A-854A-C40B8F2460D0}"/>
               </a:ext>
             </a:extLst>
           </p:cNvPr>
@@ -13624,7 +13916,7 @@
           <p:cNvPr id="10" name="page-number">
             <a:extLst xmlns:a="http://schemas.openxmlformats.org/drawingml/2006/main">
               <a:ext uri="{FF2B5EF4-FFF2-40B4-BE49-F238E27FC236}">
-                <a16:creationId xmlns:a16="http://schemas.microsoft.com/office/drawing/2014/main" id="{172347E5-A701-457D-B93E-C60162037CEE}"/>
+                <a16:creationId xmlns:a16="http://schemas.microsoft.com/office/drawing/2014/main" id="{84FEB41A-B53E-432E-81CD-577004B5C3F8}"/>
               </a:ext>
             </a:extLst>
           </p:cNvPr>
@@ -13677,7 +13969,7 @@
     </p:spTree>
     <p:extLst>
       <p:ext uri="{BB962C8B-B14F-4D97-AF65-F5344CB8AC3E}">
-        <p14:creationId xmlns:p14="http://schemas.microsoft.com/office/powerpoint/2010/main" val="1387153308"/>
+        <p14:creationId xmlns:p14="http://schemas.microsoft.com/office/powerpoint/2010/main" val="2093197839"/>
       </p:ext>
     </p:extLst>
   </p:cSld>
@@ -13708,7 +14000,7 @@
           <p:cNvPr id="11" name="slide-title">
             <a:extLst xmlns:a="http://schemas.openxmlformats.org/drawingml/2006/main">
               <a:ext uri="{FF2B5EF4-FFF2-40B4-BE49-F238E27FC236}">
-                <a16:creationId xmlns:a16="http://schemas.microsoft.com/office/drawing/2014/main" id="{50331583-117B-4BF4-A10B-F51E0224BBC2}"/>
+                <a16:creationId xmlns:a16="http://schemas.microsoft.com/office/drawing/2014/main" id="{794B08C6-15BA-45F0-ADF0-1FB282CFF4ED}"/>
               </a:ext>
             </a:extLst>
           </p:cNvPr>
@@ -13759,7 +14051,7 @@
           <p:cNvPr id="2" name="slide-subtitle">
             <a:extLst xmlns:a="http://schemas.openxmlformats.org/drawingml/2006/main">
               <a:ext uri="{FF2B5EF4-FFF2-40B4-BE49-F238E27FC236}">
-                <a16:creationId xmlns:a16="http://schemas.microsoft.com/office/drawing/2014/main" id="{CA998E6A-8668-420C-B173-D7F3072009A0}"/>
+                <a16:creationId xmlns:a16="http://schemas.microsoft.com/office/drawing/2014/main" id="{9D8DE731-3496-4503-A905-002B0E8CD377}"/>
               </a:ext>
             </a:extLst>
           </p:cNvPr>
@@ -13810,7 +14102,7 @@
           <p:cNvPr id="3" name="bullets">
             <a:extLst xmlns:a="http://schemas.openxmlformats.org/drawingml/2006/main">
               <a:ext uri="{FF2B5EF4-FFF2-40B4-BE49-F238E27FC236}">
-                <a16:creationId xmlns:a16="http://schemas.microsoft.com/office/drawing/2014/main" id="{EDE636CD-7D46-4C80-AAA9-6C57E0A19796}"/>
+                <a16:creationId xmlns:a16="http://schemas.microsoft.com/office/drawing/2014/main" id="{016324DB-62C3-4195-B2AA-C86927C92C2B}"/>
               </a:ext>
             </a:extLst>
           </p:cNvPr>
@@ -13897,7 +14189,7 @@
           <p:cNvPr id="4" name="ambient-glow">
             <a:extLst xmlns:a="http://schemas.openxmlformats.org/drawingml/2006/main">
               <a:ext uri="{FF2B5EF4-FFF2-40B4-BE49-F238E27FC236}">
-                <a16:creationId xmlns:a16="http://schemas.microsoft.com/office/drawing/2014/main" id="{4C7FD777-4661-4811-B6A2-0A7BD161C7D7}"/>
+                <a16:creationId xmlns:a16="http://schemas.microsoft.com/office/drawing/2014/main" id="{EFCD3574-DF06-46F4-A659-CDCF3632109A}"/>
               </a:ext>
             </a:extLst>
           </p:cNvPr>
@@ -13934,7 +14226,7 @@
           <p:cNvPr id="5" name="ambient-core">
             <a:extLst xmlns:a="http://schemas.openxmlformats.org/drawingml/2006/main">
               <a:ext uri="{FF2B5EF4-FFF2-40B4-BE49-F238E27FC236}">
-                <a16:creationId xmlns:a16="http://schemas.microsoft.com/office/drawing/2014/main" id="{4A704329-5312-4642-9C88-5F6C3D28A6EB}"/>
+                <a16:creationId xmlns:a16="http://schemas.microsoft.com/office/drawing/2014/main" id="{A7E43C83-C407-421B-B4DA-5A8FD94A7BDA}"/>
               </a:ext>
             </a:extLst>
           </p:cNvPr>
@@ -13971,7 +14263,7 @@
           <p:cNvPr id="6" name="section-number">
             <a:extLst xmlns:a="http://schemas.openxmlformats.org/drawingml/2006/main">
               <a:ext uri="{FF2B5EF4-FFF2-40B4-BE49-F238E27FC236}">
-                <a16:creationId xmlns:a16="http://schemas.microsoft.com/office/drawing/2014/main" id="{32D7488E-2B6D-4AC6-97AC-8F808C042DF2}"/>
+                <a16:creationId xmlns:a16="http://schemas.microsoft.com/office/drawing/2014/main" id="{95641522-B7BD-41A2-8495-FC495A0297C2}"/>
               </a:ext>
             </a:extLst>
           </p:cNvPr>
@@ -14022,7 +14314,7 @@
           <p:cNvPr id="7" name="eyebrow">
             <a:extLst xmlns:a="http://schemas.openxmlformats.org/drawingml/2006/main">
               <a:ext uri="{FF2B5EF4-FFF2-40B4-BE49-F238E27FC236}">
-                <a16:creationId xmlns:a16="http://schemas.microsoft.com/office/drawing/2014/main" id="{2A359F8F-F571-4B57-8BB6-407967C4CA65}"/>
+                <a16:creationId xmlns:a16="http://schemas.microsoft.com/office/drawing/2014/main" id="{DAE307DF-3C01-41AE-8DF9-BA2F0E489561}"/>
               </a:ext>
             </a:extLst>
           </p:cNvPr>
@@ -14073,7 +14365,7 @@
           <p:cNvPr id="8" name="footer-rule">
             <a:extLst xmlns:a="http://schemas.openxmlformats.org/drawingml/2006/main">
               <a:ext uri="{FF2B5EF4-FFF2-40B4-BE49-F238E27FC236}">
-                <a16:creationId xmlns:a16="http://schemas.microsoft.com/office/drawing/2014/main" id="{1E8A445A-F4F3-4913-8A3C-A7CDCC580AF5}"/>
+                <a16:creationId xmlns:a16="http://schemas.microsoft.com/office/drawing/2014/main" id="{D4E5AB48-6A1F-4B8F-910B-AFA68468E0FF}"/>
               </a:ext>
             </a:extLst>
           </p:cNvPr>
@@ -14106,7 +14398,7 @@
           <p:cNvPr id="9" name="footer">
             <a:extLst xmlns:a="http://schemas.openxmlformats.org/drawingml/2006/main">
               <a:ext uri="{FF2B5EF4-FFF2-40B4-BE49-F238E27FC236}">
-                <a16:creationId xmlns:a16="http://schemas.microsoft.com/office/drawing/2014/main" id="{B33E9855-993E-4EC7-9111-40531734F6A8}"/>
+                <a16:creationId xmlns:a16="http://schemas.microsoft.com/office/drawing/2014/main" id="{F78557A4-C677-41D0-ABF3-A179526088E1}"/>
               </a:ext>
             </a:extLst>
           </p:cNvPr>
@@ -14161,7 +14453,7 @@
           <p:cNvPr id="10" name="page-number">
             <a:extLst xmlns:a="http://schemas.openxmlformats.org/drawingml/2006/main">
               <a:ext uri="{FF2B5EF4-FFF2-40B4-BE49-F238E27FC236}">
-                <a16:creationId xmlns:a16="http://schemas.microsoft.com/office/drawing/2014/main" id="{803473DB-E234-4DDF-966B-57509D997B89}"/>
+                <a16:creationId xmlns:a16="http://schemas.microsoft.com/office/drawing/2014/main" id="{8D0B3884-E153-4309-AB4A-76EC7CE5DA8F}"/>
               </a:ext>
             </a:extLst>
           </p:cNvPr>
@@ -14214,7 +14506,7 @@
     </p:spTree>
     <p:extLst>
       <p:ext uri="{BB962C8B-B14F-4D97-AF65-F5344CB8AC3E}">
-        <p14:creationId xmlns:p14="http://schemas.microsoft.com/office/powerpoint/2010/main" val="1759563327"/>
+        <p14:creationId xmlns:p14="http://schemas.microsoft.com/office/powerpoint/2010/main" val="1531820784"/>
       </p:ext>
     </p:extLst>
   </p:cSld>
@@ -14253,7 +14545,7 @@
           <p:cNvPr id="10" name="slide-title">
             <a:extLst xmlns:a="http://schemas.openxmlformats.org/drawingml/2006/main">
               <a:ext uri="{FF2B5EF4-FFF2-40B4-BE49-F238E27FC236}">
-                <a16:creationId xmlns:a16="http://schemas.microsoft.com/office/drawing/2014/main" id="{D0DF262B-A713-4562-BD27-513469E49057}"/>
+                <a16:creationId xmlns:a16="http://schemas.microsoft.com/office/drawing/2014/main" id="{5DB0E79D-F99B-489E-A35B-C7E48A95F286}"/>
               </a:ext>
             </a:extLst>
           </p:cNvPr>
@@ -14304,7 +14596,7 @@
           <p:cNvPr id="2" name="visual-claim">
             <a:extLst xmlns:a="http://schemas.openxmlformats.org/drawingml/2006/main">
               <a:ext uri="{FF2B5EF4-FFF2-40B4-BE49-F238E27FC236}">
-                <a16:creationId xmlns:a16="http://schemas.microsoft.com/office/drawing/2014/main" id="{5F2E69DF-B981-44C7-B168-532A11C03F70}"/>
+                <a16:creationId xmlns:a16="http://schemas.microsoft.com/office/drawing/2014/main" id="{BFA0B6C8-1EE6-46C6-A9EE-20605E91868B}"/>
               </a:ext>
             </a:extLst>
           </p:cNvPr>
@@ -14355,7 +14647,7 @@
           <p:cNvPr id="3" name="image-surface">
             <a:extLst xmlns:a="http://schemas.openxmlformats.org/drawingml/2006/main">
               <a:ext uri="{FF2B5EF4-FFF2-40B4-BE49-F238E27FC236}">
-                <a16:creationId xmlns:a16="http://schemas.microsoft.com/office/drawing/2014/main" id="{C4C7E2EB-E3B9-486E-9B13-14358D477860}"/>
+                <a16:creationId xmlns:a16="http://schemas.microsoft.com/office/drawing/2014/main" id="{550CEB68-11CA-43F2-9555-C00C61EFE80B}"/>
               </a:ext>
             </a:extLst>
           </p:cNvPr>
@@ -14396,7 +14688,7 @@
           <p:nvPr/>
         </p:nvPicPr>
         <p:blipFill>
-          <a:blip xmlns:r="http://schemas.openxmlformats.org/officeDocument/2006/relationships" xmlns:a="http://schemas.openxmlformats.org/drawingml/2006/main" r:embed="Rc200fedfeb5f46da"/>
+          <a:blip xmlns:r="http://schemas.openxmlformats.org/officeDocument/2006/relationships" xmlns:a="http://schemas.openxmlformats.org/drawingml/2006/main" r:embed="R326f346a1b954541"/>
           <a:stretch xmlns:a="http://schemas.openxmlformats.org/drawingml/2006/main"/>
         </p:blipFill>
         <p:spPr>
@@ -14414,7 +14706,7 @@
           <p:cNvPr id="5" name="image-caption">
             <a:extLst xmlns:a="http://schemas.openxmlformats.org/drawingml/2006/main">
               <a:ext uri="{FF2B5EF4-FFF2-40B4-BE49-F238E27FC236}">
-                <a16:creationId xmlns:a16="http://schemas.microsoft.com/office/drawing/2014/main" id="{81C988AD-DAC3-471B-AE72-65BC97C3BCD7}"/>
+                <a16:creationId xmlns:a16="http://schemas.microsoft.com/office/drawing/2014/main" id="{AD96B82B-E388-4606-AAC5-7FD05C99A3FD}"/>
               </a:ext>
             </a:extLst>
           </p:cNvPr>
@@ -14465,7 +14757,7 @@
           <p:cNvPr id="6" name="eyebrow">
             <a:extLst xmlns:a="http://schemas.openxmlformats.org/drawingml/2006/main">
               <a:ext uri="{FF2B5EF4-FFF2-40B4-BE49-F238E27FC236}">
-                <a16:creationId xmlns:a16="http://schemas.microsoft.com/office/drawing/2014/main" id="{8F53556B-C04C-4C7D-B704-33EA67004C53}"/>
+                <a16:creationId xmlns:a16="http://schemas.microsoft.com/office/drawing/2014/main" id="{2129B35A-63E3-4A01-BD6E-3DBD50BCC6BB}"/>
               </a:ext>
             </a:extLst>
           </p:cNvPr>
@@ -14516,7 +14808,7 @@
           <p:cNvPr id="7" name="footer-rule">
             <a:extLst xmlns:a="http://schemas.openxmlformats.org/drawingml/2006/main">
               <a:ext uri="{FF2B5EF4-FFF2-40B4-BE49-F238E27FC236}">
-                <a16:creationId xmlns:a16="http://schemas.microsoft.com/office/drawing/2014/main" id="{DEDA4103-85C7-4FE4-A469-1BC2BA2F58FE}"/>
+                <a16:creationId xmlns:a16="http://schemas.microsoft.com/office/drawing/2014/main" id="{FF94E938-934D-427C-9467-86E546CF98BF}"/>
               </a:ext>
             </a:extLst>
           </p:cNvPr>
@@ -14549,7 +14841,7 @@
           <p:cNvPr id="8" name="footer">
             <a:extLst xmlns:a="http://schemas.openxmlformats.org/drawingml/2006/main">
               <a:ext uri="{FF2B5EF4-FFF2-40B4-BE49-F238E27FC236}">
-                <a16:creationId xmlns:a16="http://schemas.microsoft.com/office/drawing/2014/main" id="{4F3CAA9B-8C12-40BC-9E66-A7C54116B40C}"/>
+                <a16:creationId xmlns:a16="http://schemas.microsoft.com/office/drawing/2014/main" id="{881FD1F0-BAF5-4449-A6EC-19F4821DFA4C}"/>
               </a:ext>
             </a:extLst>
           </p:cNvPr>
@@ -14604,7 +14896,7 @@
           <p:cNvPr id="9" name="page-number">
             <a:extLst xmlns:a="http://schemas.openxmlformats.org/drawingml/2006/main">
               <a:ext uri="{FF2B5EF4-FFF2-40B4-BE49-F238E27FC236}">
-                <a16:creationId xmlns:a16="http://schemas.microsoft.com/office/drawing/2014/main" id="{9A2927B1-670C-4BB3-9F20-BDEF931ACEB3}"/>
+                <a16:creationId xmlns:a16="http://schemas.microsoft.com/office/drawing/2014/main" id="{F5566D0F-98E0-45D1-9DEB-8DB203E8103B}"/>
               </a:ext>
             </a:extLst>
           </p:cNvPr>
@@ -14657,7 +14949,7 @@
     </p:spTree>
     <p:extLst>
       <p:ext uri="{BB962C8B-B14F-4D97-AF65-F5344CB8AC3E}">
-        <p14:creationId xmlns:p14="http://schemas.microsoft.com/office/powerpoint/2010/main" val="1001539075"/>
+        <p14:creationId xmlns:p14="http://schemas.microsoft.com/office/powerpoint/2010/main" val="1473119199"/>
       </p:ext>
     </p:extLst>
   </p:cSld>
@@ -14696,7 +14988,7 @@
           <p:cNvPr id="11" name="slide-title">
             <a:extLst xmlns:a="http://schemas.openxmlformats.org/drawingml/2006/main">
               <a:ext uri="{FF2B5EF4-FFF2-40B4-BE49-F238E27FC236}">
-                <a16:creationId xmlns:a16="http://schemas.microsoft.com/office/drawing/2014/main" id="{FDB8B6AE-D908-4052-9274-6D66924E22DA}"/>
+                <a16:creationId xmlns:a16="http://schemas.microsoft.com/office/drawing/2014/main" id="{F8EAC34F-4E31-42E9-A421-4CFF88A1344A}"/>
               </a:ext>
             </a:extLst>
           </p:cNvPr>
@@ -14747,7 +15039,7 @@
           <p:cNvPr id="2" name="slide-subtitle">
             <a:extLst xmlns:a="http://schemas.openxmlformats.org/drawingml/2006/main">
               <a:ext uri="{FF2B5EF4-FFF2-40B4-BE49-F238E27FC236}">
-                <a16:creationId xmlns:a16="http://schemas.microsoft.com/office/drawing/2014/main" id="{223A5ED4-5A81-4D47-9C19-21D9735FF38D}"/>
+                <a16:creationId xmlns:a16="http://schemas.microsoft.com/office/drawing/2014/main" id="{D258FEB1-A662-41F6-B2C5-687AF1796BFB}"/>
               </a:ext>
             </a:extLst>
           </p:cNvPr>
@@ -14798,7 +15090,7 @@
           <p:cNvPr id="3" name="bullets">
             <a:extLst xmlns:a="http://schemas.openxmlformats.org/drawingml/2006/main">
               <a:ext uri="{FF2B5EF4-FFF2-40B4-BE49-F238E27FC236}">
-                <a16:creationId xmlns:a16="http://schemas.microsoft.com/office/drawing/2014/main" id="{DD56709E-2147-44CE-AC9D-4AB722AC90E2}"/>
+                <a16:creationId xmlns:a16="http://schemas.microsoft.com/office/drawing/2014/main" id="{D2F822F8-4A9E-4246-B52D-5BDD3D3C62C2}"/>
               </a:ext>
             </a:extLst>
           </p:cNvPr>
@@ -14903,7 +15195,7 @@
           <p:cNvPr id="4" name="ambient-glow">
             <a:extLst xmlns:a="http://schemas.openxmlformats.org/drawingml/2006/main">
               <a:ext uri="{FF2B5EF4-FFF2-40B4-BE49-F238E27FC236}">
-                <a16:creationId xmlns:a16="http://schemas.microsoft.com/office/drawing/2014/main" id="{8F1341FD-167F-4994-8343-E5FF4D92D1E0}"/>
+                <a16:creationId xmlns:a16="http://schemas.microsoft.com/office/drawing/2014/main" id="{B4A87DDC-1F9F-4CE4-9284-9AEA047E7AA6}"/>
               </a:ext>
             </a:extLst>
           </p:cNvPr>
@@ -14940,7 +15232,7 @@
           <p:cNvPr id="5" name="ambient-core">
             <a:extLst xmlns:a="http://schemas.openxmlformats.org/drawingml/2006/main">
               <a:ext uri="{FF2B5EF4-FFF2-40B4-BE49-F238E27FC236}">
-                <a16:creationId xmlns:a16="http://schemas.microsoft.com/office/drawing/2014/main" id="{A309DAF9-7DB7-4B0F-9F5D-386DF20C18F6}"/>
+                <a16:creationId xmlns:a16="http://schemas.microsoft.com/office/drawing/2014/main" id="{23D38CB9-9B9E-4B50-9F9C-F5EA1D6BB363}"/>
               </a:ext>
             </a:extLst>
           </p:cNvPr>
@@ -14977,7 +15269,7 @@
           <p:cNvPr id="6" name="section-number">
             <a:extLst xmlns:a="http://schemas.openxmlformats.org/drawingml/2006/main">
               <a:ext uri="{FF2B5EF4-FFF2-40B4-BE49-F238E27FC236}">
-                <a16:creationId xmlns:a16="http://schemas.microsoft.com/office/drawing/2014/main" id="{F6A4CA87-C5E8-4AA3-84B3-3B965AAE84DA}"/>
+                <a16:creationId xmlns:a16="http://schemas.microsoft.com/office/drawing/2014/main" id="{241E1676-B501-4197-8971-9F2B97E46328}"/>
               </a:ext>
             </a:extLst>
           </p:cNvPr>
@@ -15028,7 +15320,7 @@
           <p:cNvPr id="7" name="eyebrow">
             <a:extLst xmlns:a="http://schemas.openxmlformats.org/drawingml/2006/main">
               <a:ext uri="{FF2B5EF4-FFF2-40B4-BE49-F238E27FC236}">
-                <a16:creationId xmlns:a16="http://schemas.microsoft.com/office/drawing/2014/main" id="{33067564-595D-4FAB-B404-C9AA6245300B}"/>
+                <a16:creationId xmlns:a16="http://schemas.microsoft.com/office/drawing/2014/main" id="{E6D4EEB1-BED5-45A6-BA37-E59FD19BB7DF}"/>
               </a:ext>
             </a:extLst>
           </p:cNvPr>
@@ -15079,7 +15371,7 @@
           <p:cNvPr id="8" name="footer-rule">
             <a:extLst xmlns:a="http://schemas.openxmlformats.org/drawingml/2006/main">
               <a:ext uri="{FF2B5EF4-FFF2-40B4-BE49-F238E27FC236}">
-                <a16:creationId xmlns:a16="http://schemas.microsoft.com/office/drawing/2014/main" id="{33425ABE-830E-4FD0-AF5B-957A7DD21A28}"/>
+                <a16:creationId xmlns:a16="http://schemas.microsoft.com/office/drawing/2014/main" id="{50550AE6-6983-430F-B788-A3F51ED1A16B}"/>
               </a:ext>
             </a:extLst>
           </p:cNvPr>
@@ -15112,7 +15404,7 @@
           <p:cNvPr id="9" name="footer">
             <a:extLst xmlns:a="http://schemas.openxmlformats.org/drawingml/2006/main">
               <a:ext uri="{FF2B5EF4-FFF2-40B4-BE49-F238E27FC236}">
-                <a16:creationId xmlns:a16="http://schemas.microsoft.com/office/drawing/2014/main" id="{DCDD5674-6524-404C-A4E5-9091DBA50575}"/>
+                <a16:creationId xmlns:a16="http://schemas.microsoft.com/office/drawing/2014/main" id="{299E9AD1-5899-4193-B57D-BB4AF4AC305F}"/>
               </a:ext>
             </a:extLst>
           </p:cNvPr>
@@ -15167,7 +15459,7 @@
           <p:cNvPr id="10" name="page-number">
             <a:extLst xmlns:a="http://schemas.openxmlformats.org/drawingml/2006/main">
               <a:ext uri="{FF2B5EF4-FFF2-40B4-BE49-F238E27FC236}">
-                <a16:creationId xmlns:a16="http://schemas.microsoft.com/office/drawing/2014/main" id="{B83D1E07-EAE6-4C1B-AA91-A0BC99D092F9}"/>
+                <a16:creationId xmlns:a16="http://schemas.microsoft.com/office/drawing/2014/main" id="{F82E1A82-8335-483D-9A75-F279B7B1F742}"/>
               </a:ext>
             </a:extLst>
           </p:cNvPr>
@@ -15220,7 +15512,7 @@
     </p:spTree>
     <p:extLst>
       <p:ext uri="{BB962C8B-B14F-4D97-AF65-F5344CB8AC3E}">
-        <p14:creationId xmlns:p14="http://schemas.microsoft.com/office/powerpoint/2010/main" val="694515956"/>
+        <p14:creationId xmlns:p14="http://schemas.microsoft.com/office/powerpoint/2010/main" val="1285427839"/>
       </p:ext>
     </p:extLst>
   </p:cSld>
@@ -15251,7 +15543,7 @@
           <p:cNvPr id="10" name="slide-title">
             <a:extLst xmlns:a="http://schemas.openxmlformats.org/drawingml/2006/main">
               <a:ext uri="{FF2B5EF4-FFF2-40B4-BE49-F238E27FC236}">
-                <a16:creationId xmlns:a16="http://schemas.microsoft.com/office/drawing/2014/main" id="{753DBC0E-0E28-4733-8BE5-C930B6DAD46B}"/>
+                <a16:creationId xmlns:a16="http://schemas.microsoft.com/office/drawing/2014/main" id="{C00BA1BC-C99A-473C-98A7-41D667E8C385}"/>
               </a:ext>
             </a:extLst>
           </p:cNvPr>
@@ -15302,7 +15594,7 @@
           <p:cNvPr id="2" name="visual-claim">
             <a:extLst xmlns:a="http://schemas.openxmlformats.org/drawingml/2006/main">
               <a:ext uri="{FF2B5EF4-FFF2-40B4-BE49-F238E27FC236}">
-                <a16:creationId xmlns:a16="http://schemas.microsoft.com/office/drawing/2014/main" id="{37D4B9C8-C0C8-4439-8202-BFC705293260}"/>
+                <a16:creationId xmlns:a16="http://schemas.microsoft.com/office/drawing/2014/main" id="{53912B23-77A1-40D8-871E-29FF0C4AA9E4}"/>
               </a:ext>
             </a:extLst>
           </p:cNvPr>
@@ -15353,7 +15645,7 @@
           <p:cNvPr id="3" name="image-surface">
             <a:extLst xmlns:a="http://schemas.openxmlformats.org/drawingml/2006/main">
               <a:ext uri="{FF2B5EF4-FFF2-40B4-BE49-F238E27FC236}">
-                <a16:creationId xmlns:a16="http://schemas.microsoft.com/office/drawing/2014/main" id="{289D4479-F5E0-4723-B7C2-21246C48FDE6}"/>
+                <a16:creationId xmlns:a16="http://schemas.microsoft.com/office/drawing/2014/main" id="{0B0E71C5-4CC1-478B-B4B3-534C0C62495B}"/>
               </a:ext>
             </a:extLst>
           </p:cNvPr>
@@ -15392,7 +15684,7 @@
           <p:nvPr/>
         </p:nvPicPr>
         <p:blipFill>
-          <a:blip xmlns:r="http://schemas.openxmlformats.org/officeDocument/2006/relationships" xmlns:a="http://schemas.openxmlformats.org/drawingml/2006/main" r:embed="R6726bc8d537a42c4"/>
+          <a:blip xmlns:r="http://schemas.openxmlformats.org/officeDocument/2006/relationships" xmlns:a="http://schemas.openxmlformats.org/drawingml/2006/main" r:embed="Rb8f5d1c562d049fd"/>
           <a:stretch xmlns:a="http://schemas.openxmlformats.org/drawingml/2006/main"/>
         </p:blipFill>
         <p:spPr>
@@ -15410,7 +15702,7 @@
           <p:cNvPr id="5" name="image-caption">
             <a:extLst xmlns:a="http://schemas.openxmlformats.org/drawingml/2006/main">
               <a:ext uri="{FF2B5EF4-FFF2-40B4-BE49-F238E27FC236}">
-                <a16:creationId xmlns:a16="http://schemas.microsoft.com/office/drawing/2014/main" id="{F1895B36-B910-4C06-BEF3-D66FD733BA2E}"/>
+                <a16:creationId xmlns:a16="http://schemas.microsoft.com/office/drawing/2014/main" id="{1ACC9251-C710-40D0-B484-93BB18DE6955}"/>
               </a:ext>
             </a:extLst>
           </p:cNvPr>
@@ -15461,7 +15753,7 @@
           <p:cNvPr id="6" name="eyebrow">
             <a:extLst xmlns:a="http://schemas.openxmlformats.org/drawingml/2006/main">
               <a:ext uri="{FF2B5EF4-FFF2-40B4-BE49-F238E27FC236}">
-                <a16:creationId xmlns:a16="http://schemas.microsoft.com/office/drawing/2014/main" id="{2BB2CBA5-3832-4AC7-A394-F1F26598989F}"/>
+                <a16:creationId xmlns:a16="http://schemas.microsoft.com/office/drawing/2014/main" id="{B89A6885-4B55-49D2-8AAF-AEF1CDD51A46}"/>
               </a:ext>
             </a:extLst>
           </p:cNvPr>
@@ -15512,7 +15804,7 @@
           <p:cNvPr id="7" name="footer-rule">
             <a:extLst xmlns:a="http://schemas.openxmlformats.org/drawingml/2006/main">
               <a:ext uri="{FF2B5EF4-FFF2-40B4-BE49-F238E27FC236}">
-                <a16:creationId xmlns:a16="http://schemas.microsoft.com/office/drawing/2014/main" id="{BA83F12A-24F1-45B3-998B-F9EB1525EBE0}"/>
+                <a16:creationId xmlns:a16="http://schemas.microsoft.com/office/drawing/2014/main" id="{360BD1E4-AB8E-41DF-A0A9-0D57483AC7AA}"/>
               </a:ext>
             </a:extLst>
           </p:cNvPr>
@@ -15545,7 +15837,7 @@
           <p:cNvPr id="8" name="footer">
             <a:extLst xmlns:a="http://schemas.openxmlformats.org/drawingml/2006/main">
               <a:ext uri="{FF2B5EF4-FFF2-40B4-BE49-F238E27FC236}">
-                <a16:creationId xmlns:a16="http://schemas.microsoft.com/office/drawing/2014/main" id="{878A7016-9E08-499C-9C79-6FAE9689C298}"/>
+                <a16:creationId xmlns:a16="http://schemas.microsoft.com/office/drawing/2014/main" id="{99271A77-FBC3-40BE-993D-B5FC85BA6D6F}"/>
               </a:ext>
             </a:extLst>
           </p:cNvPr>
@@ -15600,7 +15892,7 @@
           <p:cNvPr id="9" name="page-number">
             <a:extLst xmlns:a="http://schemas.openxmlformats.org/drawingml/2006/main">
               <a:ext uri="{FF2B5EF4-FFF2-40B4-BE49-F238E27FC236}">
-                <a16:creationId xmlns:a16="http://schemas.microsoft.com/office/drawing/2014/main" id="{94C1088B-C2E9-4789-89D3-FD9856AF51F9}"/>
+                <a16:creationId xmlns:a16="http://schemas.microsoft.com/office/drawing/2014/main" id="{CA4E50B0-FCB5-4153-B42B-12E56FC4D1E3}"/>
               </a:ext>
             </a:extLst>
           </p:cNvPr>
@@ -15653,7 +15945,7 @@
     </p:spTree>
     <p:extLst>
       <p:ext uri="{BB962C8B-B14F-4D97-AF65-F5344CB8AC3E}">
-        <p14:creationId xmlns:p14="http://schemas.microsoft.com/office/powerpoint/2010/main" val="1710470893"/>
+        <p14:creationId xmlns:p14="http://schemas.microsoft.com/office/powerpoint/2010/main" val="645760378"/>
       </p:ext>
     </p:extLst>
   </p:cSld>
@@ -15684,7 +15976,7 @@
           <p:cNvPr id="11" name="slide-title">
             <a:extLst xmlns:a="http://schemas.openxmlformats.org/drawingml/2006/main">
               <a:ext uri="{FF2B5EF4-FFF2-40B4-BE49-F238E27FC236}">
-                <a16:creationId xmlns:a16="http://schemas.microsoft.com/office/drawing/2014/main" id="{6C0476F5-1A8E-4D46-83D5-B50B0B06A7ED}"/>
+                <a16:creationId xmlns:a16="http://schemas.microsoft.com/office/drawing/2014/main" id="{CCDB436E-7AB4-4839-9FB2-E799C8AD440C}"/>
               </a:ext>
             </a:extLst>
           </p:cNvPr>
@@ -15725,7 +16017,7 @@
                   <a:srgbClr val="0B1F3A"/>
                 </a:solidFill>
               </a:rPr>
-              <a:t>O repositório prepara o ambiente</a:t>
+              <a:t>O repositório restaura o ambiente</a:t>
             </a:r>
           </a:p>
         </p:txBody>
@@ -15735,7 +16027,7 @@
           <p:cNvPr id="2" name="slide-subtitle">
             <a:extLst xmlns:a="http://schemas.openxmlformats.org/drawingml/2006/main">
               <a:ext uri="{FF2B5EF4-FFF2-40B4-BE49-F238E27FC236}">
-                <a16:creationId xmlns:a16="http://schemas.microsoft.com/office/drawing/2014/main" id="{B4BBC15B-CD3C-415B-98E3-0632A659FA54}"/>
+                <a16:creationId xmlns:a16="http://schemas.microsoft.com/office/drawing/2014/main" id="{38F05AC6-E130-4EC7-B13E-4E4810C4CEF4}"/>
               </a:ext>
             </a:extLst>
           </p:cNvPr>
@@ -15776,7 +16068,7 @@
                   <a:srgbClr val="5C6F86"/>
                 </a:solidFill>
               </a:rPr>
-              <a:t>O dev container executa setup na criação e doctor a cada abertura.</a:t>
+              <a:t>Setup instala uma vez; a reabertura restaura PATH, profile e caminhos detectados.</a:t>
             </a:r>
           </a:p>
         </p:txBody>
@@ -15786,7 +16078,7 @@
           <p:cNvPr id="3" name="bullets">
             <a:extLst xmlns:a="http://schemas.openxmlformats.org/drawingml/2006/main">
               <a:ext uri="{FF2B5EF4-FFF2-40B4-BE49-F238E27FC236}">
-                <a16:creationId xmlns:a16="http://schemas.microsoft.com/office/drawing/2014/main" id="{FFD36E0E-E87E-4724-BB78-96EFD18F3642}"/>
+                <a16:creationId xmlns:a16="http://schemas.microsoft.com/office/drawing/2014/main" id="{06B808ED-FE4E-4290-AAC5-4A156699CE1B}"/>
               </a:ext>
             </a:extLst>
           </p:cNvPr>
@@ -15845,7 +16137,7 @@
                   <a:srgbClr val="0B1F3A"/>
                 </a:solidFill>
               </a:rPr>
-              <a:t>• dbt + DuckDB instalados</a:t>
+              <a:t>• dbt Core 1.12.3</a:t>
             </a:r>
           </a:p>
           <a:p xmlns:a="http://schemas.openxmlformats.org/drawingml/2006/main">
@@ -15863,7 +16155,7 @@
                   <a:srgbClr val="0B1F3A"/>
                 </a:solidFill>
               </a:rPr>
-              <a:t>• Nenhuma ativação manual</a:t>
+              <a:t>• DuckDB 1.5.5</a:t>
             </a:r>
           </a:p>
           <a:p xmlns:a="http://schemas.openxmlformats.org/drawingml/2006/main">
@@ -15881,7 +16173,7 @@
                   <a:srgbClr val="0B1F3A"/>
                 </a:solidFill>
               </a:rPr>
-              <a:t>• Checkpoint reproduzível</a:t>
+              <a:t>• Sem ativação manual</a:t>
             </a:r>
           </a:p>
         </p:txBody>
@@ -15891,7 +16183,7 @@
           <p:cNvPr id="4" name="ambient-glow">
             <a:extLst xmlns:a="http://schemas.openxmlformats.org/drawingml/2006/main">
               <a:ext uri="{FF2B5EF4-FFF2-40B4-BE49-F238E27FC236}">
-                <a16:creationId xmlns:a16="http://schemas.microsoft.com/office/drawing/2014/main" id="{D4A2377B-6C00-4E40-AF74-DFF52304C1C9}"/>
+                <a16:creationId xmlns:a16="http://schemas.microsoft.com/office/drawing/2014/main" id="{39FBEA68-CA35-4024-B162-912431C67564}"/>
               </a:ext>
             </a:extLst>
           </p:cNvPr>
@@ -15928,7 +16220,7 @@
           <p:cNvPr id="5" name="ambient-core">
             <a:extLst xmlns:a="http://schemas.openxmlformats.org/drawingml/2006/main">
               <a:ext uri="{FF2B5EF4-FFF2-40B4-BE49-F238E27FC236}">
-                <a16:creationId xmlns:a16="http://schemas.microsoft.com/office/drawing/2014/main" id="{99CF857B-F32B-49F7-9850-0EEAC283288B}"/>
+                <a16:creationId xmlns:a16="http://schemas.microsoft.com/office/drawing/2014/main" id="{9C30BCC6-BE7B-47EE-9797-7C9ADF7A7EE4}"/>
               </a:ext>
             </a:extLst>
           </p:cNvPr>
@@ -15965,7 +16257,7 @@
           <p:cNvPr id="6" name="section-number">
             <a:extLst xmlns:a="http://schemas.openxmlformats.org/drawingml/2006/main">
               <a:ext uri="{FF2B5EF4-FFF2-40B4-BE49-F238E27FC236}">
-                <a16:creationId xmlns:a16="http://schemas.microsoft.com/office/drawing/2014/main" id="{0321FF22-5183-4834-A0AE-72F03F04D2CE}"/>
+                <a16:creationId xmlns:a16="http://schemas.microsoft.com/office/drawing/2014/main" id="{75F9E7D3-DC51-4B37-8792-31A1615F49DD}"/>
               </a:ext>
             </a:extLst>
           </p:cNvPr>
@@ -16016,7 +16308,7 @@
           <p:cNvPr id="7" name="eyebrow">
             <a:extLst xmlns:a="http://schemas.openxmlformats.org/drawingml/2006/main">
               <a:ext uri="{FF2B5EF4-FFF2-40B4-BE49-F238E27FC236}">
-                <a16:creationId xmlns:a16="http://schemas.microsoft.com/office/drawing/2014/main" id="{CFB4D109-C812-4CE9-9B91-A15A37B8FD3C}"/>
+                <a16:creationId xmlns:a16="http://schemas.microsoft.com/office/drawing/2014/main" id="{B6F398CB-C54E-4910-B434-061467D8A0A3}"/>
               </a:ext>
             </a:extLst>
           </p:cNvPr>
@@ -16067,7 +16359,7 @@
           <p:cNvPr id="8" name="footer-rule">
             <a:extLst xmlns:a="http://schemas.openxmlformats.org/drawingml/2006/main">
               <a:ext uri="{FF2B5EF4-FFF2-40B4-BE49-F238E27FC236}">
-                <a16:creationId xmlns:a16="http://schemas.microsoft.com/office/drawing/2014/main" id="{400056DF-B640-4D17-B1A6-CA638699990A}"/>
+                <a16:creationId xmlns:a16="http://schemas.microsoft.com/office/drawing/2014/main" id="{C43ADDCC-26D2-473E-90BA-AB67EACAF6FD}"/>
               </a:ext>
             </a:extLst>
           </p:cNvPr>
@@ -16100,7 +16392,7 @@
           <p:cNvPr id="9" name="footer">
             <a:extLst xmlns:a="http://schemas.openxmlformats.org/drawingml/2006/main">
               <a:ext uri="{FF2B5EF4-FFF2-40B4-BE49-F238E27FC236}">
-                <a16:creationId xmlns:a16="http://schemas.microsoft.com/office/drawing/2014/main" id="{1B94D0EC-D96F-462F-BACE-D9CDA5AE74E3}"/>
+                <a16:creationId xmlns:a16="http://schemas.microsoft.com/office/drawing/2014/main" id="{B62742BB-EEED-4F83-988C-B8CF73B01A72}"/>
               </a:ext>
             </a:extLst>
           </p:cNvPr>
@@ -16155,7 +16447,7 @@
           <p:cNvPr id="10" name="page-number">
             <a:extLst xmlns:a="http://schemas.openxmlformats.org/drawingml/2006/main">
               <a:ext uri="{FF2B5EF4-FFF2-40B4-BE49-F238E27FC236}">
-                <a16:creationId xmlns:a16="http://schemas.microsoft.com/office/drawing/2014/main" id="{F0C4AD29-E891-42FE-B864-FC5E77EA3349}"/>
+                <a16:creationId xmlns:a16="http://schemas.microsoft.com/office/drawing/2014/main" id="{636B48E0-C8F0-4776-B8C2-34524836B712}"/>
               </a:ext>
             </a:extLst>
           </p:cNvPr>
@@ -16208,7 +16500,7 @@
     </p:spTree>
     <p:extLst>
       <p:ext uri="{BB962C8B-B14F-4D97-AF65-F5344CB8AC3E}">
-        <p14:creationId xmlns:p14="http://schemas.microsoft.com/office/powerpoint/2010/main" val="934032630"/>
+        <p14:creationId xmlns:p14="http://schemas.microsoft.com/office/powerpoint/2010/main" val="196273858"/>
       </p:ext>
     </p:extLst>
   </p:cSld>

</xml_diff>

<commit_message>
fix: substitui DuckDB UI no Codespaces
</commit_message>
<xml_diff>
--- a/assets/decks/aula-00-ambiente.pptx
+++ b/assets/decks/aula-00-ambiente.pptx
@@ -2,35 +2,35 @@
 <file path=ppt/presentation.xml><?xml version="1.0" encoding="utf-8"?>
 <p:presentation xmlns:p="http://schemas.openxmlformats.org/presentationml/2006/main">
   <p:sldMasterIdLst>
-    <p:sldMasterId xmlns:r="http://schemas.openxmlformats.org/officeDocument/2006/relationships" id="2147483648" r:id="R2cdf756852eb4a42"/>
-    <p:sldMasterId xmlns:r="http://schemas.openxmlformats.org/officeDocument/2006/relationships" id="2147483650" r:id="Rd56d015f13274f96"/>
+    <p:sldMasterId xmlns:r="http://schemas.openxmlformats.org/officeDocument/2006/relationships" id="2147483648" r:id="Rc66e5b7fb55d4e43"/>
+    <p:sldMasterId xmlns:r="http://schemas.openxmlformats.org/officeDocument/2006/relationships" id="2147483650" r:id="Ra1129938354d4fff"/>
   </p:sldMasterIdLst>
   <p:notesMasterIdLst>
-    <p:notesMasterId xmlns:r="http://schemas.openxmlformats.org/officeDocument/2006/relationships" r:id="Rf145efaa8b624fc5"/>
+    <p:notesMasterId xmlns:r="http://schemas.openxmlformats.org/officeDocument/2006/relationships" r:id="R74ab74d2d2d54cf2"/>
   </p:notesMasterIdLst>
   <p:sldIdLst>
-    <p:sldId xmlns:r="http://schemas.openxmlformats.org/officeDocument/2006/relationships" id="256" r:id="R598257d628f04eb2"/>
-    <p:sldId xmlns:r="http://schemas.openxmlformats.org/officeDocument/2006/relationships" id="257" r:id="R1c72c6260b964ae4"/>
-    <p:sldId xmlns:r="http://schemas.openxmlformats.org/officeDocument/2006/relationships" id="258" r:id="R43b0f2cbb6b846f1"/>
-    <p:sldId xmlns:r="http://schemas.openxmlformats.org/officeDocument/2006/relationships" id="259" r:id="Rfd27a0f0a1334be9"/>
-    <p:sldId xmlns:r="http://schemas.openxmlformats.org/officeDocument/2006/relationships" id="260" r:id="R096a49cccc80432f"/>
-    <p:sldId xmlns:r="http://schemas.openxmlformats.org/officeDocument/2006/relationships" id="261" r:id="Raad7281d8030418b"/>
-    <p:sldId xmlns:r="http://schemas.openxmlformats.org/officeDocument/2006/relationships" id="262" r:id="R56fe5049679e4cf0"/>
-    <p:sldId xmlns:r="http://schemas.openxmlformats.org/officeDocument/2006/relationships" id="263" r:id="R222ba59fdd4144ef"/>
-    <p:sldId xmlns:r="http://schemas.openxmlformats.org/officeDocument/2006/relationships" id="264" r:id="R378320da6ac1477b"/>
-    <p:sldId xmlns:r="http://schemas.openxmlformats.org/officeDocument/2006/relationships" id="265" r:id="Ra79e06bdac584763"/>
-    <p:sldId xmlns:r="http://schemas.openxmlformats.org/officeDocument/2006/relationships" id="266" r:id="R2f91e56e75694ec8"/>
-    <p:sldId xmlns:r="http://schemas.openxmlformats.org/officeDocument/2006/relationships" id="267" r:id="Rcd50333d4aad469d"/>
-    <p:sldId xmlns:r="http://schemas.openxmlformats.org/officeDocument/2006/relationships" id="268" r:id="R886512bd4f7f45b5"/>
-    <p:sldId xmlns:r="http://schemas.openxmlformats.org/officeDocument/2006/relationships" id="269" r:id="Rc824342c927643d0"/>
-    <p:sldId xmlns:r="http://schemas.openxmlformats.org/officeDocument/2006/relationships" id="270" r:id="R85f2e4329dee4ce5"/>
-    <p:sldId xmlns:r="http://schemas.openxmlformats.org/officeDocument/2006/relationships" id="271" r:id="R6c27c2e0a467478f"/>
-    <p:sldId xmlns:r="http://schemas.openxmlformats.org/officeDocument/2006/relationships" id="272" r:id="Rc8d3b7b28fe24767"/>
-    <p:sldId xmlns:r="http://schemas.openxmlformats.org/officeDocument/2006/relationships" id="273" r:id="R6dec51814432475b"/>
-    <p:sldId xmlns:r="http://schemas.openxmlformats.org/officeDocument/2006/relationships" id="274" r:id="R58bb461460bc4405"/>
-    <p:sldId xmlns:r="http://schemas.openxmlformats.org/officeDocument/2006/relationships" id="275" r:id="Rbef5bf8cb0f54770"/>
-    <p:sldId xmlns:r="http://schemas.openxmlformats.org/officeDocument/2006/relationships" id="276" r:id="R9b596c8f01024046"/>
-    <p:sldId xmlns:r="http://schemas.openxmlformats.org/officeDocument/2006/relationships" id="277" r:id="R1e87f65560d4415f"/>
+    <p:sldId xmlns:r="http://schemas.openxmlformats.org/officeDocument/2006/relationships" id="256" r:id="R3c2a1984e69e4cd1"/>
+    <p:sldId xmlns:r="http://schemas.openxmlformats.org/officeDocument/2006/relationships" id="257" r:id="R5db3506aa6b44be0"/>
+    <p:sldId xmlns:r="http://schemas.openxmlformats.org/officeDocument/2006/relationships" id="258" r:id="Rdff649bbd8fc4935"/>
+    <p:sldId xmlns:r="http://schemas.openxmlformats.org/officeDocument/2006/relationships" id="259" r:id="R9f2934003c9541bf"/>
+    <p:sldId xmlns:r="http://schemas.openxmlformats.org/officeDocument/2006/relationships" id="260" r:id="Rf34580506b5848cc"/>
+    <p:sldId xmlns:r="http://schemas.openxmlformats.org/officeDocument/2006/relationships" id="261" r:id="R53cf2a8c16fb4e7b"/>
+    <p:sldId xmlns:r="http://schemas.openxmlformats.org/officeDocument/2006/relationships" id="262" r:id="R5f87d95035774db9"/>
+    <p:sldId xmlns:r="http://schemas.openxmlformats.org/officeDocument/2006/relationships" id="263" r:id="R5a44d33d6e7a45f4"/>
+    <p:sldId xmlns:r="http://schemas.openxmlformats.org/officeDocument/2006/relationships" id="264" r:id="Rd781cb3b63fb48a5"/>
+    <p:sldId xmlns:r="http://schemas.openxmlformats.org/officeDocument/2006/relationships" id="265" r:id="R06551596b6564829"/>
+    <p:sldId xmlns:r="http://schemas.openxmlformats.org/officeDocument/2006/relationships" id="266" r:id="R5b60132737184ba3"/>
+    <p:sldId xmlns:r="http://schemas.openxmlformats.org/officeDocument/2006/relationships" id="267" r:id="R6541fd5c798a4a54"/>
+    <p:sldId xmlns:r="http://schemas.openxmlformats.org/officeDocument/2006/relationships" id="268" r:id="R0af2143e96574d44"/>
+    <p:sldId xmlns:r="http://schemas.openxmlformats.org/officeDocument/2006/relationships" id="269" r:id="Reabdeaeefcd24f23"/>
+    <p:sldId xmlns:r="http://schemas.openxmlformats.org/officeDocument/2006/relationships" id="270" r:id="R0bd1d847e8c64027"/>
+    <p:sldId xmlns:r="http://schemas.openxmlformats.org/officeDocument/2006/relationships" id="271" r:id="Recb6eff5312a454c"/>
+    <p:sldId xmlns:r="http://schemas.openxmlformats.org/officeDocument/2006/relationships" id="272" r:id="Ra3959867e2684745"/>
+    <p:sldId xmlns:r="http://schemas.openxmlformats.org/officeDocument/2006/relationships" id="273" r:id="Rec9dbd45ea70458f"/>
+    <p:sldId xmlns:r="http://schemas.openxmlformats.org/officeDocument/2006/relationships" id="274" r:id="R6fbfcecdedce4aeb"/>
+    <p:sldId xmlns:r="http://schemas.openxmlformats.org/officeDocument/2006/relationships" id="275" r:id="R2978282a319040d7"/>
+    <p:sldId xmlns:r="http://schemas.openxmlformats.org/officeDocument/2006/relationships" id="276" r:id="Rd35efcbc966c491f"/>
+    <p:sldId xmlns:r="http://schemas.openxmlformats.org/officeDocument/2006/relationships" id="277" r:id="R4f18925249084e94"/>
   </p:sldIdLst>
   <p:sldSz cx="12192000" cy="6858000"/>
   <p:notesSz cx="6858000" cy="9144000"/>
@@ -554,7 +554,12 @@
           </a:p>
           <a:p xmlns:a="http://schemas.openxmlformats.org/drawingml/2006/main">
             <a:r>
-              <a:t>- https://duckdb.org/docs/current/core_extensions/ui</a:t>
+              <a:t>- https://github.com/duckdb/duckdb-ui/issues/22</a:t>
+            </a:r>
+          </a:p>
+          <a:p xmlns:a="http://schemas.openxmlformats.org/drawingml/2006/main">
+            <a:r>
+              <a:t>- https://github.com/duckdb/duckdb-ui/issues/186</a:t>
             </a:r>
           </a:p>
           <a:p xmlns:a="http://schemas.openxmlformats.org/drawingml/2006/main">
@@ -744,7 +749,12 @@
           </a:p>
           <a:p xmlns:a="http://schemas.openxmlformats.org/drawingml/2006/main">
             <a:r>
-              <a:t>- https://duckdb.org/docs/current/core_extensions/ui</a:t>
+              <a:t>- https://github.com/duckdb/duckdb-ui/issues/22</a:t>
+            </a:r>
+          </a:p>
+          <a:p xmlns:a="http://schemas.openxmlformats.org/drawingml/2006/main">
+            <a:r>
+              <a:t>- https://github.com/duckdb/duckdb-ui/issues/186</a:t>
             </a:r>
           </a:p>
           <a:p xmlns:a="http://schemas.openxmlformats.org/drawingml/2006/main">
@@ -934,7 +944,12 @@
           </a:p>
           <a:p xmlns:a="http://schemas.openxmlformats.org/drawingml/2006/main">
             <a:r>
-              <a:t>- https://duckdb.org/docs/current/core_extensions/ui</a:t>
+              <a:t>- https://github.com/duckdb/duckdb-ui/issues/22</a:t>
+            </a:r>
+          </a:p>
+          <a:p xmlns:a="http://schemas.openxmlformats.org/drawingml/2006/main">
+            <a:r>
+              <a:t>- https://github.com/duckdb/duckdb-ui/issues/186</a:t>
             </a:r>
           </a:p>
           <a:p xmlns:a="http://schemas.openxmlformats.org/drawingml/2006/main">
@@ -1124,7 +1139,12 @@
           </a:p>
           <a:p xmlns:a="http://schemas.openxmlformats.org/drawingml/2006/main">
             <a:r>
-              <a:t>- https://duckdb.org/docs/current/core_extensions/ui</a:t>
+              <a:t>- https://github.com/duckdb/duckdb-ui/issues/22</a:t>
+            </a:r>
+          </a:p>
+          <a:p xmlns:a="http://schemas.openxmlformats.org/drawingml/2006/main">
+            <a:r>
+              <a:t>- https://github.com/duckdb/duckdb-ui/issues/186</a:t>
             </a:r>
           </a:p>
           <a:p xmlns:a="http://schemas.openxmlformats.org/drawingml/2006/main">
@@ -1249,7 +1269,7 @@
           </a:p>
           <a:p xmlns:a="http://schemas.openxmlformats.org/drawingml/2006/main">
             <a:r>
-              <a:t>A mensagem principal deste slide é: DuckDB UI abre na porta privada 4213 sem bloquear nem modificar o banco usado pelo dbt. Para tornar isso concreto, observe execute depois do checkpoint, Mantenha o terminal aberto e Ctrl+C encerra e permite atualizar. Esses pontos devem ser entendidos em conjunto; não são funcionalidades isoladas. No projeto, essa combinação transforma uma convenção informal em algo que pode ser revisado, testado ou consumido de maneira consistente.</a:t>
+              <a:t>A mensagem principal deste slide é: O explorador autoral abre na porta privada 4213 sem modificar o banco usado pelo dbt. Para tornar isso concreto, observe snapshot somente leitura, Mantenha o terminal aberto e Ctrl+C encerra e permite atualizar. Esses pontos devem ser entendidos em conjunto; não são funcionalidades isoladas. No projeto, essa combinação transforma uma convenção informal em algo que pode ser revisado, testado ou consumido de maneira consistente.</a:t>
             </a:r>
           </a:p>
           <a:p xmlns:a="http://schemas.openxmlformats.org/drawingml/2006/main">
@@ -1319,7 +1339,12 @@
           </a:p>
           <a:p xmlns:a="http://schemas.openxmlformats.org/drawingml/2006/main">
             <a:r>
-              <a:t>- https://duckdb.org/docs/current/core_extensions/ui</a:t>
+              <a:t>- https://github.com/duckdb/duckdb-ui/issues/22</a:t>
+            </a:r>
+          </a:p>
+          <a:p xmlns:a="http://schemas.openxmlformats.org/drawingml/2006/main">
+            <a:r>
+              <a:t>- https://github.com/duckdb/duckdb-ui/issues/186</a:t>
             </a:r>
           </a:p>
           <a:p xmlns:a="http://schemas.openxmlformats.org/drawingml/2006/main">
@@ -1439,7 +1464,7 @@
           </a:p>
           <a:p xmlns:a="http://schemas.openxmlformats.org/drawingml/2006/main">
             <a:r>
-              <a:t>Agora vamos ler a ideia visualmente. DuckDB UI abre na porta privada 4213 sem bloquear nem modificar o banco usado pelo dbt. Siga a composição na ordem mostrada e conecte dbt build, snapshot, DuckDB UI e navegador. A imagem ou o fluxo não cria uma regra nova; ele torna visível a relação que acabamos de explicar. Use a disposição dos elementos para reforçar causa, dependência ou comparação.</a:t>
+              <a:t>Agora vamos ler a ideia visualmente. O explorador autoral abre na porta privada 4213 sem modificar o banco usado pelo dbt. Siga a composição na ordem mostrada e conecte dbt build, snapshot, explorador e navegador. A imagem ou o fluxo não cria uma regra nova; ele torna visível a relação que acabamos de explicar. Use a disposição dos elementos para reforçar causa, dependência ou comparação.</a:t>
             </a:r>
           </a:p>
           <a:p xmlns:a="http://schemas.openxmlformats.org/drawingml/2006/main">
@@ -1509,7 +1534,12 @@
           </a:p>
           <a:p xmlns:a="http://schemas.openxmlformats.org/drawingml/2006/main">
             <a:r>
-              <a:t>- https://duckdb.org/docs/current/core_extensions/ui</a:t>
+              <a:t>- https://github.com/duckdb/duckdb-ui/issues/22</a:t>
+            </a:r>
+          </a:p>
+          <a:p xmlns:a="http://schemas.openxmlformats.org/drawingml/2006/main">
+            <a:r>
+              <a:t>- https://github.com/duckdb/duckdb-ui/issues/186</a:t>
             </a:r>
           </a:p>
           <a:p xmlns:a="http://schemas.openxmlformats.org/drawingml/2006/main">
@@ -1699,7 +1729,12 @@
           </a:p>
           <a:p xmlns:a="http://schemas.openxmlformats.org/drawingml/2006/main">
             <a:r>
-              <a:t>- https://duckdb.org/docs/current/core_extensions/ui</a:t>
+              <a:t>- https://github.com/duckdb/duckdb-ui/issues/22</a:t>
+            </a:r>
+          </a:p>
+          <a:p xmlns:a="http://schemas.openxmlformats.org/drawingml/2006/main">
+            <a:r>
+              <a:t>- https://github.com/duckdb/duckdb-ui/issues/186</a:t>
             </a:r>
           </a:p>
           <a:p xmlns:a="http://schemas.openxmlformats.org/drawingml/2006/main">
@@ -1819,7 +1854,7 @@
           </a:p>
           <a:p xmlns:a="http://schemas.openxmlformats.org/drawingml/2006/main">
             <a:r>
-              <a:t>Enquanto a execução acontece, não olhe apenas para a mensagem final. Observe dbt e DuckDB do ambiente isolado, Seeds e artifacts executados e DuckDB UI na porta privada 4213. Cada sinal responde a uma pergunta diferente sobre o pipeline. Se um deles divergir, interrompa a demonstração e investigue; o objetivo do hands-on é produzir evidência, não apenas chegar rapidamente a uma tela verde.</a:t>
+              <a:t>Enquanto a execução acontece, não olhe apenas para a mensagem final. Observe dbt e DuckDB do ambiente isolado, Seeds e artifacts executados e Explorador na porta privada 4213. Cada sinal responde a uma pergunta diferente sobre o pipeline. Se um deles divergir, interrompa a demonstração e investigue; o objetivo do hands-on é produzir evidência, não apenas chegar rapidamente a uma tela verde.</a:t>
             </a:r>
           </a:p>
           <a:p xmlns:a="http://schemas.openxmlformats.org/drawingml/2006/main">
@@ -1889,7 +1924,12 @@
           </a:p>
           <a:p xmlns:a="http://schemas.openxmlformats.org/drawingml/2006/main">
             <a:r>
-              <a:t>- https://duckdb.org/docs/current/core_extensions/ui</a:t>
+              <a:t>- https://github.com/duckdb/duckdb-ui/issues/22</a:t>
+            </a:r>
+          </a:p>
+          <a:p xmlns:a="http://schemas.openxmlformats.org/drawingml/2006/main">
+            <a:r>
+              <a:t>- https://github.com/duckdb/duckdb-ui/issues/186</a:t>
             </a:r>
           </a:p>
           <a:p xmlns:a="http://schemas.openxmlformats.org/drawingml/2006/main">
@@ -2079,7 +2119,12 @@
           </a:p>
           <a:p xmlns:a="http://schemas.openxmlformats.org/drawingml/2006/main">
             <a:r>
-              <a:t>- https://duckdb.org/docs/current/core_extensions/ui</a:t>
+              <a:t>- https://github.com/duckdb/duckdb-ui/issues/22</a:t>
+            </a:r>
+          </a:p>
+          <a:p xmlns:a="http://schemas.openxmlformats.org/drawingml/2006/main">
+            <a:r>
+              <a:t>- https://github.com/duckdb/duckdb-ui/issues/186</a:t>
             </a:r>
           </a:p>
           <a:p xmlns:a="http://schemas.openxmlformats.org/drawingml/2006/main">
@@ -2269,7 +2314,12 @@
           </a:p>
           <a:p xmlns:a="http://schemas.openxmlformats.org/drawingml/2006/main">
             <a:r>
-              <a:t>- https://duckdb.org/docs/current/core_extensions/ui</a:t>
+              <a:t>- https://github.com/duckdb/duckdb-ui/issues/22</a:t>
+            </a:r>
+          </a:p>
+          <a:p xmlns:a="http://schemas.openxmlformats.org/drawingml/2006/main">
+            <a:r>
+              <a:t>- https://github.com/duckdb/duckdb-ui/issues/186</a:t>
             </a:r>
           </a:p>
           <a:p xmlns:a="http://schemas.openxmlformats.org/drawingml/2006/main">
@@ -2459,7 +2509,12 @@
           </a:p>
           <a:p xmlns:a="http://schemas.openxmlformats.org/drawingml/2006/main">
             <a:r>
-              <a:t>- https://duckdb.org/docs/current/core_extensions/ui</a:t>
+              <a:t>- https://github.com/duckdb/duckdb-ui/issues/22</a:t>
+            </a:r>
+          </a:p>
+          <a:p xmlns:a="http://schemas.openxmlformats.org/drawingml/2006/main">
+            <a:r>
+              <a:t>- https://github.com/duckdb/duckdb-ui/issues/186</a:t>
             </a:r>
           </a:p>
           <a:p xmlns:a="http://schemas.openxmlformats.org/drawingml/2006/main">
@@ -2649,7 +2704,12 @@
           </a:p>
           <a:p xmlns:a="http://schemas.openxmlformats.org/drawingml/2006/main">
             <a:r>
-              <a:t>- https://duckdb.org/docs/current/core_extensions/ui</a:t>
+              <a:t>- https://github.com/duckdb/duckdb-ui/issues/22</a:t>
+            </a:r>
+          </a:p>
+          <a:p xmlns:a="http://schemas.openxmlformats.org/drawingml/2006/main">
+            <a:r>
+              <a:t>- https://github.com/duckdb/duckdb-ui/issues/186</a:t>
             </a:r>
           </a:p>
           <a:p xmlns:a="http://schemas.openxmlformats.org/drawingml/2006/main">
@@ -2769,7 +2829,7 @@
           </a:p>
           <a:p xmlns:a="http://schemas.openxmlformats.org/drawingml/2006/main">
             <a:r>
-              <a:t>Também precisamos declarar os limites da recomendação. Neste cenário, considere codespaces exige internet e conta pessoal GitHub, Franquias e cobrança podem mudar, DuckDB UI instala a extensão no primeiro uso e Instalação local permanece disponível. Esses pontos não anulam a técnica; eles delimitam onde a demonstração é válida e quais condições precisam ser verificadas antes de levar o padrão para produção. Tratar limites como parte do design evita transformar uma boa prática em regra universal.</a:t>
+              <a:t>Também precisamos declarar os limites da recomendação. Neste cenário, considere codespaces exige internet e conta pessoal GitHub, Franquias e cobrança podem mudar, Explorador autoral é propositalmente simples e Instalação local permanece disponível. Esses pontos não anulam a técnica; eles delimitam onde a demonstração é válida e quais condições precisam ser verificadas antes de levar o padrão para produção. Tratar limites como parte do design evita transformar uma boa prática em regra universal.</a:t>
             </a:r>
           </a:p>
           <a:p xmlns:a="http://schemas.openxmlformats.org/drawingml/2006/main">
@@ -2839,7 +2899,12 @@
           </a:p>
           <a:p xmlns:a="http://schemas.openxmlformats.org/drawingml/2006/main">
             <a:r>
-              <a:t>- https://duckdb.org/docs/current/core_extensions/ui</a:t>
+              <a:t>- https://github.com/duckdb/duckdb-ui/issues/22</a:t>
+            </a:r>
+          </a:p>
+          <a:p xmlns:a="http://schemas.openxmlformats.org/drawingml/2006/main">
+            <a:r>
+              <a:t>- https://github.com/duckdb/duckdb-ui/issues/186</a:t>
             </a:r>
           </a:p>
           <a:p xmlns:a="http://schemas.openxmlformats.org/drawingml/2006/main">
@@ -3029,7 +3094,12 @@
           </a:p>
           <a:p xmlns:a="http://schemas.openxmlformats.org/drawingml/2006/main">
             <a:r>
-              <a:t>- https://duckdb.org/docs/current/core_extensions/ui</a:t>
+              <a:t>- https://github.com/duckdb/duckdb-ui/issues/22</a:t>
+            </a:r>
+          </a:p>
+          <a:p xmlns:a="http://schemas.openxmlformats.org/drawingml/2006/main">
+            <a:r>
+              <a:t>- https://github.com/duckdb/duckdb-ui/issues/186</a:t>
             </a:r>
           </a:p>
           <a:p xmlns:a="http://schemas.openxmlformats.org/drawingml/2006/main">
@@ -3149,7 +3219,7 @@
           </a:p>
           <a:p xmlns:a="http://schemas.openxmlformats.org/drawingml/2006/main">
             <a:r>
-              <a:t>Abra o Codespace em 2-core, confira paths, execute checkpoint 01, explore a UI e pare ao terminar. Faça essa etapa antes de seguir para o próximo episódio, porque o curso é cumulativo e o checkpoint atual se torna a base da aula seguinte. Se houver divergência, use o relatório de suporte e registre o que foi observado. O objetivo é avançar com um estado conhecido e reproduzível, não apenas assistir ao conteúdo.</a:t>
+              <a:t>Abra o Codespace em 2-core, confira paths, execute checkpoint 01, explore a cópia e pare ao terminar. Faça essa etapa antes de seguir para o próximo episódio, porque o curso é cumulativo e o checkpoint atual se torna a base da aula seguinte. Se houver divergência, use o relatório de suporte e registre o que foi observado. O objetivo é avançar com um estado conhecido e reproduzível, não apenas assistir ao conteúdo.</a:t>
             </a:r>
           </a:p>
           <a:p xmlns:a="http://schemas.openxmlformats.org/drawingml/2006/main">
@@ -3219,7 +3289,12 @@
           </a:p>
           <a:p xmlns:a="http://schemas.openxmlformats.org/drawingml/2006/main">
             <a:r>
-              <a:t>- https://duckdb.org/docs/current/core_extensions/ui</a:t>
+              <a:t>- https://github.com/duckdb/duckdb-ui/issues/22</a:t>
+            </a:r>
+          </a:p>
+          <a:p xmlns:a="http://schemas.openxmlformats.org/drawingml/2006/main">
+            <a:r>
+              <a:t>- https://github.com/duckdb/duckdb-ui/issues/186</a:t>
             </a:r>
           </a:p>
           <a:p xmlns:a="http://schemas.openxmlformats.org/drawingml/2006/main">
@@ -3409,7 +3484,12 @@
           </a:p>
           <a:p xmlns:a="http://schemas.openxmlformats.org/drawingml/2006/main">
             <a:r>
-              <a:t>- https://duckdb.org/docs/current/core_extensions/ui</a:t>
+              <a:t>- https://github.com/duckdb/duckdb-ui/issues/22</a:t>
+            </a:r>
+          </a:p>
+          <a:p xmlns:a="http://schemas.openxmlformats.org/drawingml/2006/main">
+            <a:r>
+              <a:t>- https://github.com/duckdb/duckdb-ui/issues/186</a:t>
             </a:r>
           </a:p>
           <a:p xmlns:a="http://schemas.openxmlformats.org/drawingml/2006/main">
@@ -3599,7 +3679,12 @@
           </a:p>
           <a:p xmlns:a="http://schemas.openxmlformats.org/drawingml/2006/main">
             <a:r>
-              <a:t>- https://duckdb.org/docs/current/core_extensions/ui</a:t>
+              <a:t>- https://github.com/duckdb/duckdb-ui/issues/22</a:t>
+            </a:r>
+          </a:p>
+          <a:p xmlns:a="http://schemas.openxmlformats.org/drawingml/2006/main">
+            <a:r>
+              <a:t>- https://github.com/duckdb/duckdb-ui/issues/186</a:t>
             </a:r>
           </a:p>
           <a:p xmlns:a="http://schemas.openxmlformats.org/drawingml/2006/main">
@@ -3789,7 +3874,12 @@
           </a:p>
           <a:p xmlns:a="http://schemas.openxmlformats.org/drawingml/2006/main">
             <a:r>
-              <a:t>- https://duckdb.org/docs/current/core_extensions/ui</a:t>
+              <a:t>- https://github.com/duckdb/duckdb-ui/issues/22</a:t>
+            </a:r>
+          </a:p>
+          <a:p xmlns:a="http://schemas.openxmlformats.org/drawingml/2006/main">
+            <a:r>
+              <a:t>- https://github.com/duckdb/duckdb-ui/issues/186</a:t>
             </a:r>
           </a:p>
           <a:p xmlns:a="http://schemas.openxmlformats.org/drawingml/2006/main">
@@ -3979,7 +4069,12 @@
           </a:p>
           <a:p xmlns:a="http://schemas.openxmlformats.org/drawingml/2006/main">
             <a:r>
-              <a:t>- https://duckdb.org/docs/current/core_extensions/ui</a:t>
+              <a:t>- https://github.com/duckdb/duckdb-ui/issues/22</a:t>
+            </a:r>
+          </a:p>
+          <a:p xmlns:a="http://schemas.openxmlformats.org/drawingml/2006/main">
+            <a:r>
+              <a:t>- https://github.com/duckdb/duckdb-ui/issues/186</a:t>
             </a:r>
           </a:p>
           <a:p xmlns:a="http://schemas.openxmlformats.org/drawingml/2006/main">
@@ -4174,7 +4269,12 @@
           </a:p>
           <a:p xmlns:a="http://schemas.openxmlformats.org/drawingml/2006/main">
             <a:r>
-              <a:t>- https://duckdb.org/docs/current/core_extensions/ui</a:t>
+              <a:t>- https://github.com/duckdb/duckdb-ui/issues/22</a:t>
+            </a:r>
+          </a:p>
+          <a:p xmlns:a="http://schemas.openxmlformats.org/drawingml/2006/main">
+            <a:r>
+              <a:t>- https://github.com/duckdb/duckdb-ui/issues/186</a:t>
             </a:r>
           </a:p>
           <a:p xmlns:a="http://schemas.openxmlformats.org/drawingml/2006/main">
@@ -4364,7 +4464,12 @@
           </a:p>
           <a:p xmlns:a="http://schemas.openxmlformats.org/drawingml/2006/main">
             <a:r>
-              <a:t>- https://duckdb.org/docs/current/core_extensions/ui</a:t>
+              <a:t>- https://github.com/duckdb/duckdb-ui/issues/22</a:t>
+            </a:r>
+          </a:p>
+          <a:p xmlns:a="http://schemas.openxmlformats.org/drawingml/2006/main">
+            <a:r>
+              <a:t>- https://github.com/duckdb/duckdb-ui/issues/186</a:t>
             </a:r>
           </a:p>
           <a:p xmlns:a="http://schemas.openxmlformats.org/drawingml/2006/main">
@@ -4559,7 +4664,12 @@
           </a:p>
           <a:p xmlns:a="http://schemas.openxmlformats.org/drawingml/2006/main">
             <a:r>
-              <a:t>- https://duckdb.org/docs/current/core_extensions/ui</a:t>
+              <a:t>- https://github.com/duckdb/duckdb-ui/issues/22</a:t>
+            </a:r>
+          </a:p>
+          <a:p xmlns:a="http://schemas.openxmlformats.org/drawingml/2006/main">
+            <a:r>
+              <a:t>- https://github.com/duckdb/duckdb-ui/issues/186</a:t>
             </a:r>
           </a:p>
           <a:p xmlns:a="http://schemas.openxmlformats.org/drawingml/2006/main">
@@ -4691,7 +4801,7 @@
   </p:cSld>
   <p:clrMap bg1="lt1" tx1="dk1" bg2="lt2" tx2="dk2" accent1="accent1" accent2="accent2" accent3="accent3" accent4="accent4" accent5="accent5" accent6="accent6" hlink="hlink" folHlink="folHlink"/>
   <p:sldLayoutIdLst>
-    <p:sldLayoutId xmlns:r="http://schemas.openxmlformats.org/officeDocument/2006/relationships" id="2147483649" r:id="R8db020e79576446a"/>
+    <p:sldLayoutId xmlns:r="http://schemas.openxmlformats.org/officeDocument/2006/relationships" id="2147483649" r:id="Rbe31f678083e48e6"/>
   </p:sldLayoutIdLst>
   <p:txStyles>
     <p:titleStyle>
@@ -4989,8 +5099,8 @@
   </p:cSld>
   <p:clrMap bg1="lt1" tx1="dk1" bg2="lt2" tx2="dk2" accent1="accent1" accent2="accent2" accent3="accent3" accent4="accent4" accent5="accent5" accent6="accent6" hlink="hlink" folHlink="folHlink"/>
   <p:sldLayoutIdLst>
-    <p:sldLayoutId xmlns:r="http://schemas.openxmlformats.org/officeDocument/2006/relationships" id="2147483651" r:id="Re69c1d9c70d34e47"/>
-    <p:sldLayoutId xmlns:r="http://schemas.openxmlformats.org/officeDocument/2006/relationships" id="2147483652" r:id="R584deff15c944e8b"/>
+    <p:sldLayoutId xmlns:r="http://schemas.openxmlformats.org/officeDocument/2006/relationships" id="2147483651" r:id="Rac967ed00d014eeb"/>
+    <p:sldLayoutId xmlns:r="http://schemas.openxmlformats.org/officeDocument/2006/relationships" id="2147483652" r:id="Rbbddfa610bf84a82"/>
   </p:sldLayoutIdLst>
 </p:sldMaster>
 </file>
@@ -5521,7 +5631,7 @@
           <p:nvPr/>
         </p:nvPicPr>
         <p:blipFill>
-          <a:blip xmlns:r="http://schemas.openxmlformats.org/officeDocument/2006/relationships" xmlns:a="http://schemas.openxmlformats.org/drawingml/2006/main" r:embed="Ra2c06dba5c8d4e87"/>
+          <a:blip xmlns:r="http://schemas.openxmlformats.org/officeDocument/2006/relationships" xmlns:a="http://schemas.openxmlformats.org/drawingml/2006/main" r:embed="Rb04b180086ee4286"/>
           <a:srcRect xmlns:a="http://schemas.openxmlformats.org/drawingml/2006/main" l="19785" t="0" r="19785" b="0"/>
           <a:stretch xmlns:a="http://schemas.openxmlformats.org/drawingml/2006/main">
             <a:fillRect l="0" t="0" r="0" b="0"/>
@@ -5542,7 +5652,7 @@
           <p:cNvPr id="2" name="cover-text-surface">
             <a:extLst xmlns:a="http://schemas.openxmlformats.org/drawingml/2006/main">
               <a:ext uri="{FF2B5EF4-FFF2-40B4-BE49-F238E27FC236}">
-                <a16:creationId xmlns:a16="http://schemas.microsoft.com/office/drawing/2014/main" id="{78A00156-943C-4DCE-A318-5578213832CF}"/>
+                <a16:creationId xmlns:a16="http://schemas.microsoft.com/office/drawing/2014/main" id="{1F10E179-8642-4532-8E7A-77C588F250D1}"/>
               </a:ext>
             </a:extLst>
           </p:cNvPr>
@@ -5575,7 +5685,7 @@
           <p:cNvPr id="3" name="cover-divider">
             <a:extLst xmlns:a="http://schemas.openxmlformats.org/drawingml/2006/main">
               <a:ext uri="{FF2B5EF4-FFF2-40B4-BE49-F238E27FC236}">
-                <a16:creationId xmlns:a16="http://schemas.microsoft.com/office/drawing/2014/main" id="{95513F46-406C-4CAA-BE74-0B7A242970ED}"/>
+                <a16:creationId xmlns:a16="http://schemas.microsoft.com/office/drawing/2014/main" id="{C23C3CBB-AE51-4DAC-A25B-63AC86DFC6B6}"/>
               </a:ext>
             </a:extLst>
           </p:cNvPr>
@@ -5606,7 +5716,7 @@
           <p:cNvPr id="4" name="cover-episode">
             <a:extLst xmlns:a="http://schemas.openxmlformats.org/drawingml/2006/main">
               <a:ext uri="{FF2B5EF4-FFF2-40B4-BE49-F238E27FC236}">
-                <a16:creationId xmlns:a16="http://schemas.microsoft.com/office/drawing/2014/main" id="{CF02AC90-1433-4704-B79B-7435365C13E5}"/>
+                <a16:creationId xmlns:a16="http://schemas.microsoft.com/office/drawing/2014/main" id="{D0257A40-266E-497F-9C68-1B4948681A29}"/>
               </a:ext>
             </a:extLst>
           </p:cNvPr>
@@ -5657,7 +5767,7 @@
           <p:cNvPr id="5" name="cover-title">
             <a:extLst xmlns:a="http://schemas.openxmlformats.org/drawingml/2006/main">
               <a:ext uri="{FF2B5EF4-FFF2-40B4-BE49-F238E27FC236}">
-                <a16:creationId xmlns:a16="http://schemas.microsoft.com/office/drawing/2014/main" id="{58993632-6EE7-4DBC-A519-729BAA418D67}"/>
+                <a16:creationId xmlns:a16="http://schemas.microsoft.com/office/drawing/2014/main" id="{34545C1A-6F6F-46F9-93C4-4102975239C5}"/>
               </a:ext>
             </a:extLst>
           </p:cNvPr>
@@ -5708,7 +5818,7 @@
           <p:cNvPr id="6" name="cover-subtitle">
             <a:extLst xmlns:a="http://schemas.openxmlformats.org/drawingml/2006/main">
               <a:ext uri="{FF2B5EF4-FFF2-40B4-BE49-F238E27FC236}">
-                <a16:creationId xmlns:a16="http://schemas.microsoft.com/office/drawing/2014/main" id="{3CECE5B1-D43D-4E7B-92D2-975E2E8EFD92}"/>
+                <a16:creationId xmlns:a16="http://schemas.microsoft.com/office/drawing/2014/main" id="{58EE36CE-4FA0-4449-8CC8-EB39AC990A01}"/>
               </a:ext>
             </a:extLst>
           </p:cNvPr>
@@ -5759,7 +5869,7 @@
           <p:cNvPr id="7" name="cover-accent">
             <a:extLst xmlns:a="http://schemas.openxmlformats.org/drawingml/2006/main">
               <a:ext uri="{FF2B5EF4-FFF2-40B4-BE49-F238E27FC236}">
-                <a16:creationId xmlns:a16="http://schemas.microsoft.com/office/drawing/2014/main" id="{C23E8888-1E54-4F62-B822-E11043DEF3BC}"/>
+                <a16:creationId xmlns:a16="http://schemas.microsoft.com/office/drawing/2014/main" id="{31FDC005-E3D0-4CA4-8C89-1DD3B944FCF8}"/>
               </a:ext>
             </a:extLst>
           </p:cNvPr>
@@ -5790,7 +5900,7 @@
           <p:cNvPr id="8" name="cover-meta">
             <a:extLst xmlns:a="http://schemas.openxmlformats.org/drawingml/2006/main">
               <a:ext uri="{FF2B5EF4-FFF2-40B4-BE49-F238E27FC236}">
-                <a16:creationId xmlns:a16="http://schemas.microsoft.com/office/drawing/2014/main" id="{84B3F8A1-04B9-48FF-ABBB-1418E5CD72D1}"/>
+                <a16:creationId xmlns:a16="http://schemas.microsoft.com/office/drawing/2014/main" id="{334CF948-CED9-40A5-AB05-229B25C3D986}"/>
               </a:ext>
             </a:extLst>
           </p:cNvPr>
@@ -5843,7 +5953,7 @@
     </p:spTree>
     <p:extLst>
       <p:ext uri="{BB962C8B-B14F-4D97-AF65-F5344CB8AC3E}">
-        <p14:creationId xmlns:p14="http://schemas.microsoft.com/office/powerpoint/2010/main" val="2039327846"/>
+        <p14:creationId xmlns:p14="http://schemas.microsoft.com/office/powerpoint/2010/main" val="728742363"/>
       </p:ext>
     </p:extLst>
   </p:cSld>
@@ -5882,7 +5992,7 @@
           <p:cNvPr id="13" name="slide-title">
             <a:extLst xmlns:a="http://schemas.openxmlformats.org/drawingml/2006/main">
               <a:ext uri="{FF2B5EF4-FFF2-40B4-BE49-F238E27FC236}">
-                <a16:creationId xmlns:a16="http://schemas.microsoft.com/office/drawing/2014/main" id="{E9920752-E5CD-404F-862F-2FA902A2A5FC}"/>
+                <a16:creationId xmlns:a16="http://schemas.microsoft.com/office/drawing/2014/main" id="{37AF3565-ECBE-4507-8D95-09B627A99927}"/>
               </a:ext>
             </a:extLst>
           </p:cNvPr>
@@ -5933,7 +6043,7 @@
           <p:cNvPr id="2" name="flow-1">
             <a:extLst xmlns:a="http://schemas.openxmlformats.org/drawingml/2006/main">
               <a:ext uri="{FF2B5EF4-FFF2-40B4-BE49-F238E27FC236}">
-                <a16:creationId xmlns:a16="http://schemas.microsoft.com/office/drawing/2014/main" id="{FD5CFC25-C8DE-4133-943A-EA1553C62D35}"/>
+                <a16:creationId xmlns:a16="http://schemas.microsoft.com/office/drawing/2014/main" id="{650E45D0-2535-48AB-8B61-64037AAEFAD4}"/>
               </a:ext>
             </a:extLst>
           </p:cNvPr>
@@ -5990,7 +6100,7 @@
           <p:cNvPr id="3" name="flow-2">
             <a:extLst xmlns:a="http://schemas.openxmlformats.org/drawingml/2006/main">
               <a:ext uri="{FF2B5EF4-FFF2-40B4-BE49-F238E27FC236}">
-                <a16:creationId xmlns:a16="http://schemas.microsoft.com/office/drawing/2014/main" id="{956F867A-3C8E-4B9D-A0FE-A78D43D9AC75}"/>
+                <a16:creationId xmlns:a16="http://schemas.microsoft.com/office/drawing/2014/main" id="{BB89D3E9-705D-49D2-9F35-6DAFE2DF4FEE}"/>
               </a:ext>
             </a:extLst>
           </p:cNvPr>
@@ -6047,7 +6157,7 @@
           <p:cNvPr id="4" name="flow-3">
             <a:extLst xmlns:a="http://schemas.openxmlformats.org/drawingml/2006/main">
               <a:ext uri="{FF2B5EF4-FFF2-40B4-BE49-F238E27FC236}">
-                <a16:creationId xmlns:a16="http://schemas.microsoft.com/office/drawing/2014/main" id="{D51C645F-0CD7-4092-899B-B4FAEA1E15B4}"/>
+                <a16:creationId xmlns:a16="http://schemas.microsoft.com/office/drawing/2014/main" id="{443C644E-B1F3-4E2B-A4B7-3763FA9B7062}"/>
               </a:ext>
             </a:extLst>
           </p:cNvPr>
@@ -6104,7 +6214,7 @@
           <p:cNvPr id="5" name="flow-4">
             <a:extLst xmlns:a="http://schemas.openxmlformats.org/drawingml/2006/main">
               <a:ext uri="{FF2B5EF4-FFF2-40B4-BE49-F238E27FC236}">
-                <a16:creationId xmlns:a16="http://schemas.microsoft.com/office/drawing/2014/main" id="{06856412-8C22-4E8F-8FF2-2F2274FA7612}"/>
+                <a16:creationId xmlns:a16="http://schemas.microsoft.com/office/drawing/2014/main" id="{12E8E81E-25FD-4E52-829A-FCB533C4832E}"/>
               </a:ext>
             </a:extLst>
           </p:cNvPr>
@@ -6239,7 +6349,7 @@
           <p:cNvPr id="9" name="eyebrow">
             <a:extLst xmlns:a="http://schemas.openxmlformats.org/drawingml/2006/main">
               <a:ext uri="{FF2B5EF4-FFF2-40B4-BE49-F238E27FC236}">
-                <a16:creationId xmlns:a16="http://schemas.microsoft.com/office/drawing/2014/main" id="{185AAA6D-BE01-48F5-9916-5C5FB454BAED}"/>
+                <a16:creationId xmlns:a16="http://schemas.microsoft.com/office/drawing/2014/main" id="{6C92AC3D-0576-4CE6-9505-DC1833733E20}"/>
               </a:ext>
             </a:extLst>
           </p:cNvPr>
@@ -6290,7 +6400,7 @@
           <p:cNvPr id="10" name="footer-rule">
             <a:extLst xmlns:a="http://schemas.openxmlformats.org/drawingml/2006/main">
               <a:ext uri="{FF2B5EF4-FFF2-40B4-BE49-F238E27FC236}">
-                <a16:creationId xmlns:a16="http://schemas.microsoft.com/office/drawing/2014/main" id="{68A0BC67-C0DF-4028-A521-69E24C124E18}"/>
+                <a16:creationId xmlns:a16="http://schemas.microsoft.com/office/drawing/2014/main" id="{02284FAF-428A-4E6E-86E2-2734E7B3656D}"/>
               </a:ext>
             </a:extLst>
           </p:cNvPr>
@@ -6323,7 +6433,7 @@
           <p:cNvPr id="11" name="footer">
             <a:extLst xmlns:a="http://schemas.openxmlformats.org/drawingml/2006/main">
               <a:ext uri="{FF2B5EF4-FFF2-40B4-BE49-F238E27FC236}">
-                <a16:creationId xmlns:a16="http://schemas.microsoft.com/office/drawing/2014/main" id="{D99FFFAC-2C75-46F6-B08C-ECB9D9F2B252}"/>
+                <a16:creationId xmlns:a16="http://schemas.microsoft.com/office/drawing/2014/main" id="{32FF3982-AD5F-4D62-9480-1E7F1DBC9C58}"/>
               </a:ext>
             </a:extLst>
           </p:cNvPr>
@@ -6378,7 +6488,7 @@
           <p:cNvPr id="12" name="page-number">
             <a:extLst xmlns:a="http://schemas.openxmlformats.org/drawingml/2006/main">
               <a:ext uri="{FF2B5EF4-FFF2-40B4-BE49-F238E27FC236}">
-                <a16:creationId xmlns:a16="http://schemas.microsoft.com/office/drawing/2014/main" id="{1D73A6E1-1B23-46C8-A3C0-1D88E6B6205D}"/>
+                <a16:creationId xmlns:a16="http://schemas.microsoft.com/office/drawing/2014/main" id="{87589462-DC05-4F4B-A96E-251200DDA9D6}"/>
               </a:ext>
             </a:extLst>
           </p:cNvPr>
@@ -6431,7 +6541,7 @@
     </p:spTree>
     <p:extLst>
       <p:ext uri="{BB962C8B-B14F-4D97-AF65-F5344CB8AC3E}">
-        <p14:creationId xmlns:p14="http://schemas.microsoft.com/office/powerpoint/2010/main" val="711303951"/>
+        <p14:creationId xmlns:p14="http://schemas.microsoft.com/office/powerpoint/2010/main" val="668520150"/>
       </p:ext>
     </p:extLst>
   </p:cSld>
@@ -6470,7 +6580,7 @@
           <p:cNvPr id="11" name="slide-title">
             <a:extLst xmlns:a="http://schemas.openxmlformats.org/drawingml/2006/main">
               <a:ext uri="{FF2B5EF4-FFF2-40B4-BE49-F238E27FC236}">
-                <a16:creationId xmlns:a16="http://schemas.microsoft.com/office/drawing/2014/main" id="{6BA95B40-9290-435D-A65E-6253748C2A5A}"/>
+                <a16:creationId xmlns:a16="http://schemas.microsoft.com/office/drawing/2014/main" id="{CA7F5891-6091-40EC-9F34-7FADD7F614A1}"/>
               </a:ext>
             </a:extLst>
           </p:cNvPr>
@@ -6521,7 +6631,7 @@
           <p:cNvPr id="2" name="slide-subtitle">
             <a:extLst xmlns:a="http://schemas.openxmlformats.org/drawingml/2006/main">
               <a:ext uri="{FF2B5EF4-FFF2-40B4-BE49-F238E27FC236}">
-                <a16:creationId xmlns:a16="http://schemas.microsoft.com/office/drawing/2014/main" id="{FE8C4CC7-7026-4583-AC6A-2B9A859976BF}"/>
+                <a16:creationId xmlns:a16="http://schemas.microsoft.com/office/drawing/2014/main" id="{39150576-64D0-4A4E-BF44-F8787D79F1B5}"/>
               </a:ext>
             </a:extLst>
           </p:cNvPr>
@@ -6572,7 +6682,7 @@
           <p:cNvPr id="3" name="bullets">
             <a:extLst xmlns:a="http://schemas.openxmlformats.org/drawingml/2006/main">
               <a:ext uri="{FF2B5EF4-FFF2-40B4-BE49-F238E27FC236}">
-                <a16:creationId xmlns:a16="http://schemas.microsoft.com/office/drawing/2014/main" id="{A916832D-7F01-497A-8B65-FAE34C5FA753}"/>
+                <a16:creationId xmlns:a16="http://schemas.microsoft.com/office/drawing/2014/main" id="{4DB95657-74E8-4C04-8A0C-7406D852A02B}"/>
               </a:ext>
             </a:extLst>
           </p:cNvPr>
@@ -6659,7 +6769,7 @@
           <p:cNvPr id="4" name="ambient-glow">
             <a:extLst xmlns:a="http://schemas.openxmlformats.org/drawingml/2006/main">
               <a:ext uri="{FF2B5EF4-FFF2-40B4-BE49-F238E27FC236}">
-                <a16:creationId xmlns:a16="http://schemas.microsoft.com/office/drawing/2014/main" id="{9BD7EFD0-28E8-494E-8671-E4EE5F377597}"/>
+                <a16:creationId xmlns:a16="http://schemas.microsoft.com/office/drawing/2014/main" id="{69CF9BBD-CA25-4398-96B6-E251F697C5D3}"/>
               </a:ext>
             </a:extLst>
           </p:cNvPr>
@@ -6696,7 +6806,7 @@
           <p:cNvPr id="5" name="ambient-core">
             <a:extLst xmlns:a="http://schemas.openxmlformats.org/drawingml/2006/main">
               <a:ext uri="{FF2B5EF4-FFF2-40B4-BE49-F238E27FC236}">
-                <a16:creationId xmlns:a16="http://schemas.microsoft.com/office/drawing/2014/main" id="{7DF440E0-A45F-4884-8155-3187AF34E62C}"/>
+                <a16:creationId xmlns:a16="http://schemas.microsoft.com/office/drawing/2014/main" id="{B808D0AC-A201-44B6-B070-85CB7950CB4C}"/>
               </a:ext>
             </a:extLst>
           </p:cNvPr>
@@ -6733,7 +6843,7 @@
           <p:cNvPr id="6" name="section-number">
             <a:extLst xmlns:a="http://schemas.openxmlformats.org/drawingml/2006/main">
               <a:ext uri="{FF2B5EF4-FFF2-40B4-BE49-F238E27FC236}">
-                <a16:creationId xmlns:a16="http://schemas.microsoft.com/office/drawing/2014/main" id="{8D3F3C25-0BC8-4634-A10D-A1FE98356685}"/>
+                <a16:creationId xmlns:a16="http://schemas.microsoft.com/office/drawing/2014/main" id="{81002141-D6B6-40F6-8411-C4D21E6EFE9A}"/>
               </a:ext>
             </a:extLst>
           </p:cNvPr>
@@ -6784,7 +6894,7 @@
           <p:cNvPr id="7" name="eyebrow">
             <a:extLst xmlns:a="http://schemas.openxmlformats.org/drawingml/2006/main">
               <a:ext uri="{FF2B5EF4-FFF2-40B4-BE49-F238E27FC236}">
-                <a16:creationId xmlns:a16="http://schemas.microsoft.com/office/drawing/2014/main" id="{C54EA6DD-FA89-4569-95CF-EA559367FB64}"/>
+                <a16:creationId xmlns:a16="http://schemas.microsoft.com/office/drawing/2014/main" id="{19D9D516-CBDC-40C2-9047-5090D6186A82}"/>
               </a:ext>
             </a:extLst>
           </p:cNvPr>
@@ -6835,7 +6945,7 @@
           <p:cNvPr id="8" name="footer-rule">
             <a:extLst xmlns:a="http://schemas.openxmlformats.org/drawingml/2006/main">
               <a:ext uri="{FF2B5EF4-FFF2-40B4-BE49-F238E27FC236}">
-                <a16:creationId xmlns:a16="http://schemas.microsoft.com/office/drawing/2014/main" id="{D978B08C-E0FA-4DC5-A4CA-24EF9BEB73D0}"/>
+                <a16:creationId xmlns:a16="http://schemas.microsoft.com/office/drawing/2014/main" id="{5059D49C-2F7B-4ACE-961D-BCABFABB29FB}"/>
               </a:ext>
             </a:extLst>
           </p:cNvPr>
@@ -6868,7 +6978,7 @@
           <p:cNvPr id="9" name="footer">
             <a:extLst xmlns:a="http://schemas.openxmlformats.org/drawingml/2006/main">
               <a:ext uri="{FF2B5EF4-FFF2-40B4-BE49-F238E27FC236}">
-                <a16:creationId xmlns:a16="http://schemas.microsoft.com/office/drawing/2014/main" id="{75D8066A-55AD-47EB-9ADC-F9CCCA37B9B9}"/>
+                <a16:creationId xmlns:a16="http://schemas.microsoft.com/office/drawing/2014/main" id="{DA7A4830-D7CD-4320-8777-E2E950A720EC}"/>
               </a:ext>
             </a:extLst>
           </p:cNvPr>
@@ -6923,7 +7033,7 @@
           <p:cNvPr id="10" name="page-number">
             <a:extLst xmlns:a="http://schemas.openxmlformats.org/drawingml/2006/main">
               <a:ext uri="{FF2B5EF4-FFF2-40B4-BE49-F238E27FC236}">
-                <a16:creationId xmlns:a16="http://schemas.microsoft.com/office/drawing/2014/main" id="{C77A3787-7A36-4820-B200-294BC4DF0745}"/>
+                <a16:creationId xmlns:a16="http://schemas.microsoft.com/office/drawing/2014/main" id="{6F6450CB-6F20-43BA-90A6-EE377BACDDAE}"/>
               </a:ext>
             </a:extLst>
           </p:cNvPr>
@@ -6976,7 +7086,7 @@
     </p:spTree>
     <p:extLst>
       <p:ext uri="{BB962C8B-B14F-4D97-AF65-F5344CB8AC3E}">
-        <p14:creationId xmlns:p14="http://schemas.microsoft.com/office/powerpoint/2010/main" val="383801454"/>
+        <p14:creationId xmlns:p14="http://schemas.microsoft.com/office/powerpoint/2010/main" val="21039654"/>
       </p:ext>
     </p:extLst>
   </p:cSld>
@@ -7007,7 +7117,7 @@
           <p:cNvPr id="10" name="slide-title">
             <a:extLst xmlns:a="http://schemas.openxmlformats.org/drawingml/2006/main">
               <a:ext uri="{FF2B5EF4-FFF2-40B4-BE49-F238E27FC236}">
-                <a16:creationId xmlns:a16="http://schemas.microsoft.com/office/drawing/2014/main" id="{55F9A520-F08F-4D9E-85D6-B75BC7C077D3}"/>
+                <a16:creationId xmlns:a16="http://schemas.microsoft.com/office/drawing/2014/main" id="{E5431F9E-0AF6-4148-8A8B-97664B81E3A3}"/>
               </a:ext>
             </a:extLst>
           </p:cNvPr>
@@ -7058,7 +7168,7 @@
           <p:cNvPr id="2" name="visual-claim">
             <a:extLst xmlns:a="http://schemas.openxmlformats.org/drawingml/2006/main">
               <a:ext uri="{FF2B5EF4-FFF2-40B4-BE49-F238E27FC236}">
-                <a16:creationId xmlns:a16="http://schemas.microsoft.com/office/drawing/2014/main" id="{D030A6C5-F410-46E9-A61C-409F78B5A9C1}"/>
+                <a16:creationId xmlns:a16="http://schemas.microsoft.com/office/drawing/2014/main" id="{6D94BD8B-BB6D-4AF4-9D6E-777DFC56085F}"/>
               </a:ext>
             </a:extLst>
           </p:cNvPr>
@@ -7109,7 +7219,7 @@
           <p:cNvPr id="3" name="image-surface">
             <a:extLst xmlns:a="http://schemas.openxmlformats.org/drawingml/2006/main">
               <a:ext uri="{FF2B5EF4-FFF2-40B4-BE49-F238E27FC236}">
-                <a16:creationId xmlns:a16="http://schemas.microsoft.com/office/drawing/2014/main" id="{24454482-9449-4A68-BD44-169CF46530E6}"/>
+                <a16:creationId xmlns:a16="http://schemas.microsoft.com/office/drawing/2014/main" id="{BDBB2774-B96E-489A-B138-4D8AEF5CCA9B}"/>
               </a:ext>
             </a:extLst>
           </p:cNvPr>
@@ -7148,7 +7258,7 @@
           <p:nvPr/>
         </p:nvPicPr>
         <p:blipFill>
-          <a:blip xmlns:r="http://schemas.openxmlformats.org/officeDocument/2006/relationships" xmlns:a="http://schemas.openxmlformats.org/drawingml/2006/main" r:embed="Rc463f8076f48410f"/>
+          <a:blip xmlns:r="http://schemas.openxmlformats.org/officeDocument/2006/relationships" xmlns:a="http://schemas.openxmlformats.org/drawingml/2006/main" r:embed="Ra0c2a2639c71482d"/>
           <a:stretch xmlns:a="http://schemas.openxmlformats.org/drawingml/2006/main"/>
         </p:blipFill>
         <p:spPr>
@@ -7166,7 +7276,7 @@
           <p:cNvPr id="5" name="image-caption">
             <a:extLst xmlns:a="http://schemas.openxmlformats.org/drawingml/2006/main">
               <a:ext uri="{FF2B5EF4-FFF2-40B4-BE49-F238E27FC236}">
-                <a16:creationId xmlns:a16="http://schemas.microsoft.com/office/drawing/2014/main" id="{78F64461-DB26-4844-B85F-5CA6756E13C7}"/>
+                <a16:creationId xmlns:a16="http://schemas.microsoft.com/office/drawing/2014/main" id="{66E264F3-AD59-4638-B762-07E7CA2C5B26}"/>
               </a:ext>
             </a:extLst>
           </p:cNvPr>
@@ -7217,7 +7327,7 @@
           <p:cNvPr id="6" name="eyebrow">
             <a:extLst xmlns:a="http://schemas.openxmlformats.org/drawingml/2006/main">
               <a:ext uri="{FF2B5EF4-FFF2-40B4-BE49-F238E27FC236}">
-                <a16:creationId xmlns:a16="http://schemas.microsoft.com/office/drawing/2014/main" id="{16B165A4-63DE-4C5F-9E86-FFC065922BD2}"/>
+                <a16:creationId xmlns:a16="http://schemas.microsoft.com/office/drawing/2014/main" id="{F0DFCB9B-EA56-473E-839E-937F15748A96}"/>
               </a:ext>
             </a:extLst>
           </p:cNvPr>
@@ -7268,7 +7378,7 @@
           <p:cNvPr id="7" name="footer-rule">
             <a:extLst xmlns:a="http://schemas.openxmlformats.org/drawingml/2006/main">
               <a:ext uri="{FF2B5EF4-FFF2-40B4-BE49-F238E27FC236}">
-                <a16:creationId xmlns:a16="http://schemas.microsoft.com/office/drawing/2014/main" id="{BD72494F-8D03-47DF-94D2-97D62EE6A6B0}"/>
+                <a16:creationId xmlns:a16="http://schemas.microsoft.com/office/drawing/2014/main" id="{FA4A5D13-F159-4C2E-95E6-91D3A6B9E7BE}"/>
               </a:ext>
             </a:extLst>
           </p:cNvPr>
@@ -7301,7 +7411,7 @@
           <p:cNvPr id="8" name="footer">
             <a:extLst xmlns:a="http://schemas.openxmlformats.org/drawingml/2006/main">
               <a:ext uri="{FF2B5EF4-FFF2-40B4-BE49-F238E27FC236}">
-                <a16:creationId xmlns:a16="http://schemas.microsoft.com/office/drawing/2014/main" id="{AF46AE38-65A7-4F72-AFD5-FF8FB2CBBA8D}"/>
+                <a16:creationId xmlns:a16="http://schemas.microsoft.com/office/drawing/2014/main" id="{800B2B23-B70E-4549-B3D9-07FEE2AC51C1}"/>
               </a:ext>
             </a:extLst>
           </p:cNvPr>
@@ -7356,7 +7466,7 @@
           <p:cNvPr id="9" name="page-number">
             <a:extLst xmlns:a="http://schemas.openxmlformats.org/drawingml/2006/main">
               <a:ext uri="{FF2B5EF4-FFF2-40B4-BE49-F238E27FC236}">
-                <a16:creationId xmlns:a16="http://schemas.microsoft.com/office/drawing/2014/main" id="{BCEA44E9-78E8-47CB-A320-6DFD91FA6E0A}"/>
+                <a16:creationId xmlns:a16="http://schemas.microsoft.com/office/drawing/2014/main" id="{FF33D102-FA67-45AA-9C6E-12F79B1037AA}"/>
               </a:ext>
             </a:extLst>
           </p:cNvPr>
@@ -7409,7 +7519,7 @@
     </p:spTree>
     <p:extLst>
       <p:ext uri="{BB962C8B-B14F-4D97-AF65-F5344CB8AC3E}">
-        <p14:creationId xmlns:p14="http://schemas.microsoft.com/office/powerpoint/2010/main" val="1867881638"/>
+        <p14:creationId xmlns:p14="http://schemas.microsoft.com/office/powerpoint/2010/main" val="280936556"/>
       </p:ext>
     </p:extLst>
   </p:cSld>
@@ -7440,7 +7550,7 @@
           <p:cNvPr id="11" name="slide-title">
             <a:extLst xmlns:a="http://schemas.openxmlformats.org/drawingml/2006/main">
               <a:ext uri="{FF2B5EF4-FFF2-40B4-BE49-F238E27FC236}">
-                <a16:creationId xmlns:a16="http://schemas.microsoft.com/office/drawing/2014/main" id="{FFBB80D3-CD58-4E29-AF97-390D59718428}"/>
+                <a16:creationId xmlns:a16="http://schemas.microsoft.com/office/drawing/2014/main" id="{56F7C8BC-4229-426F-BF28-4528E6B73233}"/>
               </a:ext>
             </a:extLst>
           </p:cNvPr>
@@ -7491,7 +7601,7 @@
           <p:cNvPr id="2" name="slide-subtitle">
             <a:extLst xmlns:a="http://schemas.openxmlformats.org/drawingml/2006/main">
               <a:ext uri="{FF2B5EF4-FFF2-40B4-BE49-F238E27FC236}">
-                <a16:creationId xmlns:a16="http://schemas.microsoft.com/office/drawing/2014/main" id="{B845F0E7-A249-48EF-BA34-AFBE34368820}"/>
+                <a16:creationId xmlns:a16="http://schemas.microsoft.com/office/drawing/2014/main" id="{14867803-8CB2-49C4-A442-F1D7193AD1B2}"/>
               </a:ext>
             </a:extLst>
           </p:cNvPr>
@@ -7532,7 +7642,7 @@
                   <a:srgbClr val="5C6F86"/>
                 </a:solidFill>
               </a:rPr>
-              <a:t>DuckDB UI abre na porta privada 4213 sem bloquear nem modificar o banco usado pelo dbt.</a:t>
+              <a:t>O explorador autoral abre na porta privada 4213 sem modificar o banco usado pelo dbt.</a:t>
             </a:r>
           </a:p>
         </p:txBody>
@@ -7542,7 +7652,7 @@
           <p:cNvPr id="3" name="bullets">
             <a:extLst xmlns:a="http://schemas.openxmlformats.org/drawingml/2006/main">
               <a:ext uri="{FF2B5EF4-FFF2-40B4-BE49-F238E27FC236}">
-                <a16:creationId xmlns:a16="http://schemas.microsoft.com/office/drawing/2014/main" id="{23BDA795-FCC8-4AB9-BAB5-8C074EC2C1D5}"/>
+                <a16:creationId xmlns:a16="http://schemas.microsoft.com/office/drawing/2014/main" id="{28F1F3D1-323B-4C7A-B715-45B1949782AA}"/>
               </a:ext>
             </a:extLst>
           </p:cNvPr>
@@ -7583,7 +7693,7 @@
                   <a:srgbClr val="0B1F3A"/>
                 </a:solidFill>
               </a:rPr>
-              <a:t>• Execute depois do checkpoint</a:t>
+              <a:t>• Snapshot somente leitura</a:t>
             </a:r>
           </a:p>
           <a:p xmlns:a="http://schemas.openxmlformats.org/drawingml/2006/main">
@@ -7629,7 +7739,7 @@
           <p:cNvPr id="4" name="ambient-glow">
             <a:extLst xmlns:a="http://schemas.openxmlformats.org/drawingml/2006/main">
               <a:ext uri="{FF2B5EF4-FFF2-40B4-BE49-F238E27FC236}">
-                <a16:creationId xmlns:a16="http://schemas.microsoft.com/office/drawing/2014/main" id="{9D05A191-1E49-41AB-87D3-4F0DD1C9A689}"/>
+                <a16:creationId xmlns:a16="http://schemas.microsoft.com/office/drawing/2014/main" id="{6660E063-B4CE-4BEC-8205-071F11451EC4}"/>
               </a:ext>
             </a:extLst>
           </p:cNvPr>
@@ -7666,7 +7776,7 @@
           <p:cNvPr id="5" name="ambient-core">
             <a:extLst xmlns:a="http://schemas.openxmlformats.org/drawingml/2006/main">
               <a:ext uri="{FF2B5EF4-FFF2-40B4-BE49-F238E27FC236}">
-                <a16:creationId xmlns:a16="http://schemas.microsoft.com/office/drawing/2014/main" id="{333742DF-8B8F-4AFE-9ADA-89640C3EF368}"/>
+                <a16:creationId xmlns:a16="http://schemas.microsoft.com/office/drawing/2014/main" id="{ABFE4F80-E3CD-4A98-A16B-63D9B8A4D2DE}"/>
               </a:ext>
             </a:extLst>
           </p:cNvPr>
@@ -7703,7 +7813,7 @@
           <p:cNvPr id="6" name="section-number">
             <a:extLst xmlns:a="http://schemas.openxmlformats.org/drawingml/2006/main">
               <a:ext uri="{FF2B5EF4-FFF2-40B4-BE49-F238E27FC236}">
-                <a16:creationId xmlns:a16="http://schemas.microsoft.com/office/drawing/2014/main" id="{F9C0487B-8F03-448D-BE9C-F69882C041E2}"/>
+                <a16:creationId xmlns:a16="http://schemas.microsoft.com/office/drawing/2014/main" id="{3AD57237-7948-4857-B8BB-CACD3A5BF195}"/>
               </a:ext>
             </a:extLst>
           </p:cNvPr>
@@ -7754,7 +7864,7 @@
           <p:cNvPr id="7" name="eyebrow">
             <a:extLst xmlns:a="http://schemas.openxmlformats.org/drawingml/2006/main">
               <a:ext uri="{FF2B5EF4-FFF2-40B4-BE49-F238E27FC236}">
-                <a16:creationId xmlns:a16="http://schemas.microsoft.com/office/drawing/2014/main" id="{C723F1EC-0E57-4C0E-8EF4-809EB70DDBF5}"/>
+                <a16:creationId xmlns:a16="http://schemas.microsoft.com/office/drawing/2014/main" id="{93870D83-9AC2-4E21-802D-199555DC7F81}"/>
               </a:ext>
             </a:extLst>
           </p:cNvPr>
@@ -7805,7 +7915,7 @@
           <p:cNvPr id="8" name="footer-rule">
             <a:extLst xmlns:a="http://schemas.openxmlformats.org/drawingml/2006/main">
               <a:ext uri="{FF2B5EF4-FFF2-40B4-BE49-F238E27FC236}">
-                <a16:creationId xmlns:a16="http://schemas.microsoft.com/office/drawing/2014/main" id="{209A9B78-D1BE-47D7-A25B-60566AF78AAD}"/>
+                <a16:creationId xmlns:a16="http://schemas.microsoft.com/office/drawing/2014/main" id="{5A6505A3-0516-47CA-883C-AE0651CBC8A0}"/>
               </a:ext>
             </a:extLst>
           </p:cNvPr>
@@ -7838,7 +7948,7 @@
           <p:cNvPr id="9" name="footer">
             <a:extLst xmlns:a="http://schemas.openxmlformats.org/drawingml/2006/main">
               <a:ext uri="{FF2B5EF4-FFF2-40B4-BE49-F238E27FC236}">
-                <a16:creationId xmlns:a16="http://schemas.microsoft.com/office/drawing/2014/main" id="{9A030E42-F79C-4787-B439-63F7572B2A67}"/>
+                <a16:creationId xmlns:a16="http://schemas.microsoft.com/office/drawing/2014/main" id="{AF776831-6175-46FA-920D-0583295810BF}"/>
               </a:ext>
             </a:extLst>
           </p:cNvPr>
@@ -7893,7 +8003,7 @@
           <p:cNvPr id="10" name="page-number">
             <a:extLst xmlns:a="http://schemas.openxmlformats.org/drawingml/2006/main">
               <a:ext uri="{FF2B5EF4-FFF2-40B4-BE49-F238E27FC236}">
-                <a16:creationId xmlns:a16="http://schemas.microsoft.com/office/drawing/2014/main" id="{497B3FD2-03F2-4C3E-854F-16B8BD13E8F7}"/>
+                <a16:creationId xmlns:a16="http://schemas.microsoft.com/office/drawing/2014/main" id="{0D01CC7F-69E5-42D1-BA30-28DDB608ACC5}"/>
               </a:ext>
             </a:extLst>
           </p:cNvPr>
@@ -7946,7 +8056,7 @@
     </p:spTree>
     <p:extLst>
       <p:ext uri="{BB962C8B-B14F-4D97-AF65-F5344CB8AC3E}">
-        <p14:creationId xmlns:p14="http://schemas.microsoft.com/office/powerpoint/2010/main" val="1257307493"/>
+        <p14:creationId xmlns:p14="http://schemas.microsoft.com/office/powerpoint/2010/main" val="2115848414"/>
       </p:ext>
     </p:extLst>
   </p:cSld>
@@ -7985,7 +8095,7 @@
           <p:cNvPr id="13" name="slide-title">
             <a:extLst xmlns:a="http://schemas.openxmlformats.org/drawingml/2006/main">
               <a:ext uri="{FF2B5EF4-FFF2-40B4-BE49-F238E27FC236}">
-                <a16:creationId xmlns:a16="http://schemas.microsoft.com/office/drawing/2014/main" id="{378EE93E-2021-4DEC-8E03-C9BBA1390992}"/>
+                <a16:creationId xmlns:a16="http://schemas.microsoft.com/office/drawing/2014/main" id="{79475C0E-C168-444C-B200-4F2FA435BB73}"/>
               </a:ext>
             </a:extLst>
           </p:cNvPr>
@@ -8036,7 +8146,7 @@
           <p:cNvPr id="2" name="flow-1">
             <a:extLst xmlns:a="http://schemas.openxmlformats.org/drawingml/2006/main">
               <a:ext uri="{FF2B5EF4-FFF2-40B4-BE49-F238E27FC236}">
-                <a16:creationId xmlns:a16="http://schemas.microsoft.com/office/drawing/2014/main" id="{8E27CE16-1191-4364-ACC8-CE1BD70E2770}"/>
+                <a16:creationId xmlns:a16="http://schemas.microsoft.com/office/drawing/2014/main" id="{FF382106-DF4C-4B9A-BD73-A56A51D860EF}"/>
               </a:ext>
             </a:extLst>
           </p:cNvPr>
@@ -8093,7 +8203,7 @@
           <p:cNvPr id="3" name="flow-2">
             <a:extLst xmlns:a="http://schemas.openxmlformats.org/drawingml/2006/main">
               <a:ext uri="{FF2B5EF4-FFF2-40B4-BE49-F238E27FC236}">
-                <a16:creationId xmlns:a16="http://schemas.microsoft.com/office/drawing/2014/main" id="{011D50B5-1AA5-4352-BDDA-6D05FB7C9F3F}"/>
+                <a16:creationId xmlns:a16="http://schemas.microsoft.com/office/drawing/2014/main" id="{5BC3C5CF-F1D9-440A-AF63-7B445081D1E2}"/>
               </a:ext>
             </a:extLst>
           </p:cNvPr>
@@ -8150,7 +8260,7 @@
           <p:cNvPr id="4" name="flow-3">
             <a:extLst xmlns:a="http://schemas.openxmlformats.org/drawingml/2006/main">
               <a:ext uri="{FF2B5EF4-FFF2-40B4-BE49-F238E27FC236}">
-                <a16:creationId xmlns:a16="http://schemas.microsoft.com/office/drawing/2014/main" id="{EFB0E081-A919-4005-A02A-D418FA758468}"/>
+                <a16:creationId xmlns:a16="http://schemas.microsoft.com/office/drawing/2014/main" id="{67806E6B-10D7-4B34-B08E-2069FDE92F38}"/>
               </a:ext>
             </a:extLst>
           </p:cNvPr>
@@ -8197,7 +8307,7 @@
                   <a:srgbClr val="FFFFFF"/>
                 </a:solidFill>
               </a:rPr>
-              <a:t>DuckDB UI</a:t>
+              <a:t>explorador</a:t>
             </a:r>
           </a:p>
         </p:txBody>
@@ -8207,7 +8317,7 @@
           <p:cNvPr id="5" name="flow-4">
             <a:extLst xmlns:a="http://schemas.openxmlformats.org/drawingml/2006/main">
               <a:ext uri="{FF2B5EF4-FFF2-40B4-BE49-F238E27FC236}">
-                <a16:creationId xmlns:a16="http://schemas.microsoft.com/office/drawing/2014/main" id="{63AF95BB-5443-421F-9146-457A5CE41C2B}"/>
+                <a16:creationId xmlns:a16="http://schemas.microsoft.com/office/drawing/2014/main" id="{F1BEA1A4-267B-457A-94F6-7307E414792B}"/>
               </a:ext>
             </a:extLst>
           </p:cNvPr>
@@ -8342,7 +8452,7 @@
           <p:cNvPr id="9" name="eyebrow">
             <a:extLst xmlns:a="http://schemas.openxmlformats.org/drawingml/2006/main">
               <a:ext uri="{FF2B5EF4-FFF2-40B4-BE49-F238E27FC236}">
-                <a16:creationId xmlns:a16="http://schemas.microsoft.com/office/drawing/2014/main" id="{66E8346F-16B3-40F0-95C4-B8331F63D7A4}"/>
+                <a16:creationId xmlns:a16="http://schemas.microsoft.com/office/drawing/2014/main" id="{CE15A3CD-33D0-4904-81EA-C607C4674204}"/>
               </a:ext>
             </a:extLst>
           </p:cNvPr>
@@ -8393,7 +8503,7 @@
           <p:cNvPr id="10" name="footer-rule">
             <a:extLst xmlns:a="http://schemas.openxmlformats.org/drawingml/2006/main">
               <a:ext uri="{FF2B5EF4-FFF2-40B4-BE49-F238E27FC236}">
-                <a16:creationId xmlns:a16="http://schemas.microsoft.com/office/drawing/2014/main" id="{AE9A7DED-9472-480C-9C85-69D840EFC636}"/>
+                <a16:creationId xmlns:a16="http://schemas.microsoft.com/office/drawing/2014/main" id="{2CD5A576-0793-42A8-8FCE-C1971B4400D2}"/>
               </a:ext>
             </a:extLst>
           </p:cNvPr>
@@ -8426,7 +8536,7 @@
           <p:cNvPr id="11" name="footer">
             <a:extLst xmlns:a="http://schemas.openxmlformats.org/drawingml/2006/main">
               <a:ext uri="{FF2B5EF4-FFF2-40B4-BE49-F238E27FC236}">
-                <a16:creationId xmlns:a16="http://schemas.microsoft.com/office/drawing/2014/main" id="{7A454C72-E356-47AC-880E-DB4DE820FC73}"/>
+                <a16:creationId xmlns:a16="http://schemas.microsoft.com/office/drawing/2014/main" id="{7179C047-1101-446B-A8FC-CA3E0645C8FD}"/>
               </a:ext>
             </a:extLst>
           </p:cNvPr>
@@ -8481,7 +8591,7 @@
           <p:cNvPr id="12" name="page-number">
             <a:extLst xmlns:a="http://schemas.openxmlformats.org/drawingml/2006/main">
               <a:ext uri="{FF2B5EF4-FFF2-40B4-BE49-F238E27FC236}">
-                <a16:creationId xmlns:a16="http://schemas.microsoft.com/office/drawing/2014/main" id="{1764148F-6C1E-42BD-A968-5B11993D1207}"/>
+                <a16:creationId xmlns:a16="http://schemas.microsoft.com/office/drawing/2014/main" id="{4FF90C79-CF4E-4A59-871C-368D6A24909D}"/>
               </a:ext>
             </a:extLst>
           </p:cNvPr>
@@ -8534,7 +8644,7 @@
     </p:spTree>
     <p:extLst>
       <p:ext uri="{BB962C8B-B14F-4D97-AF65-F5344CB8AC3E}">
-        <p14:creationId xmlns:p14="http://schemas.microsoft.com/office/powerpoint/2010/main" val="560762889"/>
+        <p14:creationId xmlns:p14="http://schemas.microsoft.com/office/powerpoint/2010/main" val="2025010219"/>
       </p:ext>
     </p:extLst>
   </p:cSld>
@@ -8573,7 +8683,7 @@
           <p:cNvPr id="9" name="slide-title">
             <a:extLst xmlns:a="http://schemas.openxmlformats.org/drawingml/2006/main">
               <a:ext uri="{FF2B5EF4-FFF2-40B4-BE49-F238E27FC236}">
-                <a16:creationId xmlns:a16="http://schemas.microsoft.com/office/drawing/2014/main" id="{502AC5E9-C6A8-4CE3-85F5-6F64FB353811}"/>
+                <a16:creationId xmlns:a16="http://schemas.microsoft.com/office/drawing/2014/main" id="{F467EBE4-EC65-4EBA-949E-8E921CFEE792}"/>
               </a:ext>
             </a:extLst>
           </p:cNvPr>
@@ -8624,7 +8734,7 @@
           <p:cNvPr id="2" name="code-surface">
             <a:extLst xmlns:a="http://schemas.openxmlformats.org/drawingml/2006/main">
               <a:ext uri="{FF2B5EF4-FFF2-40B4-BE49-F238E27FC236}">
-                <a16:creationId xmlns:a16="http://schemas.microsoft.com/office/drawing/2014/main" id="{02285E99-0936-4913-926B-C28BC54AF476}"/>
+                <a16:creationId xmlns:a16="http://schemas.microsoft.com/office/drawing/2014/main" id="{7DB10D8D-A9F5-4B28-B220-2C954C94F451}"/>
               </a:ext>
             </a:extLst>
           </p:cNvPr>
@@ -8659,7 +8769,7 @@
           <p:cNvPr id="3" name="command">
             <a:extLst xmlns:a="http://schemas.openxmlformats.org/drawingml/2006/main">
               <a:ext uri="{FF2B5EF4-FFF2-40B4-BE49-F238E27FC236}">
-                <a16:creationId xmlns:a16="http://schemas.microsoft.com/office/drawing/2014/main" id="{A8FC6898-B120-4D76-BEDD-570093872553}"/>
+                <a16:creationId xmlns:a16="http://schemas.microsoft.com/office/drawing/2014/main" id="{9C8D05B5-55B9-4E3C-AB8F-86E67138B052}"/>
               </a:ext>
             </a:extLst>
           </p:cNvPr>
@@ -8746,7 +8856,7 @@
           <p:cNvPr id="4" name="command-help">
             <a:extLst xmlns:a="http://schemas.openxmlformats.org/drawingml/2006/main">
               <a:ext uri="{FF2B5EF4-FFF2-40B4-BE49-F238E27FC236}">
-                <a16:creationId xmlns:a16="http://schemas.microsoft.com/office/drawing/2014/main" id="{5CC5452B-D51F-4CD7-83B0-565961E910FD}"/>
+                <a16:creationId xmlns:a16="http://schemas.microsoft.com/office/drawing/2014/main" id="{63D83F0E-9AAB-4753-ADAA-417005010F18}"/>
               </a:ext>
             </a:extLst>
           </p:cNvPr>
@@ -8797,7 +8907,7 @@
           <p:cNvPr id="5" name="eyebrow">
             <a:extLst xmlns:a="http://schemas.openxmlformats.org/drawingml/2006/main">
               <a:ext uri="{FF2B5EF4-FFF2-40B4-BE49-F238E27FC236}">
-                <a16:creationId xmlns:a16="http://schemas.microsoft.com/office/drawing/2014/main" id="{5F13D0F7-FE02-421C-8ED8-A0CEE45DAD81}"/>
+                <a16:creationId xmlns:a16="http://schemas.microsoft.com/office/drawing/2014/main" id="{344823D3-72E1-4E82-BE99-128C25E792B5}"/>
               </a:ext>
             </a:extLst>
           </p:cNvPr>
@@ -8848,7 +8958,7 @@
           <p:cNvPr id="6" name="footer-rule">
             <a:extLst xmlns:a="http://schemas.openxmlformats.org/drawingml/2006/main">
               <a:ext uri="{FF2B5EF4-FFF2-40B4-BE49-F238E27FC236}">
-                <a16:creationId xmlns:a16="http://schemas.microsoft.com/office/drawing/2014/main" id="{798154F5-7A9D-4E37-B4EF-E68CE696C972}"/>
+                <a16:creationId xmlns:a16="http://schemas.microsoft.com/office/drawing/2014/main" id="{5955FEA9-A5C4-4CC6-BD22-B31D2358570A}"/>
               </a:ext>
             </a:extLst>
           </p:cNvPr>
@@ -8881,7 +8991,7 @@
           <p:cNvPr id="7" name="footer">
             <a:extLst xmlns:a="http://schemas.openxmlformats.org/drawingml/2006/main">
               <a:ext uri="{FF2B5EF4-FFF2-40B4-BE49-F238E27FC236}">
-                <a16:creationId xmlns:a16="http://schemas.microsoft.com/office/drawing/2014/main" id="{C96D0AEC-BFCF-4097-8003-3079ADCD3A3E}"/>
+                <a16:creationId xmlns:a16="http://schemas.microsoft.com/office/drawing/2014/main" id="{C7CEA63D-7CB2-4063-B2AB-6B19D80E3C19}"/>
               </a:ext>
             </a:extLst>
           </p:cNvPr>
@@ -8936,7 +9046,7 @@
           <p:cNvPr id="8" name="page-number">
             <a:extLst xmlns:a="http://schemas.openxmlformats.org/drawingml/2006/main">
               <a:ext uri="{FF2B5EF4-FFF2-40B4-BE49-F238E27FC236}">
-                <a16:creationId xmlns:a16="http://schemas.microsoft.com/office/drawing/2014/main" id="{500BAFB2-04DA-45EE-A2C4-19C883B0D59C}"/>
+                <a16:creationId xmlns:a16="http://schemas.microsoft.com/office/drawing/2014/main" id="{459428BD-F24B-4281-8C83-141EF8D76F56}"/>
               </a:ext>
             </a:extLst>
           </p:cNvPr>
@@ -8989,7 +9099,7 @@
     </p:spTree>
     <p:extLst>
       <p:ext uri="{BB962C8B-B14F-4D97-AF65-F5344CB8AC3E}">
-        <p14:creationId xmlns:p14="http://schemas.microsoft.com/office/powerpoint/2010/main" val="554509972"/>
+        <p14:creationId xmlns:p14="http://schemas.microsoft.com/office/powerpoint/2010/main" val="405607996"/>
       </p:ext>
     </p:extLst>
   </p:cSld>
@@ -9020,7 +9130,7 @@
           <p:cNvPr id="14" name="slide-title">
             <a:extLst xmlns:a="http://schemas.openxmlformats.org/drawingml/2006/main">
               <a:ext uri="{FF2B5EF4-FFF2-40B4-BE49-F238E27FC236}">
-                <a16:creationId xmlns:a16="http://schemas.microsoft.com/office/drawing/2014/main" id="{0CE5D42A-3154-4096-A28B-7DB123AB1B90}"/>
+                <a16:creationId xmlns:a16="http://schemas.microsoft.com/office/drawing/2014/main" id="{D8843C35-D569-4CB9-90B7-C29C591A9932}"/>
               </a:ext>
             </a:extLst>
           </p:cNvPr>
@@ -9071,7 +9181,7 @@
           <p:cNvPr id="2" name="step-num-1">
             <a:extLst xmlns:a="http://schemas.openxmlformats.org/drawingml/2006/main">
               <a:ext uri="{FF2B5EF4-FFF2-40B4-BE49-F238E27FC236}">
-                <a16:creationId xmlns:a16="http://schemas.microsoft.com/office/drawing/2014/main" id="{37D9C54D-B372-4264-BBA8-C22E2791DE5D}"/>
+                <a16:creationId xmlns:a16="http://schemas.microsoft.com/office/drawing/2014/main" id="{90A6C429-4BFE-4B27-A26F-1804B2CF27F2}"/>
               </a:ext>
             </a:extLst>
           </p:cNvPr>
@@ -9122,7 +9232,7 @@
           <p:cNvPr id="3" name="step-label-1">
             <a:extLst xmlns:a="http://schemas.openxmlformats.org/drawingml/2006/main">
               <a:ext uri="{FF2B5EF4-FFF2-40B4-BE49-F238E27FC236}">
-                <a16:creationId xmlns:a16="http://schemas.microsoft.com/office/drawing/2014/main" id="{E987139C-FF54-4287-9BC2-93C201F4DE44}"/>
+                <a16:creationId xmlns:a16="http://schemas.microsoft.com/office/drawing/2014/main" id="{FA798012-1725-4012-83B2-8F009681D0CC}"/>
               </a:ext>
             </a:extLst>
           </p:cNvPr>
@@ -9173,7 +9283,7 @@
           <p:cNvPr id="4" name="step-line-1">
             <a:extLst xmlns:a="http://schemas.openxmlformats.org/drawingml/2006/main">
               <a:ext uri="{FF2B5EF4-FFF2-40B4-BE49-F238E27FC236}">
-                <a16:creationId xmlns:a16="http://schemas.microsoft.com/office/drawing/2014/main" id="{DB489D0B-A0F0-491A-B395-CA8D594FA558}"/>
+                <a16:creationId xmlns:a16="http://schemas.microsoft.com/office/drawing/2014/main" id="{1CF2E536-F121-44CD-83E6-7DE6461B3A7B}"/>
               </a:ext>
             </a:extLst>
           </p:cNvPr>
@@ -9204,7 +9314,7 @@
           <p:cNvPr id="5" name="step-num-2">
             <a:extLst xmlns:a="http://schemas.openxmlformats.org/drawingml/2006/main">
               <a:ext uri="{FF2B5EF4-FFF2-40B4-BE49-F238E27FC236}">
-                <a16:creationId xmlns:a16="http://schemas.microsoft.com/office/drawing/2014/main" id="{030AEB57-3031-4BE3-BA9E-54AB7469B75C}"/>
+                <a16:creationId xmlns:a16="http://schemas.microsoft.com/office/drawing/2014/main" id="{52EAA22D-F48A-463C-887B-08B90D0F89B8}"/>
               </a:ext>
             </a:extLst>
           </p:cNvPr>
@@ -9255,7 +9365,7 @@
           <p:cNvPr id="6" name="step-label-2">
             <a:extLst xmlns:a="http://schemas.openxmlformats.org/drawingml/2006/main">
               <a:ext uri="{FF2B5EF4-FFF2-40B4-BE49-F238E27FC236}">
-                <a16:creationId xmlns:a16="http://schemas.microsoft.com/office/drawing/2014/main" id="{11523468-ABE7-4FEC-9EE9-10272DF067D5}"/>
+                <a16:creationId xmlns:a16="http://schemas.microsoft.com/office/drawing/2014/main" id="{8FDF7C65-6790-4EFF-9661-041B7DEAE193}"/>
               </a:ext>
             </a:extLst>
           </p:cNvPr>
@@ -9306,7 +9416,7 @@
           <p:cNvPr id="7" name="step-line-2">
             <a:extLst xmlns:a="http://schemas.openxmlformats.org/drawingml/2006/main">
               <a:ext uri="{FF2B5EF4-FFF2-40B4-BE49-F238E27FC236}">
-                <a16:creationId xmlns:a16="http://schemas.microsoft.com/office/drawing/2014/main" id="{7DE5663E-90E1-44C8-9003-95CD97439A71}"/>
+                <a16:creationId xmlns:a16="http://schemas.microsoft.com/office/drawing/2014/main" id="{2F4421E3-2BD1-44C4-AE20-5F717F56CB43}"/>
               </a:ext>
             </a:extLst>
           </p:cNvPr>
@@ -9337,7 +9447,7 @@
           <p:cNvPr id="8" name="step-num-3">
             <a:extLst xmlns:a="http://schemas.openxmlformats.org/drawingml/2006/main">
               <a:ext uri="{FF2B5EF4-FFF2-40B4-BE49-F238E27FC236}">
-                <a16:creationId xmlns:a16="http://schemas.microsoft.com/office/drawing/2014/main" id="{2CF2012B-D4FA-48B3-9B1A-3C3ECA2C08FE}"/>
+                <a16:creationId xmlns:a16="http://schemas.microsoft.com/office/drawing/2014/main" id="{E30825D0-8885-4A79-B447-5023E62B775D}"/>
               </a:ext>
             </a:extLst>
           </p:cNvPr>
@@ -9388,7 +9498,7 @@
           <p:cNvPr id="9" name="step-label-3">
             <a:extLst xmlns:a="http://schemas.openxmlformats.org/drawingml/2006/main">
               <a:ext uri="{FF2B5EF4-FFF2-40B4-BE49-F238E27FC236}">
-                <a16:creationId xmlns:a16="http://schemas.microsoft.com/office/drawing/2014/main" id="{10BF5CC6-FBCC-494B-80CF-D91DB5F3E323}"/>
+                <a16:creationId xmlns:a16="http://schemas.microsoft.com/office/drawing/2014/main" id="{7356B20F-E4B8-4D4C-AE7E-891969EA379F}"/>
               </a:ext>
             </a:extLst>
           </p:cNvPr>
@@ -9429,7 +9539,7 @@
                   <a:srgbClr val="0B1F3A"/>
                 </a:solidFill>
               </a:rPr>
-              <a:t>DuckDB UI na porta privada 4213</a:t>
+              <a:t>Explorador na porta privada 4213</a:t>
             </a:r>
           </a:p>
         </p:txBody>
@@ -9439,7 +9549,7 @@
           <p:cNvPr id="10" name="eyebrow">
             <a:extLst xmlns:a="http://schemas.openxmlformats.org/drawingml/2006/main">
               <a:ext uri="{FF2B5EF4-FFF2-40B4-BE49-F238E27FC236}">
-                <a16:creationId xmlns:a16="http://schemas.microsoft.com/office/drawing/2014/main" id="{E65E50EF-9842-474A-9008-A1CF63DDC3F2}"/>
+                <a16:creationId xmlns:a16="http://schemas.microsoft.com/office/drawing/2014/main" id="{138560DD-CFF9-4D71-A1BE-02F3AF53881B}"/>
               </a:ext>
             </a:extLst>
           </p:cNvPr>
@@ -9490,7 +9600,7 @@
           <p:cNvPr id="11" name="footer-rule">
             <a:extLst xmlns:a="http://schemas.openxmlformats.org/drawingml/2006/main">
               <a:ext uri="{FF2B5EF4-FFF2-40B4-BE49-F238E27FC236}">
-                <a16:creationId xmlns:a16="http://schemas.microsoft.com/office/drawing/2014/main" id="{E9A4FAF0-CDEB-41F6-B708-04D34B7BDA1A}"/>
+                <a16:creationId xmlns:a16="http://schemas.microsoft.com/office/drawing/2014/main" id="{024219FB-F1AC-4749-9362-5C8E20F5826D}"/>
               </a:ext>
             </a:extLst>
           </p:cNvPr>
@@ -9523,7 +9633,7 @@
           <p:cNvPr id="12" name="footer">
             <a:extLst xmlns:a="http://schemas.openxmlformats.org/drawingml/2006/main">
               <a:ext uri="{FF2B5EF4-FFF2-40B4-BE49-F238E27FC236}">
-                <a16:creationId xmlns:a16="http://schemas.microsoft.com/office/drawing/2014/main" id="{A63112F2-6551-4DB6-BD5D-F6E6BC3166EF}"/>
+                <a16:creationId xmlns:a16="http://schemas.microsoft.com/office/drawing/2014/main" id="{88E32CD3-AB81-4EF0-B5BD-C019AFE82DD9}"/>
               </a:ext>
             </a:extLst>
           </p:cNvPr>
@@ -9578,7 +9688,7 @@
           <p:cNvPr id="13" name="page-number">
             <a:extLst xmlns:a="http://schemas.openxmlformats.org/drawingml/2006/main">
               <a:ext uri="{FF2B5EF4-FFF2-40B4-BE49-F238E27FC236}">
-                <a16:creationId xmlns:a16="http://schemas.microsoft.com/office/drawing/2014/main" id="{B8535321-4BA7-4325-BAD2-47F175A289E6}"/>
+                <a16:creationId xmlns:a16="http://schemas.microsoft.com/office/drawing/2014/main" id="{2183389F-6692-4558-9612-C56DB58DA62A}"/>
               </a:ext>
             </a:extLst>
           </p:cNvPr>
@@ -9631,7 +9741,7 @@
     </p:spTree>
     <p:extLst>
       <p:ext uri="{BB962C8B-B14F-4D97-AF65-F5344CB8AC3E}">
-        <p14:creationId xmlns:p14="http://schemas.microsoft.com/office/powerpoint/2010/main" val="349955144"/>
+        <p14:creationId xmlns:p14="http://schemas.microsoft.com/office/powerpoint/2010/main" val="146795321"/>
       </p:ext>
     </p:extLst>
   </p:cSld>
@@ -9670,7 +9780,7 @@
           <p:cNvPr id="10" name="result-label">
             <a:extLst xmlns:a="http://schemas.openxmlformats.org/drawingml/2006/main">
               <a:ext uri="{FF2B5EF4-FFF2-40B4-BE49-F238E27FC236}">
-                <a16:creationId xmlns:a16="http://schemas.microsoft.com/office/drawing/2014/main" id="{ED6CD16E-A0A6-4CF0-AC03-3B6DBF152BAC}"/>
+                <a16:creationId xmlns:a16="http://schemas.microsoft.com/office/drawing/2014/main" id="{403A1FC7-D8E2-4C90-9540-580BB6E07619}"/>
               </a:ext>
             </a:extLst>
           </p:cNvPr>
@@ -9721,7 +9831,7 @@
           <p:cNvPr id="2" name="result">
             <a:extLst xmlns:a="http://schemas.openxmlformats.org/drawingml/2006/main">
               <a:ext uri="{FF2B5EF4-FFF2-40B4-BE49-F238E27FC236}">
-                <a16:creationId xmlns:a16="http://schemas.microsoft.com/office/drawing/2014/main" id="{B2597586-2A9C-44D3-AA09-14FE6FDA131F}"/>
+                <a16:creationId xmlns:a16="http://schemas.microsoft.com/office/drawing/2014/main" id="{E298D3F6-4809-45E9-9931-B032CA788770}"/>
               </a:ext>
             </a:extLst>
           </p:cNvPr>
@@ -9772,7 +9882,7 @@
           <p:cNvPr id="3" name="result-meta">
             <a:extLst xmlns:a="http://schemas.openxmlformats.org/drawingml/2006/main">
               <a:ext uri="{FF2B5EF4-FFF2-40B4-BE49-F238E27FC236}">
-                <a16:creationId xmlns:a16="http://schemas.microsoft.com/office/drawing/2014/main" id="{5243CF52-BFBD-4374-A3FB-2FEA64FC3693}"/>
+                <a16:creationId xmlns:a16="http://schemas.microsoft.com/office/drawing/2014/main" id="{864849BD-5F92-4E5F-8AAF-426B1EC1E76F}"/>
               </a:ext>
             </a:extLst>
           </p:cNvPr>
@@ -9823,7 +9933,7 @@
           <p:cNvPr id="4" name="ambient-glow">
             <a:extLst xmlns:a="http://schemas.openxmlformats.org/drawingml/2006/main">
               <a:ext uri="{FF2B5EF4-FFF2-40B4-BE49-F238E27FC236}">
-                <a16:creationId xmlns:a16="http://schemas.microsoft.com/office/drawing/2014/main" id="{7B8A6709-BDC8-4FF8-BA94-4A37D1A39218}"/>
+                <a16:creationId xmlns:a16="http://schemas.microsoft.com/office/drawing/2014/main" id="{20DFDAD0-013B-41BD-B06B-84E13A7366D2}"/>
               </a:ext>
             </a:extLst>
           </p:cNvPr>
@@ -9860,7 +9970,7 @@
           <p:cNvPr id="5" name="ambient-core">
             <a:extLst xmlns:a="http://schemas.openxmlformats.org/drawingml/2006/main">
               <a:ext uri="{FF2B5EF4-FFF2-40B4-BE49-F238E27FC236}">
-                <a16:creationId xmlns:a16="http://schemas.microsoft.com/office/drawing/2014/main" id="{FD9CD72E-6B0E-4DE3-A6BB-CBD54C1C6101}"/>
+                <a16:creationId xmlns:a16="http://schemas.microsoft.com/office/drawing/2014/main" id="{38D44A81-C932-4FED-9604-4EE0EFF4AF4F}"/>
               </a:ext>
             </a:extLst>
           </p:cNvPr>
@@ -9897,7 +10007,7 @@
           <p:cNvPr id="6" name="eyebrow">
             <a:extLst xmlns:a="http://schemas.openxmlformats.org/drawingml/2006/main">
               <a:ext uri="{FF2B5EF4-FFF2-40B4-BE49-F238E27FC236}">
-                <a16:creationId xmlns:a16="http://schemas.microsoft.com/office/drawing/2014/main" id="{9C33644C-70A3-401F-AEAB-C512D5FA01F7}"/>
+                <a16:creationId xmlns:a16="http://schemas.microsoft.com/office/drawing/2014/main" id="{890A43BE-4F44-4C86-A935-38FCC4FB7BE8}"/>
               </a:ext>
             </a:extLst>
           </p:cNvPr>
@@ -9948,7 +10058,7 @@
           <p:cNvPr id="7" name="footer-rule">
             <a:extLst xmlns:a="http://schemas.openxmlformats.org/drawingml/2006/main">
               <a:ext uri="{FF2B5EF4-FFF2-40B4-BE49-F238E27FC236}">
-                <a16:creationId xmlns:a16="http://schemas.microsoft.com/office/drawing/2014/main" id="{4681B2FF-A943-49EC-A769-9CCFD4A1D098}"/>
+                <a16:creationId xmlns:a16="http://schemas.microsoft.com/office/drawing/2014/main" id="{54D2D0B6-2D1A-4077-830D-11505229509F}"/>
               </a:ext>
             </a:extLst>
           </p:cNvPr>
@@ -9981,7 +10091,7 @@
           <p:cNvPr id="8" name="footer">
             <a:extLst xmlns:a="http://schemas.openxmlformats.org/drawingml/2006/main">
               <a:ext uri="{FF2B5EF4-FFF2-40B4-BE49-F238E27FC236}">
-                <a16:creationId xmlns:a16="http://schemas.microsoft.com/office/drawing/2014/main" id="{3615772D-1CF6-4DCE-AE1D-E409B9393001}"/>
+                <a16:creationId xmlns:a16="http://schemas.microsoft.com/office/drawing/2014/main" id="{4E100F60-5B1E-4B0E-B1AB-CC2B4C345A07}"/>
               </a:ext>
             </a:extLst>
           </p:cNvPr>
@@ -10036,7 +10146,7 @@
           <p:cNvPr id="9" name="page-number">
             <a:extLst xmlns:a="http://schemas.openxmlformats.org/drawingml/2006/main">
               <a:ext uri="{FF2B5EF4-FFF2-40B4-BE49-F238E27FC236}">
-                <a16:creationId xmlns:a16="http://schemas.microsoft.com/office/drawing/2014/main" id="{26803B3D-2228-4E51-AC3B-67C624651BCF}"/>
+                <a16:creationId xmlns:a16="http://schemas.microsoft.com/office/drawing/2014/main" id="{B6C1FF16-04B0-4C9D-8077-DF3403F71FCE}"/>
               </a:ext>
             </a:extLst>
           </p:cNvPr>
@@ -10089,7 +10199,7 @@
     </p:spTree>
     <p:extLst>
       <p:ext uri="{BB962C8B-B14F-4D97-AF65-F5344CB8AC3E}">
-        <p14:creationId xmlns:p14="http://schemas.microsoft.com/office/powerpoint/2010/main" val="579487179"/>
+        <p14:creationId xmlns:p14="http://schemas.microsoft.com/office/powerpoint/2010/main" val="536315837"/>
       </p:ext>
     </p:extLst>
   </p:cSld>
@@ -10120,7 +10230,7 @@
           <p:cNvPr id="14" name="slide-title">
             <a:extLst xmlns:a="http://schemas.openxmlformats.org/drawingml/2006/main">
               <a:ext uri="{FF2B5EF4-FFF2-40B4-BE49-F238E27FC236}">
-                <a16:creationId xmlns:a16="http://schemas.microsoft.com/office/drawing/2014/main" id="{DC63D2BE-B702-44E5-83BB-6A42B21CD9C6}"/>
+                <a16:creationId xmlns:a16="http://schemas.microsoft.com/office/drawing/2014/main" id="{0369B0B0-A81A-440F-8524-1B382870E49E}"/>
               </a:ext>
             </a:extLst>
           </p:cNvPr>
@@ -10171,7 +10281,7 @@
           <p:cNvPr id="2" name="step-num-1">
             <a:extLst xmlns:a="http://schemas.openxmlformats.org/drawingml/2006/main">
               <a:ext uri="{FF2B5EF4-FFF2-40B4-BE49-F238E27FC236}">
-                <a16:creationId xmlns:a16="http://schemas.microsoft.com/office/drawing/2014/main" id="{769CB97E-3668-4800-84A7-F23E6B5A9203}"/>
+                <a16:creationId xmlns:a16="http://schemas.microsoft.com/office/drawing/2014/main" id="{EC8AC712-194A-466C-B7CA-5861396EEFD3}"/>
               </a:ext>
             </a:extLst>
           </p:cNvPr>
@@ -10222,7 +10332,7 @@
           <p:cNvPr id="3" name="step-label-1">
             <a:extLst xmlns:a="http://schemas.openxmlformats.org/drawingml/2006/main">
               <a:ext uri="{FF2B5EF4-FFF2-40B4-BE49-F238E27FC236}">
-                <a16:creationId xmlns:a16="http://schemas.microsoft.com/office/drawing/2014/main" id="{40D5F8F8-2B3C-41B3-A26A-9856B0BBED6A}"/>
+                <a16:creationId xmlns:a16="http://schemas.microsoft.com/office/drawing/2014/main" id="{B7334BF4-E835-40D8-9856-F74C31361755}"/>
               </a:ext>
             </a:extLst>
           </p:cNvPr>
@@ -10273,7 +10383,7 @@
           <p:cNvPr id="4" name="step-line-1">
             <a:extLst xmlns:a="http://schemas.openxmlformats.org/drawingml/2006/main">
               <a:ext uri="{FF2B5EF4-FFF2-40B4-BE49-F238E27FC236}">
-                <a16:creationId xmlns:a16="http://schemas.microsoft.com/office/drawing/2014/main" id="{DE728F96-DF96-4683-96BE-DE8E1757E201}"/>
+                <a16:creationId xmlns:a16="http://schemas.microsoft.com/office/drawing/2014/main" id="{A45B2840-DEAA-48D0-BA1B-979CBA5A1A2E}"/>
               </a:ext>
             </a:extLst>
           </p:cNvPr>
@@ -10304,7 +10414,7 @@
           <p:cNvPr id="5" name="step-num-2">
             <a:extLst xmlns:a="http://schemas.openxmlformats.org/drawingml/2006/main">
               <a:ext uri="{FF2B5EF4-FFF2-40B4-BE49-F238E27FC236}">
-                <a16:creationId xmlns:a16="http://schemas.microsoft.com/office/drawing/2014/main" id="{A0FB96CB-0D7B-4A07-9CA1-8AB3DA97012D}"/>
+                <a16:creationId xmlns:a16="http://schemas.microsoft.com/office/drawing/2014/main" id="{D806B761-7FCB-456F-B077-4C7BA4E85572}"/>
               </a:ext>
             </a:extLst>
           </p:cNvPr>
@@ -10355,7 +10465,7 @@
           <p:cNvPr id="6" name="step-label-2">
             <a:extLst xmlns:a="http://schemas.openxmlformats.org/drawingml/2006/main">
               <a:ext uri="{FF2B5EF4-FFF2-40B4-BE49-F238E27FC236}">
-                <a16:creationId xmlns:a16="http://schemas.microsoft.com/office/drawing/2014/main" id="{AF377FA1-2C0C-4BD0-B5CA-3FED2B3A83BE}"/>
+                <a16:creationId xmlns:a16="http://schemas.microsoft.com/office/drawing/2014/main" id="{86E13AB6-AED1-4A5F-9ACE-9363254FB7E7}"/>
               </a:ext>
             </a:extLst>
           </p:cNvPr>
@@ -10406,7 +10516,7 @@
           <p:cNvPr id="7" name="step-line-2">
             <a:extLst xmlns:a="http://schemas.openxmlformats.org/drawingml/2006/main">
               <a:ext uri="{FF2B5EF4-FFF2-40B4-BE49-F238E27FC236}">
-                <a16:creationId xmlns:a16="http://schemas.microsoft.com/office/drawing/2014/main" id="{6E9B0E29-98F0-4846-A8C3-92BA04E59BE6}"/>
+                <a16:creationId xmlns:a16="http://schemas.microsoft.com/office/drawing/2014/main" id="{E6107F06-7807-4A95-8008-FE8A9BE7831E}"/>
               </a:ext>
             </a:extLst>
           </p:cNvPr>
@@ -10437,7 +10547,7 @@
           <p:cNvPr id="8" name="step-num-3">
             <a:extLst xmlns:a="http://schemas.openxmlformats.org/drawingml/2006/main">
               <a:ext uri="{FF2B5EF4-FFF2-40B4-BE49-F238E27FC236}">
-                <a16:creationId xmlns:a16="http://schemas.microsoft.com/office/drawing/2014/main" id="{1C66EB0A-DC36-4FEA-8A18-1825ACD86CD9}"/>
+                <a16:creationId xmlns:a16="http://schemas.microsoft.com/office/drawing/2014/main" id="{92DF8EED-428B-4339-9176-8F07F57428A9}"/>
               </a:ext>
             </a:extLst>
           </p:cNvPr>
@@ -10488,7 +10598,7 @@
           <p:cNvPr id="9" name="step-label-3">
             <a:extLst xmlns:a="http://schemas.openxmlformats.org/drawingml/2006/main">
               <a:ext uri="{FF2B5EF4-FFF2-40B4-BE49-F238E27FC236}">
-                <a16:creationId xmlns:a16="http://schemas.microsoft.com/office/drawing/2014/main" id="{83753B0A-AD8D-497E-A546-92ACEFC0D869}"/>
+                <a16:creationId xmlns:a16="http://schemas.microsoft.com/office/drawing/2014/main" id="{63D1D4D7-448A-42A8-A950-DD1637840769}"/>
               </a:ext>
             </a:extLst>
           </p:cNvPr>
@@ -10539,7 +10649,7 @@
           <p:cNvPr id="10" name="eyebrow">
             <a:extLst xmlns:a="http://schemas.openxmlformats.org/drawingml/2006/main">
               <a:ext uri="{FF2B5EF4-FFF2-40B4-BE49-F238E27FC236}">
-                <a16:creationId xmlns:a16="http://schemas.microsoft.com/office/drawing/2014/main" id="{6D0BAA5A-FFFB-48CF-946E-0A95B4193CDE}"/>
+                <a16:creationId xmlns:a16="http://schemas.microsoft.com/office/drawing/2014/main" id="{598A71D1-F5F5-4EAE-88EF-C2D25135AE0C}"/>
               </a:ext>
             </a:extLst>
           </p:cNvPr>
@@ -10590,7 +10700,7 @@
           <p:cNvPr id="11" name="footer-rule">
             <a:extLst xmlns:a="http://schemas.openxmlformats.org/drawingml/2006/main">
               <a:ext uri="{FF2B5EF4-FFF2-40B4-BE49-F238E27FC236}">
-                <a16:creationId xmlns:a16="http://schemas.microsoft.com/office/drawing/2014/main" id="{505FB691-A32C-44B0-A861-E6E57FFC014E}"/>
+                <a16:creationId xmlns:a16="http://schemas.microsoft.com/office/drawing/2014/main" id="{48776562-326E-4B33-A729-269D7080690C}"/>
               </a:ext>
             </a:extLst>
           </p:cNvPr>
@@ -10623,7 +10733,7 @@
           <p:cNvPr id="12" name="footer">
             <a:extLst xmlns:a="http://schemas.openxmlformats.org/drawingml/2006/main">
               <a:ext uri="{FF2B5EF4-FFF2-40B4-BE49-F238E27FC236}">
-                <a16:creationId xmlns:a16="http://schemas.microsoft.com/office/drawing/2014/main" id="{107BA4EB-93DF-4703-B21C-F11621C094AE}"/>
+                <a16:creationId xmlns:a16="http://schemas.microsoft.com/office/drawing/2014/main" id="{10748663-6A20-4882-9A14-C4D247ED75FE}"/>
               </a:ext>
             </a:extLst>
           </p:cNvPr>
@@ -10678,7 +10788,7 @@
           <p:cNvPr id="13" name="page-number">
             <a:extLst xmlns:a="http://schemas.openxmlformats.org/drawingml/2006/main">
               <a:ext uri="{FF2B5EF4-FFF2-40B4-BE49-F238E27FC236}">
-                <a16:creationId xmlns:a16="http://schemas.microsoft.com/office/drawing/2014/main" id="{00760E3A-B4EE-4836-8728-CC425FD9B3B4}"/>
+                <a16:creationId xmlns:a16="http://schemas.microsoft.com/office/drawing/2014/main" id="{7E8957D0-D18E-4222-87ED-FA062E55462C}"/>
               </a:ext>
             </a:extLst>
           </p:cNvPr>
@@ -10731,7 +10841,7 @@
     </p:spTree>
     <p:extLst>
       <p:ext uri="{BB962C8B-B14F-4D97-AF65-F5344CB8AC3E}">
-        <p14:creationId xmlns:p14="http://schemas.microsoft.com/office/powerpoint/2010/main" val="1846487983"/>
+        <p14:creationId xmlns:p14="http://schemas.microsoft.com/office/powerpoint/2010/main" val="1437273733"/>
       </p:ext>
     </p:extLst>
   </p:cSld>
@@ -10770,7 +10880,7 @@
           <p:cNvPr id="9" name="case-number">
             <a:extLst xmlns:a="http://schemas.openxmlformats.org/drawingml/2006/main">
               <a:ext uri="{FF2B5EF4-FFF2-40B4-BE49-F238E27FC236}">
-                <a16:creationId xmlns:a16="http://schemas.microsoft.com/office/drawing/2014/main" id="{CCE0BDDB-0211-4AB9-B82D-0601754F0D94}"/>
+                <a16:creationId xmlns:a16="http://schemas.microsoft.com/office/drawing/2014/main" id="{55E2A2E2-EA77-46C8-81E7-3920A7446DC6}"/>
               </a:ext>
             </a:extLst>
           </p:cNvPr>
@@ -10821,7 +10931,7 @@
           <p:cNvPr id="2" name="case-label">
             <a:extLst xmlns:a="http://schemas.openxmlformats.org/drawingml/2006/main">
               <a:ext uri="{FF2B5EF4-FFF2-40B4-BE49-F238E27FC236}">
-                <a16:creationId xmlns:a16="http://schemas.microsoft.com/office/drawing/2014/main" id="{95A8546C-7DFF-4EE6-AA92-36A6DC44D54B}"/>
+                <a16:creationId xmlns:a16="http://schemas.microsoft.com/office/drawing/2014/main" id="{18FF6D1A-3C41-4803-B58A-CA6EF38D87C1}"/>
               </a:ext>
             </a:extLst>
           </p:cNvPr>
@@ -10872,7 +10982,7 @@
           <p:cNvPr id="3" name="case-divider">
             <a:extLst xmlns:a="http://schemas.openxmlformats.org/drawingml/2006/main">
               <a:ext uri="{FF2B5EF4-FFF2-40B4-BE49-F238E27FC236}">
-                <a16:creationId xmlns:a16="http://schemas.microsoft.com/office/drawing/2014/main" id="{7D4D59EA-F033-49A9-8DFC-194D71A59FA1}"/>
+                <a16:creationId xmlns:a16="http://schemas.microsoft.com/office/drawing/2014/main" id="{CB2E090D-C138-492B-9A8F-FF0A2B49C7A1}"/>
               </a:ext>
             </a:extLst>
           </p:cNvPr>
@@ -10905,7 +11015,7 @@
           <p:cNvPr id="4" name="case-caveat">
             <a:extLst xmlns:a="http://schemas.openxmlformats.org/drawingml/2006/main">
               <a:ext uri="{FF2B5EF4-FFF2-40B4-BE49-F238E27FC236}">
-                <a16:creationId xmlns:a16="http://schemas.microsoft.com/office/drawing/2014/main" id="{95E51BDC-60DB-4069-B67A-A7FDE7CF86FE}"/>
+                <a16:creationId xmlns:a16="http://schemas.microsoft.com/office/drawing/2014/main" id="{21238ED0-2C75-45D2-A26C-F5F331A5E99B}"/>
               </a:ext>
             </a:extLst>
           </p:cNvPr>
@@ -10956,7 +11066,7 @@
           <p:cNvPr id="5" name="eyebrow">
             <a:extLst xmlns:a="http://schemas.openxmlformats.org/drawingml/2006/main">
               <a:ext uri="{FF2B5EF4-FFF2-40B4-BE49-F238E27FC236}">
-                <a16:creationId xmlns:a16="http://schemas.microsoft.com/office/drawing/2014/main" id="{F77F048A-461B-4296-987A-D0BADD6C4425}"/>
+                <a16:creationId xmlns:a16="http://schemas.microsoft.com/office/drawing/2014/main" id="{7AF12EBC-8346-4C41-B2E6-1CAE03F75529}"/>
               </a:ext>
             </a:extLst>
           </p:cNvPr>
@@ -11007,7 +11117,7 @@
           <p:cNvPr id="6" name="footer-rule">
             <a:extLst xmlns:a="http://schemas.openxmlformats.org/drawingml/2006/main">
               <a:ext uri="{FF2B5EF4-FFF2-40B4-BE49-F238E27FC236}">
-                <a16:creationId xmlns:a16="http://schemas.microsoft.com/office/drawing/2014/main" id="{F33BB4D1-7567-49DC-90B6-976FB6A977A7}"/>
+                <a16:creationId xmlns:a16="http://schemas.microsoft.com/office/drawing/2014/main" id="{C45E5D9E-000F-4CDF-AB7F-4D463FECAA55}"/>
               </a:ext>
             </a:extLst>
           </p:cNvPr>
@@ -11040,7 +11150,7 @@
           <p:cNvPr id="7" name="footer">
             <a:extLst xmlns:a="http://schemas.openxmlformats.org/drawingml/2006/main">
               <a:ext uri="{FF2B5EF4-FFF2-40B4-BE49-F238E27FC236}">
-                <a16:creationId xmlns:a16="http://schemas.microsoft.com/office/drawing/2014/main" id="{1AF7CA0C-F070-4538-B002-847AA6F72FEE}"/>
+                <a16:creationId xmlns:a16="http://schemas.microsoft.com/office/drawing/2014/main" id="{70E4FB91-75FA-4A97-8426-DB6C675A90CE}"/>
               </a:ext>
             </a:extLst>
           </p:cNvPr>
@@ -11095,7 +11205,7 @@
           <p:cNvPr id="8" name="page-number">
             <a:extLst xmlns:a="http://schemas.openxmlformats.org/drawingml/2006/main">
               <a:ext uri="{FF2B5EF4-FFF2-40B4-BE49-F238E27FC236}">
-                <a16:creationId xmlns:a16="http://schemas.microsoft.com/office/drawing/2014/main" id="{51B1A45C-1FAE-4A50-9DC3-FF4330B29A2F}"/>
+                <a16:creationId xmlns:a16="http://schemas.microsoft.com/office/drawing/2014/main" id="{F19082C8-E2E8-4575-8E8F-08FD408014DA}"/>
               </a:ext>
             </a:extLst>
           </p:cNvPr>
@@ -11148,7 +11258,7 @@
     </p:spTree>
     <p:extLst>
       <p:ext uri="{BB962C8B-B14F-4D97-AF65-F5344CB8AC3E}">
-        <p14:creationId xmlns:p14="http://schemas.microsoft.com/office/powerpoint/2010/main" val="1397957439"/>
+        <p14:creationId xmlns:p14="http://schemas.microsoft.com/office/powerpoint/2010/main" val="1557302060"/>
       </p:ext>
     </p:extLst>
   </p:cSld>
@@ -11179,7 +11289,7 @@
           <p:cNvPr id="10" name="hook">
             <a:extLst xmlns:a="http://schemas.openxmlformats.org/drawingml/2006/main">
               <a:ext uri="{FF2B5EF4-FFF2-40B4-BE49-F238E27FC236}">
-                <a16:creationId xmlns:a16="http://schemas.microsoft.com/office/drawing/2014/main" id="{B33E20CC-FD47-44D0-BB67-DD7EE9CB1958}"/>
+                <a16:creationId xmlns:a16="http://schemas.microsoft.com/office/drawing/2014/main" id="{B70FCB23-2D7C-437F-B46A-08CEBB8F2CEF}"/>
               </a:ext>
             </a:extLst>
           </p:cNvPr>
@@ -11230,7 +11340,7 @@
           <p:cNvPr id="2" name="hook-rule">
             <a:extLst xmlns:a="http://schemas.openxmlformats.org/drawingml/2006/main">
               <a:ext uri="{FF2B5EF4-FFF2-40B4-BE49-F238E27FC236}">
-                <a16:creationId xmlns:a16="http://schemas.microsoft.com/office/drawing/2014/main" id="{0FDDC59C-FA90-41AE-96DA-B56C2A8E9B31}"/>
+                <a16:creationId xmlns:a16="http://schemas.microsoft.com/office/drawing/2014/main" id="{8FAFF7F0-2412-4836-9B01-81DBB5335C13}"/>
               </a:ext>
             </a:extLst>
           </p:cNvPr>
@@ -11261,7 +11371,7 @@
           <p:cNvPr id="3" name="hook-label">
             <a:extLst xmlns:a="http://schemas.openxmlformats.org/drawingml/2006/main">
               <a:ext uri="{FF2B5EF4-FFF2-40B4-BE49-F238E27FC236}">
-                <a16:creationId xmlns:a16="http://schemas.microsoft.com/office/drawing/2014/main" id="{73CFD472-CEE8-42B2-90FA-230D36D440A5}"/>
+                <a16:creationId xmlns:a16="http://schemas.microsoft.com/office/drawing/2014/main" id="{877902FA-27E1-4C37-B7CB-B0D9B314F64D}"/>
               </a:ext>
             </a:extLst>
           </p:cNvPr>
@@ -11312,7 +11422,7 @@
           <p:cNvPr id="4" name="diagram-surface">
             <a:extLst xmlns:a="http://schemas.openxmlformats.org/drawingml/2006/main">
               <a:ext uri="{FF2B5EF4-FFF2-40B4-BE49-F238E27FC236}">
-                <a16:creationId xmlns:a16="http://schemas.microsoft.com/office/drawing/2014/main" id="{6AD275CE-8587-47B5-9284-2E7311480B8A}"/>
+                <a16:creationId xmlns:a16="http://schemas.microsoft.com/office/drawing/2014/main" id="{2296B81B-0488-4E30-B52C-2D9224017C41}"/>
               </a:ext>
             </a:extLst>
           </p:cNvPr>
@@ -11351,7 +11461,7 @@
           <p:nvPr/>
         </p:nvPicPr>
         <p:blipFill>
-          <a:blip xmlns:r="http://schemas.openxmlformats.org/officeDocument/2006/relationships" xmlns:a="http://schemas.openxmlformats.org/drawingml/2006/main" r:embed="R94af854042ce47f2"/>
+          <a:blip xmlns:r="http://schemas.openxmlformats.org/officeDocument/2006/relationships" xmlns:a="http://schemas.openxmlformats.org/drawingml/2006/main" r:embed="Rad2fba1d29bb49b4"/>
           <a:stretch xmlns:a="http://schemas.openxmlformats.org/drawingml/2006/main"/>
         </p:blipFill>
         <p:spPr>
@@ -11369,7 +11479,7 @@
           <p:cNvPr id="6" name="eyebrow">
             <a:extLst xmlns:a="http://schemas.openxmlformats.org/drawingml/2006/main">
               <a:ext uri="{FF2B5EF4-FFF2-40B4-BE49-F238E27FC236}">
-                <a16:creationId xmlns:a16="http://schemas.microsoft.com/office/drawing/2014/main" id="{9B6017FE-3684-401E-BB53-48C0D104424B}"/>
+                <a16:creationId xmlns:a16="http://schemas.microsoft.com/office/drawing/2014/main" id="{20406D80-B0CF-4330-8F2C-95494B233386}"/>
               </a:ext>
             </a:extLst>
           </p:cNvPr>
@@ -11420,7 +11530,7 @@
           <p:cNvPr id="7" name="footer-rule">
             <a:extLst xmlns:a="http://schemas.openxmlformats.org/drawingml/2006/main">
               <a:ext uri="{FF2B5EF4-FFF2-40B4-BE49-F238E27FC236}">
-                <a16:creationId xmlns:a16="http://schemas.microsoft.com/office/drawing/2014/main" id="{AEAED658-38EC-458A-8F1A-640A526606B0}"/>
+                <a16:creationId xmlns:a16="http://schemas.microsoft.com/office/drawing/2014/main" id="{5A1A19AD-6AF3-4B54-8B20-3D382C257A15}"/>
               </a:ext>
             </a:extLst>
           </p:cNvPr>
@@ -11453,7 +11563,7 @@
           <p:cNvPr id="8" name="footer">
             <a:extLst xmlns:a="http://schemas.openxmlformats.org/drawingml/2006/main">
               <a:ext uri="{FF2B5EF4-FFF2-40B4-BE49-F238E27FC236}">
-                <a16:creationId xmlns:a16="http://schemas.microsoft.com/office/drawing/2014/main" id="{61D88E26-17DA-43BE-9581-8215F6E310EA}"/>
+                <a16:creationId xmlns:a16="http://schemas.microsoft.com/office/drawing/2014/main" id="{D1FBC5E0-DBD7-477E-99E5-031BD7E4C70D}"/>
               </a:ext>
             </a:extLst>
           </p:cNvPr>
@@ -11508,7 +11618,7 @@
           <p:cNvPr id="9" name="page-number">
             <a:extLst xmlns:a="http://schemas.openxmlformats.org/drawingml/2006/main">
               <a:ext uri="{FF2B5EF4-FFF2-40B4-BE49-F238E27FC236}">
-                <a16:creationId xmlns:a16="http://schemas.microsoft.com/office/drawing/2014/main" id="{4BC644F4-5AE8-473B-B399-10FB9226A174}"/>
+                <a16:creationId xmlns:a16="http://schemas.microsoft.com/office/drawing/2014/main" id="{44E6F5C9-35F4-4A7D-A4B0-11A9AC02DE86}"/>
               </a:ext>
             </a:extLst>
           </p:cNvPr>
@@ -11561,7 +11671,7 @@
     </p:spTree>
     <p:extLst>
       <p:ext uri="{BB962C8B-B14F-4D97-AF65-F5344CB8AC3E}">
-        <p14:creationId xmlns:p14="http://schemas.microsoft.com/office/powerpoint/2010/main" val="731638468"/>
+        <p14:creationId xmlns:p14="http://schemas.microsoft.com/office/powerpoint/2010/main" val="385085420"/>
       </p:ext>
     </p:extLst>
   </p:cSld>
@@ -11592,7 +11702,7 @@
           <p:cNvPr id="7" name="slide-title">
             <a:extLst xmlns:a="http://schemas.openxmlformats.org/drawingml/2006/main">
               <a:ext uri="{FF2B5EF4-FFF2-40B4-BE49-F238E27FC236}">
-                <a16:creationId xmlns:a16="http://schemas.microsoft.com/office/drawing/2014/main" id="{4C6D3168-297A-43E3-9E26-6C696EE032EB}"/>
+                <a16:creationId xmlns:a16="http://schemas.microsoft.com/office/drawing/2014/main" id="{A732C0AB-D64A-4449-B29B-D749FC619855}"/>
               </a:ext>
             </a:extLst>
           </p:cNvPr>
@@ -11643,7 +11753,7 @@
           <p:cNvPr id="2" name="bullets">
             <a:extLst xmlns:a="http://schemas.openxmlformats.org/drawingml/2006/main">
               <a:ext uri="{FF2B5EF4-FFF2-40B4-BE49-F238E27FC236}">
-                <a16:creationId xmlns:a16="http://schemas.microsoft.com/office/drawing/2014/main" id="{43D81298-7C16-476A-95CB-7B9D5B198334}"/>
+                <a16:creationId xmlns:a16="http://schemas.microsoft.com/office/drawing/2014/main" id="{EE09A95C-4B12-4169-8330-672E8B3A3F25}"/>
               </a:ext>
             </a:extLst>
           </p:cNvPr>
@@ -11720,7 +11830,7 @@
                   <a:srgbClr val="0B1F3A"/>
                 </a:solidFill>
               </a:rPr>
-              <a:t>• DuckDB UI instala a extensão no primeiro uso</a:t>
+              <a:t>• Explorador autoral é propositalmente simples</a:t>
             </a:r>
           </a:p>
           <a:p xmlns:a="http://schemas.openxmlformats.org/drawingml/2006/main">
@@ -11748,7 +11858,7 @@
           <p:cNvPr id="3" name="eyebrow">
             <a:extLst xmlns:a="http://schemas.openxmlformats.org/drawingml/2006/main">
               <a:ext uri="{FF2B5EF4-FFF2-40B4-BE49-F238E27FC236}">
-                <a16:creationId xmlns:a16="http://schemas.microsoft.com/office/drawing/2014/main" id="{849ACCB6-216F-4599-BB15-208B54D61C83}"/>
+                <a16:creationId xmlns:a16="http://schemas.microsoft.com/office/drawing/2014/main" id="{3023EBFC-2847-4AE2-81FD-DD044F76B2BC}"/>
               </a:ext>
             </a:extLst>
           </p:cNvPr>
@@ -11799,7 +11909,7 @@
           <p:cNvPr id="4" name="footer-rule">
             <a:extLst xmlns:a="http://schemas.openxmlformats.org/drawingml/2006/main">
               <a:ext uri="{FF2B5EF4-FFF2-40B4-BE49-F238E27FC236}">
-                <a16:creationId xmlns:a16="http://schemas.microsoft.com/office/drawing/2014/main" id="{B2693FBA-B016-40EC-979A-F1A26E949FD0}"/>
+                <a16:creationId xmlns:a16="http://schemas.microsoft.com/office/drawing/2014/main" id="{323372B5-C159-4D9F-9EDA-A24DB335595C}"/>
               </a:ext>
             </a:extLst>
           </p:cNvPr>
@@ -11832,7 +11942,7 @@
           <p:cNvPr id="5" name="footer">
             <a:extLst xmlns:a="http://schemas.openxmlformats.org/drawingml/2006/main">
               <a:ext uri="{FF2B5EF4-FFF2-40B4-BE49-F238E27FC236}">
-                <a16:creationId xmlns:a16="http://schemas.microsoft.com/office/drawing/2014/main" id="{02EF495F-BCAE-484F-B59F-1386CA13FFC0}"/>
+                <a16:creationId xmlns:a16="http://schemas.microsoft.com/office/drawing/2014/main" id="{4B6C852B-D5DB-48BB-825B-D435BD1A15C2}"/>
               </a:ext>
             </a:extLst>
           </p:cNvPr>
@@ -11887,7 +11997,7 @@
           <p:cNvPr id="6" name="page-number">
             <a:extLst xmlns:a="http://schemas.openxmlformats.org/drawingml/2006/main">
               <a:ext uri="{FF2B5EF4-FFF2-40B4-BE49-F238E27FC236}">
-                <a16:creationId xmlns:a16="http://schemas.microsoft.com/office/drawing/2014/main" id="{894CDDAD-E281-459A-9B64-2BC2DA45E324}"/>
+                <a16:creationId xmlns:a16="http://schemas.microsoft.com/office/drawing/2014/main" id="{1CA39CD0-FB97-4FC9-8C2B-35001AD69BB9}"/>
               </a:ext>
             </a:extLst>
           </p:cNvPr>
@@ -11940,7 +12050,7 @@
     </p:spTree>
     <p:extLst>
       <p:ext uri="{BB962C8B-B14F-4D97-AF65-F5344CB8AC3E}">
-        <p14:creationId xmlns:p14="http://schemas.microsoft.com/office/powerpoint/2010/main" val="719168814"/>
+        <p14:creationId xmlns:p14="http://schemas.microsoft.com/office/powerpoint/2010/main" val="433528353"/>
       </p:ext>
     </p:extLst>
   </p:cSld>
@@ -11979,7 +12089,7 @@
           <p:cNvPr id="10" name="radar-label">
             <a:extLst xmlns:a="http://schemas.openxmlformats.org/drawingml/2006/main">
               <a:ext uri="{FF2B5EF4-FFF2-40B4-BE49-F238E27FC236}">
-                <a16:creationId xmlns:a16="http://schemas.microsoft.com/office/drawing/2014/main" id="{A17BE7F7-5E8A-4538-8606-7B966F3E2ADF}"/>
+                <a16:creationId xmlns:a16="http://schemas.microsoft.com/office/drawing/2014/main" id="{241C1738-9F83-45EA-A6F4-E5411D9AD21A}"/>
               </a:ext>
             </a:extLst>
           </p:cNvPr>
@@ -12030,7 +12140,7 @@
           <p:cNvPr id="2" name="radar-text">
             <a:extLst xmlns:a="http://schemas.openxmlformats.org/drawingml/2006/main">
               <a:ext uri="{FF2B5EF4-FFF2-40B4-BE49-F238E27FC236}">
-                <a16:creationId xmlns:a16="http://schemas.microsoft.com/office/drawing/2014/main" id="{57321A7E-3FF2-4538-B173-6FF205B39CDB}"/>
+                <a16:creationId xmlns:a16="http://schemas.microsoft.com/office/drawing/2014/main" id="{E4A4F3FD-C30B-4593-965B-38080B17272D}"/>
               </a:ext>
             </a:extLst>
           </p:cNvPr>
@@ -12081,7 +12191,7 @@
           <p:cNvPr id="3" name="radar-rule">
             <a:extLst xmlns:a="http://schemas.openxmlformats.org/drawingml/2006/main">
               <a:ext uri="{FF2B5EF4-FFF2-40B4-BE49-F238E27FC236}">
-                <a16:creationId xmlns:a16="http://schemas.microsoft.com/office/drawing/2014/main" id="{368CEB4F-2415-4810-B845-DD6D0F576478}"/>
+                <a16:creationId xmlns:a16="http://schemas.microsoft.com/office/drawing/2014/main" id="{52D08C92-4889-458E-853E-215A12F4D73A}"/>
               </a:ext>
             </a:extLst>
           </p:cNvPr>
@@ -12132,7 +12242,7 @@
           <p:cNvPr id="4" name="ambient-glow">
             <a:extLst xmlns:a="http://schemas.openxmlformats.org/drawingml/2006/main">
               <a:ext uri="{FF2B5EF4-FFF2-40B4-BE49-F238E27FC236}">
-                <a16:creationId xmlns:a16="http://schemas.microsoft.com/office/drawing/2014/main" id="{EFBD90C9-23E5-406B-A22A-5110AA2FCB59}"/>
+                <a16:creationId xmlns:a16="http://schemas.microsoft.com/office/drawing/2014/main" id="{C3604B8A-A0CE-4426-A87B-80C030B255F9}"/>
               </a:ext>
             </a:extLst>
           </p:cNvPr>
@@ -12169,7 +12279,7 @@
           <p:cNvPr id="5" name="ambient-core">
             <a:extLst xmlns:a="http://schemas.openxmlformats.org/drawingml/2006/main">
               <a:ext uri="{FF2B5EF4-FFF2-40B4-BE49-F238E27FC236}">
-                <a16:creationId xmlns:a16="http://schemas.microsoft.com/office/drawing/2014/main" id="{2595EADB-E2F8-4B06-A5DE-F76A938D1110}"/>
+                <a16:creationId xmlns:a16="http://schemas.microsoft.com/office/drawing/2014/main" id="{390B97B9-90BF-4F15-A0D0-FDE527DFC3C0}"/>
               </a:ext>
             </a:extLst>
           </p:cNvPr>
@@ -12206,7 +12316,7 @@
           <p:cNvPr id="6" name="eyebrow">
             <a:extLst xmlns:a="http://schemas.openxmlformats.org/drawingml/2006/main">
               <a:ext uri="{FF2B5EF4-FFF2-40B4-BE49-F238E27FC236}">
-                <a16:creationId xmlns:a16="http://schemas.microsoft.com/office/drawing/2014/main" id="{0434274B-A4FE-46EA-8E64-64D3C41AA91E}"/>
+                <a16:creationId xmlns:a16="http://schemas.microsoft.com/office/drawing/2014/main" id="{0EE13430-E8B2-4633-A564-CB5C6FE2EF4C}"/>
               </a:ext>
             </a:extLst>
           </p:cNvPr>
@@ -12257,7 +12367,7 @@
           <p:cNvPr id="7" name="footer-rule">
             <a:extLst xmlns:a="http://schemas.openxmlformats.org/drawingml/2006/main">
               <a:ext uri="{FF2B5EF4-FFF2-40B4-BE49-F238E27FC236}">
-                <a16:creationId xmlns:a16="http://schemas.microsoft.com/office/drawing/2014/main" id="{F0E8DB29-1D73-46BB-BE3A-2CD3AD12B4B5}"/>
+                <a16:creationId xmlns:a16="http://schemas.microsoft.com/office/drawing/2014/main" id="{F47DE7D2-85A1-471D-B159-227383E757CF}"/>
               </a:ext>
             </a:extLst>
           </p:cNvPr>
@@ -12290,7 +12400,7 @@
           <p:cNvPr id="8" name="footer">
             <a:extLst xmlns:a="http://schemas.openxmlformats.org/drawingml/2006/main">
               <a:ext uri="{FF2B5EF4-FFF2-40B4-BE49-F238E27FC236}">
-                <a16:creationId xmlns:a16="http://schemas.microsoft.com/office/drawing/2014/main" id="{089500D8-DDE8-4568-B491-73FBCADF05BD}"/>
+                <a16:creationId xmlns:a16="http://schemas.microsoft.com/office/drawing/2014/main" id="{8B787194-C958-49D2-9D0D-64AC6548E9B2}"/>
               </a:ext>
             </a:extLst>
           </p:cNvPr>
@@ -12345,7 +12455,7 @@
           <p:cNvPr id="9" name="page-number">
             <a:extLst xmlns:a="http://schemas.openxmlformats.org/drawingml/2006/main">
               <a:ext uri="{FF2B5EF4-FFF2-40B4-BE49-F238E27FC236}">
-                <a16:creationId xmlns:a16="http://schemas.microsoft.com/office/drawing/2014/main" id="{09B00172-0F1A-4AEF-9348-D99AE57F8CD1}"/>
+                <a16:creationId xmlns:a16="http://schemas.microsoft.com/office/drawing/2014/main" id="{4F60FBCC-B44C-4877-8744-2B01406C11BA}"/>
               </a:ext>
             </a:extLst>
           </p:cNvPr>
@@ -12398,7 +12508,7 @@
     </p:spTree>
     <p:extLst>
       <p:ext uri="{BB962C8B-B14F-4D97-AF65-F5344CB8AC3E}">
-        <p14:creationId xmlns:p14="http://schemas.microsoft.com/office/powerpoint/2010/main" val="1830265128"/>
+        <p14:creationId xmlns:p14="http://schemas.microsoft.com/office/powerpoint/2010/main" val="2025287290"/>
       </p:ext>
     </p:extLst>
   </p:cSld>
@@ -12429,7 +12539,7 @@
           <p:cNvPr id="8" name="cta-label">
             <a:extLst xmlns:a="http://schemas.openxmlformats.org/drawingml/2006/main">
               <a:ext uri="{FF2B5EF4-FFF2-40B4-BE49-F238E27FC236}">
-                <a16:creationId xmlns:a16="http://schemas.microsoft.com/office/drawing/2014/main" id="{96AD9A45-1A4D-4CD2-83FE-9FBEB234B664}"/>
+                <a16:creationId xmlns:a16="http://schemas.microsoft.com/office/drawing/2014/main" id="{AE4C58D2-9CB8-4A12-9E71-EBC321459FFA}"/>
               </a:ext>
             </a:extLst>
           </p:cNvPr>
@@ -12480,7 +12590,7 @@
           <p:cNvPr id="2" name="cta">
             <a:extLst xmlns:a="http://schemas.openxmlformats.org/drawingml/2006/main">
               <a:ext uri="{FF2B5EF4-FFF2-40B4-BE49-F238E27FC236}">
-                <a16:creationId xmlns:a16="http://schemas.microsoft.com/office/drawing/2014/main" id="{64A16B97-3E63-4410-8946-329E81906D84}"/>
+                <a16:creationId xmlns:a16="http://schemas.microsoft.com/office/drawing/2014/main" id="{45BADF0D-AC15-4466-9AEA-616F4080AEEB}"/>
               </a:ext>
             </a:extLst>
           </p:cNvPr>
@@ -12521,7 +12631,7 @@
                   <a:srgbClr val="0B1F3A"/>
                 </a:solidFill>
               </a:rPr>
-              <a:t>Abra o Codespace em 2-core, confira paths, execute checkpoint 01, explore a UI e pare ao terminar.</a:t>
+              <a:t>Abra o Codespace em 2-core, confira paths, execute checkpoint 01, explore a cópia e pare ao terminar.</a:t>
             </a:r>
           </a:p>
         </p:txBody>
@@ -12531,7 +12641,7 @@
           <p:cNvPr id="3" name="cta-meta">
             <a:extLst xmlns:a="http://schemas.openxmlformats.org/drawingml/2006/main">
               <a:ext uri="{FF2B5EF4-FFF2-40B4-BE49-F238E27FC236}">
-                <a16:creationId xmlns:a16="http://schemas.microsoft.com/office/drawing/2014/main" id="{9CA67587-1463-47EF-86EA-05B42E49A0A8}"/>
+                <a16:creationId xmlns:a16="http://schemas.microsoft.com/office/drawing/2014/main" id="{F0A32E78-759B-4DD2-B111-2F9AC73E353D}"/>
               </a:ext>
             </a:extLst>
           </p:cNvPr>
@@ -12582,7 +12692,7 @@
           <p:cNvPr id="4" name="eyebrow">
             <a:extLst xmlns:a="http://schemas.openxmlformats.org/drawingml/2006/main">
               <a:ext uri="{FF2B5EF4-FFF2-40B4-BE49-F238E27FC236}">
-                <a16:creationId xmlns:a16="http://schemas.microsoft.com/office/drawing/2014/main" id="{F3971821-34B2-453D-9C29-E97541177835}"/>
+                <a16:creationId xmlns:a16="http://schemas.microsoft.com/office/drawing/2014/main" id="{A2766C84-B2BA-4D81-A9D8-FFE6B656EBA1}"/>
               </a:ext>
             </a:extLst>
           </p:cNvPr>
@@ -12633,7 +12743,7 @@
           <p:cNvPr id="5" name="footer-rule">
             <a:extLst xmlns:a="http://schemas.openxmlformats.org/drawingml/2006/main">
               <a:ext uri="{FF2B5EF4-FFF2-40B4-BE49-F238E27FC236}">
-                <a16:creationId xmlns:a16="http://schemas.microsoft.com/office/drawing/2014/main" id="{899E8DD1-53C6-4826-8601-879B18B3FE4F}"/>
+                <a16:creationId xmlns:a16="http://schemas.microsoft.com/office/drawing/2014/main" id="{6F8FB0BE-A3F6-47C6-AED2-6F290414B675}"/>
               </a:ext>
             </a:extLst>
           </p:cNvPr>
@@ -12666,7 +12776,7 @@
           <p:cNvPr id="6" name="footer">
             <a:extLst xmlns:a="http://schemas.openxmlformats.org/drawingml/2006/main">
               <a:ext uri="{FF2B5EF4-FFF2-40B4-BE49-F238E27FC236}">
-                <a16:creationId xmlns:a16="http://schemas.microsoft.com/office/drawing/2014/main" id="{026F81E4-9B37-4193-B544-7064D411B023}"/>
+                <a16:creationId xmlns:a16="http://schemas.microsoft.com/office/drawing/2014/main" id="{FB49C426-7502-4F76-AF6F-457334F26E85}"/>
               </a:ext>
             </a:extLst>
           </p:cNvPr>
@@ -12721,7 +12831,7 @@
           <p:cNvPr id="7" name="page-number">
             <a:extLst xmlns:a="http://schemas.openxmlformats.org/drawingml/2006/main">
               <a:ext uri="{FF2B5EF4-FFF2-40B4-BE49-F238E27FC236}">
-                <a16:creationId xmlns:a16="http://schemas.microsoft.com/office/drawing/2014/main" id="{D104F694-4CD4-4319-809A-91A8C8F0477F}"/>
+                <a16:creationId xmlns:a16="http://schemas.microsoft.com/office/drawing/2014/main" id="{83383D34-D8EA-4B4B-9782-AD4596C1666C}"/>
               </a:ext>
             </a:extLst>
           </p:cNvPr>
@@ -12774,7 +12884,7 @@
     </p:spTree>
     <p:extLst>
       <p:ext uri="{BB962C8B-B14F-4D97-AF65-F5344CB8AC3E}">
-        <p14:creationId xmlns:p14="http://schemas.microsoft.com/office/powerpoint/2010/main" val="1390372137"/>
+        <p14:creationId xmlns:p14="http://schemas.microsoft.com/office/powerpoint/2010/main" val="311801575"/>
       </p:ext>
     </p:extLst>
   </p:cSld>
@@ -12813,7 +12923,7 @@
           <p:cNvPr id="14" name="slide-title">
             <a:extLst xmlns:a="http://schemas.openxmlformats.org/drawingml/2006/main">
               <a:ext uri="{FF2B5EF4-FFF2-40B4-BE49-F238E27FC236}">
-                <a16:creationId xmlns:a16="http://schemas.microsoft.com/office/drawing/2014/main" id="{4DF6763B-A9A5-4FBD-9BAD-0A9F29217A54}"/>
+                <a16:creationId xmlns:a16="http://schemas.microsoft.com/office/drawing/2014/main" id="{992C0579-1E98-4C90-BCFB-6C3F54D729CF}"/>
               </a:ext>
             </a:extLst>
           </p:cNvPr>
@@ -12864,7 +12974,7 @@
           <p:cNvPr id="2" name="step-num-1">
             <a:extLst xmlns:a="http://schemas.openxmlformats.org/drawingml/2006/main">
               <a:ext uri="{FF2B5EF4-FFF2-40B4-BE49-F238E27FC236}">
-                <a16:creationId xmlns:a16="http://schemas.microsoft.com/office/drawing/2014/main" id="{87177341-1B6F-4841-A89B-3DDCF9EF5183}"/>
+                <a16:creationId xmlns:a16="http://schemas.microsoft.com/office/drawing/2014/main" id="{1AC44FDE-2C3B-439E-B7EE-E99293B4E744}"/>
               </a:ext>
             </a:extLst>
           </p:cNvPr>
@@ -12915,7 +13025,7 @@
           <p:cNvPr id="3" name="step-label-1">
             <a:extLst xmlns:a="http://schemas.openxmlformats.org/drawingml/2006/main">
               <a:ext uri="{FF2B5EF4-FFF2-40B4-BE49-F238E27FC236}">
-                <a16:creationId xmlns:a16="http://schemas.microsoft.com/office/drawing/2014/main" id="{F48B1242-826B-4544-92A6-1845C74F5BB2}"/>
+                <a16:creationId xmlns:a16="http://schemas.microsoft.com/office/drawing/2014/main" id="{08177A3F-31EF-4316-AA24-376D5FC0F48B}"/>
               </a:ext>
             </a:extLst>
           </p:cNvPr>
@@ -12966,7 +13076,7 @@
           <p:cNvPr id="4" name="step-line-1">
             <a:extLst xmlns:a="http://schemas.openxmlformats.org/drawingml/2006/main">
               <a:ext uri="{FF2B5EF4-FFF2-40B4-BE49-F238E27FC236}">
-                <a16:creationId xmlns:a16="http://schemas.microsoft.com/office/drawing/2014/main" id="{497B69DB-5A11-458E-88F9-05384E711C63}"/>
+                <a16:creationId xmlns:a16="http://schemas.microsoft.com/office/drawing/2014/main" id="{1A6FA15D-F01B-4D6C-B21C-262F2CE9C014}"/>
               </a:ext>
             </a:extLst>
           </p:cNvPr>
@@ -12997,7 +13107,7 @@
           <p:cNvPr id="5" name="step-num-2">
             <a:extLst xmlns:a="http://schemas.openxmlformats.org/drawingml/2006/main">
               <a:ext uri="{FF2B5EF4-FFF2-40B4-BE49-F238E27FC236}">
-                <a16:creationId xmlns:a16="http://schemas.microsoft.com/office/drawing/2014/main" id="{4DA6ED3F-BE11-45EF-8AAD-915F34AB694D}"/>
+                <a16:creationId xmlns:a16="http://schemas.microsoft.com/office/drawing/2014/main" id="{A3272464-EF63-4672-BC55-64571DC4E179}"/>
               </a:ext>
             </a:extLst>
           </p:cNvPr>
@@ -13048,7 +13158,7 @@
           <p:cNvPr id="6" name="step-label-2">
             <a:extLst xmlns:a="http://schemas.openxmlformats.org/drawingml/2006/main">
               <a:ext uri="{FF2B5EF4-FFF2-40B4-BE49-F238E27FC236}">
-                <a16:creationId xmlns:a16="http://schemas.microsoft.com/office/drawing/2014/main" id="{5F4D8E54-88C9-4EAD-BC86-6AFEF9B75211}"/>
+                <a16:creationId xmlns:a16="http://schemas.microsoft.com/office/drawing/2014/main" id="{88BA5706-AFAD-4529-861E-96B7DFD1729F}"/>
               </a:ext>
             </a:extLst>
           </p:cNvPr>
@@ -13099,7 +13209,7 @@
           <p:cNvPr id="7" name="step-line-2">
             <a:extLst xmlns:a="http://schemas.openxmlformats.org/drawingml/2006/main">
               <a:ext uri="{FF2B5EF4-FFF2-40B4-BE49-F238E27FC236}">
-                <a16:creationId xmlns:a16="http://schemas.microsoft.com/office/drawing/2014/main" id="{EEA1CFF9-6F64-4593-9B17-B43F27E33C0D}"/>
+                <a16:creationId xmlns:a16="http://schemas.microsoft.com/office/drawing/2014/main" id="{D14A4A14-3655-4750-964F-759791C709DA}"/>
               </a:ext>
             </a:extLst>
           </p:cNvPr>
@@ -13130,7 +13240,7 @@
           <p:cNvPr id="8" name="step-num-3">
             <a:extLst xmlns:a="http://schemas.openxmlformats.org/drawingml/2006/main">
               <a:ext uri="{FF2B5EF4-FFF2-40B4-BE49-F238E27FC236}">
-                <a16:creationId xmlns:a16="http://schemas.microsoft.com/office/drawing/2014/main" id="{0F810D4E-CA3C-4991-A726-448196497419}"/>
+                <a16:creationId xmlns:a16="http://schemas.microsoft.com/office/drawing/2014/main" id="{59E1678A-4031-4020-9FED-812799C98077}"/>
               </a:ext>
             </a:extLst>
           </p:cNvPr>
@@ -13181,7 +13291,7 @@
           <p:cNvPr id="9" name="step-label-3">
             <a:extLst xmlns:a="http://schemas.openxmlformats.org/drawingml/2006/main">
               <a:ext uri="{FF2B5EF4-FFF2-40B4-BE49-F238E27FC236}">
-                <a16:creationId xmlns:a16="http://schemas.microsoft.com/office/drawing/2014/main" id="{3434BCC5-E8F7-4139-A64B-B9769DB6EED4}"/>
+                <a16:creationId xmlns:a16="http://schemas.microsoft.com/office/drawing/2014/main" id="{E30163AF-5304-4B1E-924A-FAF5846442E8}"/>
               </a:ext>
             </a:extLst>
           </p:cNvPr>
@@ -13232,7 +13342,7 @@
           <p:cNvPr id="10" name="eyebrow">
             <a:extLst xmlns:a="http://schemas.openxmlformats.org/drawingml/2006/main">
               <a:ext uri="{FF2B5EF4-FFF2-40B4-BE49-F238E27FC236}">
-                <a16:creationId xmlns:a16="http://schemas.microsoft.com/office/drawing/2014/main" id="{353D0FB6-A9C3-4331-8052-6AF6FD73A3B9}"/>
+                <a16:creationId xmlns:a16="http://schemas.microsoft.com/office/drawing/2014/main" id="{7AD93945-361F-44CE-AF86-F8E31F9D3460}"/>
               </a:ext>
             </a:extLst>
           </p:cNvPr>
@@ -13283,7 +13393,7 @@
           <p:cNvPr id="11" name="footer-rule">
             <a:extLst xmlns:a="http://schemas.openxmlformats.org/drawingml/2006/main">
               <a:ext uri="{FF2B5EF4-FFF2-40B4-BE49-F238E27FC236}">
-                <a16:creationId xmlns:a16="http://schemas.microsoft.com/office/drawing/2014/main" id="{F90829FE-8BA2-42C1-AE91-013BCF0DE9E2}"/>
+                <a16:creationId xmlns:a16="http://schemas.microsoft.com/office/drawing/2014/main" id="{40518D40-AE6D-4038-A534-28CE0120FDA4}"/>
               </a:ext>
             </a:extLst>
           </p:cNvPr>
@@ -13316,7 +13426,7 @@
           <p:cNvPr id="12" name="footer">
             <a:extLst xmlns:a="http://schemas.openxmlformats.org/drawingml/2006/main">
               <a:ext uri="{FF2B5EF4-FFF2-40B4-BE49-F238E27FC236}">
-                <a16:creationId xmlns:a16="http://schemas.microsoft.com/office/drawing/2014/main" id="{5E7BD1C4-C325-4C3B-A90E-55F77FABF7EA}"/>
+                <a16:creationId xmlns:a16="http://schemas.microsoft.com/office/drawing/2014/main" id="{DFD36C23-30B4-4932-BB50-EFC7E9907C32}"/>
               </a:ext>
             </a:extLst>
           </p:cNvPr>
@@ -13371,7 +13481,7 @@
           <p:cNvPr id="13" name="page-number">
             <a:extLst xmlns:a="http://schemas.openxmlformats.org/drawingml/2006/main">
               <a:ext uri="{FF2B5EF4-FFF2-40B4-BE49-F238E27FC236}">
-                <a16:creationId xmlns:a16="http://schemas.microsoft.com/office/drawing/2014/main" id="{99AA8B3F-5239-43D9-8C1B-F5B2577A4388}"/>
+                <a16:creationId xmlns:a16="http://schemas.microsoft.com/office/drawing/2014/main" id="{1D9802CB-5411-4306-8AC7-734729990D62}"/>
               </a:ext>
             </a:extLst>
           </p:cNvPr>
@@ -13424,7 +13534,7 @@
     </p:spTree>
     <p:extLst>
       <p:ext uri="{BB962C8B-B14F-4D97-AF65-F5344CB8AC3E}">
-        <p14:creationId xmlns:p14="http://schemas.microsoft.com/office/powerpoint/2010/main" val="1594604825"/>
+        <p14:creationId xmlns:p14="http://schemas.microsoft.com/office/powerpoint/2010/main" val="1706817199"/>
       </p:ext>
     </p:extLst>
   </p:cSld>
@@ -13463,7 +13573,7 @@
           <p:cNvPr id="11" name="slide-title">
             <a:extLst xmlns:a="http://schemas.openxmlformats.org/drawingml/2006/main">
               <a:ext uri="{FF2B5EF4-FFF2-40B4-BE49-F238E27FC236}">
-                <a16:creationId xmlns:a16="http://schemas.microsoft.com/office/drawing/2014/main" id="{FE997CB6-7E5B-4F4E-90A2-B31810011FA7}"/>
+                <a16:creationId xmlns:a16="http://schemas.microsoft.com/office/drawing/2014/main" id="{CECF7CF6-6EBF-49E0-ADE9-12C24B227766}"/>
               </a:ext>
             </a:extLst>
           </p:cNvPr>
@@ -13514,7 +13624,7 @@
           <p:cNvPr id="2" name="slide-subtitle">
             <a:extLst xmlns:a="http://schemas.openxmlformats.org/drawingml/2006/main">
               <a:ext uri="{FF2B5EF4-FFF2-40B4-BE49-F238E27FC236}">
-                <a16:creationId xmlns:a16="http://schemas.microsoft.com/office/drawing/2014/main" id="{AAFF1837-DBBE-43EA-AD2F-AB42A9678D02}"/>
+                <a16:creationId xmlns:a16="http://schemas.microsoft.com/office/drawing/2014/main" id="{2C56E300-DA42-4194-9D5D-09795B8414A4}"/>
               </a:ext>
             </a:extLst>
           </p:cNvPr>
@@ -13565,7 +13675,7 @@
           <p:cNvPr id="3" name="bullets">
             <a:extLst xmlns:a="http://schemas.openxmlformats.org/drawingml/2006/main">
               <a:ext uri="{FF2B5EF4-FFF2-40B4-BE49-F238E27FC236}">
-                <a16:creationId xmlns:a16="http://schemas.microsoft.com/office/drawing/2014/main" id="{CDDA3CB1-92A1-4486-BA44-A15539BB56C4}"/>
+                <a16:creationId xmlns:a16="http://schemas.microsoft.com/office/drawing/2014/main" id="{104B7AC4-1820-49E5-9A2E-1289124460B6}"/>
               </a:ext>
             </a:extLst>
           </p:cNvPr>
@@ -13652,7 +13762,7 @@
           <p:cNvPr id="4" name="ambient-glow">
             <a:extLst xmlns:a="http://schemas.openxmlformats.org/drawingml/2006/main">
               <a:ext uri="{FF2B5EF4-FFF2-40B4-BE49-F238E27FC236}">
-                <a16:creationId xmlns:a16="http://schemas.microsoft.com/office/drawing/2014/main" id="{19B00E16-4F96-4D4C-86B9-F803621859A0}"/>
+                <a16:creationId xmlns:a16="http://schemas.microsoft.com/office/drawing/2014/main" id="{8D91EB7E-F0C6-413B-B6A5-4E4862F39DBD}"/>
               </a:ext>
             </a:extLst>
           </p:cNvPr>
@@ -13689,7 +13799,7 @@
           <p:cNvPr id="5" name="ambient-core">
             <a:extLst xmlns:a="http://schemas.openxmlformats.org/drawingml/2006/main">
               <a:ext uri="{FF2B5EF4-FFF2-40B4-BE49-F238E27FC236}">
-                <a16:creationId xmlns:a16="http://schemas.microsoft.com/office/drawing/2014/main" id="{E2DF7569-4E9A-44AF-B623-91F0CB0405A6}"/>
+                <a16:creationId xmlns:a16="http://schemas.microsoft.com/office/drawing/2014/main" id="{6FB3E244-3556-4D85-B818-D495B3CC34F3}"/>
               </a:ext>
             </a:extLst>
           </p:cNvPr>
@@ -13726,7 +13836,7 @@
           <p:cNvPr id="6" name="section-number">
             <a:extLst xmlns:a="http://schemas.openxmlformats.org/drawingml/2006/main">
               <a:ext uri="{FF2B5EF4-FFF2-40B4-BE49-F238E27FC236}">
-                <a16:creationId xmlns:a16="http://schemas.microsoft.com/office/drawing/2014/main" id="{81342FDE-4A49-45ED-A7C6-9A0FB0EDE060}"/>
+                <a16:creationId xmlns:a16="http://schemas.microsoft.com/office/drawing/2014/main" id="{144386AA-44DE-4EDB-92D3-4D720A0AAAC5}"/>
               </a:ext>
             </a:extLst>
           </p:cNvPr>
@@ -13777,7 +13887,7 @@
           <p:cNvPr id="7" name="eyebrow">
             <a:extLst xmlns:a="http://schemas.openxmlformats.org/drawingml/2006/main">
               <a:ext uri="{FF2B5EF4-FFF2-40B4-BE49-F238E27FC236}">
-                <a16:creationId xmlns:a16="http://schemas.microsoft.com/office/drawing/2014/main" id="{3428A287-6DF4-4C7B-BE28-372ADFF7FEB3}"/>
+                <a16:creationId xmlns:a16="http://schemas.microsoft.com/office/drawing/2014/main" id="{710356C0-EE66-4C80-A1E4-72F547C9BD92}"/>
               </a:ext>
             </a:extLst>
           </p:cNvPr>
@@ -13828,7 +13938,7 @@
           <p:cNvPr id="8" name="footer-rule">
             <a:extLst xmlns:a="http://schemas.openxmlformats.org/drawingml/2006/main">
               <a:ext uri="{FF2B5EF4-FFF2-40B4-BE49-F238E27FC236}">
-                <a16:creationId xmlns:a16="http://schemas.microsoft.com/office/drawing/2014/main" id="{605A1B23-B3B3-4FCE-8645-F8010F5CB236}"/>
+                <a16:creationId xmlns:a16="http://schemas.microsoft.com/office/drawing/2014/main" id="{63CE5B2B-CF89-4BDB-9721-A3F79348BF1F}"/>
               </a:ext>
             </a:extLst>
           </p:cNvPr>
@@ -13861,7 +13971,7 @@
           <p:cNvPr id="9" name="footer">
             <a:extLst xmlns:a="http://schemas.openxmlformats.org/drawingml/2006/main">
               <a:ext uri="{FF2B5EF4-FFF2-40B4-BE49-F238E27FC236}">
-                <a16:creationId xmlns:a16="http://schemas.microsoft.com/office/drawing/2014/main" id="{83DF2ABE-4A6F-401A-854A-C40B8F2460D0}"/>
+                <a16:creationId xmlns:a16="http://schemas.microsoft.com/office/drawing/2014/main" id="{31C11E22-2B80-47A8-A663-03F2D2B268D4}"/>
               </a:ext>
             </a:extLst>
           </p:cNvPr>
@@ -13916,7 +14026,7 @@
           <p:cNvPr id="10" name="page-number">
             <a:extLst xmlns:a="http://schemas.openxmlformats.org/drawingml/2006/main">
               <a:ext uri="{FF2B5EF4-FFF2-40B4-BE49-F238E27FC236}">
-                <a16:creationId xmlns:a16="http://schemas.microsoft.com/office/drawing/2014/main" id="{84FEB41A-B53E-432E-81CD-577004B5C3F8}"/>
+                <a16:creationId xmlns:a16="http://schemas.microsoft.com/office/drawing/2014/main" id="{0D7066C9-8303-40EA-AF0E-596696391817}"/>
               </a:ext>
             </a:extLst>
           </p:cNvPr>
@@ -13969,7 +14079,7 @@
     </p:spTree>
     <p:extLst>
       <p:ext uri="{BB962C8B-B14F-4D97-AF65-F5344CB8AC3E}">
-        <p14:creationId xmlns:p14="http://schemas.microsoft.com/office/powerpoint/2010/main" val="2093197839"/>
+        <p14:creationId xmlns:p14="http://schemas.microsoft.com/office/powerpoint/2010/main" val="1063992983"/>
       </p:ext>
     </p:extLst>
   </p:cSld>
@@ -14000,7 +14110,7 @@
           <p:cNvPr id="11" name="slide-title">
             <a:extLst xmlns:a="http://schemas.openxmlformats.org/drawingml/2006/main">
               <a:ext uri="{FF2B5EF4-FFF2-40B4-BE49-F238E27FC236}">
-                <a16:creationId xmlns:a16="http://schemas.microsoft.com/office/drawing/2014/main" id="{794B08C6-15BA-45F0-ADF0-1FB282CFF4ED}"/>
+                <a16:creationId xmlns:a16="http://schemas.microsoft.com/office/drawing/2014/main" id="{BDD4F6D8-4B3E-49E8-80B1-8F4029B19B3F}"/>
               </a:ext>
             </a:extLst>
           </p:cNvPr>
@@ -14051,7 +14161,7 @@
           <p:cNvPr id="2" name="slide-subtitle">
             <a:extLst xmlns:a="http://schemas.openxmlformats.org/drawingml/2006/main">
               <a:ext uri="{FF2B5EF4-FFF2-40B4-BE49-F238E27FC236}">
-                <a16:creationId xmlns:a16="http://schemas.microsoft.com/office/drawing/2014/main" id="{9D8DE731-3496-4503-A905-002B0E8CD377}"/>
+                <a16:creationId xmlns:a16="http://schemas.microsoft.com/office/drawing/2014/main" id="{5408FDA1-1C52-42E5-9DD0-E064F194E6EF}"/>
               </a:ext>
             </a:extLst>
           </p:cNvPr>
@@ -14102,7 +14212,7 @@
           <p:cNvPr id="3" name="bullets">
             <a:extLst xmlns:a="http://schemas.openxmlformats.org/drawingml/2006/main">
               <a:ext uri="{FF2B5EF4-FFF2-40B4-BE49-F238E27FC236}">
-                <a16:creationId xmlns:a16="http://schemas.microsoft.com/office/drawing/2014/main" id="{016324DB-62C3-4195-B2AA-C86927C92C2B}"/>
+                <a16:creationId xmlns:a16="http://schemas.microsoft.com/office/drawing/2014/main" id="{1C250498-8BBC-4E72-9C5F-DEE3530F9259}"/>
               </a:ext>
             </a:extLst>
           </p:cNvPr>
@@ -14189,7 +14299,7 @@
           <p:cNvPr id="4" name="ambient-glow">
             <a:extLst xmlns:a="http://schemas.openxmlformats.org/drawingml/2006/main">
               <a:ext uri="{FF2B5EF4-FFF2-40B4-BE49-F238E27FC236}">
-                <a16:creationId xmlns:a16="http://schemas.microsoft.com/office/drawing/2014/main" id="{EFCD3574-DF06-46F4-A659-CDCF3632109A}"/>
+                <a16:creationId xmlns:a16="http://schemas.microsoft.com/office/drawing/2014/main" id="{A28E08BD-28CC-4BC8-9F14-67108CAC9253}"/>
               </a:ext>
             </a:extLst>
           </p:cNvPr>
@@ -14226,7 +14336,7 @@
           <p:cNvPr id="5" name="ambient-core">
             <a:extLst xmlns:a="http://schemas.openxmlformats.org/drawingml/2006/main">
               <a:ext uri="{FF2B5EF4-FFF2-40B4-BE49-F238E27FC236}">
-                <a16:creationId xmlns:a16="http://schemas.microsoft.com/office/drawing/2014/main" id="{A7E43C83-C407-421B-B4DA-5A8FD94A7BDA}"/>
+                <a16:creationId xmlns:a16="http://schemas.microsoft.com/office/drawing/2014/main" id="{1E559AB6-23AE-4544-90CE-ADA17D8DD18F}"/>
               </a:ext>
             </a:extLst>
           </p:cNvPr>
@@ -14263,7 +14373,7 @@
           <p:cNvPr id="6" name="section-number">
             <a:extLst xmlns:a="http://schemas.openxmlformats.org/drawingml/2006/main">
               <a:ext uri="{FF2B5EF4-FFF2-40B4-BE49-F238E27FC236}">
-                <a16:creationId xmlns:a16="http://schemas.microsoft.com/office/drawing/2014/main" id="{95641522-B7BD-41A2-8495-FC495A0297C2}"/>
+                <a16:creationId xmlns:a16="http://schemas.microsoft.com/office/drawing/2014/main" id="{F19BD2F0-A8B6-4C51-9CB4-241513EEFBE9}"/>
               </a:ext>
             </a:extLst>
           </p:cNvPr>
@@ -14314,7 +14424,7 @@
           <p:cNvPr id="7" name="eyebrow">
             <a:extLst xmlns:a="http://schemas.openxmlformats.org/drawingml/2006/main">
               <a:ext uri="{FF2B5EF4-FFF2-40B4-BE49-F238E27FC236}">
-                <a16:creationId xmlns:a16="http://schemas.microsoft.com/office/drawing/2014/main" id="{DAE307DF-3C01-41AE-8DF9-BA2F0E489561}"/>
+                <a16:creationId xmlns:a16="http://schemas.microsoft.com/office/drawing/2014/main" id="{99C1408B-9D50-4EB4-BD2A-EA886245DF67}"/>
               </a:ext>
             </a:extLst>
           </p:cNvPr>
@@ -14365,7 +14475,7 @@
           <p:cNvPr id="8" name="footer-rule">
             <a:extLst xmlns:a="http://schemas.openxmlformats.org/drawingml/2006/main">
               <a:ext uri="{FF2B5EF4-FFF2-40B4-BE49-F238E27FC236}">
-                <a16:creationId xmlns:a16="http://schemas.microsoft.com/office/drawing/2014/main" id="{D4E5AB48-6A1F-4B8F-910B-AFA68468E0FF}"/>
+                <a16:creationId xmlns:a16="http://schemas.microsoft.com/office/drawing/2014/main" id="{A3D1EE50-CCC0-4FB9-BF48-4AE44F408FC7}"/>
               </a:ext>
             </a:extLst>
           </p:cNvPr>
@@ -14398,7 +14508,7 @@
           <p:cNvPr id="9" name="footer">
             <a:extLst xmlns:a="http://schemas.openxmlformats.org/drawingml/2006/main">
               <a:ext uri="{FF2B5EF4-FFF2-40B4-BE49-F238E27FC236}">
-                <a16:creationId xmlns:a16="http://schemas.microsoft.com/office/drawing/2014/main" id="{F78557A4-C677-41D0-ABF3-A179526088E1}"/>
+                <a16:creationId xmlns:a16="http://schemas.microsoft.com/office/drawing/2014/main" id="{DC80ACCE-3A32-4B8A-BB0A-10858B31EC0F}"/>
               </a:ext>
             </a:extLst>
           </p:cNvPr>
@@ -14453,7 +14563,7 @@
           <p:cNvPr id="10" name="page-number">
             <a:extLst xmlns:a="http://schemas.openxmlformats.org/drawingml/2006/main">
               <a:ext uri="{FF2B5EF4-FFF2-40B4-BE49-F238E27FC236}">
-                <a16:creationId xmlns:a16="http://schemas.microsoft.com/office/drawing/2014/main" id="{8D0B3884-E153-4309-AB4A-76EC7CE5DA8F}"/>
+                <a16:creationId xmlns:a16="http://schemas.microsoft.com/office/drawing/2014/main" id="{9F13160E-F9E6-4D86-9C69-AD933FD63AAE}"/>
               </a:ext>
             </a:extLst>
           </p:cNvPr>
@@ -14506,7 +14616,7 @@
     </p:spTree>
     <p:extLst>
       <p:ext uri="{BB962C8B-B14F-4D97-AF65-F5344CB8AC3E}">
-        <p14:creationId xmlns:p14="http://schemas.microsoft.com/office/powerpoint/2010/main" val="1531820784"/>
+        <p14:creationId xmlns:p14="http://schemas.microsoft.com/office/powerpoint/2010/main" val="2043973957"/>
       </p:ext>
     </p:extLst>
   </p:cSld>
@@ -14545,7 +14655,7 @@
           <p:cNvPr id="10" name="slide-title">
             <a:extLst xmlns:a="http://schemas.openxmlformats.org/drawingml/2006/main">
               <a:ext uri="{FF2B5EF4-FFF2-40B4-BE49-F238E27FC236}">
-                <a16:creationId xmlns:a16="http://schemas.microsoft.com/office/drawing/2014/main" id="{5DB0E79D-F99B-489E-A35B-C7E48A95F286}"/>
+                <a16:creationId xmlns:a16="http://schemas.microsoft.com/office/drawing/2014/main" id="{074E39BB-5F40-4A19-AFFC-957BD4CDD1AD}"/>
               </a:ext>
             </a:extLst>
           </p:cNvPr>
@@ -14596,7 +14706,7 @@
           <p:cNvPr id="2" name="visual-claim">
             <a:extLst xmlns:a="http://schemas.openxmlformats.org/drawingml/2006/main">
               <a:ext uri="{FF2B5EF4-FFF2-40B4-BE49-F238E27FC236}">
-                <a16:creationId xmlns:a16="http://schemas.microsoft.com/office/drawing/2014/main" id="{BFA0B6C8-1EE6-46C6-A9EE-20605E91868B}"/>
+                <a16:creationId xmlns:a16="http://schemas.microsoft.com/office/drawing/2014/main" id="{32F768F0-579D-4D55-80E5-FA7A5A08614C}"/>
               </a:ext>
             </a:extLst>
           </p:cNvPr>
@@ -14647,7 +14757,7 @@
           <p:cNvPr id="3" name="image-surface">
             <a:extLst xmlns:a="http://schemas.openxmlformats.org/drawingml/2006/main">
               <a:ext uri="{FF2B5EF4-FFF2-40B4-BE49-F238E27FC236}">
-                <a16:creationId xmlns:a16="http://schemas.microsoft.com/office/drawing/2014/main" id="{550CEB68-11CA-43F2-9555-C00C61EFE80B}"/>
+                <a16:creationId xmlns:a16="http://schemas.microsoft.com/office/drawing/2014/main" id="{C23E5211-B61B-473B-B323-350ADFC35EF0}"/>
               </a:ext>
             </a:extLst>
           </p:cNvPr>
@@ -14688,7 +14798,7 @@
           <p:nvPr/>
         </p:nvPicPr>
         <p:blipFill>
-          <a:blip xmlns:r="http://schemas.openxmlformats.org/officeDocument/2006/relationships" xmlns:a="http://schemas.openxmlformats.org/drawingml/2006/main" r:embed="R326f346a1b954541"/>
+          <a:blip xmlns:r="http://schemas.openxmlformats.org/officeDocument/2006/relationships" xmlns:a="http://schemas.openxmlformats.org/drawingml/2006/main" r:embed="R00b51b5630de48c2"/>
           <a:stretch xmlns:a="http://schemas.openxmlformats.org/drawingml/2006/main"/>
         </p:blipFill>
         <p:spPr>
@@ -14706,7 +14816,7 @@
           <p:cNvPr id="5" name="image-caption">
             <a:extLst xmlns:a="http://schemas.openxmlformats.org/drawingml/2006/main">
               <a:ext uri="{FF2B5EF4-FFF2-40B4-BE49-F238E27FC236}">
-                <a16:creationId xmlns:a16="http://schemas.microsoft.com/office/drawing/2014/main" id="{AD96B82B-E388-4606-AAC5-7FD05C99A3FD}"/>
+                <a16:creationId xmlns:a16="http://schemas.microsoft.com/office/drawing/2014/main" id="{A2B5984E-D667-4214-B0B0-A1EABCB140C7}"/>
               </a:ext>
             </a:extLst>
           </p:cNvPr>
@@ -14757,7 +14867,7 @@
           <p:cNvPr id="6" name="eyebrow">
             <a:extLst xmlns:a="http://schemas.openxmlformats.org/drawingml/2006/main">
               <a:ext uri="{FF2B5EF4-FFF2-40B4-BE49-F238E27FC236}">
-                <a16:creationId xmlns:a16="http://schemas.microsoft.com/office/drawing/2014/main" id="{2129B35A-63E3-4A01-BD6E-3DBD50BCC6BB}"/>
+                <a16:creationId xmlns:a16="http://schemas.microsoft.com/office/drawing/2014/main" id="{A29F5DA5-66BA-44CD-AC19-315108068C3B}"/>
               </a:ext>
             </a:extLst>
           </p:cNvPr>
@@ -14808,7 +14918,7 @@
           <p:cNvPr id="7" name="footer-rule">
             <a:extLst xmlns:a="http://schemas.openxmlformats.org/drawingml/2006/main">
               <a:ext uri="{FF2B5EF4-FFF2-40B4-BE49-F238E27FC236}">
-                <a16:creationId xmlns:a16="http://schemas.microsoft.com/office/drawing/2014/main" id="{FF94E938-934D-427C-9467-86E546CF98BF}"/>
+                <a16:creationId xmlns:a16="http://schemas.microsoft.com/office/drawing/2014/main" id="{35D0AB36-53BC-4533-9911-2F82471E394F}"/>
               </a:ext>
             </a:extLst>
           </p:cNvPr>
@@ -14841,7 +14951,7 @@
           <p:cNvPr id="8" name="footer">
             <a:extLst xmlns:a="http://schemas.openxmlformats.org/drawingml/2006/main">
               <a:ext uri="{FF2B5EF4-FFF2-40B4-BE49-F238E27FC236}">
-                <a16:creationId xmlns:a16="http://schemas.microsoft.com/office/drawing/2014/main" id="{881FD1F0-BAF5-4449-A6EC-19F4821DFA4C}"/>
+                <a16:creationId xmlns:a16="http://schemas.microsoft.com/office/drawing/2014/main" id="{81816DBE-5F3B-4987-8BF8-4E9DACA23E33}"/>
               </a:ext>
             </a:extLst>
           </p:cNvPr>
@@ -14896,7 +15006,7 @@
           <p:cNvPr id="9" name="page-number">
             <a:extLst xmlns:a="http://schemas.openxmlformats.org/drawingml/2006/main">
               <a:ext uri="{FF2B5EF4-FFF2-40B4-BE49-F238E27FC236}">
-                <a16:creationId xmlns:a16="http://schemas.microsoft.com/office/drawing/2014/main" id="{F5566D0F-98E0-45D1-9DEB-8DB203E8103B}"/>
+                <a16:creationId xmlns:a16="http://schemas.microsoft.com/office/drawing/2014/main" id="{7E0BC533-7286-40FA-9A73-EB9AB40E0F2C}"/>
               </a:ext>
             </a:extLst>
           </p:cNvPr>
@@ -14949,7 +15059,7 @@
     </p:spTree>
     <p:extLst>
       <p:ext uri="{BB962C8B-B14F-4D97-AF65-F5344CB8AC3E}">
-        <p14:creationId xmlns:p14="http://schemas.microsoft.com/office/powerpoint/2010/main" val="1473119199"/>
+        <p14:creationId xmlns:p14="http://schemas.microsoft.com/office/powerpoint/2010/main" val="1524364088"/>
       </p:ext>
     </p:extLst>
   </p:cSld>
@@ -14988,7 +15098,7 @@
           <p:cNvPr id="11" name="slide-title">
             <a:extLst xmlns:a="http://schemas.openxmlformats.org/drawingml/2006/main">
               <a:ext uri="{FF2B5EF4-FFF2-40B4-BE49-F238E27FC236}">
-                <a16:creationId xmlns:a16="http://schemas.microsoft.com/office/drawing/2014/main" id="{F8EAC34F-4E31-42E9-A421-4CFF88A1344A}"/>
+                <a16:creationId xmlns:a16="http://schemas.microsoft.com/office/drawing/2014/main" id="{A596FD48-1DC8-465F-A2C7-C80E12BA7F6B}"/>
               </a:ext>
             </a:extLst>
           </p:cNvPr>
@@ -15039,7 +15149,7 @@
           <p:cNvPr id="2" name="slide-subtitle">
             <a:extLst xmlns:a="http://schemas.openxmlformats.org/drawingml/2006/main">
               <a:ext uri="{FF2B5EF4-FFF2-40B4-BE49-F238E27FC236}">
-                <a16:creationId xmlns:a16="http://schemas.microsoft.com/office/drawing/2014/main" id="{D258FEB1-A662-41F6-B2C5-687AF1796BFB}"/>
+                <a16:creationId xmlns:a16="http://schemas.microsoft.com/office/drawing/2014/main" id="{10A2F2E4-DDCE-4B87-AFA9-100C22FA3B47}"/>
               </a:ext>
             </a:extLst>
           </p:cNvPr>
@@ -15090,7 +15200,7 @@
           <p:cNvPr id="3" name="bullets">
             <a:extLst xmlns:a="http://schemas.openxmlformats.org/drawingml/2006/main">
               <a:ext uri="{FF2B5EF4-FFF2-40B4-BE49-F238E27FC236}">
-                <a16:creationId xmlns:a16="http://schemas.microsoft.com/office/drawing/2014/main" id="{D2F822F8-4A9E-4246-B52D-5BDD3D3C62C2}"/>
+                <a16:creationId xmlns:a16="http://schemas.microsoft.com/office/drawing/2014/main" id="{A2F0054D-B872-4D6F-9FE5-AF5B8672C66E}"/>
               </a:ext>
             </a:extLst>
           </p:cNvPr>
@@ -15195,7 +15305,7 @@
           <p:cNvPr id="4" name="ambient-glow">
             <a:extLst xmlns:a="http://schemas.openxmlformats.org/drawingml/2006/main">
               <a:ext uri="{FF2B5EF4-FFF2-40B4-BE49-F238E27FC236}">
-                <a16:creationId xmlns:a16="http://schemas.microsoft.com/office/drawing/2014/main" id="{B4A87DDC-1F9F-4CE4-9284-9AEA047E7AA6}"/>
+                <a16:creationId xmlns:a16="http://schemas.microsoft.com/office/drawing/2014/main" id="{155CA596-AF89-460E-8422-CFBE1A35F6E7}"/>
               </a:ext>
             </a:extLst>
           </p:cNvPr>
@@ -15232,7 +15342,7 @@
           <p:cNvPr id="5" name="ambient-core">
             <a:extLst xmlns:a="http://schemas.openxmlformats.org/drawingml/2006/main">
               <a:ext uri="{FF2B5EF4-FFF2-40B4-BE49-F238E27FC236}">
-                <a16:creationId xmlns:a16="http://schemas.microsoft.com/office/drawing/2014/main" id="{23D38CB9-9B9E-4B50-9F9C-F5EA1D6BB363}"/>
+                <a16:creationId xmlns:a16="http://schemas.microsoft.com/office/drawing/2014/main" id="{22258744-27E3-4A8F-BCE9-AADDB7796C3F}"/>
               </a:ext>
             </a:extLst>
           </p:cNvPr>
@@ -15269,7 +15379,7 @@
           <p:cNvPr id="6" name="section-number">
             <a:extLst xmlns:a="http://schemas.openxmlformats.org/drawingml/2006/main">
               <a:ext uri="{FF2B5EF4-FFF2-40B4-BE49-F238E27FC236}">
-                <a16:creationId xmlns:a16="http://schemas.microsoft.com/office/drawing/2014/main" id="{241E1676-B501-4197-8971-9F2B97E46328}"/>
+                <a16:creationId xmlns:a16="http://schemas.microsoft.com/office/drawing/2014/main" id="{35266A81-A4C9-4EBB-920A-A44888DBDCD2}"/>
               </a:ext>
             </a:extLst>
           </p:cNvPr>
@@ -15320,7 +15430,7 @@
           <p:cNvPr id="7" name="eyebrow">
             <a:extLst xmlns:a="http://schemas.openxmlformats.org/drawingml/2006/main">
               <a:ext uri="{FF2B5EF4-FFF2-40B4-BE49-F238E27FC236}">
-                <a16:creationId xmlns:a16="http://schemas.microsoft.com/office/drawing/2014/main" id="{E6D4EEB1-BED5-45A6-BA37-E59FD19BB7DF}"/>
+                <a16:creationId xmlns:a16="http://schemas.microsoft.com/office/drawing/2014/main" id="{815CCA0E-5D44-4992-BF96-094FC0F96F72}"/>
               </a:ext>
             </a:extLst>
           </p:cNvPr>
@@ -15371,7 +15481,7 @@
           <p:cNvPr id="8" name="footer-rule">
             <a:extLst xmlns:a="http://schemas.openxmlformats.org/drawingml/2006/main">
               <a:ext uri="{FF2B5EF4-FFF2-40B4-BE49-F238E27FC236}">
-                <a16:creationId xmlns:a16="http://schemas.microsoft.com/office/drawing/2014/main" id="{50550AE6-6983-430F-B788-A3F51ED1A16B}"/>
+                <a16:creationId xmlns:a16="http://schemas.microsoft.com/office/drawing/2014/main" id="{80014A9D-95D4-4D10-92A0-26D693C8FB55}"/>
               </a:ext>
             </a:extLst>
           </p:cNvPr>
@@ -15404,7 +15514,7 @@
           <p:cNvPr id="9" name="footer">
             <a:extLst xmlns:a="http://schemas.openxmlformats.org/drawingml/2006/main">
               <a:ext uri="{FF2B5EF4-FFF2-40B4-BE49-F238E27FC236}">
-                <a16:creationId xmlns:a16="http://schemas.microsoft.com/office/drawing/2014/main" id="{299E9AD1-5899-4193-B57D-BB4AF4AC305F}"/>
+                <a16:creationId xmlns:a16="http://schemas.microsoft.com/office/drawing/2014/main" id="{9A503593-72D0-4F54-8203-8432F717C2D5}"/>
               </a:ext>
             </a:extLst>
           </p:cNvPr>
@@ -15459,7 +15569,7 @@
           <p:cNvPr id="10" name="page-number">
             <a:extLst xmlns:a="http://schemas.openxmlformats.org/drawingml/2006/main">
               <a:ext uri="{FF2B5EF4-FFF2-40B4-BE49-F238E27FC236}">
-                <a16:creationId xmlns:a16="http://schemas.microsoft.com/office/drawing/2014/main" id="{F82E1A82-8335-483D-9A75-F279B7B1F742}"/>
+                <a16:creationId xmlns:a16="http://schemas.microsoft.com/office/drawing/2014/main" id="{83A1C053-F2AA-4F58-AEF5-177AD0BA8A32}"/>
               </a:ext>
             </a:extLst>
           </p:cNvPr>
@@ -15512,7 +15622,7 @@
     </p:spTree>
     <p:extLst>
       <p:ext uri="{BB962C8B-B14F-4D97-AF65-F5344CB8AC3E}">
-        <p14:creationId xmlns:p14="http://schemas.microsoft.com/office/powerpoint/2010/main" val="1285427839"/>
+        <p14:creationId xmlns:p14="http://schemas.microsoft.com/office/powerpoint/2010/main" val="1237958100"/>
       </p:ext>
     </p:extLst>
   </p:cSld>
@@ -15543,7 +15653,7 @@
           <p:cNvPr id="10" name="slide-title">
             <a:extLst xmlns:a="http://schemas.openxmlformats.org/drawingml/2006/main">
               <a:ext uri="{FF2B5EF4-FFF2-40B4-BE49-F238E27FC236}">
-                <a16:creationId xmlns:a16="http://schemas.microsoft.com/office/drawing/2014/main" id="{C00BA1BC-C99A-473C-98A7-41D667E8C385}"/>
+                <a16:creationId xmlns:a16="http://schemas.microsoft.com/office/drawing/2014/main" id="{7492B470-F607-4715-B1BC-BAF1E8F0EA2A}"/>
               </a:ext>
             </a:extLst>
           </p:cNvPr>
@@ -15594,7 +15704,7 @@
           <p:cNvPr id="2" name="visual-claim">
             <a:extLst xmlns:a="http://schemas.openxmlformats.org/drawingml/2006/main">
               <a:ext uri="{FF2B5EF4-FFF2-40B4-BE49-F238E27FC236}">
-                <a16:creationId xmlns:a16="http://schemas.microsoft.com/office/drawing/2014/main" id="{53912B23-77A1-40D8-871E-29FF0C4AA9E4}"/>
+                <a16:creationId xmlns:a16="http://schemas.microsoft.com/office/drawing/2014/main" id="{6CA41905-901E-48D5-BA33-421B2C4CC693}"/>
               </a:ext>
             </a:extLst>
           </p:cNvPr>
@@ -15645,7 +15755,7 @@
           <p:cNvPr id="3" name="image-surface">
             <a:extLst xmlns:a="http://schemas.openxmlformats.org/drawingml/2006/main">
               <a:ext uri="{FF2B5EF4-FFF2-40B4-BE49-F238E27FC236}">
-                <a16:creationId xmlns:a16="http://schemas.microsoft.com/office/drawing/2014/main" id="{0B0E71C5-4CC1-478B-B4B3-534C0C62495B}"/>
+                <a16:creationId xmlns:a16="http://schemas.microsoft.com/office/drawing/2014/main" id="{5A89A0D0-2671-4A8B-8E1B-9D9403A64150}"/>
               </a:ext>
             </a:extLst>
           </p:cNvPr>
@@ -15684,7 +15794,7 @@
           <p:nvPr/>
         </p:nvPicPr>
         <p:blipFill>
-          <a:blip xmlns:r="http://schemas.openxmlformats.org/officeDocument/2006/relationships" xmlns:a="http://schemas.openxmlformats.org/drawingml/2006/main" r:embed="Rb8f5d1c562d049fd"/>
+          <a:blip xmlns:r="http://schemas.openxmlformats.org/officeDocument/2006/relationships" xmlns:a="http://schemas.openxmlformats.org/drawingml/2006/main" r:embed="R1161e5fcb8ef47ba"/>
           <a:stretch xmlns:a="http://schemas.openxmlformats.org/drawingml/2006/main"/>
         </p:blipFill>
         <p:spPr>
@@ -15702,7 +15812,7 @@
           <p:cNvPr id="5" name="image-caption">
             <a:extLst xmlns:a="http://schemas.openxmlformats.org/drawingml/2006/main">
               <a:ext uri="{FF2B5EF4-FFF2-40B4-BE49-F238E27FC236}">
-                <a16:creationId xmlns:a16="http://schemas.microsoft.com/office/drawing/2014/main" id="{1ACC9251-C710-40D0-B484-93BB18DE6955}"/>
+                <a16:creationId xmlns:a16="http://schemas.microsoft.com/office/drawing/2014/main" id="{926142FD-DAEE-4548-BC10-76AD24F66E46}"/>
               </a:ext>
             </a:extLst>
           </p:cNvPr>
@@ -15753,7 +15863,7 @@
           <p:cNvPr id="6" name="eyebrow">
             <a:extLst xmlns:a="http://schemas.openxmlformats.org/drawingml/2006/main">
               <a:ext uri="{FF2B5EF4-FFF2-40B4-BE49-F238E27FC236}">
-                <a16:creationId xmlns:a16="http://schemas.microsoft.com/office/drawing/2014/main" id="{B89A6885-4B55-49D2-8AAF-AEF1CDD51A46}"/>
+                <a16:creationId xmlns:a16="http://schemas.microsoft.com/office/drawing/2014/main" id="{6D154E49-7C01-4855-9400-C4121E4EBB91}"/>
               </a:ext>
             </a:extLst>
           </p:cNvPr>
@@ -15804,7 +15914,7 @@
           <p:cNvPr id="7" name="footer-rule">
             <a:extLst xmlns:a="http://schemas.openxmlformats.org/drawingml/2006/main">
               <a:ext uri="{FF2B5EF4-FFF2-40B4-BE49-F238E27FC236}">
-                <a16:creationId xmlns:a16="http://schemas.microsoft.com/office/drawing/2014/main" id="{360BD1E4-AB8E-41DF-A0A9-0D57483AC7AA}"/>
+                <a16:creationId xmlns:a16="http://schemas.microsoft.com/office/drawing/2014/main" id="{859C49EA-20EE-443D-869A-FC1B274F674F}"/>
               </a:ext>
             </a:extLst>
           </p:cNvPr>
@@ -15837,7 +15947,7 @@
           <p:cNvPr id="8" name="footer">
             <a:extLst xmlns:a="http://schemas.openxmlformats.org/drawingml/2006/main">
               <a:ext uri="{FF2B5EF4-FFF2-40B4-BE49-F238E27FC236}">
-                <a16:creationId xmlns:a16="http://schemas.microsoft.com/office/drawing/2014/main" id="{99271A77-FBC3-40BE-993D-B5FC85BA6D6F}"/>
+                <a16:creationId xmlns:a16="http://schemas.microsoft.com/office/drawing/2014/main" id="{DE8CFEBE-D0DD-445E-96E9-B355E4EE7529}"/>
               </a:ext>
             </a:extLst>
           </p:cNvPr>
@@ -15892,7 +16002,7 @@
           <p:cNvPr id="9" name="page-number">
             <a:extLst xmlns:a="http://schemas.openxmlformats.org/drawingml/2006/main">
               <a:ext uri="{FF2B5EF4-FFF2-40B4-BE49-F238E27FC236}">
-                <a16:creationId xmlns:a16="http://schemas.microsoft.com/office/drawing/2014/main" id="{CA4E50B0-FCB5-4153-B42B-12E56FC4D1E3}"/>
+                <a16:creationId xmlns:a16="http://schemas.microsoft.com/office/drawing/2014/main" id="{20660817-3CCB-4189-B3D7-78F2E0440DBB}"/>
               </a:ext>
             </a:extLst>
           </p:cNvPr>
@@ -15945,7 +16055,7 @@
     </p:spTree>
     <p:extLst>
       <p:ext uri="{BB962C8B-B14F-4D97-AF65-F5344CB8AC3E}">
-        <p14:creationId xmlns:p14="http://schemas.microsoft.com/office/powerpoint/2010/main" val="645760378"/>
+        <p14:creationId xmlns:p14="http://schemas.microsoft.com/office/powerpoint/2010/main" val="2037243092"/>
       </p:ext>
     </p:extLst>
   </p:cSld>
@@ -15976,7 +16086,7 @@
           <p:cNvPr id="11" name="slide-title">
             <a:extLst xmlns:a="http://schemas.openxmlformats.org/drawingml/2006/main">
               <a:ext uri="{FF2B5EF4-FFF2-40B4-BE49-F238E27FC236}">
-                <a16:creationId xmlns:a16="http://schemas.microsoft.com/office/drawing/2014/main" id="{CCDB436E-7AB4-4839-9FB2-E799C8AD440C}"/>
+                <a16:creationId xmlns:a16="http://schemas.microsoft.com/office/drawing/2014/main" id="{40B94858-A4FB-4F30-99F9-2A91526E01A5}"/>
               </a:ext>
             </a:extLst>
           </p:cNvPr>
@@ -16027,7 +16137,7 @@
           <p:cNvPr id="2" name="slide-subtitle">
             <a:extLst xmlns:a="http://schemas.openxmlformats.org/drawingml/2006/main">
               <a:ext uri="{FF2B5EF4-FFF2-40B4-BE49-F238E27FC236}">
-                <a16:creationId xmlns:a16="http://schemas.microsoft.com/office/drawing/2014/main" id="{38F05AC6-E130-4EC7-B13E-4E4810C4CEF4}"/>
+                <a16:creationId xmlns:a16="http://schemas.microsoft.com/office/drawing/2014/main" id="{173D2599-B4D1-492F-B6EB-9F2A934A2D9A}"/>
               </a:ext>
             </a:extLst>
           </p:cNvPr>
@@ -16078,7 +16188,7 @@
           <p:cNvPr id="3" name="bullets">
             <a:extLst xmlns:a="http://schemas.openxmlformats.org/drawingml/2006/main">
               <a:ext uri="{FF2B5EF4-FFF2-40B4-BE49-F238E27FC236}">
-                <a16:creationId xmlns:a16="http://schemas.microsoft.com/office/drawing/2014/main" id="{06B808ED-FE4E-4290-AAC5-4A156699CE1B}"/>
+                <a16:creationId xmlns:a16="http://schemas.microsoft.com/office/drawing/2014/main" id="{BBEC3DD2-4027-43F4-B3B2-D413D6CD84AB}"/>
               </a:ext>
             </a:extLst>
           </p:cNvPr>
@@ -16183,7 +16293,7 @@
           <p:cNvPr id="4" name="ambient-glow">
             <a:extLst xmlns:a="http://schemas.openxmlformats.org/drawingml/2006/main">
               <a:ext uri="{FF2B5EF4-FFF2-40B4-BE49-F238E27FC236}">
-                <a16:creationId xmlns:a16="http://schemas.microsoft.com/office/drawing/2014/main" id="{39FBEA68-CA35-4024-B162-912431C67564}"/>
+                <a16:creationId xmlns:a16="http://schemas.microsoft.com/office/drawing/2014/main" id="{7AABF5DC-5271-4C29-95F3-A7C352055D05}"/>
               </a:ext>
             </a:extLst>
           </p:cNvPr>
@@ -16220,7 +16330,7 @@
           <p:cNvPr id="5" name="ambient-core">
             <a:extLst xmlns:a="http://schemas.openxmlformats.org/drawingml/2006/main">
               <a:ext uri="{FF2B5EF4-FFF2-40B4-BE49-F238E27FC236}">
-                <a16:creationId xmlns:a16="http://schemas.microsoft.com/office/drawing/2014/main" id="{9C30BCC6-BE7B-47EE-9797-7C9ADF7A7EE4}"/>
+                <a16:creationId xmlns:a16="http://schemas.microsoft.com/office/drawing/2014/main" id="{1CBA7B29-113F-436A-B05B-37E86ABDC716}"/>
               </a:ext>
             </a:extLst>
           </p:cNvPr>
@@ -16257,7 +16367,7 @@
           <p:cNvPr id="6" name="section-number">
             <a:extLst xmlns:a="http://schemas.openxmlformats.org/drawingml/2006/main">
               <a:ext uri="{FF2B5EF4-FFF2-40B4-BE49-F238E27FC236}">
-                <a16:creationId xmlns:a16="http://schemas.microsoft.com/office/drawing/2014/main" id="{75F9E7D3-DC51-4B37-8792-31A1615F49DD}"/>
+                <a16:creationId xmlns:a16="http://schemas.microsoft.com/office/drawing/2014/main" id="{1A2909C2-B916-412B-8DD5-D0F41AA7A5F9}"/>
               </a:ext>
             </a:extLst>
           </p:cNvPr>
@@ -16308,7 +16418,7 @@
           <p:cNvPr id="7" name="eyebrow">
             <a:extLst xmlns:a="http://schemas.openxmlformats.org/drawingml/2006/main">
               <a:ext uri="{FF2B5EF4-FFF2-40B4-BE49-F238E27FC236}">
-                <a16:creationId xmlns:a16="http://schemas.microsoft.com/office/drawing/2014/main" id="{B6F398CB-C54E-4910-B434-061467D8A0A3}"/>
+                <a16:creationId xmlns:a16="http://schemas.microsoft.com/office/drawing/2014/main" id="{FB073049-879B-4211-BABD-059C6A8DB4EA}"/>
               </a:ext>
             </a:extLst>
           </p:cNvPr>
@@ -16359,7 +16469,7 @@
           <p:cNvPr id="8" name="footer-rule">
             <a:extLst xmlns:a="http://schemas.openxmlformats.org/drawingml/2006/main">
               <a:ext uri="{FF2B5EF4-FFF2-40B4-BE49-F238E27FC236}">
-                <a16:creationId xmlns:a16="http://schemas.microsoft.com/office/drawing/2014/main" id="{C43ADDCC-26D2-473E-90BA-AB67EACAF6FD}"/>
+                <a16:creationId xmlns:a16="http://schemas.microsoft.com/office/drawing/2014/main" id="{33AC037C-D6CF-4294-87BC-AA5EA47E3E52}"/>
               </a:ext>
             </a:extLst>
           </p:cNvPr>
@@ -16392,7 +16502,7 @@
           <p:cNvPr id="9" name="footer">
             <a:extLst xmlns:a="http://schemas.openxmlformats.org/drawingml/2006/main">
               <a:ext uri="{FF2B5EF4-FFF2-40B4-BE49-F238E27FC236}">
-                <a16:creationId xmlns:a16="http://schemas.microsoft.com/office/drawing/2014/main" id="{B62742BB-EEED-4F83-988C-B8CF73B01A72}"/>
+                <a16:creationId xmlns:a16="http://schemas.microsoft.com/office/drawing/2014/main" id="{F0156CBF-ACED-4AD1-A72E-252093C6B1DF}"/>
               </a:ext>
             </a:extLst>
           </p:cNvPr>
@@ -16447,7 +16557,7 @@
           <p:cNvPr id="10" name="page-number">
             <a:extLst xmlns:a="http://schemas.openxmlformats.org/drawingml/2006/main">
               <a:ext uri="{FF2B5EF4-FFF2-40B4-BE49-F238E27FC236}">
-                <a16:creationId xmlns:a16="http://schemas.microsoft.com/office/drawing/2014/main" id="{636B48E0-C8F0-4776-B8C2-34524836B712}"/>
+                <a16:creationId xmlns:a16="http://schemas.microsoft.com/office/drawing/2014/main" id="{CD339325-6B17-43CC-88C4-DFD79CA854D3}"/>
               </a:ext>
             </a:extLst>
           </p:cNvPr>
@@ -16500,7 +16610,7 @@
     </p:spTree>
     <p:extLst>
       <p:ext uri="{BB962C8B-B14F-4D97-AF65-F5344CB8AC3E}">
-        <p14:creationId xmlns:p14="http://schemas.microsoft.com/office/powerpoint/2010/main" val="196273858"/>
+        <p14:creationId xmlns:p14="http://schemas.microsoft.com/office/powerpoint/2010/main" val="899343370"/>
       </p:ext>
     </p:extLst>
   </p:cSld>

</xml_diff>

<commit_message>
docs: atualiza Aula 0 com DuckDB UI por túnel
</commit_message>
<xml_diff>
--- a/assets/decks/aula-00-ambiente.pptx
+++ b/assets/decks/aula-00-ambiente.pptx
@@ -2,35 +2,35 @@
 <file path=ppt/presentation.xml><?xml version="1.0" encoding="utf-8"?>
 <p:presentation xmlns:p="http://schemas.openxmlformats.org/presentationml/2006/main">
   <p:sldMasterIdLst>
-    <p:sldMasterId xmlns:r="http://schemas.openxmlformats.org/officeDocument/2006/relationships" id="2147483648" r:id="Rc66e5b7fb55d4e43"/>
-    <p:sldMasterId xmlns:r="http://schemas.openxmlformats.org/officeDocument/2006/relationships" id="2147483650" r:id="Ra1129938354d4fff"/>
+    <p:sldMasterId xmlns:r="http://schemas.openxmlformats.org/officeDocument/2006/relationships" id="2147483648" r:id="R60f8e71a7024410c"/>
+    <p:sldMasterId xmlns:r="http://schemas.openxmlformats.org/officeDocument/2006/relationships" id="2147483650" r:id="R14cbf583ce314ae0"/>
   </p:sldMasterIdLst>
   <p:notesMasterIdLst>
-    <p:notesMasterId xmlns:r="http://schemas.openxmlformats.org/officeDocument/2006/relationships" r:id="R74ab74d2d2d54cf2"/>
+    <p:notesMasterId xmlns:r="http://schemas.openxmlformats.org/officeDocument/2006/relationships" r:id="Rc03f8807c30e487e"/>
   </p:notesMasterIdLst>
   <p:sldIdLst>
-    <p:sldId xmlns:r="http://schemas.openxmlformats.org/officeDocument/2006/relationships" id="256" r:id="R3c2a1984e69e4cd1"/>
-    <p:sldId xmlns:r="http://schemas.openxmlformats.org/officeDocument/2006/relationships" id="257" r:id="R5db3506aa6b44be0"/>
-    <p:sldId xmlns:r="http://schemas.openxmlformats.org/officeDocument/2006/relationships" id="258" r:id="Rdff649bbd8fc4935"/>
-    <p:sldId xmlns:r="http://schemas.openxmlformats.org/officeDocument/2006/relationships" id="259" r:id="R9f2934003c9541bf"/>
-    <p:sldId xmlns:r="http://schemas.openxmlformats.org/officeDocument/2006/relationships" id="260" r:id="Rf34580506b5848cc"/>
-    <p:sldId xmlns:r="http://schemas.openxmlformats.org/officeDocument/2006/relationships" id="261" r:id="R53cf2a8c16fb4e7b"/>
-    <p:sldId xmlns:r="http://schemas.openxmlformats.org/officeDocument/2006/relationships" id="262" r:id="R5f87d95035774db9"/>
-    <p:sldId xmlns:r="http://schemas.openxmlformats.org/officeDocument/2006/relationships" id="263" r:id="R5a44d33d6e7a45f4"/>
-    <p:sldId xmlns:r="http://schemas.openxmlformats.org/officeDocument/2006/relationships" id="264" r:id="Rd781cb3b63fb48a5"/>
-    <p:sldId xmlns:r="http://schemas.openxmlformats.org/officeDocument/2006/relationships" id="265" r:id="R06551596b6564829"/>
-    <p:sldId xmlns:r="http://schemas.openxmlformats.org/officeDocument/2006/relationships" id="266" r:id="R5b60132737184ba3"/>
-    <p:sldId xmlns:r="http://schemas.openxmlformats.org/officeDocument/2006/relationships" id="267" r:id="R6541fd5c798a4a54"/>
-    <p:sldId xmlns:r="http://schemas.openxmlformats.org/officeDocument/2006/relationships" id="268" r:id="R0af2143e96574d44"/>
-    <p:sldId xmlns:r="http://schemas.openxmlformats.org/officeDocument/2006/relationships" id="269" r:id="Reabdeaeefcd24f23"/>
-    <p:sldId xmlns:r="http://schemas.openxmlformats.org/officeDocument/2006/relationships" id="270" r:id="R0bd1d847e8c64027"/>
-    <p:sldId xmlns:r="http://schemas.openxmlformats.org/officeDocument/2006/relationships" id="271" r:id="Recb6eff5312a454c"/>
-    <p:sldId xmlns:r="http://schemas.openxmlformats.org/officeDocument/2006/relationships" id="272" r:id="Ra3959867e2684745"/>
-    <p:sldId xmlns:r="http://schemas.openxmlformats.org/officeDocument/2006/relationships" id="273" r:id="Rec9dbd45ea70458f"/>
-    <p:sldId xmlns:r="http://schemas.openxmlformats.org/officeDocument/2006/relationships" id="274" r:id="R6fbfcecdedce4aeb"/>
-    <p:sldId xmlns:r="http://schemas.openxmlformats.org/officeDocument/2006/relationships" id="275" r:id="R2978282a319040d7"/>
-    <p:sldId xmlns:r="http://schemas.openxmlformats.org/officeDocument/2006/relationships" id="276" r:id="Rd35efcbc966c491f"/>
-    <p:sldId xmlns:r="http://schemas.openxmlformats.org/officeDocument/2006/relationships" id="277" r:id="R4f18925249084e94"/>
+    <p:sldId xmlns:r="http://schemas.openxmlformats.org/officeDocument/2006/relationships" id="256" r:id="R95796218cc37415b"/>
+    <p:sldId xmlns:r="http://schemas.openxmlformats.org/officeDocument/2006/relationships" id="257" r:id="R86a26f9a8b7b4c5b"/>
+    <p:sldId xmlns:r="http://schemas.openxmlformats.org/officeDocument/2006/relationships" id="258" r:id="R4832c7d4d5294e57"/>
+    <p:sldId xmlns:r="http://schemas.openxmlformats.org/officeDocument/2006/relationships" id="259" r:id="Rffea5490777347ba"/>
+    <p:sldId xmlns:r="http://schemas.openxmlformats.org/officeDocument/2006/relationships" id="260" r:id="R5fcdf9e5e05f403c"/>
+    <p:sldId xmlns:r="http://schemas.openxmlformats.org/officeDocument/2006/relationships" id="261" r:id="Rabdcf25f3a424415"/>
+    <p:sldId xmlns:r="http://schemas.openxmlformats.org/officeDocument/2006/relationships" id="262" r:id="R60bdbfa943b241e9"/>
+    <p:sldId xmlns:r="http://schemas.openxmlformats.org/officeDocument/2006/relationships" id="263" r:id="R702a3001b837406c"/>
+    <p:sldId xmlns:r="http://schemas.openxmlformats.org/officeDocument/2006/relationships" id="264" r:id="Rb1b53e49ec724493"/>
+    <p:sldId xmlns:r="http://schemas.openxmlformats.org/officeDocument/2006/relationships" id="265" r:id="Rea4215a3142e427c"/>
+    <p:sldId xmlns:r="http://schemas.openxmlformats.org/officeDocument/2006/relationships" id="266" r:id="Rd0cf62f191d24b68"/>
+    <p:sldId xmlns:r="http://schemas.openxmlformats.org/officeDocument/2006/relationships" id="267" r:id="Rc59fd015e16b491e"/>
+    <p:sldId xmlns:r="http://schemas.openxmlformats.org/officeDocument/2006/relationships" id="268" r:id="R054c3884a2a241e0"/>
+    <p:sldId xmlns:r="http://schemas.openxmlformats.org/officeDocument/2006/relationships" id="269" r:id="R8fb70749c78c401c"/>
+    <p:sldId xmlns:r="http://schemas.openxmlformats.org/officeDocument/2006/relationships" id="270" r:id="Rf1c98e335fc34d00"/>
+    <p:sldId xmlns:r="http://schemas.openxmlformats.org/officeDocument/2006/relationships" id="271" r:id="Ra09408fb205846a4"/>
+    <p:sldId xmlns:r="http://schemas.openxmlformats.org/officeDocument/2006/relationships" id="272" r:id="R5b1d7a9210b7487c"/>
+    <p:sldId xmlns:r="http://schemas.openxmlformats.org/officeDocument/2006/relationships" id="273" r:id="Rff188005b8284a37"/>
+    <p:sldId xmlns:r="http://schemas.openxmlformats.org/officeDocument/2006/relationships" id="274" r:id="R2c1fa2dc15c04232"/>
+    <p:sldId xmlns:r="http://schemas.openxmlformats.org/officeDocument/2006/relationships" id="275" r:id="R44a5027d8fde4b61"/>
+    <p:sldId xmlns:r="http://schemas.openxmlformats.org/officeDocument/2006/relationships" id="276" r:id="R89aa6a2afa4e4760"/>
+    <p:sldId xmlns:r="http://schemas.openxmlformats.org/officeDocument/2006/relationships" id="277" r:id="Rc501fc345aca4c3f"/>
   </p:sldIdLst>
   <p:sldSz cx="12192000" cy="6858000"/>
   <p:notesSz cx="6858000" cy="9144000"/>
@@ -554,6 +554,16 @@
           </a:p>
           <a:p xmlns:a="http://schemas.openxmlformats.org/drawingml/2006/main">
             <a:r>
+              <a:t>- https://cli.github.com/manual/gh_codespace_ports_forward</a:t>
+            </a:r>
+          </a:p>
+          <a:p xmlns:a="http://schemas.openxmlformats.org/drawingml/2006/main">
+            <a:r>
+              <a:t>- https://duckdb.org/docs/current/core_extensions/ui</a:t>
+            </a:r>
+          </a:p>
+          <a:p xmlns:a="http://schemas.openxmlformats.org/drawingml/2006/main">
+            <a:r>
               <a:t>- https://github.com/duckdb/duckdb-ui/issues/22</a:t>
             </a:r>
           </a:p>
@@ -749,6 +759,16 @@
           </a:p>
           <a:p xmlns:a="http://schemas.openxmlformats.org/drawingml/2006/main">
             <a:r>
+              <a:t>- https://cli.github.com/manual/gh_codespace_ports_forward</a:t>
+            </a:r>
+          </a:p>
+          <a:p xmlns:a="http://schemas.openxmlformats.org/drawingml/2006/main">
+            <a:r>
+              <a:t>- https://duckdb.org/docs/current/core_extensions/ui</a:t>
+            </a:r>
+          </a:p>
+          <a:p xmlns:a="http://schemas.openxmlformats.org/drawingml/2006/main">
+            <a:r>
               <a:t>- https://github.com/duckdb/duckdb-ui/issues/22</a:t>
             </a:r>
           </a:p>
@@ -944,6 +964,16 @@
           </a:p>
           <a:p xmlns:a="http://schemas.openxmlformats.org/drawingml/2006/main">
             <a:r>
+              <a:t>- https://cli.github.com/manual/gh_codespace_ports_forward</a:t>
+            </a:r>
+          </a:p>
+          <a:p xmlns:a="http://schemas.openxmlformats.org/drawingml/2006/main">
+            <a:r>
+              <a:t>- https://duckdb.org/docs/current/core_extensions/ui</a:t>
+            </a:r>
+          </a:p>
+          <a:p xmlns:a="http://schemas.openxmlformats.org/drawingml/2006/main">
+            <a:r>
               <a:t>- https://github.com/duckdb/duckdb-ui/issues/22</a:t>
             </a:r>
           </a:p>
@@ -1099,7 +1129,7 @@
           </a:p>
           <a:p xmlns:a="http://schemas.openxmlformats.org/drawingml/2006/main">
             <a:r>
-              <a:t>Com esse ponto estabelecido, avance para “Explore a cópia do banco no navegador”.</a:t>
+              <a:t>Com esse ponto estabelecido, avance para “Escolha a interface certa para cada ambiente”.</a:t>
             </a:r>
           </a:p>
           <a:p xmlns:a="http://schemas.openxmlformats.org/drawingml/2006/main">
@@ -1135,6 +1165,16 @@
           <a:p xmlns:a="http://schemas.openxmlformats.org/drawingml/2006/main">
             <a:r>
               <a:t>- https://docs.github.com/en/codespaces/reference/security-in-github-codespaces</a:t>
+            </a:r>
+          </a:p>
+          <a:p xmlns:a="http://schemas.openxmlformats.org/drawingml/2006/main">
+            <a:r>
+              <a:t>- https://cli.github.com/manual/gh_codespace_ports_forward</a:t>
+            </a:r>
+          </a:p>
+          <a:p xmlns:a="http://schemas.openxmlformats.org/drawingml/2006/main">
+            <a:r>
+              <a:t>- https://duckdb.org/docs/current/core_extensions/ui</a:t>
             </a:r>
           </a:p>
           <a:p xmlns:a="http://schemas.openxmlformats.org/drawingml/2006/main">
@@ -1269,7 +1309,7 @@
           </a:p>
           <a:p xmlns:a="http://schemas.openxmlformats.org/drawingml/2006/main">
             <a:r>
-              <a:t>A mensagem principal deste slide é: O explorador autoral abre na porta privada 4213 sem modificar o banco usado pelo dbt. Para tornar isso concreto, observe snapshot somente leitura, Mantenha o terminal aberto e Ctrl+C encerra e permite atualizar. Esses pontos devem ser entendidos em conjunto; não são funcionalidades isoladas. No projeto, essa combinação transforma uma convenção informal em algo que pode ser revisado, testado ou consumido de maneira consistente.</a:t>
+              <a:t>A mensagem principal deste slide é: O explorador do curso funciona no navegador; a UI oficial exige um túnel que preserve localhost. Para tornar isso concreto, observe codespaces: python course.py official-data-ui, Local: gh auth refresh -h github.com -s codespace, Local: python course.py codespace-ui-tunnel e Navegador: http://localhost:4213. Esses pontos devem ser entendidos em conjunto; não são funcionalidades isoladas. No projeto, essa combinação transforma uma convenção informal em algo que pode ser revisado, testado ou consumido de maneira consistente.</a:t>
             </a:r>
           </a:p>
           <a:p xmlns:a="http://schemas.openxmlformats.org/drawingml/2006/main">
@@ -1299,7 +1339,7 @@
           </a:p>
           <a:p xmlns:a="http://schemas.openxmlformats.org/drawingml/2006/main">
             <a:r>
-              <a:t>Com esse ponto estabelecido, avance para “Explore a cópia do banco no navegador”.</a:t>
+              <a:t>Com esse ponto estabelecido, avance para “Escolha a interface certa para cada ambiente”.</a:t>
             </a:r>
           </a:p>
           <a:p xmlns:a="http://schemas.openxmlformats.org/drawingml/2006/main">
@@ -1335,6 +1375,16 @@
           <a:p xmlns:a="http://schemas.openxmlformats.org/drawingml/2006/main">
             <a:r>
               <a:t>- https://docs.github.com/en/codespaces/reference/security-in-github-codespaces</a:t>
+            </a:r>
+          </a:p>
+          <a:p xmlns:a="http://schemas.openxmlformats.org/drawingml/2006/main">
+            <a:r>
+              <a:t>- https://cli.github.com/manual/gh_codespace_ports_forward</a:t>
+            </a:r>
+          </a:p>
+          <a:p xmlns:a="http://schemas.openxmlformats.org/drawingml/2006/main">
+            <a:r>
+              <a:t>- https://duckdb.org/docs/current/core_extensions/ui</a:t>
             </a:r>
           </a:p>
           <a:p xmlns:a="http://schemas.openxmlformats.org/drawingml/2006/main">
@@ -1464,7 +1514,7 @@
           </a:p>
           <a:p xmlns:a="http://schemas.openxmlformats.org/drawingml/2006/main">
             <a:r>
-              <a:t>Agora vamos ler a ideia visualmente. O explorador autoral abre na porta privada 4213 sem modificar o banco usado pelo dbt. Siga a composição na ordem mostrada e conecte dbt build, snapshot, explorador e navegador. A imagem ou o fluxo não cria uma regra nova; ele torna visível a relação que acabamos de explicar. Use a disposição dos elementos para reforçar causa, dependência ou comparação.</a:t>
+              <a:t>Agora vamos ler a ideia visualmente. O explorador do curso funciona no navegador; a UI oficial exige um túnel que preserve localhost. Siga a composição na ordem mostrada e conecte duckDB, UI oficial, túnel e localhost. A imagem ou o fluxo não cria uma regra nova; ele torna visível a relação que acabamos de explicar. Use a disposição dos elementos para reforçar causa, dependência ou comparação.</a:t>
             </a:r>
           </a:p>
           <a:p xmlns:a="http://schemas.openxmlformats.org/drawingml/2006/main">
@@ -1530,6 +1580,16 @@
           <a:p xmlns:a="http://schemas.openxmlformats.org/drawingml/2006/main">
             <a:r>
               <a:t>- https://docs.github.com/en/codespaces/reference/security-in-github-codespaces</a:t>
+            </a:r>
+          </a:p>
+          <a:p xmlns:a="http://schemas.openxmlformats.org/drawingml/2006/main">
+            <a:r>
+              <a:t>- https://cli.github.com/manual/gh_codespace_ports_forward</a:t>
+            </a:r>
+          </a:p>
+          <a:p xmlns:a="http://schemas.openxmlformats.org/drawingml/2006/main">
+            <a:r>
+              <a:t>- https://duckdb.org/docs/current/core_extensions/ui</a:t>
             </a:r>
           </a:p>
           <a:p xmlns:a="http://schemas.openxmlformats.org/drawingml/2006/main">
@@ -1729,6 +1789,16 @@
           </a:p>
           <a:p xmlns:a="http://schemas.openxmlformats.org/drawingml/2006/main">
             <a:r>
+              <a:t>- https://cli.github.com/manual/gh_codespace_ports_forward</a:t>
+            </a:r>
+          </a:p>
+          <a:p xmlns:a="http://schemas.openxmlformats.org/drawingml/2006/main">
+            <a:r>
+              <a:t>- https://duckdb.org/docs/current/core_extensions/ui</a:t>
+            </a:r>
+          </a:p>
+          <a:p xmlns:a="http://schemas.openxmlformats.org/drawingml/2006/main">
+            <a:r>
               <a:t>- https://github.com/duckdb/duckdb-ui/issues/22</a:t>
             </a:r>
           </a:p>
@@ -1924,6 +1994,16 @@
           </a:p>
           <a:p xmlns:a="http://schemas.openxmlformats.org/drawingml/2006/main">
             <a:r>
+              <a:t>- https://cli.github.com/manual/gh_codespace_ports_forward</a:t>
+            </a:r>
+          </a:p>
+          <a:p xmlns:a="http://schemas.openxmlformats.org/drawingml/2006/main">
+            <a:r>
+              <a:t>- https://duckdb.org/docs/current/core_extensions/ui</a:t>
+            </a:r>
+          </a:p>
+          <a:p xmlns:a="http://schemas.openxmlformats.org/drawingml/2006/main">
+            <a:r>
               <a:t>- https://github.com/duckdb/duckdb-ui/issues/22</a:t>
             </a:r>
           </a:p>
@@ -2119,6 +2199,16 @@
           </a:p>
           <a:p xmlns:a="http://schemas.openxmlformats.org/drawingml/2006/main">
             <a:r>
+              <a:t>- https://cli.github.com/manual/gh_codespace_ports_forward</a:t>
+            </a:r>
+          </a:p>
+          <a:p xmlns:a="http://schemas.openxmlformats.org/drawingml/2006/main">
+            <a:r>
+              <a:t>- https://duckdb.org/docs/current/core_extensions/ui</a:t>
+            </a:r>
+          </a:p>
+          <a:p xmlns:a="http://schemas.openxmlformats.org/drawingml/2006/main">
+            <a:r>
               <a:t>- https://github.com/duckdb/duckdb-ui/issues/22</a:t>
             </a:r>
           </a:p>
@@ -2314,6 +2404,16 @@
           </a:p>
           <a:p xmlns:a="http://schemas.openxmlformats.org/drawingml/2006/main">
             <a:r>
+              <a:t>- https://cli.github.com/manual/gh_codespace_ports_forward</a:t>
+            </a:r>
+          </a:p>
+          <a:p xmlns:a="http://schemas.openxmlformats.org/drawingml/2006/main">
+            <a:r>
+              <a:t>- https://duckdb.org/docs/current/core_extensions/ui</a:t>
+            </a:r>
+          </a:p>
+          <a:p xmlns:a="http://schemas.openxmlformats.org/drawingml/2006/main">
+            <a:r>
               <a:t>- https://github.com/duckdb/duckdb-ui/issues/22</a:t>
             </a:r>
           </a:p>
@@ -2509,6 +2609,16 @@
           </a:p>
           <a:p xmlns:a="http://schemas.openxmlformats.org/drawingml/2006/main">
             <a:r>
+              <a:t>- https://cli.github.com/manual/gh_codespace_ports_forward</a:t>
+            </a:r>
+          </a:p>
+          <a:p xmlns:a="http://schemas.openxmlformats.org/drawingml/2006/main">
+            <a:r>
+              <a:t>- https://duckdb.org/docs/current/core_extensions/ui</a:t>
+            </a:r>
+          </a:p>
+          <a:p xmlns:a="http://schemas.openxmlformats.org/drawingml/2006/main">
+            <a:r>
               <a:t>- https://github.com/duckdb/duckdb-ui/issues/22</a:t>
             </a:r>
           </a:p>
@@ -2704,6 +2814,16 @@
           </a:p>
           <a:p xmlns:a="http://schemas.openxmlformats.org/drawingml/2006/main">
             <a:r>
+              <a:t>- https://cli.github.com/manual/gh_codespace_ports_forward</a:t>
+            </a:r>
+          </a:p>
+          <a:p xmlns:a="http://schemas.openxmlformats.org/drawingml/2006/main">
+            <a:r>
+              <a:t>- https://duckdb.org/docs/current/core_extensions/ui</a:t>
+            </a:r>
+          </a:p>
+          <a:p xmlns:a="http://schemas.openxmlformats.org/drawingml/2006/main">
+            <a:r>
               <a:t>- https://github.com/duckdb/duckdb-ui/issues/22</a:t>
             </a:r>
           </a:p>
@@ -2829,7 +2949,7 @@
           </a:p>
           <a:p xmlns:a="http://schemas.openxmlformats.org/drawingml/2006/main">
             <a:r>
-              <a:t>Também precisamos declarar os limites da recomendação. Neste cenário, considere codespaces exige internet e conta pessoal GitHub, Franquias e cobrança podem mudar, Explorador autoral é propositalmente simples e Instalação local permanece disponível. Esses pontos não anulam a técnica; eles delimitam onde a demonstração é válida e quais condições precisam ser verificadas antes de levar o padrão para produção. Tratar limites como parte do design evita transformar uma boa prática em regra universal.</a:t>
+              <a:t>Também precisamos declarar os limites da recomendação. Neste cenário, considere codespaces exige internet e conta pessoal GitHub, Franquias e cobrança podem mudar, Explorador autoral é propositalmente simples e UI oficial exige GitHub CLI local e escopo codespace. Esses pontos não anulam a técnica; eles delimitam onde a demonstração é válida e quais condições precisam ser verificadas antes de levar o padrão para produção. Tratar limites como parte do design evita transformar uma boa prática em regra universal.</a:t>
             </a:r>
           </a:p>
           <a:p xmlns:a="http://schemas.openxmlformats.org/drawingml/2006/main">
@@ -2895,6 +3015,16 @@
           <a:p xmlns:a="http://schemas.openxmlformats.org/drawingml/2006/main">
             <a:r>
               <a:t>- https://docs.github.com/en/codespaces/reference/security-in-github-codespaces</a:t>
+            </a:r>
+          </a:p>
+          <a:p xmlns:a="http://schemas.openxmlformats.org/drawingml/2006/main">
+            <a:r>
+              <a:t>- https://cli.github.com/manual/gh_codespace_ports_forward</a:t>
+            </a:r>
+          </a:p>
+          <a:p xmlns:a="http://schemas.openxmlformats.org/drawingml/2006/main">
+            <a:r>
+              <a:t>- https://duckdb.org/docs/current/core_extensions/ui</a:t>
             </a:r>
           </a:p>
           <a:p xmlns:a="http://schemas.openxmlformats.org/drawingml/2006/main">
@@ -3094,6 +3224,16 @@
           </a:p>
           <a:p xmlns:a="http://schemas.openxmlformats.org/drawingml/2006/main">
             <a:r>
+              <a:t>- https://cli.github.com/manual/gh_codespace_ports_forward</a:t>
+            </a:r>
+          </a:p>
+          <a:p xmlns:a="http://schemas.openxmlformats.org/drawingml/2006/main">
+            <a:r>
+              <a:t>- https://duckdb.org/docs/current/core_extensions/ui</a:t>
+            </a:r>
+          </a:p>
+          <a:p xmlns:a="http://schemas.openxmlformats.org/drawingml/2006/main">
+            <a:r>
               <a:t>- https://github.com/duckdb/duckdb-ui/issues/22</a:t>
             </a:r>
           </a:p>
@@ -3219,7 +3359,7 @@
           </a:p>
           <a:p xmlns:a="http://schemas.openxmlformats.org/drawingml/2006/main">
             <a:r>
-              <a:t>Abra o Codespace em 2-core, confira paths, execute checkpoint 01, explore a cópia e pare ao terminar. Faça essa etapa antes de seguir para o próximo episódio, porque o curso é cumulativo e o checkpoint atual se torna a base da aula seguinte. Se houver divergência, use o relatório de suporte e registre o que foi observado. O objetivo é avançar com um estado conhecido e reproduzível, não apenas assistir ao conteúdo.</a:t>
+              <a:t>Abra o Codespace em 2-core, execute checkpoint 01 e use a UI oficial por túnel somente como bônus. Faça essa etapa antes de seguir para o próximo episódio, porque o curso é cumulativo e o checkpoint atual se torna a base da aula seguinte. Se houver divergência, use o relatório de suporte e registre o que foi observado. O objetivo é avançar com um estado conhecido e reproduzível, não apenas assistir ao conteúdo.</a:t>
             </a:r>
           </a:p>
           <a:p xmlns:a="http://schemas.openxmlformats.org/drawingml/2006/main">
@@ -3285,6 +3425,16 @@
           <a:p xmlns:a="http://schemas.openxmlformats.org/drawingml/2006/main">
             <a:r>
               <a:t>- https://docs.github.com/en/codespaces/reference/security-in-github-codespaces</a:t>
+            </a:r>
+          </a:p>
+          <a:p xmlns:a="http://schemas.openxmlformats.org/drawingml/2006/main">
+            <a:r>
+              <a:t>- https://cli.github.com/manual/gh_codespace_ports_forward</a:t>
+            </a:r>
+          </a:p>
+          <a:p xmlns:a="http://schemas.openxmlformats.org/drawingml/2006/main">
+            <a:r>
+              <a:t>- https://duckdb.org/docs/current/core_extensions/ui</a:t>
             </a:r>
           </a:p>
           <a:p xmlns:a="http://schemas.openxmlformats.org/drawingml/2006/main">
@@ -3484,6 +3634,16 @@
           </a:p>
           <a:p xmlns:a="http://schemas.openxmlformats.org/drawingml/2006/main">
             <a:r>
+              <a:t>- https://cli.github.com/manual/gh_codespace_ports_forward</a:t>
+            </a:r>
+          </a:p>
+          <a:p xmlns:a="http://schemas.openxmlformats.org/drawingml/2006/main">
+            <a:r>
+              <a:t>- https://duckdb.org/docs/current/core_extensions/ui</a:t>
+            </a:r>
+          </a:p>
+          <a:p xmlns:a="http://schemas.openxmlformats.org/drawingml/2006/main">
+            <a:r>
               <a:t>- https://github.com/duckdb/duckdb-ui/issues/22</a:t>
             </a:r>
           </a:p>
@@ -3679,6 +3839,16 @@
           </a:p>
           <a:p xmlns:a="http://schemas.openxmlformats.org/drawingml/2006/main">
             <a:r>
+              <a:t>- https://cli.github.com/manual/gh_codespace_ports_forward</a:t>
+            </a:r>
+          </a:p>
+          <a:p xmlns:a="http://schemas.openxmlformats.org/drawingml/2006/main">
+            <a:r>
+              <a:t>- https://duckdb.org/docs/current/core_extensions/ui</a:t>
+            </a:r>
+          </a:p>
+          <a:p xmlns:a="http://schemas.openxmlformats.org/drawingml/2006/main">
+            <a:r>
               <a:t>- https://github.com/duckdb/duckdb-ui/issues/22</a:t>
             </a:r>
           </a:p>
@@ -3874,6 +4044,16 @@
           </a:p>
           <a:p xmlns:a="http://schemas.openxmlformats.org/drawingml/2006/main">
             <a:r>
+              <a:t>- https://cli.github.com/manual/gh_codespace_ports_forward</a:t>
+            </a:r>
+          </a:p>
+          <a:p xmlns:a="http://schemas.openxmlformats.org/drawingml/2006/main">
+            <a:r>
+              <a:t>- https://duckdb.org/docs/current/core_extensions/ui</a:t>
+            </a:r>
+          </a:p>
+          <a:p xmlns:a="http://schemas.openxmlformats.org/drawingml/2006/main">
+            <a:r>
               <a:t>- https://github.com/duckdb/duckdb-ui/issues/22</a:t>
             </a:r>
           </a:p>
@@ -4069,6 +4249,16 @@
           </a:p>
           <a:p xmlns:a="http://schemas.openxmlformats.org/drawingml/2006/main">
             <a:r>
+              <a:t>- https://cli.github.com/manual/gh_codespace_ports_forward</a:t>
+            </a:r>
+          </a:p>
+          <a:p xmlns:a="http://schemas.openxmlformats.org/drawingml/2006/main">
+            <a:r>
+              <a:t>- https://duckdb.org/docs/current/core_extensions/ui</a:t>
+            </a:r>
+          </a:p>
+          <a:p xmlns:a="http://schemas.openxmlformats.org/drawingml/2006/main">
+            <a:r>
               <a:t>- https://github.com/duckdb/duckdb-ui/issues/22</a:t>
             </a:r>
           </a:p>
@@ -4269,6 +4459,16 @@
           </a:p>
           <a:p xmlns:a="http://schemas.openxmlformats.org/drawingml/2006/main">
             <a:r>
+              <a:t>- https://cli.github.com/manual/gh_codespace_ports_forward</a:t>
+            </a:r>
+          </a:p>
+          <a:p xmlns:a="http://schemas.openxmlformats.org/drawingml/2006/main">
+            <a:r>
+              <a:t>- https://duckdb.org/docs/current/core_extensions/ui</a:t>
+            </a:r>
+          </a:p>
+          <a:p xmlns:a="http://schemas.openxmlformats.org/drawingml/2006/main">
+            <a:r>
               <a:t>- https://github.com/duckdb/duckdb-ui/issues/22</a:t>
             </a:r>
           </a:p>
@@ -4464,6 +4664,16 @@
           </a:p>
           <a:p xmlns:a="http://schemas.openxmlformats.org/drawingml/2006/main">
             <a:r>
+              <a:t>- https://cli.github.com/manual/gh_codespace_ports_forward</a:t>
+            </a:r>
+          </a:p>
+          <a:p xmlns:a="http://schemas.openxmlformats.org/drawingml/2006/main">
+            <a:r>
+              <a:t>- https://duckdb.org/docs/current/core_extensions/ui</a:t>
+            </a:r>
+          </a:p>
+          <a:p xmlns:a="http://schemas.openxmlformats.org/drawingml/2006/main">
+            <a:r>
               <a:t>- https://github.com/duckdb/duckdb-ui/issues/22</a:t>
             </a:r>
           </a:p>
@@ -4660,6 +4870,16 @@
           <a:p xmlns:a="http://schemas.openxmlformats.org/drawingml/2006/main">
             <a:r>
               <a:t>- https://docs.github.com/en/codespaces/reference/security-in-github-codespaces</a:t>
+            </a:r>
+          </a:p>
+          <a:p xmlns:a="http://schemas.openxmlformats.org/drawingml/2006/main">
+            <a:r>
+              <a:t>- https://cli.github.com/manual/gh_codespace_ports_forward</a:t>
+            </a:r>
+          </a:p>
+          <a:p xmlns:a="http://schemas.openxmlformats.org/drawingml/2006/main">
+            <a:r>
+              <a:t>- https://duckdb.org/docs/current/core_extensions/ui</a:t>
             </a:r>
           </a:p>
           <a:p xmlns:a="http://schemas.openxmlformats.org/drawingml/2006/main">
@@ -4801,7 +5021,7 @@
   </p:cSld>
   <p:clrMap bg1="lt1" tx1="dk1" bg2="lt2" tx2="dk2" accent1="accent1" accent2="accent2" accent3="accent3" accent4="accent4" accent5="accent5" accent6="accent6" hlink="hlink" folHlink="folHlink"/>
   <p:sldLayoutIdLst>
-    <p:sldLayoutId xmlns:r="http://schemas.openxmlformats.org/officeDocument/2006/relationships" id="2147483649" r:id="Rbe31f678083e48e6"/>
+    <p:sldLayoutId xmlns:r="http://schemas.openxmlformats.org/officeDocument/2006/relationships" id="2147483649" r:id="R0d214ca5f853403d"/>
   </p:sldLayoutIdLst>
   <p:txStyles>
     <p:titleStyle>
@@ -5099,8 +5319,8 @@
   </p:cSld>
   <p:clrMap bg1="lt1" tx1="dk1" bg2="lt2" tx2="dk2" accent1="accent1" accent2="accent2" accent3="accent3" accent4="accent4" accent5="accent5" accent6="accent6" hlink="hlink" folHlink="folHlink"/>
   <p:sldLayoutIdLst>
-    <p:sldLayoutId xmlns:r="http://schemas.openxmlformats.org/officeDocument/2006/relationships" id="2147483651" r:id="Rac967ed00d014eeb"/>
-    <p:sldLayoutId xmlns:r="http://schemas.openxmlformats.org/officeDocument/2006/relationships" id="2147483652" r:id="Rbbddfa610bf84a82"/>
+    <p:sldLayoutId xmlns:r="http://schemas.openxmlformats.org/officeDocument/2006/relationships" id="2147483651" r:id="Ra13f49743dbf4c4e"/>
+    <p:sldLayoutId xmlns:r="http://schemas.openxmlformats.org/officeDocument/2006/relationships" id="2147483652" r:id="R82eb701f764e48a2"/>
   </p:sldLayoutIdLst>
 </p:sldMaster>
 </file>
@@ -5631,7 +5851,7 @@
           <p:nvPr/>
         </p:nvPicPr>
         <p:blipFill>
-          <a:blip xmlns:r="http://schemas.openxmlformats.org/officeDocument/2006/relationships" xmlns:a="http://schemas.openxmlformats.org/drawingml/2006/main" r:embed="Rb04b180086ee4286"/>
+          <a:blip xmlns:r="http://schemas.openxmlformats.org/officeDocument/2006/relationships" xmlns:a="http://schemas.openxmlformats.org/drawingml/2006/main" r:embed="R948b56e378644f06"/>
           <a:srcRect xmlns:a="http://schemas.openxmlformats.org/drawingml/2006/main" l="19785" t="0" r="19785" b="0"/>
           <a:stretch xmlns:a="http://schemas.openxmlformats.org/drawingml/2006/main">
             <a:fillRect l="0" t="0" r="0" b="0"/>
@@ -5652,7 +5872,7 @@
           <p:cNvPr id="2" name="cover-text-surface">
             <a:extLst xmlns:a="http://schemas.openxmlformats.org/drawingml/2006/main">
               <a:ext uri="{FF2B5EF4-FFF2-40B4-BE49-F238E27FC236}">
-                <a16:creationId xmlns:a16="http://schemas.microsoft.com/office/drawing/2014/main" id="{1F10E179-8642-4532-8E7A-77C588F250D1}"/>
+                <a16:creationId xmlns:a16="http://schemas.microsoft.com/office/drawing/2014/main" id="{46F41A0E-E27B-4DC0-A5D5-3DFCF7D11DCB}"/>
               </a:ext>
             </a:extLst>
           </p:cNvPr>
@@ -5685,7 +5905,7 @@
           <p:cNvPr id="3" name="cover-divider">
             <a:extLst xmlns:a="http://schemas.openxmlformats.org/drawingml/2006/main">
               <a:ext uri="{FF2B5EF4-FFF2-40B4-BE49-F238E27FC236}">
-                <a16:creationId xmlns:a16="http://schemas.microsoft.com/office/drawing/2014/main" id="{C23C3CBB-AE51-4DAC-A25B-63AC86DFC6B6}"/>
+                <a16:creationId xmlns:a16="http://schemas.microsoft.com/office/drawing/2014/main" id="{179214D2-D2FC-4E7E-8598-D9916C749C97}"/>
               </a:ext>
             </a:extLst>
           </p:cNvPr>
@@ -5716,7 +5936,7 @@
           <p:cNvPr id="4" name="cover-episode">
             <a:extLst xmlns:a="http://schemas.openxmlformats.org/drawingml/2006/main">
               <a:ext uri="{FF2B5EF4-FFF2-40B4-BE49-F238E27FC236}">
-                <a16:creationId xmlns:a16="http://schemas.microsoft.com/office/drawing/2014/main" id="{D0257A40-266E-497F-9C68-1B4948681A29}"/>
+                <a16:creationId xmlns:a16="http://schemas.microsoft.com/office/drawing/2014/main" id="{B5707B2C-39D1-4F5B-BBD9-40BB5BEF50D6}"/>
               </a:ext>
             </a:extLst>
           </p:cNvPr>
@@ -5767,7 +5987,7 @@
           <p:cNvPr id="5" name="cover-title">
             <a:extLst xmlns:a="http://schemas.openxmlformats.org/drawingml/2006/main">
               <a:ext uri="{FF2B5EF4-FFF2-40B4-BE49-F238E27FC236}">
-                <a16:creationId xmlns:a16="http://schemas.microsoft.com/office/drawing/2014/main" id="{34545C1A-6F6F-46F9-93C4-4102975239C5}"/>
+                <a16:creationId xmlns:a16="http://schemas.microsoft.com/office/drawing/2014/main" id="{7D43DC55-1E7B-4BAF-AC3A-3EC76708ED8B}"/>
               </a:ext>
             </a:extLst>
           </p:cNvPr>
@@ -5818,7 +6038,7 @@
           <p:cNvPr id="6" name="cover-subtitle">
             <a:extLst xmlns:a="http://schemas.openxmlformats.org/drawingml/2006/main">
               <a:ext uri="{FF2B5EF4-FFF2-40B4-BE49-F238E27FC236}">
-                <a16:creationId xmlns:a16="http://schemas.microsoft.com/office/drawing/2014/main" id="{58EE36CE-4FA0-4449-8CC8-EB39AC990A01}"/>
+                <a16:creationId xmlns:a16="http://schemas.microsoft.com/office/drawing/2014/main" id="{682AD644-F92F-471B-A71D-158B8FF7FB11}"/>
               </a:ext>
             </a:extLst>
           </p:cNvPr>
@@ -5869,7 +6089,7 @@
           <p:cNvPr id="7" name="cover-accent">
             <a:extLst xmlns:a="http://schemas.openxmlformats.org/drawingml/2006/main">
               <a:ext uri="{FF2B5EF4-FFF2-40B4-BE49-F238E27FC236}">
-                <a16:creationId xmlns:a16="http://schemas.microsoft.com/office/drawing/2014/main" id="{31FDC005-E3D0-4CA4-8C89-1DD3B944FCF8}"/>
+                <a16:creationId xmlns:a16="http://schemas.microsoft.com/office/drawing/2014/main" id="{E808C68C-927A-4E31-92EA-060AB3B7CD60}"/>
               </a:ext>
             </a:extLst>
           </p:cNvPr>
@@ -5900,7 +6120,7 @@
           <p:cNvPr id="8" name="cover-meta">
             <a:extLst xmlns:a="http://schemas.openxmlformats.org/drawingml/2006/main">
               <a:ext uri="{FF2B5EF4-FFF2-40B4-BE49-F238E27FC236}">
-                <a16:creationId xmlns:a16="http://schemas.microsoft.com/office/drawing/2014/main" id="{334CF948-CED9-40A5-AB05-229B25C3D986}"/>
+                <a16:creationId xmlns:a16="http://schemas.microsoft.com/office/drawing/2014/main" id="{6DD5FEB8-3D6B-4E01-A5BF-EC8B9F90D86D}"/>
               </a:ext>
             </a:extLst>
           </p:cNvPr>
@@ -5953,7 +6173,7 @@
     </p:spTree>
     <p:extLst>
       <p:ext uri="{BB962C8B-B14F-4D97-AF65-F5344CB8AC3E}">
-        <p14:creationId xmlns:p14="http://schemas.microsoft.com/office/powerpoint/2010/main" val="728742363"/>
+        <p14:creationId xmlns:p14="http://schemas.microsoft.com/office/powerpoint/2010/main" val="59376208"/>
       </p:ext>
     </p:extLst>
   </p:cSld>
@@ -5992,7 +6212,7 @@
           <p:cNvPr id="13" name="slide-title">
             <a:extLst xmlns:a="http://schemas.openxmlformats.org/drawingml/2006/main">
               <a:ext uri="{FF2B5EF4-FFF2-40B4-BE49-F238E27FC236}">
-                <a16:creationId xmlns:a16="http://schemas.microsoft.com/office/drawing/2014/main" id="{37AF3565-ECBE-4507-8D95-09B627A99927}"/>
+                <a16:creationId xmlns:a16="http://schemas.microsoft.com/office/drawing/2014/main" id="{4F41C7E6-88D0-4FD1-8BC6-52A57F75130E}"/>
               </a:ext>
             </a:extLst>
           </p:cNvPr>
@@ -6043,7 +6263,7 @@
           <p:cNvPr id="2" name="flow-1">
             <a:extLst xmlns:a="http://schemas.openxmlformats.org/drawingml/2006/main">
               <a:ext uri="{FF2B5EF4-FFF2-40B4-BE49-F238E27FC236}">
-                <a16:creationId xmlns:a16="http://schemas.microsoft.com/office/drawing/2014/main" id="{650E45D0-2535-48AB-8B61-64037AAEFAD4}"/>
+                <a16:creationId xmlns:a16="http://schemas.microsoft.com/office/drawing/2014/main" id="{35A95312-8E85-4E8A-BB02-E690870AC3CD}"/>
               </a:ext>
             </a:extLst>
           </p:cNvPr>
@@ -6100,7 +6320,7 @@
           <p:cNvPr id="3" name="flow-2">
             <a:extLst xmlns:a="http://schemas.openxmlformats.org/drawingml/2006/main">
               <a:ext uri="{FF2B5EF4-FFF2-40B4-BE49-F238E27FC236}">
-                <a16:creationId xmlns:a16="http://schemas.microsoft.com/office/drawing/2014/main" id="{BB89D3E9-705D-49D2-9F35-6DAFE2DF4FEE}"/>
+                <a16:creationId xmlns:a16="http://schemas.microsoft.com/office/drawing/2014/main" id="{69B44238-1DEC-4AA4-92F0-0B3E88C4E793}"/>
               </a:ext>
             </a:extLst>
           </p:cNvPr>
@@ -6157,7 +6377,7 @@
           <p:cNvPr id="4" name="flow-3">
             <a:extLst xmlns:a="http://schemas.openxmlformats.org/drawingml/2006/main">
               <a:ext uri="{FF2B5EF4-FFF2-40B4-BE49-F238E27FC236}">
-                <a16:creationId xmlns:a16="http://schemas.microsoft.com/office/drawing/2014/main" id="{443C644E-B1F3-4E2B-A4B7-3763FA9B7062}"/>
+                <a16:creationId xmlns:a16="http://schemas.microsoft.com/office/drawing/2014/main" id="{C6D76D01-FCA2-4164-843B-5611483F614E}"/>
               </a:ext>
             </a:extLst>
           </p:cNvPr>
@@ -6214,7 +6434,7 @@
           <p:cNvPr id="5" name="flow-4">
             <a:extLst xmlns:a="http://schemas.openxmlformats.org/drawingml/2006/main">
               <a:ext uri="{FF2B5EF4-FFF2-40B4-BE49-F238E27FC236}">
-                <a16:creationId xmlns:a16="http://schemas.microsoft.com/office/drawing/2014/main" id="{12E8E81E-25FD-4E52-829A-FCB533C4832E}"/>
+                <a16:creationId xmlns:a16="http://schemas.microsoft.com/office/drawing/2014/main" id="{32F85C49-A50A-4966-997A-3308BE267B12}"/>
               </a:ext>
             </a:extLst>
           </p:cNvPr>
@@ -6349,7 +6569,7 @@
           <p:cNvPr id="9" name="eyebrow">
             <a:extLst xmlns:a="http://schemas.openxmlformats.org/drawingml/2006/main">
               <a:ext uri="{FF2B5EF4-FFF2-40B4-BE49-F238E27FC236}">
-                <a16:creationId xmlns:a16="http://schemas.microsoft.com/office/drawing/2014/main" id="{6C92AC3D-0576-4CE6-9505-DC1833733E20}"/>
+                <a16:creationId xmlns:a16="http://schemas.microsoft.com/office/drawing/2014/main" id="{E25625CA-44A6-4647-8B1D-BAD6AF97D852}"/>
               </a:ext>
             </a:extLst>
           </p:cNvPr>
@@ -6400,7 +6620,7 @@
           <p:cNvPr id="10" name="footer-rule">
             <a:extLst xmlns:a="http://schemas.openxmlformats.org/drawingml/2006/main">
               <a:ext uri="{FF2B5EF4-FFF2-40B4-BE49-F238E27FC236}">
-                <a16:creationId xmlns:a16="http://schemas.microsoft.com/office/drawing/2014/main" id="{02284FAF-428A-4E6E-86E2-2734E7B3656D}"/>
+                <a16:creationId xmlns:a16="http://schemas.microsoft.com/office/drawing/2014/main" id="{3BCBAB5F-B376-4859-A841-BD044E729DC1}"/>
               </a:ext>
             </a:extLst>
           </p:cNvPr>
@@ -6433,7 +6653,7 @@
           <p:cNvPr id="11" name="footer">
             <a:extLst xmlns:a="http://schemas.openxmlformats.org/drawingml/2006/main">
               <a:ext uri="{FF2B5EF4-FFF2-40B4-BE49-F238E27FC236}">
-                <a16:creationId xmlns:a16="http://schemas.microsoft.com/office/drawing/2014/main" id="{32FF3982-AD5F-4D62-9480-1E7F1DBC9C58}"/>
+                <a16:creationId xmlns:a16="http://schemas.microsoft.com/office/drawing/2014/main" id="{C3438BB7-E096-4149-81A1-4C07E106EAA6}"/>
               </a:ext>
             </a:extLst>
           </p:cNvPr>
@@ -6488,7 +6708,7 @@
           <p:cNvPr id="12" name="page-number">
             <a:extLst xmlns:a="http://schemas.openxmlformats.org/drawingml/2006/main">
               <a:ext uri="{FF2B5EF4-FFF2-40B4-BE49-F238E27FC236}">
-                <a16:creationId xmlns:a16="http://schemas.microsoft.com/office/drawing/2014/main" id="{87589462-DC05-4F4B-A96E-251200DDA9D6}"/>
+                <a16:creationId xmlns:a16="http://schemas.microsoft.com/office/drawing/2014/main" id="{CCC08BBB-0228-4D8C-9D0B-79EBEC64BC65}"/>
               </a:ext>
             </a:extLst>
           </p:cNvPr>
@@ -6541,7 +6761,7 @@
     </p:spTree>
     <p:extLst>
       <p:ext uri="{BB962C8B-B14F-4D97-AF65-F5344CB8AC3E}">
-        <p14:creationId xmlns:p14="http://schemas.microsoft.com/office/powerpoint/2010/main" val="668520150"/>
+        <p14:creationId xmlns:p14="http://schemas.microsoft.com/office/powerpoint/2010/main" val="1163550133"/>
       </p:ext>
     </p:extLst>
   </p:cSld>
@@ -6580,7 +6800,7 @@
           <p:cNvPr id="11" name="slide-title">
             <a:extLst xmlns:a="http://schemas.openxmlformats.org/drawingml/2006/main">
               <a:ext uri="{FF2B5EF4-FFF2-40B4-BE49-F238E27FC236}">
-                <a16:creationId xmlns:a16="http://schemas.microsoft.com/office/drawing/2014/main" id="{CA7F5891-6091-40EC-9F34-7FADD7F614A1}"/>
+                <a16:creationId xmlns:a16="http://schemas.microsoft.com/office/drawing/2014/main" id="{F2557948-B184-4126-8328-045FAFD1110F}"/>
               </a:ext>
             </a:extLst>
           </p:cNvPr>
@@ -6631,7 +6851,7 @@
           <p:cNvPr id="2" name="slide-subtitle">
             <a:extLst xmlns:a="http://schemas.openxmlformats.org/drawingml/2006/main">
               <a:ext uri="{FF2B5EF4-FFF2-40B4-BE49-F238E27FC236}">
-                <a16:creationId xmlns:a16="http://schemas.microsoft.com/office/drawing/2014/main" id="{39150576-64D0-4A4E-BF44-F8787D79F1B5}"/>
+                <a16:creationId xmlns:a16="http://schemas.microsoft.com/office/drawing/2014/main" id="{F1A18877-3E51-4C0C-B2B5-349822438C31}"/>
               </a:ext>
             </a:extLst>
           </p:cNvPr>
@@ -6682,7 +6902,7 @@
           <p:cNvPr id="3" name="bullets">
             <a:extLst xmlns:a="http://schemas.openxmlformats.org/drawingml/2006/main">
               <a:ext uri="{FF2B5EF4-FFF2-40B4-BE49-F238E27FC236}">
-                <a16:creationId xmlns:a16="http://schemas.microsoft.com/office/drawing/2014/main" id="{4DB95657-74E8-4C04-8A0C-7406D852A02B}"/>
+                <a16:creationId xmlns:a16="http://schemas.microsoft.com/office/drawing/2014/main" id="{6C780FB6-3278-4DD9-80D8-2D5F4EF341AA}"/>
               </a:ext>
             </a:extLst>
           </p:cNvPr>
@@ -6769,7 +6989,7 @@
           <p:cNvPr id="4" name="ambient-glow">
             <a:extLst xmlns:a="http://schemas.openxmlformats.org/drawingml/2006/main">
               <a:ext uri="{FF2B5EF4-FFF2-40B4-BE49-F238E27FC236}">
-                <a16:creationId xmlns:a16="http://schemas.microsoft.com/office/drawing/2014/main" id="{69CF9BBD-CA25-4398-96B6-E251F697C5D3}"/>
+                <a16:creationId xmlns:a16="http://schemas.microsoft.com/office/drawing/2014/main" id="{9F7A8F7D-EEE1-412C-AF9A-720E886FAC69}"/>
               </a:ext>
             </a:extLst>
           </p:cNvPr>
@@ -6806,7 +7026,7 @@
           <p:cNvPr id="5" name="ambient-core">
             <a:extLst xmlns:a="http://schemas.openxmlformats.org/drawingml/2006/main">
               <a:ext uri="{FF2B5EF4-FFF2-40B4-BE49-F238E27FC236}">
-                <a16:creationId xmlns:a16="http://schemas.microsoft.com/office/drawing/2014/main" id="{B808D0AC-A201-44B6-B070-85CB7950CB4C}"/>
+                <a16:creationId xmlns:a16="http://schemas.microsoft.com/office/drawing/2014/main" id="{1DFB3262-A5EB-4693-BEF0-74D6B7328039}"/>
               </a:ext>
             </a:extLst>
           </p:cNvPr>
@@ -6843,7 +7063,7 @@
           <p:cNvPr id="6" name="section-number">
             <a:extLst xmlns:a="http://schemas.openxmlformats.org/drawingml/2006/main">
               <a:ext uri="{FF2B5EF4-FFF2-40B4-BE49-F238E27FC236}">
-                <a16:creationId xmlns:a16="http://schemas.microsoft.com/office/drawing/2014/main" id="{81002141-D6B6-40F6-8411-C4D21E6EFE9A}"/>
+                <a16:creationId xmlns:a16="http://schemas.microsoft.com/office/drawing/2014/main" id="{4BF063A6-A050-4C14-93A9-DD91D450C934}"/>
               </a:ext>
             </a:extLst>
           </p:cNvPr>
@@ -6894,7 +7114,7 @@
           <p:cNvPr id="7" name="eyebrow">
             <a:extLst xmlns:a="http://schemas.openxmlformats.org/drawingml/2006/main">
               <a:ext uri="{FF2B5EF4-FFF2-40B4-BE49-F238E27FC236}">
-                <a16:creationId xmlns:a16="http://schemas.microsoft.com/office/drawing/2014/main" id="{19D9D516-CBDC-40C2-9047-5090D6186A82}"/>
+                <a16:creationId xmlns:a16="http://schemas.microsoft.com/office/drawing/2014/main" id="{8E74EDD5-72E8-4358-8342-34B178151E8E}"/>
               </a:ext>
             </a:extLst>
           </p:cNvPr>
@@ -6945,7 +7165,7 @@
           <p:cNvPr id="8" name="footer-rule">
             <a:extLst xmlns:a="http://schemas.openxmlformats.org/drawingml/2006/main">
               <a:ext uri="{FF2B5EF4-FFF2-40B4-BE49-F238E27FC236}">
-                <a16:creationId xmlns:a16="http://schemas.microsoft.com/office/drawing/2014/main" id="{5059D49C-2F7B-4ACE-961D-BCABFABB29FB}"/>
+                <a16:creationId xmlns:a16="http://schemas.microsoft.com/office/drawing/2014/main" id="{0B3B0886-F433-437F-AA2B-AC0CAFA91541}"/>
               </a:ext>
             </a:extLst>
           </p:cNvPr>
@@ -6978,7 +7198,7 @@
           <p:cNvPr id="9" name="footer">
             <a:extLst xmlns:a="http://schemas.openxmlformats.org/drawingml/2006/main">
               <a:ext uri="{FF2B5EF4-FFF2-40B4-BE49-F238E27FC236}">
-                <a16:creationId xmlns:a16="http://schemas.microsoft.com/office/drawing/2014/main" id="{DA7A4830-D7CD-4320-8777-E2E950A720EC}"/>
+                <a16:creationId xmlns:a16="http://schemas.microsoft.com/office/drawing/2014/main" id="{0838FDD8-C991-497C-8A75-25855FCBAA7C}"/>
               </a:ext>
             </a:extLst>
           </p:cNvPr>
@@ -7033,7 +7253,7 @@
           <p:cNvPr id="10" name="page-number">
             <a:extLst xmlns:a="http://schemas.openxmlformats.org/drawingml/2006/main">
               <a:ext uri="{FF2B5EF4-FFF2-40B4-BE49-F238E27FC236}">
-                <a16:creationId xmlns:a16="http://schemas.microsoft.com/office/drawing/2014/main" id="{6F6450CB-6F20-43BA-90A6-EE377BACDDAE}"/>
+                <a16:creationId xmlns:a16="http://schemas.microsoft.com/office/drawing/2014/main" id="{D4AFEAF0-F163-4E80-96C5-D44121B986DA}"/>
               </a:ext>
             </a:extLst>
           </p:cNvPr>
@@ -7086,7 +7306,7 @@
     </p:spTree>
     <p:extLst>
       <p:ext uri="{BB962C8B-B14F-4D97-AF65-F5344CB8AC3E}">
-        <p14:creationId xmlns:p14="http://schemas.microsoft.com/office/powerpoint/2010/main" val="21039654"/>
+        <p14:creationId xmlns:p14="http://schemas.microsoft.com/office/powerpoint/2010/main" val="1727346344"/>
       </p:ext>
     </p:extLst>
   </p:cSld>
@@ -7117,7 +7337,7 @@
           <p:cNvPr id="10" name="slide-title">
             <a:extLst xmlns:a="http://schemas.openxmlformats.org/drawingml/2006/main">
               <a:ext uri="{FF2B5EF4-FFF2-40B4-BE49-F238E27FC236}">
-                <a16:creationId xmlns:a16="http://schemas.microsoft.com/office/drawing/2014/main" id="{E5431F9E-0AF6-4148-8A8B-97664B81E3A3}"/>
+                <a16:creationId xmlns:a16="http://schemas.microsoft.com/office/drawing/2014/main" id="{5DBF96AD-2A7E-47E6-8FBC-4D40AF04147C}"/>
               </a:ext>
             </a:extLst>
           </p:cNvPr>
@@ -7168,7 +7388,7 @@
           <p:cNvPr id="2" name="visual-claim">
             <a:extLst xmlns:a="http://schemas.openxmlformats.org/drawingml/2006/main">
               <a:ext uri="{FF2B5EF4-FFF2-40B4-BE49-F238E27FC236}">
-                <a16:creationId xmlns:a16="http://schemas.microsoft.com/office/drawing/2014/main" id="{6D94BD8B-BB6D-4AF4-9D6E-777DFC56085F}"/>
+                <a16:creationId xmlns:a16="http://schemas.microsoft.com/office/drawing/2014/main" id="{157DCA50-A058-42BD-AA6B-02A03CD30CAE}"/>
               </a:ext>
             </a:extLst>
           </p:cNvPr>
@@ -7219,7 +7439,7 @@
           <p:cNvPr id="3" name="image-surface">
             <a:extLst xmlns:a="http://schemas.openxmlformats.org/drawingml/2006/main">
               <a:ext uri="{FF2B5EF4-FFF2-40B4-BE49-F238E27FC236}">
-                <a16:creationId xmlns:a16="http://schemas.microsoft.com/office/drawing/2014/main" id="{BDBB2774-B96E-489A-B138-4D8AEF5CCA9B}"/>
+                <a16:creationId xmlns:a16="http://schemas.microsoft.com/office/drawing/2014/main" id="{88585342-3893-4687-99C5-F1EE328340F1}"/>
               </a:ext>
             </a:extLst>
           </p:cNvPr>
@@ -7258,7 +7478,7 @@
           <p:nvPr/>
         </p:nvPicPr>
         <p:blipFill>
-          <a:blip xmlns:r="http://schemas.openxmlformats.org/officeDocument/2006/relationships" xmlns:a="http://schemas.openxmlformats.org/drawingml/2006/main" r:embed="Ra0c2a2639c71482d"/>
+          <a:blip xmlns:r="http://schemas.openxmlformats.org/officeDocument/2006/relationships" xmlns:a="http://schemas.openxmlformats.org/drawingml/2006/main" r:embed="R0b833951581d44bb"/>
           <a:stretch xmlns:a="http://schemas.openxmlformats.org/drawingml/2006/main"/>
         </p:blipFill>
         <p:spPr>
@@ -7276,7 +7496,7 @@
           <p:cNvPr id="5" name="image-caption">
             <a:extLst xmlns:a="http://schemas.openxmlformats.org/drawingml/2006/main">
               <a:ext uri="{FF2B5EF4-FFF2-40B4-BE49-F238E27FC236}">
-                <a16:creationId xmlns:a16="http://schemas.microsoft.com/office/drawing/2014/main" id="{66E264F3-AD59-4638-B762-07E7CA2C5B26}"/>
+                <a16:creationId xmlns:a16="http://schemas.microsoft.com/office/drawing/2014/main" id="{6B3FA25E-B0AB-46C1-9BCD-B5AEDB8D7E31}"/>
               </a:ext>
             </a:extLst>
           </p:cNvPr>
@@ -7327,7 +7547,7 @@
           <p:cNvPr id="6" name="eyebrow">
             <a:extLst xmlns:a="http://schemas.openxmlformats.org/drawingml/2006/main">
               <a:ext uri="{FF2B5EF4-FFF2-40B4-BE49-F238E27FC236}">
-                <a16:creationId xmlns:a16="http://schemas.microsoft.com/office/drawing/2014/main" id="{F0DFCB9B-EA56-473E-839E-937F15748A96}"/>
+                <a16:creationId xmlns:a16="http://schemas.microsoft.com/office/drawing/2014/main" id="{A6CB3BE4-9A44-4F11-95EA-DD85EA5692BF}"/>
               </a:ext>
             </a:extLst>
           </p:cNvPr>
@@ -7378,7 +7598,7 @@
           <p:cNvPr id="7" name="footer-rule">
             <a:extLst xmlns:a="http://schemas.openxmlformats.org/drawingml/2006/main">
               <a:ext uri="{FF2B5EF4-FFF2-40B4-BE49-F238E27FC236}">
-                <a16:creationId xmlns:a16="http://schemas.microsoft.com/office/drawing/2014/main" id="{FA4A5D13-F159-4C2E-95E6-91D3A6B9E7BE}"/>
+                <a16:creationId xmlns:a16="http://schemas.microsoft.com/office/drawing/2014/main" id="{86BE7C73-74EC-4494-ADA4-D1F6CB9660BB}"/>
               </a:ext>
             </a:extLst>
           </p:cNvPr>
@@ -7411,7 +7631,7 @@
           <p:cNvPr id="8" name="footer">
             <a:extLst xmlns:a="http://schemas.openxmlformats.org/drawingml/2006/main">
               <a:ext uri="{FF2B5EF4-FFF2-40B4-BE49-F238E27FC236}">
-                <a16:creationId xmlns:a16="http://schemas.microsoft.com/office/drawing/2014/main" id="{800B2B23-B70E-4549-B3D9-07FEE2AC51C1}"/>
+                <a16:creationId xmlns:a16="http://schemas.microsoft.com/office/drawing/2014/main" id="{E51FFC39-D749-4DA5-B310-5C2C9F833633}"/>
               </a:ext>
             </a:extLst>
           </p:cNvPr>
@@ -7466,7 +7686,7 @@
           <p:cNvPr id="9" name="page-number">
             <a:extLst xmlns:a="http://schemas.openxmlformats.org/drawingml/2006/main">
               <a:ext uri="{FF2B5EF4-FFF2-40B4-BE49-F238E27FC236}">
-                <a16:creationId xmlns:a16="http://schemas.microsoft.com/office/drawing/2014/main" id="{FF33D102-FA67-45AA-9C6E-12F79B1037AA}"/>
+                <a16:creationId xmlns:a16="http://schemas.microsoft.com/office/drawing/2014/main" id="{5EDDE50D-3E57-4E38-8E15-7BB3372D6F8D}"/>
               </a:ext>
             </a:extLst>
           </p:cNvPr>
@@ -7519,7 +7739,7 @@
     </p:spTree>
     <p:extLst>
       <p:ext uri="{BB962C8B-B14F-4D97-AF65-F5344CB8AC3E}">
-        <p14:creationId xmlns:p14="http://schemas.microsoft.com/office/powerpoint/2010/main" val="280936556"/>
+        <p14:creationId xmlns:p14="http://schemas.microsoft.com/office/powerpoint/2010/main" val="1569118459"/>
       </p:ext>
     </p:extLst>
   </p:cSld>
@@ -7550,7 +7770,7 @@
           <p:cNvPr id="11" name="slide-title">
             <a:extLst xmlns:a="http://schemas.openxmlformats.org/drawingml/2006/main">
               <a:ext uri="{FF2B5EF4-FFF2-40B4-BE49-F238E27FC236}">
-                <a16:creationId xmlns:a16="http://schemas.microsoft.com/office/drawing/2014/main" id="{56F7C8BC-4229-426F-BF28-4528E6B73233}"/>
+                <a16:creationId xmlns:a16="http://schemas.microsoft.com/office/drawing/2014/main" id="{15EC33CF-773C-4403-97EC-7A1088BC2B8A}"/>
               </a:ext>
             </a:extLst>
           </p:cNvPr>
@@ -7591,7 +7811,7 @@
                   <a:srgbClr val="0B1F3A"/>
                 </a:solidFill>
               </a:rPr>
-              <a:t>Explore a cópia do banco no navegador</a:t>
+              <a:t>Escolha a interface certa para cada ambiente</a:t>
             </a:r>
           </a:p>
         </p:txBody>
@@ -7601,7 +7821,7 @@
           <p:cNvPr id="2" name="slide-subtitle">
             <a:extLst xmlns:a="http://schemas.openxmlformats.org/drawingml/2006/main">
               <a:ext uri="{FF2B5EF4-FFF2-40B4-BE49-F238E27FC236}">
-                <a16:creationId xmlns:a16="http://schemas.microsoft.com/office/drawing/2014/main" id="{14867803-8CB2-49C4-A442-F1D7193AD1B2}"/>
+                <a16:creationId xmlns:a16="http://schemas.microsoft.com/office/drawing/2014/main" id="{2D1F61FE-99FA-467F-BADF-0387BD77059D}"/>
               </a:ext>
             </a:extLst>
           </p:cNvPr>
@@ -7642,7 +7862,7 @@
                   <a:srgbClr val="5C6F86"/>
                 </a:solidFill>
               </a:rPr>
-              <a:t>O explorador autoral abre na porta privada 4213 sem modificar o banco usado pelo dbt.</a:t>
+              <a:t>O explorador do curso funciona no navegador; a UI oficial exige um túnel que preserve localhost.</a:t>
             </a:r>
           </a:p>
         </p:txBody>
@@ -7652,7 +7872,7 @@
           <p:cNvPr id="3" name="bullets">
             <a:extLst xmlns:a="http://schemas.openxmlformats.org/drawingml/2006/main">
               <a:ext uri="{FF2B5EF4-FFF2-40B4-BE49-F238E27FC236}">
-                <a16:creationId xmlns:a16="http://schemas.microsoft.com/office/drawing/2014/main" id="{28F1F3D1-323B-4C7A-B715-45B1949782AA}"/>
+                <a16:creationId xmlns:a16="http://schemas.microsoft.com/office/drawing/2014/main" id="{4E6B70CC-FB09-42F4-BF9D-503927640D6A}"/>
               </a:ext>
             </a:extLst>
           </p:cNvPr>
@@ -7693,7 +7913,7 @@
                   <a:srgbClr val="0B1F3A"/>
                 </a:solidFill>
               </a:rPr>
-              <a:t>• Snapshot somente leitura</a:t>
+              <a:t>• Codespaces: python course.py official-data-ui</a:t>
             </a:r>
           </a:p>
           <a:p xmlns:a="http://schemas.openxmlformats.org/drawingml/2006/main">
@@ -7711,7 +7931,7 @@
                   <a:srgbClr val="0B1F3A"/>
                 </a:solidFill>
               </a:rPr>
-              <a:t>• Mantenha o terminal aberto</a:t>
+              <a:t>• Local: gh auth refresh -h github.com -s codespace</a:t>
             </a:r>
           </a:p>
           <a:p xmlns:a="http://schemas.openxmlformats.org/drawingml/2006/main">
@@ -7729,7 +7949,25 @@
                   <a:srgbClr val="0B1F3A"/>
                 </a:solidFill>
               </a:rPr>
-              <a:t>• Ctrl+C encerra e permite atualizar</a:t>
+              <a:t>• Local: python course.py codespace-ui-tunnel</a:t>
+            </a:r>
+          </a:p>
+          <a:p xmlns:a="http://schemas.openxmlformats.org/drawingml/2006/main">
+            <a:pPr>
+              <a:buNone/>
+              <a:defRPr sz="1800">
+                <a:solidFill>
+                  <a:srgbClr val="0B1F3A"/>
+                </a:solidFill>
+              </a:defRPr>
+            </a:pPr>
+            <a:r>
+              <a:rPr sz="1800">
+                <a:solidFill>
+                  <a:srgbClr val="0B1F3A"/>
+                </a:solidFill>
+              </a:rPr>
+              <a:t>• Navegador: http://localhost:4213</a:t>
             </a:r>
           </a:p>
         </p:txBody>
@@ -7739,7 +7977,7 @@
           <p:cNvPr id="4" name="ambient-glow">
             <a:extLst xmlns:a="http://schemas.openxmlformats.org/drawingml/2006/main">
               <a:ext uri="{FF2B5EF4-FFF2-40B4-BE49-F238E27FC236}">
-                <a16:creationId xmlns:a16="http://schemas.microsoft.com/office/drawing/2014/main" id="{6660E063-B4CE-4BEC-8205-071F11451EC4}"/>
+                <a16:creationId xmlns:a16="http://schemas.microsoft.com/office/drawing/2014/main" id="{D8F54495-688E-46DF-8588-535814F4B962}"/>
               </a:ext>
             </a:extLst>
           </p:cNvPr>
@@ -7776,7 +8014,7 @@
           <p:cNvPr id="5" name="ambient-core">
             <a:extLst xmlns:a="http://schemas.openxmlformats.org/drawingml/2006/main">
               <a:ext uri="{FF2B5EF4-FFF2-40B4-BE49-F238E27FC236}">
-                <a16:creationId xmlns:a16="http://schemas.microsoft.com/office/drawing/2014/main" id="{ABFE4F80-E3CD-4A98-A16B-63D9B8A4D2DE}"/>
+                <a16:creationId xmlns:a16="http://schemas.microsoft.com/office/drawing/2014/main" id="{7D8BFF9E-FC8F-4E65-8272-5F950A03B091}"/>
               </a:ext>
             </a:extLst>
           </p:cNvPr>
@@ -7813,7 +8051,7 @@
           <p:cNvPr id="6" name="section-number">
             <a:extLst xmlns:a="http://schemas.openxmlformats.org/drawingml/2006/main">
               <a:ext uri="{FF2B5EF4-FFF2-40B4-BE49-F238E27FC236}">
-                <a16:creationId xmlns:a16="http://schemas.microsoft.com/office/drawing/2014/main" id="{3AD57237-7948-4857-B8BB-CACD3A5BF195}"/>
+                <a16:creationId xmlns:a16="http://schemas.microsoft.com/office/drawing/2014/main" id="{5DC9BAB4-D31A-4112-8898-78153897B784}"/>
               </a:ext>
             </a:extLst>
           </p:cNvPr>
@@ -7864,7 +8102,7 @@
           <p:cNvPr id="7" name="eyebrow">
             <a:extLst xmlns:a="http://schemas.openxmlformats.org/drawingml/2006/main">
               <a:ext uri="{FF2B5EF4-FFF2-40B4-BE49-F238E27FC236}">
-                <a16:creationId xmlns:a16="http://schemas.microsoft.com/office/drawing/2014/main" id="{93870D83-9AC2-4E21-802D-199555DC7F81}"/>
+                <a16:creationId xmlns:a16="http://schemas.microsoft.com/office/drawing/2014/main" id="{3F69F428-A49E-46C1-9969-8333B70F1CDB}"/>
               </a:ext>
             </a:extLst>
           </p:cNvPr>
@@ -7915,7 +8153,7 @@
           <p:cNvPr id="8" name="footer-rule">
             <a:extLst xmlns:a="http://schemas.openxmlformats.org/drawingml/2006/main">
               <a:ext uri="{FF2B5EF4-FFF2-40B4-BE49-F238E27FC236}">
-                <a16:creationId xmlns:a16="http://schemas.microsoft.com/office/drawing/2014/main" id="{5A6505A3-0516-47CA-883C-AE0651CBC8A0}"/>
+                <a16:creationId xmlns:a16="http://schemas.microsoft.com/office/drawing/2014/main" id="{020A5464-9C0A-4AC7-BCF8-711FE10C3FD7}"/>
               </a:ext>
             </a:extLst>
           </p:cNvPr>
@@ -7948,7 +8186,7 @@
           <p:cNvPr id="9" name="footer">
             <a:extLst xmlns:a="http://schemas.openxmlformats.org/drawingml/2006/main">
               <a:ext uri="{FF2B5EF4-FFF2-40B4-BE49-F238E27FC236}">
-                <a16:creationId xmlns:a16="http://schemas.microsoft.com/office/drawing/2014/main" id="{AF776831-6175-46FA-920D-0583295810BF}"/>
+                <a16:creationId xmlns:a16="http://schemas.microsoft.com/office/drawing/2014/main" id="{37004183-3B9E-434B-B202-0F9B574643F2}"/>
               </a:ext>
             </a:extLst>
           </p:cNvPr>
@@ -8003,7 +8241,7 @@
           <p:cNvPr id="10" name="page-number">
             <a:extLst xmlns:a="http://schemas.openxmlformats.org/drawingml/2006/main">
               <a:ext uri="{FF2B5EF4-FFF2-40B4-BE49-F238E27FC236}">
-                <a16:creationId xmlns:a16="http://schemas.microsoft.com/office/drawing/2014/main" id="{0D01CC7F-69E5-42D1-BA30-28DDB608ACC5}"/>
+                <a16:creationId xmlns:a16="http://schemas.microsoft.com/office/drawing/2014/main" id="{D44DB15B-7B67-4C75-843F-DBF1F1CDC014}"/>
               </a:ext>
             </a:extLst>
           </p:cNvPr>
@@ -8056,7 +8294,7 @@
     </p:spTree>
     <p:extLst>
       <p:ext uri="{BB962C8B-B14F-4D97-AF65-F5344CB8AC3E}">
-        <p14:creationId xmlns:p14="http://schemas.microsoft.com/office/powerpoint/2010/main" val="2115848414"/>
+        <p14:creationId xmlns:p14="http://schemas.microsoft.com/office/powerpoint/2010/main" val="1283717871"/>
       </p:ext>
     </p:extLst>
   </p:cSld>
@@ -8095,7 +8333,7 @@
           <p:cNvPr id="13" name="slide-title">
             <a:extLst xmlns:a="http://schemas.openxmlformats.org/drawingml/2006/main">
               <a:ext uri="{FF2B5EF4-FFF2-40B4-BE49-F238E27FC236}">
-                <a16:creationId xmlns:a16="http://schemas.microsoft.com/office/drawing/2014/main" id="{79475C0E-C168-444C-B200-4F2FA435BB73}"/>
+                <a16:creationId xmlns:a16="http://schemas.microsoft.com/office/drawing/2014/main" id="{7F0F218F-143F-4C7E-A636-0F137A9C0EEF}"/>
               </a:ext>
             </a:extLst>
           </p:cNvPr>
@@ -8136,7 +8374,7 @@
                   <a:srgbClr val="FFFFFF"/>
                 </a:solidFill>
               </a:rPr>
-              <a:t>Explore a cópia do banco no navegador</a:t>
+              <a:t>Escolha a interface certa para cada ambiente</a:t>
             </a:r>
           </a:p>
         </p:txBody>
@@ -8146,7 +8384,7 @@
           <p:cNvPr id="2" name="flow-1">
             <a:extLst xmlns:a="http://schemas.openxmlformats.org/drawingml/2006/main">
               <a:ext uri="{FF2B5EF4-FFF2-40B4-BE49-F238E27FC236}">
-                <a16:creationId xmlns:a16="http://schemas.microsoft.com/office/drawing/2014/main" id="{FF382106-DF4C-4B9A-BD73-A56A51D860EF}"/>
+                <a16:creationId xmlns:a16="http://schemas.microsoft.com/office/drawing/2014/main" id="{B2307041-C83B-413B-BECF-2BFC41AD5393}"/>
               </a:ext>
             </a:extLst>
           </p:cNvPr>
@@ -8193,7 +8431,7 @@
                   <a:srgbClr val="FFFFFF"/>
                 </a:solidFill>
               </a:rPr>
-              <a:t>dbt build</a:t>
+              <a:t>DuckDB</a:t>
             </a:r>
           </a:p>
         </p:txBody>
@@ -8203,7 +8441,7 @@
           <p:cNvPr id="3" name="flow-2">
             <a:extLst xmlns:a="http://schemas.openxmlformats.org/drawingml/2006/main">
               <a:ext uri="{FF2B5EF4-FFF2-40B4-BE49-F238E27FC236}">
-                <a16:creationId xmlns:a16="http://schemas.microsoft.com/office/drawing/2014/main" id="{5BC3C5CF-F1D9-440A-AF63-7B445081D1E2}"/>
+                <a16:creationId xmlns:a16="http://schemas.microsoft.com/office/drawing/2014/main" id="{B1DD4D67-AE07-4DE2-BE5A-C191F5BF18D4}"/>
               </a:ext>
             </a:extLst>
           </p:cNvPr>
@@ -8250,7 +8488,7 @@
                   <a:srgbClr val="FFFFFF"/>
                 </a:solidFill>
               </a:rPr>
-              <a:t>snapshot</a:t>
+              <a:t>UI oficial</a:t>
             </a:r>
           </a:p>
         </p:txBody>
@@ -8260,7 +8498,7 @@
           <p:cNvPr id="4" name="flow-3">
             <a:extLst xmlns:a="http://schemas.openxmlformats.org/drawingml/2006/main">
               <a:ext uri="{FF2B5EF4-FFF2-40B4-BE49-F238E27FC236}">
-                <a16:creationId xmlns:a16="http://schemas.microsoft.com/office/drawing/2014/main" id="{67806E6B-10D7-4B34-B08E-2069FDE92F38}"/>
+                <a16:creationId xmlns:a16="http://schemas.microsoft.com/office/drawing/2014/main" id="{7A768B33-64EC-42B1-ACD9-CDCD7230D7A9}"/>
               </a:ext>
             </a:extLst>
           </p:cNvPr>
@@ -8307,7 +8545,7 @@
                   <a:srgbClr val="FFFFFF"/>
                 </a:solidFill>
               </a:rPr>
-              <a:t>explorador</a:t>
+              <a:t>túnel</a:t>
             </a:r>
           </a:p>
         </p:txBody>
@@ -8317,7 +8555,7 @@
           <p:cNvPr id="5" name="flow-4">
             <a:extLst xmlns:a="http://schemas.openxmlformats.org/drawingml/2006/main">
               <a:ext uri="{FF2B5EF4-FFF2-40B4-BE49-F238E27FC236}">
-                <a16:creationId xmlns:a16="http://schemas.microsoft.com/office/drawing/2014/main" id="{F1BEA1A4-267B-457A-94F6-7307E414792B}"/>
+                <a16:creationId xmlns:a16="http://schemas.microsoft.com/office/drawing/2014/main" id="{5B860EEA-08A5-46C9-821E-F2860873B0A6}"/>
               </a:ext>
             </a:extLst>
           </p:cNvPr>
@@ -8364,7 +8602,7 @@
                   <a:srgbClr val="FFFFFF"/>
                 </a:solidFill>
               </a:rPr>
-              <a:t>navegador</a:t>
+              <a:t>localhost</a:t>
             </a:r>
           </a:p>
         </p:txBody>
@@ -8452,7 +8690,7 @@
           <p:cNvPr id="9" name="eyebrow">
             <a:extLst xmlns:a="http://schemas.openxmlformats.org/drawingml/2006/main">
               <a:ext uri="{FF2B5EF4-FFF2-40B4-BE49-F238E27FC236}">
-                <a16:creationId xmlns:a16="http://schemas.microsoft.com/office/drawing/2014/main" id="{CE15A3CD-33D0-4904-81EA-C607C4674204}"/>
+                <a16:creationId xmlns:a16="http://schemas.microsoft.com/office/drawing/2014/main" id="{D563FCA4-69CB-4CF4-A82A-E0BBEAB4C06A}"/>
               </a:ext>
             </a:extLst>
           </p:cNvPr>
@@ -8503,7 +8741,7 @@
           <p:cNvPr id="10" name="footer-rule">
             <a:extLst xmlns:a="http://schemas.openxmlformats.org/drawingml/2006/main">
               <a:ext uri="{FF2B5EF4-FFF2-40B4-BE49-F238E27FC236}">
-                <a16:creationId xmlns:a16="http://schemas.microsoft.com/office/drawing/2014/main" id="{2CD5A576-0793-42A8-8FCE-C1971B4400D2}"/>
+                <a16:creationId xmlns:a16="http://schemas.microsoft.com/office/drawing/2014/main" id="{4CC6D0BE-9D96-49F5-9F8A-865C3A62A367}"/>
               </a:ext>
             </a:extLst>
           </p:cNvPr>
@@ -8536,7 +8774,7 @@
           <p:cNvPr id="11" name="footer">
             <a:extLst xmlns:a="http://schemas.openxmlformats.org/drawingml/2006/main">
               <a:ext uri="{FF2B5EF4-FFF2-40B4-BE49-F238E27FC236}">
-                <a16:creationId xmlns:a16="http://schemas.microsoft.com/office/drawing/2014/main" id="{7179C047-1101-446B-A8FC-CA3E0645C8FD}"/>
+                <a16:creationId xmlns:a16="http://schemas.microsoft.com/office/drawing/2014/main" id="{B019CF45-B3CC-4633-BBF5-C1C81155889D}"/>
               </a:ext>
             </a:extLst>
           </p:cNvPr>
@@ -8591,7 +8829,7 @@
           <p:cNvPr id="12" name="page-number">
             <a:extLst xmlns:a="http://schemas.openxmlformats.org/drawingml/2006/main">
               <a:ext uri="{FF2B5EF4-FFF2-40B4-BE49-F238E27FC236}">
-                <a16:creationId xmlns:a16="http://schemas.microsoft.com/office/drawing/2014/main" id="{4FF90C79-CF4E-4A59-871C-368D6A24909D}"/>
+                <a16:creationId xmlns:a16="http://schemas.microsoft.com/office/drawing/2014/main" id="{1216E70A-8E7C-45B9-A1C2-5969E8FD1BF4}"/>
               </a:ext>
             </a:extLst>
           </p:cNvPr>
@@ -8644,7 +8882,7 @@
     </p:spTree>
     <p:extLst>
       <p:ext uri="{BB962C8B-B14F-4D97-AF65-F5344CB8AC3E}">
-        <p14:creationId xmlns:p14="http://schemas.microsoft.com/office/powerpoint/2010/main" val="2025010219"/>
+        <p14:creationId xmlns:p14="http://schemas.microsoft.com/office/powerpoint/2010/main" val="584638055"/>
       </p:ext>
     </p:extLst>
   </p:cSld>
@@ -8683,7 +8921,7 @@
           <p:cNvPr id="9" name="slide-title">
             <a:extLst xmlns:a="http://schemas.openxmlformats.org/drawingml/2006/main">
               <a:ext uri="{FF2B5EF4-FFF2-40B4-BE49-F238E27FC236}">
-                <a16:creationId xmlns:a16="http://schemas.microsoft.com/office/drawing/2014/main" id="{F467EBE4-EC65-4EBA-949E-8E921CFEE792}"/>
+                <a16:creationId xmlns:a16="http://schemas.microsoft.com/office/drawing/2014/main" id="{7B27AAD6-BC47-44FC-8798-69018D36BCB5}"/>
               </a:ext>
             </a:extLst>
           </p:cNvPr>
@@ -8734,7 +8972,7 @@
           <p:cNvPr id="2" name="code-surface">
             <a:extLst xmlns:a="http://schemas.openxmlformats.org/drawingml/2006/main">
               <a:ext uri="{FF2B5EF4-FFF2-40B4-BE49-F238E27FC236}">
-                <a16:creationId xmlns:a16="http://schemas.microsoft.com/office/drawing/2014/main" id="{7DB10D8D-A9F5-4B28-B220-2C954C94F451}"/>
+                <a16:creationId xmlns:a16="http://schemas.microsoft.com/office/drawing/2014/main" id="{DBEF3606-D9CE-4AFB-8C55-B15D580A5BC8}"/>
               </a:ext>
             </a:extLst>
           </p:cNvPr>
@@ -8769,7 +9007,7 @@
           <p:cNvPr id="3" name="command">
             <a:extLst xmlns:a="http://schemas.openxmlformats.org/drawingml/2006/main">
               <a:ext uri="{FF2B5EF4-FFF2-40B4-BE49-F238E27FC236}">
-                <a16:creationId xmlns:a16="http://schemas.microsoft.com/office/drawing/2014/main" id="{9C8D05B5-55B9-4E3C-AB8F-86E67138B052}"/>
+                <a16:creationId xmlns:a16="http://schemas.microsoft.com/office/drawing/2014/main" id="{50EA78D7-F2A2-4315-986B-7AD7F9D63212}"/>
               </a:ext>
             </a:extLst>
           </p:cNvPr>
@@ -8856,7 +9094,7 @@
           <p:cNvPr id="4" name="command-help">
             <a:extLst xmlns:a="http://schemas.openxmlformats.org/drawingml/2006/main">
               <a:ext uri="{FF2B5EF4-FFF2-40B4-BE49-F238E27FC236}">
-                <a16:creationId xmlns:a16="http://schemas.microsoft.com/office/drawing/2014/main" id="{63D83F0E-9AAB-4753-ADAA-417005010F18}"/>
+                <a16:creationId xmlns:a16="http://schemas.microsoft.com/office/drawing/2014/main" id="{BF86C0F5-6D15-445E-B6F6-DFA599362E35}"/>
               </a:ext>
             </a:extLst>
           </p:cNvPr>
@@ -8907,7 +9145,7 @@
           <p:cNvPr id="5" name="eyebrow">
             <a:extLst xmlns:a="http://schemas.openxmlformats.org/drawingml/2006/main">
               <a:ext uri="{FF2B5EF4-FFF2-40B4-BE49-F238E27FC236}">
-                <a16:creationId xmlns:a16="http://schemas.microsoft.com/office/drawing/2014/main" id="{344823D3-72E1-4E82-BE99-128C25E792B5}"/>
+                <a16:creationId xmlns:a16="http://schemas.microsoft.com/office/drawing/2014/main" id="{D5869A73-3F7F-4954-A935-30FE76F65F5F}"/>
               </a:ext>
             </a:extLst>
           </p:cNvPr>
@@ -8958,7 +9196,7 @@
           <p:cNvPr id="6" name="footer-rule">
             <a:extLst xmlns:a="http://schemas.openxmlformats.org/drawingml/2006/main">
               <a:ext uri="{FF2B5EF4-FFF2-40B4-BE49-F238E27FC236}">
-                <a16:creationId xmlns:a16="http://schemas.microsoft.com/office/drawing/2014/main" id="{5955FEA9-A5C4-4CC6-BD22-B31D2358570A}"/>
+                <a16:creationId xmlns:a16="http://schemas.microsoft.com/office/drawing/2014/main" id="{92F004C7-A625-42FE-B574-4DBBEE5ECBFC}"/>
               </a:ext>
             </a:extLst>
           </p:cNvPr>
@@ -8991,7 +9229,7 @@
           <p:cNvPr id="7" name="footer">
             <a:extLst xmlns:a="http://schemas.openxmlformats.org/drawingml/2006/main">
               <a:ext uri="{FF2B5EF4-FFF2-40B4-BE49-F238E27FC236}">
-                <a16:creationId xmlns:a16="http://schemas.microsoft.com/office/drawing/2014/main" id="{C7CEA63D-7CB2-4063-B2AB-6B19D80E3C19}"/>
+                <a16:creationId xmlns:a16="http://schemas.microsoft.com/office/drawing/2014/main" id="{DC1521A5-7D45-41DB-A11F-3B6A38A72C70}"/>
               </a:ext>
             </a:extLst>
           </p:cNvPr>
@@ -9046,7 +9284,7 @@
           <p:cNvPr id="8" name="page-number">
             <a:extLst xmlns:a="http://schemas.openxmlformats.org/drawingml/2006/main">
               <a:ext uri="{FF2B5EF4-FFF2-40B4-BE49-F238E27FC236}">
-                <a16:creationId xmlns:a16="http://schemas.microsoft.com/office/drawing/2014/main" id="{459428BD-F24B-4281-8C83-141EF8D76F56}"/>
+                <a16:creationId xmlns:a16="http://schemas.microsoft.com/office/drawing/2014/main" id="{94509C04-7617-49E5-9652-E95363DE9EFB}"/>
               </a:ext>
             </a:extLst>
           </p:cNvPr>
@@ -9099,7 +9337,7 @@
     </p:spTree>
     <p:extLst>
       <p:ext uri="{BB962C8B-B14F-4D97-AF65-F5344CB8AC3E}">
-        <p14:creationId xmlns:p14="http://schemas.microsoft.com/office/powerpoint/2010/main" val="405607996"/>
+        <p14:creationId xmlns:p14="http://schemas.microsoft.com/office/powerpoint/2010/main" val="183623369"/>
       </p:ext>
     </p:extLst>
   </p:cSld>
@@ -9130,7 +9368,7 @@
           <p:cNvPr id="14" name="slide-title">
             <a:extLst xmlns:a="http://schemas.openxmlformats.org/drawingml/2006/main">
               <a:ext uri="{FF2B5EF4-FFF2-40B4-BE49-F238E27FC236}">
-                <a16:creationId xmlns:a16="http://schemas.microsoft.com/office/drawing/2014/main" id="{D8843C35-D569-4CB9-90B7-C29C591A9932}"/>
+                <a16:creationId xmlns:a16="http://schemas.microsoft.com/office/drawing/2014/main" id="{771B79BC-AFA3-43D2-AE55-DB843E4F4B4F}"/>
               </a:ext>
             </a:extLst>
           </p:cNvPr>
@@ -9181,7 +9419,7 @@
           <p:cNvPr id="2" name="step-num-1">
             <a:extLst xmlns:a="http://schemas.openxmlformats.org/drawingml/2006/main">
               <a:ext uri="{FF2B5EF4-FFF2-40B4-BE49-F238E27FC236}">
-                <a16:creationId xmlns:a16="http://schemas.microsoft.com/office/drawing/2014/main" id="{90A6C429-4BFE-4B27-A26F-1804B2CF27F2}"/>
+                <a16:creationId xmlns:a16="http://schemas.microsoft.com/office/drawing/2014/main" id="{48F29D56-884E-484D-B674-1C2C03237B69}"/>
               </a:ext>
             </a:extLst>
           </p:cNvPr>
@@ -9232,7 +9470,7 @@
           <p:cNvPr id="3" name="step-label-1">
             <a:extLst xmlns:a="http://schemas.openxmlformats.org/drawingml/2006/main">
               <a:ext uri="{FF2B5EF4-FFF2-40B4-BE49-F238E27FC236}">
-                <a16:creationId xmlns:a16="http://schemas.microsoft.com/office/drawing/2014/main" id="{FA798012-1725-4012-83B2-8F009681D0CC}"/>
+                <a16:creationId xmlns:a16="http://schemas.microsoft.com/office/drawing/2014/main" id="{6926A17C-4942-4E0C-BAB4-6D2D787343A2}"/>
               </a:ext>
             </a:extLst>
           </p:cNvPr>
@@ -9283,7 +9521,7 @@
           <p:cNvPr id="4" name="step-line-1">
             <a:extLst xmlns:a="http://schemas.openxmlformats.org/drawingml/2006/main">
               <a:ext uri="{FF2B5EF4-FFF2-40B4-BE49-F238E27FC236}">
-                <a16:creationId xmlns:a16="http://schemas.microsoft.com/office/drawing/2014/main" id="{1CF2E536-F121-44CD-83E6-7DE6461B3A7B}"/>
+                <a16:creationId xmlns:a16="http://schemas.microsoft.com/office/drawing/2014/main" id="{D25B42F6-5983-468A-8320-46DF4E3D4D7A}"/>
               </a:ext>
             </a:extLst>
           </p:cNvPr>
@@ -9314,7 +9552,7 @@
           <p:cNvPr id="5" name="step-num-2">
             <a:extLst xmlns:a="http://schemas.openxmlformats.org/drawingml/2006/main">
               <a:ext uri="{FF2B5EF4-FFF2-40B4-BE49-F238E27FC236}">
-                <a16:creationId xmlns:a16="http://schemas.microsoft.com/office/drawing/2014/main" id="{52EAA22D-F48A-463C-887B-08B90D0F89B8}"/>
+                <a16:creationId xmlns:a16="http://schemas.microsoft.com/office/drawing/2014/main" id="{BA09BB11-9ABF-4BDE-845B-2C17D1907A14}"/>
               </a:ext>
             </a:extLst>
           </p:cNvPr>
@@ -9365,7 +9603,7 @@
           <p:cNvPr id="6" name="step-label-2">
             <a:extLst xmlns:a="http://schemas.openxmlformats.org/drawingml/2006/main">
               <a:ext uri="{FF2B5EF4-FFF2-40B4-BE49-F238E27FC236}">
-                <a16:creationId xmlns:a16="http://schemas.microsoft.com/office/drawing/2014/main" id="{8FDF7C65-6790-4EFF-9661-041B7DEAE193}"/>
+                <a16:creationId xmlns:a16="http://schemas.microsoft.com/office/drawing/2014/main" id="{5D47F47A-55A4-4334-B080-0BB0A9C64F0F}"/>
               </a:ext>
             </a:extLst>
           </p:cNvPr>
@@ -9416,7 +9654,7 @@
           <p:cNvPr id="7" name="step-line-2">
             <a:extLst xmlns:a="http://schemas.openxmlformats.org/drawingml/2006/main">
               <a:ext uri="{FF2B5EF4-FFF2-40B4-BE49-F238E27FC236}">
-                <a16:creationId xmlns:a16="http://schemas.microsoft.com/office/drawing/2014/main" id="{2F4421E3-2BD1-44C4-AE20-5F717F56CB43}"/>
+                <a16:creationId xmlns:a16="http://schemas.microsoft.com/office/drawing/2014/main" id="{A8EF5BDC-80CA-4D6D-B180-C3621A3B8CE5}"/>
               </a:ext>
             </a:extLst>
           </p:cNvPr>
@@ -9447,7 +9685,7 @@
           <p:cNvPr id="8" name="step-num-3">
             <a:extLst xmlns:a="http://schemas.openxmlformats.org/drawingml/2006/main">
               <a:ext uri="{FF2B5EF4-FFF2-40B4-BE49-F238E27FC236}">
-                <a16:creationId xmlns:a16="http://schemas.microsoft.com/office/drawing/2014/main" id="{E30825D0-8885-4A79-B447-5023E62B775D}"/>
+                <a16:creationId xmlns:a16="http://schemas.microsoft.com/office/drawing/2014/main" id="{86BFE10A-1ACD-4FDA-A4DB-7D63DA6EED49}"/>
               </a:ext>
             </a:extLst>
           </p:cNvPr>
@@ -9498,7 +9736,7 @@
           <p:cNvPr id="9" name="step-label-3">
             <a:extLst xmlns:a="http://schemas.openxmlformats.org/drawingml/2006/main">
               <a:ext uri="{FF2B5EF4-FFF2-40B4-BE49-F238E27FC236}">
-                <a16:creationId xmlns:a16="http://schemas.microsoft.com/office/drawing/2014/main" id="{7356B20F-E4B8-4D4C-AE7E-891969EA379F}"/>
+                <a16:creationId xmlns:a16="http://schemas.microsoft.com/office/drawing/2014/main" id="{0D7AC1FD-6B7C-4000-8A6D-660A17CE6FF1}"/>
               </a:ext>
             </a:extLst>
           </p:cNvPr>
@@ -9549,7 +9787,7 @@
           <p:cNvPr id="10" name="eyebrow">
             <a:extLst xmlns:a="http://schemas.openxmlformats.org/drawingml/2006/main">
               <a:ext uri="{FF2B5EF4-FFF2-40B4-BE49-F238E27FC236}">
-                <a16:creationId xmlns:a16="http://schemas.microsoft.com/office/drawing/2014/main" id="{138560DD-CFF9-4D71-A1BE-02F3AF53881B}"/>
+                <a16:creationId xmlns:a16="http://schemas.microsoft.com/office/drawing/2014/main" id="{6B8A3B21-B77C-45BC-B474-1E229C5C0566}"/>
               </a:ext>
             </a:extLst>
           </p:cNvPr>
@@ -9600,7 +9838,7 @@
           <p:cNvPr id="11" name="footer-rule">
             <a:extLst xmlns:a="http://schemas.openxmlformats.org/drawingml/2006/main">
               <a:ext uri="{FF2B5EF4-FFF2-40B4-BE49-F238E27FC236}">
-                <a16:creationId xmlns:a16="http://schemas.microsoft.com/office/drawing/2014/main" id="{024219FB-F1AC-4749-9362-5C8E20F5826D}"/>
+                <a16:creationId xmlns:a16="http://schemas.microsoft.com/office/drawing/2014/main" id="{AFC50AF5-CE5F-4606-8B19-D95D16D2E5C2}"/>
               </a:ext>
             </a:extLst>
           </p:cNvPr>
@@ -9633,7 +9871,7 @@
           <p:cNvPr id="12" name="footer">
             <a:extLst xmlns:a="http://schemas.openxmlformats.org/drawingml/2006/main">
               <a:ext uri="{FF2B5EF4-FFF2-40B4-BE49-F238E27FC236}">
-                <a16:creationId xmlns:a16="http://schemas.microsoft.com/office/drawing/2014/main" id="{88E32CD3-AB81-4EF0-B5BD-C019AFE82DD9}"/>
+                <a16:creationId xmlns:a16="http://schemas.microsoft.com/office/drawing/2014/main" id="{F30F11B7-C666-438F-8AEE-06045BC7C6AC}"/>
               </a:ext>
             </a:extLst>
           </p:cNvPr>
@@ -9688,7 +9926,7 @@
           <p:cNvPr id="13" name="page-number">
             <a:extLst xmlns:a="http://schemas.openxmlformats.org/drawingml/2006/main">
               <a:ext uri="{FF2B5EF4-FFF2-40B4-BE49-F238E27FC236}">
-                <a16:creationId xmlns:a16="http://schemas.microsoft.com/office/drawing/2014/main" id="{2183389F-6692-4558-9612-C56DB58DA62A}"/>
+                <a16:creationId xmlns:a16="http://schemas.microsoft.com/office/drawing/2014/main" id="{93F606E7-04C7-487A-ABE6-44026846E6B5}"/>
               </a:ext>
             </a:extLst>
           </p:cNvPr>
@@ -9741,7 +9979,7 @@
     </p:spTree>
     <p:extLst>
       <p:ext uri="{BB962C8B-B14F-4D97-AF65-F5344CB8AC3E}">
-        <p14:creationId xmlns:p14="http://schemas.microsoft.com/office/powerpoint/2010/main" val="146795321"/>
+        <p14:creationId xmlns:p14="http://schemas.microsoft.com/office/powerpoint/2010/main" val="1367337187"/>
       </p:ext>
     </p:extLst>
   </p:cSld>
@@ -9780,7 +10018,7 @@
           <p:cNvPr id="10" name="result-label">
             <a:extLst xmlns:a="http://schemas.openxmlformats.org/drawingml/2006/main">
               <a:ext uri="{FF2B5EF4-FFF2-40B4-BE49-F238E27FC236}">
-                <a16:creationId xmlns:a16="http://schemas.microsoft.com/office/drawing/2014/main" id="{403A1FC7-D8E2-4C90-9540-580BB6E07619}"/>
+                <a16:creationId xmlns:a16="http://schemas.microsoft.com/office/drawing/2014/main" id="{2861F17E-D08B-47D4-9EF1-F998A2928B2B}"/>
               </a:ext>
             </a:extLst>
           </p:cNvPr>
@@ -9831,7 +10069,7 @@
           <p:cNvPr id="2" name="result">
             <a:extLst xmlns:a="http://schemas.openxmlformats.org/drawingml/2006/main">
               <a:ext uri="{FF2B5EF4-FFF2-40B4-BE49-F238E27FC236}">
-                <a16:creationId xmlns:a16="http://schemas.microsoft.com/office/drawing/2014/main" id="{E298D3F6-4809-45E9-9931-B032CA788770}"/>
+                <a16:creationId xmlns:a16="http://schemas.microsoft.com/office/drawing/2014/main" id="{A92D2D65-7DB8-4464-B4E1-92069795B836}"/>
               </a:ext>
             </a:extLst>
           </p:cNvPr>
@@ -9882,7 +10120,7 @@
           <p:cNvPr id="3" name="result-meta">
             <a:extLst xmlns:a="http://schemas.openxmlformats.org/drawingml/2006/main">
               <a:ext uri="{FF2B5EF4-FFF2-40B4-BE49-F238E27FC236}">
-                <a16:creationId xmlns:a16="http://schemas.microsoft.com/office/drawing/2014/main" id="{864849BD-5F92-4E5F-8AAF-426B1EC1E76F}"/>
+                <a16:creationId xmlns:a16="http://schemas.microsoft.com/office/drawing/2014/main" id="{C6A189D2-F68B-43F9-8B52-EAEC58BE0F09}"/>
               </a:ext>
             </a:extLst>
           </p:cNvPr>
@@ -9933,7 +10171,7 @@
           <p:cNvPr id="4" name="ambient-glow">
             <a:extLst xmlns:a="http://schemas.openxmlformats.org/drawingml/2006/main">
               <a:ext uri="{FF2B5EF4-FFF2-40B4-BE49-F238E27FC236}">
-                <a16:creationId xmlns:a16="http://schemas.microsoft.com/office/drawing/2014/main" id="{20DFDAD0-013B-41BD-B06B-84E13A7366D2}"/>
+                <a16:creationId xmlns:a16="http://schemas.microsoft.com/office/drawing/2014/main" id="{9B9E1ADC-B9E9-4AD2-B281-3F694EE69AD3}"/>
               </a:ext>
             </a:extLst>
           </p:cNvPr>
@@ -9970,7 +10208,7 @@
           <p:cNvPr id="5" name="ambient-core">
             <a:extLst xmlns:a="http://schemas.openxmlformats.org/drawingml/2006/main">
               <a:ext uri="{FF2B5EF4-FFF2-40B4-BE49-F238E27FC236}">
-                <a16:creationId xmlns:a16="http://schemas.microsoft.com/office/drawing/2014/main" id="{38D44A81-C932-4FED-9604-4EE0EFF4AF4F}"/>
+                <a16:creationId xmlns:a16="http://schemas.microsoft.com/office/drawing/2014/main" id="{A6A8C325-12D8-4C44-B6B7-ECA2472E0E2A}"/>
               </a:ext>
             </a:extLst>
           </p:cNvPr>
@@ -10007,7 +10245,7 @@
           <p:cNvPr id="6" name="eyebrow">
             <a:extLst xmlns:a="http://schemas.openxmlformats.org/drawingml/2006/main">
               <a:ext uri="{FF2B5EF4-FFF2-40B4-BE49-F238E27FC236}">
-                <a16:creationId xmlns:a16="http://schemas.microsoft.com/office/drawing/2014/main" id="{890A43BE-4F44-4C86-A935-38FCC4FB7BE8}"/>
+                <a16:creationId xmlns:a16="http://schemas.microsoft.com/office/drawing/2014/main" id="{5F9821C5-5E45-4F5D-A9A1-3D13335E507B}"/>
               </a:ext>
             </a:extLst>
           </p:cNvPr>
@@ -10058,7 +10296,7 @@
           <p:cNvPr id="7" name="footer-rule">
             <a:extLst xmlns:a="http://schemas.openxmlformats.org/drawingml/2006/main">
               <a:ext uri="{FF2B5EF4-FFF2-40B4-BE49-F238E27FC236}">
-                <a16:creationId xmlns:a16="http://schemas.microsoft.com/office/drawing/2014/main" id="{54D2D0B6-2D1A-4077-830D-11505229509F}"/>
+                <a16:creationId xmlns:a16="http://schemas.microsoft.com/office/drawing/2014/main" id="{471E586D-31C8-4ED8-BD3B-C30A0D018C1E}"/>
               </a:ext>
             </a:extLst>
           </p:cNvPr>
@@ -10091,7 +10329,7 @@
           <p:cNvPr id="8" name="footer">
             <a:extLst xmlns:a="http://schemas.openxmlformats.org/drawingml/2006/main">
               <a:ext uri="{FF2B5EF4-FFF2-40B4-BE49-F238E27FC236}">
-                <a16:creationId xmlns:a16="http://schemas.microsoft.com/office/drawing/2014/main" id="{4E100F60-5B1E-4B0E-B1AB-CC2B4C345A07}"/>
+                <a16:creationId xmlns:a16="http://schemas.microsoft.com/office/drawing/2014/main" id="{571362A0-D2DD-4820-9033-B52924CE0FDE}"/>
               </a:ext>
             </a:extLst>
           </p:cNvPr>
@@ -10146,7 +10384,7 @@
           <p:cNvPr id="9" name="page-number">
             <a:extLst xmlns:a="http://schemas.openxmlformats.org/drawingml/2006/main">
               <a:ext uri="{FF2B5EF4-FFF2-40B4-BE49-F238E27FC236}">
-                <a16:creationId xmlns:a16="http://schemas.microsoft.com/office/drawing/2014/main" id="{B6C1FF16-04B0-4C9D-8077-DF3403F71FCE}"/>
+                <a16:creationId xmlns:a16="http://schemas.microsoft.com/office/drawing/2014/main" id="{5EDD5DBE-533B-44D4-B3BA-A56E7D63F689}"/>
               </a:ext>
             </a:extLst>
           </p:cNvPr>
@@ -10199,7 +10437,7 @@
     </p:spTree>
     <p:extLst>
       <p:ext uri="{BB962C8B-B14F-4D97-AF65-F5344CB8AC3E}">
-        <p14:creationId xmlns:p14="http://schemas.microsoft.com/office/powerpoint/2010/main" val="536315837"/>
+        <p14:creationId xmlns:p14="http://schemas.microsoft.com/office/powerpoint/2010/main" val="1354255108"/>
       </p:ext>
     </p:extLst>
   </p:cSld>
@@ -10230,7 +10468,7 @@
           <p:cNvPr id="14" name="slide-title">
             <a:extLst xmlns:a="http://schemas.openxmlformats.org/drawingml/2006/main">
               <a:ext uri="{FF2B5EF4-FFF2-40B4-BE49-F238E27FC236}">
-                <a16:creationId xmlns:a16="http://schemas.microsoft.com/office/drawing/2014/main" id="{0369B0B0-A81A-440F-8524-1B382870E49E}"/>
+                <a16:creationId xmlns:a16="http://schemas.microsoft.com/office/drawing/2014/main" id="{4C95BEDB-14F4-4A25-89C3-B01653FE9210}"/>
               </a:ext>
             </a:extLst>
           </p:cNvPr>
@@ -10281,7 +10519,7 @@
           <p:cNvPr id="2" name="step-num-1">
             <a:extLst xmlns:a="http://schemas.openxmlformats.org/drawingml/2006/main">
               <a:ext uri="{FF2B5EF4-FFF2-40B4-BE49-F238E27FC236}">
-                <a16:creationId xmlns:a16="http://schemas.microsoft.com/office/drawing/2014/main" id="{EC8AC712-194A-466C-B7CA-5861396EEFD3}"/>
+                <a16:creationId xmlns:a16="http://schemas.microsoft.com/office/drawing/2014/main" id="{0BAEACEC-F50A-4B56-93FD-FA6373E878E4}"/>
               </a:ext>
             </a:extLst>
           </p:cNvPr>
@@ -10332,7 +10570,7 @@
           <p:cNvPr id="3" name="step-label-1">
             <a:extLst xmlns:a="http://schemas.openxmlformats.org/drawingml/2006/main">
               <a:ext uri="{FF2B5EF4-FFF2-40B4-BE49-F238E27FC236}">
-                <a16:creationId xmlns:a16="http://schemas.microsoft.com/office/drawing/2014/main" id="{B7334BF4-E835-40D8-9856-F74C31361755}"/>
+                <a16:creationId xmlns:a16="http://schemas.microsoft.com/office/drawing/2014/main" id="{2EFD32BB-E41F-420A-81B9-5BF621C0D178}"/>
               </a:ext>
             </a:extLst>
           </p:cNvPr>
@@ -10383,7 +10621,7 @@
           <p:cNvPr id="4" name="step-line-1">
             <a:extLst xmlns:a="http://schemas.openxmlformats.org/drawingml/2006/main">
               <a:ext uri="{FF2B5EF4-FFF2-40B4-BE49-F238E27FC236}">
-                <a16:creationId xmlns:a16="http://schemas.microsoft.com/office/drawing/2014/main" id="{A45B2840-DEAA-48D0-BA1B-979CBA5A1A2E}"/>
+                <a16:creationId xmlns:a16="http://schemas.microsoft.com/office/drawing/2014/main" id="{73DA9AA0-9D0E-4661-89C1-723A478F8881}"/>
               </a:ext>
             </a:extLst>
           </p:cNvPr>
@@ -10414,7 +10652,7 @@
           <p:cNvPr id="5" name="step-num-2">
             <a:extLst xmlns:a="http://schemas.openxmlformats.org/drawingml/2006/main">
               <a:ext uri="{FF2B5EF4-FFF2-40B4-BE49-F238E27FC236}">
-                <a16:creationId xmlns:a16="http://schemas.microsoft.com/office/drawing/2014/main" id="{D806B761-7FCB-456F-B077-4C7BA4E85572}"/>
+                <a16:creationId xmlns:a16="http://schemas.microsoft.com/office/drawing/2014/main" id="{76D1B589-14B2-48DE-96A2-15E43F60704E}"/>
               </a:ext>
             </a:extLst>
           </p:cNvPr>
@@ -10465,7 +10703,7 @@
           <p:cNvPr id="6" name="step-label-2">
             <a:extLst xmlns:a="http://schemas.openxmlformats.org/drawingml/2006/main">
               <a:ext uri="{FF2B5EF4-FFF2-40B4-BE49-F238E27FC236}">
-                <a16:creationId xmlns:a16="http://schemas.microsoft.com/office/drawing/2014/main" id="{86E13AB6-AED1-4A5F-9ACE-9363254FB7E7}"/>
+                <a16:creationId xmlns:a16="http://schemas.microsoft.com/office/drawing/2014/main" id="{1932228E-D658-4E4B-BB0E-E2C7CEBB2D4A}"/>
               </a:ext>
             </a:extLst>
           </p:cNvPr>
@@ -10516,7 +10754,7 @@
           <p:cNvPr id="7" name="step-line-2">
             <a:extLst xmlns:a="http://schemas.openxmlformats.org/drawingml/2006/main">
               <a:ext uri="{FF2B5EF4-FFF2-40B4-BE49-F238E27FC236}">
-                <a16:creationId xmlns:a16="http://schemas.microsoft.com/office/drawing/2014/main" id="{E6107F06-7807-4A95-8008-FE8A9BE7831E}"/>
+                <a16:creationId xmlns:a16="http://schemas.microsoft.com/office/drawing/2014/main" id="{6ABA1B6B-2C33-4090-94ED-EE228890E70A}"/>
               </a:ext>
             </a:extLst>
           </p:cNvPr>
@@ -10547,7 +10785,7 @@
           <p:cNvPr id="8" name="step-num-3">
             <a:extLst xmlns:a="http://schemas.openxmlformats.org/drawingml/2006/main">
               <a:ext uri="{FF2B5EF4-FFF2-40B4-BE49-F238E27FC236}">
-                <a16:creationId xmlns:a16="http://schemas.microsoft.com/office/drawing/2014/main" id="{92DF8EED-428B-4339-9176-8F07F57428A9}"/>
+                <a16:creationId xmlns:a16="http://schemas.microsoft.com/office/drawing/2014/main" id="{193AC7F8-F159-44C6-AEB0-01E931515B66}"/>
               </a:ext>
             </a:extLst>
           </p:cNvPr>
@@ -10598,7 +10836,7 @@
           <p:cNvPr id="9" name="step-label-3">
             <a:extLst xmlns:a="http://schemas.openxmlformats.org/drawingml/2006/main">
               <a:ext uri="{FF2B5EF4-FFF2-40B4-BE49-F238E27FC236}">
-                <a16:creationId xmlns:a16="http://schemas.microsoft.com/office/drawing/2014/main" id="{63D1D4D7-448A-42A8-A950-DD1637840769}"/>
+                <a16:creationId xmlns:a16="http://schemas.microsoft.com/office/drawing/2014/main" id="{A87CC742-12DE-479A-B50E-83863E9D6966}"/>
               </a:ext>
             </a:extLst>
           </p:cNvPr>
@@ -10649,7 +10887,7 @@
           <p:cNvPr id="10" name="eyebrow">
             <a:extLst xmlns:a="http://schemas.openxmlformats.org/drawingml/2006/main">
               <a:ext uri="{FF2B5EF4-FFF2-40B4-BE49-F238E27FC236}">
-                <a16:creationId xmlns:a16="http://schemas.microsoft.com/office/drawing/2014/main" id="{598A71D1-F5F5-4EAE-88EF-C2D25135AE0C}"/>
+                <a16:creationId xmlns:a16="http://schemas.microsoft.com/office/drawing/2014/main" id="{6F6852D6-2808-41DA-83DE-A9E41DEA1CA8}"/>
               </a:ext>
             </a:extLst>
           </p:cNvPr>
@@ -10700,7 +10938,7 @@
           <p:cNvPr id="11" name="footer-rule">
             <a:extLst xmlns:a="http://schemas.openxmlformats.org/drawingml/2006/main">
               <a:ext uri="{FF2B5EF4-FFF2-40B4-BE49-F238E27FC236}">
-                <a16:creationId xmlns:a16="http://schemas.microsoft.com/office/drawing/2014/main" id="{48776562-326E-4B33-A729-269D7080690C}"/>
+                <a16:creationId xmlns:a16="http://schemas.microsoft.com/office/drawing/2014/main" id="{24A23026-8A30-48AF-BF98-31FEEA828D56}"/>
               </a:ext>
             </a:extLst>
           </p:cNvPr>
@@ -10733,7 +10971,7 @@
           <p:cNvPr id="12" name="footer">
             <a:extLst xmlns:a="http://schemas.openxmlformats.org/drawingml/2006/main">
               <a:ext uri="{FF2B5EF4-FFF2-40B4-BE49-F238E27FC236}">
-                <a16:creationId xmlns:a16="http://schemas.microsoft.com/office/drawing/2014/main" id="{10748663-6A20-4882-9A14-C4D247ED75FE}"/>
+                <a16:creationId xmlns:a16="http://schemas.microsoft.com/office/drawing/2014/main" id="{5024C753-3152-4839-8715-D02056A6D18C}"/>
               </a:ext>
             </a:extLst>
           </p:cNvPr>
@@ -10788,7 +11026,7 @@
           <p:cNvPr id="13" name="page-number">
             <a:extLst xmlns:a="http://schemas.openxmlformats.org/drawingml/2006/main">
               <a:ext uri="{FF2B5EF4-FFF2-40B4-BE49-F238E27FC236}">
-                <a16:creationId xmlns:a16="http://schemas.microsoft.com/office/drawing/2014/main" id="{7E8957D0-D18E-4222-87ED-FA062E55462C}"/>
+                <a16:creationId xmlns:a16="http://schemas.microsoft.com/office/drawing/2014/main" id="{B2455E04-1C26-466F-998C-3B12F63A690E}"/>
               </a:ext>
             </a:extLst>
           </p:cNvPr>
@@ -10841,7 +11079,7 @@
     </p:spTree>
     <p:extLst>
       <p:ext uri="{BB962C8B-B14F-4D97-AF65-F5344CB8AC3E}">
-        <p14:creationId xmlns:p14="http://schemas.microsoft.com/office/powerpoint/2010/main" val="1437273733"/>
+        <p14:creationId xmlns:p14="http://schemas.microsoft.com/office/powerpoint/2010/main" val="161006096"/>
       </p:ext>
     </p:extLst>
   </p:cSld>
@@ -10880,7 +11118,7 @@
           <p:cNvPr id="9" name="case-number">
             <a:extLst xmlns:a="http://schemas.openxmlformats.org/drawingml/2006/main">
               <a:ext uri="{FF2B5EF4-FFF2-40B4-BE49-F238E27FC236}">
-                <a16:creationId xmlns:a16="http://schemas.microsoft.com/office/drawing/2014/main" id="{55E2A2E2-EA77-46C8-81E7-3920A7446DC6}"/>
+                <a16:creationId xmlns:a16="http://schemas.microsoft.com/office/drawing/2014/main" id="{E3CEFC2A-AC69-4717-8712-FA78DA1B4C2B}"/>
               </a:ext>
             </a:extLst>
           </p:cNvPr>
@@ -10931,7 +11169,7 @@
           <p:cNvPr id="2" name="case-label">
             <a:extLst xmlns:a="http://schemas.openxmlformats.org/drawingml/2006/main">
               <a:ext uri="{FF2B5EF4-FFF2-40B4-BE49-F238E27FC236}">
-                <a16:creationId xmlns:a16="http://schemas.microsoft.com/office/drawing/2014/main" id="{18FF6D1A-3C41-4803-B58A-CA6EF38D87C1}"/>
+                <a16:creationId xmlns:a16="http://schemas.microsoft.com/office/drawing/2014/main" id="{7CC40724-402D-4FA5-8F72-EF85B02AB04A}"/>
               </a:ext>
             </a:extLst>
           </p:cNvPr>
@@ -10982,7 +11220,7 @@
           <p:cNvPr id="3" name="case-divider">
             <a:extLst xmlns:a="http://schemas.openxmlformats.org/drawingml/2006/main">
               <a:ext uri="{FF2B5EF4-FFF2-40B4-BE49-F238E27FC236}">
-                <a16:creationId xmlns:a16="http://schemas.microsoft.com/office/drawing/2014/main" id="{CB2E090D-C138-492B-9A8F-FF0A2B49C7A1}"/>
+                <a16:creationId xmlns:a16="http://schemas.microsoft.com/office/drawing/2014/main" id="{608792F7-8F46-4FDC-BBD1-91A9424796B9}"/>
               </a:ext>
             </a:extLst>
           </p:cNvPr>
@@ -11015,7 +11253,7 @@
           <p:cNvPr id="4" name="case-caveat">
             <a:extLst xmlns:a="http://schemas.openxmlformats.org/drawingml/2006/main">
               <a:ext uri="{FF2B5EF4-FFF2-40B4-BE49-F238E27FC236}">
-                <a16:creationId xmlns:a16="http://schemas.microsoft.com/office/drawing/2014/main" id="{21238ED0-2C75-45D2-A26C-F5F331A5E99B}"/>
+                <a16:creationId xmlns:a16="http://schemas.microsoft.com/office/drawing/2014/main" id="{7ED7A4E5-4A6A-4E30-B542-889D967DE23C}"/>
               </a:ext>
             </a:extLst>
           </p:cNvPr>
@@ -11066,7 +11304,7 @@
           <p:cNvPr id="5" name="eyebrow">
             <a:extLst xmlns:a="http://schemas.openxmlformats.org/drawingml/2006/main">
               <a:ext uri="{FF2B5EF4-FFF2-40B4-BE49-F238E27FC236}">
-                <a16:creationId xmlns:a16="http://schemas.microsoft.com/office/drawing/2014/main" id="{7AF12EBC-8346-4C41-B2E6-1CAE03F75529}"/>
+                <a16:creationId xmlns:a16="http://schemas.microsoft.com/office/drawing/2014/main" id="{8CC86997-197D-45C1-80FF-D7546D728912}"/>
               </a:ext>
             </a:extLst>
           </p:cNvPr>
@@ -11117,7 +11355,7 @@
           <p:cNvPr id="6" name="footer-rule">
             <a:extLst xmlns:a="http://schemas.openxmlformats.org/drawingml/2006/main">
               <a:ext uri="{FF2B5EF4-FFF2-40B4-BE49-F238E27FC236}">
-                <a16:creationId xmlns:a16="http://schemas.microsoft.com/office/drawing/2014/main" id="{C45E5D9E-000F-4CDF-AB7F-4D463FECAA55}"/>
+                <a16:creationId xmlns:a16="http://schemas.microsoft.com/office/drawing/2014/main" id="{0FBFDAC5-437E-46CC-B54B-44D8730235B4}"/>
               </a:ext>
             </a:extLst>
           </p:cNvPr>
@@ -11150,7 +11388,7 @@
           <p:cNvPr id="7" name="footer">
             <a:extLst xmlns:a="http://schemas.openxmlformats.org/drawingml/2006/main">
               <a:ext uri="{FF2B5EF4-FFF2-40B4-BE49-F238E27FC236}">
-                <a16:creationId xmlns:a16="http://schemas.microsoft.com/office/drawing/2014/main" id="{70E4FB91-75FA-4A97-8426-DB6C675A90CE}"/>
+                <a16:creationId xmlns:a16="http://schemas.microsoft.com/office/drawing/2014/main" id="{3285A7A0-3A78-4D33-B665-C7141CBFA396}"/>
               </a:ext>
             </a:extLst>
           </p:cNvPr>
@@ -11205,7 +11443,7 @@
           <p:cNvPr id="8" name="page-number">
             <a:extLst xmlns:a="http://schemas.openxmlformats.org/drawingml/2006/main">
               <a:ext uri="{FF2B5EF4-FFF2-40B4-BE49-F238E27FC236}">
-                <a16:creationId xmlns:a16="http://schemas.microsoft.com/office/drawing/2014/main" id="{F19082C8-E2E8-4575-8E8F-08FD408014DA}"/>
+                <a16:creationId xmlns:a16="http://schemas.microsoft.com/office/drawing/2014/main" id="{59F10D3B-CF84-43DC-B81D-DC3FB1D961B5}"/>
               </a:ext>
             </a:extLst>
           </p:cNvPr>
@@ -11258,7 +11496,7 @@
     </p:spTree>
     <p:extLst>
       <p:ext uri="{BB962C8B-B14F-4D97-AF65-F5344CB8AC3E}">
-        <p14:creationId xmlns:p14="http://schemas.microsoft.com/office/powerpoint/2010/main" val="1557302060"/>
+        <p14:creationId xmlns:p14="http://schemas.microsoft.com/office/powerpoint/2010/main" val="2008790364"/>
       </p:ext>
     </p:extLst>
   </p:cSld>
@@ -11289,7 +11527,7 @@
           <p:cNvPr id="10" name="hook">
             <a:extLst xmlns:a="http://schemas.openxmlformats.org/drawingml/2006/main">
               <a:ext uri="{FF2B5EF4-FFF2-40B4-BE49-F238E27FC236}">
-                <a16:creationId xmlns:a16="http://schemas.microsoft.com/office/drawing/2014/main" id="{B70FCB23-2D7C-437F-B46A-08CEBB8F2CEF}"/>
+                <a16:creationId xmlns:a16="http://schemas.microsoft.com/office/drawing/2014/main" id="{637B2E66-0F74-4EAA-BB62-7EBC2C5D5D7A}"/>
               </a:ext>
             </a:extLst>
           </p:cNvPr>
@@ -11340,7 +11578,7 @@
           <p:cNvPr id="2" name="hook-rule">
             <a:extLst xmlns:a="http://schemas.openxmlformats.org/drawingml/2006/main">
               <a:ext uri="{FF2B5EF4-FFF2-40B4-BE49-F238E27FC236}">
-                <a16:creationId xmlns:a16="http://schemas.microsoft.com/office/drawing/2014/main" id="{8FAFF7F0-2412-4836-9B01-81DBB5335C13}"/>
+                <a16:creationId xmlns:a16="http://schemas.microsoft.com/office/drawing/2014/main" id="{B116CDF8-6D98-415D-8CB5-754A0FFA9C9F}"/>
               </a:ext>
             </a:extLst>
           </p:cNvPr>
@@ -11371,7 +11609,7 @@
           <p:cNvPr id="3" name="hook-label">
             <a:extLst xmlns:a="http://schemas.openxmlformats.org/drawingml/2006/main">
               <a:ext uri="{FF2B5EF4-FFF2-40B4-BE49-F238E27FC236}">
-                <a16:creationId xmlns:a16="http://schemas.microsoft.com/office/drawing/2014/main" id="{877902FA-27E1-4C37-B7CB-B0D9B314F64D}"/>
+                <a16:creationId xmlns:a16="http://schemas.microsoft.com/office/drawing/2014/main" id="{4DA801B0-380E-40DF-BDCB-869DF4422013}"/>
               </a:ext>
             </a:extLst>
           </p:cNvPr>
@@ -11422,7 +11660,7 @@
           <p:cNvPr id="4" name="diagram-surface">
             <a:extLst xmlns:a="http://schemas.openxmlformats.org/drawingml/2006/main">
               <a:ext uri="{FF2B5EF4-FFF2-40B4-BE49-F238E27FC236}">
-                <a16:creationId xmlns:a16="http://schemas.microsoft.com/office/drawing/2014/main" id="{2296B81B-0488-4E30-B52C-2D9224017C41}"/>
+                <a16:creationId xmlns:a16="http://schemas.microsoft.com/office/drawing/2014/main" id="{9A6A8C62-C8C9-421B-B7D2-549691500BE2}"/>
               </a:ext>
             </a:extLst>
           </p:cNvPr>
@@ -11461,7 +11699,7 @@
           <p:nvPr/>
         </p:nvPicPr>
         <p:blipFill>
-          <a:blip xmlns:r="http://schemas.openxmlformats.org/officeDocument/2006/relationships" xmlns:a="http://schemas.openxmlformats.org/drawingml/2006/main" r:embed="Rad2fba1d29bb49b4"/>
+          <a:blip xmlns:r="http://schemas.openxmlformats.org/officeDocument/2006/relationships" xmlns:a="http://schemas.openxmlformats.org/drawingml/2006/main" r:embed="Rf0ef289c8e7f4577"/>
           <a:stretch xmlns:a="http://schemas.openxmlformats.org/drawingml/2006/main"/>
         </p:blipFill>
         <p:spPr>
@@ -11479,7 +11717,7 @@
           <p:cNvPr id="6" name="eyebrow">
             <a:extLst xmlns:a="http://schemas.openxmlformats.org/drawingml/2006/main">
               <a:ext uri="{FF2B5EF4-FFF2-40B4-BE49-F238E27FC236}">
-                <a16:creationId xmlns:a16="http://schemas.microsoft.com/office/drawing/2014/main" id="{20406D80-B0CF-4330-8F2C-95494B233386}"/>
+                <a16:creationId xmlns:a16="http://schemas.microsoft.com/office/drawing/2014/main" id="{597BBD45-A1D7-4241-84FC-06F52C0C84FB}"/>
               </a:ext>
             </a:extLst>
           </p:cNvPr>
@@ -11530,7 +11768,7 @@
           <p:cNvPr id="7" name="footer-rule">
             <a:extLst xmlns:a="http://schemas.openxmlformats.org/drawingml/2006/main">
               <a:ext uri="{FF2B5EF4-FFF2-40B4-BE49-F238E27FC236}">
-                <a16:creationId xmlns:a16="http://schemas.microsoft.com/office/drawing/2014/main" id="{5A1A19AD-6AF3-4B54-8B20-3D382C257A15}"/>
+                <a16:creationId xmlns:a16="http://schemas.microsoft.com/office/drawing/2014/main" id="{E48ED884-3351-4567-A5F5-B781B0937550}"/>
               </a:ext>
             </a:extLst>
           </p:cNvPr>
@@ -11563,7 +11801,7 @@
           <p:cNvPr id="8" name="footer">
             <a:extLst xmlns:a="http://schemas.openxmlformats.org/drawingml/2006/main">
               <a:ext uri="{FF2B5EF4-FFF2-40B4-BE49-F238E27FC236}">
-                <a16:creationId xmlns:a16="http://schemas.microsoft.com/office/drawing/2014/main" id="{D1FBC5E0-DBD7-477E-99E5-031BD7E4C70D}"/>
+                <a16:creationId xmlns:a16="http://schemas.microsoft.com/office/drawing/2014/main" id="{5685C86F-77E9-44AF-91F4-0F1B6FF1B48E}"/>
               </a:ext>
             </a:extLst>
           </p:cNvPr>
@@ -11618,7 +11856,7 @@
           <p:cNvPr id="9" name="page-number">
             <a:extLst xmlns:a="http://schemas.openxmlformats.org/drawingml/2006/main">
               <a:ext uri="{FF2B5EF4-FFF2-40B4-BE49-F238E27FC236}">
-                <a16:creationId xmlns:a16="http://schemas.microsoft.com/office/drawing/2014/main" id="{44E6F5C9-35F4-4A7D-A4B0-11A9AC02DE86}"/>
+                <a16:creationId xmlns:a16="http://schemas.microsoft.com/office/drawing/2014/main" id="{DEDDDF3B-1966-4445-8B89-4091FEDA1DE4}"/>
               </a:ext>
             </a:extLst>
           </p:cNvPr>
@@ -11671,7 +11909,7 @@
     </p:spTree>
     <p:extLst>
       <p:ext uri="{BB962C8B-B14F-4D97-AF65-F5344CB8AC3E}">
-        <p14:creationId xmlns:p14="http://schemas.microsoft.com/office/powerpoint/2010/main" val="385085420"/>
+        <p14:creationId xmlns:p14="http://schemas.microsoft.com/office/powerpoint/2010/main" val="964765875"/>
       </p:ext>
     </p:extLst>
   </p:cSld>
@@ -11702,7 +11940,7 @@
           <p:cNvPr id="7" name="slide-title">
             <a:extLst xmlns:a="http://schemas.openxmlformats.org/drawingml/2006/main">
               <a:ext uri="{FF2B5EF4-FFF2-40B4-BE49-F238E27FC236}">
-                <a16:creationId xmlns:a16="http://schemas.microsoft.com/office/drawing/2014/main" id="{A732C0AB-D64A-4449-B29B-D749FC619855}"/>
+                <a16:creationId xmlns:a16="http://schemas.microsoft.com/office/drawing/2014/main" id="{77BD6EBA-4456-4EB3-8FCB-FBB0EAF793DA}"/>
               </a:ext>
             </a:extLst>
           </p:cNvPr>
@@ -11753,7 +11991,7 @@
           <p:cNvPr id="2" name="bullets">
             <a:extLst xmlns:a="http://schemas.openxmlformats.org/drawingml/2006/main">
               <a:ext uri="{FF2B5EF4-FFF2-40B4-BE49-F238E27FC236}">
-                <a16:creationId xmlns:a16="http://schemas.microsoft.com/office/drawing/2014/main" id="{EE09A95C-4B12-4169-8330-672E8B3A3F25}"/>
+                <a16:creationId xmlns:a16="http://schemas.microsoft.com/office/drawing/2014/main" id="{CD0408F1-46BB-4C3A-8875-80081CE0805D}"/>
               </a:ext>
             </a:extLst>
           </p:cNvPr>
@@ -11848,7 +12086,7 @@
                   <a:srgbClr val="0B1F3A"/>
                 </a:solidFill>
               </a:rPr>
-              <a:t>• Instalação local permanece disponível</a:t>
+              <a:t>• UI oficial exige GitHub CLI local e escopo codespace</a:t>
             </a:r>
           </a:p>
         </p:txBody>
@@ -11858,7 +12096,7 @@
           <p:cNvPr id="3" name="eyebrow">
             <a:extLst xmlns:a="http://schemas.openxmlformats.org/drawingml/2006/main">
               <a:ext uri="{FF2B5EF4-FFF2-40B4-BE49-F238E27FC236}">
-                <a16:creationId xmlns:a16="http://schemas.microsoft.com/office/drawing/2014/main" id="{3023EBFC-2847-4AE2-81FD-DD044F76B2BC}"/>
+                <a16:creationId xmlns:a16="http://schemas.microsoft.com/office/drawing/2014/main" id="{1AE967C7-A0AB-400A-A8C3-5FD1A0ACA2B2}"/>
               </a:ext>
             </a:extLst>
           </p:cNvPr>
@@ -11909,7 +12147,7 @@
           <p:cNvPr id="4" name="footer-rule">
             <a:extLst xmlns:a="http://schemas.openxmlformats.org/drawingml/2006/main">
               <a:ext uri="{FF2B5EF4-FFF2-40B4-BE49-F238E27FC236}">
-                <a16:creationId xmlns:a16="http://schemas.microsoft.com/office/drawing/2014/main" id="{323372B5-C159-4D9F-9EDA-A24DB335595C}"/>
+                <a16:creationId xmlns:a16="http://schemas.microsoft.com/office/drawing/2014/main" id="{F53C1C44-C395-4619-B34D-6A7414D0515A}"/>
               </a:ext>
             </a:extLst>
           </p:cNvPr>
@@ -11942,7 +12180,7 @@
           <p:cNvPr id="5" name="footer">
             <a:extLst xmlns:a="http://schemas.openxmlformats.org/drawingml/2006/main">
               <a:ext uri="{FF2B5EF4-FFF2-40B4-BE49-F238E27FC236}">
-                <a16:creationId xmlns:a16="http://schemas.microsoft.com/office/drawing/2014/main" id="{4B6C852B-D5DB-48BB-825B-D435BD1A15C2}"/>
+                <a16:creationId xmlns:a16="http://schemas.microsoft.com/office/drawing/2014/main" id="{F5AFDDE2-B1B3-45CD-A23F-88771D7D8E3C}"/>
               </a:ext>
             </a:extLst>
           </p:cNvPr>
@@ -11997,7 +12235,7 @@
           <p:cNvPr id="6" name="page-number">
             <a:extLst xmlns:a="http://schemas.openxmlformats.org/drawingml/2006/main">
               <a:ext uri="{FF2B5EF4-FFF2-40B4-BE49-F238E27FC236}">
-                <a16:creationId xmlns:a16="http://schemas.microsoft.com/office/drawing/2014/main" id="{1CA39CD0-FB97-4FC9-8C2B-35001AD69BB9}"/>
+                <a16:creationId xmlns:a16="http://schemas.microsoft.com/office/drawing/2014/main" id="{E8987D06-2561-494B-AAD0-09626DAA62DC}"/>
               </a:ext>
             </a:extLst>
           </p:cNvPr>
@@ -12050,7 +12288,7 @@
     </p:spTree>
     <p:extLst>
       <p:ext uri="{BB962C8B-B14F-4D97-AF65-F5344CB8AC3E}">
-        <p14:creationId xmlns:p14="http://schemas.microsoft.com/office/powerpoint/2010/main" val="433528353"/>
+        <p14:creationId xmlns:p14="http://schemas.microsoft.com/office/powerpoint/2010/main" val="1593179968"/>
       </p:ext>
     </p:extLst>
   </p:cSld>
@@ -12089,7 +12327,7 @@
           <p:cNvPr id="10" name="radar-label">
             <a:extLst xmlns:a="http://schemas.openxmlformats.org/drawingml/2006/main">
               <a:ext uri="{FF2B5EF4-FFF2-40B4-BE49-F238E27FC236}">
-                <a16:creationId xmlns:a16="http://schemas.microsoft.com/office/drawing/2014/main" id="{241C1738-9F83-45EA-A6F4-E5411D9AD21A}"/>
+                <a16:creationId xmlns:a16="http://schemas.microsoft.com/office/drawing/2014/main" id="{16251EE7-598F-45B3-8EB7-D8F45419F258}"/>
               </a:ext>
             </a:extLst>
           </p:cNvPr>
@@ -12140,7 +12378,7 @@
           <p:cNvPr id="2" name="radar-text">
             <a:extLst xmlns:a="http://schemas.openxmlformats.org/drawingml/2006/main">
               <a:ext uri="{FF2B5EF4-FFF2-40B4-BE49-F238E27FC236}">
-                <a16:creationId xmlns:a16="http://schemas.microsoft.com/office/drawing/2014/main" id="{E4A4F3FD-C30B-4593-965B-38080B17272D}"/>
+                <a16:creationId xmlns:a16="http://schemas.microsoft.com/office/drawing/2014/main" id="{C64A032F-DD98-4C1D-94F8-3B85465A8D9D}"/>
               </a:ext>
             </a:extLst>
           </p:cNvPr>
@@ -12191,7 +12429,7 @@
           <p:cNvPr id="3" name="radar-rule">
             <a:extLst xmlns:a="http://schemas.openxmlformats.org/drawingml/2006/main">
               <a:ext uri="{FF2B5EF4-FFF2-40B4-BE49-F238E27FC236}">
-                <a16:creationId xmlns:a16="http://schemas.microsoft.com/office/drawing/2014/main" id="{52D08C92-4889-458E-853E-215A12F4D73A}"/>
+                <a16:creationId xmlns:a16="http://schemas.microsoft.com/office/drawing/2014/main" id="{46F0DE14-05E1-4B23-9678-29E55C671819}"/>
               </a:ext>
             </a:extLst>
           </p:cNvPr>
@@ -12242,7 +12480,7 @@
           <p:cNvPr id="4" name="ambient-glow">
             <a:extLst xmlns:a="http://schemas.openxmlformats.org/drawingml/2006/main">
               <a:ext uri="{FF2B5EF4-FFF2-40B4-BE49-F238E27FC236}">
-                <a16:creationId xmlns:a16="http://schemas.microsoft.com/office/drawing/2014/main" id="{C3604B8A-A0CE-4426-A87B-80C030B255F9}"/>
+                <a16:creationId xmlns:a16="http://schemas.microsoft.com/office/drawing/2014/main" id="{9016BDB6-FAF9-433B-A9B9-3E5970A31D6A}"/>
               </a:ext>
             </a:extLst>
           </p:cNvPr>
@@ -12279,7 +12517,7 @@
           <p:cNvPr id="5" name="ambient-core">
             <a:extLst xmlns:a="http://schemas.openxmlformats.org/drawingml/2006/main">
               <a:ext uri="{FF2B5EF4-FFF2-40B4-BE49-F238E27FC236}">
-                <a16:creationId xmlns:a16="http://schemas.microsoft.com/office/drawing/2014/main" id="{390B97B9-90BF-4F15-A0D0-FDE527DFC3C0}"/>
+                <a16:creationId xmlns:a16="http://schemas.microsoft.com/office/drawing/2014/main" id="{B1CEFF97-4664-4499-9AD7-29A2A6DF0983}"/>
               </a:ext>
             </a:extLst>
           </p:cNvPr>
@@ -12316,7 +12554,7 @@
           <p:cNvPr id="6" name="eyebrow">
             <a:extLst xmlns:a="http://schemas.openxmlformats.org/drawingml/2006/main">
               <a:ext uri="{FF2B5EF4-FFF2-40B4-BE49-F238E27FC236}">
-                <a16:creationId xmlns:a16="http://schemas.microsoft.com/office/drawing/2014/main" id="{0EE13430-E8B2-4633-A564-CB5C6FE2EF4C}"/>
+                <a16:creationId xmlns:a16="http://schemas.microsoft.com/office/drawing/2014/main" id="{84284907-CFE6-4351-BDC2-FB1C338D38CC}"/>
               </a:ext>
             </a:extLst>
           </p:cNvPr>
@@ -12367,7 +12605,7 @@
           <p:cNvPr id="7" name="footer-rule">
             <a:extLst xmlns:a="http://schemas.openxmlformats.org/drawingml/2006/main">
               <a:ext uri="{FF2B5EF4-FFF2-40B4-BE49-F238E27FC236}">
-                <a16:creationId xmlns:a16="http://schemas.microsoft.com/office/drawing/2014/main" id="{F47DE7D2-85A1-471D-B159-227383E757CF}"/>
+                <a16:creationId xmlns:a16="http://schemas.microsoft.com/office/drawing/2014/main" id="{AC32A775-BDEF-4C2A-9458-6E372B179169}"/>
               </a:ext>
             </a:extLst>
           </p:cNvPr>
@@ -12400,7 +12638,7 @@
           <p:cNvPr id="8" name="footer">
             <a:extLst xmlns:a="http://schemas.openxmlformats.org/drawingml/2006/main">
               <a:ext uri="{FF2B5EF4-FFF2-40B4-BE49-F238E27FC236}">
-                <a16:creationId xmlns:a16="http://schemas.microsoft.com/office/drawing/2014/main" id="{8B787194-C958-49D2-9D0D-64AC6548E9B2}"/>
+                <a16:creationId xmlns:a16="http://schemas.microsoft.com/office/drawing/2014/main" id="{AC1A30B8-30A6-44B3-8801-A3D997685D2E}"/>
               </a:ext>
             </a:extLst>
           </p:cNvPr>
@@ -12455,7 +12693,7 @@
           <p:cNvPr id="9" name="page-number">
             <a:extLst xmlns:a="http://schemas.openxmlformats.org/drawingml/2006/main">
               <a:ext uri="{FF2B5EF4-FFF2-40B4-BE49-F238E27FC236}">
-                <a16:creationId xmlns:a16="http://schemas.microsoft.com/office/drawing/2014/main" id="{4F60FBCC-B44C-4877-8744-2B01406C11BA}"/>
+                <a16:creationId xmlns:a16="http://schemas.microsoft.com/office/drawing/2014/main" id="{E3C5FF2D-6936-4468-BC35-90D0D21BD583}"/>
               </a:ext>
             </a:extLst>
           </p:cNvPr>
@@ -12508,7 +12746,7 @@
     </p:spTree>
     <p:extLst>
       <p:ext uri="{BB962C8B-B14F-4D97-AF65-F5344CB8AC3E}">
-        <p14:creationId xmlns:p14="http://schemas.microsoft.com/office/powerpoint/2010/main" val="2025287290"/>
+        <p14:creationId xmlns:p14="http://schemas.microsoft.com/office/powerpoint/2010/main" val="1731095963"/>
       </p:ext>
     </p:extLst>
   </p:cSld>
@@ -12539,7 +12777,7 @@
           <p:cNvPr id="8" name="cta-label">
             <a:extLst xmlns:a="http://schemas.openxmlformats.org/drawingml/2006/main">
               <a:ext uri="{FF2B5EF4-FFF2-40B4-BE49-F238E27FC236}">
-                <a16:creationId xmlns:a16="http://schemas.microsoft.com/office/drawing/2014/main" id="{AE4C58D2-9CB8-4A12-9E71-EBC321459FFA}"/>
+                <a16:creationId xmlns:a16="http://schemas.microsoft.com/office/drawing/2014/main" id="{D839393D-9285-4469-8D57-1B532B477040}"/>
               </a:ext>
             </a:extLst>
           </p:cNvPr>
@@ -12590,7 +12828,7 @@
           <p:cNvPr id="2" name="cta">
             <a:extLst xmlns:a="http://schemas.openxmlformats.org/drawingml/2006/main">
               <a:ext uri="{FF2B5EF4-FFF2-40B4-BE49-F238E27FC236}">
-                <a16:creationId xmlns:a16="http://schemas.microsoft.com/office/drawing/2014/main" id="{45BADF0D-AC15-4466-9AEA-616F4080AEEB}"/>
+                <a16:creationId xmlns:a16="http://schemas.microsoft.com/office/drawing/2014/main" id="{6F59B9D6-AC5D-4592-B931-AD0C817FCEFC}"/>
               </a:ext>
             </a:extLst>
           </p:cNvPr>
@@ -12631,7 +12869,7 @@
                   <a:srgbClr val="0B1F3A"/>
                 </a:solidFill>
               </a:rPr>
-              <a:t>Abra o Codespace em 2-core, confira paths, execute checkpoint 01, explore a cópia e pare ao terminar.</a:t>
+              <a:t>Abra o Codespace em 2-core, execute checkpoint 01 e use a UI oficial por túnel somente como bônus.</a:t>
             </a:r>
           </a:p>
         </p:txBody>
@@ -12641,7 +12879,7 @@
           <p:cNvPr id="3" name="cta-meta">
             <a:extLst xmlns:a="http://schemas.openxmlformats.org/drawingml/2006/main">
               <a:ext uri="{FF2B5EF4-FFF2-40B4-BE49-F238E27FC236}">
-                <a16:creationId xmlns:a16="http://schemas.microsoft.com/office/drawing/2014/main" id="{F0A32E78-759B-4DD2-B111-2F9AC73E353D}"/>
+                <a16:creationId xmlns:a16="http://schemas.microsoft.com/office/drawing/2014/main" id="{1BDFFB42-AC26-48BB-A0DA-09EA08517350}"/>
               </a:ext>
             </a:extLst>
           </p:cNvPr>
@@ -12692,7 +12930,7 @@
           <p:cNvPr id="4" name="eyebrow">
             <a:extLst xmlns:a="http://schemas.openxmlformats.org/drawingml/2006/main">
               <a:ext uri="{FF2B5EF4-FFF2-40B4-BE49-F238E27FC236}">
-                <a16:creationId xmlns:a16="http://schemas.microsoft.com/office/drawing/2014/main" id="{A2766C84-B2BA-4D81-A9D8-FFE6B656EBA1}"/>
+                <a16:creationId xmlns:a16="http://schemas.microsoft.com/office/drawing/2014/main" id="{4E41AD3B-51F0-4279-96F5-1BC6CD6D86CB}"/>
               </a:ext>
             </a:extLst>
           </p:cNvPr>
@@ -12743,7 +12981,7 @@
           <p:cNvPr id="5" name="footer-rule">
             <a:extLst xmlns:a="http://schemas.openxmlformats.org/drawingml/2006/main">
               <a:ext uri="{FF2B5EF4-FFF2-40B4-BE49-F238E27FC236}">
-                <a16:creationId xmlns:a16="http://schemas.microsoft.com/office/drawing/2014/main" id="{6F8FB0BE-A3F6-47C6-AED2-6F290414B675}"/>
+                <a16:creationId xmlns:a16="http://schemas.microsoft.com/office/drawing/2014/main" id="{231BB638-7D54-4F83-A1F2-98AEB4DB821D}"/>
               </a:ext>
             </a:extLst>
           </p:cNvPr>
@@ -12776,7 +13014,7 @@
           <p:cNvPr id="6" name="footer">
             <a:extLst xmlns:a="http://schemas.openxmlformats.org/drawingml/2006/main">
               <a:ext uri="{FF2B5EF4-FFF2-40B4-BE49-F238E27FC236}">
-                <a16:creationId xmlns:a16="http://schemas.microsoft.com/office/drawing/2014/main" id="{FB49C426-7502-4F76-AF6F-457334F26E85}"/>
+                <a16:creationId xmlns:a16="http://schemas.microsoft.com/office/drawing/2014/main" id="{43D299E3-A291-41E7-9C4D-40429D6D9606}"/>
               </a:ext>
             </a:extLst>
           </p:cNvPr>
@@ -12831,7 +13069,7 @@
           <p:cNvPr id="7" name="page-number">
             <a:extLst xmlns:a="http://schemas.openxmlformats.org/drawingml/2006/main">
               <a:ext uri="{FF2B5EF4-FFF2-40B4-BE49-F238E27FC236}">
-                <a16:creationId xmlns:a16="http://schemas.microsoft.com/office/drawing/2014/main" id="{83383D34-D8EA-4B4B-9782-AD4596C1666C}"/>
+                <a16:creationId xmlns:a16="http://schemas.microsoft.com/office/drawing/2014/main" id="{A4DA4D5C-2E0B-4EC1-9681-DE4EA58E74F4}"/>
               </a:ext>
             </a:extLst>
           </p:cNvPr>
@@ -12884,7 +13122,7 @@
     </p:spTree>
     <p:extLst>
       <p:ext uri="{BB962C8B-B14F-4D97-AF65-F5344CB8AC3E}">
-        <p14:creationId xmlns:p14="http://schemas.microsoft.com/office/powerpoint/2010/main" val="311801575"/>
+        <p14:creationId xmlns:p14="http://schemas.microsoft.com/office/powerpoint/2010/main" val="1086623217"/>
       </p:ext>
     </p:extLst>
   </p:cSld>
@@ -12923,7 +13161,7 @@
           <p:cNvPr id="14" name="slide-title">
             <a:extLst xmlns:a="http://schemas.openxmlformats.org/drawingml/2006/main">
               <a:ext uri="{FF2B5EF4-FFF2-40B4-BE49-F238E27FC236}">
-                <a16:creationId xmlns:a16="http://schemas.microsoft.com/office/drawing/2014/main" id="{992C0579-1E98-4C90-BCFB-6C3F54D729CF}"/>
+                <a16:creationId xmlns:a16="http://schemas.microsoft.com/office/drawing/2014/main" id="{AEF21087-6A7B-4232-81B1-2E19A7351B81}"/>
               </a:ext>
             </a:extLst>
           </p:cNvPr>
@@ -12974,7 +13212,7 @@
           <p:cNvPr id="2" name="step-num-1">
             <a:extLst xmlns:a="http://schemas.openxmlformats.org/drawingml/2006/main">
               <a:ext uri="{FF2B5EF4-FFF2-40B4-BE49-F238E27FC236}">
-                <a16:creationId xmlns:a16="http://schemas.microsoft.com/office/drawing/2014/main" id="{1AC44FDE-2C3B-439E-B7EE-E99293B4E744}"/>
+                <a16:creationId xmlns:a16="http://schemas.microsoft.com/office/drawing/2014/main" id="{84E2AC29-112D-4BD8-AF37-867115B83B2A}"/>
               </a:ext>
             </a:extLst>
           </p:cNvPr>
@@ -13025,7 +13263,7 @@
           <p:cNvPr id="3" name="step-label-1">
             <a:extLst xmlns:a="http://schemas.openxmlformats.org/drawingml/2006/main">
               <a:ext uri="{FF2B5EF4-FFF2-40B4-BE49-F238E27FC236}">
-                <a16:creationId xmlns:a16="http://schemas.microsoft.com/office/drawing/2014/main" id="{08177A3F-31EF-4316-AA24-376D5FC0F48B}"/>
+                <a16:creationId xmlns:a16="http://schemas.microsoft.com/office/drawing/2014/main" id="{36A57930-90B5-4E1A-A913-E52515F2F7C6}"/>
               </a:ext>
             </a:extLst>
           </p:cNvPr>
@@ -13076,7 +13314,7 @@
           <p:cNvPr id="4" name="step-line-1">
             <a:extLst xmlns:a="http://schemas.openxmlformats.org/drawingml/2006/main">
               <a:ext uri="{FF2B5EF4-FFF2-40B4-BE49-F238E27FC236}">
-                <a16:creationId xmlns:a16="http://schemas.microsoft.com/office/drawing/2014/main" id="{1A6FA15D-F01B-4D6C-B21C-262F2CE9C014}"/>
+                <a16:creationId xmlns:a16="http://schemas.microsoft.com/office/drawing/2014/main" id="{35831776-3402-48F6-8DA3-71413597B1FD}"/>
               </a:ext>
             </a:extLst>
           </p:cNvPr>
@@ -13107,7 +13345,7 @@
           <p:cNvPr id="5" name="step-num-2">
             <a:extLst xmlns:a="http://schemas.openxmlformats.org/drawingml/2006/main">
               <a:ext uri="{FF2B5EF4-FFF2-40B4-BE49-F238E27FC236}">
-                <a16:creationId xmlns:a16="http://schemas.microsoft.com/office/drawing/2014/main" id="{A3272464-EF63-4672-BC55-64571DC4E179}"/>
+                <a16:creationId xmlns:a16="http://schemas.microsoft.com/office/drawing/2014/main" id="{7FE98E1B-001E-40C9-8894-513EC80BE0C1}"/>
               </a:ext>
             </a:extLst>
           </p:cNvPr>
@@ -13158,7 +13396,7 @@
           <p:cNvPr id="6" name="step-label-2">
             <a:extLst xmlns:a="http://schemas.openxmlformats.org/drawingml/2006/main">
               <a:ext uri="{FF2B5EF4-FFF2-40B4-BE49-F238E27FC236}">
-                <a16:creationId xmlns:a16="http://schemas.microsoft.com/office/drawing/2014/main" id="{88BA5706-AFAD-4529-861E-96B7DFD1729F}"/>
+                <a16:creationId xmlns:a16="http://schemas.microsoft.com/office/drawing/2014/main" id="{410096DC-44A8-48A8-8868-ECDEF15E73A9}"/>
               </a:ext>
             </a:extLst>
           </p:cNvPr>
@@ -13209,7 +13447,7 @@
           <p:cNvPr id="7" name="step-line-2">
             <a:extLst xmlns:a="http://schemas.openxmlformats.org/drawingml/2006/main">
               <a:ext uri="{FF2B5EF4-FFF2-40B4-BE49-F238E27FC236}">
-                <a16:creationId xmlns:a16="http://schemas.microsoft.com/office/drawing/2014/main" id="{D14A4A14-3655-4750-964F-759791C709DA}"/>
+                <a16:creationId xmlns:a16="http://schemas.microsoft.com/office/drawing/2014/main" id="{55F49E86-8925-4FFB-A42E-540A25149914}"/>
               </a:ext>
             </a:extLst>
           </p:cNvPr>
@@ -13240,7 +13478,7 @@
           <p:cNvPr id="8" name="step-num-3">
             <a:extLst xmlns:a="http://schemas.openxmlformats.org/drawingml/2006/main">
               <a:ext uri="{FF2B5EF4-FFF2-40B4-BE49-F238E27FC236}">
-                <a16:creationId xmlns:a16="http://schemas.microsoft.com/office/drawing/2014/main" id="{59E1678A-4031-4020-9FED-812799C98077}"/>
+                <a16:creationId xmlns:a16="http://schemas.microsoft.com/office/drawing/2014/main" id="{33319D71-821B-4A93-ACD4-A51C1357A794}"/>
               </a:ext>
             </a:extLst>
           </p:cNvPr>
@@ -13291,7 +13529,7 @@
           <p:cNvPr id="9" name="step-label-3">
             <a:extLst xmlns:a="http://schemas.openxmlformats.org/drawingml/2006/main">
               <a:ext uri="{FF2B5EF4-FFF2-40B4-BE49-F238E27FC236}">
-                <a16:creationId xmlns:a16="http://schemas.microsoft.com/office/drawing/2014/main" id="{E30163AF-5304-4B1E-924A-FAF5846442E8}"/>
+                <a16:creationId xmlns:a16="http://schemas.microsoft.com/office/drawing/2014/main" id="{FA7A5B7A-4096-482F-9629-45E0887C01A4}"/>
               </a:ext>
             </a:extLst>
           </p:cNvPr>
@@ -13342,7 +13580,7 @@
           <p:cNvPr id="10" name="eyebrow">
             <a:extLst xmlns:a="http://schemas.openxmlformats.org/drawingml/2006/main">
               <a:ext uri="{FF2B5EF4-FFF2-40B4-BE49-F238E27FC236}">
-                <a16:creationId xmlns:a16="http://schemas.microsoft.com/office/drawing/2014/main" id="{7AD93945-361F-44CE-AF86-F8E31F9D3460}"/>
+                <a16:creationId xmlns:a16="http://schemas.microsoft.com/office/drawing/2014/main" id="{66B09C49-213A-4288-997E-9BFEC27F9111}"/>
               </a:ext>
             </a:extLst>
           </p:cNvPr>
@@ -13393,7 +13631,7 @@
           <p:cNvPr id="11" name="footer-rule">
             <a:extLst xmlns:a="http://schemas.openxmlformats.org/drawingml/2006/main">
               <a:ext uri="{FF2B5EF4-FFF2-40B4-BE49-F238E27FC236}">
-                <a16:creationId xmlns:a16="http://schemas.microsoft.com/office/drawing/2014/main" id="{40518D40-AE6D-4038-A534-28CE0120FDA4}"/>
+                <a16:creationId xmlns:a16="http://schemas.microsoft.com/office/drawing/2014/main" id="{08CD6733-558B-4734-B12D-704F6C57BEC6}"/>
               </a:ext>
             </a:extLst>
           </p:cNvPr>
@@ -13426,7 +13664,7 @@
           <p:cNvPr id="12" name="footer">
             <a:extLst xmlns:a="http://schemas.openxmlformats.org/drawingml/2006/main">
               <a:ext uri="{FF2B5EF4-FFF2-40B4-BE49-F238E27FC236}">
-                <a16:creationId xmlns:a16="http://schemas.microsoft.com/office/drawing/2014/main" id="{DFD36C23-30B4-4932-BB50-EFC7E9907C32}"/>
+                <a16:creationId xmlns:a16="http://schemas.microsoft.com/office/drawing/2014/main" id="{5538C2AE-ACC3-47E4-828C-86605FB1691A}"/>
               </a:ext>
             </a:extLst>
           </p:cNvPr>
@@ -13481,7 +13719,7 @@
           <p:cNvPr id="13" name="page-number">
             <a:extLst xmlns:a="http://schemas.openxmlformats.org/drawingml/2006/main">
               <a:ext uri="{FF2B5EF4-FFF2-40B4-BE49-F238E27FC236}">
-                <a16:creationId xmlns:a16="http://schemas.microsoft.com/office/drawing/2014/main" id="{1D9802CB-5411-4306-8AC7-734729990D62}"/>
+                <a16:creationId xmlns:a16="http://schemas.microsoft.com/office/drawing/2014/main" id="{0A0D6462-2C35-47BD-919D-31D808651B35}"/>
               </a:ext>
             </a:extLst>
           </p:cNvPr>
@@ -13534,7 +13772,7 @@
     </p:spTree>
     <p:extLst>
       <p:ext uri="{BB962C8B-B14F-4D97-AF65-F5344CB8AC3E}">
-        <p14:creationId xmlns:p14="http://schemas.microsoft.com/office/powerpoint/2010/main" val="1706817199"/>
+        <p14:creationId xmlns:p14="http://schemas.microsoft.com/office/powerpoint/2010/main" val="148335205"/>
       </p:ext>
     </p:extLst>
   </p:cSld>
@@ -13573,7 +13811,7 @@
           <p:cNvPr id="11" name="slide-title">
             <a:extLst xmlns:a="http://schemas.openxmlformats.org/drawingml/2006/main">
               <a:ext uri="{FF2B5EF4-FFF2-40B4-BE49-F238E27FC236}">
-                <a16:creationId xmlns:a16="http://schemas.microsoft.com/office/drawing/2014/main" id="{CECF7CF6-6EBF-49E0-ADE9-12C24B227766}"/>
+                <a16:creationId xmlns:a16="http://schemas.microsoft.com/office/drawing/2014/main" id="{DC205F40-367C-4C5E-BA01-E4DB22B6AEA6}"/>
               </a:ext>
             </a:extLst>
           </p:cNvPr>
@@ -13624,7 +13862,7 @@
           <p:cNvPr id="2" name="slide-subtitle">
             <a:extLst xmlns:a="http://schemas.openxmlformats.org/drawingml/2006/main">
               <a:ext uri="{FF2B5EF4-FFF2-40B4-BE49-F238E27FC236}">
-                <a16:creationId xmlns:a16="http://schemas.microsoft.com/office/drawing/2014/main" id="{2C56E300-DA42-4194-9D5D-09795B8414A4}"/>
+                <a16:creationId xmlns:a16="http://schemas.microsoft.com/office/drawing/2014/main" id="{4CF628AC-A006-4871-831C-EE2892D1B0D0}"/>
               </a:ext>
             </a:extLst>
           </p:cNvPr>
@@ -13675,7 +13913,7 @@
           <p:cNvPr id="3" name="bullets">
             <a:extLst xmlns:a="http://schemas.openxmlformats.org/drawingml/2006/main">
               <a:ext uri="{FF2B5EF4-FFF2-40B4-BE49-F238E27FC236}">
-                <a16:creationId xmlns:a16="http://schemas.microsoft.com/office/drawing/2014/main" id="{104B7AC4-1820-49E5-9A2E-1289124460B6}"/>
+                <a16:creationId xmlns:a16="http://schemas.microsoft.com/office/drawing/2014/main" id="{2210262F-EFF1-4419-9CDC-68ECACE5C548}"/>
               </a:ext>
             </a:extLst>
           </p:cNvPr>
@@ -13762,7 +14000,7 @@
           <p:cNvPr id="4" name="ambient-glow">
             <a:extLst xmlns:a="http://schemas.openxmlformats.org/drawingml/2006/main">
               <a:ext uri="{FF2B5EF4-FFF2-40B4-BE49-F238E27FC236}">
-                <a16:creationId xmlns:a16="http://schemas.microsoft.com/office/drawing/2014/main" id="{8D91EB7E-F0C6-413B-B6A5-4E4862F39DBD}"/>
+                <a16:creationId xmlns:a16="http://schemas.microsoft.com/office/drawing/2014/main" id="{2E228503-AB3E-4F11-8E31-16BA9D094725}"/>
               </a:ext>
             </a:extLst>
           </p:cNvPr>
@@ -13799,7 +14037,7 @@
           <p:cNvPr id="5" name="ambient-core">
             <a:extLst xmlns:a="http://schemas.openxmlformats.org/drawingml/2006/main">
               <a:ext uri="{FF2B5EF4-FFF2-40B4-BE49-F238E27FC236}">
-                <a16:creationId xmlns:a16="http://schemas.microsoft.com/office/drawing/2014/main" id="{6FB3E244-3556-4D85-B818-D495B3CC34F3}"/>
+                <a16:creationId xmlns:a16="http://schemas.microsoft.com/office/drawing/2014/main" id="{38239922-86FF-4E60-884B-C9610C69CB04}"/>
               </a:ext>
             </a:extLst>
           </p:cNvPr>
@@ -13836,7 +14074,7 @@
           <p:cNvPr id="6" name="section-number">
             <a:extLst xmlns:a="http://schemas.openxmlformats.org/drawingml/2006/main">
               <a:ext uri="{FF2B5EF4-FFF2-40B4-BE49-F238E27FC236}">
-                <a16:creationId xmlns:a16="http://schemas.microsoft.com/office/drawing/2014/main" id="{144386AA-44DE-4EDB-92D3-4D720A0AAAC5}"/>
+                <a16:creationId xmlns:a16="http://schemas.microsoft.com/office/drawing/2014/main" id="{EE333610-B8F0-4F64-8276-5572A1682E37}"/>
               </a:ext>
             </a:extLst>
           </p:cNvPr>
@@ -13887,7 +14125,7 @@
           <p:cNvPr id="7" name="eyebrow">
             <a:extLst xmlns:a="http://schemas.openxmlformats.org/drawingml/2006/main">
               <a:ext uri="{FF2B5EF4-FFF2-40B4-BE49-F238E27FC236}">
-                <a16:creationId xmlns:a16="http://schemas.microsoft.com/office/drawing/2014/main" id="{710356C0-EE66-4C80-A1E4-72F547C9BD92}"/>
+                <a16:creationId xmlns:a16="http://schemas.microsoft.com/office/drawing/2014/main" id="{B320C635-8CEE-4597-9337-6ABB0E8D82E0}"/>
               </a:ext>
             </a:extLst>
           </p:cNvPr>
@@ -13938,7 +14176,7 @@
           <p:cNvPr id="8" name="footer-rule">
             <a:extLst xmlns:a="http://schemas.openxmlformats.org/drawingml/2006/main">
               <a:ext uri="{FF2B5EF4-FFF2-40B4-BE49-F238E27FC236}">
-                <a16:creationId xmlns:a16="http://schemas.microsoft.com/office/drawing/2014/main" id="{63CE5B2B-CF89-4BDB-9721-A3F79348BF1F}"/>
+                <a16:creationId xmlns:a16="http://schemas.microsoft.com/office/drawing/2014/main" id="{359A9C30-23E9-4033-8CD1-3DF1F7B07119}"/>
               </a:ext>
             </a:extLst>
           </p:cNvPr>
@@ -13971,7 +14209,7 @@
           <p:cNvPr id="9" name="footer">
             <a:extLst xmlns:a="http://schemas.openxmlformats.org/drawingml/2006/main">
               <a:ext uri="{FF2B5EF4-FFF2-40B4-BE49-F238E27FC236}">
-                <a16:creationId xmlns:a16="http://schemas.microsoft.com/office/drawing/2014/main" id="{31C11E22-2B80-47A8-A663-03F2D2B268D4}"/>
+                <a16:creationId xmlns:a16="http://schemas.microsoft.com/office/drawing/2014/main" id="{978AF699-FD7C-4A97-83E8-8A117B4D8E92}"/>
               </a:ext>
             </a:extLst>
           </p:cNvPr>
@@ -14026,7 +14264,7 @@
           <p:cNvPr id="10" name="page-number">
             <a:extLst xmlns:a="http://schemas.openxmlformats.org/drawingml/2006/main">
               <a:ext uri="{FF2B5EF4-FFF2-40B4-BE49-F238E27FC236}">
-                <a16:creationId xmlns:a16="http://schemas.microsoft.com/office/drawing/2014/main" id="{0D7066C9-8303-40EA-AF0E-596696391817}"/>
+                <a16:creationId xmlns:a16="http://schemas.microsoft.com/office/drawing/2014/main" id="{86A98224-1A82-490D-A7D8-A579DC0B3FDF}"/>
               </a:ext>
             </a:extLst>
           </p:cNvPr>
@@ -14079,7 +14317,7 @@
     </p:spTree>
     <p:extLst>
       <p:ext uri="{BB962C8B-B14F-4D97-AF65-F5344CB8AC3E}">
-        <p14:creationId xmlns:p14="http://schemas.microsoft.com/office/powerpoint/2010/main" val="1063992983"/>
+        <p14:creationId xmlns:p14="http://schemas.microsoft.com/office/powerpoint/2010/main" val="1272252404"/>
       </p:ext>
     </p:extLst>
   </p:cSld>
@@ -14110,7 +14348,7 @@
           <p:cNvPr id="11" name="slide-title">
             <a:extLst xmlns:a="http://schemas.openxmlformats.org/drawingml/2006/main">
               <a:ext uri="{FF2B5EF4-FFF2-40B4-BE49-F238E27FC236}">
-                <a16:creationId xmlns:a16="http://schemas.microsoft.com/office/drawing/2014/main" id="{BDD4F6D8-4B3E-49E8-80B1-8F4029B19B3F}"/>
+                <a16:creationId xmlns:a16="http://schemas.microsoft.com/office/drawing/2014/main" id="{F35CB3EF-349E-4055-BA00-B70F579A422E}"/>
               </a:ext>
             </a:extLst>
           </p:cNvPr>
@@ -14161,7 +14399,7 @@
           <p:cNvPr id="2" name="slide-subtitle">
             <a:extLst xmlns:a="http://schemas.openxmlformats.org/drawingml/2006/main">
               <a:ext uri="{FF2B5EF4-FFF2-40B4-BE49-F238E27FC236}">
-                <a16:creationId xmlns:a16="http://schemas.microsoft.com/office/drawing/2014/main" id="{5408FDA1-1C52-42E5-9DD0-E064F194E6EF}"/>
+                <a16:creationId xmlns:a16="http://schemas.microsoft.com/office/drawing/2014/main" id="{830162A6-B3D9-4115-AF37-C61F37FEBEE6}"/>
               </a:ext>
             </a:extLst>
           </p:cNvPr>
@@ -14212,7 +14450,7 @@
           <p:cNvPr id="3" name="bullets">
             <a:extLst xmlns:a="http://schemas.openxmlformats.org/drawingml/2006/main">
               <a:ext uri="{FF2B5EF4-FFF2-40B4-BE49-F238E27FC236}">
-                <a16:creationId xmlns:a16="http://schemas.microsoft.com/office/drawing/2014/main" id="{1C250498-8BBC-4E72-9C5F-DEE3530F9259}"/>
+                <a16:creationId xmlns:a16="http://schemas.microsoft.com/office/drawing/2014/main" id="{A3CDD556-E808-42BD-9A96-FF7962152038}"/>
               </a:ext>
             </a:extLst>
           </p:cNvPr>
@@ -14299,7 +14537,7 @@
           <p:cNvPr id="4" name="ambient-glow">
             <a:extLst xmlns:a="http://schemas.openxmlformats.org/drawingml/2006/main">
               <a:ext uri="{FF2B5EF4-FFF2-40B4-BE49-F238E27FC236}">
-                <a16:creationId xmlns:a16="http://schemas.microsoft.com/office/drawing/2014/main" id="{A28E08BD-28CC-4BC8-9F14-67108CAC9253}"/>
+                <a16:creationId xmlns:a16="http://schemas.microsoft.com/office/drawing/2014/main" id="{1D4FA262-458E-442E-91CB-47E01456DDD1}"/>
               </a:ext>
             </a:extLst>
           </p:cNvPr>
@@ -14336,7 +14574,7 @@
           <p:cNvPr id="5" name="ambient-core">
             <a:extLst xmlns:a="http://schemas.openxmlformats.org/drawingml/2006/main">
               <a:ext uri="{FF2B5EF4-FFF2-40B4-BE49-F238E27FC236}">
-                <a16:creationId xmlns:a16="http://schemas.microsoft.com/office/drawing/2014/main" id="{1E559AB6-23AE-4544-90CE-ADA17D8DD18F}"/>
+                <a16:creationId xmlns:a16="http://schemas.microsoft.com/office/drawing/2014/main" id="{BA33EA68-6EE2-4472-BC89-461C434E43C4}"/>
               </a:ext>
             </a:extLst>
           </p:cNvPr>
@@ -14373,7 +14611,7 @@
           <p:cNvPr id="6" name="section-number">
             <a:extLst xmlns:a="http://schemas.openxmlformats.org/drawingml/2006/main">
               <a:ext uri="{FF2B5EF4-FFF2-40B4-BE49-F238E27FC236}">
-                <a16:creationId xmlns:a16="http://schemas.microsoft.com/office/drawing/2014/main" id="{F19BD2F0-A8B6-4C51-9CB4-241513EEFBE9}"/>
+                <a16:creationId xmlns:a16="http://schemas.microsoft.com/office/drawing/2014/main" id="{89DC2A82-67EF-4DE5-866D-20F83F0EFD36}"/>
               </a:ext>
             </a:extLst>
           </p:cNvPr>
@@ -14424,7 +14662,7 @@
           <p:cNvPr id="7" name="eyebrow">
             <a:extLst xmlns:a="http://schemas.openxmlformats.org/drawingml/2006/main">
               <a:ext uri="{FF2B5EF4-FFF2-40B4-BE49-F238E27FC236}">
-                <a16:creationId xmlns:a16="http://schemas.microsoft.com/office/drawing/2014/main" id="{99C1408B-9D50-4EB4-BD2A-EA886245DF67}"/>
+                <a16:creationId xmlns:a16="http://schemas.microsoft.com/office/drawing/2014/main" id="{65749AB4-CAFE-48F8-BE9F-59C37FC4FFAF}"/>
               </a:ext>
             </a:extLst>
           </p:cNvPr>
@@ -14475,7 +14713,7 @@
           <p:cNvPr id="8" name="footer-rule">
             <a:extLst xmlns:a="http://schemas.openxmlformats.org/drawingml/2006/main">
               <a:ext uri="{FF2B5EF4-FFF2-40B4-BE49-F238E27FC236}">
-                <a16:creationId xmlns:a16="http://schemas.microsoft.com/office/drawing/2014/main" id="{A3D1EE50-CCC0-4FB9-BF48-4AE44F408FC7}"/>
+                <a16:creationId xmlns:a16="http://schemas.microsoft.com/office/drawing/2014/main" id="{1C54E99B-B3F7-42CE-B586-17C92097A535}"/>
               </a:ext>
             </a:extLst>
           </p:cNvPr>
@@ -14508,7 +14746,7 @@
           <p:cNvPr id="9" name="footer">
             <a:extLst xmlns:a="http://schemas.openxmlformats.org/drawingml/2006/main">
               <a:ext uri="{FF2B5EF4-FFF2-40B4-BE49-F238E27FC236}">
-                <a16:creationId xmlns:a16="http://schemas.microsoft.com/office/drawing/2014/main" id="{DC80ACCE-3A32-4B8A-BB0A-10858B31EC0F}"/>
+                <a16:creationId xmlns:a16="http://schemas.microsoft.com/office/drawing/2014/main" id="{C46C7262-7ED9-4C96-B265-CE32F9D409BF}"/>
               </a:ext>
             </a:extLst>
           </p:cNvPr>
@@ -14563,7 +14801,7 @@
           <p:cNvPr id="10" name="page-number">
             <a:extLst xmlns:a="http://schemas.openxmlformats.org/drawingml/2006/main">
               <a:ext uri="{FF2B5EF4-FFF2-40B4-BE49-F238E27FC236}">
-                <a16:creationId xmlns:a16="http://schemas.microsoft.com/office/drawing/2014/main" id="{9F13160E-F9E6-4D86-9C69-AD933FD63AAE}"/>
+                <a16:creationId xmlns:a16="http://schemas.microsoft.com/office/drawing/2014/main" id="{66870789-9892-432D-B794-EAA5A97828A3}"/>
               </a:ext>
             </a:extLst>
           </p:cNvPr>
@@ -14616,7 +14854,7 @@
     </p:spTree>
     <p:extLst>
       <p:ext uri="{BB962C8B-B14F-4D97-AF65-F5344CB8AC3E}">
-        <p14:creationId xmlns:p14="http://schemas.microsoft.com/office/powerpoint/2010/main" val="2043973957"/>
+        <p14:creationId xmlns:p14="http://schemas.microsoft.com/office/powerpoint/2010/main" val="1406880801"/>
       </p:ext>
     </p:extLst>
   </p:cSld>
@@ -14655,7 +14893,7 @@
           <p:cNvPr id="10" name="slide-title">
             <a:extLst xmlns:a="http://schemas.openxmlformats.org/drawingml/2006/main">
               <a:ext uri="{FF2B5EF4-FFF2-40B4-BE49-F238E27FC236}">
-                <a16:creationId xmlns:a16="http://schemas.microsoft.com/office/drawing/2014/main" id="{074E39BB-5F40-4A19-AFFC-957BD4CDD1AD}"/>
+                <a16:creationId xmlns:a16="http://schemas.microsoft.com/office/drawing/2014/main" id="{A7A40CB5-2945-4B7F-910F-81CF05B27E01}"/>
               </a:ext>
             </a:extLst>
           </p:cNvPr>
@@ -14706,7 +14944,7 @@
           <p:cNvPr id="2" name="visual-claim">
             <a:extLst xmlns:a="http://schemas.openxmlformats.org/drawingml/2006/main">
               <a:ext uri="{FF2B5EF4-FFF2-40B4-BE49-F238E27FC236}">
-                <a16:creationId xmlns:a16="http://schemas.microsoft.com/office/drawing/2014/main" id="{32F768F0-579D-4D55-80E5-FA7A5A08614C}"/>
+                <a16:creationId xmlns:a16="http://schemas.microsoft.com/office/drawing/2014/main" id="{B804B8C4-AF1F-454E-9EDD-2C23A1628CCF}"/>
               </a:ext>
             </a:extLst>
           </p:cNvPr>
@@ -14757,7 +14995,7 @@
           <p:cNvPr id="3" name="image-surface">
             <a:extLst xmlns:a="http://schemas.openxmlformats.org/drawingml/2006/main">
               <a:ext uri="{FF2B5EF4-FFF2-40B4-BE49-F238E27FC236}">
-                <a16:creationId xmlns:a16="http://schemas.microsoft.com/office/drawing/2014/main" id="{C23E5211-B61B-473B-B323-350ADFC35EF0}"/>
+                <a16:creationId xmlns:a16="http://schemas.microsoft.com/office/drawing/2014/main" id="{F6CBC4CE-A089-43DC-9CC7-65997C39DDD6}"/>
               </a:ext>
             </a:extLst>
           </p:cNvPr>
@@ -14798,7 +15036,7 @@
           <p:nvPr/>
         </p:nvPicPr>
         <p:blipFill>
-          <a:blip xmlns:r="http://schemas.openxmlformats.org/officeDocument/2006/relationships" xmlns:a="http://schemas.openxmlformats.org/drawingml/2006/main" r:embed="R00b51b5630de48c2"/>
+          <a:blip xmlns:r="http://schemas.openxmlformats.org/officeDocument/2006/relationships" xmlns:a="http://schemas.openxmlformats.org/drawingml/2006/main" r:embed="Radc9b64350214638"/>
           <a:stretch xmlns:a="http://schemas.openxmlformats.org/drawingml/2006/main"/>
         </p:blipFill>
         <p:spPr>
@@ -14816,7 +15054,7 @@
           <p:cNvPr id="5" name="image-caption">
             <a:extLst xmlns:a="http://schemas.openxmlformats.org/drawingml/2006/main">
               <a:ext uri="{FF2B5EF4-FFF2-40B4-BE49-F238E27FC236}">
-                <a16:creationId xmlns:a16="http://schemas.microsoft.com/office/drawing/2014/main" id="{A2B5984E-D667-4214-B0B0-A1EABCB140C7}"/>
+                <a16:creationId xmlns:a16="http://schemas.microsoft.com/office/drawing/2014/main" id="{E61F62D8-104A-4100-A6AA-A2D0B6DE6B05}"/>
               </a:ext>
             </a:extLst>
           </p:cNvPr>
@@ -14867,7 +15105,7 @@
           <p:cNvPr id="6" name="eyebrow">
             <a:extLst xmlns:a="http://schemas.openxmlformats.org/drawingml/2006/main">
               <a:ext uri="{FF2B5EF4-FFF2-40B4-BE49-F238E27FC236}">
-                <a16:creationId xmlns:a16="http://schemas.microsoft.com/office/drawing/2014/main" id="{A29F5DA5-66BA-44CD-AC19-315108068C3B}"/>
+                <a16:creationId xmlns:a16="http://schemas.microsoft.com/office/drawing/2014/main" id="{F06B60A7-1305-4D5F-9894-146B9AA9157C}"/>
               </a:ext>
             </a:extLst>
           </p:cNvPr>
@@ -14918,7 +15156,7 @@
           <p:cNvPr id="7" name="footer-rule">
             <a:extLst xmlns:a="http://schemas.openxmlformats.org/drawingml/2006/main">
               <a:ext uri="{FF2B5EF4-FFF2-40B4-BE49-F238E27FC236}">
-                <a16:creationId xmlns:a16="http://schemas.microsoft.com/office/drawing/2014/main" id="{35D0AB36-53BC-4533-9911-2F82471E394F}"/>
+                <a16:creationId xmlns:a16="http://schemas.microsoft.com/office/drawing/2014/main" id="{49263CEE-DE3F-460B-A2DE-11AC00CC44B4}"/>
               </a:ext>
             </a:extLst>
           </p:cNvPr>
@@ -14951,7 +15189,7 @@
           <p:cNvPr id="8" name="footer">
             <a:extLst xmlns:a="http://schemas.openxmlformats.org/drawingml/2006/main">
               <a:ext uri="{FF2B5EF4-FFF2-40B4-BE49-F238E27FC236}">
-                <a16:creationId xmlns:a16="http://schemas.microsoft.com/office/drawing/2014/main" id="{81816DBE-5F3B-4987-8BF8-4E9DACA23E33}"/>
+                <a16:creationId xmlns:a16="http://schemas.microsoft.com/office/drawing/2014/main" id="{D9CD25F7-BC22-41A9-860D-AF3A34F3F4AA}"/>
               </a:ext>
             </a:extLst>
           </p:cNvPr>
@@ -15006,7 +15244,7 @@
           <p:cNvPr id="9" name="page-number">
             <a:extLst xmlns:a="http://schemas.openxmlformats.org/drawingml/2006/main">
               <a:ext uri="{FF2B5EF4-FFF2-40B4-BE49-F238E27FC236}">
-                <a16:creationId xmlns:a16="http://schemas.microsoft.com/office/drawing/2014/main" id="{7E0BC533-7286-40FA-9A73-EB9AB40E0F2C}"/>
+                <a16:creationId xmlns:a16="http://schemas.microsoft.com/office/drawing/2014/main" id="{0B801A05-47A3-4376-A566-F5108D0A85A4}"/>
               </a:ext>
             </a:extLst>
           </p:cNvPr>
@@ -15059,7 +15297,7 @@
     </p:spTree>
     <p:extLst>
       <p:ext uri="{BB962C8B-B14F-4D97-AF65-F5344CB8AC3E}">
-        <p14:creationId xmlns:p14="http://schemas.microsoft.com/office/powerpoint/2010/main" val="1524364088"/>
+        <p14:creationId xmlns:p14="http://schemas.microsoft.com/office/powerpoint/2010/main" val="37331508"/>
       </p:ext>
     </p:extLst>
   </p:cSld>
@@ -15098,7 +15336,7 @@
           <p:cNvPr id="11" name="slide-title">
             <a:extLst xmlns:a="http://schemas.openxmlformats.org/drawingml/2006/main">
               <a:ext uri="{FF2B5EF4-FFF2-40B4-BE49-F238E27FC236}">
-                <a16:creationId xmlns:a16="http://schemas.microsoft.com/office/drawing/2014/main" id="{A596FD48-1DC8-465F-A2C7-C80E12BA7F6B}"/>
+                <a16:creationId xmlns:a16="http://schemas.microsoft.com/office/drawing/2014/main" id="{38886520-DF39-448A-A0C9-C7238D0ECD63}"/>
               </a:ext>
             </a:extLst>
           </p:cNvPr>
@@ -15149,7 +15387,7 @@
           <p:cNvPr id="2" name="slide-subtitle">
             <a:extLst xmlns:a="http://schemas.openxmlformats.org/drawingml/2006/main">
               <a:ext uri="{FF2B5EF4-FFF2-40B4-BE49-F238E27FC236}">
-                <a16:creationId xmlns:a16="http://schemas.microsoft.com/office/drawing/2014/main" id="{10A2F2E4-DDCE-4B87-AFA9-100C22FA3B47}"/>
+                <a16:creationId xmlns:a16="http://schemas.microsoft.com/office/drawing/2014/main" id="{CDF48FAD-0D99-4379-8EAA-8BD4BEB79C51}"/>
               </a:ext>
             </a:extLst>
           </p:cNvPr>
@@ -15200,7 +15438,7 @@
           <p:cNvPr id="3" name="bullets">
             <a:extLst xmlns:a="http://schemas.openxmlformats.org/drawingml/2006/main">
               <a:ext uri="{FF2B5EF4-FFF2-40B4-BE49-F238E27FC236}">
-                <a16:creationId xmlns:a16="http://schemas.microsoft.com/office/drawing/2014/main" id="{A2F0054D-B872-4D6F-9FE5-AF5B8672C66E}"/>
+                <a16:creationId xmlns:a16="http://schemas.microsoft.com/office/drawing/2014/main" id="{61A20AE3-708C-4EFB-8AED-D91A85C2D3BE}"/>
               </a:ext>
             </a:extLst>
           </p:cNvPr>
@@ -15305,7 +15543,7 @@
           <p:cNvPr id="4" name="ambient-glow">
             <a:extLst xmlns:a="http://schemas.openxmlformats.org/drawingml/2006/main">
               <a:ext uri="{FF2B5EF4-FFF2-40B4-BE49-F238E27FC236}">
-                <a16:creationId xmlns:a16="http://schemas.microsoft.com/office/drawing/2014/main" id="{155CA596-AF89-460E-8422-CFBE1A35F6E7}"/>
+                <a16:creationId xmlns:a16="http://schemas.microsoft.com/office/drawing/2014/main" id="{7D5E3581-4D02-4803-9B59-3076682838B1}"/>
               </a:ext>
             </a:extLst>
           </p:cNvPr>
@@ -15342,7 +15580,7 @@
           <p:cNvPr id="5" name="ambient-core">
             <a:extLst xmlns:a="http://schemas.openxmlformats.org/drawingml/2006/main">
               <a:ext uri="{FF2B5EF4-FFF2-40B4-BE49-F238E27FC236}">
-                <a16:creationId xmlns:a16="http://schemas.microsoft.com/office/drawing/2014/main" id="{22258744-27E3-4A8F-BCE9-AADDB7796C3F}"/>
+                <a16:creationId xmlns:a16="http://schemas.microsoft.com/office/drawing/2014/main" id="{32B1D452-C31B-4677-A17E-27D93959F23E}"/>
               </a:ext>
             </a:extLst>
           </p:cNvPr>
@@ -15379,7 +15617,7 @@
           <p:cNvPr id="6" name="section-number">
             <a:extLst xmlns:a="http://schemas.openxmlformats.org/drawingml/2006/main">
               <a:ext uri="{FF2B5EF4-FFF2-40B4-BE49-F238E27FC236}">
-                <a16:creationId xmlns:a16="http://schemas.microsoft.com/office/drawing/2014/main" id="{35266A81-A4C9-4EBB-920A-A44888DBDCD2}"/>
+                <a16:creationId xmlns:a16="http://schemas.microsoft.com/office/drawing/2014/main" id="{1840F980-4393-4E79-9ABC-DBACB3D3EE72}"/>
               </a:ext>
             </a:extLst>
           </p:cNvPr>
@@ -15430,7 +15668,7 @@
           <p:cNvPr id="7" name="eyebrow">
             <a:extLst xmlns:a="http://schemas.openxmlformats.org/drawingml/2006/main">
               <a:ext uri="{FF2B5EF4-FFF2-40B4-BE49-F238E27FC236}">
-                <a16:creationId xmlns:a16="http://schemas.microsoft.com/office/drawing/2014/main" id="{815CCA0E-5D44-4992-BF96-094FC0F96F72}"/>
+                <a16:creationId xmlns:a16="http://schemas.microsoft.com/office/drawing/2014/main" id="{5C1B52D9-B47B-4A2D-A803-604E939D1D12}"/>
               </a:ext>
             </a:extLst>
           </p:cNvPr>
@@ -15481,7 +15719,7 @@
           <p:cNvPr id="8" name="footer-rule">
             <a:extLst xmlns:a="http://schemas.openxmlformats.org/drawingml/2006/main">
               <a:ext uri="{FF2B5EF4-FFF2-40B4-BE49-F238E27FC236}">
-                <a16:creationId xmlns:a16="http://schemas.microsoft.com/office/drawing/2014/main" id="{80014A9D-95D4-4D10-92A0-26D693C8FB55}"/>
+                <a16:creationId xmlns:a16="http://schemas.microsoft.com/office/drawing/2014/main" id="{5CA6F433-D8F9-402C-AB38-F4F42ECEE88E}"/>
               </a:ext>
             </a:extLst>
           </p:cNvPr>
@@ -15514,7 +15752,7 @@
           <p:cNvPr id="9" name="footer">
             <a:extLst xmlns:a="http://schemas.openxmlformats.org/drawingml/2006/main">
               <a:ext uri="{FF2B5EF4-FFF2-40B4-BE49-F238E27FC236}">
-                <a16:creationId xmlns:a16="http://schemas.microsoft.com/office/drawing/2014/main" id="{9A503593-72D0-4F54-8203-8432F717C2D5}"/>
+                <a16:creationId xmlns:a16="http://schemas.microsoft.com/office/drawing/2014/main" id="{71DB4F32-F85A-4137-88A1-F31D7CD60CD4}"/>
               </a:ext>
             </a:extLst>
           </p:cNvPr>
@@ -15569,7 +15807,7 @@
           <p:cNvPr id="10" name="page-number">
             <a:extLst xmlns:a="http://schemas.openxmlformats.org/drawingml/2006/main">
               <a:ext uri="{FF2B5EF4-FFF2-40B4-BE49-F238E27FC236}">
-                <a16:creationId xmlns:a16="http://schemas.microsoft.com/office/drawing/2014/main" id="{83A1C053-F2AA-4F58-AEF5-177AD0BA8A32}"/>
+                <a16:creationId xmlns:a16="http://schemas.microsoft.com/office/drawing/2014/main" id="{B5D45D84-0824-417D-A841-42127761962D}"/>
               </a:ext>
             </a:extLst>
           </p:cNvPr>
@@ -15622,7 +15860,7 @@
     </p:spTree>
     <p:extLst>
       <p:ext uri="{BB962C8B-B14F-4D97-AF65-F5344CB8AC3E}">
-        <p14:creationId xmlns:p14="http://schemas.microsoft.com/office/powerpoint/2010/main" val="1237958100"/>
+        <p14:creationId xmlns:p14="http://schemas.microsoft.com/office/powerpoint/2010/main" val="1850666622"/>
       </p:ext>
     </p:extLst>
   </p:cSld>
@@ -15653,7 +15891,7 @@
           <p:cNvPr id="10" name="slide-title">
             <a:extLst xmlns:a="http://schemas.openxmlformats.org/drawingml/2006/main">
               <a:ext uri="{FF2B5EF4-FFF2-40B4-BE49-F238E27FC236}">
-                <a16:creationId xmlns:a16="http://schemas.microsoft.com/office/drawing/2014/main" id="{7492B470-F607-4715-B1BC-BAF1E8F0EA2A}"/>
+                <a16:creationId xmlns:a16="http://schemas.microsoft.com/office/drawing/2014/main" id="{E971B1FB-659A-4397-9A08-8E15088F1B1E}"/>
               </a:ext>
             </a:extLst>
           </p:cNvPr>
@@ -15704,7 +15942,7 @@
           <p:cNvPr id="2" name="visual-claim">
             <a:extLst xmlns:a="http://schemas.openxmlformats.org/drawingml/2006/main">
               <a:ext uri="{FF2B5EF4-FFF2-40B4-BE49-F238E27FC236}">
-                <a16:creationId xmlns:a16="http://schemas.microsoft.com/office/drawing/2014/main" id="{6CA41905-901E-48D5-BA33-421B2C4CC693}"/>
+                <a16:creationId xmlns:a16="http://schemas.microsoft.com/office/drawing/2014/main" id="{73BA4EA2-CDC3-49AF-B35C-A6585CD86BFE}"/>
               </a:ext>
             </a:extLst>
           </p:cNvPr>
@@ -15755,7 +15993,7 @@
           <p:cNvPr id="3" name="image-surface">
             <a:extLst xmlns:a="http://schemas.openxmlformats.org/drawingml/2006/main">
               <a:ext uri="{FF2B5EF4-FFF2-40B4-BE49-F238E27FC236}">
-                <a16:creationId xmlns:a16="http://schemas.microsoft.com/office/drawing/2014/main" id="{5A89A0D0-2671-4A8B-8E1B-9D9403A64150}"/>
+                <a16:creationId xmlns:a16="http://schemas.microsoft.com/office/drawing/2014/main" id="{9A864C97-FCAF-4F61-8C68-C1015264F1F3}"/>
               </a:ext>
             </a:extLst>
           </p:cNvPr>
@@ -15794,7 +16032,7 @@
           <p:nvPr/>
         </p:nvPicPr>
         <p:blipFill>
-          <a:blip xmlns:r="http://schemas.openxmlformats.org/officeDocument/2006/relationships" xmlns:a="http://schemas.openxmlformats.org/drawingml/2006/main" r:embed="R1161e5fcb8ef47ba"/>
+          <a:blip xmlns:r="http://schemas.openxmlformats.org/officeDocument/2006/relationships" xmlns:a="http://schemas.openxmlformats.org/drawingml/2006/main" r:embed="Ra710b4a6a85243ba"/>
           <a:stretch xmlns:a="http://schemas.openxmlformats.org/drawingml/2006/main"/>
         </p:blipFill>
         <p:spPr>
@@ -15812,7 +16050,7 @@
           <p:cNvPr id="5" name="image-caption">
             <a:extLst xmlns:a="http://schemas.openxmlformats.org/drawingml/2006/main">
               <a:ext uri="{FF2B5EF4-FFF2-40B4-BE49-F238E27FC236}">
-                <a16:creationId xmlns:a16="http://schemas.microsoft.com/office/drawing/2014/main" id="{926142FD-DAEE-4548-BC10-76AD24F66E46}"/>
+                <a16:creationId xmlns:a16="http://schemas.microsoft.com/office/drawing/2014/main" id="{AD4F9E01-1BEE-40BD-B0AA-48C44CDC0151}"/>
               </a:ext>
             </a:extLst>
           </p:cNvPr>
@@ -15863,7 +16101,7 @@
           <p:cNvPr id="6" name="eyebrow">
             <a:extLst xmlns:a="http://schemas.openxmlformats.org/drawingml/2006/main">
               <a:ext uri="{FF2B5EF4-FFF2-40B4-BE49-F238E27FC236}">
-                <a16:creationId xmlns:a16="http://schemas.microsoft.com/office/drawing/2014/main" id="{6D154E49-7C01-4855-9400-C4121E4EBB91}"/>
+                <a16:creationId xmlns:a16="http://schemas.microsoft.com/office/drawing/2014/main" id="{597B0722-A03F-4EFE-8193-CA813E2C17A5}"/>
               </a:ext>
             </a:extLst>
           </p:cNvPr>
@@ -15914,7 +16152,7 @@
           <p:cNvPr id="7" name="footer-rule">
             <a:extLst xmlns:a="http://schemas.openxmlformats.org/drawingml/2006/main">
               <a:ext uri="{FF2B5EF4-FFF2-40B4-BE49-F238E27FC236}">
-                <a16:creationId xmlns:a16="http://schemas.microsoft.com/office/drawing/2014/main" id="{859C49EA-20EE-443D-869A-FC1B274F674F}"/>
+                <a16:creationId xmlns:a16="http://schemas.microsoft.com/office/drawing/2014/main" id="{555402EE-9589-4BBC-91BD-E409F1745561}"/>
               </a:ext>
             </a:extLst>
           </p:cNvPr>
@@ -15947,7 +16185,7 @@
           <p:cNvPr id="8" name="footer">
             <a:extLst xmlns:a="http://schemas.openxmlformats.org/drawingml/2006/main">
               <a:ext uri="{FF2B5EF4-FFF2-40B4-BE49-F238E27FC236}">
-                <a16:creationId xmlns:a16="http://schemas.microsoft.com/office/drawing/2014/main" id="{DE8CFEBE-D0DD-445E-96E9-B355E4EE7529}"/>
+                <a16:creationId xmlns:a16="http://schemas.microsoft.com/office/drawing/2014/main" id="{0EE65EB3-52F7-4AD5-B97A-A09DA9C7A71C}"/>
               </a:ext>
             </a:extLst>
           </p:cNvPr>
@@ -16002,7 +16240,7 @@
           <p:cNvPr id="9" name="page-number">
             <a:extLst xmlns:a="http://schemas.openxmlformats.org/drawingml/2006/main">
               <a:ext uri="{FF2B5EF4-FFF2-40B4-BE49-F238E27FC236}">
-                <a16:creationId xmlns:a16="http://schemas.microsoft.com/office/drawing/2014/main" id="{20660817-3CCB-4189-B3D7-78F2E0440DBB}"/>
+                <a16:creationId xmlns:a16="http://schemas.microsoft.com/office/drawing/2014/main" id="{4B593467-9DFF-405B-86A1-3F713AEC5DFA}"/>
               </a:ext>
             </a:extLst>
           </p:cNvPr>
@@ -16055,7 +16293,7 @@
     </p:spTree>
     <p:extLst>
       <p:ext uri="{BB962C8B-B14F-4D97-AF65-F5344CB8AC3E}">
-        <p14:creationId xmlns:p14="http://schemas.microsoft.com/office/powerpoint/2010/main" val="2037243092"/>
+        <p14:creationId xmlns:p14="http://schemas.microsoft.com/office/powerpoint/2010/main" val="1763676169"/>
       </p:ext>
     </p:extLst>
   </p:cSld>
@@ -16086,7 +16324,7 @@
           <p:cNvPr id="11" name="slide-title">
             <a:extLst xmlns:a="http://schemas.openxmlformats.org/drawingml/2006/main">
               <a:ext uri="{FF2B5EF4-FFF2-40B4-BE49-F238E27FC236}">
-                <a16:creationId xmlns:a16="http://schemas.microsoft.com/office/drawing/2014/main" id="{40B94858-A4FB-4F30-99F9-2A91526E01A5}"/>
+                <a16:creationId xmlns:a16="http://schemas.microsoft.com/office/drawing/2014/main" id="{19F26365-4A10-4AF4-97F5-000B8D9DA4EC}"/>
               </a:ext>
             </a:extLst>
           </p:cNvPr>
@@ -16137,7 +16375,7 @@
           <p:cNvPr id="2" name="slide-subtitle">
             <a:extLst xmlns:a="http://schemas.openxmlformats.org/drawingml/2006/main">
               <a:ext uri="{FF2B5EF4-FFF2-40B4-BE49-F238E27FC236}">
-                <a16:creationId xmlns:a16="http://schemas.microsoft.com/office/drawing/2014/main" id="{173D2599-B4D1-492F-B6EB-9F2A934A2D9A}"/>
+                <a16:creationId xmlns:a16="http://schemas.microsoft.com/office/drawing/2014/main" id="{47E41C31-D30C-4A76-BAD6-91AAC9803304}"/>
               </a:ext>
             </a:extLst>
           </p:cNvPr>
@@ -16188,7 +16426,7 @@
           <p:cNvPr id="3" name="bullets">
             <a:extLst xmlns:a="http://schemas.openxmlformats.org/drawingml/2006/main">
               <a:ext uri="{FF2B5EF4-FFF2-40B4-BE49-F238E27FC236}">
-                <a16:creationId xmlns:a16="http://schemas.microsoft.com/office/drawing/2014/main" id="{BBEC3DD2-4027-43F4-B3B2-D413D6CD84AB}"/>
+                <a16:creationId xmlns:a16="http://schemas.microsoft.com/office/drawing/2014/main" id="{95E880E8-F380-4377-8BE3-829143FF50DB}"/>
               </a:ext>
             </a:extLst>
           </p:cNvPr>
@@ -16293,7 +16531,7 @@
           <p:cNvPr id="4" name="ambient-glow">
             <a:extLst xmlns:a="http://schemas.openxmlformats.org/drawingml/2006/main">
               <a:ext uri="{FF2B5EF4-FFF2-40B4-BE49-F238E27FC236}">
-                <a16:creationId xmlns:a16="http://schemas.microsoft.com/office/drawing/2014/main" id="{7AABF5DC-5271-4C29-95F3-A7C352055D05}"/>
+                <a16:creationId xmlns:a16="http://schemas.microsoft.com/office/drawing/2014/main" id="{8FCA8A02-C9A0-4C68-9FB5-6010C3DAEBB1}"/>
               </a:ext>
             </a:extLst>
           </p:cNvPr>
@@ -16330,7 +16568,7 @@
           <p:cNvPr id="5" name="ambient-core">
             <a:extLst xmlns:a="http://schemas.openxmlformats.org/drawingml/2006/main">
               <a:ext uri="{FF2B5EF4-FFF2-40B4-BE49-F238E27FC236}">
-                <a16:creationId xmlns:a16="http://schemas.microsoft.com/office/drawing/2014/main" id="{1CBA7B29-113F-436A-B05B-37E86ABDC716}"/>
+                <a16:creationId xmlns:a16="http://schemas.microsoft.com/office/drawing/2014/main" id="{A223EC8C-9C4F-49C2-9AE0-DAD3B01DB621}"/>
               </a:ext>
             </a:extLst>
           </p:cNvPr>
@@ -16367,7 +16605,7 @@
           <p:cNvPr id="6" name="section-number">
             <a:extLst xmlns:a="http://schemas.openxmlformats.org/drawingml/2006/main">
               <a:ext uri="{FF2B5EF4-FFF2-40B4-BE49-F238E27FC236}">
-                <a16:creationId xmlns:a16="http://schemas.microsoft.com/office/drawing/2014/main" id="{1A2909C2-B916-412B-8DD5-D0F41AA7A5F9}"/>
+                <a16:creationId xmlns:a16="http://schemas.microsoft.com/office/drawing/2014/main" id="{E6E5B8C6-F82D-4908-A6B4-22D9ADDE5868}"/>
               </a:ext>
             </a:extLst>
           </p:cNvPr>
@@ -16418,7 +16656,7 @@
           <p:cNvPr id="7" name="eyebrow">
             <a:extLst xmlns:a="http://schemas.openxmlformats.org/drawingml/2006/main">
               <a:ext uri="{FF2B5EF4-FFF2-40B4-BE49-F238E27FC236}">
-                <a16:creationId xmlns:a16="http://schemas.microsoft.com/office/drawing/2014/main" id="{FB073049-879B-4211-BABD-059C6A8DB4EA}"/>
+                <a16:creationId xmlns:a16="http://schemas.microsoft.com/office/drawing/2014/main" id="{82176A70-7A61-4EB6-A52E-9E5A5357733A}"/>
               </a:ext>
             </a:extLst>
           </p:cNvPr>
@@ -16469,7 +16707,7 @@
           <p:cNvPr id="8" name="footer-rule">
             <a:extLst xmlns:a="http://schemas.openxmlformats.org/drawingml/2006/main">
               <a:ext uri="{FF2B5EF4-FFF2-40B4-BE49-F238E27FC236}">
-                <a16:creationId xmlns:a16="http://schemas.microsoft.com/office/drawing/2014/main" id="{33AC037C-D6CF-4294-87BC-AA5EA47E3E52}"/>
+                <a16:creationId xmlns:a16="http://schemas.microsoft.com/office/drawing/2014/main" id="{7283226F-C17E-4041-8601-048F76ADA923}"/>
               </a:ext>
             </a:extLst>
           </p:cNvPr>
@@ -16502,7 +16740,7 @@
           <p:cNvPr id="9" name="footer">
             <a:extLst xmlns:a="http://schemas.openxmlformats.org/drawingml/2006/main">
               <a:ext uri="{FF2B5EF4-FFF2-40B4-BE49-F238E27FC236}">
-                <a16:creationId xmlns:a16="http://schemas.microsoft.com/office/drawing/2014/main" id="{F0156CBF-ACED-4AD1-A72E-252093C6B1DF}"/>
+                <a16:creationId xmlns:a16="http://schemas.microsoft.com/office/drawing/2014/main" id="{5F8EC1F8-6083-4A74-AF32-870551F460FC}"/>
               </a:ext>
             </a:extLst>
           </p:cNvPr>
@@ -16557,7 +16795,7 @@
           <p:cNvPr id="10" name="page-number">
             <a:extLst xmlns:a="http://schemas.openxmlformats.org/drawingml/2006/main">
               <a:ext uri="{FF2B5EF4-FFF2-40B4-BE49-F238E27FC236}">
-                <a16:creationId xmlns:a16="http://schemas.microsoft.com/office/drawing/2014/main" id="{CD339325-6B17-43CC-88C4-DFD79CA854D3}"/>
+                <a16:creationId xmlns:a16="http://schemas.microsoft.com/office/drawing/2014/main" id="{F07C0B84-5CEA-4C6B-91D3-0775F974315E}"/>
               </a:ext>
             </a:extLst>
           </p:cNvPr>
@@ -16610,7 +16848,7 @@
     </p:spTree>
     <p:extLst>
       <p:ext uri="{BB962C8B-B14F-4D97-AF65-F5344CB8AC3E}">
-        <p14:creationId xmlns:p14="http://schemas.microsoft.com/office/powerpoint/2010/main" val="899343370"/>
+        <p14:creationId xmlns:p14="http://schemas.microsoft.com/office/powerpoint/2010/main" val="1996774623"/>
       </p:ext>
     </p:extLst>
   </p:cSld>

</xml_diff>

<commit_message>
style: adiciona marca Rescue Point aos decks
</commit_message>
<xml_diff>
--- a/assets/decks/aula-00-ambiente.pptx
+++ b/assets/decks/aula-00-ambiente.pptx
@@ -2,35 +2,35 @@
 <file path=ppt/presentation.xml><?xml version="1.0" encoding="utf-8"?>
 <p:presentation xmlns:p="http://schemas.openxmlformats.org/presentationml/2006/main">
   <p:sldMasterIdLst>
-    <p:sldMasterId xmlns:r="http://schemas.openxmlformats.org/officeDocument/2006/relationships" id="2147483648" r:id="R60f8e71a7024410c"/>
-    <p:sldMasterId xmlns:r="http://schemas.openxmlformats.org/officeDocument/2006/relationships" id="2147483650" r:id="R14cbf583ce314ae0"/>
+    <p:sldMasterId xmlns:r="http://schemas.openxmlformats.org/officeDocument/2006/relationships" id="2147483648" r:id="Re9185732c3b2458d"/>
+    <p:sldMasterId xmlns:r="http://schemas.openxmlformats.org/officeDocument/2006/relationships" id="2147483650" r:id="R1083ab4e44cd4db6"/>
   </p:sldMasterIdLst>
   <p:notesMasterIdLst>
-    <p:notesMasterId xmlns:r="http://schemas.openxmlformats.org/officeDocument/2006/relationships" r:id="Rc03f8807c30e487e"/>
+    <p:notesMasterId xmlns:r="http://schemas.openxmlformats.org/officeDocument/2006/relationships" r:id="R397b4ce54b4b405a"/>
   </p:notesMasterIdLst>
   <p:sldIdLst>
-    <p:sldId xmlns:r="http://schemas.openxmlformats.org/officeDocument/2006/relationships" id="256" r:id="R95796218cc37415b"/>
-    <p:sldId xmlns:r="http://schemas.openxmlformats.org/officeDocument/2006/relationships" id="257" r:id="R86a26f9a8b7b4c5b"/>
-    <p:sldId xmlns:r="http://schemas.openxmlformats.org/officeDocument/2006/relationships" id="258" r:id="R4832c7d4d5294e57"/>
-    <p:sldId xmlns:r="http://schemas.openxmlformats.org/officeDocument/2006/relationships" id="259" r:id="Rffea5490777347ba"/>
-    <p:sldId xmlns:r="http://schemas.openxmlformats.org/officeDocument/2006/relationships" id="260" r:id="R5fcdf9e5e05f403c"/>
-    <p:sldId xmlns:r="http://schemas.openxmlformats.org/officeDocument/2006/relationships" id="261" r:id="Rabdcf25f3a424415"/>
-    <p:sldId xmlns:r="http://schemas.openxmlformats.org/officeDocument/2006/relationships" id="262" r:id="R60bdbfa943b241e9"/>
-    <p:sldId xmlns:r="http://schemas.openxmlformats.org/officeDocument/2006/relationships" id="263" r:id="R702a3001b837406c"/>
-    <p:sldId xmlns:r="http://schemas.openxmlformats.org/officeDocument/2006/relationships" id="264" r:id="Rb1b53e49ec724493"/>
-    <p:sldId xmlns:r="http://schemas.openxmlformats.org/officeDocument/2006/relationships" id="265" r:id="Rea4215a3142e427c"/>
-    <p:sldId xmlns:r="http://schemas.openxmlformats.org/officeDocument/2006/relationships" id="266" r:id="Rd0cf62f191d24b68"/>
-    <p:sldId xmlns:r="http://schemas.openxmlformats.org/officeDocument/2006/relationships" id="267" r:id="Rc59fd015e16b491e"/>
-    <p:sldId xmlns:r="http://schemas.openxmlformats.org/officeDocument/2006/relationships" id="268" r:id="R054c3884a2a241e0"/>
-    <p:sldId xmlns:r="http://schemas.openxmlformats.org/officeDocument/2006/relationships" id="269" r:id="R8fb70749c78c401c"/>
-    <p:sldId xmlns:r="http://schemas.openxmlformats.org/officeDocument/2006/relationships" id="270" r:id="Rf1c98e335fc34d00"/>
-    <p:sldId xmlns:r="http://schemas.openxmlformats.org/officeDocument/2006/relationships" id="271" r:id="Ra09408fb205846a4"/>
-    <p:sldId xmlns:r="http://schemas.openxmlformats.org/officeDocument/2006/relationships" id="272" r:id="R5b1d7a9210b7487c"/>
-    <p:sldId xmlns:r="http://schemas.openxmlformats.org/officeDocument/2006/relationships" id="273" r:id="Rff188005b8284a37"/>
-    <p:sldId xmlns:r="http://schemas.openxmlformats.org/officeDocument/2006/relationships" id="274" r:id="R2c1fa2dc15c04232"/>
-    <p:sldId xmlns:r="http://schemas.openxmlformats.org/officeDocument/2006/relationships" id="275" r:id="R44a5027d8fde4b61"/>
-    <p:sldId xmlns:r="http://schemas.openxmlformats.org/officeDocument/2006/relationships" id="276" r:id="R89aa6a2afa4e4760"/>
-    <p:sldId xmlns:r="http://schemas.openxmlformats.org/officeDocument/2006/relationships" id="277" r:id="Rc501fc345aca4c3f"/>
+    <p:sldId xmlns:r="http://schemas.openxmlformats.org/officeDocument/2006/relationships" id="256" r:id="R1581c77ab4734f53"/>
+    <p:sldId xmlns:r="http://schemas.openxmlformats.org/officeDocument/2006/relationships" id="257" r:id="Rc1476f5a31ba44ed"/>
+    <p:sldId xmlns:r="http://schemas.openxmlformats.org/officeDocument/2006/relationships" id="258" r:id="R71705f0de6d44fb3"/>
+    <p:sldId xmlns:r="http://schemas.openxmlformats.org/officeDocument/2006/relationships" id="259" r:id="R1fd511f225694fc8"/>
+    <p:sldId xmlns:r="http://schemas.openxmlformats.org/officeDocument/2006/relationships" id="260" r:id="R62c6d55699724152"/>
+    <p:sldId xmlns:r="http://schemas.openxmlformats.org/officeDocument/2006/relationships" id="261" r:id="Rdeea14881d904bb8"/>
+    <p:sldId xmlns:r="http://schemas.openxmlformats.org/officeDocument/2006/relationships" id="262" r:id="Rbd9050cc069a46f5"/>
+    <p:sldId xmlns:r="http://schemas.openxmlformats.org/officeDocument/2006/relationships" id="263" r:id="R6ee462ceb9d143d8"/>
+    <p:sldId xmlns:r="http://schemas.openxmlformats.org/officeDocument/2006/relationships" id="264" r:id="Rc9c7382ad7fb4dd5"/>
+    <p:sldId xmlns:r="http://schemas.openxmlformats.org/officeDocument/2006/relationships" id="265" r:id="R21f8ec0064a845ae"/>
+    <p:sldId xmlns:r="http://schemas.openxmlformats.org/officeDocument/2006/relationships" id="266" r:id="Rccab597717864ddc"/>
+    <p:sldId xmlns:r="http://schemas.openxmlformats.org/officeDocument/2006/relationships" id="267" r:id="Rff42736115b24340"/>
+    <p:sldId xmlns:r="http://schemas.openxmlformats.org/officeDocument/2006/relationships" id="268" r:id="R967ca0492a4d4bfa"/>
+    <p:sldId xmlns:r="http://schemas.openxmlformats.org/officeDocument/2006/relationships" id="269" r:id="R1466c3cc9465435d"/>
+    <p:sldId xmlns:r="http://schemas.openxmlformats.org/officeDocument/2006/relationships" id="270" r:id="R9278a31b51d64788"/>
+    <p:sldId xmlns:r="http://schemas.openxmlformats.org/officeDocument/2006/relationships" id="271" r:id="Rdc1d521ac94f40da"/>
+    <p:sldId xmlns:r="http://schemas.openxmlformats.org/officeDocument/2006/relationships" id="272" r:id="R5f678a3635ad44ec"/>
+    <p:sldId xmlns:r="http://schemas.openxmlformats.org/officeDocument/2006/relationships" id="273" r:id="R4802eda10c024a01"/>
+    <p:sldId xmlns:r="http://schemas.openxmlformats.org/officeDocument/2006/relationships" id="274" r:id="R6b3ef60b050c465c"/>
+    <p:sldId xmlns:r="http://schemas.openxmlformats.org/officeDocument/2006/relationships" id="275" r:id="R539aa9b1b80e429e"/>
+    <p:sldId xmlns:r="http://schemas.openxmlformats.org/officeDocument/2006/relationships" id="276" r:id="Rcb59c00872d943dd"/>
+    <p:sldId xmlns:r="http://schemas.openxmlformats.org/officeDocument/2006/relationships" id="277" r:id="R5ee1a2cb329d4ce3"/>
   </p:sldIdLst>
   <p:sldSz cx="12192000" cy="6858000"/>
   <p:notesSz cx="6858000" cy="9144000"/>
@@ -584,6 +584,11 @@
           </a:p>
           <a:p xmlns:a="http://schemas.openxmlformats.org/drawingml/2006/main">
             <a:r>
+              <a:t>- https://rescuepoint.com.br/assets/img/logo.png</a:t>
+            </a:r>
+          </a:p>
+          <a:p xmlns:a="http://schemas.openxmlformats.org/drawingml/2006/main">
+            <a:r>
               <a:t>- https://github.com/AnselmoBorges/dbt-moderno-na-pratica/blob/main/roteiros/aula-00-ambiente.md</a:t>
             </a:r>
           </a:p>
@@ -789,6 +794,11 @@
           </a:p>
           <a:p xmlns:a="http://schemas.openxmlformats.org/drawingml/2006/main">
             <a:r>
+              <a:t>- https://rescuepoint.com.br/assets/img/logo.png</a:t>
+            </a:r>
+          </a:p>
+          <a:p xmlns:a="http://schemas.openxmlformats.org/drawingml/2006/main">
+            <a:r>
               <a:t>- https://github.com/AnselmoBorges/dbt-moderno-na-pratica/blob/main/roteiros/aula-00-ambiente.md</a:t>
             </a:r>
           </a:p>
@@ -994,6 +1004,11 @@
           </a:p>
           <a:p xmlns:a="http://schemas.openxmlformats.org/drawingml/2006/main">
             <a:r>
+              <a:t>- https://rescuepoint.com.br/assets/img/logo.png</a:t>
+            </a:r>
+          </a:p>
+          <a:p xmlns:a="http://schemas.openxmlformats.org/drawingml/2006/main">
+            <a:r>
               <a:t>- https://github.com/AnselmoBorges/dbt-moderno-na-pratica/blob/main/roteiros/aula-00-ambiente.md</a:t>
             </a:r>
           </a:p>
@@ -1199,6 +1214,11 @@
           </a:p>
           <a:p xmlns:a="http://schemas.openxmlformats.org/drawingml/2006/main">
             <a:r>
+              <a:t>- https://rescuepoint.com.br/assets/img/logo.png</a:t>
+            </a:r>
+          </a:p>
+          <a:p xmlns:a="http://schemas.openxmlformats.org/drawingml/2006/main">
+            <a:r>
               <a:t>- https://github.com/AnselmoBorges/dbt-moderno-na-pratica/blob/main/roteiros/aula-00-ambiente.md</a:t>
             </a:r>
           </a:p>
@@ -1409,6 +1429,11 @@
           </a:p>
           <a:p xmlns:a="http://schemas.openxmlformats.org/drawingml/2006/main">
             <a:r>
+              <a:t>- https://rescuepoint.com.br/assets/img/logo.png</a:t>
+            </a:r>
+          </a:p>
+          <a:p xmlns:a="http://schemas.openxmlformats.org/drawingml/2006/main">
+            <a:r>
               <a:t>- https://github.com/AnselmoBorges/dbt-moderno-na-pratica/blob/main/roteiros/aula-00-ambiente.md</a:t>
             </a:r>
           </a:p>
@@ -1614,6 +1639,11 @@
           </a:p>
           <a:p xmlns:a="http://schemas.openxmlformats.org/drawingml/2006/main">
             <a:r>
+              <a:t>- https://rescuepoint.com.br/assets/img/logo.png</a:t>
+            </a:r>
+          </a:p>
+          <a:p xmlns:a="http://schemas.openxmlformats.org/drawingml/2006/main">
+            <a:r>
               <a:t>- https://github.com/AnselmoBorges/dbt-moderno-na-pratica/blob/main/roteiros/aula-00-ambiente.md</a:t>
             </a:r>
           </a:p>
@@ -1819,6 +1849,11 @@
           </a:p>
           <a:p xmlns:a="http://schemas.openxmlformats.org/drawingml/2006/main">
             <a:r>
+              <a:t>- https://rescuepoint.com.br/assets/img/logo.png</a:t>
+            </a:r>
+          </a:p>
+          <a:p xmlns:a="http://schemas.openxmlformats.org/drawingml/2006/main">
+            <a:r>
               <a:t>- https://github.com/AnselmoBorges/dbt-moderno-na-pratica/blob/main/roteiros/aula-00-ambiente.md</a:t>
             </a:r>
           </a:p>
@@ -2024,6 +2059,11 @@
           </a:p>
           <a:p xmlns:a="http://schemas.openxmlformats.org/drawingml/2006/main">
             <a:r>
+              <a:t>- https://rescuepoint.com.br/assets/img/logo.png</a:t>
+            </a:r>
+          </a:p>
+          <a:p xmlns:a="http://schemas.openxmlformats.org/drawingml/2006/main">
+            <a:r>
               <a:t>- https://github.com/AnselmoBorges/dbt-moderno-na-pratica/blob/main/roteiros/aula-00-ambiente.md</a:t>
             </a:r>
           </a:p>
@@ -2229,6 +2269,11 @@
           </a:p>
           <a:p xmlns:a="http://schemas.openxmlformats.org/drawingml/2006/main">
             <a:r>
+              <a:t>- https://rescuepoint.com.br/assets/img/logo.png</a:t>
+            </a:r>
+          </a:p>
+          <a:p xmlns:a="http://schemas.openxmlformats.org/drawingml/2006/main">
+            <a:r>
               <a:t>- https://github.com/AnselmoBorges/dbt-moderno-na-pratica/blob/main/roteiros/aula-00-ambiente.md</a:t>
             </a:r>
           </a:p>
@@ -2434,6 +2479,11 @@
           </a:p>
           <a:p xmlns:a="http://schemas.openxmlformats.org/drawingml/2006/main">
             <a:r>
+              <a:t>- https://rescuepoint.com.br/assets/img/logo.png</a:t>
+            </a:r>
+          </a:p>
+          <a:p xmlns:a="http://schemas.openxmlformats.org/drawingml/2006/main">
+            <a:r>
               <a:t>- https://github.com/AnselmoBorges/dbt-moderno-na-pratica/blob/main/roteiros/aula-00-ambiente.md</a:t>
             </a:r>
           </a:p>
@@ -2639,6 +2689,11 @@
           </a:p>
           <a:p xmlns:a="http://schemas.openxmlformats.org/drawingml/2006/main">
             <a:r>
+              <a:t>- https://rescuepoint.com.br/assets/img/logo.png</a:t>
+            </a:r>
+          </a:p>
+          <a:p xmlns:a="http://schemas.openxmlformats.org/drawingml/2006/main">
+            <a:r>
               <a:t>- https://github.com/AnselmoBorges/dbt-moderno-na-pratica/blob/main/roteiros/aula-00-ambiente.md</a:t>
             </a:r>
           </a:p>
@@ -2844,6 +2899,11 @@
           </a:p>
           <a:p xmlns:a="http://schemas.openxmlformats.org/drawingml/2006/main">
             <a:r>
+              <a:t>- https://rescuepoint.com.br/assets/img/logo.png</a:t>
+            </a:r>
+          </a:p>
+          <a:p xmlns:a="http://schemas.openxmlformats.org/drawingml/2006/main">
+            <a:r>
               <a:t>- https://github.com/AnselmoBorges/dbt-moderno-na-pratica/blob/main/roteiros/aula-00-ambiente.md</a:t>
             </a:r>
           </a:p>
@@ -3049,6 +3109,11 @@
           </a:p>
           <a:p xmlns:a="http://schemas.openxmlformats.org/drawingml/2006/main">
             <a:r>
+              <a:t>- https://rescuepoint.com.br/assets/img/logo.png</a:t>
+            </a:r>
+          </a:p>
+          <a:p xmlns:a="http://schemas.openxmlformats.org/drawingml/2006/main">
+            <a:r>
               <a:t>- https://github.com/AnselmoBorges/dbt-moderno-na-pratica/blob/main/roteiros/aula-00-ambiente.md</a:t>
             </a:r>
           </a:p>
@@ -3254,6 +3319,11 @@
           </a:p>
           <a:p xmlns:a="http://schemas.openxmlformats.org/drawingml/2006/main">
             <a:r>
+              <a:t>- https://rescuepoint.com.br/assets/img/logo.png</a:t>
+            </a:r>
+          </a:p>
+          <a:p xmlns:a="http://schemas.openxmlformats.org/drawingml/2006/main">
+            <a:r>
               <a:t>- https://github.com/AnselmoBorges/dbt-moderno-na-pratica/blob/main/roteiros/aula-00-ambiente.md</a:t>
             </a:r>
           </a:p>
@@ -3459,6 +3529,11 @@
           </a:p>
           <a:p xmlns:a="http://schemas.openxmlformats.org/drawingml/2006/main">
             <a:r>
+              <a:t>- https://rescuepoint.com.br/assets/img/logo.png</a:t>
+            </a:r>
+          </a:p>
+          <a:p xmlns:a="http://schemas.openxmlformats.org/drawingml/2006/main">
+            <a:r>
               <a:t>- https://github.com/AnselmoBorges/dbt-moderno-na-pratica/blob/main/roteiros/aula-00-ambiente.md</a:t>
             </a:r>
           </a:p>
@@ -3664,6 +3739,11 @@
           </a:p>
           <a:p xmlns:a="http://schemas.openxmlformats.org/drawingml/2006/main">
             <a:r>
+              <a:t>- https://rescuepoint.com.br/assets/img/logo.png</a:t>
+            </a:r>
+          </a:p>
+          <a:p xmlns:a="http://schemas.openxmlformats.org/drawingml/2006/main">
+            <a:r>
               <a:t>- https://github.com/AnselmoBorges/dbt-moderno-na-pratica/blob/main/roteiros/aula-00-ambiente.md</a:t>
             </a:r>
           </a:p>
@@ -3869,6 +3949,11 @@
           </a:p>
           <a:p xmlns:a="http://schemas.openxmlformats.org/drawingml/2006/main">
             <a:r>
+              <a:t>- https://rescuepoint.com.br/assets/img/logo.png</a:t>
+            </a:r>
+          </a:p>
+          <a:p xmlns:a="http://schemas.openxmlformats.org/drawingml/2006/main">
+            <a:r>
               <a:t>- https://github.com/AnselmoBorges/dbt-moderno-na-pratica/blob/main/roteiros/aula-00-ambiente.md</a:t>
             </a:r>
           </a:p>
@@ -4074,6 +4159,11 @@
           </a:p>
           <a:p xmlns:a="http://schemas.openxmlformats.org/drawingml/2006/main">
             <a:r>
+              <a:t>- https://rescuepoint.com.br/assets/img/logo.png</a:t>
+            </a:r>
+          </a:p>
+          <a:p xmlns:a="http://schemas.openxmlformats.org/drawingml/2006/main">
+            <a:r>
               <a:t>- https://github.com/AnselmoBorges/dbt-moderno-na-pratica/blob/main/roteiros/aula-00-ambiente.md</a:t>
             </a:r>
           </a:p>
@@ -4279,6 +4369,11 @@
           </a:p>
           <a:p xmlns:a="http://schemas.openxmlformats.org/drawingml/2006/main">
             <a:r>
+              <a:t>- https://rescuepoint.com.br/assets/img/logo.png</a:t>
+            </a:r>
+          </a:p>
+          <a:p xmlns:a="http://schemas.openxmlformats.org/drawingml/2006/main">
+            <a:r>
               <a:t>- https://github.com/AnselmoBorges/dbt-moderno-na-pratica/blob/main/roteiros/aula-00-ambiente.md</a:t>
             </a:r>
           </a:p>
@@ -4489,6 +4584,11 @@
           </a:p>
           <a:p xmlns:a="http://schemas.openxmlformats.org/drawingml/2006/main">
             <a:r>
+              <a:t>- https://rescuepoint.com.br/assets/img/logo.png</a:t>
+            </a:r>
+          </a:p>
+          <a:p xmlns:a="http://schemas.openxmlformats.org/drawingml/2006/main">
+            <a:r>
               <a:t>- https://github.com/AnselmoBorges/dbt-moderno-na-pratica/blob/main/roteiros/aula-00-ambiente.md</a:t>
             </a:r>
           </a:p>
@@ -4694,6 +4794,11 @@
           </a:p>
           <a:p xmlns:a="http://schemas.openxmlformats.org/drawingml/2006/main">
             <a:r>
+              <a:t>- https://rescuepoint.com.br/assets/img/logo.png</a:t>
+            </a:r>
+          </a:p>
+          <a:p xmlns:a="http://schemas.openxmlformats.org/drawingml/2006/main">
+            <a:r>
               <a:t>- https://github.com/AnselmoBorges/dbt-moderno-na-pratica/blob/main/roteiros/aula-00-ambiente.md</a:t>
             </a:r>
           </a:p>
@@ -4900,6 +5005,11 @@
           <a:p xmlns:a="http://schemas.openxmlformats.org/drawingml/2006/main">
             <a:r>
               <a:t>- https://github.com/dbt-labs/jaffle_shop_duckdb</a:t>
+            </a:r>
+          </a:p>
+          <a:p xmlns:a="http://schemas.openxmlformats.org/drawingml/2006/main">
+            <a:r>
+              <a:t>- https://rescuepoint.com.br/assets/img/logo.png</a:t>
             </a:r>
           </a:p>
           <a:p xmlns:a="http://schemas.openxmlformats.org/drawingml/2006/main">
@@ -5021,7 +5131,7 @@
   </p:cSld>
   <p:clrMap bg1="lt1" tx1="dk1" bg2="lt2" tx2="dk2" accent1="accent1" accent2="accent2" accent3="accent3" accent4="accent4" accent5="accent5" accent6="accent6" hlink="hlink" folHlink="folHlink"/>
   <p:sldLayoutIdLst>
-    <p:sldLayoutId xmlns:r="http://schemas.openxmlformats.org/officeDocument/2006/relationships" id="2147483649" r:id="R0d214ca5f853403d"/>
+    <p:sldLayoutId xmlns:r="http://schemas.openxmlformats.org/officeDocument/2006/relationships" id="2147483649" r:id="R523029af92964adc"/>
   </p:sldLayoutIdLst>
   <p:txStyles>
     <p:titleStyle>
@@ -5319,8 +5429,8 @@
   </p:cSld>
   <p:clrMap bg1="lt1" tx1="dk1" bg2="lt2" tx2="dk2" accent1="accent1" accent2="accent2" accent3="accent3" accent4="accent4" accent5="accent5" accent6="accent6" hlink="hlink" folHlink="folHlink"/>
   <p:sldLayoutIdLst>
-    <p:sldLayoutId xmlns:r="http://schemas.openxmlformats.org/officeDocument/2006/relationships" id="2147483651" r:id="Ra13f49743dbf4c4e"/>
-    <p:sldLayoutId xmlns:r="http://schemas.openxmlformats.org/officeDocument/2006/relationships" id="2147483652" r:id="R82eb701f764e48a2"/>
+    <p:sldLayoutId xmlns:r="http://schemas.openxmlformats.org/officeDocument/2006/relationships" id="2147483651" r:id="R62e0ede57fab4bdf"/>
+    <p:sldLayoutId xmlns:r="http://schemas.openxmlformats.org/officeDocument/2006/relationships" id="2147483652" r:id="Rb4598d5dc46943cc"/>
   </p:sldLayoutIdLst>
 </p:sldMaster>
 </file>
@@ -5844,14 +5954,14 @@
       </p:grpSpPr>
       <p:pic>
         <p:nvPicPr>
-          <p:cNvPr id="10" name="" descr="Ilustração conceitual autoral da capa: AULA 0 — Prepare seu laboratório dbt no Codespaces."/>
+          <p:cNvPr id="13" name="" descr="Ilustração conceitual autoral da capa: AULA 0 — Prepare seu laboratório dbt no Codespaces."/>
           <p:cNvPicPr>
             <a:picLocks xmlns:a="http://schemas.openxmlformats.org/drawingml/2006/main" noChangeAspect="1"/>
           </p:cNvPicPr>
           <p:nvPr/>
         </p:nvPicPr>
         <p:blipFill>
-          <a:blip xmlns:r="http://schemas.openxmlformats.org/officeDocument/2006/relationships" xmlns:a="http://schemas.openxmlformats.org/drawingml/2006/main" r:embed="R948b56e378644f06"/>
+          <a:blip xmlns:r="http://schemas.openxmlformats.org/officeDocument/2006/relationships" xmlns:a="http://schemas.openxmlformats.org/drawingml/2006/main" r:embed="R7b4224b7b08e4017"/>
           <a:srcRect xmlns:a="http://schemas.openxmlformats.org/drawingml/2006/main" l="19785" t="0" r="19785" b="0"/>
           <a:stretch xmlns:a="http://schemas.openxmlformats.org/drawingml/2006/main">
             <a:fillRect l="0" t="0" r="0" b="0"/>
@@ -5872,7 +5982,7 @@
           <p:cNvPr id="2" name="cover-text-surface">
             <a:extLst xmlns:a="http://schemas.openxmlformats.org/drawingml/2006/main">
               <a:ext uri="{FF2B5EF4-FFF2-40B4-BE49-F238E27FC236}">
-                <a16:creationId xmlns:a16="http://schemas.microsoft.com/office/drawing/2014/main" id="{46F41A0E-E27B-4DC0-A5D5-3DFCF7D11DCB}"/>
+                <a16:creationId xmlns:a16="http://schemas.microsoft.com/office/drawing/2014/main" id="{73784B68-E217-4383-AB7E-DAA27648DE93}"/>
               </a:ext>
             </a:extLst>
           </p:cNvPr>
@@ -5905,7 +6015,7 @@
           <p:cNvPr id="3" name="cover-divider">
             <a:extLst xmlns:a="http://schemas.openxmlformats.org/drawingml/2006/main">
               <a:ext uri="{FF2B5EF4-FFF2-40B4-BE49-F238E27FC236}">
-                <a16:creationId xmlns:a16="http://schemas.microsoft.com/office/drawing/2014/main" id="{179214D2-D2FC-4E7E-8598-D9916C749C97}"/>
+                <a16:creationId xmlns:a16="http://schemas.microsoft.com/office/drawing/2014/main" id="{E0686A10-0EEE-427F-BC0E-BF15A6F4709D}"/>
               </a:ext>
             </a:extLst>
           </p:cNvPr>
@@ -5936,7 +6046,7 @@
           <p:cNvPr id="4" name="cover-episode">
             <a:extLst xmlns:a="http://schemas.openxmlformats.org/drawingml/2006/main">
               <a:ext uri="{FF2B5EF4-FFF2-40B4-BE49-F238E27FC236}">
-                <a16:creationId xmlns:a16="http://schemas.microsoft.com/office/drawing/2014/main" id="{B5707B2C-39D1-4F5B-BBD9-40BB5BEF50D6}"/>
+                <a16:creationId xmlns:a16="http://schemas.microsoft.com/office/drawing/2014/main" id="{4160699E-F1A3-4DBB-9E13-AE8144ABE849}"/>
               </a:ext>
             </a:extLst>
           </p:cNvPr>
@@ -5984,10 +6094,69 @@
       </p:sp>
       <p:sp>
         <p:nvSpPr>
-          <p:cNvPr id="5" name="cover-title">
-            <a:extLst xmlns:a="http://schemas.openxmlformats.org/drawingml/2006/main">
-              <a:ext uri="{FF2B5EF4-FFF2-40B4-BE49-F238E27FC236}">
-                <a16:creationId xmlns:a16="http://schemas.microsoft.com/office/drawing/2014/main" id="{7D43DC55-1E7B-4BAF-AC3A-3EC76708ED8B}"/>
+          <p:cNvPr id="5" name="rescue-point-logo-background">
+            <a:extLst xmlns:a="http://schemas.openxmlformats.org/drawingml/2006/main">
+              <a:ext uri="{FF2B5EF4-FFF2-40B4-BE49-F238E27FC236}">
+                <a16:creationId xmlns:a16="http://schemas.microsoft.com/office/drawing/2014/main" id="{CE4ED013-D47C-4277-A11C-914BE4FFB10A}"/>
+              </a:ext>
+            </a:extLst>
+          </p:cNvPr>
+          <p:cNvSpPr>
+            <a:spLocks xmlns:a="http://schemas.openxmlformats.org/drawingml/2006/main" noGrp="1"/>
+          </p:cNvSpPr>
+          <p:nvPr/>
+        </p:nvSpPr>
+        <p:spPr>
+          <a:xfrm xmlns:a="http://schemas.openxmlformats.org/drawingml/2006/main">
+            <a:off x="9772650" y="133350"/>
+            <a:ext cx="1733550" cy="457200"/>
+          </a:xfrm>
+          <a:prstGeom xmlns:a="http://schemas.openxmlformats.org/drawingml/2006/main" prst="roundRect">
+            <a:avLst>
+              <a:gd name="adj" fmla="val 16667"/>
+            </a:avLst>
+          </a:prstGeom>
+          <a:solidFill xmlns:a="http://schemas.openxmlformats.org/drawingml/2006/main">
+            <a:srgbClr val="06142E"/>
+          </a:solidFill>
+          <a:ln xmlns:a="http://schemas.openxmlformats.org/drawingml/2006/main" w="9525">
+            <a:solidFill>
+              <a:srgbClr val="1EC5FF">
+                <a:alpha val="33333"/>
+              </a:srgbClr>
+            </a:solidFill>
+            <a:prstDash val="solid"/>
+          </a:ln>
+        </p:spPr>
+      </p:sp>
+      <p:pic>
+        <p:nvPicPr>
+          <p:cNvPr id="18" name="" descr="Ilustração conceitual autoral da capa: AULA 0 — Prepare seu laboratório dbt no Codespaces."/>
+          <p:cNvPicPr>
+            <a:picLocks xmlns:a="http://schemas.openxmlformats.org/drawingml/2006/main" noChangeAspect="1"/>
+          </p:cNvPicPr>
+          <p:nvPr/>
+        </p:nvPicPr>
+        <p:blipFill>
+          <a:blip xmlns:r="http://schemas.openxmlformats.org/officeDocument/2006/relationships" xmlns:a="http://schemas.openxmlformats.org/drawingml/2006/main" r:embed="R74be168f70754401"/>
+          <a:stretch xmlns:a="http://schemas.openxmlformats.org/drawingml/2006/main"/>
+        </p:blipFill>
+        <p:spPr>
+          <a:xfrm xmlns:a="http://schemas.openxmlformats.org/drawingml/2006/main">
+            <a:off x="9893718" y="209550"/>
+            <a:ext cx="1491414" cy="323850"/>
+          </a:xfrm>
+          <a:prstGeom xmlns:a="http://schemas.openxmlformats.org/drawingml/2006/main" prst="rect">
+            <a:avLst/>
+          </a:prstGeom>
+        </p:spPr>
+      </p:pic>
+      <p:sp>
+        <p:nvSpPr>
+          <p:cNvPr id="7" name="cover-title">
+            <a:extLst xmlns:a="http://schemas.openxmlformats.org/drawingml/2006/main">
+              <a:ext uri="{FF2B5EF4-FFF2-40B4-BE49-F238E27FC236}">
+                <a16:creationId xmlns:a16="http://schemas.microsoft.com/office/drawing/2014/main" id="{76FC812E-E405-4FF9-8554-E0A722706610}"/>
               </a:ext>
             </a:extLst>
           </p:cNvPr>
@@ -6035,10 +6204,10 @@
       </p:sp>
       <p:sp>
         <p:nvSpPr>
-          <p:cNvPr id="6" name="cover-subtitle">
-            <a:extLst xmlns:a="http://schemas.openxmlformats.org/drawingml/2006/main">
-              <a:ext uri="{FF2B5EF4-FFF2-40B4-BE49-F238E27FC236}">
-                <a16:creationId xmlns:a16="http://schemas.microsoft.com/office/drawing/2014/main" id="{682AD644-F92F-471B-A71D-158B8FF7FB11}"/>
+          <p:cNvPr id="8" name="cover-subtitle">
+            <a:extLst xmlns:a="http://schemas.openxmlformats.org/drawingml/2006/main">
+              <a:ext uri="{FF2B5EF4-FFF2-40B4-BE49-F238E27FC236}">
+                <a16:creationId xmlns:a16="http://schemas.microsoft.com/office/drawing/2014/main" id="{BA31650F-8CC9-4594-BAD2-EC4B6A203CCD}"/>
               </a:ext>
             </a:extLst>
           </p:cNvPr>
@@ -6086,10 +6255,10 @@
       </p:sp>
       <p:sp>
         <p:nvSpPr>
-          <p:cNvPr id="7" name="cover-accent">
-            <a:extLst xmlns:a="http://schemas.openxmlformats.org/drawingml/2006/main">
-              <a:ext uri="{FF2B5EF4-FFF2-40B4-BE49-F238E27FC236}">
-                <a16:creationId xmlns:a16="http://schemas.microsoft.com/office/drawing/2014/main" id="{E808C68C-927A-4E31-92EA-060AB3B7CD60}"/>
+          <p:cNvPr id="9" name="cover-accent">
+            <a:extLst xmlns:a="http://schemas.openxmlformats.org/drawingml/2006/main">
+              <a:ext uri="{FF2B5EF4-FFF2-40B4-BE49-F238E27FC236}">
+                <a16:creationId xmlns:a16="http://schemas.microsoft.com/office/drawing/2014/main" id="{36A708BA-ACC8-43BF-A00D-0D907488297F}"/>
               </a:ext>
             </a:extLst>
           </p:cNvPr>
@@ -6117,10 +6286,10 @@
       </p:sp>
       <p:sp>
         <p:nvSpPr>
-          <p:cNvPr id="8" name="cover-meta">
-            <a:extLst xmlns:a="http://schemas.openxmlformats.org/drawingml/2006/main">
-              <a:ext uri="{FF2B5EF4-FFF2-40B4-BE49-F238E27FC236}">
-                <a16:creationId xmlns:a16="http://schemas.microsoft.com/office/drawing/2014/main" id="{6DD5FEB8-3D6B-4E01-A5BF-EC8B9F90D86D}"/>
+          <p:cNvPr id="10" name="cover-meta">
+            <a:extLst xmlns:a="http://schemas.openxmlformats.org/drawingml/2006/main">
+              <a:ext uri="{FF2B5EF4-FFF2-40B4-BE49-F238E27FC236}">
+                <a16:creationId xmlns:a16="http://schemas.microsoft.com/office/drawing/2014/main" id="{E74BA74A-F1A5-4688-9720-BCAF1FF0B17A}"/>
               </a:ext>
             </a:extLst>
           </p:cNvPr>
@@ -6173,7 +6342,7 @@
     </p:spTree>
     <p:extLst>
       <p:ext uri="{BB962C8B-B14F-4D97-AF65-F5344CB8AC3E}">
-        <p14:creationId xmlns:p14="http://schemas.microsoft.com/office/powerpoint/2010/main" val="59376208"/>
+        <p14:creationId xmlns:p14="http://schemas.microsoft.com/office/powerpoint/2010/main" val="1831097134"/>
       </p:ext>
     </p:extLst>
   </p:cSld>
@@ -6209,10 +6378,10 @@
       </p:grpSpPr>
       <p:sp>
         <p:nvSpPr>
-          <p:cNvPr id="13" name="slide-title">
-            <a:extLst xmlns:a="http://schemas.openxmlformats.org/drawingml/2006/main">
-              <a:ext uri="{FF2B5EF4-FFF2-40B4-BE49-F238E27FC236}">
-                <a16:creationId xmlns:a16="http://schemas.microsoft.com/office/drawing/2014/main" id="{4F41C7E6-88D0-4FD1-8BC6-52A57F75130E}"/>
+          <p:cNvPr id="15" name="slide-title">
+            <a:extLst xmlns:a="http://schemas.openxmlformats.org/drawingml/2006/main">
+              <a:ext uri="{FF2B5EF4-FFF2-40B4-BE49-F238E27FC236}">
+                <a16:creationId xmlns:a16="http://schemas.microsoft.com/office/drawing/2014/main" id="{D45A5B1C-64B5-4843-B99D-ECEBECC072EA}"/>
               </a:ext>
             </a:extLst>
           </p:cNvPr>
@@ -6263,7 +6432,7 @@
           <p:cNvPr id="2" name="flow-1">
             <a:extLst xmlns:a="http://schemas.openxmlformats.org/drawingml/2006/main">
               <a:ext uri="{FF2B5EF4-FFF2-40B4-BE49-F238E27FC236}">
-                <a16:creationId xmlns:a16="http://schemas.microsoft.com/office/drawing/2014/main" id="{35A95312-8E85-4E8A-BB02-E690870AC3CD}"/>
+                <a16:creationId xmlns:a16="http://schemas.microsoft.com/office/drawing/2014/main" id="{4FD779E5-B977-48D3-9FC0-B548D488CCC0}"/>
               </a:ext>
             </a:extLst>
           </p:cNvPr>
@@ -6320,7 +6489,7 @@
           <p:cNvPr id="3" name="flow-2">
             <a:extLst xmlns:a="http://schemas.openxmlformats.org/drawingml/2006/main">
               <a:ext uri="{FF2B5EF4-FFF2-40B4-BE49-F238E27FC236}">
-                <a16:creationId xmlns:a16="http://schemas.microsoft.com/office/drawing/2014/main" id="{69B44238-1DEC-4AA4-92F0-0B3E88C4E793}"/>
+                <a16:creationId xmlns:a16="http://schemas.microsoft.com/office/drawing/2014/main" id="{2A9FED91-DE3F-4352-9E1C-44232B22C54C}"/>
               </a:ext>
             </a:extLst>
           </p:cNvPr>
@@ -6377,7 +6546,7 @@
           <p:cNvPr id="4" name="flow-3">
             <a:extLst xmlns:a="http://schemas.openxmlformats.org/drawingml/2006/main">
               <a:ext uri="{FF2B5EF4-FFF2-40B4-BE49-F238E27FC236}">
-                <a16:creationId xmlns:a16="http://schemas.microsoft.com/office/drawing/2014/main" id="{C6D76D01-FCA2-4164-843B-5611483F614E}"/>
+                <a16:creationId xmlns:a16="http://schemas.microsoft.com/office/drawing/2014/main" id="{DA4A1248-E81F-4D7F-9143-099A9D781C62}"/>
               </a:ext>
             </a:extLst>
           </p:cNvPr>
@@ -6434,7 +6603,7 @@
           <p:cNvPr id="5" name="flow-4">
             <a:extLst xmlns:a="http://schemas.openxmlformats.org/drawingml/2006/main">
               <a:ext uri="{FF2B5EF4-FFF2-40B4-BE49-F238E27FC236}">
-                <a16:creationId xmlns:a16="http://schemas.microsoft.com/office/drawing/2014/main" id="{32F85C49-A50A-4966-997A-3308BE267B12}"/>
+                <a16:creationId xmlns:a16="http://schemas.microsoft.com/office/drawing/2014/main" id="{BB7DB6F5-47EE-4D5C-944F-2A26588F9236}"/>
               </a:ext>
             </a:extLst>
           </p:cNvPr>
@@ -6488,7 +6657,7 @@
       </p:sp>
       <p:cxnSp>
         <p:nvCxnSpPr>
-          <p:cNvPr id="26" name=""/>
+          <p:cNvPr id="29" name=""/>
           <p:cNvCxnSpPr>
             <a:stCxn xmlns:a="http://schemas.openxmlformats.org/drawingml/2006/main" id="2" idx="3"/>
             <a:endCxn xmlns:a="http://schemas.openxmlformats.org/drawingml/2006/main" id="3" idx="1"/>
@@ -6514,7 +6683,7 @@
       </p:cxnSp>
       <p:cxnSp>
         <p:nvCxnSpPr>
-          <p:cNvPr id="27" name=""/>
+          <p:cNvPr id="30" name=""/>
           <p:cNvCxnSpPr>
             <a:stCxn xmlns:a="http://schemas.openxmlformats.org/drawingml/2006/main" id="3" idx="3"/>
             <a:endCxn xmlns:a="http://schemas.openxmlformats.org/drawingml/2006/main" id="4" idx="1"/>
@@ -6540,7 +6709,7 @@
       </p:cxnSp>
       <p:cxnSp>
         <p:nvCxnSpPr>
-          <p:cNvPr id="28" name=""/>
+          <p:cNvPr id="31" name=""/>
           <p:cNvCxnSpPr>
             <a:stCxn xmlns:a="http://schemas.openxmlformats.org/drawingml/2006/main" id="4" idx="3"/>
             <a:endCxn xmlns:a="http://schemas.openxmlformats.org/drawingml/2006/main" id="5" idx="1"/>
@@ -6569,7 +6738,7 @@
           <p:cNvPr id="9" name="eyebrow">
             <a:extLst xmlns:a="http://schemas.openxmlformats.org/drawingml/2006/main">
               <a:ext uri="{FF2B5EF4-FFF2-40B4-BE49-F238E27FC236}">
-                <a16:creationId xmlns:a16="http://schemas.microsoft.com/office/drawing/2014/main" id="{E25625CA-44A6-4647-8B1D-BAD6AF97D852}"/>
+                <a16:creationId xmlns:a16="http://schemas.microsoft.com/office/drawing/2014/main" id="{DFB65A9E-27D7-47C9-AD71-900B28EAB4C8}"/>
               </a:ext>
             </a:extLst>
           </p:cNvPr>
@@ -6617,10 +6786,69 @@
       </p:sp>
       <p:sp>
         <p:nvSpPr>
-          <p:cNvPr id="10" name="footer-rule">
-            <a:extLst xmlns:a="http://schemas.openxmlformats.org/drawingml/2006/main">
-              <a:ext uri="{FF2B5EF4-FFF2-40B4-BE49-F238E27FC236}">
-                <a16:creationId xmlns:a16="http://schemas.microsoft.com/office/drawing/2014/main" id="{3BCBAB5F-B376-4859-A841-BD044E729DC1}"/>
+          <p:cNvPr id="10" name="rescue-point-logo-background">
+            <a:extLst xmlns:a="http://schemas.openxmlformats.org/drawingml/2006/main">
+              <a:ext uri="{FF2B5EF4-FFF2-40B4-BE49-F238E27FC236}">
+                <a16:creationId xmlns:a16="http://schemas.microsoft.com/office/drawing/2014/main" id="{E497F652-E3C8-4107-8DCF-C73F92F71F62}"/>
+              </a:ext>
+            </a:extLst>
+          </p:cNvPr>
+          <p:cNvSpPr>
+            <a:spLocks xmlns:a="http://schemas.openxmlformats.org/drawingml/2006/main" noGrp="1"/>
+          </p:cNvSpPr>
+          <p:nvPr/>
+        </p:nvSpPr>
+        <p:spPr>
+          <a:xfrm xmlns:a="http://schemas.openxmlformats.org/drawingml/2006/main">
+            <a:off x="9772650" y="133350"/>
+            <a:ext cx="1733550" cy="457200"/>
+          </a:xfrm>
+          <a:prstGeom xmlns:a="http://schemas.openxmlformats.org/drawingml/2006/main" prst="roundRect">
+            <a:avLst>
+              <a:gd name="adj" fmla="val 16667"/>
+            </a:avLst>
+          </a:prstGeom>
+          <a:solidFill xmlns:a="http://schemas.openxmlformats.org/drawingml/2006/main">
+            <a:srgbClr val="06142E"/>
+          </a:solidFill>
+          <a:ln xmlns:a="http://schemas.openxmlformats.org/drawingml/2006/main" w="9525">
+            <a:solidFill>
+              <a:srgbClr val="1EC5FF">
+                <a:alpha val="33333"/>
+              </a:srgbClr>
+            </a:solidFill>
+            <a:prstDash val="solid"/>
+          </a:ln>
+        </p:spPr>
+      </p:sp>
+      <p:pic>
+        <p:nvPicPr>
+          <p:cNvPr id="34" name="" descr="Figura oficial da documentação dbt usada para explicar: O repositório restaura o ambiente — Create."/>
+          <p:cNvPicPr>
+            <a:picLocks xmlns:a="http://schemas.openxmlformats.org/drawingml/2006/main" noChangeAspect="1"/>
+          </p:cNvPicPr>
+          <p:nvPr/>
+        </p:nvPicPr>
+        <p:blipFill>
+          <a:blip xmlns:r="http://schemas.openxmlformats.org/officeDocument/2006/relationships" xmlns:a="http://schemas.openxmlformats.org/drawingml/2006/main" r:embed="R286c24446fd34de7"/>
+          <a:stretch xmlns:a="http://schemas.openxmlformats.org/drawingml/2006/main"/>
+        </p:blipFill>
+        <p:spPr>
+          <a:xfrm xmlns:a="http://schemas.openxmlformats.org/drawingml/2006/main">
+            <a:off x="9893718" y="209550"/>
+            <a:ext cx="1491414" cy="323850"/>
+          </a:xfrm>
+          <a:prstGeom xmlns:a="http://schemas.openxmlformats.org/drawingml/2006/main" prst="rect">
+            <a:avLst/>
+          </a:prstGeom>
+        </p:spPr>
+      </p:pic>
+      <p:sp>
+        <p:nvSpPr>
+          <p:cNvPr id="12" name="footer-rule">
+            <a:extLst xmlns:a="http://schemas.openxmlformats.org/drawingml/2006/main">
+              <a:ext uri="{FF2B5EF4-FFF2-40B4-BE49-F238E27FC236}">
+                <a16:creationId xmlns:a16="http://schemas.microsoft.com/office/drawing/2014/main" id="{648D802D-146F-4710-A14E-41EEBA73BC8F}"/>
               </a:ext>
             </a:extLst>
           </p:cNvPr>
@@ -6650,10 +6878,10 @@
       </p:sp>
       <p:sp>
         <p:nvSpPr>
-          <p:cNvPr id="11" name="footer">
-            <a:extLst xmlns:a="http://schemas.openxmlformats.org/drawingml/2006/main">
-              <a:ext uri="{FF2B5EF4-FFF2-40B4-BE49-F238E27FC236}">
-                <a16:creationId xmlns:a16="http://schemas.microsoft.com/office/drawing/2014/main" id="{C3438BB7-E096-4149-81A1-4C07E106EAA6}"/>
+          <p:cNvPr id="13" name="footer">
+            <a:extLst xmlns:a="http://schemas.openxmlformats.org/drawingml/2006/main">
+              <a:ext uri="{FF2B5EF4-FFF2-40B4-BE49-F238E27FC236}">
+                <a16:creationId xmlns:a16="http://schemas.microsoft.com/office/drawing/2014/main" id="{E9988866-C56C-4580-A359-928AF7AE7715}"/>
               </a:ext>
             </a:extLst>
           </p:cNvPr>
@@ -6705,10 +6933,10 @@
       </p:sp>
       <p:sp>
         <p:nvSpPr>
-          <p:cNvPr id="12" name="page-number">
-            <a:extLst xmlns:a="http://schemas.openxmlformats.org/drawingml/2006/main">
-              <a:ext uri="{FF2B5EF4-FFF2-40B4-BE49-F238E27FC236}">
-                <a16:creationId xmlns:a16="http://schemas.microsoft.com/office/drawing/2014/main" id="{CCC08BBB-0228-4D8C-9D0B-79EBEC64BC65}"/>
+          <p:cNvPr id="14" name="page-number">
+            <a:extLst xmlns:a="http://schemas.openxmlformats.org/drawingml/2006/main">
+              <a:ext uri="{FF2B5EF4-FFF2-40B4-BE49-F238E27FC236}">
+                <a16:creationId xmlns:a16="http://schemas.microsoft.com/office/drawing/2014/main" id="{20601BEC-6D0A-4AD2-88D3-D2B4039A6C6F}"/>
               </a:ext>
             </a:extLst>
           </p:cNvPr>
@@ -6761,7 +6989,7 @@
     </p:spTree>
     <p:extLst>
       <p:ext uri="{BB962C8B-B14F-4D97-AF65-F5344CB8AC3E}">
-        <p14:creationId xmlns:p14="http://schemas.microsoft.com/office/powerpoint/2010/main" val="1163550133"/>
+        <p14:creationId xmlns:p14="http://schemas.microsoft.com/office/powerpoint/2010/main" val="1401876952"/>
       </p:ext>
     </p:extLst>
   </p:cSld>
@@ -6797,10 +7025,10 @@
       </p:grpSpPr>
       <p:sp>
         <p:nvSpPr>
-          <p:cNvPr id="11" name="slide-title">
-            <a:extLst xmlns:a="http://schemas.openxmlformats.org/drawingml/2006/main">
-              <a:ext uri="{FF2B5EF4-FFF2-40B4-BE49-F238E27FC236}">
-                <a16:creationId xmlns:a16="http://schemas.microsoft.com/office/drawing/2014/main" id="{F2557948-B184-4126-8328-045FAFD1110F}"/>
+          <p:cNvPr id="13" name="slide-title">
+            <a:extLst xmlns:a="http://schemas.openxmlformats.org/drawingml/2006/main">
+              <a:ext uri="{FF2B5EF4-FFF2-40B4-BE49-F238E27FC236}">
+                <a16:creationId xmlns:a16="http://schemas.microsoft.com/office/drawing/2014/main" id="{E3B2916A-7590-423F-93B5-951C9B9D6499}"/>
               </a:ext>
             </a:extLst>
           </p:cNvPr>
@@ -6851,7 +7079,7 @@
           <p:cNvPr id="2" name="slide-subtitle">
             <a:extLst xmlns:a="http://schemas.openxmlformats.org/drawingml/2006/main">
               <a:ext uri="{FF2B5EF4-FFF2-40B4-BE49-F238E27FC236}">
-                <a16:creationId xmlns:a16="http://schemas.microsoft.com/office/drawing/2014/main" id="{F1A18877-3E51-4C0C-B2B5-349822438C31}"/>
+                <a16:creationId xmlns:a16="http://schemas.microsoft.com/office/drawing/2014/main" id="{52242C04-DFB8-4B8D-936C-7A4875B9DE03}"/>
               </a:ext>
             </a:extLst>
           </p:cNvPr>
@@ -6902,7 +7130,7 @@
           <p:cNvPr id="3" name="bullets">
             <a:extLst xmlns:a="http://schemas.openxmlformats.org/drawingml/2006/main">
               <a:ext uri="{FF2B5EF4-FFF2-40B4-BE49-F238E27FC236}">
-                <a16:creationId xmlns:a16="http://schemas.microsoft.com/office/drawing/2014/main" id="{6C780FB6-3278-4DD9-80D8-2D5F4EF341AA}"/>
+                <a16:creationId xmlns:a16="http://schemas.microsoft.com/office/drawing/2014/main" id="{BD081820-C1CB-4A49-AA26-9F407252A26D}"/>
               </a:ext>
             </a:extLst>
           </p:cNvPr>
@@ -6989,7 +7217,7 @@
           <p:cNvPr id="4" name="ambient-glow">
             <a:extLst xmlns:a="http://schemas.openxmlformats.org/drawingml/2006/main">
               <a:ext uri="{FF2B5EF4-FFF2-40B4-BE49-F238E27FC236}">
-                <a16:creationId xmlns:a16="http://schemas.microsoft.com/office/drawing/2014/main" id="{9F7A8F7D-EEE1-412C-AF9A-720E886FAC69}"/>
+                <a16:creationId xmlns:a16="http://schemas.microsoft.com/office/drawing/2014/main" id="{A3EDE469-3449-4E9B-9585-21C8227C27DE}"/>
               </a:ext>
             </a:extLst>
           </p:cNvPr>
@@ -7026,7 +7254,7 @@
           <p:cNvPr id="5" name="ambient-core">
             <a:extLst xmlns:a="http://schemas.openxmlformats.org/drawingml/2006/main">
               <a:ext uri="{FF2B5EF4-FFF2-40B4-BE49-F238E27FC236}">
-                <a16:creationId xmlns:a16="http://schemas.microsoft.com/office/drawing/2014/main" id="{1DFB3262-A5EB-4693-BEF0-74D6B7328039}"/>
+                <a16:creationId xmlns:a16="http://schemas.microsoft.com/office/drawing/2014/main" id="{8DB21DC8-FC8D-44DB-82DA-4EAC01A7EC64}"/>
               </a:ext>
             </a:extLst>
           </p:cNvPr>
@@ -7063,7 +7291,7 @@
           <p:cNvPr id="6" name="section-number">
             <a:extLst xmlns:a="http://schemas.openxmlformats.org/drawingml/2006/main">
               <a:ext uri="{FF2B5EF4-FFF2-40B4-BE49-F238E27FC236}">
-                <a16:creationId xmlns:a16="http://schemas.microsoft.com/office/drawing/2014/main" id="{4BF063A6-A050-4C14-93A9-DD91D450C934}"/>
+                <a16:creationId xmlns:a16="http://schemas.microsoft.com/office/drawing/2014/main" id="{FC62584E-1226-45C3-AAD5-EABB785C5384}"/>
               </a:ext>
             </a:extLst>
           </p:cNvPr>
@@ -7114,7 +7342,7 @@
           <p:cNvPr id="7" name="eyebrow">
             <a:extLst xmlns:a="http://schemas.openxmlformats.org/drawingml/2006/main">
               <a:ext uri="{FF2B5EF4-FFF2-40B4-BE49-F238E27FC236}">
-                <a16:creationId xmlns:a16="http://schemas.microsoft.com/office/drawing/2014/main" id="{8E74EDD5-72E8-4358-8342-34B178151E8E}"/>
+                <a16:creationId xmlns:a16="http://schemas.microsoft.com/office/drawing/2014/main" id="{2136670A-4F1A-40A7-9368-16A7E9412F4A}"/>
               </a:ext>
             </a:extLst>
           </p:cNvPr>
@@ -7162,10 +7390,69 @@
       </p:sp>
       <p:sp>
         <p:nvSpPr>
-          <p:cNvPr id="8" name="footer-rule">
-            <a:extLst xmlns:a="http://schemas.openxmlformats.org/drawingml/2006/main">
-              <a:ext uri="{FF2B5EF4-FFF2-40B4-BE49-F238E27FC236}">
-                <a16:creationId xmlns:a16="http://schemas.microsoft.com/office/drawing/2014/main" id="{0B3B0886-F433-437F-AA2B-AC0CAFA91541}"/>
+          <p:cNvPr id="8" name="rescue-point-logo-background">
+            <a:extLst xmlns:a="http://schemas.openxmlformats.org/drawingml/2006/main">
+              <a:ext uri="{FF2B5EF4-FFF2-40B4-BE49-F238E27FC236}">
+                <a16:creationId xmlns:a16="http://schemas.microsoft.com/office/drawing/2014/main" id="{640714CB-609D-4D31-AAFE-23F1F3D83981}"/>
+              </a:ext>
+            </a:extLst>
+          </p:cNvPr>
+          <p:cNvSpPr>
+            <a:spLocks xmlns:a="http://schemas.openxmlformats.org/drawingml/2006/main" noGrp="1"/>
+          </p:cNvSpPr>
+          <p:nvPr/>
+        </p:nvSpPr>
+        <p:spPr>
+          <a:xfrm xmlns:a="http://schemas.openxmlformats.org/drawingml/2006/main">
+            <a:off x="9772650" y="133350"/>
+            <a:ext cx="1733550" cy="457200"/>
+          </a:xfrm>
+          <a:prstGeom xmlns:a="http://schemas.openxmlformats.org/drawingml/2006/main" prst="roundRect">
+            <a:avLst>
+              <a:gd name="adj" fmla="val 16667"/>
+            </a:avLst>
+          </a:prstGeom>
+          <a:solidFill xmlns:a="http://schemas.openxmlformats.org/drawingml/2006/main">
+            <a:srgbClr val="06142E"/>
+          </a:solidFill>
+          <a:ln xmlns:a="http://schemas.openxmlformats.org/drawingml/2006/main" w="9525">
+            <a:solidFill>
+              <a:srgbClr val="1EC5FF">
+                <a:alpha val="33333"/>
+              </a:srgbClr>
+            </a:solidFill>
+            <a:prstDash val="solid"/>
+          </a:ln>
+        </p:spPr>
+      </p:sp>
+      <p:pic>
+        <p:nvPicPr>
+          <p:cNvPr id="23" name="" descr="Figura oficial da documentação dbt usada para explicar: Parar evita consumo de processamento — Stop codespace interrompe core-hours; armazenamento continua até excluir o ambiente.."/>
+          <p:cNvPicPr>
+            <a:picLocks xmlns:a="http://schemas.openxmlformats.org/drawingml/2006/main" noChangeAspect="1"/>
+          </p:cNvPicPr>
+          <p:nvPr/>
+        </p:nvPicPr>
+        <p:blipFill>
+          <a:blip xmlns:r="http://schemas.openxmlformats.org/officeDocument/2006/relationships" xmlns:a="http://schemas.openxmlformats.org/drawingml/2006/main" r:embed="R6fc22ae521fe4ffb"/>
+          <a:stretch xmlns:a="http://schemas.openxmlformats.org/drawingml/2006/main"/>
+        </p:blipFill>
+        <p:spPr>
+          <a:xfrm xmlns:a="http://schemas.openxmlformats.org/drawingml/2006/main">
+            <a:off x="9893718" y="209550"/>
+            <a:ext cx="1491414" cy="323850"/>
+          </a:xfrm>
+          <a:prstGeom xmlns:a="http://schemas.openxmlformats.org/drawingml/2006/main" prst="rect">
+            <a:avLst/>
+          </a:prstGeom>
+        </p:spPr>
+      </p:pic>
+      <p:sp>
+        <p:nvSpPr>
+          <p:cNvPr id="10" name="footer-rule">
+            <a:extLst xmlns:a="http://schemas.openxmlformats.org/drawingml/2006/main">
+              <a:ext uri="{FF2B5EF4-FFF2-40B4-BE49-F238E27FC236}">
+                <a16:creationId xmlns:a16="http://schemas.microsoft.com/office/drawing/2014/main" id="{036FEFFA-3CB3-41FC-ADF0-A4C53D1C1341}"/>
               </a:ext>
             </a:extLst>
           </p:cNvPr>
@@ -7195,10 +7482,10 @@
       </p:sp>
       <p:sp>
         <p:nvSpPr>
-          <p:cNvPr id="9" name="footer">
-            <a:extLst xmlns:a="http://schemas.openxmlformats.org/drawingml/2006/main">
-              <a:ext uri="{FF2B5EF4-FFF2-40B4-BE49-F238E27FC236}">
-                <a16:creationId xmlns:a16="http://schemas.microsoft.com/office/drawing/2014/main" id="{0838FDD8-C991-497C-8A75-25855FCBAA7C}"/>
+          <p:cNvPr id="11" name="footer">
+            <a:extLst xmlns:a="http://schemas.openxmlformats.org/drawingml/2006/main">
+              <a:ext uri="{FF2B5EF4-FFF2-40B4-BE49-F238E27FC236}">
+                <a16:creationId xmlns:a16="http://schemas.microsoft.com/office/drawing/2014/main" id="{22BDE695-4134-4851-A9F1-ADEB239885BF}"/>
               </a:ext>
             </a:extLst>
           </p:cNvPr>
@@ -7250,10 +7537,10 @@
       </p:sp>
       <p:sp>
         <p:nvSpPr>
-          <p:cNvPr id="10" name="page-number">
-            <a:extLst xmlns:a="http://schemas.openxmlformats.org/drawingml/2006/main">
-              <a:ext uri="{FF2B5EF4-FFF2-40B4-BE49-F238E27FC236}">
-                <a16:creationId xmlns:a16="http://schemas.microsoft.com/office/drawing/2014/main" id="{D4AFEAF0-F163-4E80-96C5-D44121B986DA}"/>
+          <p:cNvPr id="12" name="page-number">
+            <a:extLst xmlns:a="http://schemas.openxmlformats.org/drawingml/2006/main">
+              <a:ext uri="{FF2B5EF4-FFF2-40B4-BE49-F238E27FC236}">
+                <a16:creationId xmlns:a16="http://schemas.microsoft.com/office/drawing/2014/main" id="{557DFE69-8B07-46C6-A2A7-7918029639C3}"/>
               </a:ext>
             </a:extLst>
           </p:cNvPr>
@@ -7306,7 +7593,7 @@
     </p:spTree>
     <p:extLst>
       <p:ext uri="{BB962C8B-B14F-4D97-AF65-F5344CB8AC3E}">
-        <p14:creationId xmlns:p14="http://schemas.microsoft.com/office/powerpoint/2010/main" val="1727346344"/>
+        <p14:creationId xmlns:p14="http://schemas.microsoft.com/office/powerpoint/2010/main" val="1219414454"/>
       </p:ext>
     </p:extLst>
   </p:cSld>
@@ -7334,10 +7621,10 @@
       </p:grpSpPr>
       <p:sp>
         <p:nvSpPr>
-          <p:cNvPr id="10" name="slide-title">
-            <a:extLst xmlns:a="http://schemas.openxmlformats.org/drawingml/2006/main">
-              <a:ext uri="{FF2B5EF4-FFF2-40B4-BE49-F238E27FC236}">
-                <a16:creationId xmlns:a16="http://schemas.microsoft.com/office/drawing/2014/main" id="{5DBF96AD-2A7E-47E6-8FBC-4D40AF04147C}"/>
+          <p:cNvPr id="12" name="slide-title">
+            <a:extLst xmlns:a="http://schemas.openxmlformats.org/drawingml/2006/main">
+              <a:ext uri="{FF2B5EF4-FFF2-40B4-BE49-F238E27FC236}">
+                <a16:creationId xmlns:a16="http://schemas.microsoft.com/office/drawing/2014/main" id="{0ACF6CE8-4EC4-47E4-A87E-07384BC679FA}"/>
               </a:ext>
             </a:extLst>
           </p:cNvPr>
@@ -7388,7 +7675,7 @@
           <p:cNvPr id="2" name="visual-claim">
             <a:extLst xmlns:a="http://schemas.openxmlformats.org/drawingml/2006/main">
               <a:ext uri="{FF2B5EF4-FFF2-40B4-BE49-F238E27FC236}">
-                <a16:creationId xmlns:a16="http://schemas.microsoft.com/office/drawing/2014/main" id="{157DCA50-A058-42BD-AA6B-02A03CD30CAE}"/>
+                <a16:creationId xmlns:a16="http://schemas.microsoft.com/office/drawing/2014/main" id="{E26B7A36-9ECB-432A-AD64-B65732A34E4C}"/>
               </a:ext>
             </a:extLst>
           </p:cNvPr>
@@ -7439,7 +7726,7 @@
           <p:cNvPr id="3" name="image-surface">
             <a:extLst xmlns:a="http://schemas.openxmlformats.org/drawingml/2006/main">
               <a:ext uri="{FF2B5EF4-FFF2-40B4-BE49-F238E27FC236}">
-                <a16:creationId xmlns:a16="http://schemas.microsoft.com/office/drawing/2014/main" id="{88585342-3893-4687-99C5-F1EE328340F1}"/>
+                <a16:creationId xmlns:a16="http://schemas.microsoft.com/office/drawing/2014/main" id="{4D0E001C-6166-4A7F-8A85-E954150B49E6}"/>
               </a:ext>
             </a:extLst>
           </p:cNvPr>
@@ -7471,14 +7758,14 @@
       </p:sp>
       <p:pic>
         <p:nvPicPr>
-          <p:cNvPr id="15" name="" descr="Figura oficial da documentação dbt usada para explicar: Parar evita consumo de processamento — Stop codespace interrompe core-hours; armazenamento continua até excluir o ambiente.."/>
+          <p:cNvPr id="18" name="" descr="Figura oficial da documentação dbt usada para explicar: Parar evita consumo de processamento — Stop codespace interrompe core-hours; armazenamento continua até excluir o ambiente.."/>
           <p:cNvPicPr>
             <a:picLocks xmlns:a="http://schemas.openxmlformats.org/drawingml/2006/main" noChangeAspect="1"/>
           </p:cNvPicPr>
           <p:nvPr/>
         </p:nvPicPr>
         <p:blipFill>
-          <a:blip xmlns:r="http://schemas.openxmlformats.org/officeDocument/2006/relationships" xmlns:a="http://schemas.openxmlformats.org/drawingml/2006/main" r:embed="R0b833951581d44bb"/>
+          <a:blip xmlns:r="http://schemas.openxmlformats.org/officeDocument/2006/relationships" xmlns:a="http://schemas.openxmlformats.org/drawingml/2006/main" r:embed="Rc20f173c677146a1"/>
           <a:stretch xmlns:a="http://schemas.openxmlformats.org/drawingml/2006/main"/>
         </p:blipFill>
         <p:spPr>
@@ -7496,7 +7783,7 @@
           <p:cNvPr id="5" name="image-caption">
             <a:extLst xmlns:a="http://schemas.openxmlformats.org/drawingml/2006/main">
               <a:ext uri="{FF2B5EF4-FFF2-40B4-BE49-F238E27FC236}">
-                <a16:creationId xmlns:a16="http://schemas.microsoft.com/office/drawing/2014/main" id="{6B3FA25E-B0AB-46C1-9BCD-B5AEDB8D7E31}"/>
+                <a16:creationId xmlns:a16="http://schemas.microsoft.com/office/drawing/2014/main" id="{697CDB68-96DF-4FF3-921E-05E49B30B054}"/>
               </a:ext>
             </a:extLst>
           </p:cNvPr>
@@ -7547,7 +7834,7 @@
           <p:cNvPr id="6" name="eyebrow">
             <a:extLst xmlns:a="http://schemas.openxmlformats.org/drawingml/2006/main">
               <a:ext uri="{FF2B5EF4-FFF2-40B4-BE49-F238E27FC236}">
-                <a16:creationId xmlns:a16="http://schemas.microsoft.com/office/drawing/2014/main" id="{A6CB3BE4-9A44-4F11-95EA-DD85EA5692BF}"/>
+                <a16:creationId xmlns:a16="http://schemas.microsoft.com/office/drawing/2014/main" id="{3898EB09-EBF8-4A2C-A0EF-2691FB673933}"/>
               </a:ext>
             </a:extLst>
           </p:cNvPr>
@@ -7595,10 +7882,69 @@
       </p:sp>
       <p:sp>
         <p:nvSpPr>
-          <p:cNvPr id="7" name="footer-rule">
-            <a:extLst xmlns:a="http://schemas.openxmlformats.org/drawingml/2006/main">
-              <a:ext uri="{FF2B5EF4-FFF2-40B4-BE49-F238E27FC236}">
-                <a16:creationId xmlns:a16="http://schemas.microsoft.com/office/drawing/2014/main" id="{86BE7C73-74EC-4494-ADA4-D1F6CB9660BB}"/>
+          <p:cNvPr id="7" name="rescue-point-logo-background">
+            <a:extLst xmlns:a="http://schemas.openxmlformats.org/drawingml/2006/main">
+              <a:ext uri="{FF2B5EF4-FFF2-40B4-BE49-F238E27FC236}">
+                <a16:creationId xmlns:a16="http://schemas.microsoft.com/office/drawing/2014/main" id="{4EE9AB9D-21D1-4BE3-A5D0-4F0E4E2B1AE6}"/>
+              </a:ext>
+            </a:extLst>
+          </p:cNvPr>
+          <p:cNvSpPr>
+            <a:spLocks xmlns:a="http://schemas.openxmlformats.org/drawingml/2006/main" noGrp="1"/>
+          </p:cNvSpPr>
+          <p:nvPr/>
+        </p:nvSpPr>
+        <p:spPr>
+          <a:xfrm xmlns:a="http://schemas.openxmlformats.org/drawingml/2006/main">
+            <a:off x="9772650" y="133350"/>
+            <a:ext cx="1733550" cy="457200"/>
+          </a:xfrm>
+          <a:prstGeom xmlns:a="http://schemas.openxmlformats.org/drawingml/2006/main" prst="roundRect">
+            <a:avLst>
+              <a:gd name="adj" fmla="val 16667"/>
+            </a:avLst>
+          </a:prstGeom>
+          <a:solidFill xmlns:a="http://schemas.openxmlformats.org/drawingml/2006/main">
+            <a:srgbClr val="06142E"/>
+          </a:solidFill>
+          <a:ln xmlns:a="http://schemas.openxmlformats.org/drawingml/2006/main" w="9525">
+            <a:solidFill>
+              <a:srgbClr val="1EC5FF">
+                <a:alpha val="33333"/>
+              </a:srgbClr>
+            </a:solidFill>
+            <a:prstDash val="solid"/>
+          </a:ln>
+        </p:spPr>
+      </p:sp>
+      <p:pic>
+        <p:nvPicPr>
+          <p:cNvPr id="22" name="" descr="Figura oficial da documentação dbt usada para explicar: Parar evita consumo de processamento — Stop codespace interrompe core-hours; armazenamento continua até excluir o ambiente.."/>
+          <p:cNvPicPr>
+            <a:picLocks xmlns:a="http://schemas.openxmlformats.org/drawingml/2006/main" noChangeAspect="1"/>
+          </p:cNvPicPr>
+          <p:nvPr/>
+        </p:nvPicPr>
+        <p:blipFill>
+          <a:blip xmlns:r="http://schemas.openxmlformats.org/officeDocument/2006/relationships" xmlns:a="http://schemas.openxmlformats.org/drawingml/2006/main" r:embed="R46e8dd1ec5324c3c"/>
+          <a:stretch xmlns:a="http://schemas.openxmlformats.org/drawingml/2006/main"/>
+        </p:blipFill>
+        <p:spPr>
+          <a:xfrm xmlns:a="http://schemas.openxmlformats.org/drawingml/2006/main">
+            <a:off x="9893718" y="209550"/>
+            <a:ext cx="1491414" cy="323850"/>
+          </a:xfrm>
+          <a:prstGeom xmlns:a="http://schemas.openxmlformats.org/drawingml/2006/main" prst="rect">
+            <a:avLst/>
+          </a:prstGeom>
+        </p:spPr>
+      </p:pic>
+      <p:sp>
+        <p:nvSpPr>
+          <p:cNvPr id="9" name="footer-rule">
+            <a:extLst xmlns:a="http://schemas.openxmlformats.org/drawingml/2006/main">
+              <a:ext uri="{FF2B5EF4-FFF2-40B4-BE49-F238E27FC236}">
+                <a16:creationId xmlns:a16="http://schemas.microsoft.com/office/drawing/2014/main" id="{10A8A908-77DD-408E-9818-796AC3BCE966}"/>
               </a:ext>
             </a:extLst>
           </p:cNvPr>
@@ -7628,10 +7974,10 @@
       </p:sp>
       <p:sp>
         <p:nvSpPr>
-          <p:cNvPr id="8" name="footer">
-            <a:extLst xmlns:a="http://schemas.openxmlformats.org/drawingml/2006/main">
-              <a:ext uri="{FF2B5EF4-FFF2-40B4-BE49-F238E27FC236}">
-                <a16:creationId xmlns:a16="http://schemas.microsoft.com/office/drawing/2014/main" id="{E51FFC39-D749-4DA5-B310-5C2C9F833633}"/>
+          <p:cNvPr id="10" name="footer">
+            <a:extLst xmlns:a="http://schemas.openxmlformats.org/drawingml/2006/main">
+              <a:ext uri="{FF2B5EF4-FFF2-40B4-BE49-F238E27FC236}">
+                <a16:creationId xmlns:a16="http://schemas.microsoft.com/office/drawing/2014/main" id="{D0473C91-6574-4520-9C24-B0D48A75E989}"/>
               </a:ext>
             </a:extLst>
           </p:cNvPr>
@@ -7683,10 +8029,10 @@
       </p:sp>
       <p:sp>
         <p:nvSpPr>
-          <p:cNvPr id="9" name="page-number">
-            <a:extLst xmlns:a="http://schemas.openxmlformats.org/drawingml/2006/main">
-              <a:ext uri="{FF2B5EF4-FFF2-40B4-BE49-F238E27FC236}">
-                <a16:creationId xmlns:a16="http://schemas.microsoft.com/office/drawing/2014/main" id="{5EDDE50D-3E57-4E38-8E15-7BB3372D6F8D}"/>
+          <p:cNvPr id="11" name="page-number">
+            <a:extLst xmlns:a="http://schemas.openxmlformats.org/drawingml/2006/main">
+              <a:ext uri="{FF2B5EF4-FFF2-40B4-BE49-F238E27FC236}">
+                <a16:creationId xmlns:a16="http://schemas.microsoft.com/office/drawing/2014/main" id="{8C64242F-6DB4-4072-B221-003CB14D0211}"/>
               </a:ext>
             </a:extLst>
           </p:cNvPr>
@@ -7739,7 +8085,7 @@
     </p:spTree>
     <p:extLst>
       <p:ext uri="{BB962C8B-B14F-4D97-AF65-F5344CB8AC3E}">
-        <p14:creationId xmlns:p14="http://schemas.microsoft.com/office/powerpoint/2010/main" val="1569118459"/>
+        <p14:creationId xmlns:p14="http://schemas.microsoft.com/office/powerpoint/2010/main" val="352201759"/>
       </p:ext>
     </p:extLst>
   </p:cSld>
@@ -7767,10 +8113,10 @@
       </p:grpSpPr>
       <p:sp>
         <p:nvSpPr>
-          <p:cNvPr id="11" name="slide-title">
-            <a:extLst xmlns:a="http://schemas.openxmlformats.org/drawingml/2006/main">
-              <a:ext uri="{FF2B5EF4-FFF2-40B4-BE49-F238E27FC236}">
-                <a16:creationId xmlns:a16="http://schemas.microsoft.com/office/drawing/2014/main" id="{15EC33CF-773C-4403-97EC-7A1088BC2B8A}"/>
+          <p:cNvPr id="13" name="slide-title">
+            <a:extLst xmlns:a="http://schemas.openxmlformats.org/drawingml/2006/main">
+              <a:ext uri="{FF2B5EF4-FFF2-40B4-BE49-F238E27FC236}">
+                <a16:creationId xmlns:a16="http://schemas.microsoft.com/office/drawing/2014/main" id="{20CDF616-8EC8-432C-9974-55F5A970DFD0}"/>
               </a:ext>
             </a:extLst>
           </p:cNvPr>
@@ -7821,7 +8167,7 @@
           <p:cNvPr id="2" name="slide-subtitle">
             <a:extLst xmlns:a="http://schemas.openxmlformats.org/drawingml/2006/main">
               <a:ext uri="{FF2B5EF4-FFF2-40B4-BE49-F238E27FC236}">
-                <a16:creationId xmlns:a16="http://schemas.microsoft.com/office/drawing/2014/main" id="{2D1F61FE-99FA-467F-BADF-0387BD77059D}"/>
+                <a16:creationId xmlns:a16="http://schemas.microsoft.com/office/drawing/2014/main" id="{91801B50-12B5-4273-9086-9B45A64D21C3}"/>
               </a:ext>
             </a:extLst>
           </p:cNvPr>
@@ -7872,7 +8218,7 @@
           <p:cNvPr id="3" name="bullets">
             <a:extLst xmlns:a="http://schemas.openxmlformats.org/drawingml/2006/main">
               <a:ext uri="{FF2B5EF4-FFF2-40B4-BE49-F238E27FC236}">
-                <a16:creationId xmlns:a16="http://schemas.microsoft.com/office/drawing/2014/main" id="{4E6B70CC-FB09-42F4-BF9D-503927640D6A}"/>
+                <a16:creationId xmlns:a16="http://schemas.microsoft.com/office/drawing/2014/main" id="{698E9F7A-F997-40E4-8F34-7F49AEB50793}"/>
               </a:ext>
             </a:extLst>
           </p:cNvPr>
@@ -7977,7 +8323,7 @@
           <p:cNvPr id="4" name="ambient-glow">
             <a:extLst xmlns:a="http://schemas.openxmlformats.org/drawingml/2006/main">
               <a:ext uri="{FF2B5EF4-FFF2-40B4-BE49-F238E27FC236}">
-                <a16:creationId xmlns:a16="http://schemas.microsoft.com/office/drawing/2014/main" id="{D8F54495-688E-46DF-8588-535814F4B962}"/>
+                <a16:creationId xmlns:a16="http://schemas.microsoft.com/office/drawing/2014/main" id="{8E347E95-DBB7-4EC0-AA28-59D27F88472B}"/>
               </a:ext>
             </a:extLst>
           </p:cNvPr>
@@ -8014,7 +8360,7 @@
           <p:cNvPr id="5" name="ambient-core">
             <a:extLst xmlns:a="http://schemas.openxmlformats.org/drawingml/2006/main">
               <a:ext uri="{FF2B5EF4-FFF2-40B4-BE49-F238E27FC236}">
-                <a16:creationId xmlns:a16="http://schemas.microsoft.com/office/drawing/2014/main" id="{7D8BFF9E-FC8F-4E65-8272-5F950A03B091}"/>
+                <a16:creationId xmlns:a16="http://schemas.microsoft.com/office/drawing/2014/main" id="{F957EC40-E2AA-4324-8EDB-B9A53992B3F7}"/>
               </a:ext>
             </a:extLst>
           </p:cNvPr>
@@ -8051,7 +8397,7 @@
           <p:cNvPr id="6" name="section-number">
             <a:extLst xmlns:a="http://schemas.openxmlformats.org/drawingml/2006/main">
               <a:ext uri="{FF2B5EF4-FFF2-40B4-BE49-F238E27FC236}">
-                <a16:creationId xmlns:a16="http://schemas.microsoft.com/office/drawing/2014/main" id="{5DC9BAB4-D31A-4112-8898-78153897B784}"/>
+                <a16:creationId xmlns:a16="http://schemas.microsoft.com/office/drawing/2014/main" id="{85A14BD5-E590-44D1-8EC0-253C0D20F660}"/>
               </a:ext>
             </a:extLst>
           </p:cNvPr>
@@ -8102,7 +8448,7 @@
           <p:cNvPr id="7" name="eyebrow">
             <a:extLst xmlns:a="http://schemas.openxmlformats.org/drawingml/2006/main">
               <a:ext uri="{FF2B5EF4-FFF2-40B4-BE49-F238E27FC236}">
-                <a16:creationId xmlns:a16="http://schemas.microsoft.com/office/drawing/2014/main" id="{3F69F428-A49E-46C1-9969-8333B70F1CDB}"/>
+                <a16:creationId xmlns:a16="http://schemas.microsoft.com/office/drawing/2014/main" id="{5258220B-9D76-4D88-8456-CD7B81C6B7E0}"/>
               </a:ext>
             </a:extLst>
           </p:cNvPr>
@@ -8150,10 +8496,69 @@
       </p:sp>
       <p:sp>
         <p:nvSpPr>
-          <p:cNvPr id="8" name="footer-rule">
-            <a:extLst xmlns:a="http://schemas.openxmlformats.org/drawingml/2006/main">
-              <a:ext uri="{FF2B5EF4-FFF2-40B4-BE49-F238E27FC236}">
-                <a16:creationId xmlns:a16="http://schemas.microsoft.com/office/drawing/2014/main" id="{020A5464-9C0A-4AC7-BCF8-711FE10C3FD7}"/>
+          <p:cNvPr id="8" name="rescue-point-logo-background">
+            <a:extLst xmlns:a="http://schemas.openxmlformats.org/drawingml/2006/main">
+              <a:ext uri="{FF2B5EF4-FFF2-40B4-BE49-F238E27FC236}">
+                <a16:creationId xmlns:a16="http://schemas.microsoft.com/office/drawing/2014/main" id="{DDE43A89-43AE-44E1-8415-E2C7B8077DE1}"/>
+              </a:ext>
+            </a:extLst>
+          </p:cNvPr>
+          <p:cNvSpPr>
+            <a:spLocks xmlns:a="http://schemas.openxmlformats.org/drawingml/2006/main" noGrp="1"/>
+          </p:cNvSpPr>
+          <p:nvPr/>
+        </p:nvSpPr>
+        <p:spPr>
+          <a:xfrm xmlns:a="http://schemas.openxmlformats.org/drawingml/2006/main">
+            <a:off x="9772650" y="133350"/>
+            <a:ext cx="1733550" cy="457200"/>
+          </a:xfrm>
+          <a:prstGeom xmlns:a="http://schemas.openxmlformats.org/drawingml/2006/main" prst="roundRect">
+            <a:avLst>
+              <a:gd name="adj" fmla="val 16667"/>
+            </a:avLst>
+          </a:prstGeom>
+          <a:solidFill xmlns:a="http://schemas.openxmlformats.org/drawingml/2006/main">
+            <a:srgbClr val="06142E"/>
+          </a:solidFill>
+          <a:ln xmlns:a="http://schemas.openxmlformats.org/drawingml/2006/main" w="9525">
+            <a:solidFill>
+              <a:srgbClr val="1EC5FF">
+                <a:alpha val="33333"/>
+              </a:srgbClr>
+            </a:solidFill>
+            <a:prstDash val="solid"/>
+          </a:ln>
+        </p:spPr>
+      </p:sp>
+      <p:pic>
+        <p:nvPicPr>
+          <p:cNvPr id="23" name="" descr="Figura oficial da documentação dbt usada para explicar: Escolha a interface certa para cada ambiente — O explorador do curso funciona no navegador; a UI oficial exige um túnel que preserve localhost.."/>
+          <p:cNvPicPr>
+            <a:picLocks xmlns:a="http://schemas.openxmlformats.org/drawingml/2006/main" noChangeAspect="1"/>
+          </p:cNvPicPr>
+          <p:nvPr/>
+        </p:nvPicPr>
+        <p:blipFill>
+          <a:blip xmlns:r="http://schemas.openxmlformats.org/officeDocument/2006/relationships" xmlns:a="http://schemas.openxmlformats.org/drawingml/2006/main" r:embed="Raf362b2a37204553"/>
+          <a:stretch xmlns:a="http://schemas.openxmlformats.org/drawingml/2006/main"/>
+        </p:blipFill>
+        <p:spPr>
+          <a:xfrm xmlns:a="http://schemas.openxmlformats.org/drawingml/2006/main">
+            <a:off x="9893718" y="209550"/>
+            <a:ext cx="1491414" cy="323850"/>
+          </a:xfrm>
+          <a:prstGeom xmlns:a="http://schemas.openxmlformats.org/drawingml/2006/main" prst="rect">
+            <a:avLst/>
+          </a:prstGeom>
+        </p:spPr>
+      </p:pic>
+      <p:sp>
+        <p:nvSpPr>
+          <p:cNvPr id="10" name="footer-rule">
+            <a:extLst xmlns:a="http://schemas.openxmlformats.org/drawingml/2006/main">
+              <a:ext uri="{FF2B5EF4-FFF2-40B4-BE49-F238E27FC236}">
+                <a16:creationId xmlns:a16="http://schemas.microsoft.com/office/drawing/2014/main" id="{4B1BB787-F607-43B6-A109-30556E4CCCE1}"/>
               </a:ext>
             </a:extLst>
           </p:cNvPr>
@@ -8183,10 +8588,10 @@
       </p:sp>
       <p:sp>
         <p:nvSpPr>
-          <p:cNvPr id="9" name="footer">
-            <a:extLst xmlns:a="http://schemas.openxmlformats.org/drawingml/2006/main">
-              <a:ext uri="{FF2B5EF4-FFF2-40B4-BE49-F238E27FC236}">
-                <a16:creationId xmlns:a16="http://schemas.microsoft.com/office/drawing/2014/main" id="{37004183-3B9E-434B-B202-0F9B574643F2}"/>
+          <p:cNvPr id="11" name="footer">
+            <a:extLst xmlns:a="http://schemas.openxmlformats.org/drawingml/2006/main">
+              <a:ext uri="{FF2B5EF4-FFF2-40B4-BE49-F238E27FC236}">
+                <a16:creationId xmlns:a16="http://schemas.microsoft.com/office/drawing/2014/main" id="{593E70C4-835A-4B0E-A0A1-BB25E66B97D9}"/>
               </a:ext>
             </a:extLst>
           </p:cNvPr>
@@ -8238,10 +8643,10 @@
       </p:sp>
       <p:sp>
         <p:nvSpPr>
-          <p:cNvPr id="10" name="page-number">
-            <a:extLst xmlns:a="http://schemas.openxmlformats.org/drawingml/2006/main">
-              <a:ext uri="{FF2B5EF4-FFF2-40B4-BE49-F238E27FC236}">
-                <a16:creationId xmlns:a16="http://schemas.microsoft.com/office/drawing/2014/main" id="{D44DB15B-7B67-4C75-843F-DBF1F1CDC014}"/>
+          <p:cNvPr id="12" name="page-number">
+            <a:extLst xmlns:a="http://schemas.openxmlformats.org/drawingml/2006/main">
+              <a:ext uri="{FF2B5EF4-FFF2-40B4-BE49-F238E27FC236}">
+                <a16:creationId xmlns:a16="http://schemas.microsoft.com/office/drawing/2014/main" id="{B71EA089-F40D-4EBE-880A-13BDF257B70F}"/>
               </a:ext>
             </a:extLst>
           </p:cNvPr>
@@ -8294,7 +8699,7 @@
     </p:spTree>
     <p:extLst>
       <p:ext uri="{BB962C8B-B14F-4D97-AF65-F5344CB8AC3E}">
-        <p14:creationId xmlns:p14="http://schemas.microsoft.com/office/powerpoint/2010/main" val="1283717871"/>
+        <p14:creationId xmlns:p14="http://schemas.microsoft.com/office/powerpoint/2010/main" val="771179746"/>
       </p:ext>
     </p:extLst>
   </p:cSld>
@@ -8330,10 +8735,10 @@
       </p:grpSpPr>
       <p:sp>
         <p:nvSpPr>
-          <p:cNvPr id="13" name="slide-title">
-            <a:extLst xmlns:a="http://schemas.openxmlformats.org/drawingml/2006/main">
-              <a:ext uri="{FF2B5EF4-FFF2-40B4-BE49-F238E27FC236}">
-                <a16:creationId xmlns:a16="http://schemas.microsoft.com/office/drawing/2014/main" id="{7F0F218F-143F-4C7E-A636-0F137A9C0EEF}"/>
+          <p:cNvPr id="15" name="slide-title">
+            <a:extLst xmlns:a="http://schemas.openxmlformats.org/drawingml/2006/main">
+              <a:ext uri="{FF2B5EF4-FFF2-40B4-BE49-F238E27FC236}">
+                <a16:creationId xmlns:a16="http://schemas.microsoft.com/office/drawing/2014/main" id="{879CB67F-872C-4C77-BC5B-2BF38251927B}"/>
               </a:ext>
             </a:extLst>
           </p:cNvPr>
@@ -8384,7 +8789,7 @@
           <p:cNvPr id="2" name="flow-1">
             <a:extLst xmlns:a="http://schemas.openxmlformats.org/drawingml/2006/main">
               <a:ext uri="{FF2B5EF4-FFF2-40B4-BE49-F238E27FC236}">
-                <a16:creationId xmlns:a16="http://schemas.microsoft.com/office/drawing/2014/main" id="{B2307041-C83B-413B-BECF-2BFC41AD5393}"/>
+                <a16:creationId xmlns:a16="http://schemas.microsoft.com/office/drawing/2014/main" id="{4AD54873-0F03-410B-A6C0-48EEC9928609}"/>
               </a:ext>
             </a:extLst>
           </p:cNvPr>
@@ -8441,7 +8846,7 @@
           <p:cNvPr id="3" name="flow-2">
             <a:extLst xmlns:a="http://schemas.openxmlformats.org/drawingml/2006/main">
               <a:ext uri="{FF2B5EF4-FFF2-40B4-BE49-F238E27FC236}">
-                <a16:creationId xmlns:a16="http://schemas.microsoft.com/office/drawing/2014/main" id="{B1DD4D67-AE07-4DE2-BE5A-C191F5BF18D4}"/>
+                <a16:creationId xmlns:a16="http://schemas.microsoft.com/office/drawing/2014/main" id="{C90280E7-8EA5-47B7-BFF0-02D70AAA2B2D}"/>
               </a:ext>
             </a:extLst>
           </p:cNvPr>
@@ -8498,7 +8903,7 @@
           <p:cNvPr id="4" name="flow-3">
             <a:extLst xmlns:a="http://schemas.openxmlformats.org/drawingml/2006/main">
               <a:ext uri="{FF2B5EF4-FFF2-40B4-BE49-F238E27FC236}">
-                <a16:creationId xmlns:a16="http://schemas.microsoft.com/office/drawing/2014/main" id="{7A768B33-64EC-42B1-ACD9-CDCD7230D7A9}"/>
+                <a16:creationId xmlns:a16="http://schemas.microsoft.com/office/drawing/2014/main" id="{6FD6EA3A-A36A-4C3D-86C3-9CCD08620035}"/>
               </a:ext>
             </a:extLst>
           </p:cNvPr>
@@ -8555,7 +8960,7 @@
           <p:cNvPr id="5" name="flow-4">
             <a:extLst xmlns:a="http://schemas.openxmlformats.org/drawingml/2006/main">
               <a:ext uri="{FF2B5EF4-FFF2-40B4-BE49-F238E27FC236}">
-                <a16:creationId xmlns:a16="http://schemas.microsoft.com/office/drawing/2014/main" id="{5B860EEA-08A5-46C9-821E-F2860873B0A6}"/>
+                <a16:creationId xmlns:a16="http://schemas.microsoft.com/office/drawing/2014/main" id="{3F3AE306-E7E6-493D-9F7A-1E156D705C49}"/>
               </a:ext>
             </a:extLst>
           </p:cNvPr>
@@ -8609,7 +9014,7 @@
       </p:sp>
       <p:cxnSp>
         <p:nvCxnSpPr>
-          <p:cNvPr id="26" name=""/>
+          <p:cNvPr id="29" name=""/>
           <p:cNvCxnSpPr>
             <a:stCxn xmlns:a="http://schemas.openxmlformats.org/drawingml/2006/main" id="2" idx="3"/>
             <a:endCxn xmlns:a="http://schemas.openxmlformats.org/drawingml/2006/main" id="3" idx="1"/>
@@ -8635,7 +9040,7 @@
       </p:cxnSp>
       <p:cxnSp>
         <p:nvCxnSpPr>
-          <p:cNvPr id="27" name=""/>
+          <p:cNvPr id="30" name=""/>
           <p:cNvCxnSpPr>
             <a:stCxn xmlns:a="http://schemas.openxmlformats.org/drawingml/2006/main" id="3" idx="3"/>
             <a:endCxn xmlns:a="http://schemas.openxmlformats.org/drawingml/2006/main" id="4" idx="1"/>
@@ -8661,7 +9066,7 @@
       </p:cxnSp>
       <p:cxnSp>
         <p:nvCxnSpPr>
-          <p:cNvPr id="28" name=""/>
+          <p:cNvPr id="31" name=""/>
           <p:cNvCxnSpPr>
             <a:stCxn xmlns:a="http://schemas.openxmlformats.org/drawingml/2006/main" id="4" idx="3"/>
             <a:endCxn xmlns:a="http://schemas.openxmlformats.org/drawingml/2006/main" id="5" idx="1"/>
@@ -8690,7 +9095,7 @@
           <p:cNvPr id="9" name="eyebrow">
             <a:extLst xmlns:a="http://schemas.openxmlformats.org/drawingml/2006/main">
               <a:ext uri="{FF2B5EF4-FFF2-40B4-BE49-F238E27FC236}">
-                <a16:creationId xmlns:a16="http://schemas.microsoft.com/office/drawing/2014/main" id="{D563FCA4-69CB-4CF4-A82A-E0BBEAB4C06A}"/>
+                <a16:creationId xmlns:a16="http://schemas.microsoft.com/office/drawing/2014/main" id="{7196C4C4-50BF-4195-BFF7-3EEADD0C6E0F}"/>
               </a:ext>
             </a:extLst>
           </p:cNvPr>
@@ -8738,10 +9143,69 @@
       </p:sp>
       <p:sp>
         <p:nvSpPr>
-          <p:cNvPr id="10" name="footer-rule">
-            <a:extLst xmlns:a="http://schemas.openxmlformats.org/drawingml/2006/main">
-              <a:ext uri="{FF2B5EF4-FFF2-40B4-BE49-F238E27FC236}">
-                <a16:creationId xmlns:a16="http://schemas.microsoft.com/office/drawing/2014/main" id="{4CC6D0BE-9D96-49F5-9F8A-865C3A62A367}"/>
+          <p:cNvPr id="10" name="rescue-point-logo-background">
+            <a:extLst xmlns:a="http://schemas.openxmlformats.org/drawingml/2006/main">
+              <a:ext uri="{FF2B5EF4-FFF2-40B4-BE49-F238E27FC236}">
+                <a16:creationId xmlns:a16="http://schemas.microsoft.com/office/drawing/2014/main" id="{039E7002-F5A4-4C0E-B641-EF80319C0603}"/>
+              </a:ext>
+            </a:extLst>
+          </p:cNvPr>
+          <p:cNvSpPr>
+            <a:spLocks xmlns:a="http://schemas.openxmlformats.org/drawingml/2006/main" noGrp="1"/>
+          </p:cNvSpPr>
+          <p:nvPr/>
+        </p:nvSpPr>
+        <p:spPr>
+          <a:xfrm xmlns:a="http://schemas.openxmlformats.org/drawingml/2006/main">
+            <a:off x="9772650" y="133350"/>
+            <a:ext cx="1733550" cy="457200"/>
+          </a:xfrm>
+          <a:prstGeom xmlns:a="http://schemas.openxmlformats.org/drawingml/2006/main" prst="roundRect">
+            <a:avLst>
+              <a:gd name="adj" fmla="val 16667"/>
+            </a:avLst>
+          </a:prstGeom>
+          <a:solidFill xmlns:a="http://schemas.openxmlformats.org/drawingml/2006/main">
+            <a:srgbClr val="06142E"/>
+          </a:solidFill>
+          <a:ln xmlns:a="http://schemas.openxmlformats.org/drawingml/2006/main" w="9525">
+            <a:solidFill>
+              <a:srgbClr val="1EC5FF">
+                <a:alpha val="33333"/>
+              </a:srgbClr>
+            </a:solidFill>
+            <a:prstDash val="solid"/>
+          </a:ln>
+        </p:spPr>
+      </p:sp>
+      <p:pic>
+        <p:nvPicPr>
+          <p:cNvPr id="34" name="" descr="Figura oficial da documentação dbt usada para explicar: Escolha a interface certa para cada ambiente — DuckDB."/>
+          <p:cNvPicPr>
+            <a:picLocks xmlns:a="http://schemas.openxmlformats.org/drawingml/2006/main" noChangeAspect="1"/>
+          </p:cNvPicPr>
+          <p:nvPr/>
+        </p:nvPicPr>
+        <p:blipFill>
+          <a:blip xmlns:r="http://schemas.openxmlformats.org/officeDocument/2006/relationships" xmlns:a="http://schemas.openxmlformats.org/drawingml/2006/main" r:embed="R23c9384e269c4214"/>
+          <a:stretch xmlns:a="http://schemas.openxmlformats.org/drawingml/2006/main"/>
+        </p:blipFill>
+        <p:spPr>
+          <a:xfrm xmlns:a="http://schemas.openxmlformats.org/drawingml/2006/main">
+            <a:off x="9893718" y="209550"/>
+            <a:ext cx="1491414" cy="323850"/>
+          </a:xfrm>
+          <a:prstGeom xmlns:a="http://schemas.openxmlformats.org/drawingml/2006/main" prst="rect">
+            <a:avLst/>
+          </a:prstGeom>
+        </p:spPr>
+      </p:pic>
+      <p:sp>
+        <p:nvSpPr>
+          <p:cNvPr id="12" name="footer-rule">
+            <a:extLst xmlns:a="http://schemas.openxmlformats.org/drawingml/2006/main">
+              <a:ext uri="{FF2B5EF4-FFF2-40B4-BE49-F238E27FC236}">
+                <a16:creationId xmlns:a16="http://schemas.microsoft.com/office/drawing/2014/main" id="{05C41C76-58DF-4419-8786-9BB74E3E5708}"/>
               </a:ext>
             </a:extLst>
           </p:cNvPr>
@@ -8771,10 +9235,10 @@
       </p:sp>
       <p:sp>
         <p:nvSpPr>
-          <p:cNvPr id="11" name="footer">
-            <a:extLst xmlns:a="http://schemas.openxmlformats.org/drawingml/2006/main">
-              <a:ext uri="{FF2B5EF4-FFF2-40B4-BE49-F238E27FC236}">
-                <a16:creationId xmlns:a16="http://schemas.microsoft.com/office/drawing/2014/main" id="{B019CF45-B3CC-4633-BBF5-C1C81155889D}"/>
+          <p:cNvPr id="13" name="footer">
+            <a:extLst xmlns:a="http://schemas.openxmlformats.org/drawingml/2006/main">
+              <a:ext uri="{FF2B5EF4-FFF2-40B4-BE49-F238E27FC236}">
+                <a16:creationId xmlns:a16="http://schemas.microsoft.com/office/drawing/2014/main" id="{ACD9F760-7D52-478B-A791-14316A7426CA}"/>
               </a:ext>
             </a:extLst>
           </p:cNvPr>
@@ -8826,10 +9290,10 @@
       </p:sp>
       <p:sp>
         <p:nvSpPr>
-          <p:cNvPr id="12" name="page-number">
-            <a:extLst xmlns:a="http://schemas.openxmlformats.org/drawingml/2006/main">
-              <a:ext uri="{FF2B5EF4-FFF2-40B4-BE49-F238E27FC236}">
-                <a16:creationId xmlns:a16="http://schemas.microsoft.com/office/drawing/2014/main" id="{1216E70A-8E7C-45B9-A1C2-5969E8FD1BF4}"/>
+          <p:cNvPr id="14" name="page-number">
+            <a:extLst xmlns:a="http://schemas.openxmlformats.org/drawingml/2006/main">
+              <a:ext uri="{FF2B5EF4-FFF2-40B4-BE49-F238E27FC236}">
+                <a16:creationId xmlns:a16="http://schemas.microsoft.com/office/drawing/2014/main" id="{92BC14CC-6E26-40E9-ABC4-B0850A22D5C6}"/>
               </a:ext>
             </a:extLst>
           </p:cNvPr>
@@ -8882,7 +9346,7 @@
     </p:spTree>
     <p:extLst>
       <p:ext uri="{BB962C8B-B14F-4D97-AF65-F5344CB8AC3E}">
-        <p14:creationId xmlns:p14="http://schemas.microsoft.com/office/powerpoint/2010/main" val="584638055"/>
+        <p14:creationId xmlns:p14="http://schemas.microsoft.com/office/powerpoint/2010/main" val="1648768693"/>
       </p:ext>
     </p:extLst>
   </p:cSld>
@@ -8918,10 +9382,10 @@
       </p:grpSpPr>
       <p:sp>
         <p:nvSpPr>
-          <p:cNvPr id="9" name="slide-title">
-            <a:extLst xmlns:a="http://schemas.openxmlformats.org/drawingml/2006/main">
-              <a:ext uri="{FF2B5EF4-FFF2-40B4-BE49-F238E27FC236}">
-                <a16:creationId xmlns:a16="http://schemas.microsoft.com/office/drawing/2014/main" id="{7B27AAD6-BC47-44FC-8798-69018D36BCB5}"/>
+          <p:cNvPr id="11" name="slide-title">
+            <a:extLst xmlns:a="http://schemas.openxmlformats.org/drawingml/2006/main">
+              <a:ext uri="{FF2B5EF4-FFF2-40B4-BE49-F238E27FC236}">
+                <a16:creationId xmlns:a16="http://schemas.microsoft.com/office/drawing/2014/main" id="{BDCD1059-D8DB-419B-A50B-43406D47AA08}"/>
               </a:ext>
             </a:extLst>
           </p:cNvPr>
@@ -8972,7 +9436,7 @@
           <p:cNvPr id="2" name="code-surface">
             <a:extLst xmlns:a="http://schemas.openxmlformats.org/drawingml/2006/main">
               <a:ext uri="{FF2B5EF4-FFF2-40B4-BE49-F238E27FC236}">
-                <a16:creationId xmlns:a16="http://schemas.microsoft.com/office/drawing/2014/main" id="{DBEF3606-D9CE-4AFB-8C55-B15D580A5BC8}"/>
+                <a16:creationId xmlns:a16="http://schemas.microsoft.com/office/drawing/2014/main" id="{E4C6229C-34E3-4AE4-953A-CD47ECDFA586}"/>
               </a:ext>
             </a:extLst>
           </p:cNvPr>
@@ -9007,7 +9471,7 @@
           <p:cNvPr id="3" name="command">
             <a:extLst xmlns:a="http://schemas.openxmlformats.org/drawingml/2006/main">
               <a:ext uri="{FF2B5EF4-FFF2-40B4-BE49-F238E27FC236}">
-                <a16:creationId xmlns:a16="http://schemas.microsoft.com/office/drawing/2014/main" id="{50EA78D7-F2A2-4315-986B-7AD7F9D63212}"/>
+                <a16:creationId xmlns:a16="http://schemas.microsoft.com/office/drawing/2014/main" id="{7FFA4E70-46AD-4A8F-B775-220428B43AEA}"/>
               </a:ext>
             </a:extLst>
           </p:cNvPr>
@@ -9094,7 +9558,7 @@
           <p:cNvPr id="4" name="command-help">
             <a:extLst xmlns:a="http://schemas.openxmlformats.org/drawingml/2006/main">
               <a:ext uri="{FF2B5EF4-FFF2-40B4-BE49-F238E27FC236}">
-                <a16:creationId xmlns:a16="http://schemas.microsoft.com/office/drawing/2014/main" id="{BF86C0F5-6D15-445E-B6F6-DFA599362E35}"/>
+                <a16:creationId xmlns:a16="http://schemas.microsoft.com/office/drawing/2014/main" id="{429377ED-3492-4FF3-8DBE-C76456928F83}"/>
               </a:ext>
             </a:extLst>
           </p:cNvPr>
@@ -9145,7 +9609,7 @@
           <p:cNvPr id="5" name="eyebrow">
             <a:extLst xmlns:a="http://schemas.openxmlformats.org/drawingml/2006/main">
               <a:ext uri="{FF2B5EF4-FFF2-40B4-BE49-F238E27FC236}">
-                <a16:creationId xmlns:a16="http://schemas.microsoft.com/office/drawing/2014/main" id="{D5869A73-3F7F-4954-A935-30FE76F65F5F}"/>
+                <a16:creationId xmlns:a16="http://schemas.microsoft.com/office/drawing/2014/main" id="{09D64174-F7C4-40DD-AB83-E6A1E7DF249F}"/>
               </a:ext>
             </a:extLst>
           </p:cNvPr>
@@ -9193,10 +9657,69 @@
       </p:sp>
       <p:sp>
         <p:nvSpPr>
-          <p:cNvPr id="6" name="footer-rule">
-            <a:extLst xmlns:a="http://schemas.openxmlformats.org/drawingml/2006/main">
-              <a:ext uri="{FF2B5EF4-FFF2-40B4-BE49-F238E27FC236}">
-                <a16:creationId xmlns:a16="http://schemas.microsoft.com/office/drawing/2014/main" id="{92F004C7-A625-42FE-B574-4DBBEE5ECBFC}"/>
+          <p:cNvPr id="6" name="rescue-point-logo-background">
+            <a:extLst xmlns:a="http://schemas.openxmlformats.org/drawingml/2006/main">
+              <a:ext uri="{FF2B5EF4-FFF2-40B4-BE49-F238E27FC236}">
+                <a16:creationId xmlns:a16="http://schemas.microsoft.com/office/drawing/2014/main" id="{E4319904-EF91-4CFE-80D4-081FEB509748}"/>
+              </a:ext>
+            </a:extLst>
+          </p:cNvPr>
+          <p:cNvSpPr>
+            <a:spLocks xmlns:a="http://schemas.openxmlformats.org/drawingml/2006/main" noGrp="1"/>
+          </p:cNvSpPr>
+          <p:nvPr/>
+        </p:nvSpPr>
+        <p:spPr>
+          <a:xfrm xmlns:a="http://schemas.openxmlformats.org/drawingml/2006/main">
+            <a:off x="9772650" y="133350"/>
+            <a:ext cx="1733550" cy="457200"/>
+          </a:xfrm>
+          <a:prstGeom xmlns:a="http://schemas.openxmlformats.org/drawingml/2006/main" prst="roundRect">
+            <a:avLst>
+              <a:gd name="adj" fmla="val 16667"/>
+            </a:avLst>
+          </a:prstGeom>
+          <a:solidFill xmlns:a="http://schemas.openxmlformats.org/drawingml/2006/main">
+            <a:srgbClr val="06142E"/>
+          </a:solidFill>
+          <a:ln xmlns:a="http://schemas.openxmlformats.org/drawingml/2006/main" w="9525">
+            <a:solidFill>
+              <a:srgbClr val="1EC5FF">
+                <a:alpha val="33333"/>
+              </a:srgbClr>
+            </a:solidFill>
+            <a:prstDash val="solid"/>
+          </a:ln>
+        </p:spPr>
+      </p:sp>
+      <p:pic>
+        <p:nvPicPr>
+          <p:cNvPr id="19" name="" descr="Figura oficial da documentação dbt usada para explicar: Demonstração — execute — python course.py paths."/>
+          <p:cNvPicPr>
+            <a:picLocks xmlns:a="http://schemas.openxmlformats.org/drawingml/2006/main" noChangeAspect="1"/>
+          </p:cNvPicPr>
+          <p:nvPr/>
+        </p:nvPicPr>
+        <p:blipFill>
+          <a:blip xmlns:r="http://schemas.openxmlformats.org/officeDocument/2006/relationships" xmlns:a="http://schemas.openxmlformats.org/drawingml/2006/main" r:embed="Rd1a3085505224192"/>
+          <a:stretch xmlns:a="http://schemas.openxmlformats.org/drawingml/2006/main"/>
+        </p:blipFill>
+        <p:spPr>
+          <a:xfrm xmlns:a="http://schemas.openxmlformats.org/drawingml/2006/main">
+            <a:off x="9893718" y="209550"/>
+            <a:ext cx="1491414" cy="323850"/>
+          </a:xfrm>
+          <a:prstGeom xmlns:a="http://schemas.openxmlformats.org/drawingml/2006/main" prst="rect">
+            <a:avLst/>
+          </a:prstGeom>
+        </p:spPr>
+      </p:pic>
+      <p:sp>
+        <p:nvSpPr>
+          <p:cNvPr id="8" name="footer-rule">
+            <a:extLst xmlns:a="http://schemas.openxmlformats.org/drawingml/2006/main">
+              <a:ext uri="{FF2B5EF4-FFF2-40B4-BE49-F238E27FC236}">
+                <a16:creationId xmlns:a16="http://schemas.microsoft.com/office/drawing/2014/main" id="{6E7B0BD7-5D06-45DA-841D-3CE576F3A3B6}"/>
               </a:ext>
             </a:extLst>
           </p:cNvPr>
@@ -9226,10 +9749,10 @@
       </p:sp>
       <p:sp>
         <p:nvSpPr>
-          <p:cNvPr id="7" name="footer">
-            <a:extLst xmlns:a="http://schemas.openxmlformats.org/drawingml/2006/main">
-              <a:ext uri="{FF2B5EF4-FFF2-40B4-BE49-F238E27FC236}">
-                <a16:creationId xmlns:a16="http://schemas.microsoft.com/office/drawing/2014/main" id="{DC1521A5-7D45-41DB-A11F-3B6A38A72C70}"/>
+          <p:cNvPr id="9" name="footer">
+            <a:extLst xmlns:a="http://schemas.openxmlformats.org/drawingml/2006/main">
+              <a:ext uri="{FF2B5EF4-FFF2-40B4-BE49-F238E27FC236}">
+                <a16:creationId xmlns:a16="http://schemas.microsoft.com/office/drawing/2014/main" id="{F90936C9-FF34-4050-A20F-9CB27EDA9051}"/>
               </a:ext>
             </a:extLst>
           </p:cNvPr>
@@ -9281,10 +9804,10 @@
       </p:sp>
       <p:sp>
         <p:nvSpPr>
-          <p:cNvPr id="8" name="page-number">
-            <a:extLst xmlns:a="http://schemas.openxmlformats.org/drawingml/2006/main">
-              <a:ext uri="{FF2B5EF4-FFF2-40B4-BE49-F238E27FC236}">
-                <a16:creationId xmlns:a16="http://schemas.microsoft.com/office/drawing/2014/main" id="{94509C04-7617-49E5-9652-E95363DE9EFB}"/>
+          <p:cNvPr id="10" name="page-number">
+            <a:extLst xmlns:a="http://schemas.openxmlformats.org/drawingml/2006/main">
+              <a:ext uri="{FF2B5EF4-FFF2-40B4-BE49-F238E27FC236}">
+                <a16:creationId xmlns:a16="http://schemas.microsoft.com/office/drawing/2014/main" id="{5A809AA1-15C0-4CC8-9219-5A92BE5B3E52}"/>
               </a:ext>
             </a:extLst>
           </p:cNvPr>
@@ -9337,7 +9860,7 @@
     </p:spTree>
     <p:extLst>
       <p:ext uri="{BB962C8B-B14F-4D97-AF65-F5344CB8AC3E}">
-        <p14:creationId xmlns:p14="http://schemas.microsoft.com/office/powerpoint/2010/main" val="183623369"/>
+        <p14:creationId xmlns:p14="http://schemas.microsoft.com/office/powerpoint/2010/main" val="34528155"/>
       </p:ext>
     </p:extLst>
   </p:cSld>
@@ -9365,10 +9888,10 @@
       </p:grpSpPr>
       <p:sp>
         <p:nvSpPr>
-          <p:cNvPr id="14" name="slide-title">
-            <a:extLst xmlns:a="http://schemas.openxmlformats.org/drawingml/2006/main">
-              <a:ext uri="{FF2B5EF4-FFF2-40B4-BE49-F238E27FC236}">
-                <a16:creationId xmlns:a16="http://schemas.microsoft.com/office/drawing/2014/main" id="{771B79BC-AFA3-43D2-AE55-DB843E4F4B4F}"/>
+          <p:cNvPr id="16" name="slide-title">
+            <a:extLst xmlns:a="http://schemas.openxmlformats.org/drawingml/2006/main">
+              <a:ext uri="{FF2B5EF4-FFF2-40B4-BE49-F238E27FC236}">
+                <a16:creationId xmlns:a16="http://schemas.microsoft.com/office/drawing/2014/main" id="{44D8B91B-5991-4E00-B8D0-761608DB4CED}"/>
               </a:ext>
             </a:extLst>
           </p:cNvPr>
@@ -9419,7 +9942,7 @@
           <p:cNvPr id="2" name="step-num-1">
             <a:extLst xmlns:a="http://schemas.openxmlformats.org/drawingml/2006/main">
               <a:ext uri="{FF2B5EF4-FFF2-40B4-BE49-F238E27FC236}">
-                <a16:creationId xmlns:a16="http://schemas.microsoft.com/office/drawing/2014/main" id="{48F29D56-884E-484D-B674-1C2C03237B69}"/>
+                <a16:creationId xmlns:a16="http://schemas.microsoft.com/office/drawing/2014/main" id="{0CB4FF99-A923-4149-8577-AFCE323BB89B}"/>
               </a:ext>
             </a:extLst>
           </p:cNvPr>
@@ -9470,7 +9993,7 @@
           <p:cNvPr id="3" name="step-label-1">
             <a:extLst xmlns:a="http://schemas.openxmlformats.org/drawingml/2006/main">
               <a:ext uri="{FF2B5EF4-FFF2-40B4-BE49-F238E27FC236}">
-                <a16:creationId xmlns:a16="http://schemas.microsoft.com/office/drawing/2014/main" id="{6926A17C-4942-4E0C-BAB4-6D2D787343A2}"/>
+                <a16:creationId xmlns:a16="http://schemas.microsoft.com/office/drawing/2014/main" id="{1AB34CDB-ECBA-4B68-973F-9D9F1EE37488}"/>
               </a:ext>
             </a:extLst>
           </p:cNvPr>
@@ -9521,7 +10044,7 @@
           <p:cNvPr id="4" name="step-line-1">
             <a:extLst xmlns:a="http://schemas.openxmlformats.org/drawingml/2006/main">
               <a:ext uri="{FF2B5EF4-FFF2-40B4-BE49-F238E27FC236}">
-                <a16:creationId xmlns:a16="http://schemas.microsoft.com/office/drawing/2014/main" id="{D25B42F6-5983-468A-8320-46DF4E3D4D7A}"/>
+                <a16:creationId xmlns:a16="http://schemas.microsoft.com/office/drawing/2014/main" id="{65F9E6B5-42FB-439D-83BE-F6D9ACC7CD7F}"/>
               </a:ext>
             </a:extLst>
           </p:cNvPr>
@@ -9552,7 +10075,7 @@
           <p:cNvPr id="5" name="step-num-2">
             <a:extLst xmlns:a="http://schemas.openxmlformats.org/drawingml/2006/main">
               <a:ext uri="{FF2B5EF4-FFF2-40B4-BE49-F238E27FC236}">
-                <a16:creationId xmlns:a16="http://schemas.microsoft.com/office/drawing/2014/main" id="{BA09BB11-9ABF-4BDE-845B-2C17D1907A14}"/>
+                <a16:creationId xmlns:a16="http://schemas.microsoft.com/office/drawing/2014/main" id="{2031AACD-AD99-4917-8490-CE0CEC0ED5FC}"/>
               </a:ext>
             </a:extLst>
           </p:cNvPr>
@@ -9603,7 +10126,7 @@
           <p:cNvPr id="6" name="step-label-2">
             <a:extLst xmlns:a="http://schemas.openxmlformats.org/drawingml/2006/main">
               <a:ext uri="{FF2B5EF4-FFF2-40B4-BE49-F238E27FC236}">
-                <a16:creationId xmlns:a16="http://schemas.microsoft.com/office/drawing/2014/main" id="{5D47F47A-55A4-4334-B080-0BB0A9C64F0F}"/>
+                <a16:creationId xmlns:a16="http://schemas.microsoft.com/office/drawing/2014/main" id="{35279C88-AFCB-42E5-A597-B96551E62FF9}"/>
               </a:ext>
             </a:extLst>
           </p:cNvPr>
@@ -9654,7 +10177,7 @@
           <p:cNvPr id="7" name="step-line-2">
             <a:extLst xmlns:a="http://schemas.openxmlformats.org/drawingml/2006/main">
               <a:ext uri="{FF2B5EF4-FFF2-40B4-BE49-F238E27FC236}">
-                <a16:creationId xmlns:a16="http://schemas.microsoft.com/office/drawing/2014/main" id="{A8EF5BDC-80CA-4D6D-B180-C3621A3B8CE5}"/>
+                <a16:creationId xmlns:a16="http://schemas.microsoft.com/office/drawing/2014/main" id="{C1CC9D87-0B40-41FF-A639-68DC0FF5863B}"/>
               </a:ext>
             </a:extLst>
           </p:cNvPr>
@@ -9685,7 +10208,7 @@
           <p:cNvPr id="8" name="step-num-3">
             <a:extLst xmlns:a="http://schemas.openxmlformats.org/drawingml/2006/main">
               <a:ext uri="{FF2B5EF4-FFF2-40B4-BE49-F238E27FC236}">
-                <a16:creationId xmlns:a16="http://schemas.microsoft.com/office/drawing/2014/main" id="{86BFE10A-1ACD-4FDA-A4DB-7D63DA6EED49}"/>
+                <a16:creationId xmlns:a16="http://schemas.microsoft.com/office/drawing/2014/main" id="{1EC69914-FD5C-4B93-82CC-1A4A515E4E66}"/>
               </a:ext>
             </a:extLst>
           </p:cNvPr>
@@ -9736,7 +10259,7 @@
           <p:cNvPr id="9" name="step-label-3">
             <a:extLst xmlns:a="http://schemas.openxmlformats.org/drawingml/2006/main">
               <a:ext uri="{FF2B5EF4-FFF2-40B4-BE49-F238E27FC236}">
-                <a16:creationId xmlns:a16="http://schemas.microsoft.com/office/drawing/2014/main" id="{0D7AC1FD-6B7C-4000-8A6D-660A17CE6FF1}"/>
+                <a16:creationId xmlns:a16="http://schemas.microsoft.com/office/drawing/2014/main" id="{DE80F0CE-8A2A-4700-89A2-E470860BC331}"/>
               </a:ext>
             </a:extLst>
           </p:cNvPr>
@@ -9787,7 +10310,7 @@
           <p:cNvPr id="10" name="eyebrow">
             <a:extLst xmlns:a="http://schemas.openxmlformats.org/drawingml/2006/main">
               <a:ext uri="{FF2B5EF4-FFF2-40B4-BE49-F238E27FC236}">
-                <a16:creationId xmlns:a16="http://schemas.microsoft.com/office/drawing/2014/main" id="{6B8A3B21-B77C-45BC-B474-1E229C5C0566}"/>
+                <a16:creationId xmlns:a16="http://schemas.microsoft.com/office/drawing/2014/main" id="{18524B60-00FD-483A-9BB2-82EAF4BD9216}"/>
               </a:ext>
             </a:extLst>
           </p:cNvPr>
@@ -9835,10 +10358,69 @@
       </p:sp>
       <p:sp>
         <p:nvSpPr>
-          <p:cNvPr id="11" name="footer-rule">
-            <a:extLst xmlns:a="http://schemas.openxmlformats.org/drawingml/2006/main">
-              <a:ext uri="{FF2B5EF4-FFF2-40B4-BE49-F238E27FC236}">
-                <a16:creationId xmlns:a16="http://schemas.microsoft.com/office/drawing/2014/main" id="{AFC50AF5-CE5F-4606-8B19-D95D16D2E5C2}"/>
+          <p:cNvPr id="11" name="rescue-point-logo-background">
+            <a:extLst xmlns:a="http://schemas.openxmlformats.org/drawingml/2006/main">
+              <a:ext uri="{FF2B5EF4-FFF2-40B4-BE49-F238E27FC236}">
+                <a16:creationId xmlns:a16="http://schemas.microsoft.com/office/drawing/2014/main" id="{7BC6D1E5-8274-4CDF-B279-DF89FA1921A1}"/>
+              </a:ext>
+            </a:extLst>
+          </p:cNvPr>
+          <p:cNvSpPr>
+            <a:spLocks xmlns:a="http://schemas.openxmlformats.org/drawingml/2006/main" noGrp="1"/>
+          </p:cNvSpPr>
+          <p:nvPr/>
+        </p:nvSpPr>
+        <p:spPr>
+          <a:xfrm xmlns:a="http://schemas.openxmlformats.org/drawingml/2006/main">
+            <a:off x="9772650" y="133350"/>
+            <a:ext cx="1733550" cy="457200"/>
+          </a:xfrm>
+          <a:prstGeom xmlns:a="http://schemas.openxmlformats.org/drawingml/2006/main" prst="roundRect">
+            <a:avLst>
+              <a:gd name="adj" fmla="val 16667"/>
+            </a:avLst>
+          </a:prstGeom>
+          <a:solidFill xmlns:a="http://schemas.openxmlformats.org/drawingml/2006/main">
+            <a:srgbClr val="06142E"/>
+          </a:solidFill>
+          <a:ln xmlns:a="http://schemas.openxmlformats.org/drawingml/2006/main" w="9525">
+            <a:solidFill>
+              <a:srgbClr val="1EC5FF">
+                <a:alpha val="33333"/>
+              </a:srgbClr>
+            </a:solidFill>
+            <a:prstDash val="solid"/>
+          </a:ln>
+        </p:spPr>
+      </p:sp>
+      <p:pic>
+        <p:nvPicPr>
+          <p:cNvPr id="29" name="" descr="Figura oficial da documentação dbt usada para explicar: Demonstração — observe — 01."/>
+          <p:cNvPicPr>
+            <a:picLocks xmlns:a="http://schemas.openxmlformats.org/drawingml/2006/main" noChangeAspect="1"/>
+          </p:cNvPicPr>
+          <p:nvPr/>
+        </p:nvPicPr>
+        <p:blipFill>
+          <a:blip xmlns:r="http://schemas.openxmlformats.org/officeDocument/2006/relationships" xmlns:a="http://schemas.openxmlformats.org/drawingml/2006/main" r:embed="R25453ae281c74a00"/>
+          <a:stretch xmlns:a="http://schemas.openxmlformats.org/drawingml/2006/main"/>
+        </p:blipFill>
+        <p:spPr>
+          <a:xfrm xmlns:a="http://schemas.openxmlformats.org/drawingml/2006/main">
+            <a:off x="9893718" y="209550"/>
+            <a:ext cx="1491414" cy="323850"/>
+          </a:xfrm>
+          <a:prstGeom xmlns:a="http://schemas.openxmlformats.org/drawingml/2006/main" prst="rect">
+            <a:avLst/>
+          </a:prstGeom>
+        </p:spPr>
+      </p:pic>
+      <p:sp>
+        <p:nvSpPr>
+          <p:cNvPr id="13" name="footer-rule">
+            <a:extLst xmlns:a="http://schemas.openxmlformats.org/drawingml/2006/main">
+              <a:ext uri="{FF2B5EF4-FFF2-40B4-BE49-F238E27FC236}">
+                <a16:creationId xmlns:a16="http://schemas.microsoft.com/office/drawing/2014/main" id="{26DEAB2A-992C-429D-BCC6-CE01A4CD2457}"/>
               </a:ext>
             </a:extLst>
           </p:cNvPr>
@@ -9868,10 +10450,10 @@
       </p:sp>
       <p:sp>
         <p:nvSpPr>
-          <p:cNvPr id="12" name="footer">
-            <a:extLst xmlns:a="http://schemas.openxmlformats.org/drawingml/2006/main">
-              <a:ext uri="{FF2B5EF4-FFF2-40B4-BE49-F238E27FC236}">
-                <a16:creationId xmlns:a16="http://schemas.microsoft.com/office/drawing/2014/main" id="{F30F11B7-C666-438F-8AEE-06045BC7C6AC}"/>
+          <p:cNvPr id="14" name="footer">
+            <a:extLst xmlns:a="http://schemas.openxmlformats.org/drawingml/2006/main">
+              <a:ext uri="{FF2B5EF4-FFF2-40B4-BE49-F238E27FC236}">
+                <a16:creationId xmlns:a16="http://schemas.microsoft.com/office/drawing/2014/main" id="{E522DB7D-2683-47D9-B336-9606391B87DD}"/>
               </a:ext>
             </a:extLst>
           </p:cNvPr>
@@ -9923,10 +10505,10 @@
       </p:sp>
       <p:sp>
         <p:nvSpPr>
-          <p:cNvPr id="13" name="page-number">
-            <a:extLst xmlns:a="http://schemas.openxmlformats.org/drawingml/2006/main">
-              <a:ext uri="{FF2B5EF4-FFF2-40B4-BE49-F238E27FC236}">
-                <a16:creationId xmlns:a16="http://schemas.microsoft.com/office/drawing/2014/main" id="{93F606E7-04C7-487A-ABE6-44026846E6B5}"/>
+          <p:cNvPr id="15" name="page-number">
+            <a:extLst xmlns:a="http://schemas.openxmlformats.org/drawingml/2006/main">
+              <a:ext uri="{FF2B5EF4-FFF2-40B4-BE49-F238E27FC236}">
+                <a16:creationId xmlns:a16="http://schemas.microsoft.com/office/drawing/2014/main" id="{CC8962AF-0618-4472-914D-98629D85E732}"/>
               </a:ext>
             </a:extLst>
           </p:cNvPr>
@@ -9979,7 +10561,7 @@
     </p:spTree>
     <p:extLst>
       <p:ext uri="{BB962C8B-B14F-4D97-AF65-F5344CB8AC3E}">
-        <p14:creationId xmlns:p14="http://schemas.microsoft.com/office/powerpoint/2010/main" val="1367337187"/>
+        <p14:creationId xmlns:p14="http://schemas.microsoft.com/office/powerpoint/2010/main" val="1280088241"/>
       </p:ext>
     </p:extLst>
   </p:cSld>
@@ -10015,10 +10597,10 @@
       </p:grpSpPr>
       <p:sp>
         <p:nvSpPr>
-          <p:cNvPr id="10" name="result-label">
-            <a:extLst xmlns:a="http://schemas.openxmlformats.org/drawingml/2006/main">
-              <a:ext uri="{FF2B5EF4-FFF2-40B4-BE49-F238E27FC236}">
-                <a16:creationId xmlns:a16="http://schemas.microsoft.com/office/drawing/2014/main" id="{2861F17E-D08B-47D4-9EF1-F998A2928B2B}"/>
+          <p:cNvPr id="12" name="result-label">
+            <a:extLst xmlns:a="http://schemas.openxmlformats.org/drawingml/2006/main">
+              <a:ext uri="{FF2B5EF4-FFF2-40B4-BE49-F238E27FC236}">
+                <a16:creationId xmlns:a16="http://schemas.microsoft.com/office/drawing/2014/main" id="{763824DE-1F24-48CC-9328-B0BAE0D59787}"/>
               </a:ext>
             </a:extLst>
           </p:cNvPr>
@@ -10069,7 +10651,7 @@
           <p:cNvPr id="2" name="result">
             <a:extLst xmlns:a="http://schemas.openxmlformats.org/drawingml/2006/main">
               <a:ext uri="{FF2B5EF4-FFF2-40B4-BE49-F238E27FC236}">
-                <a16:creationId xmlns:a16="http://schemas.microsoft.com/office/drawing/2014/main" id="{A92D2D65-7DB8-4464-B4E1-92069795B836}"/>
+                <a16:creationId xmlns:a16="http://schemas.microsoft.com/office/drawing/2014/main" id="{5BBCBCF0-7640-4CF1-B946-1CB50494EF24}"/>
               </a:ext>
             </a:extLst>
           </p:cNvPr>
@@ -10120,7 +10702,7 @@
           <p:cNvPr id="3" name="result-meta">
             <a:extLst xmlns:a="http://schemas.openxmlformats.org/drawingml/2006/main">
               <a:ext uri="{FF2B5EF4-FFF2-40B4-BE49-F238E27FC236}">
-                <a16:creationId xmlns:a16="http://schemas.microsoft.com/office/drawing/2014/main" id="{C6A189D2-F68B-43F9-8B52-EAEC58BE0F09}"/>
+                <a16:creationId xmlns:a16="http://schemas.microsoft.com/office/drawing/2014/main" id="{F83468A7-EC94-44E4-9B60-06368B12FFC1}"/>
               </a:ext>
             </a:extLst>
           </p:cNvPr>
@@ -10171,7 +10753,7 @@
           <p:cNvPr id="4" name="ambient-glow">
             <a:extLst xmlns:a="http://schemas.openxmlformats.org/drawingml/2006/main">
               <a:ext uri="{FF2B5EF4-FFF2-40B4-BE49-F238E27FC236}">
-                <a16:creationId xmlns:a16="http://schemas.microsoft.com/office/drawing/2014/main" id="{9B9E1ADC-B9E9-4AD2-B281-3F694EE69AD3}"/>
+                <a16:creationId xmlns:a16="http://schemas.microsoft.com/office/drawing/2014/main" id="{13D412B7-7531-4A14-A490-11CE7FA02199}"/>
               </a:ext>
             </a:extLst>
           </p:cNvPr>
@@ -10208,7 +10790,7 @@
           <p:cNvPr id="5" name="ambient-core">
             <a:extLst xmlns:a="http://schemas.openxmlformats.org/drawingml/2006/main">
               <a:ext uri="{FF2B5EF4-FFF2-40B4-BE49-F238E27FC236}">
-                <a16:creationId xmlns:a16="http://schemas.microsoft.com/office/drawing/2014/main" id="{A6A8C325-12D8-4C44-B6B7-ECA2472E0E2A}"/>
+                <a16:creationId xmlns:a16="http://schemas.microsoft.com/office/drawing/2014/main" id="{06D748D0-0CED-4B82-9D5E-C31D65390C5B}"/>
               </a:ext>
             </a:extLst>
           </p:cNvPr>
@@ -10245,7 +10827,7 @@
           <p:cNvPr id="6" name="eyebrow">
             <a:extLst xmlns:a="http://schemas.openxmlformats.org/drawingml/2006/main">
               <a:ext uri="{FF2B5EF4-FFF2-40B4-BE49-F238E27FC236}">
-                <a16:creationId xmlns:a16="http://schemas.microsoft.com/office/drawing/2014/main" id="{5F9821C5-5E45-4F5D-A9A1-3D13335E507B}"/>
+                <a16:creationId xmlns:a16="http://schemas.microsoft.com/office/drawing/2014/main" id="{11DA68FF-5028-4A53-B1EA-7959DB34DAFD}"/>
               </a:ext>
             </a:extLst>
           </p:cNvPr>
@@ -10293,10 +10875,69 @@
       </p:sp>
       <p:sp>
         <p:nvSpPr>
-          <p:cNvPr id="7" name="footer-rule">
-            <a:extLst xmlns:a="http://schemas.openxmlformats.org/drawingml/2006/main">
-              <a:ext uri="{FF2B5EF4-FFF2-40B4-BE49-F238E27FC236}">
-                <a16:creationId xmlns:a16="http://schemas.microsoft.com/office/drawing/2014/main" id="{471E586D-31C8-4ED8-BD3B-C30A0D018C1E}"/>
+          <p:cNvPr id="7" name="rescue-point-logo-background">
+            <a:extLst xmlns:a="http://schemas.openxmlformats.org/drawingml/2006/main">
+              <a:ext uri="{FF2B5EF4-FFF2-40B4-BE49-F238E27FC236}">
+                <a16:creationId xmlns:a16="http://schemas.microsoft.com/office/drawing/2014/main" id="{57902B2C-A5A8-4775-A294-BFE0F2BD0C66}"/>
+              </a:ext>
+            </a:extLst>
+          </p:cNvPr>
+          <p:cNvSpPr>
+            <a:spLocks xmlns:a="http://schemas.openxmlformats.org/drawingml/2006/main" noGrp="1"/>
+          </p:cNvSpPr>
+          <p:nvPr/>
+        </p:nvSpPr>
+        <p:spPr>
+          <a:xfrm xmlns:a="http://schemas.openxmlformats.org/drawingml/2006/main">
+            <a:off x="9772650" y="133350"/>
+            <a:ext cx="1733550" cy="457200"/>
+          </a:xfrm>
+          <a:prstGeom xmlns:a="http://schemas.openxmlformats.org/drawingml/2006/main" prst="roundRect">
+            <a:avLst>
+              <a:gd name="adj" fmla="val 16667"/>
+            </a:avLst>
+          </a:prstGeom>
+          <a:solidFill xmlns:a="http://schemas.openxmlformats.org/drawingml/2006/main">
+            <a:srgbClr val="06142E"/>
+          </a:solidFill>
+          <a:ln xmlns:a="http://schemas.openxmlformats.org/drawingml/2006/main" w="9525">
+            <a:solidFill>
+              <a:srgbClr val="1EC5FF">
+                <a:alpha val="33333"/>
+              </a:srgbClr>
+            </a:solidFill>
+            <a:prstDash val="solid"/>
+          </a:ln>
+        </p:spPr>
+      </p:sp>
+      <p:pic>
+        <p:nvPicPr>
+          <p:cNvPr id="21" name="" descr="Figura oficial da documentação dbt usada para explicar: RESULTADO ESPERADO — Checkpoint 01 OK + exploração gráfica opcional."/>
+          <p:cNvPicPr>
+            <a:picLocks xmlns:a="http://schemas.openxmlformats.org/drawingml/2006/main" noChangeAspect="1"/>
+          </p:cNvPicPr>
+          <p:nvPr/>
+        </p:nvPicPr>
+        <p:blipFill>
+          <a:blip xmlns:r="http://schemas.openxmlformats.org/officeDocument/2006/relationships" xmlns:a="http://schemas.openxmlformats.org/drawingml/2006/main" r:embed="Rf1b8d385d97a4a08"/>
+          <a:stretch xmlns:a="http://schemas.openxmlformats.org/drawingml/2006/main"/>
+        </p:blipFill>
+        <p:spPr>
+          <a:xfrm xmlns:a="http://schemas.openxmlformats.org/drawingml/2006/main">
+            <a:off x="9893718" y="209550"/>
+            <a:ext cx="1491414" cy="323850"/>
+          </a:xfrm>
+          <a:prstGeom xmlns:a="http://schemas.openxmlformats.org/drawingml/2006/main" prst="rect">
+            <a:avLst/>
+          </a:prstGeom>
+        </p:spPr>
+      </p:pic>
+      <p:sp>
+        <p:nvSpPr>
+          <p:cNvPr id="9" name="footer-rule">
+            <a:extLst xmlns:a="http://schemas.openxmlformats.org/drawingml/2006/main">
+              <a:ext uri="{FF2B5EF4-FFF2-40B4-BE49-F238E27FC236}">
+                <a16:creationId xmlns:a16="http://schemas.microsoft.com/office/drawing/2014/main" id="{9CA85F37-5062-47F9-960A-2D9FD45D485C}"/>
               </a:ext>
             </a:extLst>
           </p:cNvPr>
@@ -10326,10 +10967,10 @@
       </p:sp>
       <p:sp>
         <p:nvSpPr>
-          <p:cNvPr id="8" name="footer">
-            <a:extLst xmlns:a="http://schemas.openxmlformats.org/drawingml/2006/main">
-              <a:ext uri="{FF2B5EF4-FFF2-40B4-BE49-F238E27FC236}">
-                <a16:creationId xmlns:a16="http://schemas.microsoft.com/office/drawing/2014/main" id="{571362A0-D2DD-4820-9033-B52924CE0FDE}"/>
+          <p:cNvPr id="10" name="footer">
+            <a:extLst xmlns:a="http://schemas.openxmlformats.org/drawingml/2006/main">
+              <a:ext uri="{FF2B5EF4-FFF2-40B4-BE49-F238E27FC236}">
+                <a16:creationId xmlns:a16="http://schemas.microsoft.com/office/drawing/2014/main" id="{BD9F5FE1-5076-4BF5-A243-FE1C9217A0B8}"/>
               </a:ext>
             </a:extLst>
           </p:cNvPr>
@@ -10381,10 +11022,10 @@
       </p:sp>
       <p:sp>
         <p:nvSpPr>
-          <p:cNvPr id="9" name="page-number">
-            <a:extLst xmlns:a="http://schemas.openxmlformats.org/drawingml/2006/main">
-              <a:ext uri="{FF2B5EF4-FFF2-40B4-BE49-F238E27FC236}">
-                <a16:creationId xmlns:a16="http://schemas.microsoft.com/office/drawing/2014/main" id="{5EDD5DBE-533B-44D4-B3BA-A56E7D63F689}"/>
+          <p:cNvPr id="11" name="page-number">
+            <a:extLst xmlns:a="http://schemas.openxmlformats.org/drawingml/2006/main">
+              <a:ext uri="{FF2B5EF4-FFF2-40B4-BE49-F238E27FC236}">
+                <a16:creationId xmlns:a16="http://schemas.microsoft.com/office/drawing/2014/main" id="{6F5EB1ED-710C-4EEC-A9D8-0128201900EB}"/>
               </a:ext>
             </a:extLst>
           </p:cNvPr>
@@ -10437,7 +11078,7 @@
     </p:spTree>
     <p:extLst>
       <p:ext uri="{BB962C8B-B14F-4D97-AF65-F5344CB8AC3E}">
-        <p14:creationId xmlns:p14="http://schemas.microsoft.com/office/powerpoint/2010/main" val="1354255108"/>
+        <p14:creationId xmlns:p14="http://schemas.microsoft.com/office/powerpoint/2010/main" val="1306411513"/>
       </p:ext>
     </p:extLst>
   </p:cSld>
@@ -10465,10 +11106,10 @@
       </p:grpSpPr>
       <p:sp>
         <p:nvSpPr>
-          <p:cNvPr id="14" name="slide-title">
-            <a:extLst xmlns:a="http://schemas.openxmlformats.org/drawingml/2006/main">
-              <a:ext uri="{FF2B5EF4-FFF2-40B4-BE49-F238E27FC236}">
-                <a16:creationId xmlns:a16="http://schemas.microsoft.com/office/drawing/2014/main" id="{4C95BEDB-14F4-4A25-89C3-B01653FE9210}"/>
+          <p:cNvPr id="16" name="slide-title">
+            <a:extLst xmlns:a="http://schemas.openxmlformats.org/drawingml/2006/main">
+              <a:ext uri="{FF2B5EF4-FFF2-40B4-BE49-F238E27FC236}">
+                <a16:creationId xmlns:a16="http://schemas.microsoft.com/office/drawing/2014/main" id="{567703E9-9586-40B9-9E89-04EBB77D92F4}"/>
               </a:ext>
             </a:extLst>
           </p:cNvPr>
@@ -10519,7 +11160,7 @@
           <p:cNvPr id="2" name="step-num-1">
             <a:extLst xmlns:a="http://schemas.openxmlformats.org/drawingml/2006/main">
               <a:ext uri="{FF2B5EF4-FFF2-40B4-BE49-F238E27FC236}">
-                <a16:creationId xmlns:a16="http://schemas.microsoft.com/office/drawing/2014/main" id="{0BAEACEC-F50A-4B56-93FD-FA6373E878E4}"/>
+                <a16:creationId xmlns:a16="http://schemas.microsoft.com/office/drawing/2014/main" id="{8FF372AD-CC45-4964-ABD7-89F804201A79}"/>
               </a:ext>
             </a:extLst>
           </p:cNvPr>
@@ -10570,7 +11211,7 @@
           <p:cNvPr id="3" name="step-label-1">
             <a:extLst xmlns:a="http://schemas.openxmlformats.org/drawingml/2006/main">
               <a:ext uri="{FF2B5EF4-FFF2-40B4-BE49-F238E27FC236}">
-                <a16:creationId xmlns:a16="http://schemas.microsoft.com/office/drawing/2014/main" id="{2EFD32BB-E41F-420A-81B9-5BF621C0D178}"/>
+                <a16:creationId xmlns:a16="http://schemas.microsoft.com/office/drawing/2014/main" id="{6DE85EAF-1FDD-4D11-89CB-3554F8DCB1C9}"/>
               </a:ext>
             </a:extLst>
           </p:cNvPr>
@@ -10621,7 +11262,7 @@
           <p:cNvPr id="4" name="step-line-1">
             <a:extLst xmlns:a="http://schemas.openxmlformats.org/drawingml/2006/main">
               <a:ext uri="{FF2B5EF4-FFF2-40B4-BE49-F238E27FC236}">
-                <a16:creationId xmlns:a16="http://schemas.microsoft.com/office/drawing/2014/main" id="{73DA9AA0-9D0E-4661-89C1-723A478F8881}"/>
+                <a16:creationId xmlns:a16="http://schemas.microsoft.com/office/drawing/2014/main" id="{D8478129-5C5B-455C-AA73-FE27E73647BE}"/>
               </a:ext>
             </a:extLst>
           </p:cNvPr>
@@ -10652,7 +11293,7 @@
           <p:cNvPr id="5" name="step-num-2">
             <a:extLst xmlns:a="http://schemas.openxmlformats.org/drawingml/2006/main">
               <a:ext uri="{FF2B5EF4-FFF2-40B4-BE49-F238E27FC236}">
-                <a16:creationId xmlns:a16="http://schemas.microsoft.com/office/drawing/2014/main" id="{76D1B589-14B2-48DE-96A2-15E43F60704E}"/>
+                <a16:creationId xmlns:a16="http://schemas.microsoft.com/office/drawing/2014/main" id="{61F6B08A-01A0-493D-854C-4FACE5E56417}"/>
               </a:ext>
             </a:extLst>
           </p:cNvPr>
@@ -10703,7 +11344,7 @@
           <p:cNvPr id="6" name="step-label-2">
             <a:extLst xmlns:a="http://schemas.openxmlformats.org/drawingml/2006/main">
               <a:ext uri="{FF2B5EF4-FFF2-40B4-BE49-F238E27FC236}">
-                <a16:creationId xmlns:a16="http://schemas.microsoft.com/office/drawing/2014/main" id="{1932228E-D658-4E4B-BB0E-E2C7CEBB2D4A}"/>
+                <a16:creationId xmlns:a16="http://schemas.microsoft.com/office/drawing/2014/main" id="{7F36B5BB-0800-44B8-ACB5-BA6FA9EB6124}"/>
               </a:ext>
             </a:extLst>
           </p:cNvPr>
@@ -10754,7 +11395,7 @@
           <p:cNvPr id="7" name="step-line-2">
             <a:extLst xmlns:a="http://schemas.openxmlformats.org/drawingml/2006/main">
               <a:ext uri="{FF2B5EF4-FFF2-40B4-BE49-F238E27FC236}">
-                <a16:creationId xmlns:a16="http://schemas.microsoft.com/office/drawing/2014/main" id="{6ABA1B6B-2C33-4090-94ED-EE228890E70A}"/>
+                <a16:creationId xmlns:a16="http://schemas.microsoft.com/office/drawing/2014/main" id="{1D1338A2-DE37-498A-9065-7C7A2D7DA72F}"/>
               </a:ext>
             </a:extLst>
           </p:cNvPr>
@@ -10785,7 +11426,7 @@
           <p:cNvPr id="8" name="step-num-3">
             <a:extLst xmlns:a="http://schemas.openxmlformats.org/drawingml/2006/main">
               <a:ext uri="{FF2B5EF4-FFF2-40B4-BE49-F238E27FC236}">
-                <a16:creationId xmlns:a16="http://schemas.microsoft.com/office/drawing/2014/main" id="{193AC7F8-F159-44C6-AEB0-01E931515B66}"/>
+                <a16:creationId xmlns:a16="http://schemas.microsoft.com/office/drawing/2014/main" id="{E91ADE04-E0E2-418D-B6BD-B1B2FA138B8A}"/>
               </a:ext>
             </a:extLst>
           </p:cNvPr>
@@ -10836,7 +11477,7 @@
           <p:cNvPr id="9" name="step-label-3">
             <a:extLst xmlns:a="http://schemas.openxmlformats.org/drawingml/2006/main">
               <a:ext uri="{FF2B5EF4-FFF2-40B4-BE49-F238E27FC236}">
-                <a16:creationId xmlns:a16="http://schemas.microsoft.com/office/drawing/2014/main" id="{A87CC742-12DE-479A-B50E-83863E9D6966}"/>
+                <a16:creationId xmlns:a16="http://schemas.microsoft.com/office/drawing/2014/main" id="{BBC914A1-8EC8-4C94-91D5-9E9B5C48D617}"/>
               </a:ext>
             </a:extLst>
           </p:cNvPr>
@@ -10887,7 +11528,7 @@
           <p:cNvPr id="10" name="eyebrow">
             <a:extLst xmlns:a="http://schemas.openxmlformats.org/drawingml/2006/main">
               <a:ext uri="{FF2B5EF4-FFF2-40B4-BE49-F238E27FC236}">
-                <a16:creationId xmlns:a16="http://schemas.microsoft.com/office/drawing/2014/main" id="{6F6852D6-2808-41DA-83DE-A9E41DEA1CA8}"/>
+                <a16:creationId xmlns:a16="http://schemas.microsoft.com/office/drawing/2014/main" id="{FE67ABE8-AAC2-4D0C-B7ED-C5227F97169D}"/>
               </a:ext>
             </a:extLst>
           </p:cNvPr>
@@ -10935,10 +11576,69 @@
       </p:sp>
       <p:sp>
         <p:nvSpPr>
-          <p:cNvPr id="11" name="footer-rule">
-            <a:extLst xmlns:a="http://schemas.openxmlformats.org/drawingml/2006/main">
-              <a:ext uri="{FF2B5EF4-FFF2-40B4-BE49-F238E27FC236}">
-                <a16:creationId xmlns:a16="http://schemas.microsoft.com/office/drawing/2014/main" id="{24A23026-8A30-48AF-BF98-31FEEA828D56}"/>
+          <p:cNvPr id="11" name="rescue-point-logo-background">
+            <a:extLst xmlns:a="http://schemas.openxmlformats.org/drawingml/2006/main">
+              <a:ext uri="{FF2B5EF4-FFF2-40B4-BE49-F238E27FC236}">
+                <a16:creationId xmlns:a16="http://schemas.microsoft.com/office/drawing/2014/main" id="{6A9E2D65-43F5-427E-B910-0F02169D5017}"/>
+              </a:ext>
+            </a:extLst>
+          </p:cNvPr>
+          <p:cNvSpPr>
+            <a:spLocks xmlns:a="http://schemas.openxmlformats.org/drawingml/2006/main" noGrp="1"/>
+          </p:cNvSpPr>
+          <p:nvPr/>
+        </p:nvSpPr>
+        <p:spPr>
+          <a:xfrm xmlns:a="http://schemas.openxmlformats.org/drawingml/2006/main">
+            <a:off x="9772650" y="133350"/>
+            <a:ext cx="1733550" cy="457200"/>
+          </a:xfrm>
+          <a:prstGeom xmlns:a="http://schemas.openxmlformats.org/drawingml/2006/main" prst="roundRect">
+            <a:avLst>
+              <a:gd name="adj" fmla="val 16667"/>
+            </a:avLst>
+          </a:prstGeom>
+          <a:solidFill xmlns:a="http://schemas.openxmlformats.org/drawingml/2006/main">
+            <a:srgbClr val="06142E"/>
+          </a:solidFill>
+          <a:ln xmlns:a="http://schemas.openxmlformats.org/drawingml/2006/main" w="9525">
+            <a:solidFill>
+              <a:srgbClr val="1EC5FF">
+                <a:alpha val="33333"/>
+              </a:srgbClr>
+            </a:solidFill>
+            <a:prstDash val="solid"/>
+          </a:ln>
+        </p:spPr>
+      </p:sp>
+      <p:pic>
+        <p:nvPicPr>
+          <p:cNvPr id="29" name="" descr="Figura oficial da documentação dbt usada para explicar: O mesmo recurso afeta três decisões — 01."/>
+          <p:cNvPicPr>
+            <a:picLocks xmlns:a="http://schemas.openxmlformats.org/drawingml/2006/main" noChangeAspect="1"/>
+          </p:cNvPicPr>
+          <p:nvPr/>
+        </p:nvPicPr>
+        <p:blipFill>
+          <a:blip xmlns:r="http://schemas.openxmlformats.org/officeDocument/2006/relationships" xmlns:a="http://schemas.openxmlformats.org/drawingml/2006/main" r:embed="Rcf89a58718714a95"/>
+          <a:stretch xmlns:a="http://schemas.openxmlformats.org/drawingml/2006/main"/>
+        </p:blipFill>
+        <p:spPr>
+          <a:xfrm xmlns:a="http://schemas.openxmlformats.org/drawingml/2006/main">
+            <a:off x="9893718" y="209550"/>
+            <a:ext cx="1491414" cy="323850"/>
+          </a:xfrm>
+          <a:prstGeom xmlns:a="http://schemas.openxmlformats.org/drawingml/2006/main" prst="rect">
+            <a:avLst/>
+          </a:prstGeom>
+        </p:spPr>
+      </p:pic>
+      <p:sp>
+        <p:nvSpPr>
+          <p:cNvPr id="13" name="footer-rule">
+            <a:extLst xmlns:a="http://schemas.openxmlformats.org/drawingml/2006/main">
+              <a:ext uri="{FF2B5EF4-FFF2-40B4-BE49-F238E27FC236}">
+                <a16:creationId xmlns:a16="http://schemas.microsoft.com/office/drawing/2014/main" id="{D32D4B3E-4338-4CFD-B334-DC878ACC8568}"/>
               </a:ext>
             </a:extLst>
           </p:cNvPr>
@@ -10968,10 +11668,10 @@
       </p:sp>
       <p:sp>
         <p:nvSpPr>
-          <p:cNvPr id="12" name="footer">
-            <a:extLst xmlns:a="http://schemas.openxmlformats.org/drawingml/2006/main">
-              <a:ext uri="{FF2B5EF4-FFF2-40B4-BE49-F238E27FC236}">
-                <a16:creationId xmlns:a16="http://schemas.microsoft.com/office/drawing/2014/main" id="{5024C753-3152-4839-8715-D02056A6D18C}"/>
+          <p:cNvPr id="14" name="footer">
+            <a:extLst xmlns:a="http://schemas.openxmlformats.org/drawingml/2006/main">
+              <a:ext uri="{FF2B5EF4-FFF2-40B4-BE49-F238E27FC236}">
+                <a16:creationId xmlns:a16="http://schemas.microsoft.com/office/drawing/2014/main" id="{39CBEBA9-44D1-4380-B3E3-31A0AA9C35E1}"/>
               </a:ext>
             </a:extLst>
           </p:cNvPr>
@@ -11023,10 +11723,10 @@
       </p:sp>
       <p:sp>
         <p:nvSpPr>
-          <p:cNvPr id="13" name="page-number">
-            <a:extLst xmlns:a="http://schemas.openxmlformats.org/drawingml/2006/main">
-              <a:ext uri="{FF2B5EF4-FFF2-40B4-BE49-F238E27FC236}">
-                <a16:creationId xmlns:a16="http://schemas.microsoft.com/office/drawing/2014/main" id="{B2455E04-1C26-466F-998C-3B12F63A690E}"/>
+          <p:cNvPr id="15" name="page-number">
+            <a:extLst xmlns:a="http://schemas.openxmlformats.org/drawingml/2006/main">
+              <a:ext uri="{FF2B5EF4-FFF2-40B4-BE49-F238E27FC236}">
+                <a16:creationId xmlns:a16="http://schemas.microsoft.com/office/drawing/2014/main" id="{1B7413BA-66B3-439F-8990-C1E2A9BDF5A7}"/>
               </a:ext>
             </a:extLst>
           </p:cNvPr>
@@ -11079,7 +11779,7 @@
     </p:spTree>
     <p:extLst>
       <p:ext uri="{BB962C8B-B14F-4D97-AF65-F5344CB8AC3E}">
-        <p14:creationId xmlns:p14="http://schemas.microsoft.com/office/powerpoint/2010/main" val="161006096"/>
+        <p14:creationId xmlns:p14="http://schemas.microsoft.com/office/powerpoint/2010/main" val="368034344"/>
       </p:ext>
     </p:extLst>
   </p:cSld>
@@ -11115,10 +11815,10 @@
       </p:grpSpPr>
       <p:sp>
         <p:nvSpPr>
-          <p:cNvPr id="9" name="case-number">
-            <a:extLst xmlns:a="http://schemas.openxmlformats.org/drawingml/2006/main">
-              <a:ext uri="{FF2B5EF4-FFF2-40B4-BE49-F238E27FC236}">
-                <a16:creationId xmlns:a16="http://schemas.microsoft.com/office/drawing/2014/main" id="{E3CEFC2A-AC69-4717-8712-FA78DA1B4C2B}"/>
+          <p:cNvPr id="11" name="case-number">
+            <a:extLst xmlns:a="http://schemas.openxmlformats.org/drawingml/2006/main">
+              <a:ext uri="{FF2B5EF4-FFF2-40B4-BE49-F238E27FC236}">
+                <a16:creationId xmlns:a16="http://schemas.microsoft.com/office/drawing/2014/main" id="{4B90CF87-9DF6-469E-9312-0CFBA2885E0A}"/>
               </a:ext>
             </a:extLst>
           </p:cNvPr>
@@ -11169,7 +11869,7 @@
           <p:cNvPr id="2" name="case-label">
             <a:extLst xmlns:a="http://schemas.openxmlformats.org/drawingml/2006/main">
               <a:ext uri="{FF2B5EF4-FFF2-40B4-BE49-F238E27FC236}">
-                <a16:creationId xmlns:a16="http://schemas.microsoft.com/office/drawing/2014/main" id="{7CC40724-402D-4FA5-8F72-EF85B02AB04A}"/>
+                <a16:creationId xmlns:a16="http://schemas.microsoft.com/office/drawing/2014/main" id="{48C47351-1317-4DDF-8CA5-EC4BDA11FF72}"/>
               </a:ext>
             </a:extLst>
           </p:cNvPr>
@@ -11220,7 +11920,7 @@
           <p:cNvPr id="3" name="case-divider">
             <a:extLst xmlns:a="http://schemas.openxmlformats.org/drawingml/2006/main">
               <a:ext uri="{FF2B5EF4-FFF2-40B4-BE49-F238E27FC236}">
-                <a16:creationId xmlns:a16="http://schemas.microsoft.com/office/drawing/2014/main" id="{608792F7-8F46-4FDC-BBD1-91A9424796B9}"/>
+                <a16:creationId xmlns:a16="http://schemas.microsoft.com/office/drawing/2014/main" id="{E060D826-BE5E-4357-A986-5F692F5A1607}"/>
               </a:ext>
             </a:extLst>
           </p:cNvPr>
@@ -11253,7 +11953,7 @@
           <p:cNvPr id="4" name="case-caveat">
             <a:extLst xmlns:a="http://schemas.openxmlformats.org/drawingml/2006/main">
               <a:ext uri="{FF2B5EF4-FFF2-40B4-BE49-F238E27FC236}">
-                <a16:creationId xmlns:a16="http://schemas.microsoft.com/office/drawing/2014/main" id="{7ED7A4E5-4A6A-4E30-B542-889D967DE23C}"/>
+                <a16:creationId xmlns:a16="http://schemas.microsoft.com/office/drawing/2014/main" id="{23018F2D-2A36-4981-A838-B86F78EED679}"/>
               </a:ext>
             </a:extLst>
           </p:cNvPr>
@@ -11304,7 +12004,7 @@
           <p:cNvPr id="5" name="eyebrow">
             <a:extLst xmlns:a="http://schemas.openxmlformats.org/drawingml/2006/main">
               <a:ext uri="{FF2B5EF4-FFF2-40B4-BE49-F238E27FC236}">
-                <a16:creationId xmlns:a16="http://schemas.microsoft.com/office/drawing/2014/main" id="{8CC86997-197D-45C1-80FF-D7546D728912}"/>
+                <a16:creationId xmlns:a16="http://schemas.microsoft.com/office/drawing/2014/main" id="{A3B2BFBC-BE1C-4274-B523-3408C8BA9B24}"/>
               </a:ext>
             </a:extLst>
           </p:cNvPr>
@@ -11352,10 +12052,69 @@
       </p:sp>
       <p:sp>
         <p:nvSpPr>
-          <p:cNvPr id="6" name="footer-rule">
-            <a:extLst xmlns:a="http://schemas.openxmlformats.org/drawingml/2006/main">
-              <a:ext uri="{FF2B5EF4-FFF2-40B4-BE49-F238E27FC236}">
-                <a16:creationId xmlns:a16="http://schemas.microsoft.com/office/drawing/2014/main" id="{0FBFDAC5-437E-46CC-B54B-44D8730235B4}"/>
+          <p:cNvPr id="6" name="rescue-point-logo-background">
+            <a:extLst xmlns:a="http://schemas.openxmlformats.org/drawingml/2006/main">
+              <a:ext uri="{FF2B5EF4-FFF2-40B4-BE49-F238E27FC236}">
+                <a16:creationId xmlns:a16="http://schemas.microsoft.com/office/drawing/2014/main" id="{43C559E1-2B9F-4481-8535-16AC0BC1C7E0}"/>
+              </a:ext>
+            </a:extLst>
+          </p:cNvPr>
+          <p:cNvSpPr>
+            <a:spLocks xmlns:a="http://schemas.openxmlformats.org/drawingml/2006/main" noGrp="1"/>
+          </p:cNvSpPr>
+          <p:nvPr/>
+        </p:nvSpPr>
+        <p:spPr>
+          <a:xfrm xmlns:a="http://schemas.openxmlformats.org/drawingml/2006/main">
+            <a:off x="9772650" y="133350"/>
+            <a:ext cx="1733550" cy="457200"/>
+          </a:xfrm>
+          <a:prstGeom xmlns:a="http://schemas.openxmlformats.org/drawingml/2006/main" prst="roundRect">
+            <a:avLst>
+              <a:gd name="adj" fmla="val 16667"/>
+            </a:avLst>
+          </a:prstGeom>
+          <a:solidFill xmlns:a="http://schemas.openxmlformats.org/drawingml/2006/main">
+            <a:srgbClr val="06142E"/>
+          </a:solidFill>
+          <a:ln xmlns:a="http://schemas.openxmlformats.org/drawingml/2006/main" w="9525">
+            <a:solidFill>
+              <a:srgbClr val="1EC5FF">
+                <a:alpha val="33333"/>
+              </a:srgbClr>
+            </a:solidFill>
+            <a:prstDash val="solid"/>
+          </a:ln>
+        </p:spPr>
+      </p:sp>
+      <p:pic>
+        <p:nvPicPr>
+          <p:cNvPr id="19" name="" descr="Figura oficial da documentação dbt usada para explicar: 46 recursos — baseline dbt validado localmente."/>
+          <p:cNvPicPr>
+            <a:picLocks xmlns:a="http://schemas.openxmlformats.org/drawingml/2006/main" noChangeAspect="1"/>
+          </p:cNvPicPr>
+          <p:nvPr/>
+        </p:nvPicPr>
+        <p:blipFill>
+          <a:blip xmlns:r="http://schemas.openxmlformats.org/officeDocument/2006/relationships" xmlns:a="http://schemas.openxmlformats.org/drawingml/2006/main" r:embed="Ra80b16d889244802"/>
+          <a:stretch xmlns:a="http://schemas.openxmlformats.org/drawingml/2006/main"/>
+        </p:blipFill>
+        <p:spPr>
+          <a:xfrm xmlns:a="http://schemas.openxmlformats.org/drawingml/2006/main">
+            <a:off x="9893718" y="209550"/>
+            <a:ext cx="1491414" cy="323850"/>
+          </a:xfrm>
+          <a:prstGeom xmlns:a="http://schemas.openxmlformats.org/drawingml/2006/main" prst="rect">
+            <a:avLst/>
+          </a:prstGeom>
+        </p:spPr>
+      </p:pic>
+      <p:sp>
+        <p:nvSpPr>
+          <p:cNvPr id="8" name="footer-rule">
+            <a:extLst xmlns:a="http://schemas.openxmlformats.org/drawingml/2006/main">
+              <a:ext uri="{FF2B5EF4-FFF2-40B4-BE49-F238E27FC236}">
+                <a16:creationId xmlns:a16="http://schemas.microsoft.com/office/drawing/2014/main" id="{78FFC82A-1BDA-4614-B5A5-04915554CF8B}"/>
               </a:ext>
             </a:extLst>
           </p:cNvPr>
@@ -11385,10 +12144,10 @@
       </p:sp>
       <p:sp>
         <p:nvSpPr>
-          <p:cNvPr id="7" name="footer">
-            <a:extLst xmlns:a="http://schemas.openxmlformats.org/drawingml/2006/main">
-              <a:ext uri="{FF2B5EF4-FFF2-40B4-BE49-F238E27FC236}">
-                <a16:creationId xmlns:a16="http://schemas.microsoft.com/office/drawing/2014/main" id="{3285A7A0-3A78-4D33-B665-C7141CBFA396}"/>
+          <p:cNvPr id="9" name="footer">
+            <a:extLst xmlns:a="http://schemas.openxmlformats.org/drawingml/2006/main">
+              <a:ext uri="{FF2B5EF4-FFF2-40B4-BE49-F238E27FC236}">
+                <a16:creationId xmlns:a16="http://schemas.microsoft.com/office/drawing/2014/main" id="{6DFA3B4A-3E49-4316-AECA-DFBDDC6B90DC}"/>
               </a:ext>
             </a:extLst>
           </p:cNvPr>
@@ -11440,10 +12199,10 @@
       </p:sp>
       <p:sp>
         <p:nvSpPr>
-          <p:cNvPr id="8" name="page-number">
-            <a:extLst xmlns:a="http://schemas.openxmlformats.org/drawingml/2006/main">
-              <a:ext uri="{FF2B5EF4-FFF2-40B4-BE49-F238E27FC236}">
-                <a16:creationId xmlns:a16="http://schemas.microsoft.com/office/drawing/2014/main" id="{59F10D3B-CF84-43DC-B81D-DC3FB1D961B5}"/>
+          <p:cNvPr id="10" name="page-number">
+            <a:extLst xmlns:a="http://schemas.openxmlformats.org/drawingml/2006/main">
+              <a:ext uri="{FF2B5EF4-FFF2-40B4-BE49-F238E27FC236}">
+                <a16:creationId xmlns:a16="http://schemas.microsoft.com/office/drawing/2014/main" id="{2FC90003-92FB-43C4-8D67-F9C5C5E89ED8}"/>
               </a:ext>
             </a:extLst>
           </p:cNvPr>
@@ -11496,7 +12255,7 @@
     </p:spTree>
     <p:extLst>
       <p:ext uri="{BB962C8B-B14F-4D97-AF65-F5344CB8AC3E}">
-        <p14:creationId xmlns:p14="http://schemas.microsoft.com/office/powerpoint/2010/main" val="2008790364"/>
+        <p14:creationId xmlns:p14="http://schemas.microsoft.com/office/powerpoint/2010/main" val="351427737"/>
       </p:ext>
     </p:extLst>
   </p:cSld>
@@ -11524,10 +12283,10 @@
       </p:grpSpPr>
       <p:sp>
         <p:nvSpPr>
-          <p:cNvPr id="10" name="hook">
-            <a:extLst xmlns:a="http://schemas.openxmlformats.org/drawingml/2006/main">
-              <a:ext uri="{FF2B5EF4-FFF2-40B4-BE49-F238E27FC236}">
-                <a16:creationId xmlns:a16="http://schemas.microsoft.com/office/drawing/2014/main" id="{637B2E66-0F74-4EAA-BB62-7EBC2C5D5D7A}"/>
+          <p:cNvPr id="12" name="hook">
+            <a:extLst xmlns:a="http://schemas.openxmlformats.org/drawingml/2006/main">
+              <a:ext uri="{FF2B5EF4-FFF2-40B4-BE49-F238E27FC236}">
+                <a16:creationId xmlns:a16="http://schemas.microsoft.com/office/drawing/2014/main" id="{B766B9CD-19B6-4079-8F5A-92A03DF85DD5}"/>
               </a:ext>
             </a:extLst>
           </p:cNvPr>
@@ -11578,7 +12337,7 @@
           <p:cNvPr id="2" name="hook-rule">
             <a:extLst xmlns:a="http://schemas.openxmlformats.org/drawingml/2006/main">
               <a:ext uri="{FF2B5EF4-FFF2-40B4-BE49-F238E27FC236}">
-                <a16:creationId xmlns:a16="http://schemas.microsoft.com/office/drawing/2014/main" id="{B116CDF8-6D98-415D-8CB5-754A0FFA9C9F}"/>
+                <a16:creationId xmlns:a16="http://schemas.microsoft.com/office/drawing/2014/main" id="{77E96025-E19C-4AA5-A553-EF8425283C5F}"/>
               </a:ext>
             </a:extLst>
           </p:cNvPr>
@@ -11609,7 +12368,7 @@
           <p:cNvPr id="3" name="hook-label">
             <a:extLst xmlns:a="http://schemas.openxmlformats.org/drawingml/2006/main">
               <a:ext uri="{FF2B5EF4-FFF2-40B4-BE49-F238E27FC236}">
-                <a16:creationId xmlns:a16="http://schemas.microsoft.com/office/drawing/2014/main" id="{4DA801B0-380E-40DF-BDCB-869DF4422013}"/>
+                <a16:creationId xmlns:a16="http://schemas.microsoft.com/office/drawing/2014/main" id="{B21AA22F-F048-43CE-80E1-CFECA9A3221A}"/>
               </a:ext>
             </a:extLst>
           </p:cNvPr>
@@ -11660,7 +12419,7 @@
           <p:cNvPr id="4" name="diagram-surface">
             <a:extLst xmlns:a="http://schemas.openxmlformats.org/drawingml/2006/main">
               <a:ext uri="{FF2B5EF4-FFF2-40B4-BE49-F238E27FC236}">
-                <a16:creationId xmlns:a16="http://schemas.microsoft.com/office/drawing/2014/main" id="{9A6A8C62-C8C9-421B-B7D2-549691500BE2}"/>
+                <a16:creationId xmlns:a16="http://schemas.microsoft.com/office/drawing/2014/main" id="{A3C34C00-5265-4B81-82C7-7D90FAF2D489}"/>
               </a:ext>
             </a:extLst>
           </p:cNvPr>
@@ -11692,14 +12451,14 @@
       </p:sp>
       <p:pic>
         <p:nvPicPr>
-          <p:cNvPr id="16" name="" descr="Diagrama didático autoral que apresenta: Um ambiente padronizado reduz o suporte e deixa a aula começar pelo dbt — não pela instalação. — A pergunta que guia a aula."/>
+          <p:cNvPr id="19" name="" descr="Diagrama didático autoral que apresenta: Um ambiente padronizado reduz o suporte e deixa a aula começar pelo dbt — não pela instalação. — A pergunta que guia a aula."/>
           <p:cNvPicPr>
             <a:picLocks xmlns:a="http://schemas.openxmlformats.org/drawingml/2006/main" noChangeAspect="1"/>
           </p:cNvPicPr>
           <p:nvPr/>
         </p:nvPicPr>
         <p:blipFill>
-          <a:blip xmlns:r="http://schemas.openxmlformats.org/officeDocument/2006/relationships" xmlns:a="http://schemas.openxmlformats.org/drawingml/2006/main" r:embed="Rf0ef289c8e7f4577"/>
+          <a:blip xmlns:r="http://schemas.openxmlformats.org/officeDocument/2006/relationships" xmlns:a="http://schemas.openxmlformats.org/drawingml/2006/main" r:embed="Rebdbed357ea244f9"/>
           <a:stretch xmlns:a="http://schemas.openxmlformats.org/drawingml/2006/main"/>
         </p:blipFill>
         <p:spPr>
@@ -11717,7 +12476,7 @@
           <p:cNvPr id="6" name="eyebrow">
             <a:extLst xmlns:a="http://schemas.openxmlformats.org/drawingml/2006/main">
               <a:ext uri="{FF2B5EF4-FFF2-40B4-BE49-F238E27FC236}">
-                <a16:creationId xmlns:a16="http://schemas.microsoft.com/office/drawing/2014/main" id="{597BBD45-A1D7-4241-84FC-06F52C0C84FB}"/>
+                <a16:creationId xmlns:a16="http://schemas.microsoft.com/office/drawing/2014/main" id="{691CA237-79B7-4FE8-9255-949D002E3678}"/>
               </a:ext>
             </a:extLst>
           </p:cNvPr>
@@ -11765,10 +12524,69 @@
       </p:sp>
       <p:sp>
         <p:nvSpPr>
-          <p:cNvPr id="7" name="footer-rule">
-            <a:extLst xmlns:a="http://schemas.openxmlformats.org/drawingml/2006/main">
-              <a:ext uri="{FF2B5EF4-FFF2-40B4-BE49-F238E27FC236}">
-                <a16:creationId xmlns:a16="http://schemas.microsoft.com/office/drawing/2014/main" id="{E48ED884-3351-4567-A5F5-B781B0937550}"/>
+          <p:cNvPr id="7" name="rescue-point-logo-background">
+            <a:extLst xmlns:a="http://schemas.openxmlformats.org/drawingml/2006/main">
+              <a:ext uri="{FF2B5EF4-FFF2-40B4-BE49-F238E27FC236}">
+                <a16:creationId xmlns:a16="http://schemas.microsoft.com/office/drawing/2014/main" id="{7D5DDCB7-C7FC-4206-A0F2-AE7C3032C7A8}"/>
+              </a:ext>
+            </a:extLst>
+          </p:cNvPr>
+          <p:cNvSpPr>
+            <a:spLocks xmlns:a="http://schemas.openxmlformats.org/drawingml/2006/main" noGrp="1"/>
+          </p:cNvSpPr>
+          <p:nvPr/>
+        </p:nvSpPr>
+        <p:spPr>
+          <a:xfrm xmlns:a="http://schemas.openxmlformats.org/drawingml/2006/main">
+            <a:off x="9772650" y="133350"/>
+            <a:ext cx="1733550" cy="457200"/>
+          </a:xfrm>
+          <a:prstGeom xmlns:a="http://schemas.openxmlformats.org/drawingml/2006/main" prst="roundRect">
+            <a:avLst>
+              <a:gd name="adj" fmla="val 16667"/>
+            </a:avLst>
+          </a:prstGeom>
+          <a:solidFill xmlns:a="http://schemas.openxmlformats.org/drawingml/2006/main">
+            <a:srgbClr val="06142E"/>
+          </a:solidFill>
+          <a:ln xmlns:a="http://schemas.openxmlformats.org/drawingml/2006/main" w="9525">
+            <a:solidFill>
+              <a:srgbClr val="1EC5FF">
+                <a:alpha val="33333"/>
+              </a:srgbClr>
+            </a:solidFill>
+            <a:prstDash val="solid"/>
+          </a:ln>
+        </p:spPr>
+      </p:sp>
+      <p:pic>
+        <p:nvPicPr>
+          <p:cNvPr id="22" name="" descr="Diagrama didático autoral que apresenta: Um ambiente padronizado reduz o suporte e deixa a aula começar pelo dbt — não pela instalação. — A pergunta que guia a aula."/>
+          <p:cNvPicPr>
+            <a:picLocks xmlns:a="http://schemas.openxmlformats.org/drawingml/2006/main" noChangeAspect="1"/>
+          </p:cNvPicPr>
+          <p:nvPr/>
+        </p:nvPicPr>
+        <p:blipFill>
+          <a:blip xmlns:r="http://schemas.openxmlformats.org/officeDocument/2006/relationships" xmlns:a="http://schemas.openxmlformats.org/drawingml/2006/main" r:embed="R2b2f97cd383444a6"/>
+          <a:stretch xmlns:a="http://schemas.openxmlformats.org/drawingml/2006/main"/>
+        </p:blipFill>
+        <p:spPr>
+          <a:xfrm xmlns:a="http://schemas.openxmlformats.org/drawingml/2006/main">
+            <a:off x="9893718" y="209550"/>
+            <a:ext cx="1491414" cy="323850"/>
+          </a:xfrm>
+          <a:prstGeom xmlns:a="http://schemas.openxmlformats.org/drawingml/2006/main" prst="rect">
+            <a:avLst/>
+          </a:prstGeom>
+        </p:spPr>
+      </p:pic>
+      <p:sp>
+        <p:nvSpPr>
+          <p:cNvPr id="9" name="footer-rule">
+            <a:extLst xmlns:a="http://schemas.openxmlformats.org/drawingml/2006/main">
+              <a:ext uri="{FF2B5EF4-FFF2-40B4-BE49-F238E27FC236}">
+                <a16:creationId xmlns:a16="http://schemas.microsoft.com/office/drawing/2014/main" id="{A02611CC-3F20-4B6D-A5AB-C7157613A38B}"/>
               </a:ext>
             </a:extLst>
           </p:cNvPr>
@@ -11798,10 +12616,10 @@
       </p:sp>
       <p:sp>
         <p:nvSpPr>
-          <p:cNvPr id="8" name="footer">
-            <a:extLst xmlns:a="http://schemas.openxmlformats.org/drawingml/2006/main">
-              <a:ext uri="{FF2B5EF4-FFF2-40B4-BE49-F238E27FC236}">
-                <a16:creationId xmlns:a16="http://schemas.microsoft.com/office/drawing/2014/main" id="{5685C86F-77E9-44AF-91F4-0F1B6FF1B48E}"/>
+          <p:cNvPr id="10" name="footer">
+            <a:extLst xmlns:a="http://schemas.openxmlformats.org/drawingml/2006/main">
+              <a:ext uri="{FF2B5EF4-FFF2-40B4-BE49-F238E27FC236}">
+                <a16:creationId xmlns:a16="http://schemas.microsoft.com/office/drawing/2014/main" id="{2D0E2D20-BB55-4A03-8961-7E04334DADDB}"/>
               </a:ext>
             </a:extLst>
           </p:cNvPr>
@@ -11853,10 +12671,10 @@
       </p:sp>
       <p:sp>
         <p:nvSpPr>
-          <p:cNvPr id="9" name="page-number">
-            <a:extLst xmlns:a="http://schemas.openxmlformats.org/drawingml/2006/main">
-              <a:ext uri="{FF2B5EF4-FFF2-40B4-BE49-F238E27FC236}">
-                <a16:creationId xmlns:a16="http://schemas.microsoft.com/office/drawing/2014/main" id="{DEDDDF3B-1966-4445-8B89-4091FEDA1DE4}"/>
+          <p:cNvPr id="11" name="page-number">
+            <a:extLst xmlns:a="http://schemas.openxmlformats.org/drawingml/2006/main">
+              <a:ext uri="{FF2B5EF4-FFF2-40B4-BE49-F238E27FC236}">
+                <a16:creationId xmlns:a16="http://schemas.microsoft.com/office/drawing/2014/main" id="{9EEEAB6D-9ADE-4C4F-B99E-01FD11BBFD84}"/>
               </a:ext>
             </a:extLst>
           </p:cNvPr>
@@ -11909,7 +12727,7 @@
     </p:spTree>
     <p:extLst>
       <p:ext uri="{BB962C8B-B14F-4D97-AF65-F5344CB8AC3E}">
-        <p14:creationId xmlns:p14="http://schemas.microsoft.com/office/powerpoint/2010/main" val="964765875"/>
+        <p14:creationId xmlns:p14="http://schemas.microsoft.com/office/powerpoint/2010/main" val="3529947"/>
       </p:ext>
     </p:extLst>
   </p:cSld>
@@ -11937,10 +12755,10 @@
       </p:grpSpPr>
       <p:sp>
         <p:nvSpPr>
-          <p:cNvPr id="7" name="slide-title">
-            <a:extLst xmlns:a="http://schemas.openxmlformats.org/drawingml/2006/main">
-              <a:ext uri="{FF2B5EF4-FFF2-40B4-BE49-F238E27FC236}">
-                <a16:creationId xmlns:a16="http://schemas.microsoft.com/office/drawing/2014/main" id="{77BD6EBA-4456-4EB3-8FCB-FBB0EAF793DA}"/>
+          <p:cNvPr id="9" name="slide-title">
+            <a:extLst xmlns:a="http://schemas.openxmlformats.org/drawingml/2006/main">
+              <a:ext uri="{FF2B5EF4-FFF2-40B4-BE49-F238E27FC236}">
+                <a16:creationId xmlns:a16="http://schemas.microsoft.com/office/drawing/2014/main" id="{B5F7FF97-C422-4782-8FFF-355A99322880}"/>
               </a:ext>
             </a:extLst>
           </p:cNvPr>
@@ -11991,7 +12809,7 @@
           <p:cNvPr id="2" name="bullets">
             <a:extLst xmlns:a="http://schemas.openxmlformats.org/drawingml/2006/main">
               <a:ext uri="{FF2B5EF4-FFF2-40B4-BE49-F238E27FC236}">
-                <a16:creationId xmlns:a16="http://schemas.microsoft.com/office/drawing/2014/main" id="{CD0408F1-46BB-4C3A-8875-80081CE0805D}"/>
+                <a16:creationId xmlns:a16="http://schemas.microsoft.com/office/drawing/2014/main" id="{3C47ACB8-BB62-4560-9733-0209A86BAFF5}"/>
               </a:ext>
             </a:extLst>
           </p:cNvPr>
@@ -12096,7 +12914,7 @@
           <p:cNvPr id="3" name="eyebrow">
             <a:extLst xmlns:a="http://schemas.openxmlformats.org/drawingml/2006/main">
               <a:ext uri="{FF2B5EF4-FFF2-40B4-BE49-F238E27FC236}">
-                <a16:creationId xmlns:a16="http://schemas.microsoft.com/office/drawing/2014/main" id="{1AE967C7-A0AB-400A-A8C3-5FD1A0ACA2B2}"/>
+                <a16:creationId xmlns:a16="http://schemas.microsoft.com/office/drawing/2014/main" id="{A4D96368-0525-4C02-81CC-AF26EC81B133}"/>
               </a:ext>
             </a:extLst>
           </p:cNvPr>
@@ -12144,10 +12962,69 @@
       </p:sp>
       <p:sp>
         <p:nvSpPr>
-          <p:cNvPr id="4" name="footer-rule">
-            <a:extLst xmlns:a="http://schemas.openxmlformats.org/drawingml/2006/main">
-              <a:ext uri="{FF2B5EF4-FFF2-40B4-BE49-F238E27FC236}">
-                <a16:creationId xmlns:a16="http://schemas.microsoft.com/office/drawing/2014/main" id="{F53C1C44-C395-4619-B34D-6A7414D0515A}"/>
+          <p:cNvPr id="4" name="rescue-point-logo-background">
+            <a:extLst xmlns:a="http://schemas.openxmlformats.org/drawingml/2006/main">
+              <a:ext uri="{FF2B5EF4-FFF2-40B4-BE49-F238E27FC236}">
+                <a16:creationId xmlns:a16="http://schemas.microsoft.com/office/drawing/2014/main" id="{82E3056D-3999-4E81-8C18-BFF14455AC59}"/>
+              </a:ext>
+            </a:extLst>
+          </p:cNvPr>
+          <p:cNvSpPr>
+            <a:spLocks xmlns:a="http://schemas.openxmlformats.org/drawingml/2006/main" noGrp="1"/>
+          </p:cNvSpPr>
+          <p:nvPr/>
+        </p:nvSpPr>
+        <p:spPr>
+          <a:xfrm xmlns:a="http://schemas.openxmlformats.org/drawingml/2006/main">
+            <a:off x="9772650" y="133350"/>
+            <a:ext cx="1733550" cy="457200"/>
+          </a:xfrm>
+          <a:prstGeom xmlns:a="http://schemas.openxmlformats.org/drawingml/2006/main" prst="roundRect">
+            <a:avLst>
+              <a:gd name="adj" fmla="val 16667"/>
+            </a:avLst>
+          </a:prstGeom>
+          <a:solidFill xmlns:a="http://schemas.openxmlformats.org/drawingml/2006/main">
+            <a:srgbClr val="06142E"/>
+          </a:solidFill>
+          <a:ln xmlns:a="http://schemas.openxmlformats.org/drawingml/2006/main" w="9525">
+            <a:solidFill>
+              <a:srgbClr val="1EC5FF">
+                <a:alpha val="33333"/>
+              </a:srgbClr>
+            </a:solidFill>
+            <a:prstDash val="solid"/>
+          </a:ln>
+        </p:spPr>
+      </p:sp>
+      <p:pic>
+        <p:nvPicPr>
+          <p:cNvPr id="15" name="" descr="Figura oficial da documentação dbt usada para explicar: Limitações que precisam permanecer visíveis — • Codespaces exige internet e conta pessoal GitHub."/>
+          <p:cNvPicPr>
+            <a:picLocks xmlns:a="http://schemas.openxmlformats.org/drawingml/2006/main" noChangeAspect="1"/>
+          </p:cNvPicPr>
+          <p:nvPr/>
+        </p:nvPicPr>
+        <p:blipFill>
+          <a:blip xmlns:r="http://schemas.openxmlformats.org/officeDocument/2006/relationships" xmlns:a="http://schemas.openxmlformats.org/drawingml/2006/main" r:embed="R441d2e9e1f7a4eab"/>
+          <a:stretch xmlns:a="http://schemas.openxmlformats.org/drawingml/2006/main"/>
+        </p:blipFill>
+        <p:spPr>
+          <a:xfrm xmlns:a="http://schemas.openxmlformats.org/drawingml/2006/main">
+            <a:off x="9893718" y="209550"/>
+            <a:ext cx="1491414" cy="323850"/>
+          </a:xfrm>
+          <a:prstGeom xmlns:a="http://schemas.openxmlformats.org/drawingml/2006/main" prst="rect">
+            <a:avLst/>
+          </a:prstGeom>
+        </p:spPr>
+      </p:pic>
+      <p:sp>
+        <p:nvSpPr>
+          <p:cNvPr id="6" name="footer-rule">
+            <a:extLst xmlns:a="http://schemas.openxmlformats.org/drawingml/2006/main">
+              <a:ext uri="{FF2B5EF4-FFF2-40B4-BE49-F238E27FC236}">
+                <a16:creationId xmlns:a16="http://schemas.microsoft.com/office/drawing/2014/main" id="{5D79BBD0-F094-422C-9F94-8000310C5B9F}"/>
               </a:ext>
             </a:extLst>
           </p:cNvPr>
@@ -12177,10 +13054,10 @@
       </p:sp>
       <p:sp>
         <p:nvSpPr>
-          <p:cNvPr id="5" name="footer">
-            <a:extLst xmlns:a="http://schemas.openxmlformats.org/drawingml/2006/main">
-              <a:ext uri="{FF2B5EF4-FFF2-40B4-BE49-F238E27FC236}">
-                <a16:creationId xmlns:a16="http://schemas.microsoft.com/office/drawing/2014/main" id="{F5AFDDE2-B1B3-45CD-A23F-88771D7D8E3C}"/>
+          <p:cNvPr id="7" name="footer">
+            <a:extLst xmlns:a="http://schemas.openxmlformats.org/drawingml/2006/main">
+              <a:ext uri="{FF2B5EF4-FFF2-40B4-BE49-F238E27FC236}">
+                <a16:creationId xmlns:a16="http://schemas.microsoft.com/office/drawing/2014/main" id="{95CF58C5-8A2F-4911-AD7B-4D405C2E517A}"/>
               </a:ext>
             </a:extLst>
           </p:cNvPr>
@@ -12232,10 +13109,10 @@
       </p:sp>
       <p:sp>
         <p:nvSpPr>
-          <p:cNvPr id="6" name="page-number">
-            <a:extLst xmlns:a="http://schemas.openxmlformats.org/drawingml/2006/main">
-              <a:ext uri="{FF2B5EF4-FFF2-40B4-BE49-F238E27FC236}">
-                <a16:creationId xmlns:a16="http://schemas.microsoft.com/office/drawing/2014/main" id="{E8987D06-2561-494B-AAD0-09626DAA62DC}"/>
+          <p:cNvPr id="8" name="page-number">
+            <a:extLst xmlns:a="http://schemas.openxmlformats.org/drawingml/2006/main">
+              <a:ext uri="{FF2B5EF4-FFF2-40B4-BE49-F238E27FC236}">
+                <a16:creationId xmlns:a16="http://schemas.microsoft.com/office/drawing/2014/main" id="{709EDF0B-4E34-4E2C-814D-338022B42E51}"/>
               </a:ext>
             </a:extLst>
           </p:cNvPr>
@@ -12288,7 +13165,7 @@
     </p:spTree>
     <p:extLst>
       <p:ext uri="{BB962C8B-B14F-4D97-AF65-F5344CB8AC3E}">
-        <p14:creationId xmlns:p14="http://schemas.microsoft.com/office/powerpoint/2010/main" val="1593179968"/>
+        <p14:creationId xmlns:p14="http://schemas.microsoft.com/office/powerpoint/2010/main" val="1916589029"/>
       </p:ext>
     </p:extLst>
   </p:cSld>
@@ -12324,10 +13201,10 @@
       </p:grpSpPr>
       <p:sp>
         <p:nvSpPr>
-          <p:cNvPr id="10" name="radar-label">
-            <a:extLst xmlns:a="http://schemas.openxmlformats.org/drawingml/2006/main">
-              <a:ext uri="{FF2B5EF4-FFF2-40B4-BE49-F238E27FC236}">
-                <a16:creationId xmlns:a16="http://schemas.microsoft.com/office/drawing/2014/main" id="{16251EE7-598F-45B3-8EB7-D8F45419F258}"/>
+          <p:cNvPr id="12" name="radar-label">
+            <a:extLst xmlns:a="http://schemas.openxmlformats.org/drawingml/2006/main">
+              <a:ext uri="{FF2B5EF4-FFF2-40B4-BE49-F238E27FC236}">
+                <a16:creationId xmlns:a16="http://schemas.microsoft.com/office/drawing/2014/main" id="{A717A873-F783-4F56-B2A9-F8738F2E435C}"/>
               </a:ext>
             </a:extLst>
           </p:cNvPr>
@@ -12378,7 +13255,7 @@
           <p:cNvPr id="2" name="radar-text">
             <a:extLst xmlns:a="http://schemas.openxmlformats.org/drawingml/2006/main">
               <a:ext uri="{FF2B5EF4-FFF2-40B4-BE49-F238E27FC236}">
-                <a16:creationId xmlns:a16="http://schemas.microsoft.com/office/drawing/2014/main" id="{C64A032F-DD98-4C1D-94F8-3B85465A8D9D}"/>
+                <a16:creationId xmlns:a16="http://schemas.microsoft.com/office/drawing/2014/main" id="{175E6955-F92A-46DE-9C55-17E3B42B4DB8}"/>
               </a:ext>
             </a:extLst>
           </p:cNvPr>
@@ -12429,7 +13306,7 @@
           <p:cNvPr id="3" name="radar-rule">
             <a:extLst xmlns:a="http://schemas.openxmlformats.org/drawingml/2006/main">
               <a:ext uri="{FF2B5EF4-FFF2-40B4-BE49-F238E27FC236}">
-                <a16:creationId xmlns:a16="http://schemas.microsoft.com/office/drawing/2014/main" id="{46F0DE14-05E1-4B23-9678-29E55C671819}"/>
+                <a16:creationId xmlns:a16="http://schemas.microsoft.com/office/drawing/2014/main" id="{CC75E362-78BC-49A8-A549-16DD34DB199C}"/>
               </a:ext>
             </a:extLst>
           </p:cNvPr>
@@ -12480,7 +13357,7 @@
           <p:cNvPr id="4" name="ambient-glow">
             <a:extLst xmlns:a="http://schemas.openxmlformats.org/drawingml/2006/main">
               <a:ext uri="{FF2B5EF4-FFF2-40B4-BE49-F238E27FC236}">
-                <a16:creationId xmlns:a16="http://schemas.microsoft.com/office/drawing/2014/main" id="{9016BDB6-FAF9-433B-A9B9-3E5970A31D6A}"/>
+                <a16:creationId xmlns:a16="http://schemas.microsoft.com/office/drawing/2014/main" id="{5A0A5E6D-E2A7-4707-B3DC-036A56BD06E1}"/>
               </a:ext>
             </a:extLst>
           </p:cNvPr>
@@ -12517,7 +13394,7 @@
           <p:cNvPr id="5" name="ambient-core">
             <a:extLst xmlns:a="http://schemas.openxmlformats.org/drawingml/2006/main">
               <a:ext uri="{FF2B5EF4-FFF2-40B4-BE49-F238E27FC236}">
-                <a16:creationId xmlns:a16="http://schemas.microsoft.com/office/drawing/2014/main" id="{B1CEFF97-4664-4499-9AD7-29A2A6DF0983}"/>
+                <a16:creationId xmlns:a16="http://schemas.microsoft.com/office/drawing/2014/main" id="{754CEAE0-8431-42E2-9F42-8731AFCAEC5D}"/>
               </a:ext>
             </a:extLst>
           </p:cNvPr>
@@ -12554,7 +13431,7 @@
           <p:cNvPr id="6" name="eyebrow">
             <a:extLst xmlns:a="http://schemas.openxmlformats.org/drawingml/2006/main">
               <a:ext uri="{FF2B5EF4-FFF2-40B4-BE49-F238E27FC236}">
-                <a16:creationId xmlns:a16="http://schemas.microsoft.com/office/drawing/2014/main" id="{84284907-CFE6-4351-BDC2-FB1C338D38CC}"/>
+                <a16:creationId xmlns:a16="http://schemas.microsoft.com/office/drawing/2014/main" id="{B4B82208-222B-41EA-A3B3-E33BD01824C1}"/>
               </a:ext>
             </a:extLst>
           </p:cNvPr>
@@ -12602,10 +13479,69 @@
       </p:sp>
       <p:sp>
         <p:nvSpPr>
-          <p:cNvPr id="7" name="footer-rule">
-            <a:extLst xmlns:a="http://schemas.openxmlformats.org/drawingml/2006/main">
-              <a:ext uri="{FF2B5EF4-FFF2-40B4-BE49-F238E27FC236}">
-                <a16:creationId xmlns:a16="http://schemas.microsoft.com/office/drawing/2014/main" id="{AC32A775-BDEF-4C2A-9458-6E372B179169}"/>
+          <p:cNvPr id="7" name="rescue-point-logo-background">
+            <a:extLst xmlns:a="http://schemas.openxmlformats.org/drawingml/2006/main">
+              <a:ext uri="{FF2B5EF4-FFF2-40B4-BE49-F238E27FC236}">
+                <a16:creationId xmlns:a16="http://schemas.microsoft.com/office/drawing/2014/main" id="{0D3CD07E-64DA-4E99-BF06-BBCDF745F261}"/>
+              </a:ext>
+            </a:extLst>
+          </p:cNvPr>
+          <p:cNvSpPr>
+            <a:spLocks xmlns:a="http://schemas.openxmlformats.org/drawingml/2006/main" noGrp="1"/>
+          </p:cNvSpPr>
+          <p:nvPr/>
+        </p:nvSpPr>
+        <p:spPr>
+          <a:xfrm xmlns:a="http://schemas.openxmlformats.org/drawingml/2006/main">
+            <a:off x="9772650" y="133350"/>
+            <a:ext cx="1733550" cy="457200"/>
+          </a:xfrm>
+          <a:prstGeom xmlns:a="http://schemas.openxmlformats.org/drawingml/2006/main" prst="roundRect">
+            <a:avLst>
+              <a:gd name="adj" fmla="val 16667"/>
+            </a:avLst>
+          </a:prstGeom>
+          <a:solidFill xmlns:a="http://schemas.openxmlformats.org/drawingml/2006/main">
+            <a:srgbClr val="06142E"/>
+          </a:solidFill>
+          <a:ln xmlns:a="http://schemas.openxmlformats.org/drawingml/2006/main" w="9525">
+            <a:solidFill>
+              <a:srgbClr val="1EC5FF">
+                <a:alpha val="33333"/>
+              </a:srgbClr>
+            </a:solidFill>
+            <a:prstDash val="solid"/>
+          </a:ln>
+        </p:spPr>
+      </p:sp>
+      <p:pic>
+        <p:nvPicPr>
+          <p:cNvPr id="21" name="" descr="Figura oficial da documentação dbt usada para explicar: RADAR — Core 2.0 e Fusion ficam apenas no Radar; a aula executa Core 1.12 estável.."/>
+          <p:cNvPicPr>
+            <a:picLocks xmlns:a="http://schemas.openxmlformats.org/drawingml/2006/main" noChangeAspect="1"/>
+          </p:cNvPicPr>
+          <p:nvPr/>
+        </p:nvPicPr>
+        <p:blipFill>
+          <a:blip xmlns:r="http://schemas.openxmlformats.org/officeDocument/2006/relationships" xmlns:a="http://schemas.openxmlformats.org/drawingml/2006/main" r:embed="R0091da04fc1a4965"/>
+          <a:stretch xmlns:a="http://schemas.openxmlformats.org/drawingml/2006/main"/>
+        </p:blipFill>
+        <p:spPr>
+          <a:xfrm xmlns:a="http://schemas.openxmlformats.org/drawingml/2006/main">
+            <a:off x="9893718" y="209550"/>
+            <a:ext cx="1491414" cy="323850"/>
+          </a:xfrm>
+          <a:prstGeom xmlns:a="http://schemas.openxmlformats.org/drawingml/2006/main" prst="rect">
+            <a:avLst/>
+          </a:prstGeom>
+        </p:spPr>
+      </p:pic>
+      <p:sp>
+        <p:nvSpPr>
+          <p:cNvPr id="9" name="footer-rule">
+            <a:extLst xmlns:a="http://schemas.openxmlformats.org/drawingml/2006/main">
+              <a:ext uri="{FF2B5EF4-FFF2-40B4-BE49-F238E27FC236}">
+                <a16:creationId xmlns:a16="http://schemas.microsoft.com/office/drawing/2014/main" id="{349D1CBA-9C93-4A19-93E2-0E7A73F6B4C7}"/>
               </a:ext>
             </a:extLst>
           </p:cNvPr>
@@ -12635,10 +13571,10 @@
       </p:sp>
       <p:sp>
         <p:nvSpPr>
-          <p:cNvPr id="8" name="footer">
-            <a:extLst xmlns:a="http://schemas.openxmlformats.org/drawingml/2006/main">
-              <a:ext uri="{FF2B5EF4-FFF2-40B4-BE49-F238E27FC236}">
-                <a16:creationId xmlns:a16="http://schemas.microsoft.com/office/drawing/2014/main" id="{AC1A30B8-30A6-44B3-8801-A3D997685D2E}"/>
+          <p:cNvPr id="10" name="footer">
+            <a:extLst xmlns:a="http://schemas.openxmlformats.org/drawingml/2006/main">
+              <a:ext uri="{FF2B5EF4-FFF2-40B4-BE49-F238E27FC236}">
+                <a16:creationId xmlns:a16="http://schemas.microsoft.com/office/drawing/2014/main" id="{34B04E23-83D8-43D1-A8BB-56AAA65A8F47}"/>
               </a:ext>
             </a:extLst>
           </p:cNvPr>
@@ -12690,10 +13626,10 @@
       </p:sp>
       <p:sp>
         <p:nvSpPr>
-          <p:cNvPr id="9" name="page-number">
-            <a:extLst xmlns:a="http://schemas.openxmlformats.org/drawingml/2006/main">
-              <a:ext uri="{FF2B5EF4-FFF2-40B4-BE49-F238E27FC236}">
-                <a16:creationId xmlns:a16="http://schemas.microsoft.com/office/drawing/2014/main" id="{E3C5FF2D-6936-4468-BC35-90D0D21BD583}"/>
+          <p:cNvPr id="11" name="page-number">
+            <a:extLst xmlns:a="http://schemas.openxmlformats.org/drawingml/2006/main">
+              <a:ext uri="{FF2B5EF4-FFF2-40B4-BE49-F238E27FC236}">
+                <a16:creationId xmlns:a16="http://schemas.microsoft.com/office/drawing/2014/main" id="{D22DD3DA-52B7-49F1-A26A-63154AB653EC}"/>
               </a:ext>
             </a:extLst>
           </p:cNvPr>
@@ -12746,7 +13682,7 @@
     </p:spTree>
     <p:extLst>
       <p:ext uri="{BB962C8B-B14F-4D97-AF65-F5344CB8AC3E}">
-        <p14:creationId xmlns:p14="http://schemas.microsoft.com/office/powerpoint/2010/main" val="1731095963"/>
+        <p14:creationId xmlns:p14="http://schemas.microsoft.com/office/powerpoint/2010/main" val="487414263"/>
       </p:ext>
     </p:extLst>
   </p:cSld>
@@ -12774,10 +13710,10 @@
       </p:grpSpPr>
       <p:sp>
         <p:nvSpPr>
-          <p:cNvPr id="8" name="cta-label">
-            <a:extLst xmlns:a="http://schemas.openxmlformats.org/drawingml/2006/main">
-              <a:ext uri="{FF2B5EF4-FFF2-40B4-BE49-F238E27FC236}">
-                <a16:creationId xmlns:a16="http://schemas.microsoft.com/office/drawing/2014/main" id="{D839393D-9285-4469-8D57-1B532B477040}"/>
+          <p:cNvPr id="10" name="cta-label">
+            <a:extLst xmlns:a="http://schemas.openxmlformats.org/drawingml/2006/main">
+              <a:ext uri="{FF2B5EF4-FFF2-40B4-BE49-F238E27FC236}">
+                <a16:creationId xmlns:a16="http://schemas.microsoft.com/office/drawing/2014/main" id="{59679F8B-FAC4-4C4C-99A9-A4FC395138C8}"/>
               </a:ext>
             </a:extLst>
           </p:cNvPr>
@@ -12828,7 +13764,7 @@
           <p:cNvPr id="2" name="cta">
             <a:extLst xmlns:a="http://schemas.openxmlformats.org/drawingml/2006/main">
               <a:ext uri="{FF2B5EF4-FFF2-40B4-BE49-F238E27FC236}">
-                <a16:creationId xmlns:a16="http://schemas.microsoft.com/office/drawing/2014/main" id="{6F59B9D6-AC5D-4592-B931-AD0C817FCEFC}"/>
+                <a16:creationId xmlns:a16="http://schemas.microsoft.com/office/drawing/2014/main" id="{D02B1AF4-EC93-4FD5-9FE3-A9889595DDB9}"/>
               </a:ext>
             </a:extLst>
           </p:cNvPr>
@@ -12879,7 +13815,7 @@
           <p:cNvPr id="3" name="cta-meta">
             <a:extLst xmlns:a="http://schemas.openxmlformats.org/drawingml/2006/main">
               <a:ext uri="{FF2B5EF4-FFF2-40B4-BE49-F238E27FC236}">
-                <a16:creationId xmlns:a16="http://schemas.microsoft.com/office/drawing/2014/main" id="{1BDFFB42-AC26-48BB-A0DA-09EA08517350}"/>
+                <a16:creationId xmlns:a16="http://schemas.microsoft.com/office/drawing/2014/main" id="{E6FC82E0-75C4-49A8-B2B6-1649E5A6DC23}"/>
               </a:ext>
             </a:extLst>
           </p:cNvPr>
@@ -12930,7 +13866,7 @@
           <p:cNvPr id="4" name="eyebrow">
             <a:extLst xmlns:a="http://schemas.openxmlformats.org/drawingml/2006/main">
               <a:ext uri="{FF2B5EF4-FFF2-40B4-BE49-F238E27FC236}">
-                <a16:creationId xmlns:a16="http://schemas.microsoft.com/office/drawing/2014/main" id="{4E41AD3B-51F0-4279-96F5-1BC6CD6D86CB}"/>
+                <a16:creationId xmlns:a16="http://schemas.microsoft.com/office/drawing/2014/main" id="{7B21A6CF-41EE-43AA-912A-6CFBDD9472E7}"/>
               </a:ext>
             </a:extLst>
           </p:cNvPr>
@@ -12978,10 +13914,69 @@
       </p:sp>
       <p:sp>
         <p:nvSpPr>
-          <p:cNvPr id="5" name="footer-rule">
-            <a:extLst xmlns:a="http://schemas.openxmlformats.org/drawingml/2006/main">
-              <a:ext uri="{FF2B5EF4-FFF2-40B4-BE49-F238E27FC236}">
-                <a16:creationId xmlns:a16="http://schemas.microsoft.com/office/drawing/2014/main" id="{231BB638-7D54-4F83-A1F2-98AEB4DB821D}"/>
+          <p:cNvPr id="5" name="rescue-point-logo-background">
+            <a:extLst xmlns:a="http://schemas.openxmlformats.org/drawingml/2006/main">
+              <a:ext uri="{FF2B5EF4-FFF2-40B4-BE49-F238E27FC236}">
+                <a16:creationId xmlns:a16="http://schemas.microsoft.com/office/drawing/2014/main" id="{27E7C5F4-6D13-4D10-B716-9E5436D1FFD8}"/>
+              </a:ext>
+            </a:extLst>
+          </p:cNvPr>
+          <p:cNvSpPr>
+            <a:spLocks xmlns:a="http://schemas.openxmlformats.org/drawingml/2006/main" noGrp="1"/>
+          </p:cNvSpPr>
+          <p:nvPr/>
+        </p:nvSpPr>
+        <p:spPr>
+          <a:xfrm xmlns:a="http://schemas.openxmlformats.org/drawingml/2006/main">
+            <a:off x="9772650" y="133350"/>
+            <a:ext cx="1733550" cy="457200"/>
+          </a:xfrm>
+          <a:prstGeom xmlns:a="http://schemas.openxmlformats.org/drawingml/2006/main" prst="roundRect">
+            <a:avLst>
+              <a:gd name="adj" fmla="val 16667"/>
+            </a:avLst>
+          </a:prstGeom>
+          <a:solidFill xmlns:a="http://schemas.openxmlformats.org/drawingml/2006/main">
+            <a:srgbClr val="06142E"/>
+          </a:solidFill>
+          <a:ln xmlns:a="http://schemas.openxmlformats.org/drawingml/2006/main" w="9525">
+            <a:solidFill>
+              <a:srgbClr val="1EC5FF">
+                <a:alpha val="33333"/>
+              </a:srgbClr>
+            </a:solidFill>
+            <a:prstDash val="solid"/>
+          </a:ln>
+        </p:spPr>
+      </p:sp>
+      <p:pic>
+        <p:nvPicPr>
+          <p:cNvPr id="17" name="" descr="Figura oficial da documentação dbt usada para explicar: PRÓXIMO PASSO — Abra o Codespace em 2-core, execute checkpoint 01 e use a UI oficial por túnel somente como bônus.."/>
+          <p:cNvPicPr>
+            <a:picLocks xmlns:a="http://schemas.openxmlformats.org/drawingml/2006/main" noChangeAspect="1"/>
+          </p:cNvPicPr>
+          <p:nvPr/>
+        </p:nvPicPr>
+        <p:blipFill>
+          <a:blip xmlns:r="http://schemas.openxmlformats.org/officeDocument/2006/relationships" xmlns:a="http://schemas.openxmlformats.org/drawingml/2006/main" r:embed="R1a4c1958e8074b27"/>
+          <a:stretch xmlns:a="http://schemas.openxmlformats.org/drawingml/2006/main"/>
+        </p:blipFill>
+        <p:spPr>
+          <a:xfrm xmlns:a="http://schemas.openxmlformats.org/drawingml/2006/main">
+            <a:off x="9893718" y="209550"/>
+            <a:ext cx="1491414" cy="323850"/>
+          </a:xfrm>
+          <a:prstGeom xmlns:a="http://schemas.openxmlformats.org/drawingml/2006/main" prst="rect">
+            <a:avLst/>
+          </a:prstGeom>
+        </p:spPr>
+      </p:pic>
+      <p:sp>
+        <p:nvSpPr>
+          <p:cNvPr id="7" name="footer-rule">
+            <a:extLst xmlns:a="http://schemas.openxmlformats.org/drawingml/2006/main">
+              <a:ext uri="{FF2B5EF4-FFF2-40B4-BE49-F238E27FC236}">
+                <a16:creationId xmlns:a16="http://schemas.microsoft.com/office/drawing/2014/main" id="{200D2EFA-741E-402B-A4A2-A3E9DB2CB778}"/>
               </a:ext>
             </a:extLst>
           </p:cNvPr>
@@ -13011,10 +14006,10 @@
       </p:sp>
       <p:sp>
         <p:nvSpPr>
-          <p:cNvPr id="6" name="footer">
-            <a:extLst xmlns:a="http://schemas.openxmlformats.org/drawingml/2006/main">
-              <a:ext uri="{FF2B5EF4-FFF2-40B4-BE49-F238E27FC236}">
-                <a16:creationId xmlns:a16="http://schemas.microsoft.com/office/drawing/2014/main" id="{43D299E3-A291-41E7-9C4D-40429D6D9606}"/>
+          <p:cNvPr id="8" name="footer">
+            <a:extLst xmlns:a="http://schemas.openxmlformats.org/drawingml/2006/main">
+              <a:ext uri="{FF2B5EF4-FFF2-40B4-BE49-F238E27FC236}">
+                <a16:creationId xmlns:a16="http://schemas.microsoft.com/office/drawing/2014/main" id="{FEA72C91-63C4-4405-9E4E-4EE365E611EF}"/>
               </a:ext>
             </a:extLst>
           </p:cNvPr>
@@ -13066,10 +14061,10 @@
       </p:sp>
       <p:sp>
         <p:nvSpPr>
-          <p:cNvPr id="7" name="page-number">
-            <a:extLst xmlns:a="http://schemas.openxmlformats.org/drawingml/2006/main">
-              <a:ext uri="{FF2B5EF4-FFF2-40B4-BE49-F238E27FC236}">
-                <a16:creationId xmlns:a16="http://schemas.microsoft.com/office/drawing/2014/main" id="{A4DA4D5C-2E0B-4EC1-9681-DE4EA58E74F4}"/>
+          <p:cNvPr id="9" name="page-number">
+            <a:extLst xmlns:a="http://schemas.openxmlformats.org/drawingml/2006/main">
+              <a:ext uri="{FF2B5EF4-FFF2-40B4-BE49-F238E27FC236}">
+                <a16:creationId xmlns:a16="http://schemas.microsoft.com/office/drawing/2014/main" id="{AD5C4185-AFE5-4947-8B50-E2112F2348E3}"/>
               </a:ext>
             </a:extLst>
           </p:cNvPr>
@@ -13122,7 +14117,7 @@
     </p:spTree>
     <p:extLst>
       <p:ext uri="{BB962C8B-B14F-4D97-AF65-F5344CB8AC3E}">
-        <p14:creationId xmlns:p14="http://schemas.microsoft.com/office/powerpoint/2010/main" val="1086623217"/>
+        <p14:creationId xmlns:p14="http://schemas.microsoft.com/office/powerpoint/2010/main" val="1808940296"/>
       </p:ext>
     </p:extLst>
   </p:cSld>
@@ -13158,10 +14153,10 @@
       </p:grpSpPr>
       <p:sp>
         <p:nvSpPr>
-          <p:cNvPr id="14" name="slide-title">
-            <a:extLst xmlns:a="http://schemas.openxmlformats.org/drawingml/2006/main">
-              <a:ext uri="{FF2B5EF4-FFF2-40B4-BE49-F238E27FC236}">
-                <a16:creationId xmlns:a16="http://schemas.microsoft.com/office/drawing/2014/main" id="{AEF21087-6A7B-4232-81B1-2E19A7351B81}"/>
+          <p:cNvPr id="16" name="slide-title">
+            <a:extLst xmlns:a="http://schemas.openxmlformats.org/drawingml/2006/main">
+              <a:ext uri="{FF2B5EF4-FFF2-40B4-BE49-F238E27FC236}">
+                <a16:creationId xmlns:a16="http://schemas.microsoft.com/office/drawing/2014/main" id="{DE2B1CA6-A78B-4432-A714-EFFBFEDC930C}"/>
               </a:ext>
             </a:extLst>
           </p:cNvPr>
@@ -13212,7 +14207,7 @@
           <p:cNvPr id="2" name="step-num-1">
             <a:extLst xmlns:a="http://schemas.openxmlformats.org/drawingml/2006/main">
               <a:ext uri="{FF2B5EF4-FFF2-40B4-BE49-F238E27FC236}">
-                <a16:creationId xmlns:a16="http://schemas.microsoft.com/office/drawing/2014/main" id="{84E2AC29-112D-4BD8-AF37-867115B83B2A}"/>
+                <a16:creationId xmlns:a16="http://schemas.microsoft.com/office/drawing/2014/main" id="{FDCA3554-FB9D-4065-B102-839C2BFC4FC5}"/>
               </a:ext>
             </a:extLst>
           </p:cNvPr>
@@ -13263,7 +14258,7 @@
           <p:cNvPr id="3" name="step-label-1">
             <a:extLst xmlns:a="http://schemas.openxmlformats.org/drawingml/2006/main">
               <a:ext uri="{FF2B5EF4-FFF2-40B4-BE49-F238E27FC236}">
-                <a16:creationId xmlns:a16="http://schemas.microsoft.com/office/drawing/2014/main" id="{36A57930-90B5-4E1A-A913-E52515F2F7C6}"/>
+                <a16:creationId xmlns:a16="http://schemas.microsoft.com/office/drawing/2014/main" id="{B57261C8-B35D-455E-9381-A6CFF7F511EE}"/>
               </a:ext>
             </a:extLst>
           </p:cNvPr>
@@ -13314,7 +14309,7 @@
           <p:cNvPr id="4" name="step-line-1">
             <a:extLst xmlns:a="http://schemas.openxmlformats.org/drawingml/2006/main">
               <a:ext uri="{FF2B5EF4-FFF2-40B4-BE49-F238E27FC236}">
-                <a16:creationId xmlns:a16="http://schemas.microsoft.com/office/drawing/2014/main" id="{35831776-3402-48F6-8DA3-71413597B1FD}"/>
+                <a16:creationId xmlns:a16="http://schemas.microsoft.com/office/drawing/2014/main" id="{60EFB47E-5BD4-4434-AF80-F064045117A7}"/>
               </a:ext>
             </a:extLst>
           </p:cNvPr>
@@ -13345,7 +14340,7 @@
           <p:cNvPr id="5" name="step-num-2">
             <a:extLst xmlns:a="http://schemas.openxmlformats.org/drawingml/2006/main">
               <a:ext uri="{FF2B5EF4-FFF2-40B4-BE49-F238E27FC236}">
-                <a16:creationId xmlns:a16="http://schemas.microsoft.com/office/drawing/2014/main" id="{7FE98E1B-001E-40C9-8894-513EC80BE0C1}"/>
+                <a16:creationId xmlns:a16="http://schemas.microsoft.com/office/drawing/2014/main" id="{BA590B45-0421-4363-81EB-22643E52EB1D}"/>
               </a:ext>
             </a:extLst>
           </p:cNvPr>
@@ -13396,7 +14391,7 @@
           <p:cNvPr id="6" name="step-label-2">
             <a:extLst xmlns:a="http://schemas.openxmlformats.org/drawingml/2006/main">
               <a:ext uri="{FF2B5EF4-FFF2-40B4-BE49-F238E27FC236}">
-                <a16:creationId xmlns:a16="http://schemas.microsoft.com/office/drawing/2014/main" id="{410096DC-44A8-48A8-8868-ECDEF15E73A9}"/>
+                <a16:creationId xmlns:a16="http://schemas.microsoft.com/office/drawing/2014/main" id="{3E4EE87E-CBDE-4877-A511-ED29B9FE5F5D}"/>
               </a:ext>
             </a:extLst>
           </p:cNvPr>
@@ -13447,7 +14442,7 @@
           <p:cNvPr id="7" name="step-line-2">
             <a:extLst xmlns:a="http://schemas.openxmlformats.org/drawingml/2006/main">
               <a:ext uri="{FF2B5EF4-FFF2-40B4-BE49-F238E27FC236}">
-                <a16:creationId xmlns:a16="http://schemas.microsoft.com/office/drawing/2014/main" id="{55F49E86-8925-4FFB-A42E-540A25149914}"/>
+                <a16:creationId xmlns:a16="http://schemas.microsoft.com/office/drawing/2014/main" id="{8E13E7B4-7045-47C4-843C-9600125FBF50}"/>
               </a:ext>
             </a:extLst>
           </p:cNvPr>
@@ -13478,7 +14473,7 @@
           <p:cNvPr id="8" name="step-num-3">
             <a:extLst xmlns:a="http://schemas.openxmlformats.org/drawingml/2006/main">
               <a:ext uri="{FF2B5EF4-FFF2-40B4-BE49-F238E27FC236}">
-                <a16:creationId xmlns:a16="http://schemas.microsoft.com/office/drawing/2014/main" id="{33319D71-821B-4A93-ACD4-A51C1357A794}"/>
+                <a16:creationId xmlns:a16="http://schemas.microsoft.com/office/drawing/2014/main" id="{CEC3F530-9DDD-4A37-9593-8968E6A0B8D0}"/>
               </a:ext>
             </a:extLst>
           </p:cNvPr>
@@ -13529,7 +14524,7 @@
           <p:cNvPr id="9" name="step-label-3">
             <a:extLst xmlns:a="http://schemas.openxmlformats.org/drawingml/2006/main">
               <a:ext uri="{FF2B5EF4-FFF2-40B4-BE49-F238E27FC236}">
-                <a16:creationId xmlns:a16="http://schemas.microsoft.com/office/drawing/2014/main" id="{FA7A5B7A-4096-482F-9629-45E0887C01A4}"/>
+                <a16:creationId xmlns:a16="http://schemas.microsoft.com/office/drawing/2014/main" id="{8C74E2D9-FF37-43E9-886B-87C8F76DF050}"/>
               </a:ext>
             </a:extLst>
           </p:cNvPr>
@@ -13580,7 +14575,7 @@
           <p:cNvPr id="10" name="eyebrow">
             <a:extLst xmlns:a="http://schemas.openxmlformats.org/drawingml/2006/main">
               <a:ext uri="{FF2B5EF4-FFF2-40B4-BE49-F238E27FC236}">
-                <a16:creationId xmlns:a16="http://schemas.microsoft.com/office/drawing/2014/main" id="{66B09C49-213A-4288-997E-9BFEC27F9111}"/>
+                <a16:creationId xmlns:a16="http://schemas.microsoft.com/office/drawing/2014/main" id="{B739F43F-FD3E-483A-B021-4D8953C99E54}"/>
               </a:ext>
             </a:extLst>
           </p:cNvPr>
@@ -13628,10 +14623,69 @@
       </p:sp>
       <p:sp>
         <p:nvSpPr>
-          <p:cNvPr id="11" name="footer-rule">
-            <a:extLst xmlns:a="http://schemas.openxmlformats.org/drawingml/2006/main">
-              <a:ext uri="{FF2B5EF4-FFF2-40B4-BE49-F238E27FC236}">
-                <a16:creationId xmlns:a16="http://schemas.microsoft.com/office/drawing/2014/main" id="{08CD6733-558B-4734-B12D-704F6C57BEC6}"/>
+          <p:cNvPr id="11" name="rescue-point-logo-background">
+            <a:extLst xmlns:a="http://schemas.openxmlformats.org/drawingml/2006/main">
+              <a:ext uri="{FF2B5EF4-FFF2-40B4-BE49-F238E27FC236}">
+                <a16:creationId xmlns:a16="http://schemas.microsoft.com/office/drawing/2014/main" id="{75662E30-66DB-4046-81B5-B78A2BF4CA51}"/>
+              </a:ext>
+            </a:extLst>
+          </p:cNvPr>
+          <p:cNvSpPr>
+            <a:spLocks xmlns:a="http://schemas.openxmlformats.org/drawingml/2006/main" noGrp="1"/>
+          </p:cNvSpPr>
+          <p:nvPr/>
+        </p:nvSpPr>
+        <p:spPr>
+          <a:xfrm xmlns:a="http://schemas.openxmlformats.org/drawingml/2006/main">
+            <a:off x="9772650" y="133350"/>
+            <a:ext cx="1733550" cy="457200"/>
+          </a:xfrm>
+          <a:prstGeom xmlns:a="http://schemas.openxmlformats.org/drawingml/2006/main" prst="roundRect">
+            <a:avLst>
+              <a:gd name="adj" fmla="val 16667"/>
+            </a:avLst>
+          </a:prstGeom>
+          <a:solidFill xmlns:a="http://schemas.openxmlformats.org/drawingml/2006/main">
+            <a:srgbClr val="06142E"/>
+          </a:solidFill>
+          <a:ln xmlns:a="http://schemas.openxmlformats.org/drawingml/2006/main" w="9525">
+            <a:solidFill>
+              <a:srgbClr val="1EC5FF">
+                <a:alpha val="33333"/>
+              </a:srgbClr>
+            </a:solidFill>
+            <a:prstDash val="solid"/>
+          </a:ln>
+        </p:spPr>
+      </p:sp>
+      <p:pic>
+        <p:nvPicPr>
+          <p:cNvPr id="29" name="" descr="Figura oficial da documentação dbt usada para explicar: Ao final, você consegue... — 01."/>
+          <p:cNvPicPr>
+            <a:picLocks xmlns:a="http://schemas.openxmlformats.org/drawingml/2006/main" noChangeAspect="1"/>
+          </p:cNvPicPr>
+          <p:nvPr/>
+        </p:nvPicPr>
+        <p:blipFill>
+          <a:blip xmlns:r="http://schemas.openxmlformats.org/officeDocument/2006/relationships" xmlns:a="http://schemas.openxmlformats.org/drawingml/2006/main" r:embed="R1a7ad137c9ce45f6"/>
+          <a:stretch xmlns:a="http://schemas.openxmlformats.org/drawingml/2006/main"/>
+        </p:blipFill>
+        <p:spPr>
+          <a:xfrm xmlns:a="http://schemas.openxmlformats.org/drawingml/2006/main">
+            <a:off x="9893718" y="209550"/>
+            <a:ext cx="1491414" cy="323850"/>
+          </a:xfrm>
+          <a:prstGeom xmlns:a="http://schemas.openxmlformats.org/drawingml/2006/main" prst="rect">
+            <a:avLst/>
+          </a:prstGeom>
+        </p:spPr>
+      </p:pic>
+      <p:sp>
+        <p:nvSpPr>
+          <p:cNvPr id="13" name="footer-rule">
+            <a:extLst xmlns:a="http://schemas.openxmlformats.org/drawingml/2006/main">
+              <a:ext uri="{FF2B5EF4-FFF2-40B4-BE49-F238E27FC236}">
+                <a16:creationId xmlns:a16="http://schemas.microsoft.com/office/drawing/2014/main" id="{02D3F454-8A22-44F0-825E-A559CC230832}"/>
               </a:ext>
             </a:extLst>
           </p:cNvPr>
@@ -13661,10 +14715,10 @@
       </p:sp>
       <p:sp>
         <p:nvSpPr>
-          <p:cNvPr id="12" name="footer">
-            <a:extLst xmlns:a="http://schemas.openxmlformats.org/drawingml/2006/main">
-              <a:ext uri="{FF2B5EF4-FFF2-40B4-BE49-F238E27FC236}">
-                <a16:creationId xmlns:a16="http://schemas.microsoft.com/office/drawing/2014/main" id="{5538C2AE-ACC3-47E4-828C-86605FB1691A}"/>
+          <p:cNvPr id="14" name="footer">
+            <a:extLst xmlns:a="http://schemas.openxmlformats.org/drawingml/2006/main">
+              <a:ext uri="{FF2B5EF4-FFF2-40B4-BE49-F238E27FC236}">
+                <a16:creationId xmlns:a16="http://schemas.microsoft.com/office/drawing/2014/main" id="{EF9AC102-0EA0-46FD-90E0-07379843FDC1}"/>
               </a:ext>
             </a:extLst>
           </p:cNvPr>
@@ -13716,10 +14770,10 @@
       </p:sp>
       <p:sp>
         <p:nvSpPr>
-          <p:cNvPr id="13" name="page-number">
-            <a:extLst xmlns:a="http://schemas.openxmlformats.org/drawingml/2006/main">
-              <a:ext uri="{FF2B5EF4-FFF2-40B4-BE49-F238E27FC236}">
-                <a16:creationId xmlns:a16="http://schemas.microsoft.com/office/drawing/2014/main" id="{0A0D6462-2C35-47BD-919D-31D808651B35}"/>
+          <p:cNvPr id="15" name="page-number">
+            <a:extLst xmlns:a="http://schemas.openxmlformats.org/drawingml/2006/main">
+              <a:ext uri="{FF2B5EF4-FFF2-40B4-BE49-F238E27FC236}">
+                <a16:creationId xmlns:a16="http://schemas.microsoft.com/office/drawing/2014/main" id="{80304D18-DBE4-4F2A-9767-1C423E35DED7}"/>
               </a:ext>
             </a:extLst>
           </p:cNvPr>
@@ -13772,7 +14826,7 @@
     </p:spTree>
     <p:extLst>
       <p:ext uri="{BB962C8B-B14F-4D97-AF65-F5344CB8AC3E}">
-        <p14:creationId xmlns:p14="http://schemas.microsoft.com/office/powerpoint/2010/main" val="148335205"/>
+        <p14:creationId xmlns:p14="http://schemas.microsoft.com/office/powerpoint/2010/main" val="1095210072"/>
       </p:ext>
     </p:extLst>
   </p:cSld>
@@ -13808,10 +14862,10 @@
       </p:grpSpPr>
       <p:sp>
         <p:nvSpPr>
-          <p:cNvPr id="11" name="slide-title">
-            <a:extLst xmlns:a="http://schemas.openxmlformats.org/drawingml/2006/main">
-              <a:ext uri="{FF2B5EF4-FFF2-40B4-BE49-F238E27FC236}">
-                <a16:creationId xmlns:a16="http://schemas.microsoft.com/office/drawing/2014/main" id="{DC205F40-367C-4C5E-BA01-E4DB22B6AEA6}"/>
+          <p:cNvPr id="13" name="slide-title">
+            <a:extLst xmlns:a="http://schemas.openxmlformats.org/drawingml/2006/main">
+              <a:ext uri="{FF2B5EF4-FFF2-40B4-BE49-F238E27FC236}">
+                <a16:creationId xmlns:a16="http://schemas.microsoft.com/office/drawing/2014/main" id="{510AC22A-0A98-4EB3-A3FE-B6800F83EDE2}"/>
               </a:ext>
             </a:extLst>
           </p:cNvPr>
@@ -13862,7 +14916,7 @@
           <p:cNvPr id="2" name="slide-subtitle">
             <a:extLst xmlns:a="http://schemas.openxmlformats.org/drawingml/2006/main">
               <a:ext uri="{FF2B5EF4-FFF2-40B4-BE49-F238E27FC236}">
-                <a16:creationId xmlns:a16="http://schemas.microsoft.com/office/drawing/2014/main" id="{4CF628AC-A006-4871-831C-EE2892D1B0D0}"/>
+                <a16:creationId xmlns:a16="http://schemas.microsoft.com/office/drawing/2014/main" id="{66DAB490-6A19-4D62-93E9-7280ADD8E5E7}"/>
               </a:ext>
             </a:extLst>
           </p:cNvPr>
@@ -13913,7 +14967,7 @@
           <p:cNvPr id="3" name="bullets">
             <a:extLst xmlns:a="http://schemas.openxmlformats.org/drawingml/2006/main">
               <a:ext uri="{FF2B5EF4-FFF2-40B4-BE49-F238E27FC236}">
-                <a16:creationId xmlns:a16="http://schemas.microsoft.com/office/drawing/2014/main" id="{2210262F-EFF1-4419-9CDC-68ECACE5C548}"/>
+                <a16:creationId xmlns:a16="http://schemas.microsoft.com/office/drawing/2014/main" id="{B0C11B12-86E4-4C00-AFB2-506E513EC141}"/>
               </a:ext>
             </a:extLst>
           </p:cNvPr>
@@ -14000,7 +15054,7 @@
           <p:cNvPr id="4" name="ambient-glow">
             <a:extLst xmlns:a="http://schemas.openxmlformats.org/drawingml/2006/main">
               <a:ext uri="{FF2B5EF4-FFF2-40B4-BE49-F238E27FC236}">
-                <a16:creationId xmlns:a16="http://schemas.microsoft.com/office/drawing/2014/main" id="{2E228503-AB3E-4F11-8E31-16BA9D094725}"/>
+                <a16:creationId xmlns:a16="http://schemas.microsoft.com/office/drawing/2014/main" id="{92E216E4-F7B6-4357-9D01-B6C7BAAD9C07}"/>
               </a:ext>
             </a:extLst>
           </p:cNvPr>
@@ -14037,7 +15091,7 @@
           <p:cNvPr id="5" name="ambient-core">
             <a:extLst xmlns:a="http://schemas.openxmlformats.org/drawingml/2006/main">
               <a:ext uri="{FF2B5EF4-FFF2-40B4-BE49-F238E27FC236}">
-                <a16:creationId xmlns:a16="http://schemas.microsoft.com/office/drawing/2014/main" id="{38239922-86FF-4E60-884B-C9610C69CB04}"/>
+                <a16:creationId xmlns:a16="http://schemas.microsoft.com/office/drawing/2014/main" id="{2DCEE758-B792-46AC-B2F7-49AF8C5279F7}"/>
               </a:ext>
             </a:extLst>
           </p:cNvPr>
@@ -14074,7 +15128,7 @@
           <p:cNvPr id="6" name="section-number">
             <a:extLst xmlns:a="http://schemas.openxmlformats.org/drawingml/2006/main">
               <a:ext uri="{FF2B5EF4-FFF2-40B4-BE49-F238E27FC236}">
-                <a16:creationId xmlns:a16="http://schemas.microsoft.com/office/drawing/2014/main" id="{EE333610-B8F0-4F64-8276-5572A1682E37}"/>
+                <a16:creationId xmlns:a16="http://schemas.microsoft.com/office/drawing/2014/main" id="{5568E908-FD5E-41A2-9F94-6CFC33D792D9}"/>
               </a:ext>
             </a:extLst>
           </p:cNvPr>
@@ -14125,7 +15179,7 @@
           <p:cNvPr id="7" name="eyebrow">
             <a:extLst xmlns:a="http://schemas.openxmlformats.org/drawingml/2006/main">
               <a:ext uri="{FF2B5EF4-FFF2-40B4-BE49-F238E27FC236}">
-                <a16:creationId xmlns:a16="http://schemas.microsoft.com/office/drawing/2014/main" id="{B320C635-8CEE-4597-9337-6ABB0E8D82E0}"/>
+                <a16:creationId xmlns:a16="http://schemas.microsoft.com/office/drawing/2014/main" id="{4153D2F6-6047-4529-9EA4-8076C48DBCA5}"/>
               </a:ext>
             </a:extLst>
           </p:cNvPr>
@@ -14173,10 +15227,69 @@
       </p:sp>
       <p:sp>
         <p:nvSpPr>
-          <p:cNvPr id="8" name="footer-rule">
-            <a:extLst xmlns:a="http://schemas.openxmlformats.org/drawingml/2006/main">
-              <a:ext uri="{FF2B5EF4-FFF2-40B4-BE49-F238E27FC236}">
-                <a16:creationId xmlns:a16="http://schemas.microsoft.com/office/drawing/2014/main" id="{359A9C30-23E9-4033-8CD1-3DF1F7B07119}"/>
+          <p:cNvPr id="8" name="rescue-point-logo-background">
+            <a:extLst xmlns:a="http://schemas.openxmlformats.org/drawingml/2006/main">
+              <a:ext uri="{FF2B5EF4-FFF2-40B4-BE49-F238E27FC236}">
+                <a16:creationId xmlns:a16="http://schemas.microsoft.com/office/drawing/2014/main" id="{14F2F2F2-5A2C-41B3-9277-5B6AF856E564}"/>
+              </a:ext>
+            </a:extLst>
+          </p:cNvPr>
+          <p:cNvSpPr>
+            <a:spLocks xmlns:a="http://schemas.openxmlformats.org/drawingml/2006/main" noGrp="1"/>
+          </p:cNvSpPr>
+          <p:nvPr/>
+        </p:nvSpPr>
+        <p:spPr>
+          <a:xfrm xmlns:a="http://schemas.openxmlformats.org/drawingml/2006/main">
+            <a:off x="9772650" y="133350"/>
+            <a:ext cx="1733550" cy="457200"/>
+          </a:xfrm>
+          <a:prstGeom xmlns:a="http://schemas.openxmlformats.org/drawingml/2006/main" prst="roundRect">
+            <a:avLst>
+              <a:gd name="adj" fmla="val 16667"/>
+            </a:avLst>
+          </a:prstGeom>
+          <a:solidFill xmlns:a="http://schemas.openxmlformats.org/drawingml/2006/main">
+            <a:srgbClr val="06142E"/>
+          </a:solidFill>
+          <a:ln xmlns:a="http://schemas.openxmlformats.org/drawingml/2006/main" w="9525">
+            <a:solidFill>
+              <a:srgbClr val="1EC5FF">
+                <a:alpha val="33333"/>
+              </a:srgbClr>
+            </a:solidFill>
+            <a:prstDash val="solid"/>
+          </a:ln>
+        </p:spPr>
+      </p:sp>
+      <p:pic>
+        <p:nvPicPr>
+          <p:cNvPr id="23" name="" descr="Figura oficial da documentação dbt usada para explicar: SQL básico basta para começar — Terminal, Git, Python e dbt entram passo a passo.."/>
+          <p:cNvPicPr>
+            <a:picLocks xmlns:a="http://schemas.openxmlformats.org/drawingml/2006/main" noChangeAspect="1"/>
+          </p:cNvPicPr>
+          <p:nvPr/>
+        </p:nvPicPr>
+        <p:blipFill>
+          <a:blip xmlns:r="http://schemas.openxmlformats.org/officeDocument/2006/relationships" xmlns:a="http://schemas.openxmlformats.org/drawingml/2006/main" r:embed="Rec33f428c1e9499a"/>
+          <a:stretch xmlns:a="http://schemas.openxmlformats.org/drawingml/2006/main"/>
+        </p:blipFill>
+        <p:spPr>
+          <a:xfrm xmlns:a="http://schemas.openxmlformats.org/drawingml/2006/main">
+            <a:off x="9893718" y="209550"/>
+            <a:ext cx="1491414" cy="323850"/>
+          </a:xfrm>
+          <a:prstGeom xmlns:a="http://schemas.openxmlformats.org/drawingml/2006/main" prst="rect">
+            <a:avLst/>
+          </a:prstGeom>
+        </p:spPr>
+      </p:pic>
+      <p:sp>
+        <p:nvSpPr>
+          <p:cNvPr id="10" name="footer-rule">
+            <a:extLst xmlns:a="http://schemas.openxmlformats.org/drawingml/2006/main">
+              <a:ext uri="{FF2B5EF4-FFF2-40B4-BE49-F238E27FC236}">
+                <a16:creationId xmlns:a16="http://schemas.microsoft.com/office/drawing/2014/main" id="{6DF9E6A3-DD6D-495A-BCAD-8C6A3252C034}"/>
               </a:ext>
             </a:extLst>
           </p:cNvPr>
@@ -14206,10 +15319,10 @@
       </p:sp>
       <p:sp>
         <p:nvSpPr>
-          <p:cNvPr id="9" name="footer">
-            <a:extLst xmlns:a="http://schemas.openxmlformats.org/drawingml/2006/main">
-              <a:ext uri="{FF2B5EF4-FFF2-40B4-BE49-F238E27FC236}">
-                <a16:creationId xmlns:a16="http://schemas.microsoft.com/office/drawing/2014/main" id="{978AF699-FD7C-4A97-83E8-8A117B4D8E92}"/>
+          <p:cNvPr id="11" name="footer">
+            <a:extLst xmlns:a="http://schemas.openxmlformats.org/drawingml/2006/main">
+              <a:ext uri="{FF2B5EF4-FFF2-40B4-BE49-F238E27FC236}">
+                <a16:creationId xmlns:a16="http://schemas.microsoft.com/office/drawing/2014/main" id="{C552C7C9-8974-4D22-BB4D-676F8CCC12C6}"/>
               </a:ext>
             </a:extLst>
           </p:cNvPr>
@@ -14261,10 +15374,10 @@
       </p:sp>
       <p:sp>
         <p:nvSpPr>
-          <p:cNvPr id="10" name="page-number">
-            <a:extLst xmlns:a="http://schemas.openxmlformats.org/drawingml/2006/main">
-              <a:ext uri="{FF2B5EF4-FFF2-40B4-BE49-F238E27FC236}">
-                <a16:creationId xmlns:a16="http://schemas.microsoft.com/office/drawing/2014/main" id="{86A98224-1A82-490D-A7D8-A579DC0B3FDF}"/>
+          <p:cNvPr id="12" name="page-number">
+            <a:extLst xmlns:a="http://schemas.openxmlformats.org/drawingml/2006/main">
+              <a:ext uri="{FF2B5EF4-FFF2-40B4-BE49-F238E27FC236}">
+                <a16:creationId xmlns:a16="http://schemas.microsoft.com/office/drawing/2014/main" id="{6A369D38-36A8-4F6F-896F-1010836D4465}"/>
               </a:ext>
             </a:extLst>
           </p:cNvPr>
@@ -14317,7 +15430,7 @@
     </p:spTree>
     <p:extLst>
       <p:ext uri="{BB962C8B-B14F-4D97-AF65-F5344CB8AC3E}">
-        <p14:creationId xmlns:p14="http://schemas.microsoft.com/office/powerpoint/2010/main" val="1272252404"/>
+        <p14:creationId xmlns:p14="http://schemas.microsoft.com/office/powerpoint/2010/main" val="669555660"/>
       </p:ext>
     </p:extLst>
   </p:cSld>
@@ -14345,10 +15458,10 @@
       </p:grpSpPr>
       <p:sp>
         <p:nvSpPr>
-          <p:cNvPr id="11" name="slide-title">
-            <a:extLst xmlns:a="http://schemas.openxmlformats.org/drawingml/2006/main">
-              <a:ext uri="{FF2B5EF4-FFF2-40B4-BE49-F238E27FC236}">
-                <a16:creationId xmlns:a16="http://schemas.microsoft.com/office/drawing/2014/main" id="{F35CB3EF-349E-4055-BA00-B70F579A422E}"/>
+          <p:cNvPr id="13" name="slide-title">
+            <a:extLst xmlns:a="http://schemas.openxmlformats.org/drawingml/2006/main">
+              <a:ext uri="{FF2B5EF4-FFF2-40B4-BE49-F238E27FC236}">
+                <a16:creationId xmlns:a16="http://schemas.microsoft.com/office/drawing/2014/main" id="{47CCE0C7-42EF-4642-89EA-0256810B3FA9}"/>
               </a:ext>
             </a:extLst>
           </p:cNvPr>
@@ -14399,7 +15512,7 @@
           <p:cNvPr id="2" name="slide-subtitle">
             <a:extLst xmlns:a="http://schemas.openxmlformats.org/drawingml/2006/main">
               <a:ext uri="{FF2B5EF4-FFF2-40B4-BE49-F238E27FC236}">
-                <a16:creationId xmlns:a16="http://schemas.microsoft.com/office/drawing/2014/main" id="{830162A6-B3D9-4115-AF37-C61F37FEBEE6}"/>
+                <a16:creationId xmlns:a16="http://schemas.microsoft.com/office/drawing/2014/main" id="{9CBF582C-CD6C-4FBF-A9A8-1234B6F49706}"/>
               </a:ext>
             </a:extLst>
           </p:cNvPr>
@@ -14450,7 +15563,7 @@
           <p:cNvPr id="3" name="bullets">
             <a:extLst xmlns:a="http://schemas.openxmlformats.org/drawingml/2006/main">
               <a:ext uri="{FF2B5EF4-FFF2-40B4-BE49-F238E27FC236}">
-                <a16:creationId xmlns:a16="http://schemas.microsoft.com/office/drawing/2014/main" id="{A3CDD556-E808-42BD-9A96-FF7962152038}"/>
+                <a16:creationId xmlns:a16="http://schemas.microsoft.com/office/drawing/2014/main" id="{D6C11708-EA90-404C-A19D-D2D6786C1DFD}"/>
               </a:ext>
             </a:extLst>
           </p:cNvPr>
@@ -14537,7 +15650,7 @@
           <p:cNvPr id="4" name="ambient-glow">
             <a:extLst xmlns:a="http://schemas.openxmlformats.org/drawingml/2006/main">
               <a:ext uri="{FF2B5EF4-FFF2-40B4-BE49-F238E27FC236}">
-                <a16:creationId xmlns:a16="http://schemas.microsoft.com/office/drawing/2014/main" id="{1D4FA262-458E-442E-91CB-47E01456DDD1}"/>
+                <a16:creationId xmlns:a16="http://schemas.microsoft.com/office/drawing/2014/main" id="{5D6EF226-2BC8-4A82-9EC4-70441BCCB4C6}"/>
               </a:ext>
             </a:extLst>
           </p:cNvPr>
@@ -14574,7 +15687,7 @@
           <p:cNvPr id="5" name="ambient-core">
             <a:extLst xmlns:a="http://schemas.openxmlformats.org/drawingml/2006/main">
               <a:ext uri="{FF2B5EF4-FFF2-40B4-BE49-F238E27FC236}">
-                <a16:creationId xmlns:a16="http://schemas.microsoft.com/office/drawing/2014/main" id="{BA33EA68-6EE2-4472-BC89-461C434E43C4}"/>
+                <a16:creationId xmlns:a16="http://schemas.microsoft.com/office/drawing/2014/main" id="{D46CA247-5C3D-47B5-BBB3-8B31E237E92C}"/>
               </a:ext>
             </a:extLst>
           </p:cNvPr>
@@ -14611,7 +15724,7 @@
           <p:cNvPr id="6" name="section-number">
             <a:extLst xmlns:a="http://schemas.openxmlformats.org/drawingml/2006/main">
               <a:ext uri="{FF2B5EF4-FFF2-40B4-BE49-F238E27FC236}">
-                <a16:creationId xmlns:a16="http://schemas.microsoft.com/office/drawing/2014/main" id="{89DC2A82-67EF-4DE5-866D-20F83F0EFD36}"/>
+                <a16:creationId xmlns:a16="http://schemas.microsoft.com/office/drawing/2014/main" id="{775762C2-970A-4AAE-BB1F-9FC1A83B6DEC}"/>
               </a:ext>
             </a:extLst>
           </p:cNvPr>
@@ -14662,7 +15775,7 @@
           <p:cNvPr id="7" name="eyebrow">
             <a:extLst xmlns:a="http://schemas.openxmlformats.org/drawingml/2006/main">
               <a:ext uri="{FF2B5EF4-FFF2-40B4-BE49-F238E27FC236}">
-                <a16:creationId xmlns:a16="http://schemas.microsoft.com/office/drawing/2014/main" id="{65749AB4-CAFE-48F8-BE9F-59C37FC4FFAF}"/>
+                <a16:creationId xmlns:a16="http://schemas.microsoft.com/office/drawing/2014/main" id="{FCF19915-0996-4BB8-90CA-11E9E63F811F}"/>
               </a:ext>
             </a:extLst>
           </p:cNvPr>
@@ -14710,10 +15823,69 @@
       </p:sp>
       <p:sp>
         <p:nvSpPr>
-          <p:cNvPr id="8" name="footer-rule">
-            <a:extLst xmlns:a="http://schemas.openxmlformats.org/drawingml/2006/main">
-              <a:ext uri="{FF2B5EF4-FFF2-40B4-BE49-F238E27FC236}">
-                <a16:creationId xmlns:a16="http://schemas.microsoft.com/office/drawing/2014/main" id="{1C54E99B-B3F7-42CE-B586-17C92097A535}"/>
+          <p:cNvPr id="8" name="rescue-point-logo-background">
+            <a:extLst xmlns:a="http://schemas.openxmlformats.org/drawingml/2006/main">
+              <a:ext uri="{FF2B5EF4-FFF2-40B4-BE49-F238E27FC236}">
+                <a16:creationId xmlns:a16="http://schemas.microsoft.com/office/drawing/2014/main" id="{DEC2F284-8D8A-433A-AA4E-C5027E517A8F}"/>
+              </a:ext>
+            </a:extLst>
+          </p:cNvPr>
+          <p:cNvSpPr>
+            <a:spLocks xmlns:a="http://schemas.openxmlformats.org/drawingml/2006/main" noGrp="1"/>
+          </p:cNvSpPr>
+          <p:nvPr/>
+        </p:nvSpPr>
+        <p:spPr>
+          <a:xfrm xmlns:a="http://schemas.openxmlformats.org/drawingml/2006/main">
+            <a:off x="9772650" y="133350"/>
+            <a:ext cx="1733550" cy="457200"/>
+          </a:xfrm>
+          <a:prstGeom xmlns:a="http://schemas.openxmlformats.org/drawingml/2006/main" prst="roundRect">
+            <a:avLst>
+              <a:gd name="adj" fmla="val 16667"/>
+            </a:avLst>
+          </a:prstGeom>
+          <a:solidFill xmlns:a="http://schemas.openxmlformats.org/drawingml/2006/main">
+            <a:srgbClr val="06142E"/>
+          </a:solidFill>
+          <a:ln xmlns:a="http://schemas.openxmlformats.org/drawingml/2006/main" w="9525">
+            <a:solidFill>
+              <a:srgbClr val="1EC5FF">
+                <a:alpha val="33333"/>
+              </a:srgbClr>
+            </a:solidFill>
+            <a:prstDash val="solid"/>
+          </a:ln>
+        </p:spPr>
+      </p:sp>
+      <p:pic>
+        <p:nvPicPr>
+          <p:cNvPr id="23" name="" descr="Figura oficial da documentação dbt usada para explicar: Codespaces é a rota recomendada — Code → Codespaces → Create codespace on main abre o laboratório no navegador.."/>
+          <p:cNvPicPr>
+            <a:picLocks xmlns:a="http://schemas.openxmlformats.org/drawingml/2006/main" noChangeAspect="1"/>
+          </p:cNvPicPr>
+          <p:nvPr/>
+        </p:nvPicPr>
+        <p:blipFill>
+          <a:blip xmlns:r="http://schemas.openxmlformats.org/officeDocument/2006/relationships" xmlns:a="http://schemas.openxmlformats.org/drawingml/2006/main" r:embed="R254256d732954627"/>
+          <a:stretch xmlns:a="http://schemas.openxmlformats.org/drawingml/2006/main"/>
+        </p:blipFill>
+        <p:spPr>
+          <a:xfrm xmlns:a="http://schemas.openxmlformats.org/drawingml/2006/main">
+            <a:off x="9893718" y="209550"/>
+            <a:ext cx="1491414" cy="323850"/>
+          </a:xfrm>
+          <a:prstGeom xmlns:a="http://schemas.openxmlformats.org/drawingml/2006/main" prst="rect">
+            <a:avLst/>
+          </a:prstGeom>
+        </p:spPr>
+      </p:pic>
+      <p:sp>
+        <p:nvSpPr>
+          <p:cNvPr id="10" name="footer-rule">
+            <a:extLst xmlns:a="http://schemas.openxmlformats.org/drawingml/2006/main">
+              <a:ext uri="{FF2B5EF4-FFF2-40B4-BE49-F238E27FC236}">
+                <a16:creationId xmlns:a16="http://schemas.microsoft.com/office/drawing/2014/main" id="{7115030F-7EA0-4F6B-A26D-02AD4E4FFE6A}"/>
               </a:ext>
             </a:extLst>
           </p:cNvPr>
@@ -14743,10 +15915,10 @@
       </p:sp>
       <p:sp>
         <p:nvSpPr>
-          <p:cNvPr id="9" name="footer">
-            <a:extLst xmlns:a="http://schemas.openxmlformats.org/drawingml/2006/main">
-              <a:ext uri="{FF2B5EF4-FFF2-40B4-BE49-F238E27FC236}">
-                <a16:creationId xmlns:a16="http://schemas.microsoft.com/office/drawing/2014/main" id="{C46C7262-7ED9-4C96-B265-CE32F9D409BF}"/>
+          <p:cNvPr id="11" name="footer">
+            <a:extLst xmlns:a="http://schemas.openxmlformats.org/drawingml/2006/main">
+              <a:ext uri="{FF2B5EF4-FFF2-40B4-BE49-F238E27FC236}">
+                <a16:creationId xmlns:a16="http://schemas.microsoft.com/office/drawing/2014/main" id="{33C9DF33-9266-4F8B-AAD2-FC3049EC31CA}"/>
               </a:ext>
             </a:extLst>
           </p:cNvPr>
@@ -14798,10 +15970,10 @@
       </p:sp>
       <p:sp>
         <p:nvSpPr>
-          <p:cNvPr id="10" name="page-number">
-            <a:extLst xmlns:a="http://schemas.openxmlformats.org/drawingml/2006/main">
-              <a:ext uri="{FF2B5EF4-FFF2-40B4-BE49-F238E27FC236}">
-                <a16:creationId xmlns:a16="http://schemas.microsoft.com/office/drawing/2014/main" id="{66870789-9892-432D-B794-EAA5A97828A3}"/>
+          <p:cNvPr id="12" name="page-number">
+            <a:extLst xmlns:a="http://schemas.openxmlformats.org/drawingml/2006/main">
+              <a:ext uri="{FF2B5EF4-FFF2-40B4-BE49-F238E27FC236}">
+                <a16:creationId xmlns:a16="http://schemas.microsoft.com/office/drawing/2014/main" id="{B1074DA3-66F1-45EE-8AEA-41E621936C08}"/>
               </a:ext>
             </a:extLst>
           </p:cNvPr>
@@ -14854,7 +16026,7 @@
     </p:spTree>
     <p:extLst>
       <p:ext uri="{BB962C8B-B14F-4D97-AF65-F5344CB8AC3E}">
-        <p14:creationId xmlns:p14="http://schemas.microsoft.com/office/powerpoint/2010/main" val="1406880801"/>
+        <p14:creationId xmlns:p14="http://schemas.microsoft.com/office/powerpoint/2010/main" val="554206095"/>
       </p:ext>
     </p:extLst>
   </p:cSld>
@@ -14890,10 +16062,10 @@
       </p:grpSpPr>
       <p:sp>
         <p:nvSpPr>
-          <p:cNvPr id="10" name="slide-title">
-            <a:extLst xmlns:a="http://schemas.openxmlformats.org/drawingml/2006/main">
-              <a:ext uri="{FF2B5EF4-FFF2-40B4-BE49-F238E27FC236}">
-                <a16:creationId xmlns:a16="http://schemas.microsoft.com/office/drawing/2014/main" id="{A7A40CB5-2945-4B7F-910F-81CF05B27E01}"/>
+          <p:cNvPr id="12" name="slide-title">
+            <a:extLst xmlns:a="http://schemas.openxmlformats.org/drawingml/2006/main">
+              <a:ext uri="{FF2B5EF4-FFF2-40B4-BE49-F238E27FC236}">
+                <a16:creationId xmlns:a16="http://schemas.microsoft.com/office/drawing/2014/main" id="{29086E7E-0FC9-4D86-B5EE-B765BD6331A7}"/>
               </a:ext>
             </a:extLst>
           </p:cNvPr>
@@ -14944,7 +16116,7 @@
           <p:cNvPr id="2" name="visual-claim">
             <a:extLst xmlns:a="http://schemas.openxmlformats.org/drawingml/2006/main">
               <a:ext uri="{FF2B5EF4-FFF2-40B4-BE49-F238E27FC236}">
-                <a16:creationId xmlns:a16="http://schemas.microsoft.com/office/drawing/2014/main" id="{B804B8C4-AF1F-454E-9EDD-2C23A1628CCF}"/>
+                <a16:creationId xmlns:a16="http://schemas.microsoft.com/office/drawing/2014/main" id="{3BA8B354-5F93-4067-B93B-60C8A17BC75C}"/>
               </a:ext>
             </a:extLst>
           </p:cNvPr>
@@ -14995,7 +16167,7 @@
           <p:cNvPr id="3" name="image-surface">
             <a:extLst xmlns:a="http://schemas.openxmlformats.org/drawingml/2006/main">
               <a:ext uri="{FF2B5EF4-FFF2-40B4-BE49-F238E27FC236}">
-                <a16:creationId xmlns:a16="http://schemas.microsoft.com/office/drawing/2014/main" id="{F6CBC4CE-A089-43DC-9CC7-65997C39DDD6}"/>
+                <a16:creationId xmlns:a16="http://schemas.microsoft.com/office/drawing/2014/main" id="{E5B093C2-D83B-454D-A86A-40C40955BB93}"/>
               </a:ext>
             </a:extLst>
           </p:cNvPr>
@@ -15029,14 +16201,14 @@
       </p:sp>
       <p:pic>
         <p:nvPicPr>
-          <p:cNvPr id="15" name="" descr="Figura oficial da documentação dbt usada para explicar: Codespaces é a rota recomendada — Code → Codespaces → Create codespace on main abre o laboratório no navegador.."/>
+          <p:cNvPr id="18" name="" descr="Figura oficial da documentação dbt usada para explicar: Codespaces é a rota recomendada — Code → Codespaces → Create codespace on main abre o laboratório no navegador.."/>
           <p:cNvPicPr>
             <a:picLocks xmlns:a="http://schemas.openxmlformats.org/drawingml/2006/main" noChangeAspect="1"/>
           </p:cNvPicPr>
           <p:nvPr/>
         </p:nvPicPr>
         <p:blipFill>
-          <a:blip xmlns:r="http://schemas.openxmlformats.org/officeDocument/2006/relationships" xmlns:a="http://schemas.openxmlformats.org/drawingml/2006/main" r:embed="Radc9b64350214638"/>
+          <a:blip xmlns:r="http://schemas.openxmlformats.org/officeDocument/2006/relationships" xmlns:a="http://schemas.openxmlformats.org/drawingml/2006/main" r:embed="R9cb0f87538b44b85"/>
           <a:stretch xmlns:a="http://schemas.openxmlformats.org/drawingml/2006/main"/>
         </p:blipFill>
         <p:spPr>
@@ -15054,7 +16226,7 @@
           <p:cNvPr id="5" name="image-caption">
             <a:extLst xmlns:a="http://schemas.openxmlformats.org/drawingml/2006/main">
               <a:ext uri="{FF2B5EF4-FFF2-40B4-BE49-F238E27FC236}">
-                <a16:creationId xmlns:a16="http://schemas.microsoft.com/office/drawing/2014/main" id="{E61F62D8-104A-4100-A6AA-A2D0B6DE6B05}"/>
+                <a16:creationId xmlns:a16="http://schemas.microsoft.com/office/drawing/2014/main" id="{D818048D-7B3D-4ADD-BA0A-D3846DC3C519}"/>
               </a:ext>
             </a:extLst>
           </p:cNvPr>
@@ -15105,7 +16277,7 @@
           <p:cNvPr id="6" name="eyebrow">
             <a:extLst xmlns:a="http://schemas.openxmlformats.org/drawingml/2006/main">
               <a:ext uri="{FF2B5EF4-FFF2-40B4-BE49-F238E27FC236}">
-                <a16:creationId xmlns:a16="http://schemas.microsoft.com/office/drawing/2014/main" id="{F06B60A7-1305-4D5F-9894-146B9AA9157C}"/>
+                <a16:creationId xmlns:a16="http://schemas.microsoft.com/office/drawing/2014/main" id="{917A98A5-03AE-4E97-9BB6-DC2D739580B1}"/>
               </a:ext>
             </a:extLst>
           </p:cNvPr>
@@ -15153,10 +16325,69 @@
       </p:sp>
       <p:sp>
         <p:nvSpPr>
-          <p:cNvPr id="7" name="footer-rule">
-            <a:extLst xmlns:a="http://schemas.openxmlformats.org/drawingml/2006/main">
-              <a:ext uri="{FF2B5EF4-FFF2-40B4-BE49-F238E27FC236}">
-                <a16:creationId xmlns:a16="http://schemas.microsoft.com/office/drawing/2014/main" id="{49263CEE-DE3F-460B-A2DE-11AC00CC44B4}"/>
+          <p:cNvPr id="7" name="rescue-point-logo-background">
+            <a:extLst xmlns:a="http://schemas.openxmlformats.org/drawingml/2006/main">
+              <a:ext uri="{FF2B5EF4-FFF2-40B4-BE49-F238E27FC236}">
+                <a16:creationId xmlns:a16="http://schemas.microsoft.com/office/drawing/2014/main" id="{D59D8292-CD50-4FAE-B51C-41780EC98259}"/>
+              </a:ext>
+            </a:extLst>
+          </p:cNvPr>
+          <p:cNvSpPr>
+            <a:spLocks xmlns:a="http://schemas.openxmlformats.org/drawingml/2006/main" noGrp="1"/>
+          </p:cNvSpPr>
+          <p:nvPr/>
+        </p:nvSpPr>
+        <p:spPr>
+          <a:xfrm xmlns:a="http://schemas.openxmlformats.org/drawingml/2006/main">
+            <a:off x="9772650" y="133350"/>
+            <a:ext cx="1733550" cy="457200"/>
+          </a:xfrm>
+          <a:prstGeom xmlns:a="http://schemas.openxmlformats.org/drawingml/2006/main" prst="roundRect">
+            <a:avLst>
+              <a:gd name="adj" fmla="val 16667"/>
+            </a:avLst>
+          </a:prstGeom>
+          <a:solidFill xmlns:a="http://schemas.openxmlformats.org/drawingml/2006/main">
+            <a:srgbClr val="06142E"/>
+          </a:solidFill>
+          <a:ln xmlns:a="http://schemas.openxmlformats.org/drawingml/2006/main" w="9525">
+            <a:solidFill>
+              <a:srgbClr val="1EC5FF">
+                <a:alpha val="33333"/>
+              </a:srgbClr>
+            </a:solidFill>
+            <a:prstDash val="solid"/>
+          </a:ln>
+        </p:spPr>
+      </p:sp>
+      <p:pic>
+        <p:nvPicPr>
+          <p:cNvPr id="22" name="" descr="Figura oficial da documentação dbt usada para explicar: Codespaces é a rota recomendada — Code → Codespaces → Create codespace on main abre o laboratório no navegador.."/>
+          <p:cNvPicPr>
+            <a:picLocks xmlns:a="http://schemas.openxmlformats.org/drawingml/2006/main" noChangeAspect="1"/>
+          </p:cNvPicPr>
+          <p:nvPr/>
+        </p:nvPicPr>
+        <p:blipFill>
+          <a:blip xmlns:r="http://schemas.openxmlformats.org/officeDocument/2006/relationships" xmlns:a="http://schemas.openxmlformats.org/drawingml/2006/main" r:embed="R920ef1f492de4758"/>
+          <a:stretch xmlns:a="http://schemas.openxmlformats.org/drawingml/2006/main"/>
+        </p:blipFill>
+        <p:spPr>
+          <a:xfrm xmlns:a="http://schemas.openxmlformats.org/drawingml/2006/main">
+            <a:off x="9893718" y="209550"/>
+            <a:ext cx="1491414" cy="323850"/>
+          </a:xfrm>
+          <a:prstGeom xmlns:a="http://schemas.openxmlformats.org/drawingml/2006/main" prst="rect">
+            <a:avLst/>
+          </a:prstGeom>
+        </p:spPr>
+      </p:pic>
+      <p:sp>
+        <p:nvSpPr>
+          <p:cNvPr id="9" name="footer-rule">
+            <a:extLst xmlns:a="http://schemas.openxmlformats.org/drawingml/2006/main">
+              <a:ext uri="{FF2B5EF4-FFF2-40B4-BE49-F238E27FC236}">
+                <a16:creationId xmlns:a16="http://schemas.microsoft.com/office/drawing/2014/main" id="{5C9D743C-40F0-4639-99C1-50DD35394054}"/>
               </a:ext>
             </a:extLst>
           </p:cNvPr>
@@ -15186,10 +16417,10 @@
       </p:sp>
       <p:sp>
         <p:nvSpPr>
-          <p:cNvPr id="8" name="footer">
-            <a:extLst xmlns:a="http://schemas.openxmlformats.org/drawingml/2006/main">
-              <a:ext uri="{FF2B5EF4-FFF2-40B4-BE49-F238E27FC236}">
-                <a16:creationId xmlns:a16="http://schemas.microsoft.com/office/drawing/2014/main" id="{D9CD25F7-BC22-41A9-860D-AF3A34F3F4AA}"/>
+          <p:cNvPr id="10" name="footer">
+            <a:extLst xmlns:a="http://schemas.openxmlformats.org/drawingml/2006/main">
+              <a:ext uri="{FF2B5EF4-FFF2-40B4-BE49-F238E27FC236}">
+                <a16:creationId xmlns:a16="http://schemas.microsoft.com/office/drawing/2014/main" id="{61029F33-5371-4866-BE43-A9B4B27314C7}"/>
               </a:ext>
             </a:extLst>
           </p:cNvPr>
@@ -15241,10 +16472,10 @@
       </p:sp>
       <p:sp>
         <p:nvSpPr>
-          <p:cNvPr id="9" name="page-number">
-            <a:extLst xmlns:a="http://schemas.openxmlformats.org/drawingml/2006/main">
-              <a:ext uri="{FF2B5EF4-FFF2-40B4-BE49-F238E27FC236}">
-                <a16:creationId xmlns:a16="http://schemas.microsoft.com/office/drawing/2014/main" id="{0B801A05-47A3-4376-A566-F5108D0A85A4}"/>
+          <p:cNvPr id="11" name="page-number">
+            <a:extLst xmlns:a="http://schemas.openxmlformats.org/drawingml/2006/main">
+              <a:ext uri="{FF2B5EF4-FFF2-40B4-BE49-F238E27FC236}">
+                <a16:creationId xmlns:a16="http://schemas.microsoft.com/office/drawing/2014/main" id="{BFF1D0C8-3F49-46E1-B1B1-21FE8C7200E3}"/>
               </a:ext>
             </a:extLst>
           </p:cNvPr>
@@ -15297,7 +16528,7 @@
     </p:spTree>
     <p:extLst>
       <p:ext uri="{BB962C8B-B14F-4D97-AF65-F5344CB8AC3E}">
-        <p14:creationId xmlns:p14="http://schemas.microsoft.com/office/powerpoint/2010/main" val="37331508"/>
+        <p14:creationId xmlns:p14="http://schemas.microsoft.com/office/powerpoint/2010/main" val="878422373"/>
       </p:ext>
     </p:extLst>
   </p:cSld>
@@ -15333,10 +16564,10 @@
       </p:grpSpPr>
       <p:sp>
         <p:nvSpPr>
-          <p:cNvPr id="11" name="slide-title">
-            <a:extLst xmlns:a="http://schemas.openxmlformats.org/drawingml/2006/main">
-              <a:ext uri="{FF2B5EF4-FFF2-40B4-BE49-F238E27FC236}">
-                <a16:creationId xmlns:a16="http://schemas.microsoft.com/office/drawing/2014/main" id="{38886520-DF39-448A-A0C9-C7238D0ECD63}"/>
+          <p:cNvPr id="13" name="slide-title">
+            <a:extLst xmlns:a="http://schemas.openxmlformats.org/drawingml/2006/main">
+              <a:ext uri="{FF2B5EF4-FFF2-40B4-BE49-F238E27FC236}">
+                <a16:creationId xmlns:a16="http://schemas.microsoft.com/office/drawing/2014/main" id="{569118C2-C6A2-4E75-AD75-6FFF980C7142}"/>
               </a:ext>
             </a:extLst>
           </p:cNvPr>
@@ -15387,7 +16618,7 @@
           <p:cNvPr id="2" name="slide-subtitle">
             <a:extLst xmlns:a="http://schemas.openxmlformats.org/drawingml/2006/main">
               <a:ext uri="{FF2B5EF4-FFF2-40B4-BE49-F238E27FC236}">
-                <a16:creationId xmlns:a16="http://schemas.microsoft.com/office/drawing/2014/main" id="{CDF48FAD-0D99-4379-8EAA-8BD4BEB79C51}"/>
+                <a16:creationId xmlns:a16="http://schemas.microsoft.com/office/drawing/2014/main" id="{94686BB2-7672-4060-829B-11E071FC5DD8}"/>
               </a:ext>
             </a:extLst>
           </p:cNvPr>
@@ -15438,7 +16669,7 @@
           <p:cNvPr id="3" name="bullets">
             <a:extLst xmlns:a="http://schemas.openxmlformats.org/drawingml/2006/main">
               <a:ext uri="{FF2B5EF4-FFF2-40B4-BE49-F238E27FC236}">
-                <a16:creationId xmlns:a16="http://schemas.microsoft.com/office/drawing/2014/main" id="{61A20AE3-708C-4EFB-8AED-D91A85C2D3BE}"/>
+                <a16:creationId xmlns:a16="http://schemas.microsoft.com/office/drawing/2014/main" id="{42CDF460-1385-4731-A654-8F3FD66475A3}"/>
               </a:ext>
             </a:extLst>
           </p:cNvPr>
@@ -15543,7 +16774,7 @@
           <p:cNvPr id="4" name="ambient-glow">
             <a:extLst xmlns:a="http://schemas.openxmlformats.org/drawingml/2006/main">
               <a:ext uri="{FF2B5EF4-FFF2-40B4-BE49-F238E27FC236}">
-                <a16:creationId xmlns:a16="http://schemas.microsoft.com/office/drawing/2014/main" id="{7D5E3581-4D02-4803-9B59-3076682838B1}"/>
+                <a16:creationId xmlns:a16="http://schemas.microsoft.com/office/drawing/2014/main" id="{3F51C740-91B7-4426-93AA-4943DF5FEC22}"/>
               </a:ext>
             </a:extLst>
           </p:cNvPr>
@@ -15580,7 +16811,7 @@
           <p:cNvPr id="5" name="ambient-core">
             <a:extLst xmlns:a="http://schemas.openxmlformats.org/drawingml/2006/main">
               <a:ext uri="{FF2B5EF4-FFF2-40B4-BE49-F238E27FC236}">
-                <a16:creationId xmlns:a16="http://schemas.microsoft.com/office/drawing/2014/main" id="{32B1D452-C31B-4677-A17E-27D93959F23E}"/>
+                <a16:creationId xmlns:a16="http://schemas.microsoft.com/office/drawing/2014/main" id="{B11CF87F-51B6-4DEB-A759-0A73D856D5BB}"/>
               </a:ext>
             </a:extLst>
           </p:cNvPr>
@@ -15617,7 +16848,7 @@
           <p:cNvPr id="6" name="section-number">
             <a:extLst xmlns:a="http://schemas.openxmlformats.org/drawingml/2006/main">
               <a:ext uri="{FF2B5EF4-FFF2-40B4-BE49-F238E27FC236}">
-                <a16:creationId xmlns:a16="http://schemas.microsoft.com/office/drawing/2014/main" id="{1840F980-4393-4E79-9ABC-DBACB3D3EE72}"/>
+                <a16:creationId xmlns:a16="http://schemas.microsoft.com/office/drawing/2014/main" id="{1D9346CC-481E-4F84-9108-7B785CDB2B9D}"/>
               </a:ext>
             </a:extLst>
           </p:cNvPr>
@@ -15668,7 +16899,7 @@
           <p:cNvPr id="7" name="eyebrow">
             <a:extLst xmlns:a="http://schemas.openxmlformats.org/drawingml/2006/main">
               <a:ext uri="{FF2B5EF4-FFF2-40B4-BE49-F238E27FC236}">
-                <a16:creationId xmlns:a16="http://schemas.microsoft.com/office/drawing/2014/main" id="{5C1B52D9-B47B-4A2D-A803-604E939D1D12}"/>
+                <a16:creationId xmlns:a16="http://schemas.microsoft.com/office/drawing/2014/main" id="{FF2F874C-6916-42DE-99C5-FCC77108C552}"/>
               </a:ext>
             </a:extLst>
           </p:cNvPr>
@@ -15716,10 +16947,69 @@
       </p:sp>
       <p:sp>
         <p:nvSpPr>
-          <p:cNvPr id="8" name="footer-rule">
-            <a:extLst xmlns:a="http://schemas.openxmlformats.org/drawingml/2006/main">
-              <a:ext uri="{FF2B5EF4-FFF2-40B4-BE49-F238E27FC236}">
-                <a16:creationId xmlns:a16="http://schemas.microsoft.com/office/drawing/2014/main" id="{5CA6F433-D8F9-402C-AB38-F4F42ECEE88E}"/>
+          <p:cNvPr id="8" name="rescue-point-logo-background">
+            <a:extLst xmlns:a="http://schemas.openxmlformats.org/drawingml/2006/main">
+              <a:ext uri="{FF2B5EF4-FFF2-40B4-BE49-F238E27FC236}">
+                <a16:creationId xmlns:a16="http://schemas.microsoft.com/office/drawing/2014/main" id="{DC6D3556-2917-4433-934C-F936A794D4A5}"/>
+              </a:ext>
+            </a:extLst>
+          </p:cNvPr>
+          <p:cNvSpPr>
+            <a:spLocks xmlns:a="http://schemas.openxmlformats.org/drawingml/2006/main" noGrp="1"/>
+          </p:cNvSpPr>
+          <p:nvPr/>
+        </p:nvSpPr>
+        <p:spPr>
+          <a:xfrm xmlns:a="http://schemas.openxmlformats.org/drawingml/2006/main">
+            <a:off x="9772650" y="133350"/>
+            <a:ext cx="1733550" cy="457200"/>
+          </a:xfrm>
+          <a:prstGeom xmlns:a="http://schemas.openxmlformats.org/drawingml/2006/main" prst="roundRect">
+            <a:avLst>
+              <a:gd name="adj" fmla="val 16667"/>
+            </a:avLst>
+          </a:prstGeom>
+          <a:solidFill xmlns:a="http://schemas.openxmlformats.org/drawingml/2006/main">
+            <a:srgbClr val="06142E"/>
+          </a:solidFill>
+          <a:ln xmlns:a="http://schemas.openxmlformats.org/drawingml/2006/main" w="9525">
+            <a:solidFill>
+              <a:srgbClr val="1EC5FF">
+                <a:alpha val="33333"/>
+              </a:srgbClr>
+            </a:solidFill>
+            <a:prstDash val="solid"/>
+          </a:ln>
+        </p:spPr>
+      </p:sp>
+      <p:pic>
+        <p:nvPicPr>
+          <p:cNvPr id="23" name="" descr="Figura oficial da documentação dbt usada para explicar: 2-core preserva a franquia gratuita — GitHub Free inclui 120 core-hours e 15 GB-mês; em 2-core, são cerca de 60 horas ativas.."/>
+          <p:cNvPicPr>
+            <a:picLocks xmlns:a="http://schemas.openxmlformats.org/drawingml/2006/main" noChangeAspect="1"/>
+          </p:cNvPicPr>
+          <p:nvPr/>
+        </p:nvPicPr>
+        <p:blipFill>
+          <a:blip xmlns:r="http://schemas.openxmlformats.org/officeDocument/2006/relationships" xmlns:a="http://schemas.openxmlformats.org/drawingml/2006/main" r:embed="Ra2adae2961ff4530"/>
+          <a:stretch xmlns:a="http://schemas.openxmlformats.org/drawingml/2006/main"/>
+        </p:blipFill>
+        <p:spPr>
+          <a:xfrm xmlns:a="http://schemas.openxmlformats.org/drawingml/2006/main">
+            <a:off x="9893718" y="209550"/>
+            <a:ext cx="1491414" cy="323850"/>
+          </a:xfrm>
+          <a:prstGeom xmlns:a="http://schemas.openxmlformats.org/drawingml/2006/main" prst="rect">
+            <a:avLst/>
+          </a:prstGeom>
+        </p:spPr>
+      </p:pic>
+      <p:sp>
+        <p:nvSpPr>
+          <p:cNvPr id="10" name="footer-rule">
+            <a:extLst xmlns:a="http://schemas.openxmlformats.org/drawingml/2006/main">
+              <a:ext uri="{FF2B5EF4-FFF2-40B4-BE49-F238E27FC236}">
+                <a16:creationId xmlns:a16="http://schemas.microsoft.com/office/drawing/2014/main" id="{3D97B7A0-EDB8-4160-9281-ECC3623C0043}"/>
               </a:ext>
             </a:extLst>
           </p:cNvPr>
@@ -15749,10 +17039,10 @@
       </p:sp>
       <p:sp>
         <p:nvSpPr>
-          <p:cNvPr id="9" name="footer">
-            <a:extLst xmlns:a="http://schemas.openxmlformats.org/drawingml/2006/main">
-              <a:ext uri="{FF2B5EF4-FFF2-40B4-BE49-F238E27FC236}">
-                <a16:creationId xmlns:a16="http://schemas.microsoft.com/office/drawing/2014/main" id="{71DB4F32-F85A-4137-88A1-F31D7CD60CD4}"/>
+          <p:cNvPr id="11" name="footer">
+            <a:extLst xmlns:a="http://schemas.openxmlformats.org/drawingml/2006/main">
+              <a:ext uri="{FF2B5EF4-FFF2-40B4-BE49-F238E27FC236}">
+                <a16:creationId xmlns:a16="http://schemas.microsoft.com/office/drawing/2014/main" id="{0C735F95-E078-4953-A394-2EC2FD2B795E}"/>
               </a:ext>
             </a:extLst>
           </p:cNvPr>
@@ -15804,10 +17094,10 @@
       </p:sp>
       <p:sp>
         <p:nvSpPr>
-          <p:cNvPr id="10" name="page-number">
-            <a:extLst xmlns:a="http://schemas.openxmlformats.org/drawingml/2006/main">
-              <a:ext uri="{FF2B5EF4-FFF2-40B4-BE49-F238E27FC236}">
-                <a16:creationId xmlns:a16="http://schemas.microsoft.com/office/drawing/2014/main" id="{B5D45D84-0824-417D-A841-42127761962D}"/>
+          <p:cNvPr id="12" name="page-number">
+            <a:extLst xmlns:a="http://schemas.openxmlformats.org/drawingml/2006/main">
+              <a:ext uri="{FF2B5EF4-FFF2-40B4-BE49-F238E27FC236}">
+                <a16:creationId xmlns:a16="http://schemas.microsoft.com/office/drawing/2014/main" id="{3665C999-5DCB-4A57-A463-BED6F199843F}"/>
               </a:ext>
             </a:extLst>
           </p:cNvPr>
@@ -15860,7 +17150,7 @@
     </p:spTree>
     <p:extLst>
       <p:ext uri="{BB962C8B-B14F-4D97-AF65-F5344CB8AC3E}">
-        <p14:creationId xmlns:p14="http://schemas.microsoft.com/office/powerpoint/2010/main" val="1850666622"/>
+        <p14:creationId xmlns:p14="http://schemas.microsoft.com/office/powerpoint/2010/main" val="2121903061"/>
       </p:ext>
     </p:extLst>
   </p:cSld>
@@ -15888,10 +17178,10 @@
       </p:grpSpPr>
       <p:sp>
         <p:nvSpPr>
-          <p:cNvPr id="10" name="slide-title">
-            <a:extLst xmlns:a="http://schemas.openxmlformats.org/drawingml/2006/main">
-              <a:ext uri="{FF2B5EF4-FFF2-40B4-BE49-F238E27FC236}">
-                <a16:creationId xmlns:a16="http://schemas.microsoft.com/office/drawing/2014/main" id="{E971B1FB-659A-4397-9A08-8E15088F1B1E}"/>
+          <p:cNvPr id="12" name="slide-title">
+            <a:extLst xmlns:a="http://schemas.openxmlformats.org/drawingml/2006/main">
+              <a:ext uri="{FF2B5EF4-FFF2-40B4-BE49-F238E27FC236}">
+                <a16:creationId xmlns:a16="http://schemas.microsoft.com/office/drawing/2014/main" id="{0218A707-650D-4F01-9153-1FB95627FDF7}"/>
               </a:ext>
             </a:extLst>
           </p:cNvPr>
@@ -15942,7 +17232,7 @@
           <p:cNvPr id="2" name="visual-claim">
             <a:extLst xmlns:a="http://schemas.openxmlformats.org/drawingml/2006/main">
               <a:ext uri="{FF2B5EF4-FFF2-40B4-BE49-F238E27FC236}">
-                <a16:creationId xmlns:a16="http://schemas.microsoft.com/office/drawing/2014/main" id="{73BA4EA2-CDC3-49AF-B35C-A6585CD86BFE}"/>
+                <a16:creationId xmlns:a16="http://schemas.microsoft.com/office/drawing/2014/main" id="{F729CDCC-0408-4073-A396-034E82414989}"/>
               </a:ext>
             </a:extLst>
           </p:cNvPr>
@@ -15993,7 +17283,7 @@
           <p:cNvPr id="3" name="image-surface">
             <a:extLst xmlns:a="http://schemas.openxmlformats.org/drawingml/2006/main">
               <a:ext uri="{FF2B5EF4-FFF2-40B4-BE49-F238E27FC236}">
-                <a16:creationId xmlns:a16="http://schemas.microsoft.com/office/drawing/2014/main" id="{9A864C97-FCAF-4F61-8C68-C1015264F1F3}"/>
+                <a16:creationId xmlns:a16="http://schemas.microsoft.com/office/drawing/2014/main" id="{206950D9-7240-46AD-99D4-9F06E49E0AF5}"/>
               </a:ext>
             </a:extLst>
           </p:cNvPr>
@@ -16025,14 +17315,14 @@
       </p:sp>
       <p:pic>
         <p:nvPicPr>
-          <p:cNvPr id="15" name="" descr="Figura oficial da documentação dbt usada para explicar: 2-core preserva a franquia gratuita — GitHub Free inclui 120 core-hours e 15 GB-mês; em 2-core, são cerca de 60 horas ativas.."/>
+          <p:cNvPr id="18" name="" descr="Figura oficial da documentação dbt usada para explicar: 2-core preserva a franquia gratuita — GitHub Free inclui 120 core-hours e 15 GB-mês; em 2-core, são cerca de 60 horas ativas.."/>
           <p:cNvPicPr>
             <a:picLocks xmlns:a="http://schemas.openxmlformats.org/drawingml/2006/main" noChangeAspect="1"/>
           </p:cNvPicPr>
           <p:nvPr/>
         </p:nvPicPr>
         <p:blipFill>
-          <a:blip xmlns:r="http://schemas.openxmlformats.org/officeDocument/2006/relationships" xmlns:a="http://schemas.openxmlformats.org/drawingml/2006/main" r:embed="Ra710b4a6a85243ba"/>
+          <a:blip xmlns:r="http://schemas.openxmlformats.org/officeDocument/2006/relationships" xmlns:a="http://schemas.openxmlformats.org/drawingml/2006/main" r:embed="R82482e2ea9d84387"/>
           <a:stretch xmlns:a="http://schemas.openxmlformats.org/drawingml/2006/main"/>
         </p:blipFill>
         <p:spPr>
@@ -16050,7 +17340,7 @@
           <p:cNvPr id="5" name="image-caption">
             <a:extLst xmlns:a="http://schemas.openxmlformats.org/drawingml/2006/main">
               <a:ext uri="{FF2B5EF4-FFF2-40B4-BE49-F238E27FC236}">
-                <a16:creationId xmlns:a16="http://schemas.microsoft.com/office/drawing/2014/main" id="{AD4F9E01-1BEE-40BD-B0AA-48C44CDC0151}"/>
+                <a16:creationId xmlns:a16="http://schemas.microsoft.com/office/drawing/2014/main" id="{24796614-0038-4792-8219-8E460A8D820F}"/>
               </a:ext>
             </a:extLst>
           </p:cNvPr>
@@ -16101,7 +17391,7 @@
           <p:cNvPr id="6" name="eyebrow">
             <a:extLst xmlns:a="http://schemas.openxmlformats.org/drawingml/2006/main">
               <a:ext uri="{FF2B5EF4-FFF2-40B4-BE49-F238E27FC236}">
-                <a16:creationId xmlns:a16="http://schemas.microsoft.com/office/drawing/2014/main" id="{597B0722-A03F-4EFE-8193-CA813E2C17A5}"/>
+                <a16:creationId xmlns:a16="http://schemas.microsoft.com/office/drawing/2014/main" id="{915349CA-7CC7-46B6-91F6-5695A6497611}"/>
               </a:ext>
             </a:extLst>
           </p:cNvPr>
@@ -16149,10 +17439,69 @@
       </p:sp>
       <p:sp>
         <p:nvSpPr>
-          <p:cNvPr id="7" name="footer-rule">
-            <a:extLst xmlns:a="http://schemas.openxmlformats.org/drawingml/2006/main">
-              <a:ext uri="{FF2B5EF4-FFF2-40B4-BE49-F238E27FC236}">
-                <a16:creationId xmlns:a16="http://schemas.microsoft.com/office/drawing/2014/main" id="{555402EE-9589-4BBC-91BD-E409F1745561}"/>
+          <p:cNvPr id="7" name="rescue-point-logo-background">
+            <a:extLst xmlns:a="http://schemas.openxmlformats.org/drawingml/2006/main">
+              <a:ext uri="{FF2B5EF4-FFF2-40B4-BE49-F238E27FC236}">
+                <a16:creationId xmlns:a16="http://schemas.microsoft.com/office/drawing/2014/main" id="{931DAFBB-829C-49EC-81A8-D35D24EA117D}"/>
+              </a:ext>
+            </a:extLst>
+          </p:cNvPr>
+          <p:cNvSpPr>
+            <a:spLocks xmlns:a="http://schemas.openxmlformats.org/drawingml/2006/main" noGrp="1"/>
+          </p:cNvSpPr>
+          <p:nvPr/>
+        </p:nvSpPr>
+        <p:spPr>
+          <a:xfrm xmlns:a="http://schemas.openxmlformats.org/drawingml/2006/main">
+            <a:off x="9772650" y="133350"/>
+            <a:ext cx="1733550" cy="457200"/>
+          </a:xfrm>
+          <a:prstGeom xmlns:a="http://schemas.openxmlformats.org/drawingml/2006/main" prst="roundRect">
+            <a:avLst>
+              <a:gd name="adj" fmla="val 16667"/>
+            </a:avLst>
+          </a:prstGeom>
+          <a:solidFill xmlns:a="http://schemas.openxmlformats.org/drawingml/2006/main">
+            <a:srgbClr val="06142E"/>
+          </a:solidFill>
+          <a:ln xmlns:a="http://schemas.openxmlformats.org/drawingml/2006/main" w="9525">
+            <a:solidFill>
+              <a:srgbClr val="1EC5FF">
+                <a:alpha val="33333"/>
+              </a:srgbClr>
+            </a:solidFill>
+            <a:prstDash val="solid"/>
+          </a:ln>
+        </p:spPr>
+      </p:sp>
+      <p:pic>
+        <p:nvPicPr>
+          <p:cNvPr id="22" name="" descr="Figura oficial da documentação dbt usada para explicar: 2-core preserva a franquia gratuita — GitHub Free inclui 120 core-hours e 15 GB-mês; em 2-core, são cerca de 60 horas ativas.."/>
+          <p:cNvPicPr>
+            <a:picLocks xmlns:a="http://schemas.openxmlformats.org/drawingml/2006/main" noChangeAspect="1"/>
+          </p:cNvPicPr>
+          <p:nvPr/>
+        </p:nvPicPr>
+        <p:blipFill>
+          <a:blip xmlns:r="http://schemas.openxmlformats.org/officeDocument/2006/relationships" xmlns:a="http://schemas.openxmlformats.org/drawingml/2006/main" r:embed="R8eea3b2285ed49cf"/>
+          <a:stretch xmlns:a="http://schemas.openxmlformats.org/drawingml/2006/main"/>
+        </p:blipFill>
+        <p:spPr>
+          <a:xfrm xmlns:a="http://schemas.openxmlformats.org/drawingml/2006/main">
+            <a:off x="9893718" y="209550"/>
+            <a:ext cx="1491414" cy="323850"/>
+          </a:xfrm>
+          <a:prstGeom xmlns:a="http://schemas.openxmlformats.org/drawingml/2006/main" prst="rect">
+            <a:avLst/>
+          </a:prstGeom>
+        </p:spPr>
+      </p:pic>
+      <p:sp>
+        <p:nvSpPr>
+          <p:cNvPr id="9" name="footer-rule">
+            <a:extLst xmlns:a="http://schemas.openxmlformats.org/drawingml/2006/main">
+              <a:ext uri="{FF2B5EF4-FFF2-40B4-BE49-F238E27FC236}">
+                <a16:creationId xmlns:a16="http://schemas.microsoft.com/office/drawing/2014/main" id="{D18F8B4A-3586-4DD2-9EB6-593CD0BBB355}"/>
               </a:ext>
             </a:extLst>
           </p:cNvPr>
@@ -16182,10 +17531,10 @@
       </p:sp>
       <p:sp>
         <p:nvSpPr>
-          <p:cNvPr id="8" name="footer">
-            <a:extLst xmlns:a="http://schemas.openxmlformats.org/drawingml/2006/main">
-              <a:ext uri="{FF2B5EF4-FFF2-40B4-BE49-F238E27FC236}">
-                <a16:creationId xmlns:a16="http://schemas.microsoft.com/office/drawing/2014/main" id="{0EE65EB3-52F7-4AD5-B97A-A09DA9C7A71C}"/>
+          <p:cNvPr id="10" name="footer">
+            <a:extLst xmlns:a="http://schemas.openxmlformats.org/drawingml/2006/main">
+              <a:ext uri="{FF2B5EF4-FFF2-40B4-BE49-F238E27FC236}">
+                <a16:creationId xmlns:a16="http://schemas.microsoft.com/office/drawing/2014/main" id="{14BD3289-A291-4EB0-AF0A-161FED893239}"/>
               </a:ext>
             </a:extLst>
           </p:cNvPr>
@@ -16237,10 +17586,10 @@
       </p:sp>
       <p:sp>
         <p:nvSpPr>
-          <p:cNvPr id="9" name="page-number">
-            <a:extLst xmlns:a="http://schemas.openxmlformats.org/drawingml/2006/main">
-              <a:ext uri="{FF2B5EF4-FFF2-40B4-BE49-F238E27FC236}">
-                <a16:creationId xmlns:a16="http://schemas.microsoft.com/office/drawing/2014/main" id="{4B593467-9DFF-405B-86A1-3F713AEC5DFA}"/>
+          <p:cNvPr id="11" name="page-number">
+            <a:extLst xmlns:a="http://schemas.openxmlformats.org/drawingml/2006/main">
+              <a:ext uri="{FF2B5EF4-FFF2-40B4-BE49-F238E27FC236}">
+                <a16:creationId xmlns:a16="http://schemas.microsoft.com/office/drawing/2014/main" id="{40A8EE3C-9810-41C3-9B31-5AD2C0362711}"/>
               </a:ext>
             </a:extLst>
           </p:cNvPr>
@@ -16293,7 +17642,7 @@
     </p:spTree>
     <p:extLst>
       <p:ext uri="{BB962C8B-B14F-4D97-AF65-F5344CB8AC3E}">
-        <p14:creationId xmlns:p14="http://schemas.microsoft.com/office/powerpoint/2010/main" val="1763676169"/>
+        <p14:creationId xmlns:p14="http://schemas.microsoft.com/office/powerpoint/2010/main" val="2143069290"/>
       </p:ext>
     </p:extLst>
   </p:cSld>
@@ -16321,10 +17670,10 @@
       </p:grpSpPr>
       <p:sp>
         <p:nvSpPr>
-          <p:cNvPr id="11" name="slide-title">
-            <a:extLst xmlns:a="http://schemas.openxmlformats.org/drawingml/2006/main">
-              <a:ext uri="{FF2B5EF4-FFF2-40B4-BE49-F238E27FC236}">
-                <a16:creationId xmlns:a16="http://schemas.microsoft.com/office/drawing/2014/main" id="{19F26365-4A10-4AF4-97F5-000B8D9DA4EC}"/>
+          <p:cNvPr id="13" name="slide-title">
+            <a:extLst xmlns:a="http://schemas.openxmlformats.org/drawingml/2006/main">
+              <a:ext uri="{FF2B5EF4-FFF2-40B4-BE49-F238E27FC236}">
+                <a16:creationId xmlns:a16="http://schemas.microsoft.com/office/drawing/2014/main" id="{0E894A5D-4504-4CF4-BE3F-E4D904B6B346}"/>
               </a:ext>
             </a:extLst>
           </p:cNvPr>
@@ -16375,7 +17724,7 @@
           <p:cNvPr id="2" name="slide-subtitle">
             <a:extLst xmlns:a="http://schemas.openxmlformats.org/drawingml/2006/main">
               <a:ext uri="{FF2B5EF4-FFF2-40B4-BE49-F238E27FC236}">
-                <a16:creationId xmlns:a16="http://schemas.microsoft.com/office/drawing/2014/main" id="{47E41C31-D30C-4A76-BAD6-91AAC9803304}"/>
+                <a16:creationId xmlns:a16="http://schemas.microsoft.com/office/drawing/2014/main" id="{DA8DD6DF-E0DC-470B-A106-1FC06C205984}"/>
               </a:ext>
             </a:extLst>
           </p:cNvPr>
@@ -16426,7 +17775,7 @@
           <p:cNvPr id="3" name="bullets">
             <a:extLst xmlns:a="http://schemas.openxmlformats.org/drawingml/2006/main">
               <a:ext uri="{FF2B5EF4-FFF2-40B4-BE49-F238E27FC236}">
-                <a16:creationId xmlns:a16="http://schemas.microsoft.com/office/drawing/2014/main" id="{95E880E8-F380-4377-8BE3-829143FF50DB}"/>
+                <a16:creationId xmlns:a16="http://schemas.microsoft.com/office/drawing/2014/main" id="{3D90D3D3-2AE5-4BFD-8019-FE28B7299A63}"/>
               </a:ext>
             </a:extLst>
           </p:cNvPr>
@@ -16531,7 +17880,7 @@
           <p:cNvPr id="4" name="ambient-glow">
             <a:extLst xmlns:a="http://schemas.openxmlformats.org/drawingml/2006/main">
               <a:ext uri="{FF2B5EF4-FFF2-40B4-BE49-F238E27FC236}">
-                <a16:creationId xmlns:a16="http://schemas.microsoft.com/office/drawing/2014/main" id="{8FCA8A02-C9A0-4C68-9FB5-6010C3DAEBB1}"/>
+                <a16:creationId xmlns:a16="http://schemas.microsoft.com/office/drawing/2014/main" id="{0BAACAB7-BD97-47AE-BF4D-677C517FD91E}"/>
               </a:ext>
             </a:extLst>
           </p:cNvPr>
@@ -16568,7 +17917,7 @@
           <p:cNvPr id="5" name="ambient-core">
             <a:extLst xmlns:a="http://schemas.openxmlformats.org/drawingml/2006/main">
               <a:ext uri="{FF2B5EF4-FFF2-40B4-BE49-F238E27FC236}">
-                <a16:creationId xmlns:a16="http://schemas.microsoft.com/office/drawing/2014/main" id="{A223EC8C-9C4F-49C2-9AE0-DAD3B01DB621}"/>
+                <a16:creationId xmlns:a16="http://schemas.microsoft.com/office/drawing/2014/main" id="{F45F69FD-F6B6-439A-A500-E59958D58C37}"/>
               </a:ext>
             </a:extLst>
           </p:cNvPr>
@@ -16605,7 +17954,7 @@
           <p:cNvPr id="6" name="section-number">
             <a:extLst xmlns:a="http://schemas.openxmlformats.org/drawingml/2006/main">
               <a:ext uri="{FF2B5EF4-FFF2-40B4-BE49-F238E27FC236}">
-                <a16:creationId xmlns:a16="http://schemas.microsoft.com/office/drawing/2014/main" id="{E6E5B8C6-F82D-4908-A6B4-22D9ADDE5868}"/>
+                <a16:creationId xmlns:a16="http://schemas.microsoft.com/office/drawing/2014/main" id="{CB237329-41DA-4C4C-9713-F652A52B6577}"/>
               </a:ext>
             </a:extLst>
           </p:cNvPr>
@@ -16656,7 +18005,7 @@
           <p:cNvPr id="7" name="eyebrow">
             <a:extLst xmlns:a="http://schemas.openxmlformats.org/drawingml/2006/main">
               <a:ext uri="{FF2B5EF4-FFF2-40B4-BE49-F238E27FC236}">
-                <a16:creationId xmlns:a16="http://schemas.microsoft.com/office/drawing/2014/main" id="{82176A70-7A61-4EB6-A52E-9E5A5357733A}"/>
+                <a16:creationId xmlns:a16="http://schemas.microsoft.com/office/drawing/2014/main" id="{197736C5-94CE-4E33-A5A8-269EC57E9C4A}"/>
               </a:ext>
             </a:extLst>
           </p:cNvPr>
@@ -16704,10 +18053,69 @@
       </p:sp>
       <p:sp>
         <p:nvSpPr>
-          <p:cNvPr id="8" name="footer-rule">
-            <a:extLst xmlns:a="http://schemas.openxmlformats.org/drawingml/2006/main">
-              <a:ext uri="{FF2B5EF4-FFF2-40B4-BE49-F238E27FC236}">
-                <a16:creationId xmlns:a16="http://schemas.microsoft.com/office/drawing/2014/main" id="{7283226F-C17E-4041-8601-048F76ADA923}"/>
+          <p:cNvPr id="8" name="rescue-point-logo-background">
+            <a:extLst xmlns:a="http://schemas.openxmlformats.org/drawingml/2006/main">
+              <a:ext uri="{FF2B5EF4-FFF2-40B4-BE49-F238E27FC236}">
+                <a16:creationId xmlns:a16="http://schemas.microsoft.com/office/drawing/2014/main" id="{B4D567AC-2BBC-4746-A750-15C58800FFCA}"/>
+              </a:ext>
+            </a:extLst>
+          </p:cNvPr>
+          <p:cNvSpPr>
+            <a:spLocks xmlns:a="http://schemas.openxmlformats.org/drawingml/2006/main" noGrp="1"/>
+          </p:cNvSpPr>
+          <p:nvPr/>
+        </p:nvSpPr>
+        <p:spPr>
+          <a:xfrm xmlns:a="http://schemas.openxmlformats.org/drawingml/2006/main">
+            <a:off x="9772650" y="133350"/>
+            <a:ext cx="1733550" cy="457200"/>
+          </a:xfrm>
+          <a:prstGeom xmlns:a="http://schemas.openxmlformats.org/drawingml/2006/main" prst="roundRect">
+            <a:avLst>
+              <a:gd name="adj" fmla="val 16667"/>
+            </a:avLst>
+          </a:prstGeom>
+          <a:solidFill xmlns:a="http://schemas.openxmlformats.org/drawingml/2006/main">
+            <a:srgbClr val="06142E"/>
+          </a:solidFill>
+          <a:ln xmlns:a="http://schemas.openxmlformats.org/drawingml/2006/main" w="9525">
+            <a:solidFill>
+              <a:srgbClr val="1EC5FF">
+                <a:alpha val="33333"/>
+              </a:srgbClr>
+            </a:solidFill>
+            <a:prstDash val="solid"/>
+          </a:ln>
+        </p:spPr>
+      </p:sp>
+      <p:pic>
+        <p:nvPicPr>
+          <p:cNvPr id="23" name="" descr="Figura oficial da documentação dbt usada para explicar: O repositório restaura o ambiente — Setup instala uma vez; a reabertura restaura PATH, profile e caminhos detectados.."/>
+          <p:cNvPicPr>
+            <a:picLocks xmlns:a="http://schemas.openxmlformats.org/drawingml/2006/main" noChangeAspect="1"/>
+          </p:cNvPicPr>
+          <p:nvPr/>
+        </p:nvPicPr>
+        <p:blipFill>
+          <a:blip xmlns:r="http://schemas.openxmlformats.org/officeDocument/2006/relationships" xmlns:a="http://schemas.openxmlformats.org/drawingml/2006/main" r:embed="R5a22d8142139429d"/>
+          <a:stretch xmlns:a="http://schemas.openxmlformats.org/drawingml/2006/main"/>
+        </p:blipFill>
+        <p:spPr>
+          <a:xfrm xmlns:a="http://schemas.openxmlformats.org/drawingml/2006/main">
+            <a:off x="9893718" y="209550"/>
+            <a:ext cx="1491414" cy="323850"/>
+          </a:xfrm>
+          <a:prstGeom xmlns:a="http://schemas.openxmlformats.org/drawingml/2006/main" prst="rect">
+            <a:avLst/>
+          </a:prstGeom>
+        </p:spPr>
+      </p:pic>
+      <p:sp>
+        <p:nvSpPr>
+          <p:cNvPr id="10" name="footer-rule">
+            <a:extLst xmlns:a="http://schemas.openxmlformats.org/drawingml/2006/main">
+              <a:ext uri="{FF2B5EF4-FFF2-40B4-BE49-F238E27FC236}">
+                <a16:creationId xmlns:a16="http://schemas.microsoft.com/office/drawing/2014/main" id="{CFDFDC54-5557-4D3D-BC8E-C72AA669C897}"/>
               </a:ext>
             </a:extLst>
           </p:cNvPr>
@@ -16737,10 +18145,10 @@
       </p:sp>
       <p:sp>
         <p:nvSpPr>
-          <p:cNvPr id="9" name="footer">
-            <a:extLst xmlns:a="http://schemas.openxmlformats.org/drawingml/2006/main">
-              <a:ext uri="{FF2B5EF4-FFF2-40B4-BE49-F238E27FC236}">
-                <a16:creationId xmlns:a16="http://schemas.microsoft.com/office/drawing/2014/main" id="{5F8EC1F8-6083-4A74-AF32-870551F460FC}"/>
+          <p:cNvPr id="11" name="footer">
+            <a:extLst xmlns:a="http://schemas.openxmlformats.org/drawingml/2006/main">
+              <a:ext uri="{FF2B5EF4-FFF2-40B4-BE49-F238E27FC236}">
+                <a16:creationId xmlns:a16="http://schemas.microsoft.com/office/drawing/2014/main" id="{2A9AC206-CE22-430B-AD14-88AC13A257AC}"/>
               </a:ext>
             </a:extLst>
           </p:cNvPr>
@@ -16792,10 +18200,10 @@
       </p:sp>
       <p:sp>
         <p:nvSpPr>
-          <p:cNvPr id="10" name="page-number">
-            <a:extLst xmlns:a="http://schemas.openxmlformats.org/drawingml/2006/main">
-              <a:ext uri="{FF2B5EF4-FFF2-40B4-BE49-F238E27FC236}">
-                <a16:creationId xmlns:a16="http://schemas.microsoft.com/office/drawing/2014/main" id="{F07C0B84-5CEA-4C6B-91D3-0775F974315E}"/>
+          <p:cNvPr id="12" name="page-number">
+            <a:extLst xmlns:a="http://schemas.openxmlformats.org/drawingml/2006/main">
+              <a:ext uri="{FF2B5EF4-FFF2-40B4-BE49-F238E27FC236}">
+                <a16:creationId xmlns:a16="http://schemas.microsoft.com/office/drawing/2014/main" id="{F879553C-4941-4694-8107-8E2CC491564D}"/>
               </a:ext>
             </a:extLst>
           </p:cNvPr>
@@ -16848,7 +18256,7 @@
     </p:spTree>
     <p:extLst>
       <p:ext uri="{BB962C8B-B14F-4D97-AF65-F5344CB8AC3E}">
-        <p14:creationId xmlns:p14="http://schemas.microsoft.com/office/powerpoint/2010/main" val="1996774623"/>
+        <p14:creationId xmlns:p14="http://schemas.microsoft.com/office/powerpoint/2010/main" val="1079583618"/>
       </p:ext>
     </p:extLst>
   </p:cSld>

</xml_diff>